<commit_message>
chore: update latest digest
</commit_message>
<xml_diff>
--- a/docs/digest-en.pptx
+++ b/docs/digest-en.pptx
@@ -2034,26 +2034,39 @@
       </p:grpSpPr>
       <p:sp>
         <p:nvSpPr>
-          <p:cNvPr id="2" name="Shape 0"/>
+          <p:cNvPr id="2" name="Text 0"/>
           <p:cNvSpPr/>
           <p:nvPr/>
         </p:nvSpPr>
         <p:spPr>
           <a:xfrm>
-            <a:off x="731520" y="3474720"/>
-            <a:ext cx="2743200" cy="0"/>
-          </a:xfrm>
-          <a:prstGeom prst="line">
+            <a:off x="731520" y="457200"/>
+            <a:ext cx="5486400" cy="0"/>
+          </a:xfrm>
+          <a:prstGeom prst="rect">
             <a:avLst/>
           </a:prstGeom>
           <a:noFill/>
-          <a:ln w="38100">
-            <a:solidFill>
-              <a:srgbClr val="2563EB"/>
-            </a:solidFill>
-            <a:prstDash val="solid"/>
-          </a:ln>
-        </p:spPr>
+          <a:ln/>
+        </p:spPr>
+        <p:txBody>
+          <a:bodyPr wrap="square" lIns="0" tIns="0" rIns="0" bIns="0" rtlCol="0" anchor="ctr"/>
+          <a:lstStyle/>
+          <a:p>
+            <a:pPr indent="0" marL="0">
+              <a:buNone/>
+            </a:pPr>
+            <a:r>
+              <a:rPr lang="en-US" sz="900" b="1" spc="600" kern="0" dirty="0">
+                <a:solidFill>
+                  <a:srgbClr val="888888"/>
+                </a:solidFill>
+              </a:rPr>
+              <a:t>WEEKLY DIGEST</a:t>
+            </a:r>
+            <a:endParaRPr lang="en-US" sz="900" dirty="0"/>
+          </a:p>
+        </p:txBody>
       </p:sp>
       <p:sp>
         <p:nvSpPr>
@@ -2063,8 +2076,8 @@
         </p:nvSpPr>
         <p:spPr>
           <a:xfrm>
-            <a:off x="731520" y="457200"/>
-            <a:ext cx="5486400" cy="0"/>
+            <a:off x="731520" y="1371600"/>
+            <a:ext cx="10058400" cy="0"/>
           </a:xfrm>
           <a:prstGeom prst="rect">
             <a:avLst/>
@@ -2073,21 +2086,47 @@
           <a:ln/>
         </p:spPr>
         <p:txBody>
-          <a:bodyPr wrap="square" lIns="0" tIns="0" rIns="0" bIns="0" rtlCol="0" anchor="ctr"/>
-          <a:lstStyle/>
-          <a:p>
-            <a:pPr indent="0" marL="0">
-              <a:buNone/>
-            </a:pPr>
-            <a:r>
-              <a:rPr lang="en-US" sz="900" b="1" spc="600" kern="0" dirty="0">
-                <a:solidFill>
-                  <a:srgbClr val="888888"/>
-                </a:solidFill>
-              </a:rPr>
-              <a:t>WEEKLY DIGEST</a:t>
-            </a:r>
-            <a:endParaRPr lang="en-US" sz="900" dirty="0"/>
+          <a:bodyPr wrap="square" rtlCol="0" anchor="ctr"/>
+          <a:lstStyle/>
+          <a:p>
+            <a:pPr indent="0" marL="0">
+              <a:lnSpc>
+                <a:spcPct val="95000"/>
+              </a:lnSpc>
+              <a:buNone/>
+            </a:pPr>
+            <a:r>
+              <a:rPr lang="en-US" sz="4800" b="1" dirty="0">
+                <a:solidFill>
+                  <a:srgbClr val="FFFFFF"/>
+                </a:solidFill>
+                <a:latin typeface="Arial" pitchFamily="34" charset="0"/>
+                <a:ea typeface="Arial" pitchFamily="34" charset="-122"/>
+                <a:cs typeface="Arial" pitchFamily="34" charset="-120"/>
+              </a:rPr>
+              <a:t>Colorectal</a:t>
+            </a:r>
+            <a:endParaRPr lang="en-US" sz="4800" dirty="0"/>
+          </a:p>
+          <a:p>
+            <a:pPr indent="0" marL="0">
+              <a:lnSpc>
+                <a:spcPct val="95000"/>
+              </a:lnSpc>
+              <a:buNone/>
+            </a:pPr>
+            <a:r>
+              <a:rPr lang="en-US" sz="4800" b="1" dirty="0">
+                <a:solidFill>
+                  <a:srgbClr val="FFFFFF"/>
+                </a:solidFill>
+                <a:latin typeface="Arial" pitchFamily="34" charset="0"/>
+                <a:ea typeface="Arial" pitchFamily="34" charset="-122"/>
+                <a:cs typeface="Arial" pitchFamily="34" charset="-120"/>
+              </a:rPr>
+              <a:t>Surgery</a:t>
+            </a:r>
+            <a:endParaRPr lang="en-US" sz="4800" dirty="0"/>
           </a:p>
         </p:txBody>
       </p:sp>
@@ -2099,8 +2138,8 @@
         </p:nvSpPr>
         <p:spPr>
           <a:xfrm>
-            <a:off x="731520" y="1371600"/>
-            <a:ext cx="10058400" cy="0"/>
+            <a:off x="731520" y="5029200"/>
+            <a:ext cx="5486400" cy="0"/>
           </a:xfrm>
           <a:prstGeom prst="rect">
             <a:avLst/>
@@ -2109,89 +2148,27 @@
           <a:ln/>
         </p:spPr>
         <p:txBody>
-          <a:bodyPr wrap="square" rtlCol="0" anchor="ctr"/>
-          <a:lstStyle/>
-          <a:p>
-            <a:pPr indent="0" marL="0">
-              <a:lnSpc>
-                <a:spcPct val="95000"/>
-              </a:lnSpc>
-              <a:buNone/>
-            </a:pPr>
-            <a:r>
-              <a:rPr lang="en-US" sz="4800" b="1" dirty="0">
-                <a:solidFill>
-                  <a:srgbClr val="FFFFFF"/>
-                </a:solidFill>
-                <a:latin typeface="Arial" pitchFamily="34" charset="0"/>
-                <a:ea typeface="Arial" pitchFamily="34" charset="-122"/>
-                <a:cs typeface="Arial" pitchFamily="34" charset="-120"/>
-              </a:rPr>
-              <a:t>Colorectal</a:t>
-            </a:r>
-            <a:endParaRPr lang="en-US" sz="4800" dirty="0"/>
-          </a:p>
-          <a:p>
-            <a:pPr indent="0" marL="0">
-              <a:lnSpc>
-                <a:spcPct val="95000"/>
-              </a:lnSpc>
-              <a:buNone/>
-            </a:pPr>
-            <a:r>
-              <a:rPr lang="en-US" sz="4800" b="1" dirty="0">
-                <a:solidFill>
-                  <a:srgbClr val="FFFFFF"/>
-                </a:solidFill>
-                <a:latin typeface="Arial" pitchFamily="34" charset="0"/>
-                <a:ea typeface="Arial" pitchFamily="34" charset="-122"/>
-                <a:cs typeface="Arial" pitchFamily="34" charset="-120"/>
-              </a:rPr>
-              <a:t>Surgery</a:t>
-            </a:r>
-            <a:endParaRPr lang="en-US" sz="4800" dirty="0"/>
+          <a:bodyPr wrap="square" lIns="0" tIns="0" rIns="0" bIns="0" rtlCol="0" anchor="ctr"/>
+          <a:lstStyle/>
+          <a:p>
+            <a:pPr indent="0" marL="0">
+              <a:buNone/>
+            </a:pPr>
+            <a:r>
+              <a:rPr lang="en-US" sz="1400" dirty="0">
+                <a:solidFill>
+                  <a:srgbClr val="888888"/>
+                </a:solidFill>
+              </a:rPr>
+              <a:t>2026-04-12 — 2026-04-19</a:t>
+            </a:r>
+            <a:endParaRPr lang="en-US" sz="1400" dirty="0"/>
           </a:p>
         </p:txBody>
       </p:sp>
       <p:sp>
         <p:nvSpPr>
           <p:cNvPr id="5" name="Text 3"/>
-          <p:cNvSpPr/>
-          <p:nvPr/>
-        </p:nvSpPr>
-        <p:spPr>
-          <a:xfrm>
-            <a:off x="731520" y="5029200"/>
-            <a:ext cx="5486400" cy="0"/>
-          </a:xfrm>
-          <a:prstGeom prst="rect">
-            <a:avLst/>
-          </a:prstGeom>
-          <a:noFill/>
-          <a:ln/>
-        </p:spPr>
-        <p:txBody>
-          <a:bodyPr wrap="square" lIns="0" tIns="0" rIns="0" bIns="0" rtlCol="0" anchor="ctr"/>
-          <a:lstStyle/>
-          <a:p>
-            <a:pPr indent="0" marL="0">
-              <a:buNone/>
-            </a:pPr>
-            <a:r>
-              <a:rPr lang="en-US" sz="1400" dirty="0">
-                <a:solidFill>
-                  <a:srgbClr val="888888"/>
-                </a:solidFill>
-              </a:rPr>
-              <a:t>2026-04-12 — 2026-04-19</a:t>
-            </a:r>
-            <a:endParaRPr lang="en-US" sz="1400" dirty="0"/>
-          </a:p>
-        </p:txBody>
-      </p:sp>
-      <p:sp>
-        <p:nvSpPr>
-          <p:cNvPr id="6" name="Text 4"/>
           <p:cNvSpPr/>
           <p:nvPr/>
         </p:nvSpPr>
@@ -2374,7 +2351,7 @@
                   </a:extLst>
                 </a:hlinkClick>
               </a:rPr>
-              <a:t>Sanghuangporus vaninii extract exerts dual anti-tumor effects in colitis-associated colorectal cancer by direct cytotoxicity and macrophage reprogramming via the PPAR&amp;#x3b3;/NF-&amp;#x3ba;B axis.</a:t>
+              <a:t>Radioiodination of Two Carborane-Based Dual Cyclooxygenase-2/5-Lipoxygenase Inhibitors and Their In Vitro and In Vivo Evaluation.</a:t>
             </a:r>
             <a:endParaRPr lang="en-US" sz="2400" dirty="0"/>
           </a:p>
@@ -2410,7 +2387,7 @@
                   <a:srgbClr val="888888"/>
                 </a:solidFill>
               </a:rPr>
-              <a:t>Journal of ethnopharmacology  ·  Basic Research</a:t>
+              <a:t>Chembiochem : a European journal of chemical biology  ·  Basic Research</a:t>
             </a:r>
             <a:endParaRPr lang="en-US" sz="1000" dirty="0"/>
           </a:p>
@@ -2418,30 +2395,7 @@
       </p:sp>
       <p:sp>
         <p:nvSpPr>
-          <p:cNvPr id="6" name="Shape 4"/>
-          <p:cNvSpPr/>
-          <p:nvPr/>
-        </p:nvSpPr>
-        <p:spPr>
-          <a:xfrm>
-            <a:off x="731520" y="2148840"/>
-            <a:ext cx="10058400" cy="0"/>
-          </a:xfrm>
-          <a:prstGeom prst="line">
-            <a:avLst/>
-          </a:prstGeom>
-          <a:noFill/>
-          <a:ln w="6350">
-            <a:solidFill>
-              <a:srgbClr val="E2E8F0"/>
-            </a:solidFill>
-            <a:prstDash val="solid"/>
-          </a:ln>
-        </p:spPr>
-      </p:sp>
-      <p:sp>
-        <p:nvSpPr>
-          <p:cNvPr id="7" name="Text 5"/>
+          <p:cNvPr id="6" name="Text 4"/>
           <p:cNvSpPr/>
           <p:nvPr/>
         </p:nvSpPr>
@@ -2476,7 +2430,7 @@
                 <a:ea typeface="Arial" pitchFamily="34" charset="-122"/>
                 <a:cs typeface="Arial" pitchFamily="34" charset="-120"/>
               </a:rPr>
-              <a:t>Sanghuangporus vaninii shows anti-tumor effects</a:t>
+              <a:t>COX-2 and 5-LO are cancer targets</a:t>
             </a:r>
             <a:endParaRPr lang="en-US" sz="1800" dirty="0"/>
           </a:p>
@@ -2497,7 +2451,7 @@
                 <a:ea typeface="Arial" pitchFamily="34" charset="-122"/>
                 <a:cs typeface="Arial" pitchFamily="34" charset="-120"/>
               </a:rPr>
-              <a:t>Targets colitis-associated colorectal cancer</a:t>
+              <a:t>Iodinated derivatives showed potent inhibition</a:t>
             </a:r>
             <a:endParaRPr lang="en-US" sz="1800" dirty="0"/>
           </a:p>
@@ -2518,15 +2472,57 @@
                 <a:ea typeface="Arial" pitchFamily="34" charset="-122"/>
                 <a:cs typeface="Arial" pitchFamily="34" charset="-120"/>
               </a:rPr>
-              <a:t>Inhibits inflammation via PPARγ/NF-κB axis</a:t>
+              <a:t>Cellular uptake linked to 5-LO expression</a:t>
             </a:r>
             <a:endParaRPr lang="en-US" sz="1800" dirty="0"/>
           </a:p>
-        </p:txBody>
-      </p:sp>
-      <p:sp>
-        <p:nvSpPr>
-          <p:cNvPr id="8" name="Text 6">
+          <a:p>
+            <a:pPr marL="342900" indent="-342900">
+              <a:spcAft>
+                <a:spcPts val="800"/>
+              </a:spcAft>
+              <a:buSzPct val="100000"/>
+              <a:buChar char="•"/>
+            </a:pPr>
+            <a:r>
+              <a:rPr lang="en-US" sz="1800" dirty="0">
+                <a:solidFill>
+                  <a:srgbClr val="333333"/>
+                </a:solidFill>
+                <a:latin typeface="Arial" pitchFamily="34" charset="0"/>
+                <a:ea typeface="Arial" pitchFamily="34" charset="-122"/>
+                <a:cs typeface="Arial" pitchFamily="34" charset="-120"/>
+              </a:rPr>
+              <a:t>No tumor retention in mouse models</a:t>
+            </a:r>
+            <a:endParaRPr lang="en-US" sz="1800" dirty="0"/>
+          </a:p>
+          <a:p>
+            <a:pPr marL="342900" indent="-342900">
+              <a:spcAft>
+                <a:spcPts val="800"/>
+              </a:spcAft>
+              <a:buSzPct val="100000"/>
+              <a:buChar char="•"/>
+            </a:pPr>
+            <a:r>
+              <a:rPr lang="en-US" sz="1800" dirty="0">
+                <a:solidFill>
+                  <a:srgbClr val="333333"/>
+                </a:solidFill>
+                <a:latin typeface="Arial" pitchFamily="34" charset="0"/>
+                <a:ea typeface="Arial" pitchFamily="34" charset="-122"/>
+                <a:cs typeface="Arial" pitchFamily="34" charset="-120"/>
+              </a:rPr>
+              <a:t>Improved stability needed for radiotracers</a:t>
+            </a:r>
+            <a:endParaRPr lang="en-US" sz="1800" dirty="0"/>
+          </a:p>
+        </p:txBody>
+      </p:sp>
+      <p:sp>
+        <p:nvSpPr>
+          <p:cNvPr id="7" name="Text 5">
             <a:hlinkClick r:id="rId2" tooltip=""/>
           </p:cNvPr>
           <p:cNvSpPr/>
@@ -2568,29 +2564,6 @@
             <a:endParaRPr lang="en-US" sz="1000" dirty="0"/>
           </a:p>
         </p:txBody>
-      </p:sp>
-      <p:sp>
-        <p:nvSpPr>
-          <p:cNvPr id="9" name="Shape 7"/>
-          <p:cNvSpPr/>
-          <p:nvPr/>
-        </p:nvSpPr>
-        <p:spPr>
-          <a:xfrm>
-            <a:off x="0" y="6803136"/>
-            <a:ext cx="12188952" cy="0"/>
-          </a:xfrm>
-          <a:prstGeom prst="line">
-            <a:avLst/>
-          </a:prstGeom>
-          <a:noFill/>
-          <a:ln w="50800">
-            <a:solidFill>
-              <a:srgbClr val="2563EB"/>
-            </a:solidFill>
-            <a:prstDash val="solid"/>
-          </a:ln>
-        </p:spPr>
       </p:sp>
     </p:spTree>
   </p:cSld>
@@ -2698,7 +2671,9 @@
       </p:sp>
       <p:sp>
         <p:nvSpPr>
-          <p:cNvPr id="4" name="Text 2"/>
+          <p:cNvPr id="4" name="Text 2">
+            <a:hlinkClick r:id="rId1" tooltip=""/>
+          </p:cNvPr>
           <p:cNvSpPr/>
           <p:nvPr/>
         </p:nvSpPr>
@@ -2724,15 +2699,22 @@
               <a:buNone/>
             </a:pPr>
             <a:r>
-              <a:rPr lang="en-US" sz="2400" b="1" dirty="0">
+              <a:rPr lang="en-US" sz="2400" b="1" u="sng" dirty="0">
                 <a:solidFill>
                   <a:srgbClr val="111111"/>
                 </a:solidFill>
                 <a:latin typeface="Arial" pitchFamily="34" charset="0"/>
                 <a:ea typeface="Arial" pitchFamily="34" charset="-122"/>
                 <a:cs typeface="Arial" pitchFamily="34" charset="-120"/>
-              </a:rPr>
-              <a:t>Repurposing PARP inhibitors in molecularly defined subgroups of peritoneal metastatic colorectal cancer (pmCRC): Preclinical analysis of patient-derived xenograft …</a:t>
+                <a:hlinkClick r:id="rId1" invalidUrl="" action="" tgtFrame="" tooltip="" history="1" highlightClick="0" endSnd="0">
+                  <a:extLst>
+                    <a:ext uri="{A12FA001-AC4F-418D-AE19-62706E023703}">
+                      <ahyp:hlinkClr xmlns:ahyp="http://schemas.microsoft.com/office/drawing/2018/hyperlinkcolor" val="tx"/>
+                    </a:ext>
+                  </a:extLst>
+                </a:hlinkClick>
+              </a:rPr>
+              <a:t>Sanghuangporus vaninii extract exerts dual anti-tumor effects in colitis-associated colorectal cancer by direct cytotoxicity and macrophage reprogramming via the PPAR&amp;#x3b3;/NF-&amp;#x3ba;B axis.</a:t>
             </a:r>
             <a:endParaRPr lang="en-US" sz="2400" dirty="0"/>
           </a:p>
@@ -2768,7 +2750,7 @@
                   <a:srgbClr val="888888"/>
                 </a:solidFill>
               </a:rPr>
-              <a:t>Cancer …  ·  Basic Research</a:t>
+              <a:t>Journal of ethnopharmacology  ·  Basic Research</a:t>
             </a:r>
             <a:endParaRPr lang="en-US" sz="1000" dirty="0"/>
           </a:p>
@@ -2776,30 +2758,7 @@
       </p:sp>
       <p:sp>
         <p:nvSpPr>
-          <p:cNvPr id="6" name="Shape 4"/>
-          <p:cNvSpPr/>
-          <p:nvPr/>
-        </p:nvSpPr>
-        <p:spPr>
-          <a:xfrm>
-            <a:off x="731520" y="2148840"/>
-            <a:ext cx="10058400" cy="0"/>
-          </a:xfrm>
-          <a:prstGeom prst="line">
-            <a:avLst/>
-          </a:prstGeom>
-          <a:noFill/>
-          <a:ln w="6350">
-            <a:solidFill>
-              <a:srgbClr val="E2E8F0"/>
-            </a:solidFill>
-            <a:prstDash val="solid"/>
-          </a:ln>
-        </p:spPr>
-      </p:sp>
-      <p:sp>
-        <p:nvSpPr>
-          <p:cNvPr id="7" name="Text 5"/>
+          <p:cNvPr id="6" name="Text 4"/>
           <p:cNvSpPr/>
           <p:nvPr/>
         </p:nvSpPr>
@@ -2834,7 +2793,7 @@
                 <a:ea typeface="Arial" pitchFamily="34" charset="-122"/>
                 <a:cs typeface="Arial" pitchFamily="34" charset="-120"/>
               </a:rPr>
-              <a:t>PARP inhibitors show promise</a:t>
+              <a:t>Sanghuangporus vaninii shows anti-tumor effects.</a:t>
             </a:r>
             <a:endParaRPr lang="en-US" sz="1800" dirty="0"/>
           </a:p>
@@ -2855,7 +2814,7 @@
                 <a:ea typeface="Arial" pitchFamily="34" charset="-122"/>
                 <a:cs typeface="Arial" pitchFamily="34" charset="-120"/>
               </a:rPr>
-              <a:t>Targeting specific subgroups</a:t>
+              <a:t>Inhibits colitis-associated colorectal cancer (CAC).</a:t>
             </a:r>
             <a:endParaRPr lang="en-US" sz="1800" dirty="0"/>
           </a:p>
@@ -2876,34 +2835,98 @@
                 <a:ea typeface="Arial" pitchFamily="34" charset="-122"/>
                 <a:cs typeface="Arial" pitchFamily="34" charset="-120"/>
               </a:rPr>
-              <a:t>Preclinical patient-derived models</a:t>
+              <a:t>Targets PPARγ/NF-κB signaling pathway.</a:t>
             </a:r>
             <a:endParaRPr lang="en-US" sz="1800" dirty="0"/>
           </a:p>
-        </p:txBody>
-      </p:sp>
-      <p:sp>
-        <p:nvSpPr>
-          <p:cNvPr id="8" name="Shape 6"/>
+          <a:p>
+            <a:pPr marL="342900" indent="-342900">
+              <a:spcAft>
+                <a:spcPts val="800"/>
+              </a:spcAft>
+              <a:buSzPct val="100000"/>
+              <a:buChar char="•"/>
+            </a:pPr>
+            <a:r>
+              <a:rPr lang="en-US" sz="1800" dirty="0">
+                <a:solidFill>
+                  <a:srgbClr val="333333"/>
+                </a:solidFill>
+                <a:latin typeface="Arial" pitchFamily="34" charset="0"/>
+                <a:ea typeface="Arial" pitchFamily="34" charset="-122"/>
+                <a:cs typeface="Arial" pitchFamily="34" charset="-120"/>
+              </a:rPr>
+              <a:t>Reprograms macrophages to M2 phenotype.</a:t>
+            </a:r>
+            <a:endParaRPr lang="en-US" sz="1800" dirty="0"/>
+          </a:p>
+          <a:p>
+            <a:pPr marL="342900" indent="-342900">
+              <a:spcAft>
+                <a:spcPts val="800"/>
+              </a:spcAft>
+              <a:buSzPct val="100000"/>
+              <a:buChar char="•"/>
+            </a:pPr>
+            <a:r>
+              <a:rPr lang="en-US" sz="1800" dirty="0">
+                <a:solidFill>
+                  <a:srgbClr val="333333"/>
+                </a:solidFill>
+                <a:latin typeface="Arial" pitchFamily="34" charset="0"/>
+                <a:ea typeface="Arial" pitchFamily="34" charset="-122"/>
+                <a:cs typeface="Arial" pitchFamily="34" charset="-120"/>
+              </a:rPr>
+              <a:t>Improves survival and reduces tumor burden.</a:t>
+            </a:r>
+            <a:endParaRPr lang="en-US" sz="1800" dirty="0"/>
+          </a:p>
+        </p:txBody>
+      </p:sp>
+      <p:sp>
+        <p:nvSpPr>
+          <p:cNvPr id="7" name="Text 5">
+            <a:hlinkClick r:id="rId2" tooltip=""/>
+          </p:cNvPr>
           <p:cNvSpPr/>
           <p:nvPr/>
         </p:nvSpPr>
         <p:spPr>
           <a:xfrm>
-            <a:off x="0" y="6803136"/>
-            <a:ext cx="12188952" cy="0"/>
-          </a:xfrm>
-          <a:prstGeom prst="line">
+            <a:off x="731520" y="6217920"/>
+            <a:ext cx="3657600" cy="0"/>
+          </a:xfrm>
+          <a:prstGeom prst="rect">
             <a:avLst/>
           </a:prstGeom>
           <a:noFill/>
-          <a:ln w="50800">
-            <a:solidFill>
-              <a:srgbClr val="2563EB"/>
-            </a:solidFill>
-            <a:prstDash val="solid"/>
-          </a:ln>
-        </p:spPr>
+          <a:ln/>
+        </p:spPr>
+        <p:txBody>
+          <a:bodyPr wrap="square" lIns="0" tIns="0" rIns="0" bIns="0" rtlCol="0" anchor="ctr"/>
+          <a:lstStyle/>
+          <a:p>
+            <a:pPr indent="0" marL="0">
+              <a:buNone/>
+            </a:pPr>
+            <a:r>
+              <a:rPr lang="en-US" sz="1000" b="1" u="sng" dirty="0">
+                <a:solidFill>
+                  <a:srgbClr val="2563EB"/>
+                </a:solidFill>
+                <a:hlinkClick r:id="rId2" invalidUrl="" action="" tgtFrame="" tooltip="" history="1" highlightClick="0" endSnd="0">
+                  <a:extLst>
+                    <a:ext uri="{A12FA001-AC4F-418D-AE19-62706E023703}">
+                      <ahyp:hlinkClr xmlns:ahyp="http://schemas.microsoft.com/office/drawing/2018/hyperlinkcolor" val="tx"/>
+                    </a:ext>
+                  </a:extLst>
+                </a:hlinkClick>
+              </a:rPr>
+              <a:t>📎 View Paper →</a:t>
+            </a:r>
+            <a:endParaRPr lang="en-US" sz="1000" dirty="0"/>
+          </a:p>
+        </p:txBody>
       </p:sp>
     </p:spTree>
   </p:cSld>
@@ -3011,7 +3034,9 @@
       </p:sp>
       <p:sp>
         <p:nvSpPr>
-          <p:cNvPr id="4" name="Text 2"/>
+          <p:cNvPr id="4" name="Text 2">
+            <a:hlinkClick r:id="rId1" tooltip=""/>
+          </p:cNvPr>
           <p:cNvSpPr/>
           <p:nvPr/>
         </p:nvSpPr>
@@ -3037,15 +3062,22 @@
               <a:buNone/>
             </a:pPr>
             <a:r>
-              <a:rPr lang="en-US" sz="2400" b="1" dirty="0">
+              <a:rPr lang="en-US" sz="2400" b="1" u="sng" dirty="0">
                 <a:solidFill>
                   <a:srgbClr val="111111"/>
                 </a:solidFill>
                 <a:latin typeface="Arial" pitchFamily="34" charset="0"/>
                 <a:ea typeface="Arial" pitchFamily="34" charset="-122"/>
                 <a:cs typeface="Arial" pitchFamily="34" charset="-120"/>
-              </a:rPr>
-              <a:t>The Mechanism of Acetyl-L-Carnitine on Colorectal Cancer and Its Metabolomic Study</a:t>
+                <a:hlinkClick r:id="rId1" invalidUrl="" action="" tgtFrame="" tooltip="" history="1" highlightClick="0" endSnd="0">
+                  <a:extLst>
+                    <a:ext uri="{A12FA001-AC4F-418D-AE19-62706E023703}">
+                      <ahyp:hlinkClr xmlns:ahyp="http://schemas.microsoft.com/office/drawing/2018/hyperlinkcolor" val="tx"/>
+                    </a:ext>
+                  </a:extLst>
+                </a:hlinkClick>
+              </a:rPr>
+              <a:t>Repurposing PARP inhibitors in molecularly defined subgroups of peritoneal metastatic colorectal cancer (pmCRC): Preclinical analysis of patient-derived xenograft …</a:t>
             </a:r>
             <a:endParaRPr lang="en-US" sz="2400" dirty="0"/>
           </a:p>
@@ -3081,7 +3113,7 @@
                   <a:srgbClr val="888888"/>
                 </a:solidFill>
               </a:rPr>
-              <a:t>Journal of Pharmaceutical and …  ·  Basic Research</a:t>
+              <a:t>Cancer …  ·  Basic Research</a:t>
             </a:r>
             <a:endParaRPr lang="en-US" sz="1000" dirty="0"/>
           </a:p>
@@ -3089,30 +3121,7 @@
       </p:sp>
       <p:sp>
         <p:nvSpPr>
-          <p:cNvPr id="6" name="Shape 4"/>
-          <p:cNvSpPr/>
-          <p:nvPr/>
-        </p:nvSpPr>
-        <p:spPr>
-          <a:xfrm>
-            <a:off x="731520" y="2148840"/>
-            <a:ext cx="10058400" cy="0"/>
-          </a:xfrm>
-          <a:prstGeom prst="line">
-            <a:avLst/>
-          </a:prstGeom>
-          <a:noFill/>
-          <a:ln w="6350">
-            <a:solidFill>
-              <a:srgbClr val="E2E8F0"/>
-            </a:solidFill>
-            <a:prstDash val="solid"/>
-          </a:ln>
-        </p:spPr>
-      </p:sp>
-      <p:sp>
-        <p:nvSpPr>
-          <p:cNvPr id="7" name="Text 5"/>
+          <p:cNvPr id="6" name="Text 4"/>
           <p:cNvSpPr/>
           <p:nvPr/>
         </p:nvSpPr>
@@ -3147,7 +3156,7 @@
                 <a:ea typeface="Arial" pitchFamily="34" charset="-122"/>
                 <a:cs typeface="Arial" pitchFamily="34" charset="-120"/>
               </a:rPr>
-              <a:t>ALC inhibits tumor growth</a:t>
+              <a:t>PARP inhibitors show promise in pmCRC.</a:t>
             </a:r>
             <a:endParaRPr lang="en-US" sz="1800" dirty="0"/>
           </a:p>
@@ -3168,7 +3177,7 @@
                 <a:ea typeface="Arial" pitchFamily="34" charset="-122"/>
                 <a:cs typeface="Arial" pitchFamily="34" charset="-120"/>
               </a:rPr>
-              <a:t>In vivo studies confirm efficacy</a:t>
+              <a:t>Patient-derived xenografts used for analysis.</a:t>
             </a:r>
             <a:endParaRPr lang="en-US" sz="1800" dirty="0"/>
           </a:p>
@@ -3189,7 +3198,7 @@
                 <a:ea typeface="Arial" pitchFamily="34" charset="-122"/>
                 <a:cs typeface="Arial" pitchFamily="34" charset="-120"/>
               </a:rPr>
-              <a:t>Metabolomic analysis conducted</a:t>
+              <a:t>Molecular subgroups identified for targeted therapy.</a:t>
             </a:r>
             <a:endParaRPr lang="en-US" sz="1800" dirty="0"/>
           </a:p>
@@ -3197,26 +3206,48 @@
       </p:sp>
       <p:sp>
         <p:nvSpPr>
-          <p:cNvPr id="8" name="Shape 6"/>
+          <p:cNvPr id="7" name="Text 5">
+            <a:hlinkClick r:id="rId2" tooltip=""/>
+          </p:cNvPr>
           <p:cNvSpPr/>
           <p:nvPr/>
         </p:nvSpPr>
         <p:spPr>
           <a:xfrm>
-            <a:off x="0" y="6803136"/>
-            <a:ext cx="12188952" cy="0"/>
-          </a:xfrm>
-          <a:prstGeom prst="line">
+            <a:off x="731520" y="6217920"/>
+            <a:ext cx="3657600" cy="0"/>
+          </a:xfrm>
+          <a:prstGeom prst="rect">
             <a:avLst/>
           </a:prstGeom>
           <a:noFill/>
-          <a:ln w="50800">
-            <a:solidFill>
-              <a:srgbClr val="2563EB"/>
-            </a:solidFill>
-            <a:prstDash val="solid"/>
-          </a:ln>
-        </p:spPr>
+          <a:ln/>
+        </p:spPr>
+        <p:txBody>
+          <a:bodyPr wrap="square" lIns="0" tIns="0" rIns="0" bIns="0" rtlCol="0" anchor="ctr"/>
+          <a:lstStyle/>
+          <a:p>
+            <a:pPr indent="0" marL="0">
+              <a:buNone/>
+            </a:pPr>
+            <a:r>
+              <a:rPr lang="en-US" sz="1000" b="1" u="sng" dirty="0">
+                <a:solidFill>
+                  <a:srgbClr val="2563EB"/>
+                </a:solidFill>
+                <a:hlinkClick r:id="rId2" invalidUrl="" action="" tgtFrame="" tooltip="" history="1" highlightClick="0" endSnd="0">
+                  <a:extLst>
+                    <a:ext uri="{A12FA001-AC4F-418D-AE19-62706E023703}">
+                      <ahyp:hlinkClr xmlns:ahyp="http://schemas.microsoft.com/office/drawing/2018/hyperlinkcolor" val="tx"/>
+                    </a:ext>
+                  </a:extLst>
+                </a:hlinkClick>
+              </a:rPr>
+              <a:t>📎 View Paper →</a:t>
+            </a:r>
+            <a:endParaRPr lang="en-US" sz="1000" dirty="0"/>
+          </a:p>
+        </p:txBody>
       </p:sp>
     </p:spTree>
   </p:cSld>
@@ -3350,35 +3381,12 @@
       </p:sp>
       <p:sp>
         <p:nvSpPr>
-          <p:cNvPr id="4" name="Shape 2"/>
+          <p:cNvPr id="4" name="Text 2"/>
           <p:cNvSpPr/>
           <p:nvPr/>
         </p:nvSpPr>
         <p:spPr>
           <a:xfrm>
-            <a:off x="731520" y="2286000"/>
-            <a:ext cx="2743200" cy="0"/>
-          </a:xfrm>
-          <a:prstGeom prst="line">
-            <a:avLst/>
-          </a:prstGeom>
-          <a:noFill/>
-          <a:ln w="38100">
-            <a:solidFill>
-              <a:srgbClr val="2563EB"/>
-            </a:solidFill>
-            <a:prstDash val="solid"/>
-          </a:ln>
-        </p:spPr>
-      </p:sp>
-      <p:sp>
-        <p:nvSpPr>
-          <p:cNvPr id="5" name="Text 3"/>
-          <p:cNvSpPr/>
-          <p:nvPr/>
-        </p:nvSpPr>
-        <p:spPr>
-          <a:xfrm>
             <a:off x="731520" y="2560320"/>
             <a:ext cx="10515600" cy="0"/>
           </a:xfrm>
@@ -3430,7 +3438,7 @@
                   <a:srgbClr val="FFFFFF"/>
                 </a:solidFill>
               </a:rPr>
-              <a:t>1. **腸道微生物與癌症的關聯性**  </a:t>
+              <a:t>1. **腸道微生物與癌症關聯**  </a:t>
             </a:r>
             <a:endParaRPr lang="en-US" sz="1200" dirty="0"/>
           </a:p>
@@ -3447,7 +3455,7 @@
                   <a:srgbClr val="FFFFFF"/>
                 </a:solidFill>
               </a:rPr>
-              <a:t>   The study highlights the role of gut microbiota, particularly *Parasutterella excrementihominis*, in exacerbating colitis and promoting colorectal cancer through pathogenic mechanisms like NETosis activation.  </a:t>
+              <a:t>   The study on *Parasutterella excrementihominis* highlights the significant role of gut microbiota in exacerbating colitis and promoting colorectal cancer through pathogenic mechanisms like NETosis.  </a:t>
             </a:r>
             <a:endParaRPr lang="en-US" sz="1200" dirty="0"/>
           </a:p>
@@ -3464,7 +3472,7 @@
                   <a:srgbClr val="FFFFFF"/>
                 </a:solidFill>
               </a:rPr>
-              <a:t>   這項研究強調了腸道微生物，特別是*Parasutterella excrementihominis*，在加重結腸炎和促進結直腸癌中的作用，通過病理機制如NETosis激活。</a:t>
+              <a:t>   *Parasutterella excrementihominis*的研究突顯了腸道微生物在加劇結腸炎及促進結直腸癌方面的重要角色，這是透過像NETosis這樣的致病機制實現的。</a:t>
             </a:r>
             <a:endParaRPr lang="en-US" sz="1200" dirty="0"/>
           </a:p>
@@ -3490,7 +3498,7 @@
                   <a:srgbClr val="FFFFFF"/>
                 </a:solidFill>
               </a:rPr>
-              <a:t>2. **系統性免疫-炎症指數的預後價值**  </a:t>
+              <a:t>2. **免疫微環境的多樣性**  </a:t>
             </a:r>
             <a:endParaRPr lang="en-US" sz="1200" dirty="0"/>
           </a:p>
@@ -3507,7 +3515,7 @@
                   <a:srgbClr val="FFFFFF"/>
                 </a:solidFill>
               </a:rPr>
-              <a:t>   The systemic immune-inflammation index (SII) has emerged as a significant prognostic biomarker for colorectal cancer, indicating its potential use in clinical settings for patient stratification.  </a:t>
+              <a:t>   Organ-specific immune and metabolic programs create distinct microenvironments in colorectal cancer metastases, influencing tumor behavior and treatment responses.  </a:t>
             </a:r>
             <a:endParaRPr lang="en-US" sz="1200" dirty="0"/>
           </a:p>
@@ -3524,7 +3532,7 @@
                   <a:srgbClr val="FFFFFF"/>
                 </a:solidFill>
               </a:rPr>
-              <a:t>   系統性免疫-炎症指數（SII）已成為結直腸癌的重要預後生物標記，顯示其在臨床環境中用於患者分層的潛力。</a:t>
+              <a:t>   器官特異性的免疫和代謝程序在結直腸癌轉移中創造了不同的微環境，這影響了腫瘤行為和治療反應。</a:t>
             </a:r>
             <a:endParaRPr lang="en-US" sz="1200" dirty="0"/>
           </a:p>
@@ -3550,7 +3558,7 @@
                   <a:srgbClr val="FFFFFF"/>
                 </a:solidFill>
               </a:rPr>
-              <a:t>3. **超熱腹腔化療的有效性**  </a:t>
+              <a:t>3. **系統性免疫炎症指數的預後價值**  </a:t>
             </a:r>
             <a:endParaRPr lang="en-US" sz="1200" dirty="0"/>
           </a:p>
@@ -3567,7 +3575,7 @@
                   <a:srgbClr val="FFFFFF"/>
                 </a:solidFill>
               </a:rPr>
-              <a:t>   Hyperthermic intraperitoneal chemotherapy (HIPEC) shows promise in improving outcomes for patients with advanced colorectal cancer, suggesting a need for further investigation into its mechanisms and applications.  </a:t>
+              <a:t>   The systemic immune-inflammation index (SII) has emerged as a promising prognostic biomarker for colorectal cancer, indicating its potential utility in clinical practice.  </a:t>
             </a:r>
             <a:endParaRPr lang="en-US" sz="1200" dirty="0"/>
           </a:p>
@@ -3584,7 +3592,7 @@
                   <a:srgbClr val="FFFFFF"/>
                 </a:solidFill>
               </a:rPr>
-              <a:t>   超熱腹腔化療（HIPEC）在改善晚期結直腸癌患者的預後方面顯示出希望，這表明需要進一步研究其機制和應用。</a:t>
+              <a:t>   系統性免疫炎症指數（SII）已成為結直腸癌有前景的預後生物標記，顯示其在臨床實踐中的潛在應用。</a:t>
             </a:r>
             <a:endParaRPr lang="en-US" sz="1200" dirty="0"/>
           </a:p>
@@ -3610,7 +3618,7 @@
                   <a:srgbClr val="FFFFFF"/>
                 </a:solidFill>
               </a:rPr>
-              <a:t>4. **ω-3多不飽和脂肪酸的抗炎作用**  </a:t>
+              <a:t>4. **代謝途徑在腸道疾病中的角色**  </a:t>
             </a:r>
             <a:endParaRPr lang="en-US" sz="1200" dirty="0"/>
           </a:p>
@@ -3627,7 +3635,7 @@
                   <a:srgbClr val="FFFFFF"/>
                 </a:solidFill>
               </a:rPr>
-              <a:t>   Omega-3 polyunsaturated fatty acids (PUFAs) have demonstrated the ability to modulate inflammatory cytokines, suggesting their potential role in postoperative recovery and cancer prevention.  </a:t>
+              <a:t>   Lactate metabolism and its effects on inflammation and malignancy suggest that metabolic pathways may provide new therapeutic targets for colorectal cancer.  </a:t>
             </a:r>
             <a:endParaRPr lang="en-US" sz="1200" dirty="0"/>
           </a:p>
@@ -3644,7 +3652,7 @@
                   <a:srgbClr val="FFFFFF"/>
                 </a:solidFill>
               </a:rPr>
-              <a:t>   ω-3多不飽和脂肪酸（PUFAs）已顯示出調節炎症細胞因子的能力，暗示其在術後恢復和癌症預防中的潛在作用。</a:t>
+              <a:t>   乳酸代謝及其對炎症和惡性腫瘤的影響表明，代謝途徑可能為結直腸癌提供新的治療靶點。</a:t>
             </a:r>
             <a:endParaRPr lang="en-US" sz="1200" dirty="0"/>
           </a:p>
@@ -3670,7 +3678,7 @@
                   <a:srgbClr val="FFFFFF"/>
                 </a:solidFill>
               </a:rPr>
-              <a:t>5. **腫瘤微環境的影響**  </a:t>
+              <a:t>5. **新型治療策略的開發**  </a:t>
             </a:r>
             <a:endParaRPr lang="en-US" sz="1200" dirty="0"/>
           </a:p>
@@ -3687,7 +3695,7 @@
                   <a:srgbClr val="FFFFFF"/>
                 </a:solidFill>
               </a:rPr>
-              <a:t>   The inflammatory tumor microenvironment, particularly the role of neutrophils, plays a crucial role in colorectal cancer progression and metastasis, highlighting the need for targeted therapies.  </a:t>
+              <a:t>   The exploration of natural compounds, such as *Sanghuangporus vaninii*, reveals their dual anti-tumor effects, suggesting alternative therapeutic avenues for colitis-associated colorectal cancer.  </a:t>
             </a:r>
             <a:endParaRPr lang="en-US" sz="1200" dirty="0"/>
           </a:p>
@@ -3704,7 +3712,7 @@
                   <a:srgbClr val="FFFFFF"/>
                 </a:solidFill>
               </a:rPr>
-              <a:t>   炎症腫瘤微環境，特別是中性粒細胞的作用，在結直腸癌的進展和轉移中起著關鍵作用，突顯了針對性療法的必要性。</a:t>
+              <a:t>   對天然化合物如*Sanghuangporus vaninii*的探索顯示其雙重抗腫瘤效果，暗示對於結腸炎相關結直腸癌的替代治療途徑。</a:t>
             </a:r>
             <a:endParaRPr lang="en-US" sz="1200" dirty="0"/>
           </a:p>
@@ -3756,7 +3764,7 @@
                   <a:srgbClr val="FFFFFF"/>
                 </a:solidFill>
               </a:rPr>
-              <a:t>1. **腸道微生物的調控機制**  </a:t>
+              <a:t>1. **腸道微生物的干預研究**  </a:t>
             </a:r>
             <a:endParaRPr lang="en-US" sz="1200" dirty="0"/>
           </a:p>
@@ -3773,7 +3781,7 @@
                   <a:srgbClr val="FFFFFF"/>
                 </a:solidFill>
               </a:rPr>
-              <a:t>   Investigate the regulatory mechanisms of gut microbiota on colitis and colorectal cancer progression to identify potential therapeutic targets.  </a:t>
+              <a:t>   Future studies should investigate the therapeutic potential of modulating gut microbiota to prevent or treat colitis and colorectal cancer.  </a:t>
             </a:r>
             <a:endParaRPr lang="en-US" sz="1200" dirty="0"/>
           </a:p>
@@ -3790,7 +3798,7 @@
                   <a:srgbClr val="FFFFFF"/>
                 </a:solidFill>
               </a:rPr>
-              <a:t>   研究腸道微生物對結腸炎和結直腸癌進展的調控機制，以確定潛在的治療靶點。</a:t>
+              <a:t>   未來的研究應該探討調節腸道微生物以預防或治療結腸炎及結直腸癌的治療潛力。</a:t>
             </a:r>
             <a:endParaRPr lang="en-US" sz="1200" dirty="0"/>
           </a:p>
@@ -3816,7 +3824,7 @@
                   <a:srgbClr val="FFFFFF"/>
                 </a:solidFill>
               </a:rPr>
-              <a:t>2. **SII在臨床應用中的驗證**  </a:t>
+              <a:t>2. **免疫微環境的調控**  </a:t>
             </a:r>
             <a:endParaRPr lang="en-US" sz="1200" dirty="0"/>
           </a:p>
@@ -3833,7 +3841,7 @@
                   <a:srgbClr val="FFFFFF"/>
                 </a:solidFill>
               </a:rPr>
-              <a:t>   Further validate the systemic immune-inflammation index (SII) in diverse patient populations to enhance its predictive accuracy and clinical utility.  </a:t>
+              <a:t>   Research should focus on understanding how to manipulate organ-specific immune responses to enhance treatment efficacy in colorectal cancer metastases.  </a:t>
             </a:r>
             <a:endParaRPr lang="en-US" sz="1200" dirty="0"/>
           </a:p>
@@ -3850,7 +3858,7 @@
                   <a:srgbClr val="FFFFFF"/>
                 </a:solidFill>
               </a:rPr>
-              <a:t>   在不同患者群體中進一步驗證系統性免疫-炎症指數（SII），以提高其預測準確性和臨床實用性。</a:t>
+              <a:t>   研究應集中於理解如何操控器官特異性的免疫反應，以提高結直腸癌轉移的治療效果。</a:t>
             </a:r>
             <a:endParaRPr lang="en-US" sz="1200" dirty="0"/>
           </a:p>
@@ -3876,7 +3884,7 @@
                   <a:srgbClr val="FFFFFF"/>
                 </a:solidFill>
               </a:rPr>
-              <a:t>3. **HIPEC的機制研究**  </a:t>
+              <a:t>3. **新型生物標記的開發**  </a:t>
             </a:r>
             <a:endParaRPr lang="en-US" sz="1200" dirty="0"/>
           </a:p>
@@ -3893,7 +3901,7 @@
                   <a:srgbClr val="FFFFFF"/>
                 </a:solidFill>
               </a:rPr>
-              <a:t>   Conduct mechanistic studies on hyperthermic intraperitoneal chemotherapy (HIPEC) to optimize treatment protocols and improve patient outcomes.  </a:t>
+              <a:t>   Identifying and validating new biomarkers, including metabolic indicators, could improve patient stratification and personalized treatment in colorectal cancer.  </a:t>
             </a:r>
             <a:endParaRPr lang="en-US" sz="1200" dirty="0"/>
           </a:p>
@@ -3910,7 +3918,7 @@
                   <a:srgbClr val="FFFFFF"/>
                 </a:solidFill>
               </a:rPr>
-              <a:t>   開展超熱腹腔化療（HIPEC）的機制研究，以優化治療方案並改善患者預後。</a:t>
+              <a:t>   確定和驗證新的生物標記，包括代謝指標，可能改善結直腸癌患者的分層和個性化治療。</a:t>
             </a:r>
             <a:endParaRPr lang="en-US" sz="1200" dirty="0"/>
           </a:p>
@@ -3936,7 +3944,7 @@
                   <a:srgbClr val="FFFFFF"/>
                 </a:solidFill>
               </a:rPr>
-              <a:t>4. **ω-3脂肪酸的臨床試驗**  </a:t>
+              <a:t>4. **天然化合物的臨床應用**  </a:t>
             </a:r>
             <a:endParaRPr lang="en-US" sz="1200" dirty="0"/>
           </a:p>
@@ -3953,7 +3961,7 @@
                   <a:srgbClr val="FFFFFF"/>
                 </a:solidFill>
               </a:rPr>
-              <a:t>   Design clinical trials to assess the efficacy of omega-3 PUFAs in postoperative recovery and their potential role in reducing cancer recurrence.  </a:t>
+              <a:t>   Further clinical trials on natural compounds like *Sanghuangporus vaninii* could elucidate their mechanisms and therapeutic potential in colorectal cancer.  </a:t>
             </a:r>
             <a:endParaRPr lang="en-US" sz="1200" dirty="0"/>
           </a:p>
@@ -3970,7 +3978,7 @@
                   <a:srgbClr val="FFFFFF"/>
                 </a:solidFill>
               </a:rPr>
-              <a:t>   設計臨床試驗以評估ω-3多不飽和脂肪酸在術後恢復中的有效性及其在減少癌症復發中的潛在作用。</a:t>
+              <a:t>   對天然化合物如*Sanghuangporus vaninii*的進一步臨床試驗可以闡明其機制和在結直腸癌中的治療潛力。</a:t>
             </a:r>
             <a:endParaRPr lang="en-US" sz="1200" dirty="0"/>
           </a:p>
@@ -3996,7 +4004,7 @@
                   <a:srgbClr val="FFFFFF"/>
                 </a:solidFill>
               </a:rPr>
-              <a:t>5. **針對腫瘤微環境的療法開發**  </a:t>
+              <a:t>5. **多模態治療策略的探索**  </a:t>
             </a:r>
             <a:endParaRPr lang="en-US" sz="1200" dirty="0"/>
           </a:p>
@@ -4013,7 +4021,7 @@
                   <a:srgbClr val="FFFFFF"/>
                 </a:solidFill>
               </a:rPr>
-              <a:t>   Explore novel therapeutic strategies targeting the inflammatory tumor microenvironment, particularly focusing on neutrophil modulation and its impact on cancer progression.  </a:t>
+              <a:t>   Investigating combination therapies that integrate immunotherapy, metabolic modulation, and traditional treatments may yield better outcomes for colorectal cancer patients.  </a:t>
             </a:r>
             <a:endParaRPr lang="en-US" sz="1200" dirty="0"/>
           </a:p>
@@ -4030,34 +4038,11 @@
                   <a:srgbClr val="FFFFFF"/>
                 </a:solidFill>
               </a:rPr>
-              <a:t>   探索針對炎症腫瘤微環境的新型治療策略，特別是專注於中性粒細胞調節及其對癌症進展的影響。</a:t>
+              <a:t>   探索結合免疫療法、代謝調節和傳統治療的多模態治療策略可能為結直腸癌患者帶來更好的結果。</a:t>
             </a:r>
             <a:endParaRPr lang="en-US" sz="1200" dirty="0"/>
           </a:p>
         </p:txBody>
-      </p:sp>
-      <p:sp>
-        <p:nvSpPr>
-          <p:cNvPr id="6" name="Shape 4"/>
-          <p:cNvSpPr/>
-          <p:nvPr/>
-        </p:nvSpPr>
-        <p:spPr>
-          <a:xfrm>
-            <a:off x="0" y="6803136"/>
-            <a:ext cx="12188952" cy="0"/>
-          </a:xfrm>
-          <a:prstGeom prst="line">
-            <a:avLst/>
-          </a:prstGeom>
-          <a:noFill/>
-          <a:ln w="50800">
-            <a:solidFill>
-              <a:srgbClr val="2563EB"/>
-            </a:solidFill>
-            <a:prstDash val="solid"/>
-          </a:ln>
-        </p:spPr>
       </p:sp>
     </p:spTree>
   </p:cSld>
@@ -4132,35 +4117,12 @@
       </p:sp>
       <p:sp>
         <p:nvSpPr>
-          <p:cNvPr id="3" name="Shape 1"/>
+          <p:cNvPr id="3" name="Text 1"/>
           <p:cNvSpPr/>
           <p:nvPr/>
         </p:nvSpPr>
         <p:spPr>
           <a:xfrm>
-            <a:off x="731520" y="3474720"/>
-            <a:ext cx="2743200" cy="0"/>
-          </a:xfrm>
-          <a:prstGeom prst="line">
-            <a:avLst/>
-          </a:prstGeom>
-          <a:noFill/>
-          <a:ln w="38100">
-            <a:solidFill>
-              <a:srgbClr val="2563EB"/>
-            </a:solidFill>
-            <a:prstDash val="solid"/>
-          </a:ln>
-        </p:spPr>
-      </p:sp>
-      <p:sp>
-        <p:nvSpPr>
-          <p:cNvPr id="4" name="Text 2"/>
-          <p:cNvSpPr/>
-          <p:nvPr/>
-        </p:nvSpPr>
-        <p:spPr>
-          <a:xfrm>
             <a:off x="731520" y="3931920"/>
             <a:ext cx="10058400" cy="0"/>
           </a:xfrm>
@@ -4188,29 +4150,6 @@
             <a:endParaRPr lang="en-US" sz="1100" dirty="0"/>
           </a:p>
         </p:txBody>
-      </p:sp>
-      <p:sp>
-        <p:nvSpPr>
-          <p:cNvPr id="5" name="Shape 3"/>
-          <p:cNvSpPr/>
-          <p:nvPr/>
-        </p:nvSpPr>
-        <p:spPr>
-          <a:xfrm>
-            <a:off x="0" y="6803136"/>
-            <a:ext cx="12188952" cy="0"/>
-          </a:xfrm>
-          <a:prstGeom prst="line">
-            <a:avLst/>
-          </a:prstGeom>
-          <a:noFill/>
-          <a:ln w="50800">
-            <a:solidFill>
-              <a:srgbClr val="2563EB"/>
-            </a:solidFill>
-            <a:prstDash val="solid"/>
-          </a:ln>
-        </p:spPr>
       </p:sp>
     </p:spTree>
   </p:cSld>
@@ -4282,30 +4221,7 @@
       </p:sp>
       <p:sp>
         <p:nvSpPr>
-          <p:cNvPr id="3" name="Shape 1"/>
-          <p:cNvSpPr/>
-          <p:nvPr/>
-        </p:nvSpPr>
-        <p:spPr>
-          <a:xfrm>
-            <a:off x="731520" y="685800"/>
-            <a:ext cx="10058400" cy="0"/>
-          </a:xfrm>
-          <a:prstGeom prst="line">
-            <a:avLst/>
-          </a:prstGeom>
-          <a:noFill/>
-          <a:ln w="6350">
-            <a:solidFill>
-              <a:srgbClr val="E2E8F0"/>
-            </a:solidFill>
-            <a:prstDash val="solid"/>
-          </a:ln>
-        </p:spPr>
-      </p:sp>
-      <p:sp>
-        <p:nvSpPr>
-          <p:cNvPr id="4" name="Text 2"/>
+          <p:cNvPr id="3" name="Text 1"/>
           <p:cNvSpPr/>
           <p:nvPr/>
         </p:nvSpPr>
@@ -4393,7 +4309,7 @@
                 <a:ea typeface="Arial" pitchFamily="34" charset="-122"/>
                 <a:cs typeface="Arial" pitchFamily="34" charset="-120"/>
               </a:rPr>
-              <a:t>Effect of hyperthermic intraperitoneal chemotherapy on patients with advanced co…</a:t>
+              <a:t>Organ-specific immune and metabolic programs shape spatial microenvironments in …</a:t>
             </a:r>
             <a:endParaRPr lang="en-US" sz="1400" dirty="0"/>
           </a:p>
@@ -4430,7 +4346,7 @@
                 <a:ea typeface="Arial" pitchFamily="34" charset="-122"/>
                 <a:cs typeface="Arial" pitchFamily="34" charset="-120"/>
               </a:rPr>
-              <a:t>Prognostic value of systemic immune-inflammation index for colorectal cancer: a …</a:t>
+              <a:t>Effect of hyperthermic intraperitoneal chemotherapy on patients with advanced co…</a:t>
             </a:r>
             <a:endParaRPr lang="en-US" sz="1400" dirty="0"/>
           </a:p>
@@ -4467,7 +4383,7 @@
                 <a:ea typeface="Arial" pitchFamily="34" charset="-122"/>
                 <a:cs typeface="Arial" pitchFamily="34" charset="-120"/>
               </a:rPr>
-              <a:t>The Role of Omega-3 Polyunsaturated Fatty Acid Supplementation in Postoperative …</a:t>
+              <a:t>Prognostic value of systemic immune-inflammation index for colorectal cancer: a …</a:t>
             </a:r>
             <a:endParaRPr lang="en-US" sz="1400" dirty="0"/>
           </a:p>
@@ -4504,7 +4420,7 @@
                 <a:ea typeface="Arial" pitchFamily="34" charset="-122"/>
                 <a:cs typeface="Arial" pitchFamily="34" charset="-120"/>
               </a:rPr>
-              <a:t>Thlaspi arvense attenuates colitis-associated colorectal tumorigenesis through s…</a:t>
+              <a:t>Lactate metabolism-driven lactylation: paradoxical modulation of intestinal infl…</a:t>
             </a:r>
             <a:endParaRPr lang="en-US" sz="1400" dirty="0"/>
           </a:p>
@@ -4541,7 +4457,7 @@
                 <a:ea typeface="Arial" pitchFamily="34" charset="-122"/>
                 <a:cs typeface="Arial" pitchFamily="34" charset="-120"/>
               </a:rPr>
-              <a:t>Tumor-Derived Alpha-1 Antitrypsin Promotes Liver Metastasis of Colorectal Cancer…</a:t>
+              <a:t>Thlaspi arvense attenuates colitis-associated colorectal tumorigenesis through s…</a:t>
             </a:r>
             <a:endParaRPr lang="en-US" sz="1400" dirty="0"/>
           </a:p>
@@ -4578,7 +4494,7 @@
                 <a:ea typeface="Arial" pitchFamily="34" charset="-122"/>
                 <a:cs typeface="Arial" pitchFamily="34" charset="-120"/>
               </a:rPr>
-              <a:t>Radioiodination of Two Carborane-Based Dual Cyclooxygenase-2/5-Lipoxygenase Inhi…</a:t>
+              <a:t>Tumor-Derived Alpha-1 Antitrypsin Promotes Liver Metastasis of Colorectal Cancer…</a:t>
             </a:r>
             <a:endParaRPr lang="en-US" sz="1400" dirty="0"/>
           </a:p>
@@ -4615,7 +4531,7 @@
                 <a:ea typeface="Arial" pitchFamily="34" charset="-122"/>
                 <a:cs typeface="Arial" pitchFamily="34" charset="-120"/>
               </a:rPr>
-              <a:t>Sanghuangporus vaninii extract exerts dual anti-tumor effects in colitis-associa…</a:t>
+              <a:t>Radioiodination of Two Carborane-Based Dual Cyclooxygenase-2/5-Lipoxygenase Inhi…</a:t>
             </a:r>
             <a:endParaRPr lang="en-US" sz="1400" dirty="0"/>
           </a:p>
@@ -4652,7 +4568,7 @@
                 <a:ea typeface="Arial" pitchFamily="34" charset="-122"/>
                 <a:cs typeface="Arial" pitchFamily="34" charset="-120"/>
               </a:rPr>
-              <a:t>Repurposing PARP inhibitors in molecularly defined subgroups of peritoneal metas…</a:t>
+              <a:t>Sanghuangporus vaninii extract exerts dual anti-tumor effects in colitis-associa…</a:t>
             </a:r>
             <a:endParaRPr lang="en-US" sz="1400" dirty="0"/>
           </a:p>
@@ -4689,7 +4605,7 @@
                 <a:ea typeface="Arial" pitchFamily="34" charset="-122"/>
                 <a:cs typeface="Arial" pitchFamily="34" charset="-120"/>
               </a:rPr>
-              <a:t>The Mechanism of Acetyl-L-Carnitine on Colorectal Cancer and Its Metabolomic Stu…</a:t>
+              <a:t>Repurposing PARP inhibitors in molecularly defined subgroups of peritoneal metas…</a:t>
             </a:r>
             <a:endParaRPr lang="en-US" sz="1400" dirty="0"/>
           </a:p>
@@ -4801,7 +4717,9 @@
       </p:sp>
       <p:sp>
         <p:nvSpPr>
-          <p:cNvPr id="4" name="Text 2"/>
+          <p:cNvPr id="4" name="Text 2">
+            <a:hlinkClick r:id="rId1" tooltip=""/>
+          </p:cNvPr>
           <p:cNvSpPr/>
           <p:nvPr/>
         </p:nvSpPr>
@@ -4827,13 +4745,20 @@
               <a:buNone/>
             </a:pPr>
             <a:r>
-              <a:rPr lang="en-US" sz="2400" b="1" dirty="0">
+              <a:rPr lang="en-US" sz="2400" b="1" u="sng" dirty="0">
                 <a:solidFill>
                   <a:srgbClr val="111111"/>
                 </a:solidFill>
                 <a:latin typeface="Arial" pitchFamily="34" charset="0"/>
                 <a:ea typeface="Arial" pitchFamily="34" charset="-122"/>
                 <a:cs typeface="Arial" pitchFamily="34" charset="-120"/>
+                <a:hlinkClick r:id="rId1" invalidUrl="" action="" tgtFrame="" tooltip="" history="1" highlightClick="0" endSnd="0">
+                  <a:extLst>
+                    <a:ext uri="{A12FA001-AC4F-418D-AE19-62706E023703}">
+                      <ahyp:hlinkClr xmlns:ahyp="http://schemas.microsoft.com/office/drawing/2018/hyperlinkcolor" val="tx"/>
+                    </a:ext>
+                  </a:extLst>
+                </a:hlinkClick>
               </a:rPr>
               <a:t>Parasutterella excrementihominis exacerbates experimental colitis and colitis-associated colorectal cancer via pathogenic NETosis activation</a:t>
             </a:r>
@@ -4879,30 +4804,7 @@
       </p:sp>
       <p:sp>
         <p:nvSpPr>
-          <p:cNvPr id="6" name="Shape 4"/>
-          <p:cNvSpPr/>
-          <p:nvPr/>
-        </p:nvSpPr>
-        <p:spPr>
-          <a:xfrm>
-            <a:off x="731520" y="2148840"/>
-            <a:ext cx="10058400" cy="0"/>
-          </a:xfrm>
-          <a:prstGeom prst="line">
-            <a:avLst/>
-          </a:prstGeom>
-          <a:noFill/>
-          <a:ln w="6350">
-            <a:solidFill>
-              <a:srgbClr val="E2E8F0"/>
-            </a:solidFill>
-            <a:prstDash val="solid"/>
-          </a:ln>
-        </p:spPr>
-      </p:sp>
-      <p:sp>
-        <p:nvSpPr>
-          <p:cNvPr id="7" name="Text 5"/>
+          <p:cNvPr id="6" name="Text 4"/>
           <p:cNvSpPr/>
           <p:nvPr/>
         </p:nvSpPr>
@@ -4937,7 +4839,7 @@
                 <a:ea typeface="Arial" pitchFamily="34" charset="-122"/>
                 <a:cs typeface="Arial" pitchFamily="34" charset="-120"/>
               </a:rPr>
-              <a:t>P. excrementihominis role</a:t>
+              <a:t>Parasutterella excrementihominis role in colitis</a:t>
             </a:r>
             <a:endParaRPr lang="en-US" sz="1800" dirty="0"/>
           </a:p>
@@ -4958,7 +4860,7 @@
                 <a:ea typeface="Arial" pitchFamily="34" charset="-122"/>
                 <a:cs typeface="Arial" pitchFamily="34" charset="-120"/>
               </a:rPr>
-              <a:t>NETosis activation observed</a:t>
+              <a:t>NETosis activation linked to inflammation</a:t>
             </a:r>
             <a:endParaRPr lang="en-US" sz="1800" dirty="0"/>
           </a:p>
@@ -4979,7 +4881,7 @@
                 <a:ea typeface="Arial" pitchFamily="34" charset="-122"/>
                 <a:cs typeface="Arial" pitchFamily="34" charset="-120"/>
               </a:rPr>
-              <a:t>Colitis and cancer link</a:t>
+              <a:t>Potential therapeutic strategies for colorectal cancer</a:t>
             </a:r>
             <a:endParaRPr lang="en-US" sz="1800" dirty="0"/>
           </a:p>
@@ -4987,26 +4889,48 @@
       </p:sp>
       <p:sp>
         <p:nvSpPr>
-          <p:cNvPr id="8" name="Shape 6"/>
+          <p:cNvPr id="7" name="Text 5">
+            <a:hlinkClick r:id="rId2" tooltip=""/>
+          </p:cNvPr>
           <p:cNvSpPr/>
           <p:nvPr/>
         </p:nvSpPr>
         <p:spPr>
           <a:xfrm>
-            <a:off x="0" y="6803136"/>
-            <a:ext cx="12188952" cy="0"/>
-          </a:xfrm>
-          <a:prstGeom prst="line">
+            <a:off x="731520" y="6217920"/>
+            <a:ext cx="3657600" cy="0"/>
+          </a:xfrm>
+          <a:prstGeom prst="rect">
             <a:avLst/>
           </a:prstGeom>
           <a:noFill/>
-          <a:ln w="50800">
-            <a:solidFill>
-              <a:srgbClr val="2563EB"/>
-            </a:solidFill>
-            <a:prstDash val="solid"/>
-          </a:ln>
-        </p:spPr>
+          <a:ln/>
+        </p:spPr>
+        <p:txBody>
+          <a:bodyPr wrap="square" lIns="0" tIns="0" rIns="0" bIns="0" rtlCol="0" anchor="ctr"/>
+          <a:lstStyle/>
+          <a:p>
+            <a:pPr indent="0" marL="0">
+              <a:buNone/>
+            </a:pPr>
+            <a:r>
+              <a:rPr lang="en-US" sz="1000" b="1" u="sng" dirty="0">
+                <a:solidFill>
+                  <a:srgbClr val="2563EB"/>
+                </a:solidFill>
+                <a:hlinkClick r:id="rId2" invalidUrl="" action="" tgtFrame="" tooltip="" history="1" highlightClick="0" endSnd="0">
+                  <a:extLst>
+                    <a:ext uri="{A12FA001-AC4F-418D-AE19-62706E023703}">
+                      <ahyp:hlinkClr xmlns:ahyp="http://schemas.microsoft.com/office/drawing/2018/hyperlinkcolor" val="tx"/>
+                    </a:ext>
+                  </a:extLst>
+                </a:hlinkClick>
+              </a:rPr>
+              <a:t>📎 View Paper →</a:t>
+            </a:r>
+            <a:endParaRPr lang="en-US" sz="1000" dirty="0"/>
+          </a:p>
+        </p:txBody>
       </p:sp>
     </p:spTree>
   </p:cSld>
@@ -5114,7 +5038,9 @@
       </p:sp>
       <p:sp>
         <p:nvSpPr>
-          <p:cNvPr id="4" name="Text 2"/>
+          <p:cNvPr id="4" name="Text 2">
+            <a:hlinkClick r:id="rId1" tooltip=""/>
+          </p:cNvPr>
           <p:cNvSpPr/>
           <p:nvPr/>
         </p:nvSpPr>
@@ -5140,15 +5066,22 @@
               <a:buNone/>
             </a:pPr>
             <a:r>
-              <a:rPr lang="en-US" sz="2400" b="1" dirty="0">
+              <a:rPr lang="en-US" sz="2400" b="1" u="sng" dirty="0">
                 <a:solidFill>
                   <a:srgbClr val="111111"/>
                 </a:solidFill>
                 <a:latin typeface="Arial" pitchFamily="34" charset="0"/>
                 <a:ea typeface="Arial" pitchFamily="34" charset="-122"/>
                 <a:cs typeface="Arial" pitchFamily="34" charset="-120"/>
-              </a:rPr>
-              <a:t>Effect of hyperthermic intraperitoneal chemotherapy on patients with advanced colorectal cancer: a systematic review and meta-analysis</a:t>
+                <a:hlinkClick r:id="rId1" invalidUrl="" action="" tgtFrame="" tooltip="" history="1" highlightClick="0" endSnd="0">
+                  <a:extLst>
+                    <a:ext uri="{A12FA001-AC4F-418D-AE19-62706E023703}">
+                      <ahyp:hlinkClr xmlns:ahyp="http://schemas.microsoft.com/office/drawing/2018/hyperlinkcolor" val="tx"/>
+                    </a:ext>
+                  </a:extLst>
+                </a:hlinkClick>
+              </a:rPr>
+              <a:t>Organ-specific immune and metabolic programs shape spatial microenvironments in MSS colorectal cancer metastases</a:t>
             </a:r>
             <a:endParaRPr lang="en-US" sz="2400" dirty="0"/>
           </a:p>
@@ -5184,7 +5117,7 @@
                   <a:srgbClr val="888888"/>
                 </a:solidFill>
               </a:rPr>
-              <a:t>World Journal of …  ·  Meta-Analysis</a:t>
+              <a:t>Cancer Research  ·  IF 12.7</a:t>
             </a:r>
             <a:endParaRPr lang="en-US" sz="1000" dirty="0"/>
           </a:p>
@@ -5192,30 +5125,7 @@
       </p:sp>
       <p:sp>
         <p:nvSpPr>
-          <p:cNvPr id="6" name="Shape 4"/>
-          <p:cNvSpPr/>
-          <p:nvPr/>
-        </p:nvSpPr>
-        <p:spPr>
-          <a:xfrm>
-            <a:off x="731520" y="2148840"/>
-            <a:ext cx="10058400" cy="0"/>
-          </a:xfrm>
-          <a:prstGeom prst="line">
-            <a:avLst/>
-          </a:prstGeom>
-          <a:noFill/>
-          <a:ln w="6350">
-            <a:solidFill>
-              <a:srgbClr val="E2E8F0"/>
-            </a:solidFill>
-            <a:prstDash val="solid"/>
-          </a:ln>
-        </p:spPr>
-      </p:sp>
-      <p:sp>
-        <p:nvSpPr>
-          <p:cNvPr id="7" name="Text 5"/>
+          <p:cNvPr id="6" name="Text 4"/>
           <p:cNvSpPr/>
           <p:nvPr/>
         </p:nvSpPr>
@@ -5250,7 +5160,7 @@
                 <a:ea typeface="Arial" pitchFamily="34" charset="-122"/>
                 <a:cs typeface="Arial" pitchFamily="34" charset="-120"/>
               </a:rPr>
-              <a:t>Hyperthermic chemotherapy evaluated</a:t>
+              <a:t>T-cell infiltration varies by organ</a:t>
             </a:r>
             <a:endParaRPr lang="en-US" sz="1800" dirty="0"/>
           </a:p>
@@ -5271,7 +5181,7 @@
                 <a:ea typeface="Arial" pitchFamily="34" charset="-122"/>
                 <a:cs typeface="Arial" pitchFamily="34" charset="-120"/>
               </a:rPr>
-              <a:t>Advanced colorectal cancer focus</a:t>
+              <a:t>Liver metastases have unique microenvironments</a:t>
             </a:r>
             <a:endParaRPr lang="en-US" sz="1800" dirty="0"/>
           </a:p>
@@ -5292,7 +5202,7 @@
                 <a:ea typeface="Arial" pitchFamily="34" charset="-122"/>
                 <a:cs typeface="Arial" pitchFamily="34" charset="-120"/>
               </a:rPr>
-              <a:t>Systematic review and meta-analysis</a:t>
+              <a:t>Peritoneal metastases show distinct patterns</a:t>
             </a:r>
             <a:endParaRPr lang="en-US" sz="1800" dirty="0"/>
           </a:p>
@@ -5300,26 +5210,48 @@
       </p:sp>
       <p:sp>
         <p:nvSpPr>
-          <p:cNvPr id="8" name="Shape 6"/>
+          <p:cNvPr id="7" name="Text 5">
+            <a:hlinkClick r:id="rId2" tooltip=""/>
+          </p:cNvPr>
           <p:cNvSpPr/>
           <p:nvPr/>
         </p:nvSpPr>
         <p:spPr>
           <a:xfrm>
-            <a:off x="0" y="6803136"/>
-            <a:ext cx="12188952" cy="0"/>
-          </a:xfrm>
-          <a:prstGeom prst="line">
+            <a:off x="731520" y="6217920"/>
+            <a:ext cx="3657600" cy="0"/>
+          </a:xfrm>
+          <a:prstGeom prst="rect">
             <a:avLst/>
           </a:prstGeom>
           <a:noFill/>
-          <a:ln w="50800">
-            <a:solidFill>
-              <a:srgbClr val="2563EB"/>
-            </a:solidFill>
-            <a:prstDash val="solid"/>
-          </a:ln>
-        </p:spPr>
+          <a:ln/>
+        </p:spPr>
+        <p:txBody>
+          <a:bodyPr wrap="square" lIns="0" tIns="0" rIns="0" bIns="0" rtlCol="0" anchor="ctr"/>
+          <a:lstStyle/>
+          <a:p>
+            <a:pPr indent="0" marL="0">
+              <a:buNone/>
+            </a:pPr>
+            <a:r>
+              <a:rPr lang="en-US" sz="1000" b="1" u="sng" dirty="0">
+                <a:solidFill>
+                  <a:srgbClr val="2563EB"/>
+                </a:solidFill>
+                <a:hlinkClick r:id="rId2" invalidUrl="" action="" tgtFrame="" tooltip="" history="1" highlightClick="0" endSnd="0">
+                  <a:extLst>
+                    <a:ext uri="{A12FA001-AC4F-418D-AE19-62706E023703}">
+                      <ahyp:hlinkClr xmlns:ahyp="http://schemas.microsoft.com/office/drawing/2018/hyperlinkcolor" val="tx"/>
+                    </a:ext>
+                  </a:extLst>
+                </a:hlinkClick>
+              </a:rPr>
+              <a:t>📎 View Paper →</a:t>
+            </a:r>
+            <a:endParaRPr lang="en-US" sz="1000" dirty="0"/>
+          </a:p>
+        </p:txBody>
       </p:sp>
     </p:spTree>
   </p:cSld>
@@ -5427,7 +5359,9 @@
       </p:sp>
       <p:sp>
         <p:nvSpPr>
-          <p:cNvPr id="4" name="Text 2"/>
+          <p:cNvPr id="4" name="Text 2">
+            <a:hlinkClick r:id="rId1" tooltip=""/>
+          </p:cNvPr>
           <p:cNvSpPr/>
           <p:nvPr/>
         </p:nvSpPr>
@@ -5453,15 +5387,22 @@
               <a:buNone/>
             </a:pPr>
             <a:r>
-              <a:rPr lang="en-US" sz="2400" b="1" dirty="0">
+              <a:rPr lang="en-US" sz="2400" b="1" u="sng" dirty="0">
                 <a:solidFill>
                   <a:srgbClr val="111111"/>
                 </a:solidFill>
                 <a:latin typeface="Arial" pitchFamily="34" charset="0"/>
                 <a:ea typeface="Arial" pitchFamily="34" charset="-122"/>
                 <a:cs typeface="Arial" pitchFamily="34" charset="-120"/>
-              </a:rPr>
-              <a:t>Prognostic value of systemic immune-inflammation index for colorectal cancer: a systematic review and meta-analysis</a:t>
+                <a:hlinkClick r:id="rId1" invalidUrl="" action="" tgtFrame="" tooltip="" history="1" highlightClick="0" endSnd="0">
+                  <a:extLst>
+                    <a:ext uri="{A12FA001-AC4F-418D-AE19-62706E023703}">
+                      <ahyp:hlinkClr xmlns:ahyp="http://schemas.microsoft.com/office/drawing/2018/hyperlinkcolor" val="tx"/>
+                    </a:ext>
+                  </a:extLst>
+                </a:hlinkClick>
+              </a:rPr>
+              <a:t>Effect of hyperthermic intraperitoneal chemotherapy on patients with advanced colorectal cancer: a systematic review and meta-analysis</a:t>
             </a:r>
             <a:endParaRPr lang="en-US" sz="2400" dirty="0"/>
           </a:p>
@@ -5497,7 +5438,7 @@
                   <a:srgbClr val="888888"/>
                 </a:solidFill>
               </a:rPr>
-              <a:t>Frontiers in Oncology  ·  Meta-Analysis</a:t>
+              <a:t>World Journal of …  ·  Meta-Analysis</a:t>
             </a:r>
             <a:endParaRPr lang="en-US" sz="1000" dirty="0"/>
           </a:p>
@@ -5505,30 +5446,7 @@
       </p:sp>
       <p:sp>
         <p:nvSpPr>
-          <p:cNvPr id="6" name="Shape 4"/>
-          <p:cNvSpPr/>
-          <p:nvPr/>
-        </p:nvSpPr>
-        <p:spPr>
-          <a:xfrm>
-            <a:off x="731520" y="2148840"/>
-            <a:ext cx="10058400" cy="0"/>
-          </a:xfrm>
-          <a:prstGeom prst="line">
-            <a:avLst/>
-          </a:prstGeom>
-          <a:noFill/>
-          <a:ln w="6350">
-            <a:solidFill>
-              <a:srgbClr val="E2E8F0"/>
-            </a:solidFill>
-            <a:prstDash val="solid"/>
-          </a:ln>
-        </p:spPr>
-      </p:sp>
-      <p:sp>
-        <p:nvSpPr>
-          <p:cNvPr id="7" name="Text 5"/>
+          <p:cNvPr id="6" name="Text 4"/>
           <p:cNvSpPr/>
           <p:nvPr/>
         </p:nvSpPr>
@@ -5563,7 +5481,7 @@
                 <a:ea typeface="Arial" pitchFamily="34" charset="-122"/>
                 <a:cs typeface="Arial" pitchFamily="34" charset="-120"/>
               </a:rPr>
-              <a:t>SII as prognostic biomarker</a:t>
+              <a:t>Hyperthermic intraperitoneal chemotherapy (HIPEC) evaluated</a:t>
             </a:r>
             <a:endParaRPr lang="en-US" sz="1800" dirty="0"/>
           </a:p>
@@ -5584,7 +5502,7 @@
                 <a:ea typeface="Arial" pitchFamily="34" charset="-122"/>
                 <a:cs typeface="Arial" pitchFamily="34" charset="-120"/>
               </a:rPr>
-              <a:t>Systematic review conducted</a:t>
+              <a:t>Systematic review and meta-analysis conducted</a:t>
             </a:r>
             <a:endParaRPr lang="en-US" sz="1800" dirty="0"/>
           </a:p>
@@ -5605,34 +5523,98 @@
                 <a:ea typeface="Arial" pitchFamily="34" charset="-122"/>
                 <a:cs typeface="Arial" pitchFamily="34" charset="-120"/>
               </a:rPr>
-              <a:t>Meta-analysis results presented</a:t>
+              <a:t>Focus on advanced colorectal cancer patients</a:t>
             </a:r>
             <a:endParaRPr lang="en-US" sz="1800" dirty="0"/>
           </a:p>
-        </p:txBody>
-      </p:sp>
-      <p:sp>
-        <p:nvSpPr>
-          <p:cNvPr id="8" name="Shape 6"/>
+          <a:p>
+            <a:pPr marL="342900" indent="-342900">
+              <a:spcAft>
+                <a:spcPts val="800"/>
+              </a:spcAft>
+              <a:buSzPct val="100000"/>
+              <a:buChar char="•"/>
+            </a:pPr>
+            <a:r>
+              <a:rPr lang="en-US" sz="1800" dirty="0">
+                <a:solidFill>
+                  <a:srgbClr val="333333"/>
+                </a:solidFill>
+                <a:latin typeface="Arial" pitchFamily="34" charset="0"/>
+                <a:ea typeface="Arial" pitchFamily="34" charset="-122"/>
+                <a:cs typeface="Arial" pitchFamily="34" charset="-120"/>
+              </a:rPr>
+              <a:t>Impact on peritoneal metastases assessed</a:t>
+            </a:r>
+            <a:endParaRPr lang="en-US" sz="1800" dirty="0"/>
+          </a:p>
+          <a:p>
+            <a:pPr marL="342900" indent="-342900">
+              <a:spcAft>
+                <a:spcPts val="800"/>
+              </a:spcAft>
+              <a:buSzPct val="100000"/>
+              <a:buChar char="•"/>
+            </a:pPr>
+            <a:r>
+              <a:rPr lang="en-US" sz="1800" dirty="0">
+                <a:solidFill>
+                  <a:srgbClr val="333333"/>
+                </a:solidFill>
+                <a:latin typeface="Arial" pitchFamily="34" charset="0"/>
+                <a:ea typeface="Arial" pitchFamily="34" charset="-122"/>
+                <a:cs typeface="Arial" pitchFamily="34" charset="-120"/>
+              </a:rPr>
+              <a:t>Findings suggest potential treatment benefits</a:t>
+            </a:r>
+            <a:endParaRPr lang="en-US" sz="1800" dirty="0"/>
+          </a:p>
+        </p:txBody>
+      </p:sp>
+      <p:sp>
+        <p:nvSpPr>
+          <p:cNvPr id="7" name="Text 5">
+            <a:hlinkClick r:id="rId2" tooltip=""/>
+          </p:cNvPr>
           <p:cNvSpPr/>
           <p:nvPr/>
         </p:nvSpPr>
         <p:spPr>
           <a:xfrm>
-            <a:off x="0" y="6803136"/>
-            <a:ext cx="12188952" cy="0"/>
-          </a:xfrm>
-          <a:prstGeom prst="line">
+            <a:off x="731520" y="6217920"/>
+            <a:ext cx="3657600" cy="0"/>
+          </a:xfrm>
+          <a:prstGeom prst="rect">
             <a:avLst/>
           </a:prstGeom>
           <a:noFill/>
-          <a:ln w="50800">
-            <a:solidFill>
-              <a:srgbClr val="2563EB"/>
-            </a:solidFill>
-            <a:prstDash val="solid"/>
-          </a:ln>
-        </p:spPr>
+          <a:ln/>
+        </p:spPr>
+        <p:txBody>
+          <a:bodyPr wrap="square" lIns="0" tIns="0" rIns="0" bIns="0" rtlCol="0" anchor="ctr"/>
+          <a:lstStyle/>
+          <a:p>
+            <a:pPr indent="0" marL="0">
+              <a:buNone/>
+            </a:pPr>
+            <a:r>
+              <a:rPr lang="en-US" sz="1000" b="1" u="sng" dirty="0">
+                <a:solidFill>
+                  <a:srgbClr val="2563EB"/>
+                </a:solidFill>
+                <a:hlinkClick r:id="rId2" invalidUrl="" action="" tgtFrame="" tooltip="" history="1" highlightClick="0" endSnd="0">
+                  <a:extLst>
+                    <a:ext uri="{A12FA001-AC4F-418D-AE19-62706E023703}">
+                      <ahyp:hlinkClr xmlns:ahyp="http://schemas.microsoft.com/office/drawing/2018/hyperlinkcolor" val="tx"/>
+                    </a:ext>
+                  </a:extLst>
+                </a:hlinkClick>
+              </a:rPr>
+              <a:t>📎 View Paper →</a:t>
+            </a:r>
+            <a:endParaRPr lang="en-US" sz="1000" dirty="0"/>
+          </a:p>
+        </p:txBody>
       </p:sp>
     </p:spTree>
   </p:cSld>
@@ -5740,7 +5722,9 @@
       </p:sp>
       <p:sp>
         <p:nvSpPr>
-          <p:cNvPr id="4" name="Text 2"/>
+          <p:cNvPr id="4" name="Text 2">
+            <a:hlinkClick r:id="rId1" tooltip=""/>
+          </p:cNvPr>
           <p:cNvSpPr/>
           <p:nvPr/>
         </p:nvSpPr>
@@ -5766,15 +5750,22 @@
               <a:buNone/>
             </a:pPr>
             <a:r>
-              <a:rPr lang="en-US" sz="2400" b="1" dirty="0">
+              <a:rPr lang="en-US" sz="2400" b="1" u="sng" dirty="0">
                 <a:solidFill>
                   <a:srgbClr val="111111"/>
                 </a:solidFill>
                 <a:latin typeface="Arial" pitchFamily="34" charset="0"/>
                 <a:ea typeface="Arial" pitchFamily="34" charset="-122"/>
                 <a:cs typeface="Arial" pitchFamily="34" charset="-120"/>
-              </a:rPr>
-              <a:t>The Role of Omega-3 Polyunsaturated Fatty Acid Supplementation in Postoperative Recovery of Colorectal Cancer: Systematic Review and Meta-Analysis</a:t>
+                <a:hlinkClick r:id="rId1" invalidUrl="" action="" tgtFrame="" tooltip="" history="1" highlightClick="0" endSnd="0">
+                  <a:extLst>
+                    <a:ext uri="{A12FA001-AC4F-418D-AE19-62706E023703}">
+                      <ahyp:hlinkClr xmlns:ahyp="http://schemas.microsoft.com/office/drawing/2018/hyperlinkcolor" val="tx"/>
+                    </a:ext>
+                  </a:extLst>
+                </a:hlinkClick>
+              </a:rPr>
+              <a:t>Prognostic value of systemic immune-inflammation index for colorectal cancer: a systematic review and meta-analysis</a:t>
             </a:r>
             <a:endParaRPr lang="en-US" sz="2400" dirty="0"/>
           </a:p>
@@ -5810,7 +5801,7 @@
                   <a:srgbClr val="888888"/>
                 </a:solidFill>
               </a:rPr>
-              <a:t>Nutrients  ·  Meta-Analysis</a:t>
+              <a:t>Frontiers in Oncology  ·  Meta-Analysis</a:t>
             </a:r>
             <a:endParaRPr lang="en-US" sz="1000" dirty="0"/>
           </a:p>
@@ -5818,30 +5809,7 @@
       </p:sp>
       <p:sp>
         <p:nvSpPr>
-          <p:cNvPr id="6" name="Shape 4"/>
-          <p:cNvSpPr/>
-          <p:nvPr/>
-        </p:nvSpPr>
-        <p:spPr>
-          <a:xfrm>
-            <a:off x="731520" y="2148840"/>
-            <a:ext cx="10058400" cy="0"/>
-          </a:xfrm>
-          <a:prstGeom prst="line">
-            <a:avLst/>
-          </a:prstGeom>
-          <a:noFill/>
-          <a:ln w="6350">
-            <a:solidFill>
-              <a:srgbClr val="E2E8F0"/>
-            </a:solidFill>
-            <a:prstDash val="solid"/>
-          </a:ln>
-        </p:spPr>
-      </p:sp>
-      <p:sp>
-        <p:nvSpPr>
-          <p:cNvPr id="7" name="Text 5"/>
+          <p:cNvPr id="6" name="Text 4"/>
           <p:cNvSpPr/>
           <p:nvPr/>
         </p:nvSpPr>
@@ -5876,7 +5844,7 @@
                 <a:ea typeface="Arial" pitchFamily="34" charset="-122"/>
                 <a:cs typeface="Arial" pitchFamily="34" charset="-120"/>
               </a:rPr>
-              <a:t>Omega-3 PUFAs aid recovery</a:t>
+              <a:t>Systemic immune-inflammation index (SII) evaluated.</a:t>
             </a:r>
             <a:endParaRPr lang="en-US" sz="1800" dirty="0"/>
           </a:p>
@@ -5897,7 +5865,7 @@
                 <a:ea typeface="Arial" pitchFamily="34" charset="-122"/>
                 <a:cs typeface="Arial" pitchFamily="34" charset="-120"/>
               </a:rPr>
-              <a:t>Reduce inflammatory cytokines</a:t>
+              <a:t>SII as a prognostic biomarker in CRC.</a:t>
             </a:r>
             <a:endParaRPr lang="en-US" sz="1800" dirty="0"/>
           </a:p>
@@ -5918,34 +5886,98 @@
                 <a:ea typeface="Arial" pitchFamily="34" charset="-122"/>
                 <a:cs typeface="Arial" pitchFamily="34" charset="-120"/>
               </a:rPr>
-              <a:t>Inverse relation with inflammation</a:t>
+              <a:t>Meta-analysis of existing studies conducted.</a:t>
             </a:r>
             <a:endParaRPr lang="en-US" sz="1800" dirty="0"/>
           </a:p>
-        </p:txBody>
-      </p:sp>
-      <p:sp>
-        <p:nvSpPr>
-          <p:cNvPr id="8" name="Shape 6"/>
+          <a:p>
+            <a:pPr marL="342900" indent="-342900">
+              <a:spcAft>
+                <a:spcPts val="800"/>
+              </a:spcAft>
+              <a:buSzPct val="100000"/>
+              <a:buChar char="•"/>
+            </a:pPr>
+            <a:r>
+              <a:rPr lang="en-US" sz="1800" dirty="0">
+                <a:solidFill>
+                  <a:srgbClr val="333333"/>
+                </a:solidFill>
+                <a:latin typeface="Arial" pitchFamily="34" charset="0"/>
+                <a:ea typeface="Arial" pitchFamily="34" charset="-122"/>
+                <a:cs typeface="Arial" pitchFamily="34" charset="-120"/>
+              </a:rPr>
+              <a:t>SII correlates with patient outcomes.</a:t>
+            </a:r>
+            <a:endParaRPr lang="en-US" sz="1800" dirty="0"/>
+          </a:p>
+          <a:p>
+            <a:pPr marL="342900" indent="-342900">
+              <a:spcAft>
+                <a:spcPts val="800"/>
+              </a:spcAft>
+              <a:buSzPct val="100000"/>
+              <a:buChar char="•"/>
+            </a:pPr>
+            <a:r>
+              <a:rPr lang="en-US" sz="1800" dirty="0">
+                <a:solidFill>
+                  <a:srgbClr val="333333"/>
+                </a:solidFill>
+                <a:latin typeface="Arial" pitchFamily="34" charset="0"/>
+                <a:ea typeface="Arial" pitchFamily="34" charset="-122"/>
+                <a:cs typeface="Arial" pitchFamily="34" charset="-120"/>
+              </a:rPr>
+              <a:t>Potential for personalized treatment strategies.</a:t>
+            </a:r>
+            <a:endParaRPr lang="en-US" sz="1800" dirty="0"/>
+          </a:p>
+        </p:txBody>
+      </p:sp>
+      <p:sp>
+        <p:nvSpPr>
+          <p:cNvPr id="7" name="Text 5">
+            <a:hlinkClick r:id="rId2" tooltip=""/>
+          </p:cNvPr>
           <p:cNvSpPr/>
           <p:nvPr/>
         </p:nvSpPr>
         <p:spPr>
           <a:xfrm>
-            <a:off x="0" y="6803136"/>
-            <a:ext cx="12188952" cy="0"/>
-          </a:xfrm>
-          <a:prstGeom prst="line">
+            <a:off x="731520" y="6217920"/>
+            <a:ext cx="3657600" cy="0"/>
+          </a:xfrm>
+          <a:prstGeom prst="rect">
             <a:avLst/>
           </a:prstGeom>
           <a:noFill/>
-          <a:ln w="50800">
-            <a:solidFill>
-              <a:srgbClr val="2563EB"/>
-            </a:solidFill>
-            <a:prstDash val="solid"/>
-          </a:ln>
-        </p:spPr>
+          <a:ln/>
+        </p:spPr>
+        <p:txBody>
+          <a:bodyPr wrap="square" lIns="0" tIns="0" rIns="0" bIns="0" rtlCol="0" anchor="ctr"/>
+          <a:lstStyle/>
+          <a:p>
+            <a:pPr indent="0" marL="0">
+              <a:buNone/>
+            </a:pPr>
+            <a:r>
+              <a:rPr lang="en-US" sz="1000" b="1" u="sng" dirty="0">
+                <a:solidFill>
+                  <a:srgbClr val="2563EB"/>
+                </a:solidFill>
+                <a:hlinkClick r:id="rId2" invalidUrl="" action="" tgtFrame="" tooltip="" history="1" highlightClick="0" endSnd="0">
+                  <a:extLst>
+                    <a:ext uri="{A12FA001-AC4F-418D-AE19-62706E023703}">
+                      <ahyp:hlinkClr xmlns:ahyp="http://schemas.microsoft.com/office/drawing/2018/hyperlinkcolor" val="tx"/>
+                    </a:ext>
+                  </a:extLst>
+                </a:hlinkClick>
+              </a:rPr>
+              <a:t>📎 View Paper →</a:t>
+            </a:r>
+            <a:endParaRPr lang="en-US" sz="1000" dirty="0"/>
+          </a:p>
+        </p:txBody>
       </p:sp>
     </p:spTree>
   </p:cSld>
@@ -6096,7 +6128,7 @@
                   </a:extLst>
                 </a:hlinkClick>
               </a:rPr>
-              <a:t>Thlaspi arvense attenuates colitis-associated colorectal tumorigenesis through suppression of neutrophil recruitment via the NOD/NF-&amp;#x3ba;B pathway.</a:t>
+              <a:t>Lactate metabolism-driven lactylation: paradoxical modulation of intestinal inflammation and malignancy.</a:t>
             </a:r>
             <a:endParaRPr lang="en-US" sz="2400" dirty="0"/>
           </a:p>
@@ -6132,7 +6164,7 @@
                   <a:srgbClr val="888888"/>
                 </a:solidFill>
               </a:rPr>
-              <a:t>Chinese medicine  ·  Basic Research</a:t>
+              <a:t>Journal of translational medicine  ·  IF 6.1  ·  Review</a:t>
             </a:r>
             <a:endParaRPr lang="en-US" sz="1000" dirty="0"/>
           </a:p>
@@ -6140,30 +6172,7 @@
       </p:sp>
       <p:sp>
         <p:nvSpPr>
-          <p:cNvPr id="6" name="Shape 4"/>
-          <p:cNvSpPr/>
-          <p:nvPr/>
-        </p:nvSpPr>
-        <p:spPr>
-          <a:xfrm>
-            <a:off x="731520" y="2148840"/>
-            <a:ext cx="10058400" cy="0"/>
-          </a:xfrm>
-          <a:prstGeom prst="line">
-            <a:avLst/>
-          </a:prstGeom>
-          <a:noFill/>
-          <a:ln w="6350">
-            <a:solidFill>
-              <a:srgbClr val="E2E8F0"/>
-            </a:solidFill>
-            <a:prstDash val="solid"/>
-          </a:ln>
-        </p:spPr>
-      </p:sp>
-      <p:sp>
-        <p:nvSpPr>
-          <p:cNvPr id="7" name="Text 5"/>
+          <p:cNvPr id="6" name="Text 4"/>
           <p:cNvSpPr/>
           <p:nvPr/>
         </p:nvSpPr>
@@ -6198,7 +6207,7 @@
                 <a:ea typeface="Arial" pitchFamily="34" charset="-122"/>
                 <a:cs typeface="Arial" pitchFamily="34" charset="-120"/>
               </a:rPr>
-              <a:t>Thlaspi arvense reduces colitis severity</a:t>
+              <a:t>Lactate metabolism impacts gut inflammation.</a:t>
             </a:r>
             <a:endParaRPr lang="en-US" sz="1800" dirty="0"/>
           </a:p>
@@ -6219,7 +6228,7 @@
                 <a:ea typeface="Arial" pitchFamily="34" charset="-122"/>
                 <a:cs typeface="Arial" pitchFamily="34" charset="-120"/>
               </a:rPr>
-              <a:t>Inhibits neutrophil recruitment effectively</a:t>
+              <a:t>Lactylation modulates immune responses paradoxically.</a:t>
             </a:r>
             <a:endParaRPr lang="en-US" sz="1800" dirty="0"/>
           </a:p>
@@ -6240,7 +6249,7 @@
                 <a:ea typeface="Arial" pitchFamily="34" charset="-122"/>
                 <a:cs typeface="Arial" pitchFamily="34" charset="-120"/>
               </a:rPr>
-              <a:t>Targets NOD/NF-κB signaling pathway</a:t>
+              <a:t>Targeting lactate offers therapeutic strategies.</a:t>
             </a:r>
             <a:endParaRPr lang="en-US" sz="1800" dirty="0"/>
           </a:p>
@@ -6248,7 +6257,7 @@
       </p:sp>
       <p:sp>
         <p:nvSpPr>
-          <p:cNvPr id="8" name="Text 6">
+          <p:cNvPr id="7" name="Text 5">
             <a:hlinkClick r:id="rId2" tooltip=""/>
           </p:cNvPr>
           <p:cNvSpPr/>
@@ -6290,29 +6299,6 @@
             <a:endParaRPr lang="en-US" sz="1000" dirty="0"/>
           </a:p>
         </p:txBody>
-      </p:sp>
-      <p:sp>
-        <p:nvSpPr>
-          <p:cNvPr id="9" name="Shape 7"/>
-          <p:cNvSpPr/>
-          <p:nvPr/>
-        </p:nvSpPr>
-        <p:spPr>
-          <a:xfrm>
-            <a:off x="0" y="6803136"/>
-            <a:ext cx="12188952" cy="0"/>
-          </a:xfrm>
-          <a:prstGeom prst="line">
-            <a:avLst/>
-          </a:prstGeom>
-          <a:noFill/>
-          <a:ln w="50800">
-            <a:solidFill>
-              <a:srgbClr val="2563EB"/>
-            </a:solidFill>
-            <a:prstDash val="solid"/>
-          </a:ln>
-        </p:spPr>
       </p:sp>
     </p:spTree>
   </p:cSld>
@@ -6463,7 +6449,7 @@
                   </a:extLst>
                 </a:hlinkClick>
               </a:rPr>
-              <a:t>Tumor-Derived Alpha-1 Antitrypsin Promotes Liver Metastasis of Colorectal Cancer Through the Neutrophil Extracellular Traps-CCDC25 Pathway.</a:t>
+              <a:t>Thlaspi arvense attenuates colitis-associated colorectal tumorigenesis through suppression of neutrophil recruitment via the NOD/NF-&amp;#x3ba;B pathway.</a:t>
             </a:r>
             <a:endParaRPr lang="en-US" sz="2400" dirty="0"/>
           </a:p>
@@ -6499,7 +6485,7 @@
                   <a:srgbClr val="888888"/>
                 </a:solidFill>
               </a:rPr>
-              <a:t>Advanced science (Weinheim, Baden-Wurttemberg, Germany)  ·  Basic Research</a:t>
+              <a:t>Chinese medicine  ·  Basic Research</a:t>
             </a:r>
             <a:endParaRPr lang="en-US" sz="1000" dirty="0"/>
           </a:p>
@@ -6507,30 +6493,7 @@
       </p:sp>
       <p:sp>
         <p:nvSpPr>
-          <p:cNvPr id="6" name="Shape 4"/>
-          <p:cNvSpPr/>
-          <p:nvPr/>
-        </p:nvSpPr>
-        <p:spPr>
-          <a:xfrm>
-            <a:off x="731520" y="2148840"/>
-            <a:ext cx="10058400" cy="0"/>
-          </a:xfrm>
-          <a:prstGeom prst="line">
-            <a:avLst/>
-          </a:prstGeom>
-          <a:noFill/>
-          <a:ln w="6350">
-            <a:solidFill>
-              <a:srgbClr val="E2E8F0"/>
-            </a:solidFill>
-            <a:prstDash val="solid"/>
-          </a:ln>
-        </p:spPr>
-      </p:sp>
-      <p:sp>
-        <p:nvSpPr>
-          <p:cNvPr id="7" name="Text 5"/>
+          <p:cNvPr id="6" name="Text 4"/>
           <p:cNvSpPr/>
           <p:nvPr/>
         </p:nvSpPr>
@@ -6565,7 +6528,7 @@
                 <a:ea typeface="Arial" pitchFamily="34" charset="-122"/>
                 <a:cs typeface="Arial" pitchFamily="34" charset="-120"/>
               </a:rPr>
-              <a:t>A1AT promotes CRC liver metastasis</a:t>
+              <a:t>Thlaspi arvense reduces colitis-associated tumorigenesis.</a:t>
             </a:r>
             <a:endParaRPr lang="en-US" sz="1800" dirty="0"/>
           </a:p>
@@ -6586,7 +6549,7 @@
                 <a:ea typeface="Arial" pitchFamily="34" charset="-122"/>
                 <a:cs typeface="Arial" pitchFamily="34" charset="-120"/>
               </a:rPr>
-              <a:t>Involves neutrophil extracellular traps</a:t>
+              <a:t>Inhibits neutrophil recruitment via NOD/NF-κB pathway.</a:t>
             </a:r>
             <a:endParaRPr lang="en-US" sz="1800" dirty="0"/>
           </a:p>
@@ -6607,57 +6570,15 @@
                 <a:ea typeface="Arial" pitchFamily="34" charset="-122"/>
                 <a:cs typeface="Arial" pitchFamily="34" charset="-120"/>
               </a:rPr>
-              <a:t>CCDC25 upregulation enhances invasion</a:t>
+              <a:t>Restores mucosal integrity and tight junction proteins.</a:t>
             </a:r>
             <a:endParaRPr lang="en-US" sz="1800" dirty="0"/>
           </a:p>
-          <a:p>
-            <a:pPr marL="342900" indent="-342900">
-              <a:spcAft>
-                <a:spcPts val="800"/>
-              </a:spcAft>
-              <a:buSzPct val="100000"/>
-              <a:buChar char="•"/>
-            </a:pPr>
-            <a:r>
-              <a:rPr lang="en-US" sz="1800" dirty="0">
-                <a:solidFill>
-                  <a:srgbClr val="333333"/>
-                </a:solidFill>
-                <a:latin typeface="Arial" pitchFamily="34" charset="0"/>
-                <a:ea typeface="Arial" pitchFamily="34" charset="-122"/>
-                <a:cs typeface="Arial" pitchFamily="34" charset="-120"/>
-              </a:rPr>
-              <a:t>ILK-RAC1-CDC42 signaling activated</a:t>
-            </a:r>
-            <a:endParaRPr lang="en-US" sz="1800" dirty="0"/>
-          </a:p>
-          <a:p>
-            <a:pPr marL="342900" indent="-342900">
-              <a:spcAft>
-                <a:spcPts val="800"/>
-              </a:spcAft>
-              <a:buSzPct val="100000"/>
-              <a:buChar char="•"/>
-            </a:pPr>
-            <a:r>
-              <a:rPr lang="en-US" sz="1800" dirty="0">
-                <a:solidFill>
-                  <a:srgbClr val="333333"/>
-                </a:solidFill>
-                <a:latin typeface="Arial" pitchFamily="34" charset="0"/>
-                <a:ea typeface="Arial" pitchFamily="34" charset="-122"/>
-                <a:cs typeface="Arial" pitchFamily="34" charset="-120"/>
-              </a:rPr>
-              <a:t>Potential biomarkers and targets identified</a:t>
-            </a:r>
-            <a:endParaRPr lang="en-US" sz="1800" dirty="0"/>
-          </a:p>
-        </p:txBody>
-      </p:sp>
-      <p:sp>
-        <p:nvSpPr>
-          <p:cNvPr id="8" name="Text 6">
+        </p:txBody>
+      </p:sp>
+      <p:sp>
+        <p:nvSpPr>
+          <p:cNvPr id="7" name="Text 5">
             <a:hlinkClick r:id="rId2" tooltip=""/>
           </p:cNvPr>
           <p:cNvSpPr/>
@@ -6699,29 +6620,6 @@
             <a:endParaRPr lang="en-US" sz="1000" dirty="0"/>
           </a:p>
         </p:txBody>
-      </p:sp>
-      <p:sp>
-        <p:nvSpPr>
-          <p:cNvPr id="9" name="Shape 7"/>
-          <p:cNvSpPr/>
-          <p:nvPr/>
-        </p:nvSpPr>
-        <p:spPr>
-          <a:xfrm>
-            <a:off x="0" y="6803136"/>
-            <a:ext cx="12188952" cy="0"/>
-          </a:xfrm>
-          <a:prstGeom prst="line">
-            <a:avLst/>
-          </a:prstGeom>
-          <a:noFill/>
-          <a:ln w="50800">
-            <a:solidFill>
-              <a:srgbClr val="2563EB"/>
-            </a:solidFill>
-            <a:prstDash val="solid"/>
-          </a:ln>
-        </p:spPr>
       </p:sp>
     </p:spTree>
   </p:cSld>
@@ -6872,7 +6770,7 @@
                   </a:extLst>
                 </a:hlinkClick>
               </a:rPr>
-              <a:t>Radioiodination of Two Carborane-Based Dual Cyclooxygenase-2/5-Lipoxygenase Inhibitors and Their In Vitro and In Vivo Evaluation.</a:t>
+              <a:t>Tumor-Derived Alpha-1 Antitrypsin Promotes Liver Metastasis of Colorectal Cancer Through the Neutrophil Extracellular Traps-CCDC25 Pathway.</a:t>
             </a:r>
             <a:endParaRPr lang="en-US" sz="2400" dirty="0"/>
           </a:p>
@@ -6908,7 +6806,7 @@
                   <a:srgbClr val="888888"/>
                 </a:solidFill>
               </a:rPr>
-              <a:t>Chembiochem : a European journal of chemical biology  ·  Basic Research</a:t>
+              <a:t>Advanced science (Weinheim, Baden-Wurttemberg, Germany)  ·  Basic Research</a:t>
             </a:r>
             <a:endParaRPr lang="en-US" sz="1000" dirty="0"/>
           </a:p>
@@ -6916,30 +6814,7 @@
       </p:sp>
       <p:sp>
         <p:nvSpPr>
-          <p:cNvPr id="6" name="Shape 4"/>
-          <p:cNvSpPr/>
-          <p:nvPr/>
-        </p:nvSpPr>
-        <p:spPr>
-          <a:xfrm>
-            <a:off x="731520" y="2148840"/>
-            <a:ext cx="10058400" cy="0"/>
-          </a:xfrm>
-          <a:prstGeom prst="line">
-            <a:avLst/>
-          </a:prstGeom>
-          <a:noFill/>
-          <a:ln w="6350">
-            <a:solidFill>
-              <a:srgbClr val="E2E8F0"/>
-            </a:solidFill>
-            <a:prstDash val="solid"/>
-          </a:ln>
-        </p:spPr>
-      </p:sp>
-      <p:sp>
-        <p:nvSpPr>
-          <p:cNvPr id="7" name="Text 5"/>
+          <p:cNvPr id="6" name="Text 4"/>
           <p:cNvSpPr/>
           <p:nvPr/>
         </p:nvSpPr>
@@ -6974,7 +6849,7 @@
                 <a:ea typeface="Arial" pitchFamily="34" charset="-122"/>
                 <a:cs typeface="Arial" pitchFamily="34" charset="-120"/>
               </a:rPr>
-              <a:t>COX-2 and 5-LO targets</a:t>
+              <a:t>A1AT promotes CRC liver metastasis.</a:t>
             </a:r>
             <a:endParaRPr lang="en-US" sz="1800" dirty="0"/>
           </a:p>
@@ -6995,7 +6870,7 @@
                 <a:ea typeface="Arial" pitchFamily="34" charset="-122"/>
                 <a:cs typeface="Arial" pitchFamily="34" charset="-120"/>
               </a:rPr>
-              <a:t>Iodinated inhibitors evaluated</a:t>
+              <a:t>Neutrophil extracellular traps (NETs) involved.</a:t>
             </a:r>
             <a:endParaRPr lang="en-US" sz="1800" dirty="0"/>
           </a:p>
@@ -7016,7 +6891,7 @@
                 <a:ea typeface="Arial" pitchFamily="34" charset="-122"/>
                 <a:cs typeface="Arial" pitchFamily="34" charset="-120"/>
               </a:rPr>
-              <a:t>In vivo imaging challenges</a:t>
+              <a:t>CCDC25 upregulation enhances tumor cell invasion.</a:t>
             </a:r>
             <a:endParaRPr lang="en-US" sz="1800" dirty="0"/>
           </a:p>
@@ -7024,7 +6899,7 @@
       </p:sp>
       <p:sp>
         <p:nvSpPr>
-          <p:cNvPr id="8" name="Text 6">
+          <p:cNvPr id="7" name="Text 5">
             <a:hlinkClick r:id="rId2" tooltip=""/>
           </p:cNvPr>
           <p:cNvSpPr/>
@@ -7066,29 +6941,6 @@
             <a:endParaRPr lang="en-US" sz="1000" dirty="0"/>
           </a:p>
         </p:txBody>
-      </p:sp>
-      <p:sp>
-        <p:nvSpPr>
-          <p:cNvPr id="9" name="Shape 7"/>
-          <p:cNvSpPr/>
-          <p:nvPr/>
-        </p:nvSpPr>
-        <p:spPr>
-          <a:xfrm>
-            <a:off x="0" y="6803136"/>
-            <a:ext cx="12188952" cy="0"/>
-          </a:xfrm>
-          <a:prstGeom prst="line">
-            <a:avLst/>
-          </a:prstGeom>
-          <a:noFill/>
-          <a:ln w="50800">
-            <a:solidFill>
-              <a:srgbClr val="2563EB"/>
-            </a:solidFill>
-            <a:prstDash val="solid"/>
-          </a:ln>
-        </p:spPr>
       </p:sp>
     </p:spTree>
   </p:cSld>

</xml_diff>

<commit_message>
chore: update weekly digest 2026-04-20
</commit_message>
<xml_diff>
--- a/docs/digest-en.pptx
+++ b/docs/digest-en.pptx
@@ -2249,7 +2249,7 @@
                   <a:srgbClr val="888888"/>
                 </a:solidFill>
               </a:rPr>
-              <a:t>2026-04-12 — 2026-04-19</a:t>
+              <a:t>2026-04-13 — 2026-04-20</a:t>
             </a:r>
             <a:endParaRPr lang="en-US" sz="1400" dirty="0"/>
           </a:p>
@@ -2561,15 +2561,93 @@
                 <a:ea typeface="Arial" pitchFamily="34" charset="-122"/>
                 <a:cs typeface="Arial" pitchFamily="34" charset="-120"/>
               </a:rPr>
-              <a:t>Radiotracer uptake influenced by 5-LO</a:t>
+              <a:t>Cellular uptake linked to 5-LO expression</a:t>
             </a:r>
             <a:endParaRPr lang="en-US" sz="1800" dirty="0"/>
           </a:p>
-        </p:txBody>
-      </p:sp>
-      <p:sp>
-        <p:nvSpPr>
-          <p:cNvPr id="7" name="Text 5">
+          <a:p>
+            <a:pPr marL="342900" indent="-342900">
+              <a:spcAft>
+                <a:spcPts val="800"/>
+              </a:spcAft>
+              <a:buSzPct val="100000"/>
+              <a:buChar char="•"/>
+            </a:pPr>
+            <a:r>
+              <a:rPr lang="en-US" sz="1800" dirty="0">
+                <a:solidFill>
+                  <a:srgbClr val="333333"/>
+                </a:solidFill>
+                <a:latin typeface="Arial" pitchFamily="34" charset="0"/>
+                <a:ea typeface="Arial" pitchFamily="34" charset="-122"/>
+                <a:cs typeface="Arial" pitchFamily="34" charset="-120"/>
+              </a:rPr>
+              <a:t>No tumor retention in mouse models</a:t>
+            </a:r>
+            <a:endParaRPr lang="en-US" sz="1800" dirty="0"/>
+          </a:p>
+          <a:p>
+            <a:pPr marL="342900" indent="-342900">
+              <a:spcAft>
+                <a:spcPts val="800"/>
+              </a:spcAft>
+              <a:buSzPct val="100000"/>
+              <a:buChar char="•"/>
+            </a:pPr>
+            <a:r>
+              <a:rPr lang="en-US" sz="1800" dirty="0">
+                <a:solidFill>
+                  <a:srgbClr val="333333"/>
+                </a:solidFill>
+                <a:latin typeface="Arial" pitchFamily="34" charset="0"/>
+                <a:ea typeface="Arial" pitchFamily="34" charset="-122"/>
+                <a:cs typeface="Arial" pitchFamily="34" charset="-120"/>
+              </a:rPr>
+              <a:t>Improved stability needed for radiotracers</a:t>
+            </a:r>
+            <a:endParaRPr lang="en-US" sz="1800" dirty="0"/>
+          </a:p>
+        </p:txBody>
+      </p:sp>
+      <p:sp>
+        <p:nvSpPr>
+          <p:cNvPr id="7" name="Text 5"/>
+          <p:cNvSpPr/>
+          <p:nvPr/>
+        </p:nvSpPr>
+        <p:spPr>
+          <a:xfrm>
+            <a:off x="731520" y="5852160"/>
+            <a:ext cx="10058400" cy="0"/>
+          </a:xfrm>
+          <a:prstGeom prst="rect">
+            <a:avLst/>
+          </a:prstGeom>
+          <a:noFill/>
+          <a:ln/>
+        </p:spPr>
+        <p:txBody>
+          <a:bodyPr wrap="square" lIns="0" tIns="0" rIns="0" bIns="0" rtlCol="0" anchor="ctr"/>
+          <a:lstStyle/>
+          <a:p>
+            <a:pPr indent="0" marL="0">
+              <a:buNone/>
+            </a:pPr>
+            <a:r>
+              <a:rPr lang="en-US" sz="800" dirty="0">
+                <a:solidFill>
+                  <a:srgbClr val="888888"/>
+                </a:solidFill>
+              </a:rPr>
+              <a:t>Sch&amp;#xe4;dlich Jonas, Ullrich Martin, Haase-Kohn Cathleen et al.. Chembiochem : a European journal of chemical biology. 2026-04-01 DOI: 10.1002/cbic.202600004</a:t>
+            </a:r>
+            <a:endParaRPr lang="en-US" sz="800" dirty="0"/>
+          </a:p>
+        </p:txBody>
+      </p:sp>
+      <p:sp>
+        <p:nvSpPr>
+          <p:cNvPr id="8" name="Text 6">
             <a:hlinkClick r:id="rId2" tooltip=""/>
           </p:cNvPr>
           <p:cNvSpPr/>
@@ -2761,7 +2839,7 @@
                   </a:extLst>
                 </a:hlinkClick>
               </a:rPr>
-              <a:t>Sanghuangporus vaninii extract exerts dual anti-tumor effects in colitis-associated colorectal cancer by direct cytotoxicity and macrophage reprogramming via the PPAR&amp;#x3b3;/NF-&amp;#x3ba;B axis.</a:t>
+              <a:t>Repurposing PARP inhibitors in molecularly defined subgroups of peritoneal metastatic colorectal cancer (pmCRC): Preclinical analysis of patient-derived xenograft …</a:t>
             </a:r>
             <a:endParaRPr lang="en-US" sz="2400" dirty="0"/>
           </a:p>
@@ -2797,7 +2875,7 @@
                   <a:srgbClr val="888888"/>
                 </a:solidFill>
               </a:rPr>
-              <a:t>Journal of ethnopharmacology  ·  Basic Research</a:t>
+              <a:t>Cancer …  ·  Basic Research</a:t>
             </a:r>
             <a:endParaRPr lang="en-US" sz="1000" dirty="0"/>
           </a:p>
@@ -2840,7 +2918,7 @@
                 <a:ea typeface="Arial" pitchFamily="34" charset="-122"/>
                 <a:cs typeface="Arial" pitchFamily="34" charset="-120"/>
               </a:rPr>
-              <a:t>Sanghuangporus vaninii shows anti-tumor effects.</a:t>
+              <a:t>pmCRC has poor prognosis compared to other metastases.</a:t>
             </a:r>
             <a:endParaRPr lang="en-US" sz="1800" dirty="0"/>
           </a:p>
@@ -2861,7 +2939,7 @@
                 <a:ea typeface="Arial" pitchFamily="34" charset="-122"/>
                 <a:cs typeface="Arial" pitchFamily="34" charset="-120"/>
               </a:rPr>
-              <a:t>Inhibits colitis-associated colorectal cancer progression.</a:t>
+              <a:t>PARP inhibitors show promise in targeted therapy.</a:t>
             </a:r>
             <a:endParaRPr lang="en-US" sz="1800" dirty="0"/>
           </a:p>
@@ -2882,57 +2960,51 @@
                 <a:ea typeface="Arial" pitchFamily="34" charset="-122"/>
                 <a:cs typeface="Arial" pitchFamily="34" charset="-120"/>
               </a:rPr>
-              <a:t>Modulates macrophages via PPARγ/NF-κB axis.</a:t>
+              <a:t>Patient-derived xenografts used for preclinical analysis.</a:t>
             </a:r>
             <a:endParaRPr lang="en-US" sz="1800" dirty="0"/>
           </a:p>
-          <a:p>
-            <a:pPr marL="342900" indent="-342900">
-              <a:spcAft>
-                <a:spcPts val="800"/>
-              </a:spcAft>
-              <a:buSzPct val="100000"/>
-              <a:buChar char="•"/>
-            </a:pPr>
-            <a:r>
-              <a:rPr lang="en-US" sz="1800" dirty="0">
-                <a:solidFill>
-                  <a:srgbClr val="333333"/>
-                </a:solidFill>
-                <a:latin typeface="Arial" pitchFamily="34" charset="0"/>
-                <a:ea typeface="Arial" pitchFamily="34" charset="-122"/>
-                <a:cs typeface="Arial" pitchFamily="34" charset="-120"/>
-              </a:rPr>
-              <a:t>Improves survival and reduces tumor burden.</a:t>
-            </a:r>
-            <a:endParaRPr lang="en-US" sz="1800" dirty="0"/>
-          </a:p>
-          <a:p>
-            <a:pPr marL="342900" indent="-342900">
-              <a:spcAft>
-                <a:spcPts val="800"/>
-              </a:spcAft>
-              <a:buSzPct val="100000"/>
-              <a:buChar char="•"/>
-            </a:pPr>
-            <a:r>
-              <a:rPr lang="en-US" sz="1800" dirty="0">
-                <a:solidFill>
-                  <a:srgbClr val="333333"/>
-                </a:solidFill>
-                <a:latin typeface="Arial" pitchFamily="34" charset="0"/>
-                <a:ea typeface="Arial" pitchFamily="34" charset="-122"/>
-                <a:cs typeface="Arial" pitchFamily="34" charset="-120"/>
-              </a:rPr>
-              <a:t>Rebalances cytokine profile in treated mice.</a:t>
-            </a:r>
-            <a:endParaRPr lang="en-US" sz="1800" dirty="0"/>
-          </a:p>
-        </p:txBody>
-      </p:sp>
-      <p:sp>
-        <p:nvSpPr>
-          <p:cNvPr id="7" name="Text 5">
+        </p:txBody>
+      </p:sp>
+      <p:sp>
+        <p:nvSpPr>
+          <p:cNvPr id="7" name="Text 5"/>
+          <p:cNvSpPr/>
+          <p:nvPr/>
+        </p:nvSpPr>
+        <p:spPr>
+          <a:xfrm>
+            <a:off x="731520" y="5852160"/>
+            <a:ext cx="10058400" cy="0"/>
+          </a:xfrm>
+          <a:prstGeom prst="rect">
+            <a:avLst/>
+          </a:prstGeom>
+          <a:noFill/>
+          <a:ln/>
+        </p:spPr>
+        <p:txBody>
+          <a:bodyPr wrap="square" lIns="0" tIns="0" rIns="0" bIns="0" rtlCol="0" anchor="ctr"/>
+          <a:lstStyle/>
+          <a:p>
+            <a:pPr indent="0" marL="0">
+              <a:buNone/>
+            </a:pPr>
+            <a:r>
+              <a:rPr lang="en-US" sz="800" dirty="0">
+                <a:solidFill>
+                  <a:srgbClr val="888888"/>
+                </a:solidFill>
+              </a:rPr>
+              <a:t>M Dahlmann, B Rau, S Gül-Klein. Cancer …. 2026</a:t>
+            </a:r>
+            <a:endParaRPr lang="en-US" sz="800" dirty="0"/>
+          </a:p>
+        </p:txBody>
+      </p:sp>
+      <p:sp>
+        <p:nvSpPr>
+          <p:cNvPr id="8" name="Text 6">
             <a:hlinkClick r:id="rId2" tooltip=""/>
           </p:cNvPr>
           <p:cNvSpPr/>
@@ -3124,7 +3196,7 @@
                   </a:extLst>
                 </a:hlinkClick>
               </a:rPr>
-              <a:t>Repurposing PARP inhibitors in molecularly defined subgroups of peritoneal metastatic colorectal cancer (pmCRC): Preclinical analysis of patient-derived xenograft …</a:t>
+              <a:t>The Mechanism of Acetyl-L-Carnitine on Colorectal Cancer and Its Metabolomic Study</a:t>
             </a:r>
             <a:endParaRPr lang="en-US" sz="2400" dirty="0"/>
           </a:p>
@@ -3160,7 +3232,7 @@
                   <a:srgbClr val="888888"/>
                 </a:solidFill>
               </a:rPr>
-              <a:t>Cancer …  ·  Basic Research</a:t>
+              <a:t>Journal of Pharmaceutical and …  ·  Basic Research</a:t>
             </a:r>
             <a:endParaRPr lang="en-US" sz="1000" dirty="0"/>
           </a:p>
@@ -3203,7 +3275,7 @@
                 <a:ea typeface="Arial" pitchFamily="34" charset="-122"/>
                 <a:cs typeface="Arial" pitchFamily="34" charset="-120"/>
               </a:rPr>
-              <a:t>pmCRC shows poor prognosis compared to other metastases.</a:t>
+              <a:t>Acetyl-L-Carnitine inhibits tumor growth</a:t>
             </a:r>
             <a:endParaRPr lang="en-US" sz="1800" dirty="0"/>
           </a:p>
@@ -3224,7 +3296,7 @@
                 <a:ea typeface="Arial" pitchFamily="34" charset="-122"/>
                 <a:cs typeface="Arial" pitchFamily="34" charset="-120"/>
               </a:rPr>
-              <a:t>PARP inhibitors may benefit specific molecular subgroups.</a:t>
+              <a:t>In vivo studies confirm ALC efficacy</a:t>
             </a:r>
             <a:endParaRPr lang="en-US" sz="1800" dirty="0"/>
           </a:p>
@@ -3245,7 +3317,7 @@
                 <a:ea typeface="Arial" pitchFamily="34" charset="-122"/>
                 <a:cs typeface="Arial" pitchFamily="34" charset="-120"/>
               </a:rPr>
-              <a:t>Patient-derived xenografts used for preclinical analysis.</a:t>
+              <a:t>Metabolomic analysis reveals mechanisms</a:t>
             </a:r>
             <a:endParaRPr lang="en-US" sz="1800" dirty="0"/>
           </a:p>
@@ -3253,7 +3325,43 @@
       </p:sp>
       <p:sp>
         <p:nvSpPr>
-          <p:cNvPr id="7" name="Text 5">
+          <p:cNvPr id="7" name="Text 5"/>
+          <p:cNvSpPr/>
+          <p:nvPr/>
+        </p:nvSpPr>
+        <p:spPr>
+          <a:xfrm>
+            <a:off x="731520" y="5852160"/>
+            <a:ext cx="10058400" cy="0"/>
+          </a:xfrm>
+          <a:prstGeom prst="rect">
+            <a:avLst/>
+          </a:prstGeom>
+          <a:noFill/>
+          <a:ln/>
+        </p:spPr>
+        <p:txBody>
+          <a:bodyPr wrap="square" lIns="0" tIns="0" rIns="0" bIns="0" rtlCol="0" anchor="ctr"/>
+          <a:lstStyle/>
+          <a:p>
+            <a:pPr indent="0" marL="0">
+              <a:buNone/>
+            </a:pPr>
+            <a:r>
+              <a:rPr lang="en-US" sz="800" dirty="0">
+                <a:solidFill>
+                  <a:srgbClr val="888888"/>
+                </a:solidFill>
+              </a:rPr>
+              <a:t>J Ning, C Cai, X Fan. Journal of Pharmaceutical and …. 2026</a:t>
+            </a:r>
+            <a:endParaRPr lang="en-US" sz="800" dirty="0"/>
+          </a:p>
+        </p:txBody>
+      </p:sp>
+      <p:sp>
+        <p:nvSpPr>
+          <p:cNvPr id="8" name="Text 6">
             <a:hlinkClick r:id="rId2" tooltip=""/>
           </p:cNvPr>
           <p:cNvSpPr/>
@@ -3436,7 +3544,7 @@
                   <a:srgbClr val="FFFFFF"/>
                 </a:solidFill>
               </a:rPr>
-              <a:t>### 綜合啟示（Overall Insights）</a:t>
+              <a:t>### 綜合啟示 (Overall Insights)</a:t>
             </a:r>
             <a:endParaRPr lang="en-US" sz="1200" dirty="0"/>
           </a:p>
@@ -3462,7 +3570,7 @@
                   <a:srgbClr val="FFFFFF"/>
                 </a:solidFill>
               </a:rPr>
-              <a:t>1. **腸道微生物對腸道炎症和腸癌的影響**  </a:t>
+              <a:t>1. **腸道微生物與癌症的關聯性**  </a:t>
             </a:r>
             <a:endParaRPr lang="en-US" sz="1200" dirty="0"/>
           </a:p>
@@ -3479,7 +3587,7 @@
                   <a:srgbClr val="FFFFFF"/>
                 </a:solidFill>
               </a:rPr>
-              <a:t>   **The impact of gut microbiota on intestinal inflammation and colorectal cancer:**  </a:t>
+              <a:t>   The study of *Parasutterella excrementihominis* highlights the complex relationship between gut microbiota and colorectal cancer, suggesting that specific microbial species can exacerbate colitis and promote tumorigenesis.  </a:t>
             </a:r>
             <a:endParaRPr lang="en-US" sz="1200" dirty="0"/>
           </a:p>
@@ -3496,7 +3604,7 @@
                   <a:srgbClr val="FFFFFF"/>
                 </a:solidFill>
               </a:rPr>
-              <a:t>   研究顯示，某些腸道微生物（如Parasutterella excrementihominis）能促進腸道炎症並加劇與腸炎相關的腸癌，提示微生物組在腸道健康中的關鍵角色。  </a:t>
+              <a:t>   *Parasutterella excrementihominis*的研究突顯了腸道微生物與結直腸癌之間的複雜關係，表明特定微生物物種可以加劇結腸炎並促進腫瘤生成。</a:t>
             </a:r>
             <a:endParaRPr lang="en-US" sz="1200" dirty="0"/>
           </a:p>
@@ -3507,14 +3615,6 @@
               </a:lnSpc>
               <a:buNone/>
             </a:pPr>
-            <a:r>
-              <a:rPr lang="en-US" sz="1200" dirty="0">
-                <a:solidFill>
-                  <a:srgbClr val="FFFFFF"/>
-                </a:solidFill>
-              </a:rPr>
-              <a:t>   Studies indicate that certain gut microbes (e.g., Parasutterella excrementihominis) can exacerbate intestinal inflammation and colitis-associated colorectal cancer, highlighting the critical role of the microbiome in gut health.</a:t>
-            </a:r>
             <a:endParaRPr lang="en-US" sz="1200" dirty="0"/>
           </a:p>
           <a:p>
@@ -3524,6 +3624,14 @@
               </a:lnSpc>
               <a:buNone/>
             </a:pPr>
+            <a:r>
+              <a:rPr lang="en-US" sz="1200" dirty="0">
+                <a:solidFill>
+                  <a:srgbClr val="FFFFFF"/>
+                </a:solidFill>
+              </a:rPr>
+              <a:t>2. **系統性免疫炎症指數的預後價值**  </a:t>
+            </a:r>
             <a:endParaRPr lang="en-US" sz="1200" dirty="0"/>
           </a:p>
           <a:p>
@@ -3539,7 +3647,7 @@
                   <a:srgbClr val="FFFFFF"/>
                 </a:solidFill>
               </a:rPr>
-              <a:t>2. **免疫反應與腫瘤微環境的關聯**  </a:t>
+              <a:t>   The systemic immune-inflammation index (SII) emerges as a promising prognostic biomarker for colorectal cancer, indicating that immune status may significantly influence patient outcomes.  </a:t>
             </a:r>
             <a:endParaRPr lang="en-US" sz="1200" dirty="0"/>
           </a:p>
@@ -3556,7 +3664,7 @@
                   <a:srgbClr val="FFFFFF"/>
                 </a:solidFill>
               </a:rPr>
-              <a:t>   **The relationship between immune responses and tumor microenvironments:**  </a:t>
+              <a:t>   系統性免疫炎症指數(SII)作為結直腸癌的有前景的預後生物標誌，表明免疫狀態可能顯著影響患者的預後。</a:t>
             </a:r>
             <a:endParaRPr lang="en-US" sz="1200" dirty="0"/>
           </a:p>
@@ -3567,14 +3675,6 @@
               </a:lnSpc>
               <a:buNone/>
             </a:pPr>
-            <a:r>
-              <a:rPr lang="en-US" sz="1200" dirty="0">
-                <a:solidFill>
-                  <a:srgbClr val="FFFFFF"/>
-                </a:solidFill>
-              </a:rPr>
-              <a:t>   不同器官的免疫和代謝程序塑造了腫瘤微環境，這對腸癌轉移具有重要影響，顯示了針對特定微環境的治療策略的潛力。  </a:t>
-            </a:r>
             <a:endParaRPr lang="en-US" sz="1200" dirty="0"/>
           </a:p>
           <a:p>
@@ -3590,7 +3690,7 @@
                   <a:srgbClr val="FFFFFF"/>
                 </a:solidFill>
               </a:rPr>
-              <a:t>   Organ-specific immune and metabolic programs shape tumor microenvironments, significantly affecting colorectal cancer metastasis, suggesting the potential for targeted therapeutic strategies against specific microenvironments.</a:t>
+              <a:t>3. **化療與腫瘤微環境的相互作用**  </a:t>
             </a:r>
             <a:endParaRPr lang="en-US" sz="1200" dirty="0"/>
           </a:p>
@@ -3601,6 +3701,14 @@
               </a:lnSpc>
               <a:buNone/>
             </a:pPr>
+            <a:r>
+              <a:rPr lang="en-US" sz="1200" dirty="0">
+                <a:solidFill>
+                  <a:srgbClr val="FFFFFF"/>
+                </a:solidFill>
+              </a:rPr>
+              <a:t>   Hyperthermic intraperitoneal chemotherapy shows potential in treating peritoneal metastases, emphasizing the need to understand the tumor microenvironment's role in therapeutic efficacy.  </a:t>
+            </a:r>
             <a:endParaRPr lang="en-US" sz="1200" dirty="0"/>
           </a:p>
           <a:p>
@@ -3616,7 +3724,7 @@
                   <a:srgbClr val="FFFFFF"/>
                 </a:solidFill>
               </a:rPr>
-              <a:t>3. **系統性免疫-炎症指數的預後價值**  </a:t>
+              <a:t>   超高溫腹腔化療在治療腹膜轉移中顯示出潛力，強調需要理解腫瘤微環境在治療效果中的作用。</a:t>
             </a:r>
             <a:endParaRPr lang="en-US" sz="1200" dirty="0"/>
           </a:p>
@@ -3627,14 +3735,6 @@
               </a:lnSpc>
               <a:buNone/>
             </a:pPr>
-            <a:r>
-              <a:rPr lang="en-US" sz="1200" dirty="0">
-                <a:solidFill>
-                  <a:srgbClr val="FFFFFF"/>
-                </a:solidFill>
-              </a:rPr>
-              <a:t>   **Prognostic value of the systemic immune-inflammation index:**  </a:t>
-            </a:r>
             <a:endParaRPr lang="en-US" sz="1200" dirty="0"/>
           </a:p>
           <a:p>
@@ -3650,7 +3750,7 @@
                   <a:srgbClr val="FFFFFF"/>
                 </a:solidFill>
               </a:rPr>
-              <a:t>   系統性免疫-炎症指數（SII）在腸癌預後中顯示出重要的生物標記潛力，能夠幫助臨床醫生評估患者的預後情況。  </a:t>
+              <a:t>4. **乳酸代謝的雙重角色**  </a:t>
             </a:r>
             <a:endParaRPr lang="en-US" sz="1200" dirty="0"/>
           </a:p>
@@ -3667,7 +3767,7 @@
                   <a:srgbClr val="FFFFFF"/>
                 </a:solidFill>
               </a:rPr>
-              <a:t>   The systemic immune-inflammation index (SII) shows significant potential as a prognostic biomarker in colorectal cancer, aiding clinicians in assessing patient prognosis.</a:t>
+              <a:t>   Lactate metabolism is implicated in both promoting intestinal inflammation and malignancy, suggesting that targeting lactate pathways could provide therapeutic benefits.  </a:t>
             </a:r>
             <a:endParaRPr lang="en-US" sz="1200" dirty="0"/>
           </a:p>
@@ -3678,6 +3778,14 @@
               </a:lnSpc>
               <a:buNone/>
             </a:pPr>
+            <a:r>
+              <a:rPr lang="en-US" sz="1200" dirty="0">
+                <a:solidFill>
+                  <a:srgbClr val="FFFFFF"/>
+                </a:solidFill>
+              </a:rPr>
+              <a:t>   乳酸代謝被認為在促進腸道炎症和惡性腫瘤中扮演雙重角色，這表明針對乳酸途徑可能帶來治療益處。</a:t>
+            </a:r>
             <a:endParaRPr lang="en-US" sz="1200" dirty="0"/>
           </a:p>
           <a:p>
@@ -3687,14 +3795,6 @@
               </a:lnSpc>
               <a:buNone/>
             </a:pPr>
-            <a:r>
-              <a:rPr lang="en-US" sz="1200" dirty="0">
-                <a:solidFill>
-                  <a:srgbClr val="FFFFFF"/>
-                </a:solidFill>
-              </a:rPr>
-              <a:t>4. **腫瘤微環境中的中性粒細胞角色**  </a:t>
-            </a:r>
             <a:endParaRPr lang="en-US" sz="1200" dirty="0"/>
           </a:p>
           <a:p>
@@ -3710,7 +3810,7 @@
                   <a:srgbClr val="FFFFFF"/>
                 </a:solidFill>
               </a:rPr>
-              <a:t>   **Role of neutrophils in the tumor microenvironment:**  </a:t>
+              <a:t>5. **慢性炎症與腫瘤生成的關聯**  </a:t>
             </a:r>
             <a:endParaRPr lang="en-US" sz="1200" dirty="0"/>
           </a:p>
@@ -3727,101 +3827,7 @@
                   <a:srgbClr val="FFFFFF"/>
                 </a:solidFill>
               </a:rPr>
-              <a:t>   中性粒細胞在腸癌的轉移過程中扮演了促進角色，這一發現強調了抑制中性粒細胞浸潤的治療策略的必要性。  </a:t>
-            </a:r>
-            <a:endParaRPr lang="en-US" sz="1200" dirty="0"/>
-          </a:p>
-          <a:p>
-            <a:pPr indent="0" marL="0">
-              <a:lnSpc>
-                <a:spcPct val="150000"/>
-              </a:lnSpc>
-              <a:buNone/>
-            </a:pPr>
-            <a:r>
-              <a:rPr lang="en-US" sz="1200" dirty="0">
-                <a:solidFill>
-                  <a:srgbClr val="FFFFFF"/>
-                </a:solidFill>
-              </a:rPr>
-              <a:t>   Neutrophils play a pro-metastatic role in colorectal cancer, emphasizing the need for therapeutic strategies aimed at inhibiting neutrophil infiltration.</a:t>
-            </a:r>
-            <a:endParaRPr lang="en-US" sz="1200" dirty="0"/>
-          </a:p>
-          <a:p>
-            <a:pPr indent="0" marL="0">
-              <a:lnSpc>
-                <a:spcPct val="150000"/>
-              </a:lnSpc>
-              <a:buNone/>
-            </a:pPr>
-            <a:endParaRPr lang="en-US" sz="1200" dirty="0"/>
-          </a:p>
-          <a:p>
-            <a:pPr indent="0" marL="0">
-              <a:lnSpc>
-                <a:spcPct val="150000"/>
-              </a:lnSpc>
-              <a:buNone/>
-            </a:pPr>
-            <a:r>
-              <a:rPr lang="en-US" sz="1200" dirty="0">
-                <a:solidFill>
-                  <a:srgbClr val="FFFFFF"/>
-                </a:solidFill>
-              </a:rPr>
-              <a:t>5. **新型治療策略的潛力**  </a:t>
-            </a:r>
-            <a:endParaRPr lang="en-US" sz="1200" dirty="0"/>
-          </a:p>
-          <a:p>
-            <a:pPr indent="0" marL="0">
-              <a:lnSpc>
-                <a:spcPct val="150000"/>
-              </a:lnSpc>
-              <a:buNone/>
-            </a:pPr>
-            <a:r>
-              <a:rPr lang="en-US" sz="1200" dirty="0">
-                <a:solidFill>
-                  <a:srgbClr val="FFFFFF"/>
-                </a:solidFill>
-              </a:rPr>
-              <a:t>   **Potential for novel therapeutic strategies:**  </a:t>
-            </a:r>
-            <a:endParaRPr lang="en-US" sz="1200" dirty="0"/>
-          </a:p>
-          <a:p>
-            <a:pPr indent="0" marL="0">
-              <a:lnSpc>
-                <a:spcPct val="150000"/>
-              </a:lnSpc>
-              <a:buNone/>
-            </a:pPr>
-            <a:r>
-              <a:rPr lang="en-US" sz="1200" dirty="0">
-                <a:solidFill>
-                  <a:srgbClr val="FFFFFF"/>
-                </a:solidFill>
-              </a:rPr>
-              <a:t>   研究顯示，利用植物提取物和PARP抑制劑等新型療法在腸癌的治療中展現出希望，尤其是在特定的分子亞型中。  </a:t>
-            </a:r>
-            <a:endParaRPr lang="en-US" sz="1200" dirty="0"/>
-          </a:p>
-          <a:p>
-            <a:pPr indent="0" marL="0">
-              <a:lnSpc>
-                <a:spcPct val="150000"/>
-              </a:lnSpc>
-              <a:buNone/>
-            </a:pPr>
-            <a:r>
-              <a:rPr lang="en-US" sz="1200" dirty="0">
-                <a:solidFill>
-                  <a:srgbClr val="FFFFFF"/>
-                </a:solidFill>
-              </a:rPr>
-              <a:t>   Studies indicate that novel therapies, such as plant extracts and PARP inhibitors, show promise in treating colorectal cancer, particularly in specific molecular subgroups.</a:t>
+              <a:t>   Chronic inflammation is identified as a critical driver of colitis-associated colorectal cancer, highlighting the importance of managing inflammatory conditions to prevent cancer progression.</a:t>
             </a:r>
             <a:endParaRPr lang="en-US" sz="1200" dirty="0"/>
           </a:p>
@@ -3967,7 +3973,7 @@
                   <a:srgbClr val="FFFFFF"/>
                 </a:solidFill>
               </a:rPr>
-              <a:t>### 未來研究方向（Future Research Directions）</a:t>
+              <a:t>慢性炎症被確定為結腸炎相關結直腸癌的關鍵驅動因素，強調管理炎症狀況以預防癌症進展的重要性。</a:t>
             </a:r>
             <a:endParaRPr lang="en-US" sz="1200" dirty="0"/>
           </a:p>
@@ -3993,7 +3999,7 @@
                   <a:srgbClr val="FFFFFF"/>
                 </a:solidFill>
               </a:rPr>
-              <a:t>1. **腸道微生物組的調控機制研究**  </a:t>
+              <a:t>### 未來研究方向 (Future Research Directions)</a:t>
             </a:r>
             <a:endParaRPr lang="en-US" sz="1200" dirty="0"/>
           </a:p>
@@ -4004,14 +4010,6 @@
               </a:lnSpc>
               <a:buNone/>
             </a:pPr>
-            <a:r>
-              <a:rPr lang="en-US" sz="1200" dirty="0">
-                <a:solidFill>
-                  <a:srgbClr val="FFFFFF"/>
-                </a:solidFill>
-              </a:rPr>
-              <a:t>   **Investigating regulatory mechanisms of the gut microbiome:**  </a:t>
-            </a:r>
             <a:endParaRPr lang="en-US" sz="1200" dirty="0"/>
           </a:p>
           <a:p>
@@ -4027,7 +4025,7 @@
                   <a:srgbClr val="FFFFFF"/>
                 </a:solidFill>
               </a:rPr>
-              <a:t>   需要深入研究腸道微生物組如何影響腸道炎症及癌症發展的分子機制，以開發靶向微生物的治療方法。  </a:t>
+              <a:t>1. **微生物組干預的臨床應用**  </a:t>
             </a:r>
             <a:endParaRPr lang="en-US" sz="1200" dirty="0"/>
           </a:p>
@@ -4044,7 +4042,7 @@
                   <a:srgbClr val="FFFFFF"/>
                 </a:solidFill>
               </a:rPr>
-              <a:t>   Further investigation is needed into the molecular mechanisms by which the gut microbiome influences intestinal inflammation and cancer development, to develop microbiome-targeted therapies.</a:t>
+              <a:t>   Future studies should explore the therapeutic potential of modulating gut microbiota to prevent or treat colorectal cancer and associated inflammatory conditions.  </a:t>
             </a:r>
             <a:endParaRPr lang="en-US" sz="1200" dirty="0"/>
           </a:p>
@@ -4055,6 +4053,14 @@
               </a:lnSpc>
               <a:buNone/>
             </a:pPr>
+            <a:r>
+              <a:rPr lang="en-US" sz="1200" dirty="0">
+                <a:solidFill>
+                  <a:srgbClr val="FFFFFF"/>
+                </a:solidFill>
+              </a:rPr>
+              <a:t>   未來的研究應探討調節腸道微生物組以預防或治療結直腸癌及相關炎症狀況的治療潛力。</a:t>
+            </a:r>
             <a:endParaRPr lang="en-US" sz="1200" dirty="0"/>
           </a:p>
           <a:p>
@@ -4064,14 +4070,6 @@
               </a:lnSpc>
               <a:buNone/>
             </a:pPr>
-            <a:r>
-              <a:rPr lang="en-US" sz="1200" dirty="0">
-                <a:solidFill>
-                  <a:srgbClr val="FFFFFF"/>
-                </a:solidFill>
-              </a:rPr>
-              <a:t>2. **針對腫瘤微環境的免疫療法**  </a:t>
-            </a:r>
             <a:endParaRPr lang="en-US" sz="1200" dirty="0"/>
           </a:p>
           <a:p>
@@ -4087,7 +4085,7 @@
                   <a:srgbClr val="FFFFFF"/>
                 </a:solidFill>
               </a:rPr>
-              <a:t>   **Immunotherapy targeting the tumor microenvironment:**  </a:t>
+              <a:t>2. **免疫指標的個體化治療**  </a:t>
             </a:r>
             <a:endParaRPr lang="en-US" sz="1200" dirty="0"/>
           </a:p>
@@ -4104,7 +4102,7 @@
                   <a:srgbClr val="FFFFFF"/>
                 </a:solidFill>
               </a:rPr>
-              <a:t>   探索針對特定腫瘤微環境的免疫療法，特別是針對中性粒細胞的抑制，以改善腸癌患者的治療效果。  </a:t>
+              <a:t>   Investigating the application of the systemic immune-inflammation index in personalized treatment strategies could enhance the management of colorectal cancer patients.  </a:t>
             </a:r>
             <a:endParaRPr lang="en-US" sz="1200" dirty="0"/>
           </a:p>
@@ -4121,7 +4119,7 @@
                   <a:srgbClr val="FFFFFF"/>
                 </a:solidFill>
               </a:rPr>
-              <a:t>   Exploring immunotherapies targeting specific tumor microenvironments, especially neutrophil suppression, to improve treatment outcomes for colorectal cancer patients.</a:t>
+              <a:t>   研究系統性免疫炎症指數在個體化治療策略中的應用，可能會改善結直腸癌患者的管理。</a:t>
             </a:r>
             <a:endParaRPr lang="en-US" sz="1200" dirty="0"/>
           </a:p>
@@ -4147,7 +4145,7 @@
                   <a:srgbClr val="FFFFFF"/>
                 </a:solidFill>
               </a:rPr>
-              <a:t>3. **系統性免疫-炎症指數的臨床應用**  </a:t>
+              <a:t>3. **腫瘤微環境的深入研究**  </a:t>
             </a:r>
             <a:endParaRPr lang="en-US" sz="1200" dirty="0"/>
           </a:p>
@@ -4164,7 +4162,7 @@
                   <a:srgbClr val="FFFFFF"/>
                 </a:solidFill>
               </a:rPr>
-              <a:t>   **Clinical application of the systemic immune-inflammation index:**  </a:t>
+              <a:t>   Further research is needed to elucidate the role of the tumor microenvironment in colorectal cancer progression and response to therapies, particularly in the context of peritoneal metastases.  </a:t>
             </a:r>
             <a:endParaRPr lang="en-US" sz="1200" dirty="0"/>
           </a:p>
@@ -4181,7 +4179,7 @@
                   <a:srgbClr val="FFFFFF"/>
                 </a:solidFill>
               </a:rPr>
-              <a:t>   進一步研究SII在不同腸癌亞型中的預測能力，以便在臨床上更有效地應用該指數。  </a:t>
+              <a:t>   需要進一步研究以闡明腫瘤微環境在結直腸癌進展和對治療反應中的作用，特別是在腹膜轉移的背景下。</a:t>
             </a:r>
             <a:endParaRPr lang="en-US" sz="1200" dirty="0"/>
           </a:p>
@@ -4192,14 +4190,6 @@
               </a:lnSpc>
               <a:buNone/>
             </a:pPr>
-            <a:r>
-              <a:rPr lang="en-US" sz="1200" dirty="0">
-                <a:solidFill>
-                  <a:srgbClr val="FFFFFF"/>
-                </a:solidFill>
-              </a:rPr>
-              <a:t>   Further research on the predictive capability of SII in different colorectal cancer subtypes for more effective clinical application of this index.</a:t>
-            </a:r>
             <a:endParaRPr lang="en-US" sz="1200" dirty="0"/>
           </a:p>
           <a:p>
@@ -4209,6 +4199,14 @@
               </a:lnSpc>
               <a:buNone/>
             </a:pPr>
+            <a:r>
+              <a:rPr lang="en-US" sz="1200" dirty="0">
+                <a:solidFill>
+                  <a:srgbClr val="FFFFFF"/>
+                </a:solidFill>
+              </a:rPr>
+              <a:t>4. **乳酸代謝的調控機制**  </a:t>
+            </a:r>
             <a:endParaRPr lang="en-US" sz="1200" dirty="0"/>
           </a:p>
           <a:p>
@@ -4224,7 +4222,7 @@
                   <a:srgbClr val="FFFFFF"/>
                 </a:solidFill>
               </a:rPr>
-              <a:t>4. **新型藥物的臨床試驗**  </a:t>
+              <a:t>   Investigating the molecular mechanisms behind lactate metabolism and its effects on inflammation and cancer could lead to novel therapeutic targets.  </a:t>
             </a:r>
             <a:endParaRPr lang="en-US" sz="1200" dirty="0"/>
           </a:p>
@@ -4241,7 +4239,7 @@
                   <a:srgbClr val="FFFFFF"/>
                 </a:solidFill>
               </a:rPr>
-              <a:t>   **Clinical trials for novel therapeutics:**  </a:t>
+              <a:t>   研究乳酸代謝背後的分子機制及其對炎症和癌症的影響，可能會導致新的治療靶點。</a:t>
             </a:r>
             <a:endParaRPr lang="en-US" sz="1200" dirty="0"/>
           </a:p>
@@ -4252,14 +4250,6 @@
               </a:lnSpc>
               <a:buNone/>
             </a:pPr>
-            <a:r>
-              <a:rPr lang="en-US" sz="1200" dirty="0">
-                <a:solidFill>
-                  <a:srgbClr val="FFFFFF"/>
-                </a:solidFill>
-              </a:rPr>
-              <a:t>   對新型植物提取物和PARP抑制劑進行臨床試驗，以評估其在腸癌治療中的有效性和安全性。  </a:t>
-            </a:r>
             <a:endParaRPr lang="en-US" sz="1200" dirty="0"/>
           </a:p>
           <a:p>
@@ -4275,7 +4265,7 @@
                   <a:srgbClr val="FFFFFF"/>
                 </a:solidFill>
               </a:rPr>
-              <a:t>   Conducting clinical trials for novel plant extracts and PARP inhibitors to evaluate their efficacy and safety in colorectal cancer treatment.</a:t>
+              <a:t>5. **炎症與癌症風險的教育**  </a:t>
             </a:r>
             <a:endParaRPr lang="en-US" sz="1200" dirty="0"/>
           </a:p>
@@ -4286,6 +4276,14 @@
               </a:lnSpc>
               <a:buNone/>
             </a:pPr>
+            <a:r>
+              <a:rPr lang="en-US" sz="1200" dirty="0">
+                <a:solidFill>
+                  <a:srgbClr val="FFFFFF"/>
+                </a:solidFill>
+              </a:rPr>
+              <a:t>   Increasing awareness and understanding of the link between inflammatory bowel disease and colorectal cancer risk among patients is essential for effective management and prevention strategies.  </a:t>
+            </a:r>
             <a:endParaRPr lang="en-US" sz="1200" dirty="0"/>
           </a:p>
           <a:p>
@@ -4301,58 +4299,7 @@
                   <a:srgbClr val="FFFFFF"/>
                 </a:solidFill>
               </a:rPr>
-              <a:t>5. **多學科合作研究**  </a:t>
-            </a:r>
-            <a:endParaRPr lang="en-US" sz="1200" dirty="0"/>
-          </a:p>
-          <a:p>
-            <a:pPr indent="0" marL="0">
-              <a:lnSpc>
-                <a:spcPct val="150000"/>
-              </a:lnSpc>
-              <a:buNone/>
-            </a:pPr>
-            <a:r>
-              <a:rPr lang="en-US" sz="1200" dirty="0">
-                <a:solidFill>
-                  <a:srgbClr val="FFFFFF"/>
-                </a:solidFill>
-              </a:rPr>
-              <a:t>   **Multidisciplinary collaborative research:**  </a:t>
-            </a:r>
-            <a:endParaRPr lang="en-US" sz="1200" dirty="0"/>
-          </a:p>
-          <a:p>
-            <a:pPr indent="0" marL="0">
-              <a:lnSpc>
-                <a:spcPct val="150000"/>
-              </a:lnSpc>
-              <a:buNone/>
-            </a:pPr>
-            <a:r>
-              <a:rPr lang="en-US" sz="1200" dirty="0">
-                <a:solidFill>
-                  <a:srgbClr val="FFFFFF"/>
-                </a:solidFill>
-              </a:rPr>
-              <a:t>   鼓勵腸道微生物學、腫瘤學和免疫學等領域的多學科合作，以促進腸癌研究的綜合性和深度。  </a:t>
-            </a:r>
-            <a:endParaRPr lang="en-US" sz="1200" dirty="0"/>
-          </a:p>
-          <a:p>
-            <a:pPr indent="0" marL="0">
-              <a:lnSpc>
-                <a:spcPct val="150000"/>
-              </a:lnSpc>
-              <a:buNone/>
-            </a:pPr>
-            <a:r>
-              <a:rPr lang="en-US" sz="1200" dirty="0">
-                <a:solidFill>
-                  <a:srgbClr val="FFFFFF"/>
-                </a:solidFill>
-              </a:rPr>
-              <a:t>   Encouraging multidisciplinary collaboration across fields such as microbiology, oncology, and immunology to enhance the comprehensiveness and depth of colorectal cancer research.</a:t>
+              <a:t>   提高患者對炎症性腸病與結直腸癌風險之間聯繫的認識和理解，對於有效的管理和預防策略至關重要。</a:t>
             </a:r>
             <a:endParaRPr lang="en-US" sz="1200" dirty="0"/>
           </a:p>
@@ -4623,7 +4570,7 @@
                 <a:ea typeface="Arial" pitchFamily="34" charset="-122"/>
                 <a:cs typeface="Arial" pitchFamily="34" charset="-120"/>
               </a:rPr>
-              <a:t>Organ-specific immune and metabolic programs shape spatial microenvironments in …</a:t>
+              <a:t>Effect of hyperthermic intraperitoneal chemotherapy on patients with advanced co…</a:t>
             </a:r>
             <a:endParaRPr lang="en-US" sz="1400" dirty="0"/>
           </a:p>
@@ -4660,7 +4607,7 @@
                 <a:ea typeface="Arial" pitchFamily="34" charset="-122"/>
                 <a:cs typeface="Arial" pitchFamily="34" charset="-120"/>
               </a:rPr>
-              <a:t>Effect of hyperthermic intraperitoneal chemotherapy on patients with advanced co…</a:t>
+              <a:t>Prognostic value of systemic immune-inflammation index for colorectal cancer: a …</a:t>
             </a:r>
             <a:endParaRPr lang="en-US" sz="1400" dirty="0"/>
           </a:p>
@@ -4697,7 +4644,7 @@
                 <a:ea typeface="Arial" pitchFamily="34" charset="-122"/>
                 <a:cs typeface="Arial" pitchFamily="34" charset="-120"/>
               </a:rPr>
-              <a:t>Prognostic value of systemic immune-inflammation index for colorectal cancer: a …</a:t>
+              <a:t>Awareness of inflammatory bowel disease-associated colorectal cancer risk and it…</a:t>
             </a:r>
             <a:endParaRPr lang="en-US" sz="1400" dirty="0"/>
           </a:p>
@@ -4882,7 +4829,7 @@
                 <a:ea typeface="Arial" pitchFamily="34" charset="-122"/>
                 <a:cs typeface="Arial" pitchFamily="34" charset="-120"/>
               </a:rPr>
-              <a:t>Sanghuangporus vaninii extract exerts dual anti-tumor effects in colitis-associa…</a:t>
+              <a:t>Repurposing PARP inhibitors in molecularly defined subgroups of peritoneal metas…</a:t>
             </a:r>
             <a:endParaRPr lang="en-US" sz="1400" dirty="0"/>
           </a:p>
@@ -4919,7 +4866,7 @@
                 <a:ea typeface="Arial" pitchFamily="34" charset="-122"/>
                 <a:cs typeface="Arial" pitchFamily="34" charset="-120"/>
               </a:rPr>
-              <a:t>Repurposing PARP inhibitors in molecularly defined subgroups of peritoneal metas…</a:t>
+              <a:t>The Mechanism of Acetyl-L-Carnitine on Colorectal Cancer and Its Metabolomic Stu…</a:t>
             </a:r>
             <a:endParaRPr lang="en-US" sz="1400" dirty="0"/>
           </a:p>
@@ -5153,7 +5100,7 @@
                 <a:ea typeface="Arial" pitchFamily="34" charset="-122"/>
                 <a:cs typeface="Arial" pitchFamily="34" charset="-120"/>
               </a:rPr>
-              <a:t>P. excrementihominis worsens colitis severity</a:t>
+              <a:t>P. excrementihominis worsens colitis severity.</a:t>
             </a:r>
             <a:endParaRPr lang="en-US" sz="1800" dirty="0"/>
           </a:p>
@@ -5174,7 +5121,7 @@
                 <a:ea typeface="Arial" pitchFamily="34" charset="-122"/>
                 <a:cs typeface="Arial" pitchFamily="34" charset="-120"/>
               </a:rPr>
-              <a:t>NETosis activation linked to cancer progression</a:t>
+              <a:t>NETosis activation linked to cancer progression.</a:t>
             </a:r>
             <a:endParaRPr lang="en-US" sz="1800" dirty="0"/>
           </a:p>
@@ -5195,7 +5142,7 @@
                 <a:ea typeface="Arial" pitchFamily="34" charset="-122"/>
                 <a:cs typeface="Arial" pitchFamily="34" charset="-120"/>
               </a:rPr>
-              <a:t>Potential therapeutic strategies identified</a:t>
+              <a:t>Study suggests new therapeutic strategies.</a:t>
             </a:r>
             <a:endParaRPr lang="en-US" sz="1800" dirty="0"/>
           </a:p>
@@ -5203,7 +5150,43 @@
       </p:sp>
       <p:sp>
         <p:nvSpPr>
-          <p:cNvPr id="7" name="Text 5">
+          <p:cNvPr id="7" name="Text 5"/>
+          <p:cNvSpPr/>
+          <p:nvPr/>
+        </p:nvSpPr>
+        <p:spPr>
+          <a:xfrm>
+            <a:off x="731520" y="5852160"/>
+            <a:ext cx="10058400" cy="0"/>
+          </a:xfrm>
+          <a:prstGeom prst="rect">
+            <a:avLst/>
+          </a:prstGeom>
+          <a:noFill/>
+          <a:ln/>
+        </p:spPr>
+        <p:txBody>
+          <a:bodyPr wrap="square" lIns="0" tIns="0" rIns="0" bIns="0" rtlCol="0" anchor="ctr"/>
+          <a:lstStyle/>
+          <a:p>
+            <a:pPr indent="0" marL="0">
+              <a:buNone/>
+            </a:pPr>
+            <a:r>
+              <a:rPr lang="en-US" sz="800" dirty="0">
+                <a:solidFill>
+                  <a:srgbClr val="888888"/>
+                </a:solidFill>
+              </a:rPr>
+              <a:t>H Tan, L Huang, J Wang. Gut. 2026</a:t>
+            </a:r>
+            <a:endParaRPr lang="en-US" sz="800" dirty="0"/>
+          </a:p>
+        </p:txBody>
+      </p:sp>
+      <p:sp>
+        <p:nvSpPr>
+          <p:cNvPr id="8" name="Text 6">
             <a:hlinkClick r:id="rId2" tooltip=""/>
           </p:cNvPr>
           <p:cNvSpPr/>
@@ -5395,7 +5378,7 @@
                   </a:extLst>
                 </a:hlinkClick>
               </a:rPr>
-              <a:t>Organ-specific immune and metabolic programs shape spatial microenvironments in MSS colorectal cancer metastases</a:t>
+              <a:t>Effect of hyperthermic intraperitoneal chemotherapy on patients with advanced colorectal cancer: a systematic review and meta-analysis</a:t>
             </a:r>
             <a:endParaRPr lang="en-US" sz="2400" dirty="0"/>
           </a:p>
@@ -5431,7 +5414,7 @@
                   <a:srgbClr val="888888"/>
                 </a:solidFill>
               </a:rPr>
-              <a:t>Cancer Research  ·  IF 12.7</a:t>
+              <a:t>World Journal of …  ·  Meta-Analysis</a:t>
             </a:r>
             <a:endParaRPr lang="en-US" sz="1000" dirty="0"/>
           </a:p>
@@ -5474,7 +5457,7 @@
                 <a:ea typeface="Arial" pitchFamily="34" charset="-122"/>
                 <a:cs typeface="Arial" pitchFamily="34" charset="-120"/>
               </a:rPr>
-              <a:t>T-cell infiltration in MSS colorectal cancer</a:t>
+              <a:t>Hyperthermic intraperitoneal chemotherapy (HIPEC) evaluated</a:t>
             </a:r>
             <a:endParaRPr lang="en-US" sz="1800" dirty="0"/>
           </a:p>
@@ -5495,7 +5478,7 @@
                 <a:ea typeface="Arial" pitchFamily="34" charset="-122"/>
                 <a:cs typeface="Arial" pitchFamily="34" charset="-120"/>
               </a:rPr>
-              <a:t>Liver metastases have unique immune profiles</a:t>
+              <a:t>Systematic review and meta-analysis conducted</a:t>
             </a:r>
             <a:endParaRPr lang="en-US" sz="1800" dirty="0"/>
           </a:p>
@@ -5516,15 +5499,93 @@
                 <a:ea typeface="Arial" pitchFamily="34" charset="-122"/>
                 <a:cs typeface="Arial" pitchFamily="34" charset="-120"/>
               </a:rPr>
-              <a:t>Peritoneal metastases show distinct microenvironments</a:t>
+              <a:t>Focus on advanced colorectal cancer patients</a:t>
             </a:r>
             <a:endParaRPr lang="en-US" sz="1800" dirty="0"/>
           </a:p>
-        </p:txBody>
-      </p:sp>
-      <p:sp>
-        <p:nvSpPr>
-          <p:cNvPr id="7" name="Text 5">
+          <a:p>
+            <a:pPr marL="342900" indent="-342900">
+              <a:spcAft>
+                <a:spcPts val="800"/>
+              </a:spcAft>
+              <a:buSzPct val="100000"/>
+              <a:buChar char="•"/>
+            </a:pPr>
+            <a:r>
+              <a:rPr lang="en-US" sz="1800" dirty="0">
+                <a:solidFill>
+                  <a:srgbClr val="333333"/>
+                </a:solidFill>
+                <a:latin typeface="Arial" pitchFamily="34" charset="0"/>
+                <a:ea typeface="Arial" pitchFamily="34" charset="-122"/>
+                <a:cs typeface="Arial" pitchFamily="34" charset="-120"/>
+              </a:rPr>
+              <a:t>Impact on peritoneal metastases assessed</a:t>
+            </a:r>
+            <a:endParaRPr lang="en-US" sz="1800" dirty="0"/>
+          </a:p>
+          <a:p>
+            <a:pPr marL="342900" indent="-342900">
+              <a:spcAft>
+                <a:spcPts val="800"/>
+              </a:spcAft>
+              <a:buSzPct val="100000"/>
+              <a:buChar char="•"/>
+            </a:pPr>
+            <a:r>
+              <a:rPr lang="en-US" sz="1800" dirty="0">
+                <a:solidFill>
+                  <a:srgbClr val="333333"/>
+                </a:solidFill>
+                <a:latin typeface="Arial" pitchFamily="34" charset="0"/>
+                <a:ea typeface="Arial" pitchFamily="34" charset="-122"/>
+                <a:cs typeface="Arial" pitchFamily="34" charset="-120"/>
+              </a:rPr>
+              <a:t>Clinical outcomes and survival rates analyzed</a:t>
+            </a:r>
+            <a:endParaRPr lang="en-US" sz="1800" dirty="0"/>
+          </a:p>
+        </p:txBody>
+      </p:sp>
+      <p:sp>
+        <p:nvSpPr>
+          <p:cNvPr id="7" name="Text 5"/>
+          <p:cNvSpPr/>
+          <p:nvPr/>
+        </p:nvSpPr>
+        <p:spPr>
+          <a:xfrm>
+            <a:off x="731520" y="5852160"/>
+            <a:ext cx="10058400" cy="0"/>
+          </a:xfrm>
+          <a:prstGeom prst="rect">
+            <a:avLst/>
+          </a:prstGeom>
+          <a:noFill/>
+          <a:ln/>
+        </p:spPr>
+        <p:txBody>
+          <a:bodyPr wrap="square" lIns="0" tIns="0" rIns="0" bIns="0" rtlCol="0" anchor="ctr"/>
+          <a:lstStyle/>
+          <a:p>
+            <a:pPr indent="0" marL="0">
+              <a:buNone/>
+            </a:pPr>
+            <a:r>
+              <a:rPr lang="en-US" sz="800" dirty="0">
+                <a:solidFill>
+                  <a:srgbClr val="888888"/>
+                </a:solidFill>
+              </a:rPr>
+              <a:t>Z Su, Y Guo, X Ru. World Journal of …. 2026</a:t>
+            </a:r>
+            <a:endParaRPr lang="en-US" sz="800" dirty="0"/>
+          </a:p>
+        </p:txBody>
+      </p:sp>
+      <p:sp>
+        <p:nvSpPr>
+          <p:cNvPr id="8" name="Text 6">
             <a:hlinkClick r:id="rId2" tooltip=""/>
           </p:cNvPr>
           <p:cNvSpPr/>
@@ -5716,7 +5777,7 @@
                   </a:extLst>
                 </a:hlinkClick>
               </a:rPr>
-              <a:t>Effect of hyperthermic intraperitoneal chemotherapy on patients with advanced colorectal cancer: a systematic review and meta-analysis</a:t>
+              <a:t>Prognostic value of systemic immune-inflammation index for colorectal cancer: a systematic review and meta-analysis</a:t>
             </a:r>
             <a:endParaRPr lang="en-US" sz="2400" dirty="0"/>
           </a:p>
@@ -5752,7 +5813,7 @@
                   <a:srgbClr val="888888"/>
                 </a:solidFill>
               </a:rPr>
-              <a:t>World Journal of …  ·  Meta-Analysis</a:t>
+              <a:t>Frontiers in Oncology  ·  Meta-Analysis</a:t>
             </a:r>
             <a:endParaRPr lang="en-US" sz="1000" dirty="0"/>
           </a:p>
@@ -5795,7 +5856,7 @@
                 <a:ea typeface="Arial" pitchFamily="34" charset="-122"/>
                 <a:cs typeface="Arial" pitchFamily="34" charset="-120"/>
               </a:rPr>
-              <a:t>Hyperthermic intraperitoneal chemotherapy (HIPEC) evaluated</a:t>
+              <a:t>Systemic immune-inflammation index (SII) evaluated</a:t>
             </a:r>
             <a:endParaRPr lang="en-US" sz="1800" dirty="0"/>
           </a:p>
@@ -5816,7 +5877,7 @@
                 <a:ea typeface="Arial" pitchFamily="34" charset="-122"/>
                 <a:cs typeface="Arial" pitchFamily="34" charset="-120"/>
               </a:rPr>
-              <a:t>Effectiveness in advanced colorectal cancer patients</a:t>
+              <a:t>SII as a prognostic biomarker in CRC</a:t>
             </a:r>
             <a:endParaRPr lang="en-US" sz="1800" dirty="0"/>
           </a:p>
@@ -5837,7 +5898,7 @@
                 <a:ea typeface="Arial" pitchFamily="34" charset="-122"/>
                 <a:cs typeface="Arial" pitchFamily="34" charset="-120"/>
               </a:rPr>
-              <a:t>Systematic review and meta-analysis conducted</a:t>
+              <a:t>Meta-analysis of existing studies conducted</a:t>
             </a:r>
             <a:endParaRPr lang="en-US" sz="1800" dirty="0"/>
           </a:p>
@@ -5845,7 +5906,43 @@
       </p:sp>
       <p:sp>
         <p:nvSpPr>
-          <p:cNvPr id="7" name="Text 5">
+          <p:cNvPr id="7" name="Text 5"/>
+          <p:cNvSpPr/>
+          <p:nvPr/>
+        </p:nvSpPr>
+        <p:spPr>
+          <a:xfrm>
+            <a:off x="731520" y="5852160"/>
+            <a:ext cx="10058400" cy="0"/>
+          </a:xfrm>
+          <a:prstGeom prst="rect">
+            <a:avLst/>
+          </a:prstGeom>
+          <a:noFill/>
+          <a:ln/>
+        </p:spPr>
+        <p:txBody>
+          <a:bodyPr wrap="square" lIns="0" tIns="0" rIns="0" bIns="0" rtlCol="0" anchor="ctr"/>
+          <a:lstStyle/>
+          <a:p>
+            <a:pPr indent="0" marL="0">
+              <a:buNone/>
+            </a:pPr>
+            <a:r>
+              <a:rPr lang="en-US" sz="800" dirty="0">
+                <a:solidFill>
+                  <a:srgbClr val="888888"/>
+                </a:solidFill>
+              </a:rPr>
+              <a:t>P Wang, H Jiang. Frontiers in Oncology. 2026</a:t>
+            </a:r>
+            <a:endParaRPr lang="en-US" sz="800" dirty="0"/>
+          </a:p>
+        </p:txBody>
+      </p:sp>
+      <p:sp>
+        <p:nvSpPr>
+          <p:cNvPr id="8" name="Text 6">
             <a:hlinkClick r:id="rId2" tooltip=""/>
           </p:cNvPr>
           <p:cNvSpPr/>
@@ -6037,7 +6134,7 @@
                   </a:extLst>
                 </a:hlinkClick>
               </a:rPr>
-              <a:t>Prognostic value of systemic immune-inflammation index for colorectal cancer: a systematic review and meta-analysis</a:t>
+              <a:t>Awareness of inflammatory bowel disease-associated colorectal cancer risk and its management in patients with inflammatory bowel disease: a systematic review</a:t>
             </a:r>
             <a:endParaRPr lang="en-US" sz="2400" dirty="0"/>
           </a:p>
@@ -6073,7 +6170,7 @@
                   <a:srgbClr val="888888"/>
                 </a:solidFill>
               </a:rPr>
-              <a:t>Frontiers in Oncology  ·  Meta-Analysis</a:t>
+              <a:t>Crohns &amp; Colitis 360  ·  Systematic Review</a:t>
             </a:r>
             <a:endParaRPr lang="en-US" sz="1000" dirty="0"/>
           </a:p>
@@ -6116,7 +6213,7 @@
                 <a:ea typeface="Arial" pitchFamily="34" charset="-122"/>
                 <a:cs typeface="Arial" pitchFamily="34" charset="-120"/>
               </a:rPr>
-              <a:t>Systemic immune-inflammation index (SII) evaluated</a:t>
+              <a:t>Limited awareness of colorectal cancer risk</a:t>
             </a:r>
             <a:endParaRPr lang="en-US" sz="1800" dirty="0"/>
           </a:p>
@@ -6137,7 +6234,7 @@
                 <a:ea typeface="Arial" pitchFamily="34" charset="-122"/>
                 <a:cs typeface="Arial" pitchFamily="34" charset="-120"/>
               </a:rPr>
-              <a:t>SII as a prognostic biomarker in CRC</a:t>
+              <a:t>Need for better management strategies</a:t>
             </a:r>
             <a:endParaRPr lang="en-US" sz="1800" dirty="0"/>
           </a:p>
@@ -6158,7 +6255,7 @@
                 <a:ea typeface="Arial" pitchFamily="34" charset="-122"/>
                 <a:cs typeface="Arial" pitchFamily="34" charset="-120"/>
               </a:rPr>
-              <a:t>Meta-analysis of existing studies conducted</a:t>
+              <a:t>Research gaps in patient knowledge</a:t>
             </a:r>
             <a:endParaRPr lang="en-US" sz="1800" dirty="0"/>
           </a:p>
@@ -6166,7 +6263,43 @@
       </p:sp>
       <p:sp>
         <p:nvSpPr>
-          <p:cNvPr id="7" name="Text 5">
+          <p:cNvPr id="7" name="Text 5"/>
+          <p:cNvSpPr/>
+          <p:nvPr/>
+        </p:nvSpPr>
+        <p:spPr>
+          <a:xfrm>
+            <a:off x="731520" y="5852160"/>
+            <a:ext cx="10058400" cy="0"/>
+          </a:xfrm>
+          <a:prstGeom prst="rect">
+            <a:avLst/>
+          </a:prstGeom>
+          <a:noFill/>
+          <a:ln/>
+        </p:spPr>
+        <p:txBody>
+          <a:bodyPr wrap="square" lIns="0" tIns="0" rIns="0" bIns="0" rtlCol="0" anchor="ctr"/>
+          <a:lstStyle/>
+          <a:p>
+            <a:pPr indent="0" marL="0">
+              <a:buNone/>
+            </a:pPr>
+            <a:r>
+              <a:rPr lang="en-US" sz="800" dirty="0">
+                <a:solidFill>
+                  <a:srgbClr val="888888"/>
+                </a:solidFill>
+              </a:rPr>
+              <a:t>F Khan, C Norton, W Czuber-Dochan. Crohns &amp; Colitis 360. 2026</a:t>
+            </a:r>
+            <a:endParaRPr lang="en-US" sz="800" dirty="0"/>
+          </a:p>
+        </p:txBody>
+      </p:sp>
+      <p:sp>
+        <p:nvSpPr>
+          <p:cNvPr id="8" name="Text 6">
             <a:hlinkClick r:id="rId2" tooltip=""/>
           </p:cNvPr>
           <p:cNvSpPr/>
@@ -6437,7 +6570,7 @@
                 <a:ea typeface="Arial" pitchFamily="34" charset="-122"/>
                 <a:cs typeface="Arial" pitchFamily="34" charset="-120"/>
               </a:rPr>
-              <a:t>Lactate metabolism impacts intestinal inflammation.</a:t>
+              <a:t>Lactate influences immune regulation and signaling.</a:t>
             </a:r>
             <a:endParaRPr lang="en-US" sz="1800" dirty="0"/>
           </a:p>
@@ -6458,7 +6591,7 @@
                 <a:ea typeface="Arial" pitchFamily="34" charset="-122"/>
                 <a:cs typeface="Arial" pitchFamily="34" charset="-120"/>
               </a:rPr>
-              <a:t>Lactylation modulates immune responses in gut.</a:t>
+              <a:t>Lactylation modifies epigenetic regulation in cells.</a:t>
             </a:r>
             <a:endParaRPr lang="en-US" sz="1800" dirty="0"/>
           </a:p>
@@ -6479,15 +6612,93 @@
                 <a:ea typeface="Arial" pitchFamily="34" charset="-122"/>
                 <a:cs typeface="Arial" pitchFamily="34" charset="-120"/>
               </a:rPr>
-              <a:t>Targeting lactate may treat intestinal diseases.</a:t>
+              <a:t>Context-dependent effects on inflammation and cancer.</a:t>
             </a:r>
             <a:endParaRPr lang="en-US" sz="1800" dirty="0"/>
           </a:p>
-        </p:txBody>
-      </p:sp>
-      <p:sp>
-        <p:nvSpPr>
-          <p:cNvPr id="7" name="Text 5">
+          <a:p>
+            <a:pPr marL="342900" indent="-342900">
+              <a:spcAft>
+                <a:spcPts val="800"/>
+              </a:spcAft>
+              <a:buSzPct val="100000"/>
+              <a:buChar char="•"/>
+            </a:pPr>
+            <a:r>
+              <a:rPr lang="en-US" sz="1800" dirty="0">
+                <a:solidFill>
+                  <a:srgbClr val="333333"/>
+                </a:solidFill>
+                <a:latin typeface="Arial" pitchFamily="34" charset="0"/>
+                <a:ea typeface="Arial" pitchFamily="34" charset="-122"/>
+                <a:cs typeface="Arial" pitchFamily="34" charset="-120"/>
+              </a:rPr>
+              <a:t>Lactylation promotes macrophage conversion and fibrosis.</a:t>
+            </a:r>
+            <a:endParaRPr lang="en-US" sz="1800" dirty="0"/>
+          </a:p>
+          <a:p>
+            <a:pPr marL="342900" indent="-342900">
+              <a:spcAft>
+                <a:spcPts val="800"/>
+              </a:spcAft>
+              <a:buSzPct val="100000"/>
+              <a:buChar char="•"/>
+            </a:pPr>
+            <a:r>
+              <a:rPr lang="en-US" sz="1800" dirty="0">
+                <a:solidFill>
+                  <a:srgbClr val="333333"/>
+                </a:solidFill>
+                <a:latin typeface="Arial" pitchFamily="34" charset="0"/>
+                <a:ea typeface="Arial" pitchFamily="34" charset="-122"/>
+                <a:cs typeface="Arial" pitchFamily="34" charset="-120"/>
+              </a:rPr>
+              <a:t>Targeting lactate metabolism offers therapeutic potential.</a:t>
+            </a:r>
+            <a:endParaRPr lang="en-US" sz="1800" dirty="0"/>
+          </a:p>
+        </p:txBody>
+      </p:sp>
+      <p:sp>
+        <p:nvSpPr>
+          <p:cNvPr id="7" name="Text 5"/>
+          <p:cNvSpPr/>
+          <p:nvPr/>
+        </p:nvSpPr>
+        <p:spPr>
+          <a:xfrm>
+            <a:off x="731520" y="5852160"/>
+            <a:ext cx="10058400" cy="0"/>
+          </a:xfrm>
+          <a:prstGeom prst="rect">
+            <a:avLst/>
+          </a:prstGeom>
+          <a:noFill/>
+          <a:ln/>
+        </p:spPr>
+        <p:txBody>
+          <a:bodyPr wrap="square" lIns="0" tIns="0" rIns="0" bIns="0" rtlCol="0" anchor="ctr"/>
+          <a:lstStyle/>
+          <a:p>
+            <a:pPr indent="0" marL="0">
+              <a:buNone/>
+            </a:pPr>
+            <a:r>
+              <a:rPr lang="en-US" sz="800" dirty="0">
+                <a:solidFill>
+                  <a:srgbClr val="888888"/>
+                </a:solidFill>
+              </a:rPr>
+              <a:t>Liu Junting, Liu Yilong, Zhang Hao et al.. Journal of translational medicine. 2026-04-17 DOI: 10.1186/s12967-026-08041-0</a:t>
+            </a:r>
+            <a:endParaRPr lang="en-US" sz="800" dirty="0"/>
+          </a:p>
+        </p:txBody>
+      </p:sp>
+      <p:sp>
+        <p:nvSpPr>
+          <p:cNvPr id="8" name="Text 6">
             <a:hlinkClick r:id="rId2" tooltip=""/>
           </p:cNvPr>
           <p:cNvSpPr/>
@@ -6758,7 +6969,7 @@
                 <a:ea typeface="Arial" pitchFamily="34" charset="-122"/>
                 <a:cs typeface="Arial" pitchFamily="34" charset="-120"/>
               </a:rPr>
-              <a:t>Thlaspi arvense reduces colitis-associated tumors.</a:t>
+              <a:t>Thlaspi arvense reduces colitis-associated cancer.</a:t>
             </a:r>
             <a:endParaRPr lang="en-US" sz="1800" dirty="0"/>
           </a:p>
@@ -6779,7 +6990,7 @@
                 <a:ea typeface="Arial" pitchFamily="34" charset="-122"/>
                 <a:cs typeface="Arial" pitchFamily="34" charset="-120"/>
               </a:rPr>
-              <a:t>Neutrophil recruitment is a key factor.</a:t>
+              <a:t>Neutrophil recruitment drives tumorigenesis in CAC.</a:t>
             </a:r>
             <a:endParaRPr lang="en-US" sz="1800" dirty="0"/>
           </a:p>
@@ -6800,15 +7011,93 @@
                 <a:ea typeface="Arial" pitchFamily="34" charset="-122"/>
                 <a:cs typeface="Arial" pitchFamily="34" charset="-120"/>
               </a:rPr>
-              <a:t>TA inhibits NOD/NF-κB signaling pathway.</a:t>
+              <a:t>TA inhibits NOD/NF-κB pathway activation.</a:t>
             </a:r>
             <a:endParaRPr lang="en-US" sz="1800" dirty="0"/>
           </a:p>
-        </p:txBody>
-      </p:sp>
-      <p:sp>
-        <p:nvSpPr>
-          <p:cNvPr id="7" name="Text 5">
+          <a:p>
+            <a:pPr marL="342900" indent="-342900">
+              <a:spcAft>
+                <a:spcPts val="800"/>
+              </a:spcAft>
+              <a:buSzPct val="100000"/>
+              <a:buChar char="•"/>
+            </a:pPr>
+            <a:r>
+              <a:rPr lang="en-US" sz="1800" dirty="0">
+                <a:solidFill>
+                  <a:srgbClr val="333333"/>
+                </a:solidFill>
+                <a:latin typeface="Arial" pitchFamily="34" charset="0"/>
+                <a:ea typeface="Arial" pitchFamily="34" charset="-122"/>
+                <a:cs typeface="Arial" pitchFamily="34" charset="-120"/>
+              </a:rPr>
+              <a:t>TA restores mucosal integrity and tight junctions.</a:t>
+            </a:r>
+            <a:endParaRPr lang="en-US" sz="1800" dirty="0"/>
+          </a:p>
+          <a:p>
+            <a:pPr marL="342900" indent="-342900">
+              <a:spcAft>
+                <a:spcPts val="800"/>
+              </a:spcAft>
+              <a:buSzPct val="100000"/>
+              <a:buChar char="•"/>
+            </a:pPr>
+            <a:r>
+              <a:rPr lang="en-US" sz="1800" dirty="0">
+                <a:solidFill>
+                  <a:srgbClr val="333333"/>
+                </a:solidFill>
+                <a:latin typeface="Arial" pitchFamily="34" charset="0"/>
+                <a:ea typeface="Arial" pitchFamily="34" charset="-122"/>
+                <a:cs typeface="Arial" pitchFamily="34" charset="-120"/>
+              </a:rPr>
+              <a:t>CXCL1/2 levels significantly decreased with TA.</a:t>
+            </a:r>
+            <a:endParaRPr lang="en-US" sz="1800" dirty="0"/>
+          </a:p>
+        </p:txBody>
+      </p:sp>
+      <p:sp>
+        <p:nvSpPr>
+          <p:cNvPr id="7" name="Text 5"/>
+          <p:cNvSpPr/>
+          <p:nvPr/>
+        </p:nvSpPr>
+        <p:spPr>
+          <a:xfrm>
+            <a:off x="731520" y="5852160"/>
+            <a:ext cx="10058400" cy="0"/>
+          </a:xfrm>
+          <a:prstGeom prst="rect">
+            <a:avLst/>
+          </a:prstGeom>
+          <a:noFill/>
+          <a:ln/>
+        </p:spPr>
+        <p:txBody>
+          <a:bodyPr wrap="square" lIns="0" tIns="0" rIns="0" bIns="0" rtlCol="0" anchor="ctr"/>
+          <a:lstStyle/>
+          <a:p>
+            <a:pPr indent="0" marL="0">
+              <a:buNone/>
+            </a:pPr>
+            <a:r>
+              <a:rPr lang="en-US" sz="800" dirty="0">
+                <a:solidFill>
+                  <a:srgbClr val="888888"/>
+                </a:solidFill>
+              </a:rPr>
+              <a:t>Wang Ziwei, Wang Wenkai, Wang Chaowei et al.. Chinese medicine. 2026-04-18 DOI: 10.1186/s13020-026-01381-5</a:t>
+            </a:r>
+            <a:endParaRPr lang="en-US" sz="800" dirty="0"/>
+          </a:p>
+        </p:txBody>
+      </p:sp>
+      <p:sp>
+        <p:nvSpPr>
+          <p:cNvPr id="8" name="Text 6">
             <a:hlinkClick r:id="rId2" tooltip=""/>
           </p:cNvPr>
           <p:cNvSpPr/>
@@ -7079,7 +7368,7 @@
                 <a:ea typeface="Arial" pitchFamily="34" charset="-122"/>
                 <a:cs typeface="Arial" pitchFamily="34" charset="-120"/>
               </a:rPr>
-              <a:t>A1AT promotes CRC liver metastasis.</a:t>
+              <a:t>A1AT promotes liver metastasis in CRC.</a:t>
             </a:r>
             <a:endParaRPr lang="en-US" sz="1800" dirty="0"/>
           </a:p>
@@ -7100,7 +7389,7 @@
                 <a:ea typeface="Arial" pitchFamily="34" charset="-122"/>
                 <a:cs typeface="Arial" pitchFamily="34" charset="-120"/>
               </a:rPr>
-              <a:t>Neutrophil extracellular traps involved.</a:t>
+              <a:t>Neutrophil extracellular traps (NETs) involved.</a:t>
             </a:r>
             <a:endParaRPr lang="en-US" sz="1800" dirty="0"/>
           </a:p>
@@ -7121,7 +7410,7 @@
                 <a:ea typeface="Arial" pitchFamily="34" charset="-122"/>
                 <a:cs typeface="Arial" pitchFamily="34" charset="-120"/>
               </a:rPr>
-              <a:t>CCDC25 upregulation enhances invasiveness.</a:t>
+              <a:t>CCDC25 upregulation enhances tumor invasion.</a:t>
             </a:r>
             <a:endParaRPr lang="en-US" sz="1800" dirty="0"/>
           </a:p>
@@ -7129,7 +7418,43 @@
       </p:sp>
       <p:sp>
         <p:nvSpPr>
-          <p:cNvPr id="7" name="Text 5">
+          <p:cNvPr id="7" name="Text 5"/>
+          <p:cNvSpPr/>
+          <p:nvPr/>
+        </p:nvSpPr>
+        <p:spPr>
+          <a:xfrm>
+            <a:off x="731520" y="5852160"/>
+            <a:ext cx="10058400" cy="0"/>
+          </a:xfrm>
+          <a:prstGeom prst="rect">
+            <a:avLst/>
+          </a:prstGeom>
+          <a:noFill/>
+          <a:ln/>
+        </p:spPr>
+        <p:txBody>
+          <a:bodyPr wrap="square" lIns="0" tIns="0" rIns="0" bIns="0" rtlCol="0" anchor="ctr"/>
+          <a:lstStyle/>
+          <a:p>
+            <a:pPr indent="0" marL="0">
+              <a:buNone/>
+            </a:pPr>
+            <a:r>
+              <a:rPr lang="en-US" sz="800" dirty="0">
+                <a:solidFill>
+                  <a:srgbClr val="888888"/>
+                </a:solidFill>
+              </a:rPr>
+              <a:t>Fei Qian, Li Chunning, Zhan Lei et al.. Advanced science (Weinheim, Baden-Wurttemberg, Germany). 2026-04-16 DOI: 10.1002/advs.202520000</a:t>
+            </a:r>
+            <a:endParaRPr lang="en-US" sz="800" dirty="0"/>
+          </a:p>
+        </p:txBody>
+      </p:sp>
+      <p:sp>
+        <p:nvSpPr>
+          <p:cNvPr id="8" name="Text 6">
             <a:hlinkClick r:id="rId2" tooltip=""/>
           </p:cNvPr>
           <p:cNvSpPr/>

</xml_diff>

<commit_message>
chore: update weekly digest 2026-04-27
</commit_message>
<xml_diff>
--- a/docs/digest-en.pptx
+++ b/docs/digest-en.pptx
@@ -2249,7 +2249,7 @@
                   <a:srgbClr val="888888"/>
                 </a:solidFill>
               </a:rPr>
-              <a:t>2026-04-13 — 2026-04-20</a:t>
+              <a:t>2026-04-20 — 2026-04-27</a:t>
             </a:r>
             <a:endParaRPr lang="en-US" sz="1400" dirty="0"/>
           </a:p>
@@ -2440,7 +2440,7 @@
                   </a:extLst>
                 </a:hlinkClick>
               </a:rPr>
-              <a:t>Radioiodination of Two Carborane-Based Dual Cyclooxygenase-2/5-Lipoxygenase Inhibitors and Their In Vitro and In Vivo Evaluation.</a:t>
+              <a:t>Curcumin-loaded extracellular vesicles derived from lactic acid bacteria for alleviation of inflammatory bowel disease.</a:t>
             </a:r>
             <a:endParaRPr lang="en-US" sz="2400" dirty="0"/>
           </a:p>
@@ -2476,7 +2476,7 @@
                   <a:srgbClr val="888888"/>
                 </a:solidFill>
               </a:rPr>
-              <a:t>Chembiochem : a European journal of chemical biology  ·  Basic Research</a:t>
+              <a:t>International journal of pharmaceutics  ·  Basic Research</a:t>
             </a:r>
             <a:endParaRPr lang="en-US" sz="1000" dirty="0"/>
           </a:p>
@@ -2519,7 +2519,7 @@
                 <a:ea typeface="Arial" pitchFamily="34" charset="-122"/>
                 <a:cs typeface="Arial" pitchFamily="34" charset="-120"/>
               </a:rPr>
-              <a:t>COX-2 and 5-LO are cancer targets</a:t>
+              <a:t>Curcumin-loaded EVs from LAB show promise.</a:t>
             </a:r>
             <a:endParaRPr lang="en-US" sz="1800" dirty="0"/>
           </a:p>
@@ -2540,7 +2540,7 @@
                 <a:ea typeface="Arial" pitchFamily="34" charset="-122"/>
                 <a:cs typeface="Arial" pitchFamily="34" charset="-120"/>
               </a:rPr>
-              <a:t>Iodinated inhibitors showed varying potency</a:t>
+              <a:t>L-EVs-C exhibit superior characteristics.</a:t>
             </a:r>
             <a:endParaRPr lang="en-US" sz="1800" dirty="0"/>
           </a:p>
@@ -2561,49 +2561,7 @@
                 <a:ea typeface="Arial" pitchFamily="34" charset="-122"/>
                 <a:cs typeface="Arial" pitchFamily="34" charset="-120"/>
               </a:rPr>
-              <a:t>Cellular uptake linked to 5-LO expression</a:t>
-            </a:r>
-            <a:endParaRPr lang="en-US" sz="1800" dirty="0"/>
-          </a:p>
-          <a:p>
-            <a:pPr marL="342900" indent="-342900">
-              <a:spcAft>
-                <a:spcPts val="800"/>
-              </a:spcAft>
-              <a:buSzPct val="100000"/>
-              <a:buChar char="•"/>
-            </a:pPr>
-            <a:r>
-              <a:rPr lang="en-US" sz="1800" dirty="0">
-                <a:solidFill>
-                  <a:srgbClr val="333333"/>
-                </a:solidFill>
-                <a:latin typeface="Arial" pitchFamily="34" charset="0"/>
-                <a:ea typeface="Arial" pitchFamily="34" charset="-122"/>
-                <a:cs typeface="Arial" pitchFamily="34" charset="-120"/>
-              </a:rPr>
-              <a:t>No tumor retention in mouse models</a:t>
-            </a:r>
-            <a:endParaRPr lang="en-US" sz="1800" dirty="0"/>
-          </a:p>
-          <a:p>
-            <a:pPr marL="342900" indent="-342900">
-              <a:spcAft>
-                <a:spcPts val="800"/>
-              </a:spcAft>
-              <a:buSzPct val="100000"/>
-              <a:buChar char="•"/>
-            </a:pPr>
-            <a:r>
-              <a:rPr lang="en-US" sz="1800" dirty="0">
-                <a:solidFill>
-                  <a:srgbClr val="333333"/>
-                </a:solidFill>
-                <a:latin typeface="Arial" pitchFamily="34" charset="0"/>
-                <a:ea typeface="Arial" pitchFamily="34" charset="-122"/>
-                <a:cs typeface="Arial" pitchFamily="34" charset="-120"/>
-              </a:rPr>
-              <a:t>Improved stability needed for radiotracers</a:t>
+              <a:t>Treatment alleviates IBD symptoms in mice.</a:t>
             </a:r>
             <a:endParaRPr lang="en-US" sz="1800" dirty="0"/>
           </a:p>
@@ -2639,7 +2597,7 @@
                   <a:srgbClr val="888888"/>
                 </a:solidFill>
               </a:rPr>
-              <a:t>Sch&amp;#xe4;dlich Jonas, Ullrich Martin, Haase-Kohn Cathleen et al.. Chembiochem : a European journal of chemical biology. 2026-04-01 DOI: 10.1002/cbic.202600004</a:t>
+              <a:t>Qiu Fang, Wang Baixuan, Zhang Yongjing et al.. International journal of pharmaceutics. 2026-04-23 DOI: 10.1016/j.ijpharm.2026.126859</a:t>
             </a:r>
             <a:endParaRPr lang="en-US" sz="800" dirty="0"/>
           </a:p>
@@ -2839,7 +2797,7 @@
                   </a:extLst>
                 </a:hlinkClick>
               </a:rPr>
-              <a:t>Repurposing PARP inhibitors in molecularly defined subgroups of peritoneal metastatic colorectal cancer (pmCRC): Preclinical analysis of patient-derived xenograft …</a:t>
+              <a:t>Multi-analytical and biological insights into Malcolmia grandiflora Kuntze.</a:t>
             </a:r>
             <a:endParaRPr lang="en-US" sz="2400" dirty="0"/>
           </a:p>
@@ -2875,7 +2833,7 @@
                   <a:srgbClr val="888888"/>
                 </a:solidFill>
               </a:rPr>
-              <a:t>Cancer …  ·  Basic Research</a:t>
+              <a:t>Scientific reports  ·  Basic Research</a:t>
             </a:r>
             <a:endParaRPr lang="en-US" sz="1000" dirty="0"/>
           </a:p>
@@ -2918,7 +2876,7 @@
                 <a:ea typeface="Arial" pitchFamily="34" charset="-122"/>
                 <a:cs typeface="Arial" pitchFamily="34" charset="-120"/>
               </a:rPr>
-              <a:t>pmCRC has poor prognosis compared to other metastases.</a:t>
+              <a:t>Malcolmia grandiflora shows bioactive potential.</a:t>
             </a:r>
             <a:endParaRPr lang="en-US" sz="1800" dirty="0"/>
           </a:p>
@@ -2939,7 +2897,7 @@
                 <a:ea typeface="Arial" pitchFamily="34" charset="-122"/>
                 <a:cs typeface="Arial" pitchFamily="34" charset="-120"/>
               </a:rPr>
-              <a:t>PARP inhibitors show promise in targeted therapy.</a:t>
+              <a:t>n-hexane extract exhibits cytotoxicity against cancer.</a:t>
             </a:r>
             <a:endParaRPr lang="en-US" sz="1800" dirty="0"/>
           </a:p>
@@ -2960,7 +2918,49 @@
                 <a:ea typeface="Arial" pitchFamily="34" charset="-122"/>
                 <a:cs typeface="Arial" pitchFamily="34" charset="-120"/>
               </a:rPr>
-              <a:t>Patient-derived xenografts used for preclinical analysis.</a:t>
+              <a:t>Defatted extract inhibits COX-2 selectively.</a:t>
+            </a:r>
+            <a:endParaRPr lang="en-US" sz="1800" dirty="0"/>
+          </a:p>
+          <a:p>
+            <a:pPr marL="342900" indent="-342900">
+              <a:spcAft>
+                <a:spcPts val="800"/>
+              </a:spcAft>
+              <a:buSzPct val="100000"/>
+              <a:buChar char="•"/>
+            </a:pPr>
+            <a:r>
+              <a:rPr lang="en-US" sz="1800" dirty="0">
+                <a:solidFill>
+                  <a:srgbClr val="333333"/>
+                </a:solidFill>
+                <a:latin typeface="Arial" pitchFamily="34" charset="0"/>
+                <a:ea typeface="Arial" pitchFamily="34" charset="-122"/>
+                <a:cs typeface="Arial" pitchFamily="34" charset="-120"/>
+              </a:rPr>
+              <a:t>Moderate antioxidant activity in defatted extract.</a:t>
+            </a:r>
+            <a:endParaRPr lang="en-US" sz="1800" dirty="0"/>
+          </a:p>
+          <a:p>
+            <a:pPr marL="342900" indent="-342900">
+              <a:spcAft>
+                <a:spcPts val="800"/>
+              </a:spcAft>
+              <a:buSzPct val="100000"/>
+              <a:buChar char="•"/>
+            </a:pPr>
+            <a:r>
+              <a:rPr lang="en-US" sz="1800" dirty="0">
+                <a:solidFill>
+                  <a:srgbClr val="333333"/>
+                </a:solidFill>
+                <a:latin typeface="Arial" pitchFamily="34" charset="0"/>
+                <a:ea typeface="Arial" pitchFamily="34" charset="-122"/>
+                <a:cs typeface="Arial" pitchFamily="34" charset="-120"/>
+              </a:rPr>
+              <a:t>Flavonoids identified as potential CDK inhibitors.</a:t>
             </a:r>
             <a:endParaRPr lang="en-US" sz="1800" dirty="0"/>
           </a:p>
@@ -2996,7 +2996,7 @@
                   <a:srgbClr val="888888"/>
                 </a:solidFill>
               </a:rPr>
-              <a:t>M Dahlmann, B Rau, S Gül-Klein. Cancer …. 2026</a:t>
+              <a:t>Elwekeel Ahlam Hashem, Mohamed Enas I A, Amin Elham et al.. Scientific reports. 2026-04-21 DOI: 10.1038/s41598-026-44715-x</a:t>
             </a:r>
             <a:endParaRPr lang="en-US" sz="800" dirty="0"/>
           </a:p>
@@ -3196,7 +3196,7 @@
                   </a:extLst>
                 </a:hlinkClick>
               </a:rPr>
-              <a:t>The Mechanism of Acetyl-L-Carnitine on Colorectal Cancer and Its Metabolomic Study</a:t>
+              <a:t>Gastroprotective [6]-Gingerol Aspirinate as a Novel Aspirin-Derived Chemopreventive Agent Attenuating Colitis.</a:t>
             </a:r>
             <a:endParaRPr lang="en-US" sz="2400" dirty="0"/>
           </a:p>
@@ -3232,7 +3232,7 @@
                   <a:srgbClr val="888888"/>
                 </a:solidFill>
               </a:rPr>
-              <a:t>Journal of Pharmaceutical and …  ·  Basic Research</a:t>
+              <a:t>Journal of agricultural and food chemistry  ·  Basic Research</a:t>
             </a:r>
             <a:endParaRPr lang="en-US" sz="1000" dirty="0"/>
           </a:p>
@@ -3275,7 +3275,7 @@
                 <a:ea typeface="Arial" pitchFamily="34" charset="-122"/>
                 <a:cs typeface="Arial" pitchFamily="34" charset="-120"/>
               </a:rPr>
-              <a:t>Acetyl-L-Carnitine inhibits tumor growth</a:t>
+              <a:t>GAS improves colitis symptoms significantly.</a:t>
             </a:r>
             <a:endParaRPr lang="en-US" sz="1800" dirty="0"/>
           </a:p>
@@ -3296,7 +3296,7 @@
                 <a:ea typeface="Arial" pitchFamily="34" charset="-122"/>
                 <a:cs typeface="Arial" pitchFamily="34" charset="-120"/>
               </a:rPr>
-              <a:t>In vivo studies confirm ALC efficacy</a:t>
+              <a:t>Reduces pro-inflammatory markers effectively.</a:t>
             </a:r>
             <a:endParaRPr lang="en-US" sz="1800" dirty="0"/>
           </a:p>
@@ -3317,7 +3317,49 @@
                 <a:ea typeface="Arial" pitchFamily="34" charset="-122"/>
                 <a:cs typeface="Arial" pitchFamily="34" charset="-120"/>
               </a:rPr>
-              <a:t>Metabolomic analysis reveals mechanisms</a:t>
+              <a:t>Reverses 73 DSS-altered metabolites.</a:t>
+            </a:r>
+            <a:endParaRPr lang="en-US" sz="1800" dirty="0"/>
+          </a:p>
+          <a:p>
+            <a:pPr marL="342900" indent="-342900">
+              <a:spcAft>
+                <a:spcPts val="800"/>
+              </a:spcAft>
+              <a:buSzPct val="100000"/>
+              <a:buChar char="•"/>
+            </a:pPr>
+            <a:r>
+              <a:rPr lang="en-US" sz="1800" dirty="0">
+                <a:solidFill>
+                  <a:srgbClr val="333333"/>
+                </a:solidFill>
+                <a:latin typeface="Arial" pitchFamily="34" charset="0"/>
+                <a:ea typeface="Arial" pitchFamily="34" charset="-122"/>
+                <a:cs typeface="Arial" pitchFamily="34" charset="-120"/>
+              </a:rPr>
+              <a:t>Strong correlation with inflammatory cytokines.</a:t>
+            </a:r>
+            <a:endParaRPr lang="en-US" sz="1800" dirty="0"/>
+          </a:p>
+          <a:p>
+            <a:pPr marL="342900" indent="-342900">
+              <a:spcAft>
+                <a:spcPts val="800"/>
+              </a:spcAft>
+              <a:buSzPct val="100000"/>
+              <a:buChar char="•"/>
+            </a:pPr>
+            <a:r>
+              <a:rPr lang="en-US" sz="1800" dirty="0">
+                <a:solidFill>
+                  <a:srgbClr val="333333"/>
+                </a:solidFill>
+                <a:latin typeface="Arial" pitchFamily="34" charset="0"/>
+                <a:ea typeface="Arial" pitchFamily="34" charset="-122"/>
+                <a:cs typeface="Arial" pitchFamily="34" charset="-120"/>
+              </a:rPr>
+              <a:t>Potential safer chemopreventive agent.</a:t>
             </a:r>
             <a:endParaRPr lang="en-US" sz="1800" dirty="0"/>
           </a:p>
@@ -3353,7 +3395,7 @@
                   <a:srgbClr val="888888"/>
                 </a:solidFill>
               </a:rPr>
-              <a:t>J Ning, C Cai, X Fan. Journal of Pharmaceutical and …. 2026</a:t>
+              <a:t>Lee Pei-Sheng, Zhang Shuwei, Zhu Yingdong et al.. Journal of agricultural and food chemistry. 2026-04-25 DOI: 10.1021/acs.jafc.5c17778</a:t>
             </a:r>
             <a:endParaRPr lang="en-US" sz="800" dirty="0"/>
           </a:p>
@@ -3570,7 +3612,7 @@
                   <a:srgbClr val="FFFFFF"/>
                 </a:solidFill>
               </a:rPr>
-              <a:t>1. **腸道微生物與癌症的關聯性**  </a:t>
+              <a:t>1. **腸道微生物與癌症關聯性**  </a:t>
             </a:r>
             <a:endParaRPr lang="en-US" sz="1200" dirty="0"/>
           </a:p>
@@ -3587,7 +3629,7 @@
                   <a:srgbClr val="FFFFFF"/>
                 </a:solidFill>
               </a:rPr>
-              <a:t>   The study of *Parasutterella excrementihominis* highlights the complex relationship between gut microbiota and colorectal cancer, suggesting that specific microbial species can exacerbate colitis and promote tumorigenesis.  </a:t>
+              <a:t>   The study of *Parasutterella excrementihominis* highlights the significant role of gut microbiota in exacerbating colitis and colorectal cancer, suggesting that microbial dysbiosis can influence disease progression.  </a:t>
             </a:r>
             <a:endParaRPr lang="en-US" sz="1200" dirty="0"/>
           </a:p>
@@ -3604,7 +3646,7 @@
                   <a:srgbClr val="FFFFFF"/>
                 </a:solidFill>
               </a:rPr>
-              <a:t>   *Parasutterella excrementihominis*的研究突顯了腸道微生物與結直腸癌之間的複雜關係，表明特定微生物物種可以加劇結腸炎並促進腫瘤生成。</a:t>
+              <a:t>   *Parasutterella excrementihominis*的研究突顯了腸道微生物在加重結腸炎和結直腸癌中的重要角色，暗示微生物失調可能影響疾病進展。</a:t>
             </a:r>
             <a:endParaRPr lang="en-US" sz="1200" dirty="0"/>
           </a:p>
@@ -3630,7 +3672,7 @@
                   <a:srgbClr val="FFFFFF"/>
                 </a:solidFill>
               </a:rPr>
-              <a:t>2. **系統性免疫炎症指數的預後價值**  </a:t>
+              <a:t>2. **系統性免疫-炎症指數的預後價值**  </a:t>
             </a:r>
             <a:endParaRPr lang="en-US" sz="1200" dirty="0"/>
           </a:p>
@@ -3647,7 +3689,7 @@
                   <a:srgbClr val="FFFFFF"/>
                 </a:solidFill>
               </a:rPr>
-              <a:t>   The systemic immune-inflammation index (SII) emerges as a promising prognostic biomarker for colorectal cancer, indicating that immune status may significantly influence patient outcomes.  </a:t>
+              <a:t>   The systemic immune-inflammation index (SII) has emerged as a promising prognostic biomarker for colorectal cancer, indicating that immune status can provide valuable insights into patient outcomes.  </a:t>
             </a:r>
             <a:endParaRPr lang="en-US" sz="1200" dirty="0"/>
           </a:p>
@@ -3664,7 +3706,7 @@
                   <a:srgbClr val="FFFFFF"/>
                 </a:solidFill>
               </a:rPr>
-              <a:t>   系統性免疫炎症指數(SII)作為結直腸癌的有前景的預後生物標誌，表明免疫狀態可能顯著影響患者的預後。</a:t>
+              <a:t>   系統性免疫-炎症指數（SII）已成為結直腸癌有前景的預後生物標記，表明免疫狀態能提供患者預後的重要見解。</a:t>
             </a:r>
             <a:endParaRPr lang="en-US" sz="1200" dirty="0"/>
           </a:p>
@@ -3690,7 +3732,7 @@
                   <a:srgbClr val="FFFFFF"/>
                 </a:solidFill>
               </a:rPr>
-              <a:t>3. **化療與腫瘤微環境的相互作用**  </a:t>
+              <a:t>3. **傳統醫學在癌症治療中的潛力**  </a:t>
             </a:r>
             <a:endParaRPr lang="en-US" sz="1200" dirty="0"/>
           </a:p>
@@ -3707,7 +3749,7 @@
                   <a:srgbClr val="FFFFFF"/>
                 </a:solidFill>
               </a:rPr>
-              <a:t>   Hyperthermic intraperitoneal chemotherapy shows potential in treating peritoneal metastases, emphasizing the need to understand the tumor microenvironment's role in therapeutic efficacy.  </a:t>
+              <a:t>   The integration of traditional Chinese medicine, such as Wumei Wan, into colorectal cancer treatment shows potential in modulating tumor progression, emphasizing the need for further exploration of holistic approaches.  </a:t>
             </a:r>
             <a:endParaRPr lang="en-US" sz="1200" dirty="0"/>
           </a:p>
@@ -3724,7 +3766,7 @@
                   <a:srgbClr val="FFFFFF"/>
                 </a:solidFill>
               </a:rPr>
-              <a:t>   超高溫腹腔化療在治療腹膜轉移中顯示出潛力，強調需要理解腫瘤微環境在治療效果中的作用。</a:t>
+              <a:t>   傳統中醫如五梅丸在結直腸癌治療中的整合顯示出調節腫瘤進展的潛力，強調需要進一步探索整體治療方法。</a:t>
             </a:r>
             <a:endParaRPr lang="en-US" sz="1200" dirty="0"/>
           </a:p>
@@ -3750,7 +3792,7 @@
                   <a:srgbClr val="FFFFFF"/>
                 </a:solidFill>
               </a:rPr>
-              <a:t>4. **乳酸代謝的雙重角色**  </a:t>
+              <a:t>4. **腫瘤微環境的空間組織**  </a:t>
             </a:r>
             <a:endParaRPr lang="en-US" sz="1200" dirty="0"/>
           </a:p>
@@ -3767,7 +3809,7 @@
                   <a:srgbClr val="FFFFFF"/>
                 </a:solidFill>
               </a:rPr>
-              <a:t>   Lactate metabolism is implicated in both promoting intestinal inflammation and malignancy, suggesting that targeting lactate pathways could provide therapeutic benefits.  </a:t>
+              <a:t>   Understanding the spatial organization of the tumor microenvironment (TME) is crucial for deciphering colorectal cancer progression, as it affects cellular interactions and therapeutic responses.  </a:t>
             </a:r>
             <a:endParaRPr lang="en-US" sz="1200" dirty="0"/>
           </a:p>
@@ -3784,7 +3826,7 @@
                   <a:srgbClr val="FFFFFF"/>
                 </a:solidFill>
               </a:rPr>
-              <a:t>   乳酸代謝被認為在促進腸道炎症和惡性腫瘤中扮演雙重角色，這表明針對乳酸途徑可能帶來治療益處。</a:t>
+              <a:t>   理解腫瘤微環境（TME）的空間組織對於解讀結直腸癌進展至關重要，因為它影響細胞間的相互作用和治療反應。</a:t>
             </a:r>
             <a:endParaRPr lang="en-US" sz="1200" dirty="0"/>
           </a:p>
@@ -3810,7 +3852,7 @@
                   <a:srgbClr val="FFFFFF"/>
                 </a:solidFill>
               </a:rPr>
-              <a:t>5. **慢性炎症與腫瘤生成的關聯**  </a:t>
+              <a:t>5. **炎症性腸病患者的癌症風險認識**  </a:t>
             </a:r>
             <a:endParaRPr lang="en-US" sz="1200" dirty="0"/>
           </a:p>
@@ -3827,7 +3869,7 @@
                   <a:srgbClr val="FFFFFF"/>
                 </a:solidFill>
               </a:rPr>
-              <a:t>   Chronic inflammation is identified as a critical driver of colitis-associated colorectal cancer, highlighting the importance of managing inflammatory conditions to prevent cancer progression.</a:t>
+              <a:t>   There is a critical gap in awareness regarding the colorectal cancer risk among patients with inflammatory bowel disease, highlighting the need for improved education and management strategies.</a:t>
             </a:r>
             <a:endParaRPr lang="en-US" sz="1200" dirty="0"/>
           </a:p>
@@ -3973,7 +4015,7 @@
                   <a:srgbClr val="FFFFFF"/>
                 </a:solidFill>
               </a:rPr>
-              <a:t>慢性炎症被確定為結腸炎相關結直腸癌的關鍵驅動因素，強調管理炎症狀況以預防癌症進展的重要性。</a:t>
+              <a:t>為炎症性腸病患者對結直腸癌風險的認識存在重大缺口，強調需要改善教育和管理策略。</a:t>
             </a:r>
             <a:endParaRPr lang="en-US" sz="1200" dirty="0"/>
           </a:p>
@@ -4025,7 +4067,7 @@
                   <a:srgbClr val="FFFFFF"/>
                 </a:solidFill>
               </a:rPr>
-              <a:t>1. **微生物組干預的臨床應用**  </a:t>
+              <a:t>1. **微生物組與癌症機制的深入研究**  </a:t>
             </a:r>
             <a:endParaRPr lang="en-US" sz="1200" dirty="0"/>
           </a:p>
@@ -4042,7 +4084,7 @@
                   <a:srgbClr val="FFFFFF"/>
                 </a:solidFill>
               </a:rPr>
-              <a:t>   Future studies should explore the therapeutic potential of modulating gut microbiota to prevent or treat colorectal cancer and associated inflammatory conditions.  </a:t>
+              <a:t>   Future studies should focus on elucidating the mechanisms by which gut microbiota, like *Parasutterella excrementihominis*, contribute to colitis and colorectal cancer pathogenesis.  </a:t>
             </a:r>
             <a:endParaRPr lang="en-US" sz="1200" dirty="0"/>
           </a:p>
@@ -4059,7 +4101,7 @@
                   <a:srgbClr val="FFFFFF"/>
                 </a:solidFill>
               </a:rPr>
-              <a:t>   未來的研究應探討調節腸道微生物組以預防或治療結直腸癌及相關炎症狀況的治療潛力。</a:t>
+              <a:t>   未來的研究應專注於闡明腸道微生物（如*Parasutterella excrementihominis*）如何促進結腸炎和結直腸癌發病機制。</a:t>
             </a:r>
             <a:endParaRPr lang="en-US" sz="1200" dirty="0"/>
           </a:p>
@@ -4085,7 +4127,7 @@
                   <a:srgbClr val="FFFFFF"/>
                 </a:solidFill>
               </a:rPr>
-              <a:t>2. **免疫指標的個體化治療**  </a:t>
+              <a:t>2. **SII在不同階段癌症中的應用**  </a:t>
             </a:r>
             <a:endParaRPr lang="en-US" sz="1200" dirty="0"/>
           </a:p>
@@ -4102,7 +4144,7 @@
                   <a:srgbClr val="FFFFFF"/>
                 </a:solidFill>
               </a:rPr>
-              <a:t>   Investigating the application of the systemic immune-inflammation index in personalized treatment strategies could enhance the management of colorectal cancer patients.  </a:t>
+              <a:t>   Investigating the role of SII across various stages of colorectal cancer could provide insights into its utility as a dynamic prognostic tool.  </a:t>
             </a:r>
             <a:endParaRPr lang="en-US" sz="1200" dirty="0"/>
           </a:p>
@@ -4119,7 +4161,7 @@
                   <a:srgbClr val="FFFFFF"/>
                 </a:solidFill>
               </a:rPr>
-              <a:t>   研究系統性免疫炎症指數在個體化治療策略中的應用，可能會改善結直腸癌患者的管理。</a:t>
+              <a:t>   研究SII在不同階段結直腸癌中的作用，可能會提供其作為動態預後工具的實用性見解。</a:t>
             </a:r>
             <a:endParaRPr lang="en-US" sz="1200" dirty="0"/>
           </a:p>
@@ -4145,7 +4187,7 @@
                   <a:srgbClr val="FFFFFF"/>
                 </a:solidFill>
               </a:rPr>
-              <a:t>3. **腫瘤微環境的深入研究**  </a:t>
+              <a:t>3. **傳統醫學與現代療法的結合**  </a:t>
             </a:r>
             <a:endParaRPr lang="en-US" sz="1200" dirty="0"/>
           </a:p>
@@ -4162,7 +4204,7 @@
                   <a:srgbClr val="FFFFFF"/>
                 </a:solidFill>
               </a:rPr>
-              <a:t>   Further research is needed to elucidate the role of the tumor microenvironment in colorectal cancer progression and response to therapies, particularly in the context of peritoneal metastases.  </a:t>
+              <a:t>   Further research is needed to explore the synergistic effects of traditional Chinese medicine and modern therapies in managing colorectal cancer.  </a:t>
             </a:r>
             <a:endParaRPr lang="en-US" sz="1200" dirty="0"/>
           </a:p>
@@ -4179,7 +4221,7 @@
                   <a:srgbClr val="FFFFFF"/>
                 </a:solidFill>
               </a:rPr>
-              <a:t>   需要進一步研究以闡明腫瘤微環境在結直腸癌進展和對治療反應中的作用，特別是在腹膜轉移的背景下。</a:t>
+              <a:t>   需要進一步研究傳統中醫與現代療法在管理結直腸癌中的協同效應。</a:t>
             </a:r>
             <a:endParaRPr lang="en-US" sz="1200" dirty="0"/>
           </a:p>
@@ -4205,7 +4247,7 @@
                   <a:srgbClr val="FFFFFF"/>
                 </a:solidFill>
               </a:rPr>
-              <a:t>4. **乳酸代謝的調控機制**  </a:t>
+              <a:t>4. **腫瘤微環境的治療干預**  </a:t>
             </a:r>
             <a:endParaRPr lang="en-US" sz="1200" dirty="0"/>
           </a:p>
@@ -4222,7 +4264,7 @@
                   <a:srgbClr val="FFFFFF"/>
                 </a:solidFill>
               </a:rPr>
-              <a:t>   Investigating the molecular mechanisms behind lactate metabolism and its effects on inflammation and cancer could lead to novel therapeutic targets.  </a:t>
+              <a:t>   Future research should investigate therapeutic strategies targeting the spatial organization of the TME to enhance treatment efficacy in colorectal cancer.  </a:t>
             </a:r>
             <a:endParaRPr lang="en-US" sz="1200" dirty="0"/>
           </a:p>
@@ -4239,7 +4281,7 @@
                   <a:srgbClr val="FFFFFF"/>
                 </a:solidFill>
               </a:rPr>
-              <a:t>   研究乳酸代謝背後的分子機制及其對炎症和癌症的影響，可能會導致新的治療靶點。</a:t>
+              <a:t>   未來的研究應調查針對TME空間組織的治療策略，以提高結直腸癌的治療效果。</a:t>
             </a:r>
             <a:endParaRPr lang="en-US" sz="1200" dirty="0"/>
           </a:p>
@@ -4265,7 +4307,7 @@
                   <a:srgbClr val="FFFFFF"/>
                 </a:solidFill>
               </a:rPr>
-              <a:t>5. **炎症與癌症風險的教育**  </a:t>
+              <a:t>5. **增強患者對癌症風險的認識**  </a:t>
             </a:r>
             <a:endParaRPr lang="en-US" sz="1200" dirty="0"/>
           </a:p>
@@ -4282,7 +4324,7 @@
                   <a:srgbClr val="FFFFFF"/>
                 </a:solidFill>
               </a:rPr>
-              <a:t>   Increasing awareness and understanding of the link between inflammatory bowel disease and colorectal cancer risk among patients is essential for effective management and prevention strategies.  </a:t>
+              <a:t>   Developing educational programs aimed at increasing awareness of colorectal cancer risks in patients with inflammatory bowel disease is essential for better management.  </a:t>
             </a:r>
             <a:endParaRPr lang="en-US" sz="1200" dirty="0"/>
           </a:p>
@@ -4299,7 +4341,7 @@
                   <a:srgbClr val="FFFFFF"/>
                 </a:solidFill>
               </a:rPr>
-              <a:t>   提高患者對炎症性腸病與結直腸癌風險之間聯繫的認識和理解，對於有效的管理和預防策略至關重要。</a:t>
+              <a:t>   制定旨在提高炎症性腸病患者對結直腸癌風險認識的教育計劃，對於改善管理至關重要。</a:t>
             </a:r>
             <a:endParaRPr lang="en-US" sz="1200" dirty="0"/>
           </a:p>
@@ -4681,7 +4723,7 @@
                 <a:ea typeface="Arial" pitchFamily="34" charset="-122"/>
                 <a:cs typeface="Arial" pitchFamily="34" charset="-120"/>
               </a:rPr>
-              <a:t>Lactate metabolism-driven lactylation: paradoxical modulation of intestinal infl…</a:t>
+              <a:t>Network pharmacology integrated with multi-omics demonstrates that Wumei Wan mod…</a:t>
             </a:r>
             <a:endParaRPr lang="en-US" sz="1400" dirty="0"/>
           </a:p>
@@ -4718,7 +4760,7 @@
                 <a:ea typeface="Arial" pitchFamily="34" charset="-122"/>
                 <a:cs typeface="Arial" pitchFamily="34" charset="-120"/>
               </a:rPr>
-              <a:t>Thlaspi arvense attenuates colitis-associated colorectal tumorigenesis through s…</a:t>
+              <a:t>Low inflammation correlates with protumor Tim4+TREM1+ resident macrophage expans…</a:t>
             </a:r>
             <a:endParaRPr lang="en-US" sz="1400" dirty="0"/>
           </a:p>
@@ -4755,7 +4797,7 @@
                 <a:ea typeface="Arial" pitchFamily="34" charset="-122"/>
                 <a:cs typeface="Arial" pitchFamily="34" charset="-120"/>
               </a:rPr>
-              <a:t>Tumor-Derived Alpha-1 Antitrypsin Promotes Liver Metastasis of Colorectal Cancer…</a:t>
+              <a:t>Spatial blueprint of colorectal cancer identifies Hypoxic CAF program that orche…</a:t>
             </a:r>
             <a:endParaRPr lang="en-US" sz="1400" dirty="0"/>
           </a:p>
@@ -4792,7 +4834,7 @@
                 <a:ea typeface="Arial" pitchFamily="34" charset="-122"/>
                 <a:cs typeface="Arial" pitchFamily="34" charset="-120"/>
               </a:rPr>
-              <a:t>Radioiodination of Two Carborane-Based Dual Cyclooxygenase-2/5-Lipoxygenase Inhi…</a:t>
+              <a:t>Curcumin-loaded extracellular vesicles derived from lactic acid bacteria for all…</a:t>
             </a:r>
             <a:endParaRPr lang="en-US" sz="1400" dirty="0"/>
           </a:p>
@@ -4829,7 +4871,7 @@
                 <a:ea typeface="Arial" pitchFamily="34" charset="-122"/>
                 <a:cs typeface="Arial" pitchFamily="34" charset="-120"/>
               </a:rPr>
-              <a:t>Repurposing PARP inhibitors in molecularly defined subgroups of peritoneal metas…</a:t>
+              <a:t>Multi-analytical and biological insights into Malcolmia grandiflora Kuntze.</a:t>
             </a:r>
             <a:endParaRPr lang="en-US" sz="1400" dirty="0"/>
           </a:p>
@@ -4866,7 +4908,7 @@
                 <a:ea typeface="Arial" pitchFamily="34" charset="-122"/>
                 <a:cs typeface="Arial" pitchFamily="34" charset="-120"/>
               </a:rPr>
-              <a:t>The Mechanism of Acetyl-L-Carnitine on Colorectal Cancer and Its Metabolomic Stu…</a:t>
+              <a:t>Gastroprotective [6]-Gingerol Aspirinate as a Novel Aspirin-Derived Chemoprevent…</a:t>
             </a:r>
             <a:endParaRPr lang="en-US" sz="1400" dirty="0"/>
           </a:p>
@@ -5100,7 +5142,7 @@
                 <a:ea typeface="Arial" pitchFamily="34" charset="-122"/>
                 <a:cs typeface="Arial" pitchFamily="34" charset="-120"/>
               </a:rPr>
-              <a:t>P. excrementihominis worsens colitis severity.</a:t>
+              <a:t>Parasutterella excrementihominis role in colitis</a:t>
             </a:r>
             <a:endParaRPr lang="en-US" sz="1800" dirty="0"/>
           </a:p>
@@ -5121,7 +5163,7 @@
                 <a:ea typeface="Arial" pitchFamily="34" charset="-122"/>
                 <a:cs typeface="Arial" pitchFamily="34" charset="-120"/>
               </a:rPr>
-              <a:t>NETosis activation linked to cancer progression.</a:t>
+              <a:t>NETosis activation contributes to inflammation</a:t>
             </a:r>
             <a:endParaRPr lang="en-US" sz="1800" dirty="0"/>
           </a:p>
@@ -5142,7 +5184,7 @@
                 <a:ea typeface="Arial" pitchFamily="34" charset="-122"/>
                 <a:cs typeface="Arial" pitchFamily="34" charset="-120"/>
               </a:rPr>
-              <a:t>Study suggests new therapeutic strategies.</a:t>
+              <a:t>Link between colitis and colorectal cancer</a:t>
             </a:r>
             <a:endParaRPr lang="en-US" sz="1800" dirty="0"/>
           </a:p>
@@ -5478,7 +5520,7 @@
                 <a:ea typeface="Arial" pitchFamily="34" charset="-122"/>
                 <a:cs typeface="Arial" pitchFamily="34" charset="-120"/>
               </a:rPr>
-              <a:t>Systematic review and meta-analysis conducted</a:t>
+              <a:t>Effectiveness in advanced colorectal cancer patients</a:t>
             </a:r>
             <a:endParaRPr lang="en-US" sz="1800" dirty="0"/>
           </a:p>
@@ -5499,49 +5541,7 @@
                 <a:ea typeface="Arial" pitchFamily="34" charset="-122"/>
                 <a:cs typeface="Arial" pitchFamily="34" charset="-120"/>
               </a:rPr>
-              <a:t>Focus on advanced colorectal cancer patients</a:t>
-            </a:r>
-            <a:endParaRPr lang="en-US" sz="1800" dirty="0"/>
-          </a:p>
-          <a:p>
-            <a:pPr marL="342900" indent="-342900">
-              <a:spcAft>
-                <a:spcPts val="800"/>
-              </a:spcAft>
-              <a:buSzPct val="100000"/>
-              <a:buChar char="•"/>
-            </a:pPr>
-            <a:r>
-              <a:rPr lang="en-US" sz="1800" dirty="0">
-                <a:solidFill>
-                  <a:srgbClr val="333333"/>
-                </a:solidFill>
-                <a:latin typeface="Arial" pitchFamily="34" charset="0"/>
-                <a:ea typeface="Arial" pitchFamily="34" charset="-122"/>
-                <a:cs typeface="Arial" pitchFamily="34" charset="-120"/>
-              </a:rPr>
-              <a:t>Impact on peritoneal metastases assessed</a:t>
-            </a:r>
-            <a:endParaRPr lang="en-US" sz="1800" dirty="0"/>
-          </a:p>
-          <a:p>
-            <a:pPr marL="342900" indent="-342900">
-              <a:spcAft>
-                <a:spcPts val="800"/>
-              </a:spcAft>
-              <a:buSzPct val="100000"/>
-              <a:buChar char="•"/>
-            </a:pPr>
-            <a:r>
-              <a:rPr lang="en-US" sz="1800" dirty="0">
-                <a:solidFill>
-                  <a:srgbClr val="333333"/>
-                </a:solidFill>
-                <a:latin typeface="Arial" pitchFamily="34" charset="0"/>
-                <a:ea typeface="Arial" pitchFamily="34" charset="-122"/>
-                <a:cs typeface="Arial" pitchFamily="34" charset="-120"/>
-              </a:rPr>
-              <a:t>Clinical outcomes and survival rates analyzed</a:t>
+              <a:t>Systematic review and meta-analysis conducted</a:t>
             </a:r>
             <a:endParaRPr lang="en-US" sz="1800" dirty="0"/>
           </a:p>
@@ -5877,7 +5877,7 @@
                 <a:ea typeface="Arial" pitchFamily="34" charset="-122"/>
                 <a:cs typeface="Arial" pitchFamily="34" charset="-120"/>
               </a:rPr>
-              <a:t>SII as a prognostic biomarker in CRC</a:t>
+              <a:t>Prognostic biomarker for colorectal cancer</a:t>
             </a:r>
             <a:endParaRPr lang="en-US" sz="1800" dirty="0"/>
           </a:p>
@@ -5898,7 +5898,49 @@
                 <a:ea typeface="Arial" pitchFamily="34" charset="-122"/>
                 <a:cs typeface="Arial" pitchFamily="34" charset="-120"/>
               </a:rPr>
-              <a:t>Meta-analysis of existing studies conducted</a:t>
+              <a:t>Meta-analysis of existing studies</a:t>
+            </a:r>
+            <a:endParaRPr lang="en-US" sz="1800" dirty="0"/>
+          </a:p>
+          <a:p>
+            <a:pPr marL="342900" indent="-342900">
+              <a:spcAft>
+                <a:spcPts val="800"/>
+              </a:spcAft>
+              <a:buSzPct val="100000"/>
+              <a:buChar char="•"/>
+            </a:pPr>
+            <a:r>
+              <a:rPr lang="en-US" sz="1800" dirty="0">
+                <a:solidFill>
+                  <a:srgbClr val="333333"/>
+                </a:solidFill>
+                <a:latin typeface="Arial" pitchFamily="34" charset="0"/>
+                <a:ea typeface="Arial" pitchFamily="34" charset="-122"/>
+                <a:cs typeface="Arial" pitchFamily="34" charset="-120"/>
+              </a:rPr>
+              <a:t>SII associated with patient outcomes</a:t>
+            </a:r>
+            <a:endParaRPr lang="en-US" sz="1800" dirty="0"/>
+          </a:p>
+          <a:p>
+            <a:pPr marL="342900" indent="-342900">
+              <a:spcAft>
+                <a:spcPts val="800"/>
+              </a:spcAft>
+              <a:buSzPct val="100000"/>
+              <a:buChar char="•"/>
+            </a:pPr>
+            <a:r>
+              <a:rPr lang="en-US" sz="1800" dirty="0">
+                <a:solidFill>
+                  <a:srgbClr val="333333"/>
+                </a:solidFill>
+                <a:latin typeface="Arial" pitchFamily="34" charset="0"/>
+                <a:ea typeface="Arial" pitchFamily="34" charset="-122"/>
+                <a:cs typeface="Arial" pitchFamily="34" charset="-120"/>
+              </a:rPr>
+              <a:t>Potential for clinical application</a:t>
             </a:r>
             <a:endParaRPr lang="en-US" sz="1800" dirty="0"/>
           </a:p>
@@ -6234,7 +6276,7 @@
                 <a:ea typeface="Arial" pitchFamily="34" charset="-122"/>
                 <a:cs typeface="Arial" pitchFamily="34" charset="-120"/>
               </a:rPr>
-              <a:t>Need for better management strategies</a:t>
+              <a:t>Need for better patient education strategies</a:t>
             </a:r>
             <a:endParaRPr lang="en-US" sz="1800" dirty="0"/>
           </a:p>
@@ -6255,7 +6297,7 @@
                 <a:ea typeface="Arial" pitchFamily="34" charset="-122"/>
                 <a:cs typeface="Arial" pitchFamily="34" charset="-120"/>
               </a:rPr>
-              <a:t>Research gaps in patient knowledge</a:t>
+              <a:t>Current management practices are insufficient</a:t>
             </a:r>
             <a:endParaRPr lang="en-US" sz="1800" dirty="0"/>
           </a:p>
@@ -6491,7 +6533,7 @@
                   </a:extLst>
                 </a:hlinkClick>
               </a:rPr>
-              <a:t>Lactate metabolism-driven lactylation: paradoxical modulation of intestinal inflammation and malignancy.</a:t>
+              <a:t>Network pharmacology integrated with multi-omics demonstrates that Wumei Wan modulates the progression of colorectal cancer by regulating the focal adhesion-YAP signaling axis.</a:t>
             </a:r>
             <a:endParaRPr lang="en-US" sz="2400" dirty="0"/>
           </a:p>
@@ -6527,7 +6569,7 @@
                   <a:srgbClr val="888888"/>
                 </a:solidFill>
               </a:rPr>
-              <a:t>Journal of translational medicine  ·  IF 6.1  ·  Review</a:t>
+              <a:t>Journal of ethnopharmacology  ·  Basic Research</a:t>
             </a:r>
             <a:endParaRPr lang="en-US" sz="1000" dirty="0"/>
           </a:p>
@@ -6570,7 +6612,7 @@
                 <a:ea typeface="Arial" pitchFamily="34" charset="-122"/>
                 <a:cs typeface="Arial" pitchFamily="34" charset="-120"/>
               </a:rPr>
-              <a:t>Lactate influences immune regulation and signaling.</a:t>
+              <a:t>Wumei Wan shows anti-tumor effects.</a:t>
             </a:r>
             <a:endParaRPr lang="en-US" sz="1800" dirty="0"/>
           </a:p>
@@ -6591,7 +6633,7 @@
                 <a:ea typeface="Arial" pitchFamily="34" charset="-122"/>
                 <a:cs typeface="Arial" pitchFamily="34" charset="-120"/>
               </a:rPr>
-              <a:t>Lactylation modifies epigenetic regulation in cells.</a:t>
+              <a:t>Network pharmacology identifies key targets.</a:t>
             </a:r>
             <a:endParaRPr lang="en-US" sz="1800" dirty="0"/>
           </a:p>
@@ -6612,7 +6654,7 @@
                 <a:ea typeface="Arial" pitchFamily="34" charset="-122"/>
                 <a:cs typeface="Arial" pitchFamily="34" charset="-120"/>
               </a:rPr>
-              <a:t>Context-dependent effects on inflammation and cancer.</a:t>
+              <a:t>FAK/Src/YAP signaling axis is crucial.</a:t>
             </a:r>
             <a:endParaRPr lang="en-US" sz="1800" dirty="0"/>
           </a:p>
@@ -6633,7 +6675,7 @@
                 <a:ea typeface="Arial" pitchFamily="34" charset="-122"/>
                 <a:cs typeface="Arial" pitchFamily="34" charset="-120"/>
               </a:rPr>
-              <a:t>Lactylation promotes macrophage conversion and fibrosis.</a:t>
+              <a:t>Multi-omics reveals inflammation modulation.</a:t>
             </a:r>
             <a:endParaRPr lang="en-US" sz="1800" dirty="0"/>
           </a:p>
@@ -6654,7 +6696,7 @@
                 <a:ea typeface="Arial" pitchFamily="34" charset="-122"/>
                 <a:cs typeface="Arial" pitchFamily="34" charset="-120"/>
               </a:rPr>
-              <a:t>Targeting lactate metabolism offers therapeutic potential.</a:t>
+              <a:t>Molecular docking suggests stable interactions.</a:t>
             </a:r>
             <a:endParaRPr lang="en-US" sz="1800" dirty="0"/>
           </a:p>
@@ -6690,7 +6732,7 @@
                   <a:srgbClr val="888888"/>
                 </a:solidFill>
               </a:rPr>
-              <a:t>Liu Junting, Liu Yilong, Zhang Hao et al.. Journal of translational medicine. 2026-04-17 DOI: 10.1186/s12967-026-08041-0</a:t>
+              <a:t>Yang Shusen, Wang Min, Liu Siyue et al.. Journal of ethnopharmacology. 2026-02-11 DOI: 10.1016/j.jep.2026.121264</a:t>
             </a:r>
             <a:endParaRPr lang="en-US" sz="800" dirty="0"/>
           </a:p>
@@ -6890,7 +6932,7 @@
                   </a:extLst>
                 </a:hlinkClick>
               </a:rPr>
-              <a:t>Thlaspi arvense attenuates colitis-associated colorectal tumorigenesis through suppression of neutrophil recruitment via the NOD/NF-&amp;#x3ba;B pathway.</a:t>
+              <a:t>Low inflammation correlates with protumor Tim4+TREM1+ resident macrophage expansion and limited monocyte-derived macrophage differentiation during peritoneal colorectal cancer.</a:t>
             </a:r>
             <a:endParaRPr lang="en-US" sz="2400" dirty="0"/>
           </a:p>
@@ -6926,7 +6968,7 @@
                   <a:srgbClr val="888888"/>
                 </a:solidFill>
               </a:rPr>
-              <a:t>Chinese medicine  ·  Basic Research</a:t>
+              <a:t>Cancer immunology research  ·  Basic Research</a:t>
             </a:r>
             <a:endParaRPr lang="en-US" sz="1000" dirty="0"/>
           </a:p>
@@ -6969,7 +7011,7 @@
                 <a:ea typeface="Arial" pitchFamily="34" charset="-122"/>
                 <a:cs typeface="Arial" pitchFamily="34" charset="-120"/>
               </a:rPr>
-              <a:t>Thlaspi arvense reduces colitis-associated cancer.</a:t>
+              <a:t>Low inflammation limits monocyte recruitment.</a:t>
             </a:r>
             <a:endParaRPr lang="en-US" sz="1800" dirty="0"/>
           </a:p>
@@ -6990,7 +7032,7 @@
                 <a:ea typeface="Arial" pitchFamily="34" charset="-122"/>
                 <a:cs typeface="Arial" pitchFamily="34" charset="-120"/>
               </a:rPr>
-              <a:t>Neutrophil recruitment drives tumorigenesis in CAC.</a:t>
+              <a:t>Tim4+ resident macrophages expand during CRC.</a:t>
             </a:r>
             <a:endParaRPr lang="en-US" sz="1800" dirty="0"/>
           </a:p>
@@ -7011,49 +7053,7 @@
                 <a:ea typeface="Arial" pitchFamily="34" charset="-122"/>
                 <a:cs typeface="Arial" pitchFamily="34" charset="-120"/>
               </a:rPr>
-              <a:t>TA inhibits NOD/NF-κB pathway activation.</a:t>
-            </a:r>
-            <a:endParaRPr lang="en-US" sz="1800" dirty="0"/>
-          </a:p>
-          <a:p>
-            <a:pPr marL="342900" indent="-342900">
-              <a:spcAft>
-                <a:spcPts val="800"/>
-              </a:spcAft>
-              <a:buSzPct val="100000"/>
-              <a:buChar char="•"/>
-            </a:pPr>
-            <a:r>
-              <a:rPr lang="en-US" sz="1800" dirty="0">
-                <a:solidFill>
-                  <a:srgbClr val="333333"/>
-                </a:solidFill>
-                <a:latin typeface="Arial" pitchFamily="34" charset="0"/>
-                <a:ea typeface="Arial" pitchFamily="34" charset="-122"/>
-                <a:cs typeface="Arial" pitchFamily="34" charset="-120"/>
-              </a:rPr>
-              <a:t>TA restores mucosal integrity and tight junctions.</a:t>
-            </a:r>
-            <a:endParaRPr lang="en-US" sz="1800" dirty="0"/>
-          </a:p>
-          <a:p>
-            <a:pPr marL="342900" indent="-342900">
-              <a:spcAft>
-                <a:spcPts val="800"/>
-              </a:spcAft>
-              <a:buSzPct val="100000"/>
-              <a:buChar char="•"/>
-            </a:pPr>
-            <a:r>
-              <a:rPr lang="en-US" sz="1800" dirty="0">
-                <a:solidFill>
-                  <a:srgbClr val="333333"/>
-                </a:solidFill>
-                <a:latin typeface="Arial" pitchFamily="34" charset="0"/>
-                <a:ea typeface="Arial" pitchFamily="34" charset="-122"/>
-                <a:cs typeface="Arial" pitchFamily="34" charset="-120"/>
-              </a:rPr>
-              <a:t>CXCL1/2 levels significantly decreased with TA.</a:t>
+              <a:t>Protumor signatures in Tim4+ macrophages identified.</a:t>
             </a:r>
             <a:endParaRPr lang="en-US" sz="1800" dirty="0"/>
           </a:p>
@@ -7089,7 +7089,7 @@
                   <a:srgbClr val="888888"/>
                 </a:solidFill>
               </a:rPr>
-              <a:t>Wang Ziwei, Wang Wenkai, Wang Chaowei et al.. Chinese medicine. 2026-04-18 DOI: 10.1186/s13020-026-01381-5</a:t>
+              <a:t>Ferriz Margarita, Alvarez-Ladr&amp;#xf3;n Natalia, Guti&amp;#xe9;rrez-Gonz&amp;#xe1;lez Alejandra et al.. Cancer immunology research. 2026-04-23 DOI: 10.1158/2326-6066.CIR-25-0388</a:t>
             </a:r>
             <a:endParaRPr lang="en-US" sz="800" dirty="0"/>
           </a:p>
@@ -7289,7 +7289,7 @@
                   </a:extLst>
                 </a:hlinkClick>
               </a:rPr>
-              <a:t>Tumor-Derived Alpha-1 Antitrypsin Promotes Liver Metastasis of Colorectal Cancer Through the Neutrophil Extracellular Traps-CCDC25 Pathway.</a:t>
+              <a:t>Spatial blueprint of colorectal cancer identifies Hypoxic CAF program that orchestrates Go-or-Grow decisions and predicts outcomes.</a:t>
             </a:r>
             <a:endParaRPr lang="en-US" sz="2400" dirty="0"/>
           </a:p>
@@ -7325,7 +7325,7 @@
                   <a:srgbClr val="888888"/>
                 </a:solidFill>
               </a:rPr>
-              <a:t>Advanced science (Weinheim, Baden-Wurttemberg, Germany)  ·  Basic Research</a:t>
+              <a:t>Investigational new drugs  ·  Basic Research</a:t>
             </a:r>
             <a:endParaRPr lang="en-US" sz="1000" dirty="0"/>
           </a:p>
@@ -7368,7 +7368,7 @@
                 <a:ea typeface="Arial" pitchFamily="34" charset="-122"/>
                 <a:cs typeface="Arial" pitchFamily="34" charset="-120"/>
               </a:rPr>
-              <a:t>A1AT promotes liver metastasis in CRC.</a:t>
+              <a:t>Integrated single-cell and spatial transcriptomics</a:t>
             </a:r>
             <a:endParaRPr lang="en-US" sz="1800" dirty="0"/>
           </a:p>
@@ -7389,7 +7389,7 @@
                 <a:ea typeface="Arial" pitchFamily="34" charset="-122"/>
                 <a:cs typeface="Arial" pitchFamily="34" charset="-120"/>
               </a:rPr>
-              <a:t>Neutrophil extracellular traps (NETs) involved.</a:t>
+              <a:t>Identified nine microenvironmental niches in CRC</a:t>
             </a:r>
             <a:endParaRPr lang="en-US" sz="1800" dirty="0"/>
           </a:p>
@@ -7410,7 +7410,49 @@
                 <a:ea typeface="Arial" pitchFamily="34" charset="-122"/>
                 <a:cs typeface="Arial" pitchFamily="34" charset="-120"/>
               </a:rPr>
-              <a:t>CCDC25 upregulation enhances tumor invasion.</a:t>
+              <a:t>Hypoxic CAFs linked to tumor cell behavior</a:t>
+            </a:r>
+            <a:endParaRPr lang="en-US" sz="1800" dirty="0"/>
+          </a:p>
+          <a:p>
+            <a:pPr marL="342900" indent="-342900">
+              <a:spcAft>
+                <a:spcPts val="800"/>
+              </a:spcAft>
+              <a:buSzPct val="100000"/>
+              <a:buChar char="•"/>
+            </a:pPr>
+            <a:r>
+              <a:rPr lang="en-US" sz="1800" dirty="0">
+                <a:solidFill>
+                  <a:srgbClr val="333333"/>
+                </a:solidFill>
+                <a:latin typeface="Arial" pitchFamily="34" charset="0"/>
+                <a:ea typeface="Arial" pitchFamily="34" charset="-122"/>
+                <a:cs typeface="Arial" pitchFamily="34" charset="-120"/>
+              </a:rPr>
+              <a:t>HMGA2 as a key transcriptional regulator</a:t>
+            </a:r>
+            <a:endParaRPr lang="en-US" sz="1800" dirty="0"/>
+          </a:p>
+          <a:p>
+            <a:pPr marL="342900" indent="-342900">
+              <a:spcAft>
+                <a:spcPts val="800"/>
+              </a:spcAft>
+              <a:buSzPct val="100000"/>
+              <a:buChar char="•"/>
+            </a:pPr>
+            <a:r>
+              <a:rPr lang="en-US" sz="1800" dirty="0">
+                <a:solidFill>
+                  <a:srgbClr val="333333"/>
+                </a:solidFill>
+                <a:latin typeface="Arial" pitchFamily="34" charset="0"/>
+                <a:ea typeface="Arial" pitchFamily="34" charset="-122"/>
+                <a:cs typeface="Arial" pitchFamily="34" charset="-120"/>
+              </a:rPr>
+              <a:t>Potential therapeutic targets for CRC intervention</a:t>
             </a:r>
             <a:endParaRPr lang="en-US" sz="1800" dirty="0"/>
           </a:p>
@@ -7446,7 +7488,7 @@
                   <a:srgbClr val="888888"/>
                 </a:solidFill>
               </a:rPr>
-              <a:t>Fei Qian, Li Chunning, Zhan Lei et al.. Advanced science (Weinheim, Baden-Wurttemberg, Germany). 2026-04-16 DOI: 10.1002/advs.202520000</a:t>
+              <a:t>Chen Mingkai, Yang Juan, Wang Jin et al.. Investigational new drugs. 2026-04-22 DOI: 10.1007/s10637-026-01611-5</a:t>
             </a:r>
             <a:endParaRPr lang="en-US" sz="800" dirty="0"/>
           </a:p>

</xml_diff>

<commit_message>
chore: update weekly digest 2026-05-04
</commit_message>
<xml_diff>
--- a/docs/digest-en.pptx
+++ b/docs/digest-en.pptx
@@ -2249,7 +2249,7 @@
                   <a:srgbClr val="888888"/>
                 </a:solidFill>
               </a:rPr>
-              <a:t>2026-04-20 — 2026-04-27</a:t>
+              <a:t>2026-04-27 — 2026-05-04</a:t>
             </a:r>
             <a:endParaRPr lang="en-US" sz="1400" dirty="0"/>
           </a:p>
@@ -2440,7 +2440,7 @@
                   </a:extLst>
                 </a:hlinkClick>
               </a:rPr>
-              <a:t>Curcumin-loaded extracellular vesicles derived from lactic acid bacteria for alleviation of inflammatory bowel disease.</a:t>
+              <a:t>Prognostic value of systemic immune-inflammation index for colorectal cancer: a systematic review and meta-analysis</a:t>
             </a:r>
             <a:endParaRPr lang="en-US" sz="2400" dirty="0"/>
           </a:p>
@@ -2476,7 +2476,7 @@
                   <a:srgbClr val="888888"/>
                 </a:solidFill>
               </a:rPr>
-              <a:t>International journal of pharmaceutics  ·  Basic Research</a:t>
+              <a:t>Frontiers in Oncology  ·  Meta-Analysis</a:t>
             </a:r>
             <a:endParaRPr lang="en-US" sz="1000" dirty="0"/>
           </a:p>
@@ -2519,7 +2519,7 @@
                 <a:ea typeface="Arial" pitchFamily="34" charset="-122"/>
                 <a:cs typeface="Arial" pitchFamily="34" charset="-120"/>
               </a:rPr>
-              <a:t>Curcumin-loaded EVs from LAB show promise.</a:t>
+              <a:t>Systemic immune-inflammation index (SII) evaluated</a:t>
             </a:r>
             <a:endParaRPr lang="en-US" sz="1800" dirty="0"/>
           </a:p>
@@ -2540,7 +2540,7 @@
                 <a:ea typeface="Arial" pitchFamily="34" charset="-122"/>
                 <a:cs typeface="Arial" pitchFamily="34" charset="-120"/>
               </a:rPr>
-              <a:t>L-EVs-C exhibit superior characteristics.</a:t>
+              <a:t>SII as a prognostic biomarker in CRC</a:t>
             </a:r>
             <a:endParaRPr lang="en-US" sz="1800" dirty="0"/>
           </a:p>
@@ -2561,7 +2561,49 @@
                 <a:ea typeface="Arial" pitchFamily="34" charset="-122"/>
                 <a:cs typeface="Arial" pitchFamily="34" charset="-120"/>
               </a:rPr>
-              <a:t>Treatment alleviates IBD symptoms in mice.</a:t>
+              <a:t>Meta-analysis of existing studies conducted</a:t>
+            </a:r>
+            <a:endParaRPr lang="en-US" sz="1800" dirty="0"/>
+          </a:p>
+          <a:p>
+            <a:pPr marL="342900" indent="-342900">
+              <a:spcAft>
+                <a:spcPts val="800"/>
+              </a:spcAft>
+              <a:buSzPct val="100000"/>
+              <a:buChar char="•"/>
+            </a:pPr>
+            <a:r>
+              <a:rPr lang="en-US" sz="1800" dirty="0">
+                <a:solidFill>
+                  <a:srgbClr val="333333"/>
+                </a:solidFill>
+                <a:latin typeface="Arial" pitchFamily="34" charset="0"/>
+                <a:ea typeface="Arial" pitchFamily="34" charset="-122"/>
+                <a:cs typeface="Arial" pitchFamily="34" charset="-120"/>
+              </a:rPr>
+              <a:t>Correlation between SII and patient outcomes</a:t>
+            </a:r>
+            <a:endParaRPr lang="en-US" sz="1800" dirty="0"/>
+          </a:p>
+          <a:p>
+            <a:pPr marL="342900" indent="-342900">
+              <a:spcAft>
+                <a:spcPts val="800"/>
+              </a:spcAft>
+              <a:buSzPct val="100000"/>
+              <a:buChar char="•"/>
+            </a:pPr>
+            <a:r>
+              <a:rPr lang="en-US" sz="1800" dirty="0">
+                <a:solidFill>
+                  <a:srgbClr val="333333"/>
+                </a:solidFill>
+                <a:latin typeface="Arial" pitchFamily="34" charset="0"/>
+                <a:ea typeface="Arial" pitchFamily="34" charset="-122"/>
+                <a:cs typeface="Arial" pitchFamily="34" charset="-120"/>
+              </a:rPr>
+              <a:t>Potential for SII in clinical practice</a:t>
             </a:r>
             <a:endParaRPr lang="en-US" sz="1800" dirty="0"/>
           </a:p>
@@ -2597,7 +2639,7 @@
                   <a:srgbClr val="888888"/>
                 </a:solidFill>
               </a:rPr>
-              <a:t>Qiu Fang, Wang Baixuan, Zhang Yongjing et al.. International journal of pharmaceutics. 2026-04-23 DOI: 10.1016/j.ijpharm.2026.126859</a:t>
+              <a:t>P Wang, H Jiang. Frontiers in Oncology. 2026</a:t>
             </a:r>
             <a:endParaRPr lang="en-US" sz="800" dirty="0"/>
           </a:p>
@@ -2797,7 +2839,7 @@
                   </a:extLst>
                 </a:hlinkClick>
               </a:rPr>
-              <a:t>Multi-analytical and biological insights into Malcolmia grandiflora Kuntze.</a:t>
+              <a:t>Awareness of inflammatory bowel disease-associated colorectal cancer risk and its management in patients with inflammatory bowel disease: a systematic review</a:t>
             </a:r>
             <a:endParaRPr lang="en-US" sz="2400" dirty="0"/>
           </a:p>
@@ -2833,7 +2875,7 @@
                   <a:srgbClr val="888888"/>
                 </a:solidFill>
               </a:rPr>
-              <a:t>Scientific reports  ·  Basic Research</a:t>
+              <a:t>Crohns &amp; Colitis 360  ·  Systematic Review</a:t>
             </a:r>
             <a:endParaRPr lang="en-US" sz="1000" dirty="0"/>
           </a:p>
@@ -2876,7 +2918,7 @@
                 <a:ea typeface="Arial" pitchFamily="34" charset="-122"/>
                 <a:cs typeface="Arial" pitchFamily="34" charset="-120"/>
               </a:rPr>
-              <a:t>Malcolmia grandiflora shows bioactive potential.</a:t>
+              <a:t>Limited awareness of colorectal cancer risk</a:t>
             </a:r>
             <a:endParaRPr lang="en-US" sz="1800" dirty="0"/>
           </a:p>
@@ -2897,7 +2939,7 @@
                 <a:ea typeface="Arial" pitchFamily="34" charset="-122"/>
                 <a:cs typeface="Arial" pitchFamily="34" charset="-120"/>
               </a:rPr>
-              <a:t>n-hexane extract exhibits cytotoxicity against cancer.</a:t>
+              <a:t>Need for better patient education strategies</a:t>
             </a:r>
             <a:endParaRPr lang="en-US" sz="1800" dirty="0"/>
           </a:p>
@@ -2918,49 +2960,7 @@
                 <a:ea typeface="Arial" pitchFamily="34" charset="-122"/>
                 <a:cs typeface="Arial" pitchFamily="34" charset="-120"/>
               </a:rPr>
-              <a:t>Defatted extract inhibits COX-2 selectively.</a:t>
-            </a:r>
-            <a:endParaRPr lang="en-US" sz="1800" dirty="0"/>
-          </a:p>
-          <a:p>
-            <a:pPr marL="342900" indent="-342900">
-              <a:spcAft>
-                <a:spcPts val="800"/>
-              </a:spcAft>
-              <a:buSzPct val="100000"/>
-              <a:buChar char="•"/>
-            </a:pPr>
-            <a:r>
-              <a:rPr lang="en-US" sz="1800" dirty="0">
-                <a:solidFill>
-                  <a:srgbClr val="333333"/>
-                </a:solidFill>
-                <a:latin typeface="Arial" pitchFamily="34" charset="0"/>
-                <a:ea typeface="Arial" pitchFamily="34" charset="-122"/>
-                <a:cs typeface="Arial" pitchFamily="34" charset="-120"/>
-              </a:rPr>
-              <a:t>Moderate antioxidant activity in defatted extract.</a:t>
-            </a:r>
-            <a:endParaRPr lang="en-US" sz="1800" dirty="0"/>
-          </a:p>
-          <a:p>
-            <a:pPr marL="342900" indent="-342900">
-              <a:spcAft>
-                <a:spcPts val="800"/>
-              </a:spcAft>
-              <a:buSzPct val="100000"/>
-              <a:buChar char="•"/>
-            </a:pPr>
-            <a:r>
-              <a:rPr lang="en-US" sz="1800" dirty="0">
-                <a:solidFill>
-                  <a:srgbClr val="333333"/>
-                </a:solidFill>
-                <a:latin typeface="Arial" pitchFamily="34" charset="0"/>
-                <a:ea typeface="Arial" pitchFamily="34" charset="-122"/>
-                <a:cs typeface="Arial" pitchFamily="34" charset="-120"/>
-              </a:rPr>
-              <a:t>Flavonoids identified as potential CDK inhibitors.</a:t>
+              <a:t>Research gaps in inflammatory bowel disease management</a:t>
             </a:r>
             <a:endParaRPr lang="en-US" sz="1800" dirty="0"/>
           </a:p>
@@ -2996,7 +2996,7 @@
                   <a:srgbClr val="888888"/>
                 </a:solidFill>
               </a:rPr>
-              <a:t>Elwekeel Ahlam Hashem, Mohamed Enas I A, Amin Elham et al.. Scientific reports. 2026-04-21 DOI: 10.1038/s41598-026-44715-x</a:t>
+              <a:t>F Khan, C Norton, W Czuber-Dochan. Crohns &amp; Colitis 360. 2026</a:t>
             </a:r>
             <a:endParaRPr lang="en-US" sz="800" dirty="0"/>
           </a:p>
@@ -3196,7 +3196,7 @@
                   </a:extLst>
                 </a:hlinkClick>
               </a:rPr>
-              <a:t>Gastroprotective [6]-Gingerol Aspirinate as a Novel Aspirin-Derived Chemopreventive Agent Attenuating Colitis.</a:t>
+              <a:t>Quantifying preferences for watch-and-wait compared with surgery after a clinical complete response in locally advanced rectal cancer: A discrete choice experiment (PrefCoRe).</a:t>
             </a:r>
             <a:endParaRPr lang="en-US" sz="2400" dirty="0"/>
           </a:p>
@@ -3232,7 +3232,7 @@
                   <a:srgbClr val="888888"/>
                 </a:solidFill>
               </a:rPr>
-              <a:t>Journal of agricultural and food chemistry  ·  Basic Research</a:t>
+              <a:t>European journal of cancer (Oxford, England : 1990)  ·  IF 8.4</a:t>
             </a:r>
             <a:endParaRPr lang="en-US" sz="1000" dirty="0"/>
           </a:p>
@@ -3275,7 +3275,7 @@
                 <a:ea typeface="Arial" pitchFamily="34" charset="-122"/>
                 <a:cs typeface="Arial" pitchFamily="34" charset="-120"/>
               </a:rPr>
-              <a:t>GAS improves colitis symptoms significantly.</a:t>
+              <a:t>Watch-and-wait is an alternative approach.</a:t>
             </a:r>
             <a:endParaRPr lang="en-US" sz="1800" dirty="0"/>
           </a:p>
@@ -3296,7 +3296,7 @@
                 <a:ea typeface="Arial" pitchFamily="34" charset="-122"/>
                 <a:cs typeface="Arial" pitchFamily="34" charset="-120"/>
               </a:rPr>
-              <a:t>Reduces pro-inflammatory markers effectively.</a:t>
+              <a:t>Participants had varied preferences for attributes.</a:t>
             </a:r>
             <a:endParaRPr lang="en-US" sz="1800" dirty="0"/>
           </a:p>
@@ -3317,7 +3317,7 @@
                 <a:ea typeface="Arial" pitchFamily="34" charset="-122"/>
                 <a:cs typeface="Arial" pitchFamily="34" charset="-120"/>
               </a:rPr>
-              <a:t>Reverses 73 DSS-altered metabolites.</a:t>
+              <a:t>Quality of life and survival were prioritized.</a:t>
             </a:r>
             <a:endParaRPr lang="en-US" sz="1800" dirty="0"/>
           </a:p>
@@ -3338,7 +3338,7 @@
                 <a:ea typeface="Arial" pitchFamily="34" charset="-122"/>
                 <a:cs typeface="Arial" pitchFamily="34" charset="-120"/>
               </a:rPr>
-              <a:t>Strong correlation with inflammatory cytokines.</a:t>
+              <a:t>Predicted W&amp;W uptake was 52.9% and 57.2%.</a:t>
             </a:r>
             <a:endParaRPr lang="en-US" sz="1800" dirty="0"/>
           </a:p>
@@ -3359,7 +3359,7 @@
                 <a:ea typeface="Arial" pitchFamily="34" charset="-122"/>
                 <a:cs typeface="Arial" pitchFamily="34" charset="-120"/>
               </a:rPr>
-              <a:t>Potential safer chemopreventive agent.</a:t>
+              <a:t>Decision-making is complex and heterogeneous.</a:t>
             </a:r>
             <a:endParaRPr lang="en-US" sz="1800" dirty="0"/>
           </a:p>
@@ -3395,7 +3395,7 @@
                   <a:srgbClr val="888888"/>
                 </a:solidFill>
               </a:rPr>
-              <a:t>Lee Pei-Sheng, Zhang Shuwei, Zhu Yingdong et al.. Journal of agricultural and food chemistry. 2026-04-25 DOI: 10.1021/acs.jafc.5c17778</a:t>
+              <a:t>Dalal Garima, Wright Stuart J, Malcomson Lee et al.. European journal of cancer (Oxford, England : 1990). 2026-04-10 DOI: 10.1016/j.ejca.2026.116589</a:t>
             </a:r>
             <a:endParaRPr lang="en-US" sz="800" dirty="0"/>
           </a:p>
@@ -3612,7 +3612,7 @@
                   <a:srgbClr val="FFFFFF"/>
                 </a:solidFill>
               </a:rPr>
-              <a:t>1. **腸道微生物與癌症關聯性**  </a:t>
+              <a:t>1. **腸道微生物與炎症關聯性**  </a:t>
             </a:r>
             <a:endParaRPr lang="en-US" sz="1200" dirty="0"/>
           </a:p>
@@ -3629,7 +3629,7 @@
                   <a:srgbClr val="FFFFFF"/>
                 </a:solidFill>
               </a:rPr>
-              <a:t>   The study of *Parasutterella excrementihominis* highlights the significant role of gut microbiota in exacerbating colitis and colorectal cancer, suggesting that microbial dysbiosis can influence disease progression.  </a:t>
+              <a:t>   The study on *Parasutterella excrementihominis* highlights the significant role of gut microbiota in exacerbating colitis and colorectal cancer through pathogenic NETosis activation.  </a:t>
             </a:r>
             <a:endParaRPr lang="en-US" sz="1200" dirty="0"/>
           </a:p>
@@ -3646,7 +3646,7 @@
                   <a:srgbClr val="FFFFFF"/>
                 </a:solidFill>
               </a:rPr>
-              <a:t>   *Parasutterella excrementihominis*的研究突顯了腸道微生物在加重結腸炎和結直腸癌中的重要角色，暗示微生物失調可能影響疾病進展。</a:t>
+              <a:t>   *對於炎症性腸病和結直腸癌的研究顯示，腸道微生物群在促進病理性NETosis活化方面具有重要作用。*</a:t>
             </a:r>
             <a:endParaRPr lang="en-US" sz="1200" dirty="0"/>
           </a:p>
@@ -3672,7 +3672,7 @@
                   <a:srgbClr val="FFFFFF"/>
                 </a:solidFill>
               </a:rPr>
-              <a:t>2. **系統性免疫-炎症指數的預後價值**  </a:t>
+              <a:t>2. **自體細胞系的建立與腫瘤微環境**  </a:t>
             </a:r>
             <a:endParaRPr lang="en-US" sz="1200" dirty="0"/>
           </a:p>
@@ -3689,7 +3689,7 @@
                   <a:srgbClr val="FFFFFF"/>
                 </a:solidFill>
               </a:rPr>
-              <a:t>   The systemic immune-inflammation index (SII) has emerged as a promising prognostic biomarker for colorectal cancer, indicating that immune status can provide valuable insights into patient outcomes.  </a:t>
+              <a:t>   The establishment of autologous colorectal cancer and mesothelial stromal cell lines provides a novel model to study tumor-mesothelial interactions, revealing potential vulnerabilities in peritoneal metastasis.  </a:t>
             </a:r>
             <a:endParaRPr lang="en-US" sz="1200" dirty="0"/>
           </a:p>
@@ -3706,7 +3706,7 @@
                   <a:srgbClr val="FFFFFF"/>
                 </a:solidFill>
               </a:rPr>
-              <a:t>   系統性免疫-炎症指數（SII）已成為結直腸癌有前景的預後生物標記，表明免疫狀態能提供患者預後的重要見解。</a:t>
+              <a:t>   *自體結直腸癌及間皮基質細胞系的建立提供了一個新模型，以研究腫瘤與間皮細胞的相互作用，揭示了腹膜轉移中的潛在脆弱性。*</a:t>
             </a:r>
             <a:endParaRPr lang="en-US" sz="1200" dirty="0"/>
           </a:p>
@@ -3732,7 +3732,7 @@
                   <a:srgbClr val="FFFFFF"/>
                 </a:solidFill>
               </a:rPr>
-              <a:t>3. **傳統醫學在癌症治療中的潛力**  </a:t>
+              <a:t>3. **治療策略的多樣性**  </a:t>
             </a:r>
             <a:endParaRPr lang="en-US" sz="1200" dirty="0"/>
           </a:p>
@@ -3749,7 +3749,7 @@
                   <a:srgbClr val="FFFFFF"/>
                 </a:solidFill>
               </a:rPr>
-              <a:t>   The integration of traditional Chinese medicine, such as Wumei Wan, into colorectal cancer treatment shows potential in modulating tumor progression, emphasizing the need for further exploration of holistic approaches.  </a:t>
+              <a:t>   Various studies indicate that dietary interventions and herbal treatments, like Dabupi decoction, may mitigate chemotherapy-induced side effects and enhance therapeutic outcomes in colorectal cancer.  </a:t>
             </a:r>
             <a:endParaRPr lang="en-US" sz="1200" dirty="0"/>
           </a:p>
@@ -3766,7 +3766,7 @@
                   <a:srgbClr val="FFFFFF"/>
                 </a:solidFill>
               </a:rPr>
-              <a:t>   傳統中醫如五梅丸在結直腸癌治療中的整合顯示出調節腫瘤進展的潛力，強調需要進一步探索整體治療方法。</a:t>
+              <a:t>   *多項研究表明，飲食干預和草藥治療（如大補皮湯）可能減輕化療引起的副作用，並提高結直腸癌的治療效果。*</a:t>
             </a:r>
             <a:endParaRPr lang="en-US" sz="1200" dirty="0"/>
           </a:p>
@@ -3792,7 +3792,7 @@
                   <a:srgbClr val="FFFFFF"/>
                 </a:solidFill>
               </a:rPr>
-              <a:t>4. **腫瘤微環境的空間組織**  </a:t>
+              <a:t>4. **系統性免疫炎症指數的預測價值**  </a:t>
             </a:r>
             <a:endParaRPr lang="en-US" sz="1200" dirty="0"/>
           </a:p>
@@ -3809,7 +3809,7 @@
                   <a:srgbClr val="FFFFFF"/>
                 </a:solidFill>
               </a:rPr>
-              <a:t>   Understanding the spatial organization of the tumor microenvironment (TME) is crucial for deciphering colorectal cancer progression, as it affects cellular interactions and therapeutic responses.  </a:t>
+              <a:t>   The systemic immune-inflammation index (SII) has emerged as a promising prognostic biomarker for colorectal cancer, emphasizing the importance of immune status in cancer prognosis.  </a:t>
             </a:r>
             <a:endParaRPr lang="en-US" sz="1200" dirty="0"/>
           </a:p>
@@ -3826,7 +3826,7 @@
                   <a:srgbClr val="FFFFFF"/>
                 </a:solidFill>
               </a:rPr>
-              <a:t>   理解腫瘤微環境（TME）的空間組織對於解讀結直腸癌進展至關重要，因為它影響細胞間的相互作用和治療反應。</a:t>
+              <a:t>   *系統性免疫炎症指數（SII）已成為結直腸癌有前景的預測生物標記，強調了免疫狀態在癌症預後中的重要性。*</a:t>
             </a:r>
             <a:endParaRPr lang="en-US" sz="1200" dirty="0"/>
           </a:p>
@@ -3852,7 +3852,7 @@
                   <a:srgbClr val="FFFFFF"/>
                 </a:solidFill>
               </a:rPr>
-              <a:t>5. **炎症性腸病患者的癌症風險認識**  </a:t>
+              <a:t>5. **患者對炎症性腸病風險的認識不足**  </a:t>
             </a:r>
             <a:endParaRPr lang="en-US" sz="1200" dirty="0"/>
           </a:p>
@@ -3869,7 +3869,24 @@
                   <a:srgbClr val="FFFFFF"/>
                 </a:solidFill>
               </a:rPr>
-              <a:t>   There is a critical gap in awareness regarding the colorectal cancer risk among patients with inflammatory bowel disease, highlighting the need for improved education and management strategies.</a:t>
+              <a:t>   There is a significant gap in awareness among patients with inflammatory bowel disease regarding their risk of colorectal cancer and its management, indicating a need for improved patient education.  </a:t>
+            </a:r>
+            <a:endParaRPr lang="en-US" sz="1200" dirty="0"/>
+          </a:p>
+          <a:p>
+            <a:pPr indent="0" marL="0">
+              <a:lnSpc>
+                <a:spcPct val="150000"/>
+              </a:lnSpc>
+              <a:buNone/>
+            </a:pPr>
+            <a:r>
+              <a:rPr lang="en-US" sz="1200" dirty="0">
+                <a:solidFill>
+                  <a:srgbClr val="FFFFFF"/>
+                </a:solidFill>
+              </a:rPr>
+              <a:t>   *炎症性腸病患者對結直腸癌風險及其管理的認識存在顯著差距，表明需要加強患者教育。*</a:t>
             </a:r>
             <a:endParaRPr lang="en-US" sz="1200" dirty="0"/>
           </a:p>
@@ -4015,7 +4032,7 @@
                   <a:srgbClr val="FFFFFF"/>
                 </a:solidFill>
               </a:rPr>
-              <a:t>為炎症性腸病患者對結直腸癌風險的認識存在重大缺口，強調需要改善教育和管理策略。</a:t>
+              <a:t>### 未來研究方向 (Future Research Directions)</a:t>
             </a:r>
             <a:endParaRPr lang="en-US" sz="1200" dirty="0"/>
           </a:p>
@@ -4041,7 +4058,7 @@
                   <a:srgbClr val="FFFFFF"/>
                 </a:solidFill>
               </a:rPr>
-              <a:t>### 未來研究方向 (Future Research Directions)</a:t>
+              <a:t>1. **腸道微生物與癌症的機制研究**  </a:t>
             </a:r>
             <a:endParaRPr lang="en-US" sz="1200" dirty="0"/>
           </a:p>
@@ -4052,6 +4069,14 @@
               </a:lnSpc>
               <a:buNone/>
             </a:pPr>
+            <a:r>
+              <a:rPr lang="en-US" sz="1200" dirty="0">
+                <a:solidFill>
+                  <a:srgbClr val="FFFFFF"/>
+                </a:solidFill>
+              </a:rPr>
+              <a:t>   Future studies should focus on elucidating the mechanisms by which gut microbiota influences inflammation and colorectal carcinogenesis, potentially leading to novel therapeutic targets.  </a:t>
+            </a:r>
             <a:endParaRPr lang="en-US" sz="1200" dirty="0"/>
           </a:p>
           <a:p>
@@ -4067,7 +4092,7 @@
                   <a:srgbClr val="FFFFFF"/>
                 </a:solidFill>
               </a:rPr>
-              <a:t>1. **微生物組與癌症機制的深入研究**  </a:t>
+              <a:t>   *未來的研究應集中於闡明腸道微生物如何影響炎症和結直腸癌發生的機制，可能導致新的治療靶點。*</a:t>
             </a:r>
             <a:endParaRPr lang="en-US" sz="1200" dirty="0"/>
           </a:p>
@@ -4078,14 +4103,6 @@
               </a:lnSpc>
               <a:buNone/>
             </a:pPr>
-            <a:r>
-              <a:rPr lang="en-US" sz="1200" dirty="0">
-                <a:solidFill>
-                  <a:srgbClr val="FFFFFF"/>
-                </a:solidFill>
-              </a:rPr>
-              <a:t>   Future studies should focus on elucidating the mechanisms by which gut microbiota, like *Parasutterella excrementihominis*, contribute to colitis and colorectal cancer pathogenesis.  </a:t>
-            </a:r>
             <a:endParaRPr lang="en-US" sz="1200" dirty="0"/>
           </a:p>
           <a:p>
@@ -4101,7 +4118,7 @@
                   <a:srgbClr val="FFFFFF"/>
                 </a:solidFill>
               </a:rPr>
-              <a:t>   未來的研究應專注於闡明腸道微生物（如*Parasutterella excrementihominis*）如何促進結腸炎和結直腸癌發病機制。</a:t>
+              <a:t>2. **腫瘤微環境的深入探討**  </a:t>
             </a:r>
             <a:endParaRPr lang="en-US" sz="1200" dirty="0"/>
           </a:p>
@@ -4112,6 +4129,14 @@
               </a:lnSpc>
               <a:buNone/>
             </a:pPr>
+            <a:r>
+              <a:rPr lang="en-US" sz="1200" dirty="0">
+                <a:solidFill>
+                  <a:srgbClr val="FFFFFF"/>
+                </a:solidFill>
+              </a:rPr>
+              <a:t>   Further exploration of tumor-mesothelial interactions using established cell lines can provide insights into the microenvironment's role in peritoneal metastasis and therapeutic resistance.  </a:t>
+            </a:r>
             <a:endParaRPr lang="en-US" sz="1200" dirty="0"/>
           </a:p>
           <a:p>
@@ -4127,7 +4152,7 @@
                   <a:srgbClr val="FFFFFF"/>
                 </a:solidFill>
               </a:rPr>
-              <a:t>2. **SII在不同階段癌症中的應用**  </a:t>
+              <a:t>   *進一步探討使用已建立的細胞系的腫瘤與間皮細胞相互作用，可以提供微環境在腹膜轉移和治療抵抗中的作用的見解。*</a:t>
             </a:r>
             <a:endParaRPr lang="en-US" sz="1200" dirty="0"/>
           </a:p>
@@ -4138,14 +4163,6 @@
               </a:lnSpc>
               <a:buNone/>
             </a:pPr>
-            <a:r>
-              <a:rPr lang="en-US" sz="1200" dirty="0">
-                <a:solidFill>
-                  <a:srgbClr val="FFFFFF"/>
-                </a:solidFill>
-              </a:rPr>
-              <a:t>   Investigating the role of SII across various stages of colorectal cancer could provide insights into its utility as a dynamic prognostic tool.  </a:t>
-            </a:r>
             <a:endParaRPr lang="en-US" sz="1200" dirty="0"/>
           </a:p>
           <a:p>
@@ -4161,7 +4178,7 @@
                   <a:srgbClr val="FFFFFF"/>
                 </a:solidFill>
               </a:rPr>
-              <a:t>   研究SII在不同階段結直腸癌中的作用，可能會提供其作為動態預後工具的實用性見解。</a:t>
+              <a:t>3. **整合多種治療策略**  </a:t>
             </a:r>
             <a:endParaRPr lang="en-US" sz="1200" dirty="0"/>
           </a:p>
@@ -4172,6 +4189,14 @@
               </a:lnSpc>
               <a:buNone/>
             </a:pPr>
+            <a:r>
+              <a:rPr lang="en-US" sz="1200" dirty="0">
+                <a:solidFill>
+                  <a:srgbClr val="FFFFFF"/>
+                </a:solidFill>
+              </a:rPr>
+              <a:t>   Research should investigate the efficacy of combining dietary interventions and traditional herbal remedies with conventional therapies to enhance treatment outcomes in colorectal cancer.  </a:t>
+            </a:r>
             <a:endParaRPr lang="en-US" sz="1200" dirty="0"/>
           </a:p>
           <a:p>
@@ -4187,7 +4212,7 @@
                   <a:srgbClr val="FFFFFF"/>
                 </a:solidFill>
               </a:rPr>
-              <a:t>3. **傳統醫學與現代療法的結合**  </a:t>
+              <a:t>   *研究應調查將飲食干預和傳統草藥療法與常規治療相結合的有效性，以提高結直腸癌的治療效果。*</a:t>
             </a:r>
             <a:endParaRPr lang="en-US" sz="1200" dirty="0"/>
           </a:p>
@@ -4198,14 +4223,6 @@
               </a:lnSpc>
               <a:buNone/>
             </a:pPr>
-            <a:r>
-              <a:rPr lang="en-US" sz="1200" dirty="0">
-                <a:solidFill>
-                  <a:srgbClr val="FFFFFF"/>
-                </a:solidFill>
-              </a:rPr>
-              <a:t>   Further research is needed to explore the synergistic effects of traditional Chinese medicine and modern therapies in managing colorectal cancer.  </a:t>
-            </a:r>
             <a:endParaRPr lang="en-US" sz="1200" dirty="0"/>
           </a:p>
           <a:p>
@@ -4221,7 +4238,7 @@
                   <a:srgbClr val="FFFFFF"/>
                 </a:solidFill>
               </a:rPr>
-              <a:t>   需要進一步研究傳統中醫與現代療法在管理結直腸癌中的協同效應。</a:t>
+              <a:t>4. **患者教育與風險管理**  </a:t>
             </a:r>
             <a:endParaRPr lang="en-US" sz="1200" dirty="0"/>
           </a:p>
@@ -4232,6 +4249,14 @@
               </a:lnSpc>
               <a:buNone/>
             </a:pPr>
+            <a:r>
+              <a:rPr lang="en-US" sz="1200" dirty="0">
+                <a:solidFill>
+                  <a:srgbClr val="FFFFFF"/>
+                </a:solidFill>
+              </a:rPr>
+              <a:t>   Developing educational programs aimed at increasing awareness of colorectal cancer risks among patients with inflammatory bowel disease could improve early detection and management.  </a:t>
+            </a:r>
             <a:endParaRPr lang="en-US" sz="1200" dirty="0"/>
           </a:p>
           <a:p>
@@ -4247,7 +4272,7 @@
                   <a:srgbClr val="FFFFFF"/>
                 </a:solidFill>
               </a:rPr>
-              <a:t>4. **腫瘤微環境的治療干預**  </a:t>
+              <a:t>   *開發旨在提高炎症性腸病患者對結直腸癌風險認識的教育計劃，可能改善早期檢測和管理。*</a:t>
             </a:r>
             <a:endParaRPr lang="en-US" sz="1200" dirty="0"/>
           </a:p>
@@ -4258,14 +4283,6 @@
               </a:lnSpc>
               <a:buNone/>
             </a:pPr>
-            <a:r>
-              <a:rPr lang="en-US" sz="1200" dirty="0">
-                <a:solidFill>
-                  <a:srgbClr val="FFFFFF"/>
-                </a:solidFill>
-              </a:rPr>
-              <a:t>   Future research should investigate therapeutic strategies targeting the spatial organization of the TME to enhance treatment efficacy in colorectal cancer.  </a:t>
-            </a:r>
             <a:endParaRPr lang="en-US" sz="1200" dirty="0"/>
           </a:p>
           <a:p>
@@ -4281,7 +4298,7 @@
                   <a:srgbClr val="FFFFFF"/>
                 </a:solidFill>
               </a:rPr>
-              <a:t>   未來的研究應調查針對TME空間組織的治療策略，以提高結直腸癌的治療效果。</a:t>
+              <a:t>5. **生物標記的臨床應用**  </a:t>
             </a:r>
             <a:endParaRPr lang="en-US" sz="1200" dirty="0"/>
           </a:p>
@@ -4292,6 +4309,14 @@
               </a:lnSpc>
               <a:buNone/>
             </a:pPr>
+            <a:r>
+              <a:rPr lang="en-US" sz="1200" dirty="0">
+                <a:solidFill>
+                  <a:srgbClr val="FFFFFF"/>
+                </a:solidFill>
+              </a:rPr>
+              <a:t>   Investigating the clinical applicability of the systemic immune-inflammation index and other biomarkers could refine prognostic assessments and personalized treatment approaches in colorectal cancer.  </a:t>
+            </a:r>
             <a:endParaRPr lang="en-US" sz="1200" dirty="0"/>
           </a:p>
           <a:p>
@@ -4307,41 +4332,7 @@
                   <a:srgbClr val="FFFFFF"/>
                 </a:solidFill>
               </a:rPr>
-              <a:t>5. **增強患者對癌症風險的認識**  </a:t>
-            </a:r>
-            <a:endParaRPr lang="en-US" sz="1200" dirty="0"/>
-          </a:p>
-          <a:p>
-            <a:pPr indent="0" marL="0">
-              <a:lnSpc>
-                <a:spcPct val="150000"/>
-              </a:lnSpc>
-              <a:buNone/>
-            </a:pPr>
-            <a:r>
-              <a:rPr lang="en-US" sz="1200" dirty="0">
-                <a:solidFill>
-                  <a:srgbClr val="FFFFFF"/>
-                </a:solidFill>
-              </a:rPr>
-              <a:t>   Developing educational programs aimed at increasing awareness of colorectal cancer risks in patients with inflammatory bowel disease is essential for better management.  </a:t>
-            </a:r>
-            <a:endParaRPr lang="en-US" sz="1200" dirty="0"/>
-          </a:p>
-          <a:p>
-            <a:pPr indent="0" marL="0">
-              <a:lnSpc>
-                <a:spcPct val="150000"/>
-              </a:lnSpc>
-              <a:buNone/>
-            </a:pPr>
-            <a:r>
-              <a:rPr lang="en-US" sz="1200" dirty="0">
-                <a:solidFill>
-                  <a:srgbClr val="FFFFFF"/>
-                </a:solidFill>
-              </a:rPr>
-              <a:t>   制定旨在提高炎症性腸病患者對結直腸癌風險認識的教育計劃，對於改善管理至關重要。</a:t>
+              <a:t>   *研究系統性免疫炎症指數及其他生物標記的臨床應用，可能改善結直腸癌的預後評估和個性化治療方法。*</a:t>
             </a:r>
             <a:endParaRPr lang="en-US" sz="1200" dirty="0"/>
           </a:p>
@@ -4612,7 +4603,7 @@
                 <a:ea typeface="Arial" pitchFamily="34" charset="-122"/>
                 <a:cs typeface="Arial" pitchFamily="34" charset="-120"/>
               </a:rPr>
-              <a:t>Effect of hyperthermic intraperitoneal chemotherapy on patients with advanced co…</a:t>
+              <a:t>Simultaneous Establishment of Autologous Colorectal Cancer and Mesothelial Strom…</a:t>
             </a:r>
             <a:endParaRPr lang="en-US" sz="1400" dirty="0"/>
           </a:p>
@@ -4649,7 +4640,7 @@
                 <a:ea typeface="Arial" pitchFamily="34" charset="-122"/>
                 <a:cs typeface="Arial" pitchFamily="34" charset="-120"/>
               </a:rPr>
-              <a:t>Prognostic value of systemic immune-inflammation index for colorectal cancer: a …</a:t>
+              <a:t>Dabupi decoction mitigates fluorouracil-induced intestinal mucositis via farneso…</a:t>
             </a:r>
             <a:endParaRPr lang="en-US" sz="1400" dirty="0"/>
           </a:p>
@@ -4686,7 +4677,7 @@
                 <a:ea typeface="Arial" pitchFamily="34" charset="-122"/>
                 <a:cs typeface="Arial" pitchFamily="34" charset="-120"/>
               </a:rPr>
-              <a:t>Awareness of inflammatory bowel disease-associated colorectal cancer risk and it…</a:t>
+              <a:t>The effects of dietary beef powder on the dextran sulfate sodium-induced colitis…</a:t>
             </a:r>
             <a:endParaRPr lang="en-US" sz="1400" dirty="0"/>
           </a:p>
@@ -4723,7 +4714,7 @@
                 <a:ea typeface="Arial" pitchFamily="34" charset="-122"/>
                 <a:cs typeface="Arial" pitchFamily="34" charset="-120"/>
               </a:rPr>
-              <a:t>Network pharmacology integrated with multi-omics demonstrates that Wumei Wan mod…</a:t>
+              <a:t>Enhanced mRNA Expression of Colonic IL-6 in Cronkhite-Canada Syndrome Bearing Co…</a:t>
             </a:r>
             <a:endParaRPr lang="en-US" sz="1400" dirty="0"/>
           </a:p>
@@ -4760,7 +4751,7 @@
                 <a:ea typeface="Arial" pitchFamily="34" charset="-122"/>
                 <a:cs typeface="Arial" pitchFamily="34" charset="-120"/>
               </a:rPr>
-              <a:t>Low inflammation correlates with protumor Tim4+TREM1+ resident macrophage expans…</a:t>
+              <a:t>A Cascade-Responsive AND-Logic-Activatable Nanoprobe for Intraoperative Fluoresc…</a:t>
             </a:r>
             <a:endParaRPr lang="en-US" sz="1400" dirty="0"/>
           </a:p>
@@ -4797,7 +4788,7 @@
                 <a:ea typeface="Arial" pitchFamily="34" charset="-122"/>
                 <a:cs typeface="Arial" pitchFamily="34" charset="-120"/>
               </a:rPr>
-              <a:t>Spatial blueprint of colorectal cancer identifies Hypoxic CAF program that orche…</a:t>
+              <a:t>Effect of hyperthermic intraperitoneal chemotherapy on patients with advanced co…</a:t>
             </a:r>
             <a:endParaRPr lang="en-US" sz="1400" dirty="0"/>
           </a:p>
@@ -4834,7 +4825,7 @@
                 <a:ea typeface="Arial" pitchFamily="34" charset="-122"/>
                 <a:cs typeface="Arial" pitchFamily="34" charset="-120"/>
               </a:rPr>
-              <a:t>Curcumin-loaded extracellular vesicles derived from lactic acid bacteria for all…</a:t>
+              <a:t>Prognostic value of systemic immune-inflammation index for colorectal cancer: a …</a:t>
             </a:r>
             <a:endParaRPr lang="en-US" sz="1400" dirty="0"/>
           </a:p>
@@ -4871,7 +4862,7 @@
                 <a:ea typeface="Arial" pitchFamily="34" charset="-122"/>
                 <a:cs typeface="Arial" pitchFamily="34" charset="-120"/>
               </a:rPr>
-              <a:t>Multi-analytical and biological insights into Malcolmia grandiflora Kuntze.</a:t>
+              <a:t>Awareness of inflammatory bowel disease-associated colorectal cancer risk and it…</a:t>
             </a:r>
             <a:endParaRPr lang="en-US" sz="1400" dirty="0"/>
           </a:p>
@@ -4908,7 +4899,7 @@
                 <a:ea typeface="Arial" pitchFamily="34" charset="-122"/>
                 <a:cs typeface="Arial" pitchFamily="34" charset="-120"/>
               </a:rPr>
-              <a:t>Gastroprotective [6]-Gingerol Aspirinate as a Novel Aspirin-Derived Chemoprevent…</a:t>
+              <a:t>Quantifying preferences for watch-and-wait compared with surgery after a clinica…</a:t>
             </a:r>
             <a:endParaRPr lang="en-US" sz="1400" dirty="0"/>
           </a:p>
@@ -5163,7 +5154,7 @@
                 <a:ea typeface="Arial" pitchFamily="34" charset="-122"/>
                 <a:cs typeface="Arial" pitchFamily="34" charset="-120"/>
               </a:rPr>
-              <a:t>NETosis activation contributes to inflammation</a:t>
+              <a:t>NETosis activation linked to cancer progression</a:t>
             </a:r>
             <a:endParaRPr lang="en-US" sz="1800" dirty="0"/>
           </a:p>
@@ -5184,7 +5175,7 @@
                 <a:ea typeface="Arial" pitchFamily="34" charset="-122"/>
                 <a:cs typeface="Arial" pitchFamily="34" charset="-120"/>
               </a:rPr>
-              <a:t>Link between colitis and colorectal cancer</a:t>
+              <a:t>Potential therapeutic strategies identified</a:t>
             </a:r>
             <a:endParaRPr lang="en-US" sz="1800" dirty="0"/>
           </a:p>
@@ -5420,7 +5411,7 @@
                   </a:extLst>
                 </a:hlinkClick>
               </a:rPr>
-              <a:t>Effect of hyperthermic intraperitoneal chemotherapy on patients with advanced colorectal cancer: a systematic review and meta-analysis</a:t>
+              <a:t>Simultaneous Establishment of Autologous Colorectal Cancer and Mesothelial Stromal Cell Lines from Malignant Ascites Reveals a Mesothelial-Stromal FGFR3 Axis as a Potential Vulnerability in Peritoneal Metastasis.</a:t>
             </a:r>
             <a:endParaRPr lang="en-US" sz="2400" dirty="0"/>
           </a:p>
@@ -5456,7 +5447,7 @@
                   <a:srgbClr val="888888"/>
                 </a:solidFill>
               </a:rPr>
-              <a:t>World Journal of …  ·  Meta-Analysis</a:t>
+              <a:t>Cancer medicine  ·  IF 4.7  ·  Basic Research  ·  🌏 Asia</a:t>
             </a:r>
             <a:endParaRPr lang="en-US" sz="1000" dirty="0"/>
           </a:p>
@@ -5499,7 +5490,7 @@
                 <a:ea typeface="Arial" pitchFamily="34" charset="-122"/>
                 <a:cs typeface="Arial" pitchFamily="34" charset="-120"/>
               </a:rPr>
-              <a:t>Hyperthermic intraperitoneal chemotherapy (HIPEC) evaluated</a:t>
+              <a:t>Established autologous CRC and mesothelial cell lines.</a:t>
             </a:r>
             <a:endParaRPr lang="en-US" sz="1800" dirty="0"/>
           </a:p>
@@ -5520,7 +5511,7 @@
                 <a:ea typeface="Arial" pitchFamily="34" charset="-122"/>
                 <a:cs typeface="Arial" pitchFamily="34" charset="-120"/>
               </a:rPr>
-              <a:t>Effectiveness in advanced colorectal cancer patients</a:t>
+              <a:t>OMUCR-1 shows strong tumorigenic capacity.</a:t>
             </a:r>
             <a:endParaRPr lang="en-US" sz="1800" dirty="0"/>
           </a:p>
@@ -5541,7 +5532,49 @@
                 <a:ea typeface="Arial" pitchFamily="34" charset="-122"/>
                 <a:cs typeface="Arial" pitchFamily="34" charset="-120"/>
               </a:rPr>
-              <a:t>Systematic review and meta-analysis conducted</a:t>
+              <a:t>CAmeso enhances CRC cell migration and invasion.</a:t>
+            </a:r>
+            <a:endParaRPr lang="en-US" sz="1800" dirty="0"/>
+          </a:p>
+          <a:p>
+            <a:pPr marL="342900" indent="-342900">
+              <a:spcAft>
+                <a:spcPts val="800"/>
+              </a:spcAft>
+              <a:buSzPct val="100000"/>
+              <a:buChar char="•"/>
+            </a:pPr>
+            <a:r>
+              <a:rPr lang="en-US" sz="1800" dirty="0">
+                <a:solidFill>
+                  <a:srgbClr val="333333"/>
+                </a:solidFill>
+                <a:latin typeface="Arial" pitchFamily="34" charset="0"/>
+                <a:ea typeface="Arial" pitchFamily="34" charset="-122"/>
+                <a:cs typeface="Arial" pitchFamily="34" charset="-120"/>
+              </a:rPr>
+              <a:t>FGFR3 identified as potential therapeutic target.</a:t>
+            </a:r>
+            <a:endParaRPr lang="en-US" sz="1800" dirty="0"/>
+          </a:p>
+          <a:p>
+            <a:pPr marL="342900" indent="-342900">
+              <a:spcAft>
+                <a:spcPts val="800"/>
+              </a:spcAft>
+              <a:buSzPct val="100000"/>
+              <a:buChar char="•"/>
+            </a:pPr>
+            <a:r>
+              <a:rPr lang="en-US" sz="1800" dirty="0">
+                <a:solidFill>
+                  <a:srgbClr val="333333"/>
+                </a:solidFill>
+                <a:latin typeface="Arial" pitchFamily="34" charset="0"/>
+                <a:ea typeface="Arial" pitchFamily="34" charset="-122"/>
+                <a:cs typeface="Arial" pitchFamily="34" charset="-120"/>
+              </a:rPr>
+              <a:t>Model aids in studying tumor-stroma interactions.</a:t>
             </a:r>
             <a:endParaRPr lang="en-US" sz="1800" dirty="0"/>
           </a:p>
@@ -5577,7 +5610,7 @@
                   <a:srgbClr val="888888"/>
                 </a:solidFill>
               </a:rPr>
-              <a:t>Z Su, Y Guo, X Ru. World Journal of …. 2026</a:t>
+              <a:t>Fukui Yasuhiro, Kasashima Hiroaki, Wang Zizhou et al.. Cancer medicine. 2026-04-25 DOI: 10.1002/cam4.71804</a:t>
             </a:r>
             <a:endParaRPr lang="en-US" sz="800" dirty="0"/>
           </a:p>
@@ -5777,7 +5810,7 @@
                   </a:extLst>
                 </a:hlinkClick>
               </a:rPr>
-              <a:t>Prognostic value of systemic immune-inflammation index for colorectal cancer: a systematic review and meta-analysis</a:t>
+              <a:t>Dabupi decoction mitigates fluorouracil-induced intestinal mucositis via farnesoid X receptor activation and dihydropyrimidine dehydrogenase upregulation.</a:t>
             </a:r>
             <a:endParaRPr lang="en-US" sz="2400" dirty="0"/>
           </a:p>
@@ -5813,7 +5846,7 @@
                   <a:srgbClr val="888888"/>
                 </a:solidFill>
               </a:rPr>
-              <a:t>Frontiers in Oncology  ·  Meta-Analysis</a:t>
+              <a:t>Journal of ethnopharmacology  ·  Basic Research  ·  🌏 Asia</a:t>
             </a:r>
             <a:endParaRPr lang="en-US" sz="1000" dirty="0"/>
           </a:p>
@@ -5856,7 +5889,7 @@
                 <a:ea typeface="Arial" pitchFamily="34" charset="-122"/>
                 <a:cs typeface="Arial" pitchFamily="34" charset="-120"/>
               </a:rPr>
-              <a:t>Systemic immune-inflammation index (SII) evaluated</a:t>
+              <a:t>5-FU causes intestinal mucositis toxicity.</a:t>
             </a:r>
             <a:endParaRPr lang="en-US" sz="1800" dirty="0"/>
           </a:p>
@@ -5877,7 +5910,7 @@
                 <a:ea typeface="Arial" pitchFamily="34" charset="-122"/>
                 <a:cs typeface="Arial" pitchFamily="34" charset="-120"/>
               </a:rPr>
-              <a:t>Prognostic biomarker for colorectal cancer</a:t>
+              <a:t>DBPD activates FXR and upregulates DPYD.</a:t>
             </a:r>
             <a:endParaRPr lang="en-US" sz="1800" dirty="0"/>
           </a:p>
@@ -5898,7 +5931,7 @@
                 <a:ea typeface="Arial" pitchFamily="34" charset="-122"/>
                 <a:cs typeface="Arial" pitchFamily="34" charset="-120"/>
               </a:rPr>
-              <a:t>Meta-analysis of existing studies</a:t>
+              <a:t>Bile acid metabolism is disrupted by 5-FU.</a:t>
             </a:r>
             <a:endParaRPr lang="en-US" sz="1800" dirty="0"/>
           </a:p>
@@ -5919,7 +5952,7 @@
                 <a:ea typeface="Arial" pitchFamily="34" charset="-122"/>
                 <a:cs typeface="Arial" pitchFamily="34" charset="-120"/>
               </a:rPr>
-              <a:t>SII associated with patient outcomes</a:t>
+              <a:t>DBPD improves intestinal barrier integrity.</a:t>
             </a:r>
             <a:endParaRPr lang="en-US" sz="1800" dirty="0"/>
           </a:p>
@@ -5940,7 +5973,7 @@
                 <a:ea typeface="Arial" pitchFamily="34" charset="-122"/>
                 <a:cs typeface="Arial" pitchFamily="34" charset="-120"/>
               </a:rPr>
-              <a:t>Potential for clinical application</a:t>
+              <a:t>Low UGT1A1/FXR levels link to poor prognosis.</a:t>
             </a:r>
             <a:endParaRPr lang="en-US" sz="1800" dirty="0"/>
           </a:p>
@@ -5976,7 +6009,7 @@
                   <a:srgbClr val="888888"/>
                 </a:solidFill>
               </a:rPr>
-              <a:t>P Wang, H Jiang. Frontiers in Oncology. 2026</a:t>
+              <a:t>Wang ShunZhi, Li Yaling, Ma Jing et al.. Journal of ethnopharmacology. 2026-05-03 DOI: 10.1016/j.jep.2026.121742</a:t>
             </a:r>
             <a:endParaRPr lang="en-US" sz="800" dirty="0"/>
           </a:p>
@@ -6176,7 +6209,7 @@
                   </a:extLst>
                 </a:hlinkClick>
               </a:rPr>
-              <a:t>Awareness of inflammatory bowel disease-associated colorectal cancer risk and its management in patients with inflammatory bowel disease: a systematic review</a:t>
+              <a:t>The effects of dietary beef powder on the dextran sulfate sodium-induced colitis in a mouse model through COX-2 pathway.</a:t>
             </a:r>
             <a:endParaRPr lang="en-US" sz="2400" dirty="0"/>
           </a:p>
@@ -6212,7 +6245,7 @@
                   <a:srgbClr val="888888"/>
                 </a:solidFill>
               </a:rPr>
-              <a:t>Crohns &amp; Colitis 360  ·  Systematic Review</a:t>
+              <a:t>Food science of animal resources  ·  Basic Research  ·  🌏 Asia</a:t>
             </a:r>
             <a:endParaRPr lang="en-US" sz="1000" dirty="0"/>
           </a:p>
@@ -6255,7 +6288,7 @@
                 <a:ea typeface="Arial" pitchFamily="34" charset="-122"/>
                 <a:cs typeface="Arial" pitchFamily="34" charset="-120"/>
               </a:rPr>
-              <a:t>Limited awareness of colorectal cancer risk</a:t>
+              <a:t>Beef powder shows anti-inflammatory effects.</a:t>
             </a:r>
             <a:endParaRPr lang="en-US" sz="1800" dirty="0"/>
           </a:p>
@@ -6276,7 +6309,7 @@
                 <a:ea typeface="Arial" pitchFamily="34" charset="-122"/>
                 <a:cs typeface="Arial" pitchFamily="34" charset="-120"/>
               </a:rPr>
-              <a:t>Need for better patient education strategies</a:t>
+              <a:t>20% HR beef powder reduces colitis severity.</a:t>
             </a:r>
             <a:endParaRPr lang="en-US" sz="1800" dirty="0"/>
           </a:p>
@@ -6297,7 +6330,49 @@
                 <a:ea typeface="Arial" pitchFamily="34" charset="-122"/>
                 <a:cs typeface="Arial" pitchFamily="34" charset="-120"/>
               </a:rPr>
-              <a:t>Current management practices are insufficient</a:t>
+              <a:t>Supplementation lowers triglycerides and cholesterol.</a:t>
+            </a:r>
+            <a:endParaRPr lang="en-US" sz="1800" dirty="0"/>
+          </a:p>
+          <a:p>
+            <a:pPr marL="342900" indent="-342900">
+              <a:spcAft>
+                <a:spcPts val="800"/>
+              </a:spcAft>
+              <a:buSzPct val="100000"/>
+              <a:buChar char="•"/>
+            </a:pPr>
+            <a:r>
+              <a:rPr lang="en-US" sz="1800" dirty="0">
+                <a:solidFill>
+                  <a:srgbClr val="333333"/>
+                </a:solidFill>
+                <a:latin typeface="Arial" pitchFamily="34" charset="0"/>
+                <a:ea typeface="Arial" pitchFamily="34" charset="-122"/>
+                <a:cs typeface="Arial" pitchFamily="34" charset="-120"/>
+              </a:rPr>
+              <a:t>COX-2 expression decreased in treated mice.</a:t>
+            </a:r>
+            <a:endParaRPr lang="en-US" sz="1800" dirty="0"/>
+          </a:p>
+          <a:p>
+            <a:pPr marL="342900" indent="-342900">
+              <a:spcAft>
+                <a:spcPts val="800"/>
+              </a:spcAft>
+              <a:buSzPct val="100000"/>
+              <a:buChar char="•"/>
+            </a:pPr>
+            <a:r>
+              <a:rPr lang="en-US" sz="1800" dirty="0">
+                <a:solidFill>
+                  <a:srgbClr val="333333"/>
+                </a:solidFill>
+                <a:latin typeface="Arial" pitchFamily="34" charset="0"/>
+                <a:ea typeface="Arial" pitchFamily="34" charset="-122"/>
+                <a:cs typeface="Arial" pitchFamily="34" charset="-120"/>
+              </a:rPr>
+              <a:t>Oxidative stress alleviated in colonic tissue.</a:t>
             </a:r>
             <a:endParaRPr lang="en-US" sz="1800" dirty="0"/>
           </a:p>
@@ -6333,7 +6408,7 @@
                   <a:srgbClr val="888888"/>
                 </a:solidFill>
               </a:rPr>
-              <a:t>F Khan, C Norton, W Czuber-Dochan. Crohns &amp; Colitis 360. 2026</a:t>
+              <a:t>Kim Hye-Jin, Kim Dongwook, Jang Aera. Food science of animal resources. 2026-04-28 DOI: 10.1007/s44463-025-00054-5</a:t>
             </a:r>
             <a:endParaRPr lang="en-US" sz="800" dirty="0"/>
           </a:p>
@@ -6533,7 +6608,7 @@
                   </a:extLst>
                 </a:hlinkClick>
               </a:rPr>
-              <a:t>Network pharmacology integrated with multi-omics demonstrates that Wumei Wan modulates the progression of colorectal cancer by regulating the focal adhesion-YAP signaling axis.</a:t>
+              <a:t>Enhanced mRNA Expression of Colonic IL-6 in Cronkhite-Canada Syndrome Bearing Colorectal Cancer.</a:t>
             </a:r>
             <a:endParaRPr lang="en-US" sz="2400" dirty="0"/>
           </a:p>
@@ -6569,7 +6644,7 @@
                   <a:srgbClr val="888888"/>
                 </a:solidFill>
               </a:rPr>
-              <a:t>Journal of ethnopharmacology  ·  Basic Research</a:t>
+              <a:t>In vivo (Athens, Greece)  ·  🌏 Asia</a:t>
             </a:r>
             <a:endParaRPr lang="en-US" sz="1000" dirty="0"/>
           </a:p>
@@ -6612,7 +6687,7 @@
                 <a:ea typeface="Arial" pitchFamily="34" charset="-122"/>
                 <a:cs typeface="Arial" pitchFamily="34" charset="-120"/>
               </a:rPr>
-              <a:t>Wumei Wan shows anti-tumor effects.</a:t>
+              <a:t>CCS improves with immunosuppressive treatments.</a:t>
             </a:r>
             <a:endParaRPr lang="en-US" sz="1800" dirty="0"/>
           </a:p>
@@ -6633,7 +6708,7 @@
                 <a:ea typeface="Arial" pitchFamily="34" charset="-122"/>
                 <a:cs typeface="Arial" pitchFamily="34" charset="-120"/>
               </a:rPr>
-              <a:t>Network pharmacology identifies key targets.</a:t>
+              <a:t>CCS polyps include various types.</a:t>
             </a:r>
             <a:endParaRPr lang="en-US" sz="1800" dirty="0"/>
           </a:p>
@@ -6654,49 +6729,7 @@
                 <a:ea typeface="Arial" pitchFamily="34" charset="-122"/>
                 <a:cs typeface="Arial" pitchFamily="34" charset="-120"/>
               </a:rPr>
-              <a:t>FAK/Src/YAP signaling axis is crucial.</a:t>
-            </a:r>
-            <a:endParaRPr lang="en-US" sz="1800" dirty="0"/>
-          </a:p>
-          <a:p>
-            <a:pPr marL="342900" indent="-342900">
-              <a:spcAft>
-                <a:spcPts val="800"/>
-              </a:spcAft>
-              <a:buSzPct val="100000"/>
-              <a:buChar char="•"/>
-            </a:pPr>
-            <a:r>
-              <a:rPr lang="en-US" sz="1800" dirty="0">
-                <a:solidFill>
-                  <a:srgbClr val="333333"/>
-                </a:solidFill>
-                <a:latin typeface="Arial" pitchFamily="34" charset="0"/>
-                <a:ea typeface="Arial" pitchFamily="34" charset="-122"/>
-                <a:cs typeface="Arial" pitchFamily="34" charset="-120"/>
-              </a:rPr>
-              <a:t>Multi-omics reveals inflammation modulation.</a:t>
-            </a:r>
-            <a:endParaRPr lang="en-US" sz="1800" dirty="0"/>
-          </a:p>
-          <a:p>
-            <a:pPr marL="342900" indent="-342900">
-              <a:spcAft>
-                <a:spcPts val="800"/>
-              </a:spcAft>
-              <a:buSzPct val="100000"/>
-              <a:buChar char="•"/>
-            </a:pPr>
-            <a:r>
-              <a:rPr lang="en-US" sz="1800" dirty="0">
-                <a:solidFill>
-                  <a:srgbClr val="333333"/>
-                </a:solidFill>
-                <a:latin typeface="Arial" pitchFamily="34" charset="0"/>
-                <a:ea typeface="Arial" pitchFamily="34" charset="-122"/>
-                <a:cs typeface="Arial" pitchFamily="34" charset="-120"/>
-              </a:rPr>
-              <a:t>Molecular docking suggests stable interactions.</a:t>
+              <a:t>IL-6 expression linked to CRC development.</a:t>
             </a:r>
             <a:endParaRPr lang="en-US" sz="1800" dirty="0"/>
           </a:p>
@@ -6732,7 +6765,7 @@
                   <a:srgbClr val="888888"/>
                 </a:solidFill>
               </a:rPr>
-              <a:t>Yang Shusen, Wang Min, Liu Siyue et al.. Journal of ethnopharmacology. 2026-02-11 DOI: 10.1016/j.jep.2026.121264</a:t>
+              <a:t>Fujihara Daisuke, Honjo Hajime, Masuta Yasuhiro et al.. In vivo (Athens, Greece). 2026-04-28 DOI: 10.21873/invivo.14334</a:t>
             </a:r>
             <a:endParaRPr lang="en-US" sz="800" dirty="0"/>
           </a:p>
@@ -6932,7 +6965,7 @@
                   </a:extLst>
                 </a:hlinkClick>
               </a:rPr>
-              <a:t>Low inflammation correlates with protumor Tim4+TREM1+ resident macrophage expansion and limited monocyte-derived macrophage differentiation during peritoneal colorectal cancer.</a:t>
+              <a:t>A Cascade-Responsive AND-Logic-Activatable Nanoprobe for Intraoperative Fluorescence Imaging of Colorectal Cancer.</a:t>
             </a:r>
             <a:endParaRPr lang="en-US" sz="2400" dirty="0"/>
           </a:p>
@@ -6968,7 +7001,7 @@
                   <a:srgbClr val="888888"/>
                 </a:solidFill>
               </a:rPr>
-              <a:t>Cancer immunology research  ·  Basic Research</a:t>
+              <a:t>Journal of the American Chemical Society  ·  🌏 Asia</a:t>
             </a:r>
             <a:endParaRPr lang="en-US" sz="1000" dirty="0"/>
           </a:p>
@@ -7011,7 +7044,7 @@
                 <a:ea typeface="Arial" pitchFamily="34" charset="-122"/>
                 <a:cs typeface="Arial" pitchFamily="34" charset="-120"/>
               </a:rPr>
-              <a:t>Low inflammation limits monocyte recruitment.</a:t>
+              <a:t>duNP-DA enhances intraoperative imaging</a:t>
             </a:r>
             <a:endParaRPr lang="en-US" sz="1800" dirty="0"/>
           </a:p>
@@ -7032,7 +7065,7 @@
                 <a:ea typeface="Arial" pitchFamily="34" charset="-122"/>
                 <a:cs typeface="Arial" pitchFamily="34" charset="-120"/>
               </a:rPr>
-              <a:t>Tim4+ resident macrophages expand during CRC.</a:t>
+              <a:t>Utilizes acidic tumor microenvironment for activation</a:t>
             </a:r>
             <a:endParaRPr lang="en-US" sz="1800" dirty="0"/>
           </a:p>
@@ -7053,7 +7086,49 @@
                 <a:ea typeface="Arial" pitchFamily="34" charset="-122"/>
                 <a:cs typeface="Arial" pitchFamily="34" charset="-120"/>
               </a:rPr>
-              <a:t>Protumor signatures in Tim4+ macrophages identified.</a:t>
+              <a:t>Achieves high tumor-to-background ratio</a:t>
+            </a:r>
+            <a:endParaRPr lang="en-US" sz="1800" dirty="0"/>
+          </a:p>
+          <a:p>
+            <a:pPr marL="342900" indent="-342900">
+              <a:spcAft>
+                <a:spcPts val="800"/>
+              </a:spcAft>
+              <a:buSzPct val="100000"/>
+              <a:buChar char="•"/>
+            </a:pPr>
+            <a:r>
+              <a:rPr lang="en-US" sz="1800" dirty="0">
+                <a:solidFill>
+                  <a:srgbClr val="333333"/>
+                </a:solidFill>
+                <a:latin typeface="Arial" pitchFamily="34" charset="0"/>
+                <a:ea typeface="Arial" pitchFamily="34" charset="-122"/>
+                <a:cs typeface="Arial" pitchFamily="34" charset="-120"/>
+              </a:rPr>
+              <a:t>Delineates lesions as small as 2 mm</a:t>
+            </a:r>
+            <a:endParaRPr lang="en-US" sz="1800" dirty="0"/>
+          </a:p>
+          <a:p>
+            <a:pPr marL="342900" indent="-342900">
+              <a:spcAft>
+                <a:spcPts val="800"/>
+              </a:spcAft>
+              <a:buSzPct val="100000"/>
+              <a:buChar char="•"/>
+            </a:pPr>
+            <a:r>
+              <a:rPr lang="en-US" sz="1800" dirty="0">
+                <a:solidFill>
+                  <a:srgbClr val="333333"/>
+                </a:solidFill>
+                <a:latin typeface="Arial" pitchFamily="34" charset="0"/>
+                <a:ea typeface="Arial" pitchFamily="34" charset="-122"/>
+                <a:cs typeface="Arial" pitchFamily="34" charset="-120"/>
+              </a:rPr>
+              <a:t>100% diagnostic sensitivity and specificity</a:t>
             </a:r>
             <a:endParaRPr lang="en-US" sz="1800" dirty="0"/>
           </a:p>
@@ -7089,7 +7164,7 @@
                   <a:srgbClr val="888888"/>
                 </a:solidFill>
               </a:rPr>
-              <a:t>Ferriz Margarita, Alvarez-Ladr&amp;#xf3;n Natalia, Guti&amp;#xe9;rrez-Gonz&amp;#xe1;lez Alejandra et al.. Cancer immunology research. 2026-04-23 DOI: 10.1158/2326-6066.CIR-25-0388</a:t>
+              <a:t>Fang Leyi, Ishigaki Yusuke, Huang Weijing et al.. Journal of the American Chemical Society. 2026-04-29 DOI: 10.1021/jacs.6c04349</a:t>
             </a:r>
             <a:endParaRPr lang="en-US" sz="800" dirty="0"/>
           </a:p>
@@ -7289,7 +7364,7 @@
                   </a:extLst>
                 </a:hlinkClick>
               </a:rPr>
-              <a:t>Spatial blueprint of colorectal cancer identifies Hypoxic CAF program that orchestrates Go-or-Grow decisions and predicts outcomes.</a:t>
+              <a:t>Effect of hyperthermic intraperitoneal chemotherapy on patients with advanced colorectal cancer: a systematic review and meta-analysis</a:t>
             </a:r>
             <a:endParaRPr lang="en-US" sz="2400" dirty="0"/>
           </a:p>
@@ -7325,7 +7400,7 @@
                   <a:srgbClr val="888888"/>
                 </a:solidFill>
               </a:rPr>
-              <a:t>Investigational new drugs  ·  Basic Research</a:t>
+              <a:t>World Journal of …  ·  Meta-Analysis</a:t>
             </a:r>
             <a:endParaRPr lang="en-US" sz="1000" dirty="0"/>
           </a:p>
@@ -7368,7 +7443,7 @@
                 <a:ea typeface="Arial" pitchFamily="34" charset="-122"/>
                 <a:cs typeface="Arial" pitchFamily="34" charset="-120"/>
               </a:rPr>
-              <a:t>Integrated single-cell and spatial transcriptomics</a:t>
+              <a:t>Hyperthermic intraperitoneal chemotherapy (HIPEC) evaluated</a:t>
             </a:r>
             <a:endParaRPr lang="en-US" sz="1800" dirty="0"/>
           </a:p>
@@ -7389,7 +7464,7 @@
                 <a:ea typeface="Arial" pitchFamily="34" charset="-122"/>
                 <a:cs typeface="Arial" pitchFamily="34" charset="-120"/>
               </a:rPr>
-              <a:t>Identified nine microenvironmental niches in CRC</a:t>
+              <a:t>Systematic review and meta-analysis conducted</a:t>
             </a:r>
             <a:endParaRPr lang="en-US" sz="1800" dirty="0"/>
           </a:p>
@@ -7410,7 +7485,7 @@
                 <a:ea typeface="Arial" pitchFamily="34" charset="-122"/>
                 <a:cs typeface="Arial" pitchFamily="34" charset="-120"/>
               </a:rPr>
-              <a:t>Hypoxic CAFs linked to tumor cell behavior</a:t>
+              <a:t>Focus on advanced colorectal cancer patients</a:t>
             </a:r>
             <a:endParaRPr lang="en-US" sz="1800" dirty="0"/>
           </a:p>
@@ -7431,7 +7506,7 @@
                 <a:ea typeface="Arial" pitchFamily="34" charset="-122"/>
                 <a:cs typeface="Arial" pitchFamily="34" charset="-120"/>
               </a:rPr>
-              <a:t>HMGA2 as a key transcriptional regulator</a:t>
+              <a:t>Impact on peritoneal metastases assessed</a:t>
             </a:r>
             <a:endParaRPr lang="en-US" sz="1800" dirty="0"/>
           </a:p>
@@ -7452,7 +7527,7 @@
                 <a:ea typeface="Arial" pitchFamily="34" charset="-122"/>
                 <a:cs typeface="Arial" pitchFamily="34" charset="-120"/>
               </a:rPr>
-              <a:t>Potential therapeutic targets for CRC intervention</a:t>
+              <a:t>Findings suggest potential survival benefits</a:t>
             </a:r>
             <a:endParaRPr lang="en-US" sz="1800" dirty="0"/>
           </a:p>
@@ -7488,7 +7563,7 @@
                   <a:srgbClr val="888888"/>
                 </a:solidFill>
               </a:rPr>
-              <a:t>Chen Mingkai, Yang Juan, Wang Jin et al.. Investigational new drugs. 2026-04-22 DOI: 10.1007/s10637-026-01611-5</a:t>
+              <a:t>Z Su, Y Guo, X Ru. World Journal of …. 2026</a:t>
             </a:r>
             <a:endParaRPr lang="en-US" sz="800" dirty="0"/>
           </a:p>

</xml_diff>

<commit_message>
chore: update weekly digest 2026-05-11
</commit_message>
<xml_diff>
--- a/docs/digest-en.pptx
+++ b/docs/digest-en.pptx
@@ -2249,7 +2249,7 @@
                   <a:srgbClr val="888888"/>
                 </a:solidFill>
               </a:rPr>
-              <a:t>2026-04-27 — 2026-05-04</a:t>
+              <a:t>2026-05-04 — 2026-05-11</a:t>
             </a:r>
             <a:endParaRPr lang="en-US" sz="1400" dirty="0"/>
           </a:p>
@@ -2440,7 +2440,7 @@
                   </a:extLst>
                 </a:hlinkClick>
               </a:rPr>
-              <a:t>Prognostic value of systemic immune-inflammation index for colorectal cancer: a systematic review and meta-analysis</a:t>
+              <a:t>… Cancer and Mesothelial Stromal Cell Lines from Malignant Ascites Reveals a Mesothelial‐Stromal FGFR3 Axis as a Potential Vulnerability in Peritoneal Metastasis</a:t>
             </a:r>
             <a:endParaRPr lang="en-US" sz="2400" dirty="0"/>
           </a:p>
@@ -2476,7 +2476,7 @@
                   <a:srgbClr val="888888"/>
                 </a:solidFill>
               </a:rPr>
-              <a:t>Frontiers in Oncology  ·  Meta-Analysis</a:t>
+              <a:t>Cancer …  ·  Basic Research</a:t>
             </a:r>
             <a:endParaRPr lang="en-US" sz="1000" dirty="0"/>
           </a:p>
@@ -2519,7 +2519,7 @@
                 <a:ea typeface="Arial" pitchFamily="34" charset="-122"/>
                 <a:cs typeface="Arial" pitchFamily="34" charset="-120"/>
               </a:rPr>
-              <a:t>Systemic immune-inflammation index (SII) evaluated</a:t>
+              <a:t>Colorectal cancer poses treatment challenges.</a:t>
             </a:r>
             <a:endParaRPr lang="en-US" sz="1800" dirty="0"/>
           </a:p>
@@ -2540,7 +2540,7 @@
                 <a:ea typeface="Arial" pitchFamily="34" charset="-122"/>
                 <a:cs typeface="Arial" pitchFamily="34" charset="-120"/>
               </a:rPr>
-              <a:t>SII as a prognostic biomarker in CRC</a:t>
+              <a:t>Mesothelial-stromal FGFR3 axis identified.</a:t>
             </a:r>
             <a:endParaRPr lang="en-US" sz="1800" dirty="0"/>
           </a:p>
@@ -2561,49 +2561,7 @@
                 <a:ea typeface="Arial" pitchFamily="34" charset="-122"/>
                 <a:cs typeface="Arial" pitchFamily="34" charset="-120"/>
               </a:rPr>
-              <a:t>Meta-analysis of existing studies conducted</a:t>
-            </a:r>
-            <a:endParaRPr lang="en-US" sz="1800" dirty="0"/>
-          </a:p>
-          <a:p>
-            <a:pPr marL="342900" indent="-342900">
-              <a:spcAft>
-                <a:spcPts val="800"/>
-              </a:spcAft>
-              <a:buSzPct val="100000"/>
-              <a:buChar char="•"/>
-            </a:pPr>
-            <a:r>
-              <a:rPr lang="en-US" sz="1800" dirty="0">
-                <a:solidFill>
-                  <a:srgbClr val="333333"/>
-                </a:solidFill>
-                <a:latin typeface="Arial" pitchFamily="34" charset="0"/>
-                <a:ea typeface="Arial" pitchFamily="34" charset="-122"/>
-                <a:cs typeface="Arial" pitchFamily="34" charset="-120"/>
-              </a:rPr>
-              <a:t>Correlation between SII and patient outcomes</a:t>
-            </a:r>
-            <a:endParaRPr lang="en-US" sz="1800" dirty="0"/>
-          </a:p>
-          <a:p>
-            <a:pPr marL="342900" indent="-342900">
-              <a:spcAft>
-                <a:spcPts val="800"/>
-              </a:spcAft>
-              <a:buSzPct val="100000"/>
-              <a:buChar char="•"/>
-            </a:pPr>
-            <a:r>
-              <a:rPr lang="en-US" sz="1800" dirty="0">
-                <a:solidFill>
-                  <a:srgbClr val="333333"/>
-                </a:solidFill>
-                <a:latin typeface="Arial" pitchFamily="34" charset="0"/>
-                <a:ea typeface="Arial" pitchFamily="34" charset="-122"/>
-                <a:cs typeface="Arial" pitchFamily="34" charset="-120"/>
-              </a:rPr>
-              <a:t>Potential for SII in clinical practice</a:t>
+              <a:t>Potential vulnerability in peritoneal metastasis.</a:t>
             </a:r>
             <a:endParaRPr lang="en-US" sz="1800" dirty="0"/>
           </a:p>
@@ -2639,7 +2597,7 @@
                   <a:srgbClr val="888888"/>
                 </a:solidFill>
               </a:rPr>
-              <a:t>P Wang, H Jiang. Frontiers in Oncology. 2026</a:t>
+              <a:t>Y Fukui, H Kasashima, Z Wang. Cancer …. 2026</a:t>
             </a:r>
             <a:endParaRPr lang="en-US" sz="800" dirty="0"/>
           </a:p>
@@ -2839,7 +2797,7 @@
                   </a:extLst>
                 </a:hlinkClick>
               </a:rPr>
-              <a:t>Awareness of inflammatory bowel disease-associated colorectal cancer risk and its management in patients with inflammatory bowel disease: a systematic review</a:t>
+              <a:t>Repurposing PARP inhibitors in molecularly defined subgroups of peritoneal metastatic colorectal cancer (pmCRC): Preclinical analysis of patient-derived xenograft …</a:t>
             </a:r>
             <a:endParaRPr lang="en-US" sz="2400" dirty="0"/>
           </a:p>
@@ -2875,7 +2833,7 @@
                   <a:srgbClr val="888888"/>
                 </a:solidFill>
               </a:rPr>
-              <a:t>Crohns &amp; Colitis 360  ·  Systematic Review</a:t>
+              <a:t>Cancer …  ·  Basic Research</a:t>
             </a:r>
             <a:endParaRPr lang="en-US" sz="1000" dirty="0"/>
           </a:p>
@@ -2918,7 +2876,7 @@
                 <a:ea typeface="Arial" pitchFamily="34" charset="-122"/>
                 <a:cs typeface="Arial" pitchFamily="34" charset="-120"/>
               </a:rPr>
-              <a:t>Limited awareness of colorectal cancer risk</a:t>
+              <a:t>pmCRC shows poor prognosis compared to other metastases.</a:t>
             </a:r>
             <a:endParaRPr lang="en-US" sz="1800" dirty="0"/>
           </a:p>
@@ -2939,7 +2897,7 @@
                 <a:ea typeface="Arial" pitchFamily="34" charset="-122"/>
                 <a:cs typeface="Arial" pitchFamily="34" charset="-120"/>
               </a:rPr>
-              <a:t>Need for better patient education strategies</a:t>
+              <a:t>PARP inhibitors may benefit specific molecular subgroups.</a:t>
             </a:r>
             <a:endParaRPr lang="en-US" sz="1800" dirty="0"/>
           </a:p>
@@ -2960,7 +2918,7 @@
                 <a:ea typeface="Arial" pitchFamily="34" charset="-122"/>
                 <a:cs typeface="Arial" pitchFamily="34" charset="-120"/>
               </a:rPr>
-              <a:t>Research gaps in inflammatory bowel disease management</a:t>
+              <a:t>Preclinical models used patient-derived xenografts.</a:t>
             </a:r>
             <a:endParaRPr lang="en-US" sz="1800" dirty="0"/>
           </a:p>
@@ -2996,7 +2954,7 @@
                   <a:srgbClr val="888888"/>
                 </a:solidFill>
               </a:rPr>
-              <a:t>F Khan, C Norton, W Czuber-Dochan. Crohns &amp; Colitis 360. 2026</a:t>
+              <a:t>M Dahlmann, B Rau, S Gül-Klein. Cancer …. 2026</a:t>
             </a:r>
             <a:endParaRPr lang="en-US" sz="800" dirty="0"/>
           </a:p>
@@ -3196,7 +3154,7 @@
                   </a:extLst>
                 </a:hlinkClick>
               </a:rPr>
-              <a:t>Quantifying preferences for watch-and-wait compared with surgery after a clinical complete response in locally advanced rectal cancer: A discrete choice experiment (PrefCoRe).</a:t>
+              <a:t>The Mechanism of Acetyl-L-Carnitine on Colorectal Cancer and Its Metabolomic Study</a:t>
             </a:r>
             <a:endParaRPr lang="en-US" sz="2400" dirty="0"/>
           </a:p>
@@ -3232,7 +3190,7 @@
                   <a:srgbClr val="888888"/>
                 </a:solidFill>
               </a:rPr>
-              <a:t>European journal of cancer (Oxford, England : 1990)  ·  IF 8.4</a:t>
+              <a:t>Journal of Pharmaceutical and …  ·  Basic Research</a:t>
             </a:r>
             <a:endParaRPr lang="en-US" sz="1000" dirty="0"/>
           </a:p>
@@ -3275,7 +3233,7 @@
                 <a:ea typeface="Arial" pitchFamily="34" charset="-122"/>
                 <a:cs typeface="Arial" pitchFamily="34" charset="-120"/>
               </a:rPr>
-              <a:t>Watch-and-wait is an alternative approach.</a:t>
+              <a:t>Acetyl-L-Carnitine inhibits tumor growth</a:t>
             </a:r>
             <a:endParaRPr lang="en-US" sz="1800" dirty="0"/>
           </a:p>
@@ -3296,7 +3254,7 @@
                 <a:ea typeface="Arial" pitchFamily="34" charset="-122"/>
                 <a:cs typeface="Arial" pitchFamily="34" charset="-120"/>
               </a:rPr>
-              <a:t>Participants had varied preferences for attributes.</a:t>
+              <a:t>In vivo studies confirm ALC efficacy</a:t>
             </a:r>
             <a:endParaRPr lang="en-US" sz="1800" dirty="0"/>
           </a:p>
@@ -3317,49 +3275,7 @@
                 <a:ea typeface="Arial" pitchFamily="34" charset="-122"/>
                 <a:cs typeface="Arial" pitchFamily="34" charset="-120"/>
               </a:rPr>
-              <a:t>Quality of life and survival were prioritized.</a:t>
-            </a:r>
-            <a:endParaRPr lang="en-US" sz="1800" dirty="0"/>
-          </a:p>
-          <a:p>
-            <a:pPr marL="342900" indent="-342900">
-              <a:spcAft>
-                <a:spcPts val="800"/>
-              </a:spcAft>
-              <a:buSzPct val="100000"/>
-              <a:buChar char="•"/>
-            </a:pPr>
-            <a:r>
-              <a:rPr lang="en-US" sz="1800" dirty="0">
-                <a:solidFill>
-                  <a:srgbClr val="333333"/>
-                </a:solidFill>
-                <a:latin typeface="Arial" pitchFamily="34" charset="0"/>
-                <a:ea typeface="Arial" pitchFamily="34" charset="-122"/>
-                <a:cs typeface="Arial" pitchFamily="34" charset="-120"/>
-              </a:rPr>
-              <a:t>Predicted W&amp;W uptake was 52.9% and 57.2%.</a:t>
-            </a:r>
-            <a:endParaRPr lang="en-US" sz="1800" dirty="0"/>
-          </a:p>
-          <a:p>
-            <a:pPr marL="342900" indent="-342900">
-              <a:spcAft>
-                <a:spcPts val="800"/>
-              </a:spcAft>
-              <a:buSzPct val="100000"/>
-              <a:buChar char="•"/>
-            </a:pPr>
-            <a:r>
-              <a:rPr lang="en-US" sz="1800" dirty="0">
-                <a:solidFill>
-                  <a:srgbClr val="333333"/>
-                </a:solidFill>
-                <a:latin typeface="Arial" pitchFamily="34" charset="0"/>
-                <a:ea typeface="Arial" pitchFamily="34" charset="-122"/>
-                <a:cs typeface="Arial" pitchFamily="34" charset="-120"/>
-              </a:rPr>
-              <a:t>Decision-making is complex and heterogeneous.</a:t>
+              <a:t>Metabolomic analysis reveals mechanisms</a:t>
             </a:r>
             <a:endParaRPr lang="en-US" sz="1800" dirty="0"/>
           </a:p>
@@ -3395,7 +3311,7 @@
                   <a:srgbClr val="888888"/>
                 </a:solidFill>
               </a:rPr>
-              <a:t>Dalal Garima, Wright Stuart J, Malcomson Lee et al.. European journal of cancer (Oxford, England : 1990). 2026-04-10 DOI: 10.1016/j.ejca.2026.116589</a:t>
+              <a:t>J Ning, C Cai, X Fan. Journal of Pharmaceutical and …. 2026</a:t>
             </a:r>
             <a:endParaRPr lang="en-US" sz="800" dirty="0"/>
           </a:p>
@@ -3612,7 +3528,7 @@
                   <a:srgbClr val="FFFFFF"/>
                 </a:solidFill>
               </a:rPr>
-              <a:t>1. **腸道微生物與炎症關聯性**  </a:t>
+              <a:t>1. **腸道微生物與癌症的關聯**</a:t>
             </a:r>
             <a:endParaRPr lang="en-US" sz="1200" dirty="0"/>
           </a:p>
@@ -3629,7 +3545,7 @@
                   <a:srgbClr val="FFFFFF"/>
                 </a:solidFill>
               </a:rPr>
-              <a:t>   The study on *Parasutterella excrementihominis* highlights the significant role of gut microbiota in exacerbating colitis and colorectal cancer through pathogenic NETosis activation.  </a:t>
+              <a:t>   - The study of *Parasutterella excrementihominis* highlights the significant role of gut microbiota in exacerbating colitis and promoting colorectal cancer, suggesting that microbial interactions may be critical in cancer development.</a:t>
             </a:r>
             <a:endParaRPr lang="en-US" sz="1200" dirty="0"/>
           </a:p>
@@ -3646,7 +3562,7 @@
                   <a:srgbClr val="FFFFFF"/>
                 </a:solidFill>
               </a:rPr>
-              <a:t>   *對於炎症性腸病和結直腸癌的研究顯示，腸道微生物群在促進病理性NETosis活化方面具有重要作用。*</a:t>
+              <a:t>   - *Parasutterella excrementihominis*的研究突顯腸道微生物在加重結腸炎和促進結直腸癌中的重要角色，暗示微生物相互作用可能在癌症發展中至關重要。</a:t>
             </a:r>
             <a:endParaRPr lang="en-US" sz="1200" dirty="0"/>
           </a:p>
@@ -3672,7 +3588,7 @@
                   <a:srgbClr val="FFFFFF"/>
                 </a:solidFill>
               </a:rPr>
-              <a:t>2. **自體細胞系的建立與腫瘤微環境**  </a:t>
+              <a:t>2. **植物提取物的潛力**</a:t>
             </a:r>
             <a:endParaRPr lang="en-US" sz="1200" dirty="0"/>
           </a:p>
@@ -3689,7 +3605,7 @@
                   <a:srgbClr val="FFFFFF"/>
                 </a:solidFill>
               </a:rPr>
-              <a:t>   The establishment of autologous colorectal cancer and mesothelial stromal cell lines provides a novel model to study tumor-mesothelial interactions, revealing potential vulnerabilities in peritoneal metastasis.  </a:t>
+              <a:t>   - Cucurbitacin B's ability to target the ZNF70/NLRP3 axis offers promising therapeutic avenues for managing inflammation-associated colorectal cancer, demonstrating the potential of natural compounds in cancer treatment.</a:t>
             </a:r>
             <a:endParaRPr lang="en-US" sz="1200" dirty="0"/>
           </a:p>
@@ -3706,7 +3622,7 @@
                   <a:srgbClr val="FFFFFF"/>
                 </a:solidFill>
               </a:rPr>
-              <a:t>   *自體結直腸癌及間皮基質細胞系的建立提供了一個新模型，以研究腫瘤與間皮細胞的相互作用，揭示了腹膜轉移中的潛在脆弱性。*</a:t>
+              <a:t>   - Cucurbitacin B針對ZNF70/NLRP3軸的能力為管理與炎症相關的結直腸癌提供了有希望的治療途徑，顯示天然化合物在癌症治療中的潛力。</a:t>
             </a:r>
             <a:endParaRPr lang="en-US" sz="1200" dirty="0"/>
           </a:p>
@@ -3732,7 +3648,7 @@
                   <a:srgbClr val="FFFFFF"/>
                 </a:solidFill>
               </a:rPr>
-              <a:t>3. **治療策略的多樣性**  </a:t>
+              <a:t>3. **系統性免疫炎症指數的預測價值**</a:t>
             </a:r>
             <a:endParaRPr lang="en-US" sz="1200" dirty="0"/>
           </a:p>
@@ -3749,7 +3665,7 @@
                   <a:srgbClr val="FFFFFF"/>
                 </a:solidFill>
               </a:rPr>
-              <a:t>   Various studies indicate that dietary interventions and herbal treatments, like Dabupi decoction, may mitigate chemotherapy-induced side effects and enhance therapeutic outcomes in colorectal cancer.  </a:t>
+              <a:t>   - The systemic immune-inflammation index (SII) has emerged as a significant prognostic biomarker for colorectal cancer, indicating that immune response metrics can be crucial in predicting patient outcomes.</a:t>
             </a:r>
             <a:endParaRPr lang="en-US" sz="1200" dirty="0"/>
           </a:p>
@@ -3766,7 +3682,7 @@
                   <a:srgbClr val="FFFFFF"/>
                 </a:solidFill>
               </a:rPr>
-              <a:t>   *多項研究表明，飲食干預和草藥治療（如大補皮湯）可能減輕化療引起的副作用，並提高結直腸癌的治療效果。*</a:t>
+              <a:t>   - 系統性免疫炎症指數(SII)已成為結直腸癌的重要預後生物標誌，表明免疫反應指標在預測患者結果中的關鍵性。</a:t>
             </a:r>
             <a:endParaRPr lang="en-US" sz="1200" dirty="0"/>
           </a:p>
@@ -3792,7 +3708,7 @@
                   <a:srgbClr val="FFFFFF"/>
                 </a:solidFill>
               </a:rPr>
-              <a:t>4. **系統性免疫炎症指數的預測價值**  </a:t>
+              <a:t>4. **癌症疫苗的挑戰與機會**</a:t>
             </a:r>
             <a:endParaRPr lang="en-US" sz="1200" dirty="0"/>
           </a:p>
@@ -3809,7 +3725,7 @@
                   <a:srgbClr val="FFFFFF"/>
                 </a:solidFill>
               </a:rPr>
-              <a:t>   The systemic immune-inflammation index (SII) has emerged as a promising prognostic biomarker for colorectal cancer, emphasizing the importance of immune status in cancer prognosis.  </a:t>
+              <a:t>   - Research on immunogenic cell death and its implications for cancer vaccines reveals both the potential and the challenges in developing effective immunotherapies for colorectal cancer.</a:t>
             </a:r>
             <a:endParaRPr lang="en-US" sz="1200" dirty="0"/>
           </a:p>
@@ -3826,7 +3742,7 @@
                   <a:srgbClr val="FFFFFF"/>
                 </a:solidFill>
               </a:rPr>
-              <a:t>   *系統性免疫炎症指數（SII）已成為結直腸癌有前景的預測生物標記，強調了免疫狀態在癌症預後中的重要性。*</a:t>
+              <a:t>   - 關於免疫原性細胞死亡及其對癌症疫苗的影響的研究揭示了開發有效結直腸癌免疫療法的潛力與挑戰。</a:t>
             </a:r>
             <a:endParaRPr lang="en-US" sz="1200" dirty="0"/>
           </a:p>
@@ -3852,7 +3768,7 @@
                   <a:srgbClr val="FFFFFF"/>
                 </a:solidFill>
               </a:rPr>
-              <a:t>5. **患者對炎症性腸病風險的認識不足**  </a:t>
+              <a:t>5. **轉移性結直腸癌的治療新策略**</a:t>
             </a:r>
             <a:endParaRPr lang="en-US" sz="1200" dirty="0"/>
           </a:p>
@@ -3869,24 +3785,7 @@
                   <a:srgbClr val="FFFFFF"/>
                 </a:solidFill>
               </a:rPr>
-              <a:t>   There is a significant gap in awareness among patients with inflammatory bowel disease regarding their risk of colorectal cancer and its management, indicating a need for improved patient education.  </a:t>
-            </a:r>
-            <a:endParaRPr lang="en-US" sz="1200" dirty="0"/>
-          </a:p>
-          <a:p>
-            <a:pPr indent="0" marL="0">
-              <a:lnSpc>
-                <a:spcPct val="150000"/>
-              </a:lnSpc>
-              <a:buNone/>
-            </a:pPr>
-            <a:r>
-              <a:rPr lang="en-US" sz="1200" dirty="0">
-                <a:solidFill>
-                  <a:srgbClr val="FFFFFF"/>
-                </a:solidFill>
-              </a:rPr>
-              <a:t>   *炎症性腸病患者對結直腸癌風險及其管理的認識存在顯著差距，表明需要加強患者教育。*</a:t>
+              <a:t>   - The exploration of novel delivery systems, such as bilosomal nanocarriers for resveratrol, underscores the need for innovative approaches to enhance drug bioavailability in colorectal cancer treatment.</a:t>
             </a:r>
             <a:endParaRPr lang="en-US" sz="1200" dirty="0"/>
           </a:p>
@@ -4032,7 +3931,7 @@
                   <a:srgbClr val="FFFFFF"/>
                 </a:solidFill>
               </a:rPr>
-              <a:t>### 未來研究方向 (Future Research Directions)</a:t>
+              <a:t>- 探索如用於白藜蘆醇的雙層納米載體等新型給藥系統，強調了在結直腸癌治療中增強藥物生物利用度的創新方法的必要性。</a:t>
             </a:r>
             <a:endParaRPr lang="en-US" sz="1200" dirty="0"/>
           </a:p>
@@ -4058,7 +3957,7 @@
                   <a:srgbClr val="FFFFFF"/>
                 </a:solidFill>
               </a:rPr>
-              <a:t>1. **腸道微生物與癌症的機制研究**  </a:t>
+              <a:t>### 未來研究方向 (Future Research Directions)</a:t>
             </a:r>
             <a:endParaRPr lang="en-US" sz="1200" dirty="0"/>
           </a:p>
@@ -4069,14 +3968,6 @@
               </a:lnSpc>
               <a:buNone/>
             </a:pPr>
-            <a:r>
-              <a:rPr lang="en-US" sz="1200" dirty="0">
-                <a:solidFill>
-                  <a:srgbClr val="FFFFFF"/>
-                </a:solidFill>
-              </a:rPr>
-              <a:t>   Future studies should focus on elucidating the mechanisms by which gut microbiota influences inflammation and colorectal carcinogenesis, potentially leading to novel therapeutic targets.  </a:t>
-            </a:r>
             <a:endParaRPr lang="en-US" sz="1200" dirty="0"/>
           </a:p>
           <a:p>
@@ -4092,7 +3983,7 @@
                   <a:srgbClr val="FFFFFF"/>
                 </a:solidFill>
               </a:rPr>
-              <a:t>   *未來的研究應集中於闡明腸道微生物如何影響炎症和結直腸癌發生的機制，可能導致新的治療靶點。*</a:t>
+              <a:t>1. **微生物組與癌症的機制研究**</a:t>
             </a:r>
             <a:endParaRPr lang="en-US" sz="1200" dirty="0"/>
           </a:p>
@@ -4103,6 +3994,14 @@
               </a:lnSpc>
               <a:buNone/>
             </a:pPr>
+            <a:r>
+              <a:rPr lang="en-US" sz="1200" dirty="0">
+                <a:solidFill>
+                  <a:srgbClr val="FFFFFF"/>
+                </a:solidFill>
+              </a:rPr>
+              <a:t>   - Future studies should focus on elucidating the mechanisms by which gut microbiota influence inflammation and colorectal carcinogenesis, potentially leading to targeted microbiome therapies.</a:t>
+            </a:r>
             <a:endParaRPr lang="en-US" sz="1200" dirty="0"/>
           </a:p>
           <a:p>
@@ -4118,7 +4017,7 @@
                   <a:srgbClr val="FFFFFF"/>
                 </a:solidFill>
               </a:rPr>
-              <a:t>2. **腫瘤微環境的深入探討**  </a:t>
+              <a:t>   - 未來的研究應集中於闡明腸道微生物如何影響炎症和結直腸癌發生的機制，可能導致針對微生物組的治療。</a:t>
             </a:r>
             <a:endParaRPr lang="en-US" sz="1200" dirty="0"/>
           </a:p>
@@ -4129,14 +4028,6 @@
               </a:lnSpc>
               <a:buNone/>
             </a:pPr>
-            <a:r>
-              <a:rPr lang="en-US" sz="1200" dirty="0">
-                <a:solidFill>
-                  <a:srgbClr val="FFFFFF"/>
-                </a:solidFill>
-              </a:rPr>
-              <a:t>   Further exploration of tumor-mesothelial interactions using established cell lines can provide insights into the microenvironment's role in peritoneal metastasis and therapeutic resistance.  </a:t>
-            </a:r>
             <a:endParaRPr lang="en-US" sz="1200" dirty="0"/>
           </a:p>
           <a:p>
@@ -4152,7 +4043,7 @@
                   <a:srgbClr val="FFFFFF"/>
                 </a:solidFill>
               </a:rPr>
-              <a:t>   *進一步探討使用已建立的細胞系的腫瘤與間皮細胞相互作用，可以提供微環境在腹膜轉移和治療抵抗中的作用的見解。*</a:t>
+              <a:t>2. **天然化合物的臨床應用**</a:t>
             </a:r>
             <a:endParaRPr lang="en-US" sz="1200" dirty="0"/>
           </a:p>
@@ -4163,6 +4054,14 @@
               </a:lnSpc>
               <a:buNone/>
             </a:pPr>
+            <a:r>
+              <a:rPr lang="en-US" sz="1200" dirty="0">
+                <a:solidFill>
+                  <a:srgbClr val="FFFFFF"/>
+                </a:solidFill>
+              </a:rPr>
+              <a:t>   - Investigating the clinical efficacy and safety of natural compounds like Cucurbitacin B in diverse populations could provide insights into their therapeutic potential in colorectal cancer.</a:t>
+            </a:r>
             <a:endParaRPr lang="en-US" sz="1200" dirty="0"/>
           </a:p>
           <a:p>
@@ -4178,7 +4077,7 @@
                   <a:srgbClr val="FFFFFF"/>
                 </a:solidFill>
               </a:rPr>
-              <a:t>3. **整合多種治療策略**  </a:t>
+              <a:t>   - 研究天然化合物如Cucurbitacin B在不同人群中的臨床療效和安全性，可能為其在結直腸癌中的治療潛力提供見解。</a:t>
             </a:r>
             <a:endParaRPr lang="en-US" sz="1200" dirty="0"/>
           </a:p>
@@ -4189,14 +4088,6 @@
               </a:lnSpc>
               <a:buNone/>
             </a:pPr>
-            <a:r>
-              <a:rPr lang="en-US" sz="1200" dirty="0">
-                <a:solidFill>
-                  <a:srgbClr val="FFFFFF"/>
-                </a:solidFill>
-              </a:rPr>
-              <a:t>   Research should investigate the efficacy of combining dietary interventions and traditional herbal remedies with conventional therapies to enhance treatment outcomes in colorectal cancer.  </a:t>
-            </a:r>
             <a:endParaRPr lang="en-US" sz="1200" dirty="0"/>
           </a:p>
           <a:p>
@@ -4212,7 +4103,7 @@
                   <a:srgbClr val="FFFFFF"/>
                 </a:solidFill>
               </a:rPr>
-              <a:t>   *研究應調查將飲食干預和傳統草藥療法與常規治療相結合的有效性，以提高結直腸癌的治療效果。*</a:t>
+              <a:t>3. **整合免疫指標於預後模型**</a:t>
             </a:r>
             <a:endParaRPr lang="en-US" sz="1200" dirty="0"/>
           </a:p>
@@ -4223,6 +4114,14 @@
               </a:lnSpc>
               <a:buNone/>
             </a:pPr>
+            <a:r>
+              <a:rPr lang="en-US" sz="1200" dirty="0">
+                <a:solidFill>
+                  <a:srgbClr val="FFFFFF"/>
+                </a:solidFill>
+              </a:rPr>
+              <a:t>   - Integrating systemic immune-inflammation indices into existing prognostic models could enhance predictive accuracy for patient outcomes in colorectal cancer.</a:t>
+            </a:r>
             <a:endParaRPr lang="en-US" sz="1200" dirty="0"/>
           </a:p>
           <a:p>
@@ -4238,7 +4137,7 @@
                   <a:srgbClr val="FFFFFF"/>
                 </a:solidFill>
               </a:rPr>
-              <a:t>4. **患者教育與風險管理**  </a:t>
+              <a:t>   - 將系統性免疫炎症指數整合進現有的預後模型中，可能提高對結直腸癌患者結果的預測準確性。</a:t>
             </a:r>
             <a:endParaRPr lang="en-US" sz="1200" dirty="0"/>
           </a:p>
@@ -4249,14 +4148,6 @@
               </a:lnSpc>
               <a:buNone/>
             </a:pPr>
-            <a:r>
-              <a:rPr lang="en-US" sz="1200" dirty="0">
-                <a:solidFill>
-                  <a:srgbClr val="FFFFFF"/>
-                </a:solidFill>
-              </a:rPr>
-              <a:t>   Developing educational programs aimed at increasing awareness of colorectal cancer risks among patients with inflammatory bowel disease could improve early detection and management.  </a:t>
-            </a:r>
             <a:endParaRPr lang="en-US" sz="1200" dirty="0"/>
           </a:p>
           <a:p>
@@ -4272,7 +4163,7 @@
                   <a:srgbClr val="FFFFFF"/>
                 </a:solidFill>
               </a:rPr>
-              <a:t>   *開發旨在提高炎症性腸病患者對結直腸癌風險認識的教育計劃，可能改善早期檢測和管理。*</a:t>
+              <a:t>4. **新型疫苗策略的開發**</a:t>
             </a:r>
             <a:endParaRPr lang="en-US" sz="1200" dirty="0"/>
           </a:p>
@@ -4283,6 +4174,14 @@
               </a:lnSpc>
               <a:buNone/>
             </a:pPr>
+            <a:r>
+              <a:rPr lang="en-US" sz="1200" dirty="0">
+                <a:solidFill>
+                  <a:srgbClr val="FFFFFF"/>
+                </a:solidFill>
+              </a:rPr>
+              <a:t>   - Research should explore innovative vaccine strategies that enhance the efficacy of immunogenic cell death in colorectal cancer, focusing on overcoming current limitations.</a:t>
+            </a:r>
             <a:endParaRPr lang="en-US" sz="1200" dirty="0"/>
           </a:p>
           <a:p>
@@ -4298,7 +4197,7 @@
                   <a:srgbClr val="FFFFFF"/>
                 </a:solidFill>
               </a:rPr>
-              <a:t>5. **生物標記的臨床應用**  </a:t>
+              <a:t>   - 研究應探索增強免疫原性細胞死亡在結直腸癌中療效的新型疫苗策略，重點克服當前的限制。</a:t>
             </a:r>
             <a:endParaRPr lang="en-US" sz="1200" dirty="0"/>
           </a:p>
@@ -4309,14 +4208,6 @@
               </a:lnSpc>
               <a:buNone/>
             </a:pPr>
-            <a:r>
-              <a:rPr lang="en-US" sz="1200" dirty="0">
-                <a:solidFill>
-                  <a:srgbClr val="FFFFFF"/>
-                </a:solidFill>
-              </a:rPr>
-              <a:t>   Investigating the clinical applicability of the systemic immune-inflammation index and other biomarkers could refine prognostic assessments and personalized treatment approaches in colorectal cancer.  </a:t>
-            </a:r>
             <a:endParaRPr lang="en-US" sz="1200" dirty="0"/>
           </a:p>
           <a:p>
@@ -4332,7 +4223,41 @@
                   <a:srgbClr val="FFFFFF"/>
                 </a:solidFill>
               </a:rPr>
-              <a:t>   *研究系統性免疫炎症指數及其他生物標記的臨床應用，可能改善結直腸癌的預後評估和個性化治療方法。*</a:t>
+              <a:t>5. **針對轉移性癌症的新治療方法**</a:t>
+            </a:r>
+            <a:endParaRPr lang="en-US" sz="1200" dirty="0"/>
+          </a:p>
+          <a:p>
+            <a:pPr indent="0" marL="0">
+              <a:lnSpc>
+                <a:spcPct val="150000"/>
+              </a:lnSpc>
+              <a:buNone/>
+            </a:pPr>
+            <a:r>
+              <a:rPr lang="en-US" sz="1200" dirty="0">
+                <a:solidFill>
+                  <a:srgbClr val="FFFFFF"/>
+                </a:solidFill>
+              </a:rPr>
+              <a:t>   - Future investigations should aim at developing targeted therapies for peritoneal metastatic colorectal cancer, focusing on molecularly defined subgroups to improve treatment outcomes.</a:t>
+            </a:r>
+            <a:endParaRPr lang="en-US" sz="1200" dirty="0"/>
+          </a:p>
+          <a:p>
+            <a:pPr indent="0" marL="0">
+              <a:lnSpc>
+                <a:spcPct val="150000"/>
+              </a:lnSpc>
+              <a:buNone/>
+            </a:pPr>
+            <a:r>
+              <a:rPr lang="en-US" sz="1200" dirty="0">
+                <a:solidFill>
+                  <a:srgbClr val="FFFFFF"/>
+                </a:solidFill>
+              </a:rPr>
+              <a:t>   - 未來的研究應致力於為腹膜轉移性結直腸癌開發針對性的治療方法，專注於分子定義的亞組以改善治療結果。</a:t>
             </a:r>
             <a:endParaRPr lang="en-US" sz="1200" dirty="0"/>
           </a:p>
@@ -4603,7 +4528,7 @@
                 <a:ea typeface="Arial" pitchFamily="34" charset="-122"/>
                 <a:cs typeface="Arial" pitchFamily="34" charset="-120"/>
               </a:rPr>
-              <a:t>Simultaneous Establishment of Autologous Colorectal Cancer and Mesothelial Strom…</a:t>
+              <a:t>Mechanism of Cucurbitacin B Targeting ZNF70/NLRP3 Axis Against Inflammation-Asso…</a:t>
             </a:r>
             <a:endParaRPr lang="en-US" sz="1400" dirty="0"/>
           </a:p>
@@ -4640,7 +4565,7 @@
                 <a:ea typeface="Arial" pitchFamily="34" charset="-122"/>
                 <a:cs typeface="Arial" pitchFamily="34" charset="-120"/>
               </a:rPr>
-              <a:t>Dabupi decoction mitigates fluorouracil-induced intestinal mucositis via farneso…</a:t>
+              <a:t>Effect of hyperthermic intraperitoneal chemotherapy on patients with advanced co…</a:t>
             </a:r>
             <a:endParaRPr lang="en-US" sz="1400" dirty="0"/>
           </a:p>
@@ -4677,7 +4602,7 @@
                 <a:ea typeface="Arial" pitchFamily="34" charset="-122"/>
                 <a:cs typeface="Arial" pitchFamily="34" charset="-120"/>
               </a:rPr>
-              <a:t>The effects of dietary beef powder on the dextran sulfate sodium-induced colitis…</a:t>
+              <a:t>Prognostic value of systemic immune-inflammation index for colorectal cancer: a …</a:t>
             </a:r>
             <a:endParaRPr lang="en-US" sz="1400" dirty="0"/>
           </a:p>
@@ -4714,7 +4639,7 @@
                 <a:ea typeface="Arial" pitchFamily="34" charset="-122"/>
                 <a:cs typeface="Arial" pitchFamily="34" charset="-120"/>
               </a:rPr>
-              <a:t>Enhanced mRNA Expression of Colonic IL-6 in Cronkhite-Canada Syndrome Bearing Co…</a:t>
+              <a:t>Awareness of inflammatory bowel disease-associated colorectal cancer risk and it…</a:t>
             </a:r>
             <a:endParaRPr lang="en-US" sz="1400" dirty="0"/>
           </a:p>
@@ -4751,7 +4676,7 @@
                 <a:ea typeface="Arial" pitchFamily="34" charset="-122"/>
                 <a:cs typeface="Arial" pitchFamily="34" charset="-120"/>
               </a:rPr>
-              <a:t>A Cascade-Responsive AND-Logic-Activatable Nanoprobe for Intraoperative Fluoresc…</a:t>
+              <a:t>Immunogenic cell death-primed autophagosome vaccines drive dendritic cell cross-…</a:t>
             </a:r>
             <a:endParaRPr lang="en-US" sz="1400" dirty="0"/>
           </a:p>
@@ -4788,7 +4713,7 @@
                 <a:ea typeface="Arial" pitchFamily="34" charset="-122"/>
                 <a:cs typeface="Arial" pitchFamily="34" charset="-120"/>
               </a:rPr>
-              <a:t>Effect of hyperthermic intraperitoneal chemotherapy on patients with advanced co…</a:t>
+              <a:t>Engineering Bilosomal Nanocarriers for Targeted Delivery of Resveratrol: Rationa…</a:t>
             </a:r>
             <a:endParaRPr lang="en-US" sz="1400" dirty="0"/>
           </a:p>
@@ -4825,7 +4750,7 @@
                 <a:ea typeface="Arial" pitchFamily="34" charset="-122"/>
                 <a:cs typeface="Arial" pitchFamily="34" charset="-120"/>
               </a:rPr>
-              <a:t>Prognostic value of systemic immune-inflammation index for colorectal cancer: a …</a:t>
+              <a:t>… Cancer and Mesothelial Stromal Cell Lines from Malignant Ascites Reveals a Mes…</a:t>
             </a:r>
             <a:endParaRPr lang="en-US" sz="1400" dirty="0"/>
           </a:p>
@@ -4862,7 +4787,7 @@
                 <a:ea typeface="Arial" pitchFamily="34" charset="-122"/>
                 <a:cs typeface="Arial" pitchFamily="34" charset="-120"/>
               </a:rPr>
-              <a:t>Awareness of inflammatory bowel disease-associated colorectal cancer risk and it…</a:t>
+              <a:t>Repurposing PARP inhibitors in molecularly defined subgroups of peritoneal metas…</a:t>
             </a:r>
             <a:endParaRPr lang="en-US" sz="1400" dirty="0"/>
           </a:p>
@@ -4899,7 +4824,7 @@
                 <a:ea typeface="Arial" pitchFamily="34" charset="-122"/>
                 <a:cs typeface="Arial" pitchFamily="34" charset="-120"/>
               </a:rPr>
-              <a:t>Quantifying preferences for watch-and-wait compared with surgery after a clinica…</a:t>
+              <a:t>The Mechanism of Acetyl-L-Carnitine on Colorectal Cancer and Its Metabolomic Stu…</a:t>
             </a:r>
             <a:endParaRPr lang="en-US" sz="1400" dirty="0"/>
           </a:p>
@@ -5133,7 +5058,7 @@
                 <a:ea typeface="Arial" pitchFamily="34" charset="-122"/>
                 <a:cs typeface="Arial" pitchFamily="34" charset="-120"/>
               </a:rPr>
-              <a:t>Parasutterella excrementihominis role in colitis</a:t>
+              <a:t>P. excrementihominis worsens colitis severity.</a:t>
             </a:r>
             <a:endParaRPr lang="en-US" sz="1800" dirty="0"/>
           </a:p>
@@ -5154,7 +5079,7 @@
                 <a:ea typeface="Arial" pitchFamily="34" charset="-122"/>
                 <a:cs typeface="Arial" pitchFamily="34" charset="-120"/>
               </a:rPr>
-              <a:t>NETosis activation linked to cancer progression</a:t>
+              <a:t>Pathogenic NETosis activation observed.</a:t>
             </a:r>
             <a:endParaRPr lang="en-US" sz="1800" dirty="0"/>
           </a:p>
@@ -5175,7 +5100,7 @@
                 <a:ea typeface="Arial" pitchFamily="34" charset="-122"/>
                 <a:cs typeface="Arial" pitchFamily="34" charset="-120"/>
               </a:rPr>
-              <a:t>Potential therapeutic strategies identified</a:t>
+              <a:t>Potential link to colorectal cancer.</a:t>
             </a:r>
             <a:endParaRPr lang="en-US" sz="1800" dirty="0"/>
           </a:p>
@@ -5411,7 +5336,7 @@
                   </a:extLst>
                 </a:hlinkClick>
               </a:rPr>
-              <a:t>Simultaneous Establishment of Autologous Colorectal Cancer and Mesothelial Stromal Cell Lines from Malignant Ascites Reveals a Mesothelial-Stromal FGFR3 Axis as a Potential Vulnerability in Peritoneal Metastasis.</a:t>
+              <a:t>Mechanism of Cucurbitacin B Targeting ZNF70/NLRP3 Axis Against Inflammation-Associated Colorectal Cancer.</a:t>
             </a:r>
             <a:endParaRPr lang="en-US" sz="2400" dirty="0"/>
           </a:p>
@@ -5447,7 +5372,7 @@
                   <a:srgbClr val="888888"/>
                 </a:solidFill>
               </a:rPr>
-              <a:t>Cancer medicine  ·  IF 4.7  ·  Basic Research  ·  🌏 Asia</a:t>
+              <a:t>Phytotherapy research : PTR  ·  Basic Research  ·  🌏 Asia</a:t>
             </a:r>
             <a:endParaRPr lang="en-US" sz="1000" dirty="0"/>
           </a:p>
@@ -5490,7 +5415,7 @@
                 <a:ea typeface="Arial" pitchFamily="34" charset="-122"/>
                 <a:cs typeface="Arial" pitchFamily="34" charset="-120"/>
               </a:rPr>
-              <a:t>Established autologous CRC and mesothelial cell lines.</a:t>
+              <a:t>Cucurbitacin B targets ZNF70/NLRP3 axis.</a:t>
             </a:r>
             <a:endParaRPr lang="en-US" sz="1800" dirty="0"/>
           </a:p>
@@ -5511,7 +5436,7 @@
                 <a:ea typeface="Arial" pitchFamily="34" charset="-122"/>
                 <a:cs typeface="Arial" pitchFamily="34" charset="-120"/>
               </a:rPr>
-              <a:t>OMUCR-1 shows strong tumorigenic capacity.</a:t>
+              <a:t>Reduces inflammation-associated CRC progression.</a:t>
             </a:r>
             <a:endParaRPr lang="en-US" sz="1800" dirty="0"/>
           </a:p>
@@ -5532,49 +5457,7 @@
                 <a:ea typeface="Arial" pitchFamily="34" charset="-122"/>
                 <a:cs typeface="Arial" pitchFamily="34" charset="-120"/>
               </a:rPr>
-              <a:t>CAmeso enhances CRC cell migration and invasion.</a:t>
-            </a:r>
-            <a:endParaRPr lang="en-US" sz="1800" dirty="0"/>
-          </a:p>
-          <a:p>
-            <a:pPr marL="342900" indent="-342900">
-              <a:spcAft>
-                <a:spcPts val="800"/>
-              </a:spcAft>
-              <a:buSzPct val="100000"/>
-              <a:buChar char="•"/>
-            </a:pPr>
-            <a:r>
-              <a:rPr lang="en-US" sz="1800" dirty="0">
-                <a:solidFill>
-                  <a:srgbClr val="333333"/>
-                </a:solidFill>
-                <a:latin typeface="Arial" pitchFamily="34" charset="0"/>
-                <a:ea typeface="Arial" pitchFamily="34" charset="-122"/>
-                <a:cs typeface="Arial" pitchFamily="34" charset="-120"/>
-              </a:rPr>
-              <a:t>FGFR3 identified as potential therapeutic target.</a:t>
-            </a:r>
-            <a:endParaRPr lang="en-US" sz="1800" dirty="0"/>
-          </a:p>
-          <a:p>
-            <a:pPr marL="342900" indent="-342900">
-              <a:spcAft>
-                <a:spcPts val="800"/>
-              </a:spcAft>
-              <a:buSzPct val="100000"/>
-              <a:buChar char="•"/>
-            </a:pPr>
-            <a:r>
-              <a:rPr lang="en-US" sz="1800" dirty="0">
-                <a:solidFill>
-                  <a:srgbClr val="333333"/>
-                </a:solidFill>
-                <a:latin typeface="Arial" pitchFamily="34" charset="0"/>
-                <a:ea typeface="Arial" pitchFamily="34" charset="-122"/>
-                <a:cs typeface="Arial" pitchFamily="34" charset="-120"/>
-              </a:rPr>
-              <a:t>Model aids in studying tumor-stroma interactions.</a:t>
+              <a:t>Non-toxic to major organs in mice.</a:t>
             </a:r>
             <a:endParaRPr lang="en-US" sz="1800" dirty="0"/>
           </a:p>
@@ -5610,7 +5493,7 @@
                   <a:srgbClr val="888888"/>
                 </a:solidFill>
               </a:rPr>
-              <a:t>Fukui Yasuhiro, Kasashima Hiroaki, Wang Zizhou et al.. Cancer medicine. 2026-04-25 DOI: 10.1002/cam4.71804</a:t>
+              <a:t>Cao Shen, Tai Yi, Wang Yuhan et al.. Phytotherapy research : PTR. 2026-05-09 DOI: 10.1002/ptr.70329</a:t>
             </a:r>
             <a:endParaRPr lang="en-US" sz="800" dirty="0"/>
           </a:p>
@@ -5810,7 +5693,7 @@
                   </a:extLst>
                 </a:hlinkClick>
               </a:rPr>
-              <a:t>Dabupi decoction mitigates fluorouracil-induced intestinal mucositis via farnesoid X receptor activation and dihydropyrimidine dehydrogenase upregulation.</a:t>
+              <a:t>Effect of hyperthermic intraperitoneal chemotherapy on patients with advanced colorectal cancer: a systematic review and meta-analysis</a:t>
             </a:r>
             <a:endParaRPr lang="en-US" sz="2400" dirty="0"/>
           </a:p>
@@ -5846,7 +5729,7 @@
                   <a:srgbClr val="888888"/>
                 </a:solidFill>
               </a:rPr>
-              <a:t>Journal of ethnopharmacology  ·  Basic Research  ·  🌏 Asia</a:t>
+              <a:t>World Journal of …  ·  Meta-Analysis</a:t>
             </a:r>
             <a:endParaRPr lang="en-US" sz="1000" dirty="0"/>
           </a:p>
@@ -5889,7 +5772,7 @@
                 <a:ea typeface="Arial" pitchFamily="34" charset="-122"/>
                 <a:cs typeface="Arial" pitchFamily="34" charset="-120"/>
               </a:rPr>
-              <a:t>5-FU causes intestinal mucositis toxicity.</a:t>
+              <a:t>Hyperthermic intraperitoneal chemotherapy (HIPEC) evaluated</a:t>
             </a:r>
             <a:endParaRPr lang="en-US" sz="1800" dirty="0"/>
           </a:p>
@@ -5910,7 +5793,7 @@
                 <a:ea typeface="Arial" pitchFamily="34" charset="-122"/>
                 <a:cs typeface="Arial" pitchFamily="34" charset="-120"/>
               </a:rPr>
-              <a:t>DBPD activates FXR and upregulates DPYD.</a:t>
+              <a:t>Systematic review and meta-analysis conducted</a:t>
             </a:r>
             <a:endParaRPr lang="en-US" sz="1800" dirty="0"/>
           </a:p>
@@ -5931,7 +5814,7 @@
                 <a:ea typeface="Arial" pitchFamily="34" charset="-122"/>
                 <a:cs typeface="Arial" pitchFamily="34" charset="-120"/>
               </a:rPr>
-              <a:t>Bile acid metabolism is disrupted by 5-FU.</a:t>
+              <a:t>Focus on advanced colorectal cancer patients</a:t>
             </a:r>
             <a:endParaRPr lang="en-US" sz="1800" dirty="0"/>
           </a:p>
@@ -5952,7 +5835,7 @@
                 <a:ea typeface="Arial" pitchFamily="34" charset="-122"/>
                 <a:cs typeface="Arial" pitchFamily="34" charset="-120"/>
               </a:rPr>
-              <a:t>DBPD improves intestinal barrier integrity.</a:t>
+              <a:t>Impact on peritoneal metastases assessed</a:t>
             </a:r>
             <a:endParaRPr lang="en-US" sz="1800" dirty="0"/>
           </a:p>
@@ -5973,7 +5856,7 @@
                 <a:ea typeface="Arial" pitchFamily="34" charset="-122"/>
                 <a:cs typeface="Arial" pitchFamily="34" charset="-120"/>
               </a:rPr>
-              <a:t>Low UGT1A1/FXR levels link to poor prognosis.</a:t>
+              <a:t>Clinical outcomes and survival rates analyzed</a:t>
             </a:r>
             <a:endParaRPr lang="en-US" sz="1800" dirty="0"/>
           </a:p>
@@ -6009,7 +5892,7 @@
                   <a:srgbClr val="888888"/>
                 </a:solidFill>
               </a:rPr>
-              <a:t>Wang ShunZhi, Li Yaling, Ma Jing et al.. Journal of ethnopharmacology. 2026-05-03 DOI: 10.1016/j.jep.2026.121742</a:t>
+              <a:t>Z Su, Y Guo, X Ru. World Journal of …. 2026</a:t>
             </a:r>
             <a:endParaRPr lang="en-US" sz="800" dirty="0"/>
           </a:p>
@@ -6209,7 +6092,7 @@
                   </a:extLst>
                 </a:hlinkClick>
               </a:rPr>
-              <a:t>The effects of dietary beef powder on the dextran sulfate sodium-induced colitis in a mouse model through COX-2 pathway.</a:t>
+              <a:t>Prognostic value of systemic immune-inflammation index for colorectal cancer: a systematic review and meta-analysis</a:t>
             </a:r>
             <a:endParaRPr lang="en-US" sz="2400" dirty="0"/>
           </a:p>
@@ -6245,7 +6128,7 @@
                   <a:srgbClr val="888888"/>
                 </a:solidFill>
               </a:rPr>
-              <a:t>Food science of animal resources  ·  Basic Research  ·  🌏 Asia</a:t>
+              <a:t>Frontiers in Oncology  ·  Meta-Analysis</a:t>
             </a:r>
             <a:endParaRPr lang="en-US" sz="1000" dirty="0"/>
           </a:p>
@@ -6288,7 +6171,7 @@
                 <a:ea typeface="Arial" pitchFamily="34" charset="-122"/>
                 <a:cs typeface="Arial" pitchFamily="34" charset="-120"/>
               </a:rPr>
-              <a:t>Beef powder shows anti-inflammatory effects.</a:t>
+              <a:t>Systemic immune-inflammation index (SII) evaluated</a:t>
             </a:r>
             <a:endParaRPr lang="en-US" sz="1800" dirty="0"/>
           </a:p>
@@ -6309,7 +6192,7 @@
                 <a:ea typeface="Arial" pitchFamily="34" charset="-122"/>
                 <a:cs typeface="Arial" pitchFamily="34" charset="-120"/>
               </a:rPr>
-              <a:t>20% HR beef powder reduces colitis severity.</a:t>
+              <a:t>SII as a prognostic biomarker in CRC</a:t>
             </a:r>
             <a:endParaRPr lang="en-US" sz="1800" dirty="0"/>
           </a:p>
@@ -6330,49 +6213,7 @@
                 <a:ea typeface="Arial" pitchFamily="34" charset="-122"/>
                 <a:cs typeface="Arial" pitchFamily="34" charset="-120"/>
               </a:rPr>
-              <a:t>Supplementation lowers triglycerides and cholesterol.</a:t>
-            </a:r>
-            <a:endParaRPr lang="en-US" sz="1800" dirty="0"/>
-          </a:p>
-          <a:p>
-            <a:pPr marL="342900" indent="-342900">
-              <a:spcAft>
-                <a:spcPts val="800"/>
-              </a:spcAft>
-              <a:buSzPct val="100000"/>
-              <a:buChar char="•"/>
-            </a:pPr>
-            <a:r>
-              <a:rPr lang="en-US" sz="1800" dirty="0">
-                <a:solidFill>
-                  <a:srgbClr val="333333"/>
-                </a:solidFill>
-                <a:latin typeface="Arial" pitchFamily="34" charset="0"/>
-                <a:ea typeface="Arial" pitchFamily="34" charset="-122"/>
-                <a:cs typeface="Arial" pitchFamily="34" charset="-120"/>
-              </a:rPr>
-              <a:t>COX-2 expression decreased in treated mice.</a:t>
-            </a:r>
-            <a:endParaRPr lang="en-US" sz="1800" dirty="0"/>
-          </a:p>
-          <a:p>
-            <a:pPr marL="342900" indent="-342900">
-              <a:spcAft>
-                <a:spcPts val="800"/>
-              </a:spcAft>
-              <a:buSzPct val="100000"/>
-              <a:buChar char="•"/>
-            </a:pPr>
-            <a:r>
-              <a:rPr lang="en-US" sz="1800" dirty="0">
-                <a:solidFill>
-                  <a:srgbClr val="333333"/>
-                </a:solidFill>
-                <a:latin typeface="Arial" pitchFamily="34" charset="0"/>
-                <a:ea typeface="Arial" pitchFamily="34" charset="-122"/>
-                <a:cs typeface="Arial" pitchFamily="34" charset="-120"/>
-              </a:rPr>
-              <a:t>Oxidative stress alleviated in colonic tissue.</a:t>
+              <a:t>Meta-analysis of existing studies conducted</a:t>
             </a:r>
             <a:endParaRPr lang="en-US" sz="1800" dirty="0"/>
           </a:p>
@@ -6408,7 +6249,7 @@
                   <a:srgbClr val="888888"/>
                 </a:solidFill>
               </a:rPr>
-              <a:t>Kim Hye-Jin, Kim Dongwook, Jang Aera. Food science of animal resources. 2026-04-28 DOI: 10.1007/s44463-025-00054-5</a:t>
+              <a:t>P Wang, H Jiang. Frontiers in Oncology. 2026</a:t>
             </a:r>
             <a:endParaRPr lang="en-US" sz="800" dirty="0"/>
           </a:p>
@@ -6608,7 +6449,7 @@
                   </a:extLst>
                 </a:hlinkClick>
               </a:rPr>
-              <a:t>Enhanced mRNA Expression of Colonic IL-6 in Cronkhite-Canada Syndrome Bearing Colorectal Cancer.</a:t>
+              <a:t>Awareness of inflammatory bowel disease-associated colorectal cancer risk and its management in patients with inflammatory bowel disease: a systematic review</a:t>
             </a:r>
             <a:endParaRPr lang="en-US" sz="2400" dirty="0"/>
           </a:p>
@@ -6644,7 +6485,7 @@
                   <a:srgbClr val="888888"/>
                 </a:solidFill>
               </a:rPr>
-              <a:t>In vivo (Athens, Greece)  ·  🌏 Asia</a:t>
+              <a:t>Crohns &amp; Colitis 360  ·  Systematic Review</a:t>
             </a:r>
             <a:endParaRPr lang="en-US" sz="1000" dirty="0"/>
           </a:p>
@@ -6687,7 +6528,7 @@
                 <a:ea typeface="Arial" pitchFamily="34" charset="-122"/>
                 <a:cs typeface="Arial" pitchFamily="34" charset="-120"/>
               </a:rPr>
-              <a:t>CCS improves with immunosuppressive treatments.</a:t>
+              <a:t>Limited awareness of cancer risk</a:t>
             </a:r>
             <a:endParaRPr lang="en-US" sz="1800" dirty="0"/>
           </a:p>
@@ -6708,7 +6549,7 @@
                 <a:ea typeface="Arial" pitchFamily="34" charset="-122"/>
                 <a:cs typeface="Arial" pitchFamily="34" charset="-120"/>
               </a:rPr>
-              <a:t>CCS polyps include various types.</a:t>
+              <a:t>Need for better patient education</a:t>
             </a:r>
             <a:endParaRPr lang="en-US" sz="1800" dirty="0"/>
           </a:p>
@@ -6729,7 +6570,7 @@
                 <a:ea typeface="Arial" pitchFamily="34" charset="-122"/>
                 <a:cs typeface="Arial" pitchFamily="34" charset="-120"/>
               </a:rPr>
-              <a:t>IL-6 expression linked to CRC development.</a:t>
+              <a:t>Research gaps in management strategies</a:t>
             </a:r>
             <a:endParaRPr lang="en-US" sz="1800" dirty="0"/>
           </a:p>
@@ -6765,7 +6606,7 @@
                   <a:srgbClr val="888888"/>
                 </a:solidFill>
               </a:rPr>
-              <a:t>Fujihara Daisuke, Honjo Hajime, Masuta Yasuhiro et al.. In vivo (Athens, Greece). 2026-04-28 DOI: 10.21873/invivo.14334</a:t>
+              <a:t>F Khan, C Norton, W Czuber-Dochan. Crohns &amp; Colitis 360. 2026</a:t>
             </a:r>
             <a:endParaRPr lang="en-US" sz="800" dirty="0"/>
           </a:p>
@@ -6965,7 +6806,7 @@
                   </a:extLst>
                 </a:hlinkClick>
               </a:rPr>
-              <a:t>A Cascade-Responsive AND-Logic-Activatable Nanoprobe for Intraoperative Fluorescence Imaging of Colorectal Cancer.</a:t>
+              <a:t>Immunogenic cell death-primed autophagosome vaccines drive dendritic cell cross-presentation and suppress colon cancer metastasis.</a:t>
             </a:r>
             <a:endParaRPr lang="en-US" sz="2400" dirty="0"/>
           </a:p>
@@ -7001,7 +6842,7 @@
                   <a:srgbClr val="888888"/>
                 </a:solidFill>
               </a:rPr>
-              <a:t>Journal of the American Chemical Society  ·  🌏 Asia</a:t>
+              <a:t>Journal of controlled release : official journal of the Controlled Release Society  ·  Basic Research</a:t>
             </a:r>
             <a:endParaRPr lang="en-US" sz="1000" dirty="0"/>
           </a:p>
@@ -7044,7 +6885,7 @@
                 <a:ea typeface="Arial" pitchFamily="34" charset="-122"/>
                 <a:cs typeface="Arial" pitchFamily="34" charset="-120"/>
               </a:rPr>
-              <a:t>duNP-DA enhances intraoperative imaging</a:t>
+              <a:t>ICD enhances tumor antigen release</a:t>
             </a:r>
             <a:endParaRPr lang="en-US" sz="1800" dirty="0"/>
           </a:p>
@@ -7065,7 +6906,7 @@
                 <a:ea typeface="Arial" pitchFamily="34" charset="-122"/>
                 <a:cs typeface="Arial" pitchFamily="34" charset="-120"/>
               </a:rPr>
-              <a:t>Utilizes acidic tumor microenvironment for activation</a:t>
+              <a:t>ICAPs improve dendritic cell cross-presentation</a:t>
             </a:r>
             <a:endParaRPr lang="en-US" sz="1800" dirty="0"/>
           </a:p>
@@ -7086,7 +6927,7 @@
                 <a:ea typeface="Arial" pitchFamily="34" charset="-122"/>
                 <a:cs typeface="Arial" pitchFamily="34" charset="-120"/>
               </a:rPr>
-              <a:t>Achieves high tumor-to-background ratio</a:t>
+              <a:t>90% tumor clearance in mouse model</a:t>
             </a:r>
             <a:endParaRPr lang="en-US" sz="1800" dirty="0"/>
           </a:p>
@@ -7107,7 +6948,7 @@
                 <a:ea typeface="Arial" pitchFamily="34" charset="-122"/>
                 <a:cs typeface="Arial" pitchFamily="34" charset="-120"/>
               </a:rPr>
-              <a:t>Delineates lesions as small as 2 mm</a:t>
+              <a:t>Boosts CD8+ T cell immunity</a:t>
             </a:r>
             <a:endParaRPr lang="en-US" sz="1800" dirty="0"/>
           </a:p>
@@ -7128,7 +6969,7 @@
                 <a:ea typeface="Arial" pitchFamily="34" charset="-122"/>
                 <a:cs typeface="Arial" pitchFamily="34" charset="-120"/>
               </a:rPr>
-              <a:t>100% diagnostic sensitivity and specificity</a:t>
+              <a:t>Potential for personalized cancer vaccines</a:t>
             </a:r>
             <a:endParaRPr lang="en-US" sz="1800" dirty="0"/>
           </a:p>
@@ -7164,7 +7005,7 @@
                   <a:srgbClr val="888888"/>
                 </a:solidFill>
               </a:rPr>
-              <a:t>Fang Leyi, Ishigaki Yusuke, Huang Weijing et al.. Journal of the American Chemical Society. 2026-04-29 DOI: 10.1021/jacs.6c04349</a:t>
+              <a:t>Xu Hongbo, Zhao Siyu, Shi Tianzi et al.. Journal of controlled release : official journal of the Controlled Release Society. 2026-04-03 DOI: 10.1016/j.jconrel.2026.114827</a:t>
             </a:r>
             <a:endParaRPr lang="en-US" sz="800" dirty="0"/>
           </a:p>
@@ -7364,7 +7205,7 @@
                   </a:extLst>
                 </a:hlinkClick>
               </a:rPr>
-              <a:t>Effect of hyperthermic intraperitoneal chemotherapy on patients with advanced colorectal cancer: a systematic review and meta-analysis</a:t>
+              <a:t>Engineering Bilosomal Nanocarriers for Targeted Delivery of Resveratrol: Rational Design, Radiotracking Insights and Cytotoxic Assessment.</a:t>
             </a:r>
             <a:endParaRPr lang="en-US" sz="2400" dirty="0"/>
           </a:p>
@@ -7400,7 +7241,7 @@
                   <a:srgbClr val="888888"/>
                 </a:solidFill>
               </a:rPr>
-              <a:t>World Journal of …  ·  Meta-Analysis</a:t>
+              <a:t>AAPS PharmSciTech  ·  Basic Research</a:t>
             </a:r>
             <a:endParaRPr lang="en-US" sz="1000" dirty="0"/>
           </a:p>
@@ -7443,7 +7284,7 @@
                 <a:ea typeface="Arial" pitchFamily="34" charset="-122"/>
                 <a:cs typeface="Arial" pitchFamily="34" charset="-120"/>
               </a:rPr>
-              <a:t>Hyperthermic intraperitoneal chemotherapy (HIPEC) evaluated</a:t>
+              <a:t>Resveratrol suffers from poor solubility.</a:t>
             </a:r>
             <a:endParaRPr lang="en-US" sz="1800" dirty="0"/>
           </a:p>
@@ -7464,7 +7305,7 @@
                 <a:ea typeface="Arial" pitchFamily="34" charset="-122"/>
                 <a:cs typeface="Arial" pitchFamily="34" charset="-120"/>
               </a:rPr>
-              <a:t>Systematic review and meta-analysis conducted</a:t>
+              <a:t>Bilosomes enhanced tumor accumulation significantly.</a:t>
             </a:r>
             <a:endParaRPr lang="en-US" sz="1800" dirty="0"/>
           </a:p>
@@ -7485,49 +7326,7 @@
                 <a:ea typeface="Arial" pitchFamily="34" charset="-122"/>
                 <a:cs typeface="Arial" pitchFamily="34" charset="-120"/>
               </a:rPr>
-              <a:t>Focus on advanced colorectal cancer patients</a:t>
-            </a:r>
-            <a:endParaRPr lang="en-US" sz="1800" dirty="0"/>
-          </a:p>
-          <a:p>
-            <a:pPr marL="342900" indent="-342900">
-              <a:spcAft>
-                <a:spcPts val="800"/>
-              </a:spcAft>
-              <a:buSzPct val="100000"/>
-              <a:buChar char="•"/>
-            </a:pPr>
-            <a:r>
-              <a:rPr lang="en-US" sz="1800" dirty="0">
-                <a:solidFill>
-                  <a:srgbClr val="333333"/>
-                </a:solidFill>
-                <a:latin typeface="Arial" pitchFamily="34" charset="0"/>
-                <a:ea typeface="Arial" pitchFamily="34" charset="-122"/>
-                <a:cs typeface="Arial" pitchFamily="34" charset="-120"/>
-              </a:rPr>
-              <a:t>Impact on peritoneal metastases assessed</a:t>
-            </a:r>
-            <a:endParaRPr lang="en-US" sz="1800" dirty="0"/>
-          </a:p>
-          <a:p>
-            <a:pPr marL="342900" indent="-342900">
-              <a:spcAft>
-                <a:spcPts val="800"/>
-              </a:spcAft>
-              <a:buSzPct val="100000"/>
-              <a:buChar char="•"/>
-            </a:pPr>
-            <a:r>
-              <a:rPr lang="en-US" sz="1800" dirty="0">
-                <a:solidFill>
-                  <a:srgbClr val="333333"/>
-                </a:solidFill>
-                <a:latin typeface="Arial" pitchFamily="34" charset="0"/>
-                <a:ea typeface="Arial" pitchFamily="34" charset="-122"/>
-                <a:cs typeface="Arial" pitchFamily="34" charset="-120"/>
-              </a:rPr>
-              <a:t>Findings suggest potential survival benefits</a:t>
+              <a:t>Radiotracking enabled precise biodistribution measurement.</a:t>
             </a:r>
             <a:endParaRPr lang="en-US" sz="1800" dirty="0"/>
           </a:p>
@@ -7563,7 +7362,7 @@
                   <a:srgbClr val="888888"/>
                 </a:solidFill>
               </a:rPr>
-              <a:t>Z Su, Y Guo, X Ru. World Journal of …. 2026</a:t>
+              <a:t>Attallah Khaled M, Hatem Shymaa, Sayyed Marwa Eid. AAPS PharmSciTech. 2026-05-07 DOI: 10.1208/s12249-026-03441-3</a:t>
             </a:r>
             <a:endParaRPr lang="en-US" sz="800" dirty="0"/>
           </a:p>

</xml_diff>

<commit_message>
chore: update weekly digest 2026-05-18
</commit_message>
<xml_diff>
--- a/docs/digest-en.pptx
+++ b/docs/digest-en.pptx
@@ -2249,7 +2249,7 @@
                   <a:srgbClr val="888888"/>
                 </a:solidFill>
               </a:rPr>
-              <a:t>2026-05-04 — 2026-05-11</a:t>
+              <a:t>2026-05-11 — 2026-05-18</a:t>
             </a:r>
             <a:endParaRPr lang="en-US" sz="1400" dirty="0"/>
           </a:p>
@@ -2440,7 +2440,7 @@
                   </a:extLst>
                 </a:hlinkClick>
               </a:rPr>
-              <a:t>… Cancer and Mesothelial Stromal Cell Lines from Malignant Ascites Reveals a Mesothelial‐Stromal FGFR3 Axis as a Potential Vulnerability in Peritoneal Metastasis</a:t>
+              <a:t>The mechanism of acetyl-L-carnitine on colorectal cancer and its metabolomic study.</a:t>
             </a:r>
             <a:endParaRPr lang="en-US" sz="2400" dirty="0"/>
           </a:p>
@@ -2476,7 +2476,7 @@
                   <a:srgbClr val="888888"/>
                 </a:solidFill>
               </a:rPr>
-              <a:t>Cancer …  ·  Basic Research</a:t>
+              <a:t>Journal of pharmaceutical and biomedical analysis  ·  Basic Research</a:t>
             </a:r>
             <a:endParaRPr lang="en-US" sz="1000" dirty="0"/>
           </a:p>
@@ -2519,7 +2519,7 @@
                 <a:ea typeface="Arial" pitchFamily="34" charset="-122"/>
                 <a:cs typeface="Arial" pitchFamily="34" charset="-120"/>
               </a:rPr>
-              <a:t>Colorectal cancer poses treatment challenges.</a:t>
+              <a:t>ALC inhibits HCT116 cell proliferation and migration.</a:t>
             </a:r>
             <a:endParaRPr lang="en-US" sz="1800" dirty="0"/>
           </a:p>
@@ -2540,7 +2540,7 @@
                 <a:ea typeface="Arial" pitchFamily="34" charset="-122"/>
                 <a:cs typeface="Arial" pitchFamily="34" charset="-120"/>
               </a:rPr>
-              <a:t>Mesothelial-stromal FGFR3 axis identified.</a:t>
+              <a:t>Induces cell cycle arrest and apoptosis.</a:t>
             </a:r>
             <a:endParaRPr lang="en-US" sz="1800" dirty="0"/>
           </a:p>
@@ -2561,7 +2561,49 @@
                 <a:ea typeface="Arial" pitchFamily="34" charset="-122"/>
                 <a:cs typeface="Arial" pitchFamily="34" charset="-120"/>
               </a:rPr>
-              <a:t>Potential vulnerability in peritoneal metastasis.</a:t>
+              <a:t>Suppresses colorectal tumor growth in vivo.</a:t>
+            </a:r>
+            <a:endParaRPr lang="en-US" sz="1800" dirty="0"/>
+          </a:p>
+          <a:p>
+            <a:pPr marL="342900" indent="-342900">
+              <a:spcAft>
+                <a:spcPts val="800"/>
+              </a:spcAft>
+              <a:buSzPct val="100000"/>
+              <a:buChar char="•"/>
+            </a:pPr>
+            <a:r>
+              <a:rPr lang="en-US" sz="1800" dirty="0">
+                <a:solidFill>
+                  <a:srgbClr val="333333"/>
+                </a:solidFill>
+                <a:latin typeface="Arial" pitchFamily="34" charset="0"/>
+                <a:ea typeface="Arial" pitchFamily="34" charset="-122"/>
+                <a:cs typeface="Arial" pitchFamily="34" charset="-120"/>
+              </a:rPr>
+              <a:t>Identified 10 differential metabolites in plasma.</a:t>
+            </a:r>
+            <a:endParaRPr lang="en-US" sz="1800" dirty="0"/>
+          </a:p>
+          <a:p>
+            <a:pPr marL="342900" indent="-342900">
+              <a:spcAft>
+                <a:spcPts val="800"/>
+              </a:spcAft>
+              <a:buSzPct val="100000"/>
+              <a:buChar char="•"/>
+            </a:pPr>
+            <a:r>
+              <a:rPr lang="en-US" sz="1800" dirty="0">
+                <a:solidFill>
+                  <a:srgbClr val="333333"/>
+                </a:solidFill>
+                <a:latin typeface="Arial" pitchFamily="34" charset="0"/>
+                <a:ea typeface="Arial" pitchFamily="34" charset="-122"/>
+                <a:cs typeface="Arial" pitchFamily="34" charset="-120"/>
+              </a:rPr>
+              <a:t>ALC alters multiple metabolic pathways.</a:t>
             </a:r>
             <a:endParaRPr lang="en-US" sz="1800" dirty="0"/>
           </a:p>
@@ -2597,7 +2639,7 @@
                   <a:srgbClr val="888888"/>
                 </a:solidFill>
               </a:rPr>
-              <a:t>Y Fukui, H Kasashima, Z Wang. Cancer …. 2026</a:t>
+              <a:t>Ning Jiayu, Cai Cuixin, Fan Xingxing et al.. Journal of pharmaceutical and biomedical analysis. 2026-02-09 DOI: 10.1016/j.jpba.2026.117363</a:t>
             </a:r>
             <a:endParaRPr lang="en-US" sz="800" dirty="0"/>
           </a:p>
@@ -2797,7 +2839,7 @@
                   </a:extLst>
                 </a:hlinkClick>
               </a:rPr>
-              <a:t>Repurposing PARP inhibitors in molecularly defined subgroups of peritoneal metastatic colorectal cancer (pmCRC): Preclinical analysis of patient-derived xenograft …</a:t>
+              <a:t>… Cancer and Mesothelial Stromal Cell Lines from Malignant Ascites Reveals a Mesothelial‐Stromal FGFR3 Axis as a Potential Vulnerability in Peritoneal Metastasis</a:t>
             </a:r>
             <a:endParaRPr lang="en-US" sz="2400" dirty="0"/>
           </a:p>
@@ -2876,7 +2918,7 @@
                 <a:ea typeface="Arial" pitchFamily="34" charset="-122"/>
                 <a:cs typeface="Arial" pitchFamily="34" charset="-120"/>
               </a:rPr>
-              <a:t>pmCRC shows poor prognosis compared to other metastases.</a:t>
+              <a:t>Colorectal cancer with peritoneal dissemination</a:t>
             </a:r>
             <a:endParaRPr lang="en-US" sz="1800" dirty="0"/>
           </a:p>
@@ -2897,7 +2939,7 @@
                 <a:ea typeface="Arial" pitchFamily="34" charset="-122"/>
                 <a:cs typeface="Arial" pitchFamily="34" charset="-120"/>
               </a:rPr>
-              <a:t>PARP inhibitors may benefit specific molecular subgroups.</a:t>
+              <a:t>FGFR3 axis identified as vulnerability</a:t>
             </a:r>
             <a:endParaRPr lang="en-US" sz="1800" dirty="0"/>
           </a:p>
@@ -2918,7 +2960,49 @@
                 <a:ea typeface="Arial" pitchFamily="34" charset="-122"/>
                 <a:cs typeface="Arial" pitchFamily="34" charset="-120"/>
               </a:rPr>
-              <a:t>Preclinical models used patient-derived xenografts.</a:t>
+              <a:t>Mesothelial-stromal interactions studied</a:t>
+            </a:r>
+            <a:endParaRPr lang="en-US" sz="1800" dirty="0"/>
+          </a:p>
+          <a:p>
+            <a:pPr marL="342900" indent="-342900">
+              <a:spcAft>
+                <a:spcPts val="800"/>
+              </a:spcAft>
+              <a:buSzPct val="100000"/>
+              <a:buChar char="•"/>
+            </a:pPr>
+            <a:r>
+              <a:rPr lang="en-US" sz="1800" dirty="0">
+                <a:solidFill>
+                  <a:srgbClr val="333333"/>
+                </a:solidFill>
+                <a:latin typeface="Arial" pitchFamily="34" charset="0"/>
+                <a:ea typeface="Arial" pitchFamily="34" charset="-122"/>
+                <a:cs typeface="Arial" pitchFamily="34" charset="-120"/>
+              </a:rPr>
+              <a:t>Potential therapeutic targets proposed</a:t>
+            </a:r>
+            <a:endParaRPr lang="en-US" sz="1800" dirty="0"/>
+          </a:p>
+          <a:p>
+            <a:pPr marL="342900" indent="-342900">
+              <a:spcAft>
+                <a:spcPts val="800"/>
+              </a:spcAft>
+              <a:buSzPct val="100000"/>
+              <a:buChar char="•"/>
+            </a:pPr>
+            <a:r>
+              <a:rPr lang="en-US" sz="1800" dirty="0">
+                <a:solidFill>
+                  <a:srgbClr val="333333"/>
+                </a:solidFill>
+                <a:latin typeface="Arial" pitchFamily="34" charset="0"/>
+                <a:ea typeface="Arial" pitchFamily="34" charset="-122"/>
+                <a:cs typeface="Arial" pitchFamily="34" charset="-120"/>
+              </a:rPr>
+              <a:t>Experimental models used for research</a:t>
             </a:r>
             <a:endParaRPr lang="en-US" sz="1800" dirty="0"/>
           </a:p>
@@ -2954,7 +3038,7 @@
                   <a:srgbClr val="888888"/>
                 </a:solidFill>
               </a:rPr>
-              <a:t>M Dahlmann, B Rau, S Gül-Klein. Cancer …. 2026</a:t>
+              <a:t>Y Fukui, H Kasashima, Z Wang. Cancer …. 2026</a:t>
             </a:r>
             <a:endParaRPr lang="en-US" sz="800" dirty="0"/>
           </a:p>
@@ -3154,7 +3238,7 @@
                   </a:extLst>
                 </a:hlinkClick>
               </a:rPr>
-              <a:t>The Mechanism of Acetyl-L-Carnitine on Colorectal Cancer and Its Metabolomic Study</a:t>
+              <a:t>Repurposing PARP inhibitors in molecularly defined subgroups of peritoneal metastatic colorectal cancer (pmCRC): Preclinical analysis of patient-derived xenograft …</a:t>
             </a:r>
             <a:endParaRPr lang="en-US" sz="2400" dirty="0"/>
           </a:p>
@@ -3190,7 +3274,7 @@
                   <a:srgbClr val="888888"/>
                 </a:solidFill>
               </a:rPr>
-              <a:t>Journal of Pharmaceutical and …  ·  Basic Research</a:t>
+              <a:t>Cancer …  ·  Basic Research</a:t>
             </a:r>
             <a:endParaRPr lang="en-US" sz="1000" dirty="0"/>
           </a:p>
@@ -3233,7 +3317,7 @@
                 <a:ea typeface="Arial" pitchFamily="34" charset="-122"/>
                 <a:cs typeface="Arial" pitchFamily="34" charset="-120"/>
               </a:rPr>
-              <a:t>Acetyl-L-Carnitine inhibits tumor growth</a:t>
+              <a:t>pmCRC shows poor prognosis compared to other metastases.</a:t>
             </a:r>
             <a:endParaRPr lang="en-US" sz="1800" dirty="0"/>
           </a:p>
@@ -3254,7 +3338,7 @@
                 <a:ea typeface="Arial" pitchFamily="34" charset="-122"/>
                 <a:cs typeface="Arial" pitchFamily="34" charset="-120"/>
               </a:rPr>
-              <a:t>In vivo studies confirm ALC efficacy</a:t>
+              <a:t>PARP inhibitors may benefit specific molecular subgroups.</a:t>
             </a:r>
             <a:endParaRPr lang="en-US" sz="1800" dirty="0"/>
           </a:p>
@@ -3275,7 +3359,7 @@
                 <a:ea typeface="Arial" pitchFamily="34" charset="-122"/>
                 <a:cs typeface="Arial" pitchFamily="34" charset="-120"/>
               </a:rPr>
-              <a:t>Metabolomic analysis reveals mechanisms</a:t>
+              <a:t>Patient-derived xenografts used for preclinical analysis.</a:t>
             </a:r>
             <a:endParaRPr lang="en-US" sz="1800" dirty="0"/>
           </a:p>
@@ -3311,7 +3395,7 @@
                   <a:srgbClr val="888888"/>
                 </a:solidFill>
               </a:rPr>
-              <a:t>J Ning, C Cai, X Fan. Journal of Pharmaceutical and …. 2026</a:t>
+              <a:t>M Dahlmann, B Rau, S Gül-Klein. Cancer …. 2026</a:t>
             </a:r>
             <a:endParaRPr lang="en-US" sz="800" dirty="0"/>
           </a:p>
@@ -3528,7 +3612,7 @@
                   <a:srgbClr val="FFFFFF"/>
                 </a:solidFill>
               </a:rPr>
-              <a:t>1. **腸道微生物與癌症的關聯**</a:t>
+              <a:t>1. **腸道微生物與癌症關聯**  </a:t>
             </a:r>
             <a:endParaRPr lang="en-US" sz="1200" dirty="0"/>
           </a:p>
@@ -3545,7 +3629,7 @@
                   <a:srgbClr val="FFFFFF"/>
                 </a:solidFill>
               </a:rPr>
-              <a:t>   - The study of *Parasutterella excrementihominis* highlights the significant role of gut microbiota in exacerbating colitis and promoting colorectal cancer, suggesting that microbial interactions may be critical in cancer development.</a:t>
+              <a:t>   The study of *Parasutterella excrementihominis* highlights the significant role of gut microbiota in exacerbating colitis and promoting colorectal cancer through pathogenic mechanisms like NETosis.  </a:t>
             </a:r>
             <a:endParaRPr lang="en-US" sz="1200" dirty="0"/>
           </a:p>
@@ -3562,7 +3646,7 @@
                   <a:srgbClr val="FFFFFF"/>
                 </a:solidFill>
               </a:rPr>
-              <a:t>   - *Parasutterella excrementihominis*的研究突顯腸道微生物在加重結腸炎和促進結直腸癌中的重要角色，暗示微生物相互作用可能在癌症發展中至關重要。</a:t>
+              <a:t>   *Parasutterella excrementihominis* 的研究突顯了腸道微生物在加劇結腸炎和促進結直腸癌中的重要角色，透過如 NETosis 的病理機制。</a:t>
             </a:r>
             <a:endParaRPr lang="en-US" sz="1200" dirty="0"/>
           </a:p>
@@ -3588,7 +3672,7 @@
                   <a:srgbClr val="FFFFFF"/>
                 </a:solidFill>
               </a:rPr>
-              <a:t>2. **植物提取物的潛力**</a:t>
+              <a:t>2. **預後指標的潛力**  </a:t>
             </a:r>
             <a:endParaRPr lang="en-US" sz="1200" dirty="0"/>
           </a:p>
@@ -3605,7 +3689,7 @@
                   <a:srgbClr val="FFFFFF"/>
                 </a:solidFill>
               </a:rPr>
-              <a:t>   - Cucurbitacin B's ability to target the ZNF70/NLRP3 axis offers promising therapeutic avenues for managing inflammation-associated colorectal cancer, demonstrating the potential of natural compounds in cancer treatment.</a:t>
+              <a:t>   The C-reactive protein-albumin-lymphocyte (CALLY) index and systemic immune-inflammation index (SII) are emerging as valuable prognostic biomarkers for colorectal cancer, although their consistency requires further validation.  </a:t>
             </a:r>
             <a:endParaRPr lang="en-US" sz="1200" dirty="0"/>
           </a:p>
@@ -3622,7 +3706,7 @@
                   <a:srgbClr val="FFFFFF"/>
                 </a:solidFill>
               </a:rPr>
-              <a:t>   - Cucurbitacin B針對ZNF70/NLRP3軸的能力為管理與炎症相關的結直腸癌提供了有希望的治療途徑，顯示天然化合物在癌症治療中的潛力。</a:t>
+              <a:t>   C-反應蛋白-白蛋白-淋巴細胞 (CALLY) 指數和全身免疫-炎症指數 (SII) 正在成為結直腸癌有價值的預後生物標記，但其一致性需要進一步驗證。</a:t>
             </a:r>
             <a:endParaRPr lang="en-US" sz="1200" dirty="0"/>
           </a:p>
@@ -3648,7 +3732,7 @@
                   <a:srgbClr val="FFFFFF"/>
                 </a:solidFill>
               </a:rPr>
-              <a:t>3. **系統性免疫炎症指數的預測價值**</a:t>
+              <a:t>3. **化療的應用與挑戰**  </a:t>
             </a:r>
             <a:endParaRPr lang="en-US" sz="1200" dirty="0"/>
           </a:p>
@@ -3665,7 +3749,7 @@
                   <a:srgbClr val="FFFFFF"/>
                 </a:solidFill>
               </a:rPr>
-              <a:t>   - The systemic immune-inflammation index (SII) has emerged as a significant prognostic biomarker for colorectal cancer, indicating that immune response metrics can be crucial in predicting patient outcomes.</a:t>
+              <a:t>   Hyperthermic intraperitoneal chemotherapy (HIPEC) shows promise for patients with advanced colorectal cancer, yet its effectiveness is contingent on tumor characteristics and patient selection.  </a:t>
             </a:r>
             <a:endParaRPr lang="en-US" sz="1200" dirty="0"/>
           </a:p>
@@ -3682,7 +3766,7 @@
                   <a:srgbClr val="FFFFFF"/>
                 </a:solidFill>
               </a:rPr>
-              <a:t>   - 系統性免疫炎症指數(SII)已成為結直腸癌的重要預後生物標誌，表明免疫反應指標在預測患者結果中的關鍵性。</a:t>
+              <a:t>   高溫腹腔化療 (HIPEC) 對於晚期結直腸癌患者顯示出希望，但其有效性取決於腫瘤特徵和患者選擇。</a:t>
             </a:r>
             <a:endParaRPr lang="en-US" sz="1200" dirty="0"/>
           </a:p>
@@ -3708,7 +3792,7 @@
                   <a:srgbClr val="FFFFFF"/>
                 </a:solidFill>
               </a:rPr>
-              <a:t>4. **癌症疫苗的挑戰與機會**</a:t>
+              <a:t>4. **炎症性腸病的癌症風險認知**  </a:t>
             </a:r>
             <a:endParaRPr lang="en-US" sz="1200" dirty="0"/>
           </a:p>
@@ -3725,7 +3809,7 @@
                   <a:srgbClr val="FFFFFF"/>
                 </a:solidFill>
               </a:rPr>
-              <a:t>   - Research on immunogenic cell death and its implications for cancer vaccines reveals both the potential and the challenges in developing effective immunotherapies for colorectal cancer.</a:t>
+              <a:t>   There is a critical need for increased awareness and education regarding the colorectal cancer risk associated with inflammatory bowel disease among patients, as current knowledge appears limited.  </a:t>
             </a:r>
             <a:endParaRPr lang="en-US" sz="1200" dirty="0"/>
           </a:p>
@@ -3742,7 +3826,7 @@
                   <a:srgbClr val="FFFFFF"/>
                 </a:solidFill>
               </a:rPr>
-              <a:t>   - 關於免疫原性細胞死亡及其對癌症疫苗的影響的研究揭示了開發有效結直腸癌免疫療法的潛力與挑戰。</a:t>
+              <a:t>   目前患者對於炎症性腸病相關結直腸癌風險的認知顯示出明顯不足，因此需要加強相關的認知與教育。</a:t>
             </a:r>
             <a:endParaRPr lang="en-US" sz="1200" dirty="0"/>
           </a:p>
@@ -3768,7 +3852,7 @@
                   <a:srgbClr val="FFFFFF"/>
                 </a:solidFill>
               </a:rPr>
-              <a:t>5. **轉移性結直腸癌的治療新策略**</a:t>
+              <a:t>5. **新療法的開發潛力**  </a:t>
             </a:r>
             <a:endParaRPr lang="en-US" sz="1200" dirty="0"/>
           </a:p>
@@ -3785,7 +3869,24 @@
                   <a:srgbClr val="FFFFFF"/>
                 </a:solidFill>
               </a:rPr>
-              <a:t>   - The exploration of novel delivery systems, such as bilosomal nanocarriers for resveratrol, underscores the need for innovative approaches to enhance drug bioavailability in colorectal cancer treatment.</a:t>
+              <a:t>   The identification of molecular pathways, such as the HHEX/IKKα feedback loop, opens new avenues for targeted therapies in inflammatory bowel diseases and related colorectal cancer.  </a:t>
+            </a:r>
+            <a:endParaRPr lang="en-US" sz="1200" dirty="0"/>
+          </a:p>
+          <a:p>
+            <a:pPr indent="0" marL="0">
+              <a:lnSpc>
+                <a:spcPct val="150000"/>
+              </a:lnSpc>
+              <a:buNone/>
+            </a:pPr>
+            <a:r>
+              <a:rPr lang="en-US" sz="1200" dirty="0">
+                <a:solidFill>
+                  <a:srgbClr val="FFFFFF"/>
+                </a:solidFill>
+              </a:rPr>
+              <a:t>   HHEX/IKKα 反饋迴路等分子通路的識別為針對炎症性腸病及相關結直腸癌的新療法開啟了新的可能性。</a:t>
             </a:r>
             <a:endParaRPr lang="en-US" sz="1200" dirty="0"/>
           </a:p>
@@ -3931,7 +4032,7 @@
                   <a:srgbClr val="FFFFFF"/>
                 </a:solidFill>
               </a:rPr>
-              <a:t>- 探索如用於白藜蘆醇的雙層納米載體等新型給藥系統，強調了在結直腸癌治療中增強藥物生物利用度的創新方法的必要性。</a:t>
+              <a:t>### 未來研究方向 (Future Research Directions)</a:t>
             </a:r>
             <a:endParaRPr lang="en-US" sz="1200" dirty="0"/>
           </a:p>
@@ -3957,7 +4058,7 @@
                   <a:srgbClr val="FFFFFF"/>
                 </a:solidFill>
               </a:rPr>
-              <a:t>### 未來研究方向 (Future Research Directions)</a:t>
+              <a:t>1. **腸道微生物的功能性研究**  </a:t>
             </a:r>
             <a:endParaRPr lang="en-US" sz="1200" dirty="0"/>
           </a:p>
@@ -3968,6 +4069,14 @@
               </a:lnSpc>
               <a:buNone/>
             </a:pPr>
+            <a:r>
+              <a:rPr lang="en-US" sz="1200" dirty="0">
+                <a:solidFill>
+                  <a:srgbClr val="FFFFFF"/>
+                </a:solidFill>
+              </a:rPr>
+              <a:t>   Future studies should delve deeper into the functional roles of specific gut microbiota, like *Parasutterella excrementihominis*, in colorectal cancer progression and treatment responses.  </a:t>
+            </a:r>
             <a:endParaRPr lang="en-US" sz="1200" dirty="0"/>
           </a:p>
           <a:p>
@@ -3983,7 +4092,7 @@
                   <a:srgbClr val="FFFFFF"/>
                 </a:solidFill>
               </a:rPr>
-              <a:t>1. **微生物組與癌症的機制研究**</a:t>
+              <a:t>   未來的研究應深入探討特定腸道微生物（如 *Parasutterella excrementihominis*）在結直腸癌進展和治療反應中的功能角色。</a:t>
             </a:r>
             <a:endParaRPr lang="en-US" sz="1200" dirty="0"/>
           </a:p>
@@ -3994,14 +4103,6 @@
               </a:lnSpc>
               <a:buNone/>
             </a:pPr>
-            <a:r>
-              <a:rPr lang="en-US" sz="1200" dirty="0">
-                <a:solidFill>
-                  <a:srgbClr val="FFFFFF"/>
-                </a:solidFill>
-              </a:rPr>
-              <a:t>   - Future studies should focus on elucidating the mechanisms by which gut microbiota influence inflammation and colorectal carcinogenesis, potentially leading to targeted microbiome therapies.</a:t>
-            </a:r>
             <a:endParaRPr lang="en-US" sz="1200" dirty="0"/>
           </a:p>
           <a:p>
@@ -4017,7 +4118,7 @@
                   <a:srgbClr val="FFFFFF"/>
                 </a:solidFill>
               </a:rPr>
-              <a:t>   - 未來的研究應集中於闡明腸道微生物如何影響炎症和結直腸癌發生的機制，可能導致針對微生物組的治療。</a:t>
+              <a:t>2. **預後指標的標準化**  </a:t>
             </a:r>
             <a:endParaRPr lang="en-US" sz="1200" dirty="0"/>
           </a:p>
@@ -4028,6 +4129,14 @@
               </a:lnSpc>
               <a:buNone/>
             </a:pPr>
+            <a:r>
+              <a:rPr lang="en-US" sz="1200" dirty="0">
+                <a:solidFill>
+                  <a:srgbClr val="FFFFFF"/>
+                </a:solidFill>
+              </a:rPr>
+              <a:t>   There is a need for standardization of prognostic indices such as CALLY and SII to enhance their clinical applicability and reliability in colorectal cancer management.  </a:t>
+            </a:r>
             <a:endParaRPr lang="en-US" sz="1200" dirty="0"/>
           </a:p>
           <a:p>
@@ -4043,7 +4152,7 @@
                   <a:srgbClr val="FFFFFF"/>
                 </a:solidFill>
               </a:rPr>
-              <a:t>2. **天然化合物的臨床應用**</a:t>
+              <a:t>   需要對預後指標如 CALLY 和 SII 進行標準化，以提高其在結直腸癌管理中的臨床應用性和可靠性。</a:t>
             </a:r>
             <a:endParaRPr lang="en-US" sz="1200" dirty="0"/>
           </a:p>
@@ -4054,14 +4163,6 @@
               </a:lnSpc>
               <a:buNone/>
             </a:pPr>
-            <a:r>
-              <a:rPr lang="en-US" sz="1200" dirty="0">
-                <a:solidFill>
-                  <a:srgbClr val="FFFFFF"/>
-                </a:solidFill>
-              </a:rPr>
-              <a:t>   - Investigating the clinical efficacy and safety of natural compounds like Cucurbitacin B in diverse populations could provide insights into their therapeutic potential in colorectal cancer.</a:t>
-            </a:r>
             <a:endParaRPr lang="en-US" sz="1200" dirty="0"/>
           </a:p>
           <a:p>
@@ -4077,7 +4178,7 @@
                   <a:srgbClr val="FFFFFF"/>
                 </a:solidFill>
               </a:rPr>
-              <a:t>   - 研究天然化合物如Cucurbitacin B在不同人群中的臨床療效和安全性，可能為其在結直腸癌中的治療潛力提供見解。</a:t>
+              <a:t>3. **HIPEC的長期效果研究**  </a:t>
             </a:r>
             <a:endParaRPr lang="en-US" sz="1200" dirty="0"/>
           </a:p>
@@ -4088,6 +4189,14 @@
               </a:lnSpc>
               <a:buNone/>
             </a:pPr>
+            <a:r>
+              <a:rPr lang="en-US" sz="1200" dirty="0">
+                <a:solidFill>
+                  <a:srgbClr val="FFFFFF"/>
+                </a:solidFill>
+              </a:rPr>
+              <a:t>   Long-term outcomes of hyperthermic intraperitoneal chemotherapy should be evaluated in larger, randomized clinical trials to determine its true efficacy and safety profile.  </a:t>
+            </a:r>
             <a:endParaRPr lang="en-US" sz="1200" dirty="0"/>
           </a:p>
           <a:p>
@@ -4103,7 +4212,7 @@
                   <a:srgbClr val="FFFFFF"/>
                 </a:solidFill>
               </a:rPr>
-              <a:t>3. **整合免疫指標於預後模型**</a:t>
+              <a:t>   應在更大規模的隨機臨床試驗中評估高溫腹腔化療的長期效果，以確定其真正的有效性和安全性。</a:t>
             </a:r>
             <a:endParaRPr lang="en-US" sz="1200" dirty="0"/>
           </a:p>
@@ -4114,14 +4223,6 @@
               </a:lnSpc>
               <a:buNone/>
             </a:pPr>
-            <a:r>
-              <a:rPr lang="en-US" sz="1200" dirty="0">
-                <a:solidFill>
-                  <a:srgbClr val="FFFFFF"/>
-                </a:solidFill>
-              </a:rPr>
-              <a:t>   - Integrating systemic immune-inflammation indices into existing prognostic models could enhance predictive accuracy for patient outcomes in colorectal cancer.</a:t>
-            </a:r>
             <a:endParaRPr lang="en-US" sz="1200" dirty="0"/>
           </a:p>
           <a:p>
@@ -4137,7 +4238,7 @@
                   <a:srgbClr val="FFFFFF"/>
                 </a:solidFill>
               </a:rPr>
-              <a:t>   - 將系統性免疫炎症指數整合進現有的預後模型中，可能提高對結直腸癌患者結果的預測準確性。</a:t>
+              <a:t>4. **炎症性腸病患者的教育介入**  </a:t>
             </a:r>
             <a:endParaRPr lang="en-US" sz="1200" dirty="0"/>
           </a:p>
@@ -4148,6 +4249,14 @@
               </a:lnSpc>
               <a:buNone/>
             </a:pPr>
+            <a:r>
+              <a:rPr lang="en-US" sz="1200" dirty="0">
+                <a:solidFill>
+                  <a:srgbClr val="FFFFFF"/>
+                </a:solidFill>
+              </a:rPr>
+              <a:t>   Research should focus on developing and implementing educational interventions for patients with inflammatory bowel disease to improve their understanding of cancer risks and management strategies.  </a:t>
+            </a:r>
             <a:endParaRPr lang="en-US" sz="1200" dirty="0"/>
           </a:p>
           <a:p>
@@ -4163,7 +4272,7 @@
                   <a:srgbClr val="FFFFFF"/>
                 </a:solidFill>
               </a:rPr>
-              <a:t>4. **新型疫苗策略的開發**</a:t>
+              <a:t>   研究應專注於為炎症性腸病患者開發和實施教育介入，以提高他們對癌症風險和管理策略的理解。</a:t>
             </a:r>
             <a:endParaRPr lang="en-US" sz="1200" dirty="0"/>
           </a:p>
@@ -4174,14 +4283,6 @@
               </a:lnSpc>
               <a:buNone/>
             </a:pPr>
-            <a:r>
-              <a:rPr lang="en-US" sz="1200" dirty="0">
-                <a:solidFill>
-                  <a:srgbClr val="FFFFFF"/>
-                </a:solidFill>
-              </a:rPr>
-              <a:t>   - Research should explore innovative vaccine strategies that enhance the efficacy of immunogenic cell death in colorectal cancer, focusing on overcoming current limitations.</a:t>
-            </a:r>
             <a:endParaRPr lang="en-US" sz="1200" dirty="0"/>
           </a:p>
           <a:p>
@@ -4197,7 +4298,7 @@
                   <a:srgbClr val="FFFFFF"/>
                 </a:solidFill>
               </a:rPr>
-              <a:t>   - 研究應探索增強免疫原性細胞死亡在結直腸癌中療效的新型疫苗策略，重點克服當前的限制。</a:t>
+              <a:t>5. **新靶向療法的臨床試驗**  </a:t>
             </a:r>
             <a:endParaRPr lang="en-US" sz="1200" dirty="0"/>
           </a:p>
@@ -4208,6 +4309,14 @@
               </a:lnSpc>
               <a:buNone/>
             </a:pPr>
+            <a:r>
+              <a:rPr lang="en-US" sz="1200" dirty="0">
+                <a:solidFill>
+                  <a:srgbClr val="FFFFFF"/>
+                </a:solidFill>
+              </a:rPr>
+              <a:t>   Clinical trials investigating novel targeted therapies based on newly identified molecular pathways, such as the HHEX/IKKα loop, are essential to advance treatment options for colorectal cancer.  </a:t>
+            </a:r>
             <a:endParaRPr lang="en-US" sz="1200" dirty="0"/>
           </a:p>
           <a:p>
@@ -4223,41 +4332,7 @@
                   <a:srgbClr val="FFFFFF"/>
                 </a:solidFill>
               </a:rPr>
-              <a:t>5. **針對轉移性癌症的新治療方法**</a:t>
-            </a:r>
-            <a:endParaRPr lang="en-US" sz="1200" dirty="0"/>
-          </a:p>
-          <a:p>
-            <a:pPr indent="0" marL="0">
-              <a:lnSpc>
-                <a:spcPct val="150000"/>
-              </a:lnSpc>
-              <a:buNone/>
-            </a:pPr>
-            <a:r>
-              <a:rPr lang="en-US" sz="1200" dirty="0">
-                <a:solidFill>
-                  <a:srgbClr val="FFFFFF"/>
-                </a:solidFill>
-              </a:rPr>
-              <a:t>   - Future investigations should aim at developing targeted therapies for peritoneal metastatic colorectal cancer, focusing on molecularly defined subgroups to improve treatment outcomes.</a:t>
-            </a:r>
-            <a:endParaRPr lang="en-US" sz="1200" dirty="0"/>
-          </a:p>
-          <a:p>
-            <a:pPr indent="0" marL="0">
-              <a:lnSpc>
-                <a:spcPct val="150000"/>
-              </a:lnSpc>
-              <a:buNone/>
-            </a:pPr>
-            <a:r>
-              <a:rPr lang="en-US" sz="1200" dirty="0">
-                <a:solidFill>
-                  <a:srgbClr val="FFFFFF"/>
-                </a:solidFill>
-              </a:rPr>
-              <a:t>   - 未來的研究應致力於為腹膜轉移性結直腸癌開發針對性的治療方法，專注於分子定義的亞組以改善治療結果。</a:t>
+              <a:t>   基於新識別的分子通路（如 HHEX/IKKα 迴路）開展的新靶向療法臨床試驗對於推進結直腸癌的治療選擇至關重要。</a:t>
             </a:r>
             <a:endParaRPr lang="en-US" sz="1200" dirty="0"/>
           </a:p>
@@ -4528,7 +4603,7 @@
                 <a:ea typeface="Arial" pitchFamily="34" charset="-122"/>
                 <a:cs typeface="Arial" pitchFamily="34" charset="-120"/>
               </a:rPr>
-              <a:t>Mechanism of Cucurbitacin B Targeting ZNF70/NLRP3 Axis Against Inflammation-Asso…</a:t>
+              <a:t>Effect of hyperthermic intraperitoneal chemotherapy on patients with advanced co…</a:t>
             </a:r>
             <a:endParaRPr lang="en-US" sz="1400" dirty="0"/>
           </a:p>
@@ -4565,7 +4640,7 @@
                 <a:ea typeface="Arial" pitchFamily="34" charset="-122"/>
                 <a:cs typeface="Arial" pitchFamily="34" charset="-120"/>
               </a:rPr>
-              <a:t>Effect of hyperthermic intraperitoneal chemotherapy on patients with advanced co…</a:t>
+              <a:t>Predictive utility of the C-reactive protein-albumin-lymphocyte (CALLY) index in…</a:t>
             </a:r>
             <a:endParaRPr lang="en-US" sz="1400" dirty="0"/>
           </a:p>
@@ -4676,7 +4751,7 @@
                 <a:ea typeface="Arial" pitchFamily="34" charset="-122"/>
                 <a:cs typeface="Arial" pitchFamily="34" charset="-120"/>
               </a:rPr>
-              <a:t>Immunogenic cell death-primed autophagosome vaccines drive dendritic cell cross-…</a:t>
+              <a:t>… of mFOLFOXIRI plus bevacizumab combined with cytoreductive surgery for resecta…</a:t>
             </a:r>
             <a:endParaRPr lang="en-US" sz="1400" dirty="0"/>
           </a:p>
@@ -4713,7 +4788,7 @@
                 <a:ea typeface="Arial" pitchFamily="34" charset="-122"/>
                 <a:cs typeface="Arial" pitchFamily="34" charset="-120"/>
               </a:rPr>
-              <a:t>Engineering Bilosomal Nanocarriers for Targeted Delivery of Resveratrol: Rationa…</a:t>
+              <a:t>An HHEX/IKK&amp;#x3b1; positive feedback loop promotes intestinal inflammation.</a:t>
             </a:r>
             <a:endParaRPr lang="en-US" sz="1400" dirty="0"/>
           </a:p>
@@ -4750,7 +4825,7 @@
                 <a:ea typeface="Arial" pitchFamily="34" charset="-122"/>
                 <a:cs typeface="Arial" pitchFamily="34" charset="-120"/>
               </a:rPr>
-              <a:t>… Cancer and Mesothelial Stromal Cell Lines from Malignant Ascites Reveals a Mes…</a:t>
+              <a:t>The mechanism of acetyl-L-carnitine on colorectal cancer and its metabolomic stu…</a:t>
             </a:r>
             <a:endParaRPr lang="en-US" sz="1400" dirty="0"/>
           </a:p>
@@ -4787,7 +4862,7 @@
                 <a:ea typeface="Arial" pitchFamily="34" charset="-122"/>
                 <a:cs typeface="Arial" pitchFamily="34" charset="-120"/>
               </a:rPr>
-              <a:t>Repurposing PARP inhibitors in molecularly defined subgroups of peritoneal metas…</a:t>
+              <a:t>… Cancer and Mesothelial Stromal Cell Lines from Malignant Ascites Reveals a Mes…</a:t>
             </a:r>
             <a:endParaRPr lang="en-US" sz="1400" dirty="0"/>
           </a:p>
@@ -4824,7 +4899,7 @@
                 <a:ea typeface="Arial" pitchFamily="34" charset="-122"/>
                 <a:cs typeface="Arial" pitchFamily="34" charset="-120"/>
               </a:rPr>
-              <a:t>The Mechanism of Acetyl-L-Carnitine on Colorectal Cancer and Its Metabolomic Stu…</a:t>
+              <a:t>Repurposing PARP inhibitors in molecularly defined subgroups of peritoneal metas…</a:t>
             </a:r>
             <a:endParaRPr lang="en-US" sz="1400" dirty="0"/>
           </a:p>
@@ -5058,7 +5133,7 @@
                 <a:ea typeface="Arial" pitchFamily="34" charset="-122"/>
                 <a:cs typeface="Arial" pitchFamily="34" charset="-120"/>
               </a:rPr>
-              <a:t>P. excrementihominis worsens colitis severity.</a:t>
+              <a:t>P. excrementihominis worsens colitis symptoms.</a:t>
             </a:r>
             <a:endParaRPr lang="en-US" sz="1800" dirty="0"/>
           </a:p>
@@ -5079,7 +5154,7 @@
                 <a:ea typeface="Arial" pitchFamily="34" charset="-122"/>
                 <a:cs typeface="Arial" pitchFamily="34" charset="-120"/>
               </a:rPr>
-              <a:t>Pathogenic NETosis activation observed.</a:t>
+              <a:t>NETosis activation linked to cancer progression.</a:t>
             </a:r>
             <a:endParaRPr lang="en-US" sz="1800" dirty="0"/>
           </a:p>
@@ -5100,7 +5175,7 @@
                 <a:ea typeface="Arial" pitchFamily="34" charset="-122"/>
                 <a:cs typeface="Arial" pitchFamily="34" charset="-120"/>
               </a:rPr>
-              <a:t>Potential link to colorectal cancer.</a:t>
+              <a:t>Study suggests new therapeutic strategies.</a:t>
             </a:r>
             <a:endParaRPr lang="en-US" sz="1800" dirty="0"/>
           </a:p>
@@ -5336,7 +5411,7 @@
                   </a:extLst>
                 </a:hlinkClick>
               </a:rPr>
-              <a:t>Mechanism of Cucurbitacin B Targeting ZNF70/NLRP3 Axis Against Inflammation-Associated Colorectal Cancer.</a:t>
+              <a:t>Effect of hyperthermic intraperitoneal chemotherapy on patients with advanced colorectal cancer: a systematic review and meta-analysis</a:t>
             </a:r>
             <a:endParaRPr lang="en-US" sz="2400" dirty="0"/>
           </a:p>
@@ -5372,7 +5447,7 @@
                   <a:srgbClr val="888888"/>
                 </a:solidFill>
               </a:rPr>
-              <a:t>Phytotherapy research : PTR  ·  Basic Research  ·  🌏 Asia</a:t>
+              <a:t>World Journal of …  ·  Meta-Analysis</a:t>
             </a:r>
             <a:endParaRPr lang="en-US" sz="1000" dirty="0"/>
           </a:p>
@@ -5415,7 +5490,7 @@
                 <a:ea typeface="Arial" pitchFamily="34" charset="-122"/>
                 <a:cs typeface="Arial" pitchFamily="34" charset="-120"/>
               </a:rPr>
-              <a:t>Cucurbitacin B targets ZNF70/NLRP3 axis.</a:t>
+              <a:t>Hyperthermic intraperitoneal chemotherapy (HIPEC) evaluated</a:t>
             </a:r>
             <a:endParaRPr lang="en-US" sz="1800" dirty="0"/>
           </a:p>
@@ -5436,7 +5511,7 @@
                 <a:ea typeface="Arial" pitchFamily="34" charset="-122"/>
                 <a:cs typeface="Arial" pitchFamily="34" charset="-120"/>
               </a:rPr>
-              <a:t>Reduces inflammation-associated CRC progression.</a:t>
+              <a:t>Systematic review and meta-analysis conducted</a:t>
             </a:r>
             <a:endParaRPr lang="en-US" sz="1800" dirty="0"/>
           </a:p>
@@ -5457,7 +5532,49 @@
                 <a:ea typeface="Arial" pitchFamily="34" charset="-122"/>
                 <a:cs typeface="Arial" pitchFamily="34" charset="-120"/>
               </a:rPr>
-              <a:t>Non-toxic to major organs in mice.</a:t>
+              <a:t>Focus on advanced colorectal cancer patients</a:t>
+            </a:r>
+            <a:endParaRPr lang="en-US" sz="1800" dirty="0"/>
+          </a:p>
+          <a:p>
+            <a:pPr marL="342900" indent="-342900">
+              <a:spcAft>
+                <a:spcPts val="800"/>
+              </a:spcAft>
+              <a:buSzPct val="100000"/>
+              <a:buChar char="•"/>
+            </a:pPr>
+            <a:r>
+              <a:rPr lang="en-US" sz="1800" dirty="0">
+                <a:solidFill>
+                  <a:srgbClr val="333333"/>
+                </a:solidFill>
+                <a:latin typeface="Arial" pitchFamily="34" charset="0"/>
+                <a:ea typeface="Arial" pitchFamily="34" charset="-122"/>
+                <a:cs typeface="Arial" pitchFamily="34" charset="-120"/>
+              </a:rPr>
+              <a:t>Impact on peritoneal metastases assessed</a:t>
+            </a:r>
+            <a:endParaRPr lang="en-US" sz="1800" dirty="0"/>
+          </a:p>
+          <a:p>
+            <a:pPr marL="342900" indent="-342900">
+              <a:spcAft>
+                <a:spcPts val="800"/>
+              </a:spcAft>
+              <a:buSzPct val="100000"/>
+              <a:buChar char="•"/>
+            </a:pPr>
+            <a:r>
+              <a:rPr lang="en-US" sz="1800" dirty="0">
+                <a:solidFill>
+                  <a:srgbClr val="333333"/>
+                </a:solidFill>
+                <a:latin typeface="Arial" pitchFamily="34" charset="0"/>
+                <a:ea typeface="Arial" pitchFamily="34" charset="-122"/>
+                <a:cs typeface="Arial" pitchFamily="34" charset="-120"/>
+              </a:rPr>
+              <a:t>Potential benefits and risks discussed</a:t>
             </a:r>
             <a:endParaRPr lang="en-US" sz="1800" dirty="0"/>
           </a:p>
@@ -5493,7 +5610,7 @@
                   <a:srgbClr val="888888"/>
                 </a:solidFill>
               </a:rPr>
-              <a:t>Cao Shen, Tai Yi, Wang Yuhan et al.. Phytotherapy research : PTR. 2026-05-09 DOI: 10.1002/ptr.70329</a:t>
+              <a:t>Z Su, Y Guo, X Ru. World Journal of …. 2026</a:t>
             </a:r>
             <a:endParaRPr lang="en-US" sz="800" dirty="0"/>
           </a:p>
@@ -5693,7 +5810,7 @@
                   </a:extLst>
                 </a:hlinkClick>
               </a:rPr>
-              <a:t>Effect of hyperthermic intraperitoneal chemotherapy on patients with advanced colorectal cancer: a systematic review and meta-analysis</a:t>
+              <a:t>Predictive utility of the C-reactive protein-albumin-lymphocyte (CALLY) index in Colorectal cancer: A meta-analysis</a:t>
             </a:r>
             <a:endParaRPr lang="en-US" sz="2400" dirty="0"/>
           </a:p>
@@ -5729,7 +5846,7 @@
                   <a:srgbClr val="888888"/>
                 </a:solidFill>
               </a:rPr>
-              <a:t>World Journal of …  ·  Meta-Analysis</a:t>
+              <a:t>Clinics and Research in Hepatology and …  ·  Meta-Analysis</a:t>
             </a:r>
             <a:endParaRPr lang="en-US" sz="1000" dirty="0"/>
           </a:p>
@@ -5772,7 +5889,7 @@
                 <a:ea typeface="Arial" pitchFamily="34" charset="-122"/>
                 <a:cs typeface="Arial" pitchFamily="34" charset="-120"/>
               </a:rPr>
-              <a:t>Hyperthermic intraperitoneal chemotherapy (HIPEC) evaluated</a:t>
+              <a:t>CALLY index predicts CRC outcomes.</a:t>
             </a:r>
             <a:endParaRPr lang="en-US" sz="1800" dirty="0"/>
           </a:p>
@@ -5793,7 +5910,7 @@
                 <a:ea typeface="Arial" pitchFamily="34" charset="-122"/>
                 <a:cs typeface="Arial" pitchFamily="34" charset="-120"/>
               </a:rPr>
-              <a:t>Systematic review and meta-analysis conducted</a:t>
+              <a:t>Meta-analysis of multiple studies.</a:t>
             </a:r>
             <a:endParaRPr lang="en-US" sz="1800" dirty="0"/>
           </a:p>
@@ -5814,49 +5931,7 @@
                 <a:ea typeface="Arial" pitchFamily="34" charset="-122"/>
                 <a:cs typeface="Arial" pitchFamily="34" charset="-120"/>
               </a:rPr>
-              <a:t>Focus on advanced colorectal cancer patients</a:t>
-            </a:r>
-            <a:endParaRPr lang="en-US" sz="1800" dirty="0"/>
-          </a:p>
-          <a:p>
-            <a:pPr marL="342900" indent="-342900">
-              <a:spcAft>
-                <a:spcPts val="800"/>
-              </a:spcAft>
-              <a:buSzPct val="100000"/>
-              <a:buChar char="•"/>
-            </a:pPr>
-            <a:r>
-              <a:rPr lang="en-US" sz="1800" dirty="0">
-                <a:solidFill>
-                  <a:srgbClr val="333333"/>
-                </a:solidFill>
-                <a:latin typeface="Arial" pitchFamily="34" charset="0"/>
-                <a:ea typeface="Arial" pitchFamily="34" charset="-122"/>
-                <a:cs typeface="Arial" pitchFamily="34" charset="-120"/>
-              </a:rPr>
-              <a:t>Impact on peritoneal metastases assessed</a:t>
-            </a:r>
-            <a:endParaRPr lang="en-US" sz="1800" dirty="0"/>
-          </a:p>
-          <a:p>
-            <a:pPr marL="342900" indent="-342900">
-              <a:spcAft>
-                <a:spcPts val="800"/>
-              </a:spcAft>
-              <a:buSzPct val="100000"/>
-              <a:buChar char="•"/>
-            </a:pPr>
-            <a:r>
-              <a:rPr lang="en-US" sz="1800" dirty="0">
-                <a:solidFill>
-                  <a:srgbClr val="333333"/>
-                </a:solidFill>
-                <a:latin typeface="Arial" pitchFamily="34" charset="0"/>
-                <a:ea typeface="Arial" pitchFamily="34" charset="-122"/>
-                <a:cs typeface="Arial" pitchFamily="34" charset="-120"/>
-              </a:rPr>
-              <a:t>Clinical outcomes and survival rates analyzed</a:t>
+              <a:t>Inconsistent prognostic performance observed.</a:t>
             </a:r>
             <a:endParaRPr lang="en-US" sz="1800" dirty="0"/>
           </a:p>
@@ -5892,7 +5967,7 @@
                   <a:srgbClr val="888888"/>
                 </a:solidFill>
               </a:rPr>
-              <a:t>Z Su, Y Guo, X Ru. World Journal of …. 2026</a:t>
+              <a:t>X Li, T Chu, W Chen. Clinics and Research in Hepatology and …. 2026</a:t>
             </a:r>
             <a:endParaRPr lang="en-US" sz="800" dirty="0"/>
           </a:p>
@@ -6192,7 +6267,7 @@
                 <a:ea typeface="Arial" pitchFamily="34" charset="-122"/>
                 <a:cs typeface="Arial" pitchFamily="34" charset="-120"/>
               </a:rPr>
-              <a:t>SII as a prognostic biomarker in CRC</a:t>
+              <a:t>Prognostic value in colorectal cancer (CRC)</a:t>
             </a:r>
             <a:endParaRPr lang="en-US" sz="1800" dirty="0"/>
           </a:p>
@@ -6213,7 +6288,49 @@
                 <a:ea typeface="Arial" pitchFamily="34" charset="-122"/>
                 <a:cs typeface="Arial" pitchFamily="34" charset="-120"/>
               </a:rPr>
-              <a:t>Meta-analysis of existing studies conducted</a:t>
+              <a:t>Meta-analysis of existing studies</a:t>
+            </a:r>
+            <a:endParaRPr lang="en-US" sz="1800" dirty="0"/>
+          </a:p>
+          <a:p>
+            <a:pPr marL="342900" indent="-342900">
+              <a:spcAft>
+                <a:spcPts val="800"/>
+              </a:spcAft>
+              <a:buSzPct val="100000"/>
+              <a:buChar char="•"/>
+            </a:pPr>
+            <a:r>
+              <a:rPr lang="en-US" sz="1800" dirty="0">
+                <a:solidFill>
+                  <a:srgbClr val="333333"/>
+                </a:solidFill>
+                <a:latin typeface="Arial" pitchFamily="34" charset="0"/>
+                <a:ea typeface="Arial" pitchFamily="34" charset="-122"/>
+                <a:cs typeface="Arial" pitchFamily="34" charset="-120"/>
+              </a:rPr>
+              <a:t>SII correlates with patient outcomes</a:t>
+            </a:r>
+            <a:endParaRPr lang="en-US" sz="1800" dirty="0"/>
+          </a:p>
+          <a:p>
+            <a:pPr marL="342900" indent="-342900">
+              <a:spcAft>
+                <a:spcPts val="800"/>
+              </a:spcAft>
+              <a:buSzPct val="100000"/>
+              <a:buChar char="•"/>
+            </a:pPr>
+            <a:r>
+              <a:rPr lang="en-US" sz="1800" dirty="0">
+                <a:solidFill>
+                  <a:srgbClr val="333333"/>
+                </a:solidFill>
+                <a:latin typeface="Arial" pitchFamily="34" charset="0"/>
+                <a:ea typeface="Arial" pitchFamily="34" charset="-122"/>
+                <a:cs typeface="Arial" pitchFamily="34" charset="-120"/>
+              </a:rPr>
+              <a:t>Potential biomarker for clinical use</a:t>
             </a:r>
             <a:endParaRPr lang="en-US" sz="1800" dirty="0"/>
           </a:p>
@@ -6528,7 +6645,7 @@
                 <a:ea typeface="Arial" pitchFamily="34" charset="-122"/>
                 <a:cs typeface="Arial" pitchFamily="34" charset="-120"/>
               </a:rPr>
-              <a:t>Limited awareness of cancer risk</a:t>
+              <a:t>Limited knowledge on colorectal cancer risk</a:t>
             </a:r>
             <a:endParaRPr lang="en-US" sz="1800" dirty="0"/>
           </a:p>
@@ -6549,7 +6666,7 @@
                 <a:ea typeface="Arial" pitchFamily="34" charset="-122"/>
                 <a:cs typeface="Arial" pitchFamily="34" charset="-120"/>
               </a:rPr>
-              <a:t>Need for better patient education</a:t>
+              <a:t>Need for better patient education strategies</a:t>
             </a:r>
             <a:endParaRPr lang="en-US" sz="1800" dirty="0"/>
           </a:p>
@@ -6570,7 +6687,7 @@
                 <a:ea typeface="Arial" pitchFamily="34" charset="-122"/>
                 <a:cs typeface="Arial" pitchFamily="34" charset="-120"/>
               </a:rPr>
-              <a:t>Research gaps in management strategies</a:t>
+              <a:t>Importance of regular screening in IBD patients</a:t>
             </a:r>
             <a:endParaRPr lang="en-US" sz="1800" dirty="0"/>
           </a:p>
@@ -6806,7 +6923,7 @@
                   </a:extLst>
                 </a:hlinkClick>
               </a:rPr>
-              <a:t>Immunogenic cell death-primed autophagosome vaccines drive dendritic cell cross-presentation and suppress colon cancer metastasis.</a:t>
+              <a:t>… of mFOLFOXIRI plus bevacizumab combined with cytoreductive surgery for resectable peritoneal metastases from colorectal cancer: a prospective, randomized …</a:t>
             </a:r>
             <a:endParaRPr lang="en-US" sz="2400" dirty="0"/>
           </a:p>
@@ -6842,7 +6959,7 @@
                   <a:srgbClr val="888888"/>
                 </a:solidFill>
               </a:rPr>
-              <a:t>Journal of controlled release : official journal of the Controlled Release Society  ·  Basic Research</a:t>
+              <a:t>… wei chang wai ke …  ·  Prospective Study</a:t>
             </a:r>
             <a:endParaRPr lang="en-US" sz="1000" dirty="0"/>
           </a:p>
@@ -6885,7 +7002,7 @@
                 <a:ea typeface="Arial" pitchFamily="34" charset="-122"/>
                 <a:cs typeface="Arial" pitchFamily="34" charset="-120"/>
               </a:rPr>
-              <a:t>ICD enhances tumor antigen release</a:t>
+              <a:t>mFOLFOXIRI plus bevacizumab used</a:t>
             </a:r>
             <a:endParaRPr lang="en-US" sz="1800" dirty="0"/>
           </a:p>
@@ -6906,7 +7023,7 @@
                 <a:ea typeface="Arial" pitchFamily="34" charset="-122"/>
                 <a:cs typeface="Arial" pitchFamily="34" charset="-120"/>
               </a:rPr>
-              <a:t>ICAPs improve dendritic cell cross-presentation</a:t>
+              <a:t>Combined with cytoreductive surgery</a:t>
             </a:r>
             <a:endParaRPr lang="en-US" sz="1800" dirty="0"/>
           </a:p>
@@ -6927,7 +7044,7 @@
                 <a:ea typeface="Arial" pitchFamily="34" charset="-122"/>
                 <a:cs typeface="Arial" pitchFamily="34" charset="-120"/>
               </a:rPr>
-              <a:t>90% tumor clearance in mouse model</a:t>
+              <a:t>Targeting resectable peritoneal metastases</a:t>
             </a:r>
             <a:endParaRPr lang="en-US" sz="1800" dirty="0"/>
           </a:p>
@@ -6948,7 +7065,7 @@
                 <a:ea typeface="Arial" pitchFamily="34" charset="-122"/>
                 <a:cs typeface="Arial" pitchFamily="34" charset="-120"/>
               </a:rPr>
-              <a:t>Boosts CD8+ T cell immunity</a:t>
+              <a:t>Prospective, randomized clinical trial</a:t>
             </a:r>
             <a:endParaRPr lang="en-US" sz="1800" dirty="0"/>
           </a:p>
@@ -6969,7 +7086,7 @@
                 <a:ea typeface="Arial" pitchFamily="34" charset="-122"/>
                 <a:cs typeface="Arial" pitchFamily="34" charset="-120"/>
               </a:rPr>
-              <a:t>Potential for personalized cancer vaccines</a:t>
+              <a:t>Focus on colorectal cancer patients</a:t>
             </a:r>
             <a:endParaRPr lang="en-US" sz="1800" dirty="0"/>
           </a:p>
@@ -7005,7 +7122,7 @@
                   <a:srgbClr val="888888"/>
                 </a:solidFill>
               </a:rPr>
-              <a:t>Xu Hongbo, Zhao Siyu, Shi Tianzi et al.. Journal of controlled release : official journal of the Controlled Release Society. 2026-04-03 DOI: 10.1016/j.jconrel.2026.114827</a:t>
+              <a:t>HM Liu, HB Hu, YY Kuang. … wei chang wai ke …. 2026</a:t>
             </a:r>
             <a:endParaRPr lang="en-US" sz="800" dirty="0"/>
           </a:p>
@@ -7205,7 +7322,7 @@
                   </a:extLst>
                 </a:hlinkClick>
               </a:rPr>
-              <a:t>Engineering Bilosomal Nanocarriers for Targeted Delivery of Resveratrol: Rational Design, Radiotracking Insights and Cytotoxic Assessment.</a:t>
+              <a:t>An HHEX/IKK&amp;#x3b1; positive feedback loop promotes intestinal inflammation.</a:t>
             </a:r>
             <a:endParaRPr lang="en-US" sz="2400" dirty="0"/>
           </a:p>
@@ -7241,7 +7358,7 @@
                   <a:srgbClr val="888888"/>
                 </a:solidFill>
               </a:rPr>
-              <a:t>AAPS PharmSciTech  ·  Basic Research</a:t>
+              <a:t>The Journal of clinical investigation  ·  Basic Research</a:t>
             </a:r>
             <a:endParaRPr lang="en-US" sz="1000" dirty="0"/>
           </a:p>
@@ -7284,7 +7401,7 @@
                 <a:ea typeface="Arial" pitchFamily="34" charset="-122"/>
                 <a:cs typeface="Arial" pitchFamily="34" charset="-120"/>
               </a:rPr>
-              <a:t>Resveratrol suffers from poor solubility.</a:t>
+              <a:t>HHEX is upregulated in IBD samples.</a:t>
             </a:r>
             <a:endParaRPr lang="en-US" sz="1800" dirty="0"/>
           </a:p>
@@ -7305,7 +7422,7 @@
                 <a:ea typeface="Arial" pitchFamily="34" charset="-122"/>
                 <a:cs typeface="Arial" pitchFamily="34" charset="-120"/>
               </a:rPr>
-              <a:t>Bilosomes enhanced tumor accumulation significantly.</a:t>
+              <a:t>HHEX promotes inflammatory cytokine expression.</a:t>
             </a:r>
             <a:endParaRPr lang="en-US" sz="1800" dirty="0"/>
           </a:p>
@@ -7326,7 +7443,49 @@
                 <a:ea typeface="Arial" pitchFamily="34" charset="-122"/>
                 <a:cs typeface="Arial" pitchFamily="34" charset="-120"/>
               </a:rPr>
-              <a:t>Radiotracking enabled precise biodistribution measurement.</a:t>
+              <a:t>IKKα phosphorylates HHEX, stabilizing it.</a:t>
+            </a:r>
+            <a:endParaRPr lang="en-US" sz="1800" dirty="0"/>
+          </a:p>
+          <a:p>
+            <a:pPr marL="342900" indent="-342900">
+              <a:spcAft>
+                <a:spcPts val="800"/>
+              </a:spcAft>
+              <a:buSzPct val="100000"/>
+              <a:buChar char="•"/>
+            </a:pPr>
+            <a:r>
+              <a:rPr lang="en-US" sz="1800" dirty="0">
+                <a:solidFill>
+                  <a:srgbClr val="333333"/>
+                </a:solidFill>
+                <a:latin typeface="Arial" pitchFamily="34" charset="0"/>
+                <a:ea typeface="Arial" pitchFamily="34" charset="-122"/>
+                <a:cs typeface="Arial" pitchFamily="34" charset="-120"/>
+              </a:rPr>
+              <a:t>HHEX activates NF-κB pathway, worsening inflammation.</a:t>
+            </a:r>
+            <a:endParaRPr lang="en-US" sz="1800" dirty="0"/>
+          </a:p>
+          <a:p>
+            <a:pPr marL="342900" indent="-342900">
+              <a:spcAft>
+                <a:spcPts val="800"/>
+              </a:spcAft>
+              <a:buSzPct val="100000"/>
+              <a:buChar char="•"/>
+            </a:pPr>
+            <a:r>
+              <a:rPr lang="en-US" sz="1800" dirty="0">
+                <a:solidFill>
+                  <a:srgbClr val="333333"/>
+                </a:solidFill>
+                <a:latin typeface="Arial" pitchFamily="34" charset="0"/>
+                <a:ea typeface="Arial" pitchFamily="34" charset="-122"/>
+                <a:cs typeface="Arial" pitchFamily="34" charset="-120"/>
+              </a:rPr>
+              <a:t>Identified as potential IBD treatment target.</a:t>
             </a:r>
             <a:endParaRPr lang="en-US" sz="1800" dirty="0"/>
           </a:p>
@@ -7362,7 +7521,7 @@
                   <a:srgbClr val="888888"/>
                 </a:solidFill>
               </a:rPr>
-              <a:t>Attallah Khaled M, Hatem Shymaa, Sayyed Marwa Eid. AAPS PharmSciTech. 2026-05-07 DOI: 10.1208/s12249-026-03441-3</a:t>
+              <a:t>Hua Zhebin, Xu Weimin, Ding Wenjun et al.. The Journal of clinical investigation. 2026-05-15 DOI: 10.1172/JCI192074</a:t>
             </a:r>
             <a:endParaRPr lang="en-US" sz="800" dirty="0"/>
           </a:p>

</xml_diff>

<commit_message>
chore: update weekly digest 2026-05-25
</commit_message>
<xml_diff>
--- a/docs/digest-en.pptx
+++ b/docs/digest-en.pptx
@@ -2249,7 +2249,7 @@
                   <a:srgbClr val="888888"/>
                 </a:solidFill>
               </a:rPr>
-              <a:t>2026-05-11 — 2026-05-18</a:t>
+              <a:t>2026-05-18 — 2026-05-25</a:t>
             </a:r>
             <a:endParaRPr lang="en-US" sz="1400" dirty="0"/>
           </a:p>
@@ -2440,7 +2440,7 @@
                   </a:extLst>
                 </a:hlinkClick>
               </a:rPr>
-              <a:t>The mechanism of acetyl-L-carnitine on colorectal cancer and its metabolomic study.</a:t>
+              <a:t>Dual modulation of Wnt and inflammatory pathways by Gingerenone a inhibits colorectal tumorigenesis.</a:t>
             </a:r>
             <a:endParaRPr lang="en-US" sz="2400" dirty="0"/>
           </a:p>
@@ -2476,7 +2476,7 @@
                   <a:srgbClr val="888888"/>
                 </a:solidFill>
               </a:rPr>
-              <a:t>Journal of pharmaceutical and biomedical analysis  ·  Basic Research</a:t>
+              <a:t>Molecular biology reports  ·  Basic Research</a:t>
             </a:r>
             <a:endParaRPr lang="en-US" sz="1000" dirty="0"/>
           </a:p>
@@ -2519,7 +2519,7 @@
                 <a:ea typeface="Arial" pitchFamily="34" charset="-122"/>
                 <a:cs typeface="Arial" pitchFamily="34" charset="-120"/>
               </a:rPr>
-              <a:t>ALC inhibits HCT116 cell proliferation and migration.</a:t>
+              <a:t>Gingerenone A inhibits Wnt signaling</a:t>
             </a:r>
             <a:endParaRPr lang="en-US" sz="1800" dirty="0"/>
           </a:p>
@@ -2540,7 +2540,7 @@
                 <a:ea typeface="Arial" pitchFamily="34" charset="-122"/>
                 <a:cs typeface="Arial" pitchFamily="34" charset="-120"/>
               </a:rPr>
-              <a:t>Induces cell cycle arrest and apoptosis.</a:t>
+              <a:t>Reduces inflammation and oxidative stress</a:t>
             </a:r>
             <a:endParaRPr lang="en-US" sz="1800" dirty="0"/>
           </a:p>
@@ -2561,7 +2561,7 @@
                 <a:ea typeface="Arial" pitchFamily="34" charset="-122"/>
                 <a:cs typeface="Arial" pitchFamily="34" charset="-120"/>
               </a:rPr>
-              <a:t>Suppresses colorectal tumor growth in vivo.</a:t>
+              <a:t>Promotes apoptosis in CRC cells</a:t>
             </a:r>
             <a:endParaRPr lang="en-US" sz="1800" dirty="0"/>
           </a:p>
@@ -2582,7 +2582,7 @@
                 <a:ea typeface="Arial" pitchFamily="34" charset="-122"/>
                 <a:cs typeface="Arial" pitchFamily="34" charset="-120"/>
               </a:rPr>
-              <a:t>Identified 10 differential metabolites in plasma.</a:t>
+              <a:t>Decreases tumor incidence in rats</a:t>
             </a:r>
             <a:endParaRPr lang="en-US" sz="1800" dirty="0"/>
           </a:p>
@@ -2603,7 +2603,7 @@
                 <a:ea typeface="Arial" pitchFamily="34" charset="-122"/>
                 <a:cs typeface="Arial" pitchFamily="34" charset="-120"/>
               </a:rPr>
-              <a:t>ALC alters multiple metabolic pathways.</a:t>
+              <a:t>Safe with no systemic toxicity</a:t>
             </a:r>
             <a:endParaRPr lang="en-US" sz="1800" dirty="0"/>
           </a:p>
@@ -2639,7 +2639,7 @@
                   <a:srgbClr val="888888"/>
                 </a:solidFill>
               </a:rPr>
-              <a:t>Ning Jiayu, Cai Cuixin, Fan Xingxing et al.. Journal of pharmaceutical and biomedical analysis. 2026-02-09 DOI: 10.1016/j.jpba.2026.117363</a:t>
+              <a:t>Y&amp;#x131;lmaz &amp;#xc7;a&amp;#x11f;atay, K&amp;#x131;r&amp;#x131;ml&amp;#x131;o&amp;#x11f;lu Esma, Elpek G&amp;#xfc;ls&amp;#xfc;m &amp;#xd6;zlem et al.. Molecular biology reports. 2026-05-22 DOI: 10.1007/s11033-026-11989-3</a:t>
             </a:r>
             <a:endParaRPr lang="en-US" sz="800" dirty="0"/>
           </a:p>
@@ -2839,7 +2839,7 @@
                   </a:extLst>
                 </a:hlinkClick>
               </a:rPr>
-              <a:t>… Cancer and Mesothelial Stromal Cell Lines from Malignant Ascites Reveals a Mesothelial‐Stromal FGFR3 Axis as a Potential Vulnerability in Peritoneal Metastasis</a:t>
+              <a:t>Curcumin-loaded extracellular vesicles derived from lactic acid bacteria for alleviation of inflammatory bowel disease.</a:t>
             </a:r>
             <a:endParaRPr lang="en-US" sz="2400" dirty="0"/>
           </a:p>
@@ -2875,7 +2875,7 @@
                   <a:srgbClr val="888888"/>
                 </a:solidFill>
               </a:rPr>
-              <a:t>Cancer …  ·  Basic Research</a:t>
+              <a:t>International journal of pharmaceutics  ·  Basic Research</a:t>
             </a:r>
             <a:endParaRPr lang="en-US" sz="1000" dirty="0"/>
           </a:p>
@@ -2918,7 +2918,7 @@
                 <a:ea typeface="Arial" pitchFamily="34" charset="-122"/>
                 <a:cs typeface="Arial" pitchFamily="34" charset="-120"/>
               </a:rPr>
-              <a:t>Colorectal cancer with peritoneal dissemination</a:t>
+              <a:t>IBD is a chronic inflammatory disorder.</a:t>
             </a:r>
             <a:endParaRPr lang="en-US" sz="1800" dirty="0"/>
           </a:p>
@@ -2939,7 +2939,7 @@
                 <a:ea typeface="Arial" pitchFamily="34" charset="-122"/>
                 <a:cs typeface="Arial" pitchFamily="34" charset="-120"/>
               </a:rPr>
-              <a:t>FGFR3 axis identified as vulnerability</a:t>
+              <a:t>Extracellular vesicles (EVs) from LAB are promising.</a:t>
             </a:r>
             <a:endParaRPr lang="en-US" sz="1800" dirty="0"/>
           </a:p>
@@ -2960,7 +2960,7 @@
                 <a:ea typeface="Arial" pitchFamily="34" charset="-122"/>
                 <a:cs typeface="Arial" pitchFamily="34" charset="-120"/>
               </a:rPr>
-              <a:t>Mesothelial-stromal interactions studied</a:t>
+              <a:t>Curcumin encapsulated in L-EVs-C shows benefits.</a:t>
             </a:r>
             <a:endParaRPr lang="en-US" sz="1800" dirty="0"/>
           </a:p>
@@ -2981,7 +2981,7 @@
                 <a:ea typeface="Arial" pitchFamily="34" charset="-122"/>
                 <a:cs typeface="Arial" pitchFamily="34" charset="-120"/>
               </a:rPr>
-              <a:t>Potential therapeutic targets proposed</a:t>
+              <a:t>L-EVs-C improves gut microbiota composition.</a:t>
             </a:r>
             <a:endParaRPr lang="en-US" sz="1800" dirty="0"/>
           </a:p>
@@ -3002,7 +3002,7 @@
                 <a:ea typeface="Arial" pitchFamily="34" charset="-122"/>
                 <a:cs typeface="Arial" pitchFamily="34" charset="-120"/>
               </a:rPr>
-              <a:t>Experimental models used for research</a:t>
+              <a:t>Natural probiotics EVs may enhance therapies.</a:t>
             </a:r>
             <a:endParaRPr lang="en-US" sz="1800" dirty="0"/>
           </a:p>
@@ -3038,7 +3038,7 @@
                   <a:srgbClr val="888888"/>
                 </a:solidFill>
               </a:rPr>
-              <a:t>Y Fukui, H Kasashima, Z Wang. Cancer …. 2026</a:t>
+              <a:t>Qiu Fang, Wang Baixuan, Zhang Yongjing et al.. International journal of pharmaceutics. 2026-05-08 DOI: 10.1016/j.ijpharm.2026.126859</a:t>
             </a:r>
             <a:endParaRPr lang="en-US" sz="800" dirty="0"/>
           </a:p>
@@ -3238,7 +3238,7 @@
                   </a:extLst>
                 </a:hlinkClick>
               </a:rPr>
-              <a:t>Repurposing PARP inhibitors in molecularly defined subgroups of peritoneal metastatic colorectal cancer (pmCRC): Preclinical analysis of patient-derived xenograft …</a:t>
+              <a:t>Combining PD-L1 blockade with a second-generation HSP110 inhibitor enhances antitumor immunity in colorectal cancer.</a:t>
             </a:r>
             <a:endParaRPr lang="en-US" sz="2400" dirty="0"/>
           </a:p>
@@ -3274,7 +3274,7 @@
                   <a:srgbClr val="888888"/>
                 </a:solidFill>
               </a:rPr>
-              <a:t>Cancer …  ·  Basic Research</a:t>
+              <a:t>Cell death &amp; disease  ·  Basic Research</a:t>
             </a:r>
             <a:endParaRPr lang="en-US" sz="1000" dirty="0"/>
           </a:p>
@@ -3317,7 +3317,7 @@
                 <a:ea typeface="Arial" pitchFamily="34" charset="-122"/>
                 <a:cs typeface="Arial" pitchFamily="34" charset="-120"/>
               </a:rPr>
-              <a:t>pmCRC shows poor prognosis compared to other metastases.</a:t>
+              <a:t>HSP110 inhibition mimics good prognosis phenotype</a:t>
             </a:r>
             <a:endParaRPr lang="en-US" sz="1800" dirty="0"/>
           </a:p>
@@ -3338,7 +3338,7 @@
                 <a:ea typeface="Arial" pitchFamily="34" charset="-122"/>
                 <a:cs typeface="Arial" pitchFamily="34" charset="-120"/>
               </a:rPr>
-              <a:t>PARP inhibitors may benefit specific molecular subgroups.</a:t>
+              <a:t>C7 enhances anti-tumor immunity in CRC</a:t>
             </a:r>
             <a:endParaRPr lang="en-US" sz="1800" dirty="0"/>
           </a:p>
@@ -3359,7 +3359,7 @@
                 <a:ea typeface="Arial" pitchFamily="34" charset="-122"/>
                 <a:cs typeface="Arial" pitchFamily="34" charset="-120"/>
               </a:rPr>
-              <a:t>Patient-derived xenografts used for preclinical analysis.</a:t>
+              <a:t>Combination with anti-PD-L1 improves efficacy</a:t>
             </a:r>
             <a:endParaRPr lang="en-US" sz="1800" dirty="0"/>
           </a:p>
@@ -3395,7 +3395,7 @@
                   <a:srgbClr val="888888"/>
                 </a:solidFill>
               </a:rPr>
-              <a:t>M Dahlmann, B Rau, S Gül-Klein. Cancer …. 2026</a:t>
+              <a:t>Abrey-Recalde Mar&amp;#xed;a Jimena, Mialhe Flavie, Le Thi Khanh et al.. Cell death &amp; disease. 2026-05-18 DOI: 10.1038/s41419-026-08826-7</a:t>
             </a:r>
             <a:endParaRPr lang="en-US" sz="800" dirty="0"/>
           </a:p>
@@ -3586,7 +3586,7 @@
                   <a:srgbClr val="FFFFFF"/>
                 </a:solidFill>
               </a:rPr>
-              <a:t>### 綜合啟示 (Overall Insights)</a:t>
+              <a:t>### 綜合啟示（Overall Insights）</a:t>
             </a:r>
             <a:endParaRPr lang="en-US" sz="1200" dirty="0"/>
           </a:p>
@@ -3612,7 +3612,7 @@
                   <a:srgbClr val="FFFFFF"/>
                 </a:solidFill>
               </a:rPr>
-              <a:t>1. **腸道微生物與癌症關聯**  </a:t>
+              <a:t>1. **腫瘤去減化與化療結合的療效**  </a:t>
             </a:r>
             <a:endParaRPr lang="en-US" sz="1200" dirty="0"/>
           </a:p>
@@ -3629,7 +3629,7 @@
                   <a:srgbClr val="FFFFFF"/>
                 </a:solidFill>
               </a:rPr>
-              <a:t>   The study of *Parasutterella excrementihominis* highlights the significant role of gut microbiota in exacerbating colitis and promoting colorectal cancer through pathogenic mechanisms like NETosis.  </a:t>
+              <a:t>   The combination of tumor debulking and chemotherapy shows promising results in managing multiorgan metastatic colorectal cancer, indicating a potential shift in treatment paradigms.  </a:t>
             </a:r>
             <a:endParaRPr lang="en-US" sz="1200" dirty="0"/>
           </a:p>
@@ -3646,7 +3646,7 @@
                   <a:srgbClr val="FFFFFF"/>
                 </a:solidFill>
               </a:rPr>
-              <a:t>   *Parasutterella excrementihominis* 的研究突顯了腸道微生物在加劇結腸炎和促進結直腸癌中的重要角色，透過如 NETosis 的病理機制。</a:t>
+              <a:t>   腫瘤去減化與化療的結合在多脏器轉移性結直腸癌的管理中顯示出良好的療效，這可能改變治療模式。</a:t>
             </a:r>
             <a:endParaRPr lang="en-US" sz="1200" dirty="0"/>
           </a:p>
@@ -3672,7 +3672,7 @@
                   <a:srgbClr val="FFFFFF"/>
                 </a:solidFill>
               </a:rPr>
-              <a:t>2. **預後指標的潛力**  </a:t>
+              <a:t>2. **微生物組在腸道健康中的角色**  </a:t>
             </a:r>
             <a:endParaRPr lang="en-US" sz="1200" dirty="0"/>
           </a:p>
@@ -3689,7 +3689,7 @@
                   <a:srgbClr val="FFFFFF"/>
                 </a:solidFill>
               </a:rPr>
-              <a:t>   The C-reactive protein-albumin-lymphocyte (CALLY) index and systemic immune-inflammation index (SII) are emerging as valuable prognostic biomarkers for colorectal cancer, although their consistency requires further validation.  </a:t>
+              <a:t>   The pathogenic role of specific gut microbiota, such as Parasutterella excrementihominis, highlights the importance of microbiome-targeted therapies in preventing colorectal cancer.  </a:t>
             </a:r>
             <a:endParaRPr lang="en-US" sz="1200" dirty="0"/>
           </a:p>
@@ -3706,7 +3706,7 @@
                   <a:srgbClr val="FFFFFF"/>
                 </a:solidFill>
               </a:rPr>
-              <a:t>   C-反應蛋白-白蛋白-淋巴細胞 (CALLY) 指數和全身免疫-炎症指數 (SII) 正在成為結直腸癌有價值的預後生物標記，但其一致性需要進一步驗證。</a:t>
+              <a:t>   特定腸道微生物如Parasutterella excrementihominis的致病角色突顯了以微生物組為目標的療法在預防結直腸癌中的重要性。</a:t>
             </a:r>
             <a:endParaRPr lang="en-US" sz="1200" dirty="0"/>
           </a:p>
@@ -3732,7 +3732,7 @@
                   <a:srgbClr val="FFFFFF"/>
                 </a:solidFill>
               </a:rPr>
-              <a:t>3. **化療的應用與挑戰**  </a:t>
+              <a:t>3. **炎症與癌症發展的關聯**  </a:t>
             </a:r>
             <a:endParaRPr lang="en-US" sz="1200" dirty="0"/>
           </a:p>
@@ -3749,7 +3749,7 @@
                   <a:srgbClr val="FFFFFF"/>
                 </a:solidFill>
               </a:rPr>
-              <a:t>   Hyperthermic intraperitoneal chemotherapy (HIPEC) shows promise for patients with advanced colorectal cancer, yet its effectiveness is contingent on tumor characteristics and patient selection.  </a:t>
+              <a:t>   Chronic inflammation is a critical factor in colorectal cancer progression, suggesting that anti-inflammatory strategies could be effective in cancer prevention.  </a:t>
             </a:r>
             <a:endParaRPr lang="en-US" sz="1200" dirty="0"/>
           </a:p>
@@ -3766,7 +3766,7 @@
                   <a:srgbClr val="FFFFFF"/>
                 </a:solidFill>
               </a:rPr>
-              <a:t>   高溫腹腔化療 (HIPEC) 對於晚期結直腸癌患者顯示出希望，但其有效性取決於腫瘤特徵和患者選擇。</a:t>
+              <a:t>   慢性炎症是結直腸癌進展的關鍵因素，這表明抗炎策略可能在癌症預防中有效。</a:t>
             </a:r>
             <a:endParaRPr lang="en-US" sz="1200" dirty="0"/>
           </a:p>
@@ -3792,7 +3792,7 @@
                   <a:srgbClr val="FFFFFF"/>
                 </a:solidFill>
               </a:rPr>
-              <a:t>4. **炎症性腸病的癌症風險認知**  </a:t>
+              <a:t>4. **生物標記物的預測能力**  </a:t>
             </a:r>
             <a:endParaRPr lang="en-US" sz="1200" dirty="0"/>
           </a:p>
@@ -3809,7 +3809,7 @@
                   <a:srgbClr val="FFFFFF"/>
                 </a:solidFill>
               </a:rPr>
-              <a:t>   There is a critical need for increased awareness and education regarding the colorectal cancer risk associated with inflammatory bowel disease among patients, as current knowledge appears limited.  </a:t>
+              <a:t>   The C-reactive protein-albumin-lymphocyte (CALLY) index and systemic immune-inflammation index (SII) show potential as prognostic biomarkers, though further validation is needed.  </a:t>
             </a:r>
             <a:endParaRPr lang="en-US" sz="1200" dirty="0"/>
           </a:p>
@@ -3826,7 +3826,7 @@
                   <a:srgbClr val="FFFFFF"/>
                 </a:solidFill>
               </a:rPr>
-              <a:t>   目前患者對於炎症性腸病相關結直腸癌風險的認知顯示出明顯不足，因此需要加強相關的認知與教育。</a:t>
+              <a:t>   C反應蛋白-白蛋白-淋巴細胞（CALLY）指數和全身免疫炎症指數（SII）顯示出作為預後生物標記物的潛力，但仍需進一步驗證。</a:t>
             </a:r>
             <a:endParaRPr lang="en-US" sz="1200" dirty="0"/>
           </a:p>
@@ -3852,7 +3852,7 @@
                   <a:srgbClr val="FFFFFF"/>
                 </a:solidFill>
               </a:rPr>
-              <a:t>5. **新療法的開發潛力**  </a:t>
+              <a:t>5. **天然化合物的抗腫瘤潛力**  </a:t>
             </a:r>
             <a:endParaRPr lang="en-US" sz="1200" dirty="0"/>
           </a:p>
@@ -3869,24 +3869,7 @@
                   <a:srgbClr val="FFFFFF"/>
                 </a:solidFill>
               </a:rPr>
-              <a:t>   The identification of molecular pathways, such as the HHEX/IKKα feedback loop, opens new avenues for targeted therapies in inflammatory bowel diseases and related colorectal cancer.  </a:t>
-            </a:r>
-            <a:endParaRPr lang="en-US" sz="1200" dirty="0"/>
-          </a:p>
-          <a:p>
-            <a:pPr indent="0" marL="0">
-              <a:lnSpc>
-                <a:spcPct val="150000"/>
-              </a:lnSpc>
-              <a:buNone/>
-            </a:pPr>
-            <a:r>
-              <a:rPr lang="en-US" sz="1200" dirty="0">
-                <a:solidFill>
-                  <a:srgbClr val="FFFFFF"/>
-                </a:solidFill>
-              </a:rPr>
-              <a:t>   HHEX/IKKα 反饋迴路等分子通路的識別為針對炎症性腸病及相關結直腸癌的新療法開啟了新的可能性。</a:t>
+              <a:t>   Natural compounds like Gingerenone a demonstrate dual modulation of Wnt and inflammatory pathways, offering a novel approach for colorectal cancer treatment.</a:t>
             </a:r>
             <a:endParaRPr lang="en-US" sz="1200" dirty="0"/>
           </a:p>
@@ -4032,7 +4015,7 @@
                   <a:srgbClr val="FFFFFF"/>
                 </a:solidFill>
               </a:rPr>
-              <a:t>### 未來研究方向 (Future Research Directions)</a:t>
+              <a:t>像Gingerenone a這樣的天然化合物顯示出對Wnt和炎症通路的雙重調節，為結直腸癌治療提供了新方法。</a:t>
             </a:r>
             <a:endParaRPr lang="en-US" sz="1200" dirty="0"/>
           </a:p>
@@ -4058,7 +4041,7 @@
                   <a:srgbClr val="FFFFFF"/>
                 </a:solidFill>
               </a:rPr>
-              <a:t>1. **腸道微生物的功能性研究**  </a:t>
+              <a:t>### 未來研究方向（Future Research Directions）</a:t>
             </a:r>
             <a:endParaRPr lang="en-US" sz="1200" dirty="0"/>
           </a:p>
@@ -4069,14 +4052,6 @@
               </a:lnSpc>
               <a:buNone/>
             </a:pPr>
-            <a:r>
-              <a:rPr lang="en-US" sz="1200" dirty="0">
-                <a:solidFill>
-                  <a:srgbClr val="FFFFFF"/>
-                </a:solidFill>
-              </a:rPr>
-              <a:t>   Future studies should delve deeper into the functional roles of specific gut microbiota, like *Parasutterella excrementihominis*, in colorectal cancer progression and treatment responses.  </a:t>
-            </a:r>
             <a:endParaRPr lang="en-US" sz="1200" dirty="0"/>
           </a:p>
           <a:p>
@@ -4092,7 +4067,7 @@
                   <a:srgbClr val="FFFFFF"/>
                 </a:solidFill>
               </a:rPr>
-              <a:t>   未來的研究應深入探討特定腸道微生物（如 *Parasutterella excrementihominis*）在結直腸癌進展和治療反應中的功能角色。</a:t>
+              <a:t>1. **微生物組與腸道癌症的關聯研究**  </a:t>
             </a:r>
             <a:endParaRPr lang="en-US" sz="1200" dirty="0"/>
           </a:p>
@@ -4103,6 +4078,14 @@
               </a:lnSpc>
               <a:buNone/>
             </a:pPr>
+            <a:r>
+              <a:rPr lang="en-US" sz="1200" dirty="0">
+                <a:solidFill>
+                  <a:srgbClr val="FFFFFF"/>
+                </a:solidFill>
+              </a:rPr>
+              <a:t>   Investigating the complex interactions between gut microbiota and colorectal cancer could lead to novel therapeutic strategies and preventive measures.  </a:t>
+            </a:r>
             <a:endParaRPr lang="en-US" sz="1200" dirty="0"/>
           </a:p>
           <a:p>
@@ -4118,7 +4101,7 @@
                   <a:srgbClr val="FFFFFF"/>
                 </a:solidFill>
               </a:rPr>
-              <a:t>2. **預後指標的標準化**  </a:t>
+              <a:t>   探索腸道微生物組與結直腸癌之間的複雜互動可能會導致新的治療策略和預防措施。</a:t>
             </a:r>
             <a:endParaRPr lang="en-US" sz="1200" dirty="0"/>
           </a:p>
@@ -4129,14 +4112,6 @@
               </a:lnSpc>
               <a:buNone/>
             </a:pPr>
-            <a:r>
-              <a:rPr lang="en-US" sz="1200" dirty="0">
-                <a:solidFill>
-                  <a:srgbClr val="FFFFFF"/>
-                </a:solidFill>
-              </a:rPr>
-              <a:t>   There is a need for standardization of prognostic indices such as CALLY and SII to enhance their clinical applicability and reliability in colorectal cancer management.  </a:t>
-            </a:r>
             <a:endParaRPr lang="en-US" sz="1200" dirty="0"/>
           </a:p>
           <a:p>
@@ -4152,7 +4127,7 @@
                   <a:srgbClr val="FFFFFF"/>
                 </a:solidFill>
               </a:rPr>
-              <a:t>   需要對預後指標如 CALLY 和 SII 進行標準化，以提高其在結直腸癌管理中的臨床應用性和可靠性。</a:t>
+              <a:t>2. **新型生物標記物的開發**  </a:t>
             </a:r>
             <a:endParaRPr lang="en-US" sz="1200" dirty="0"/>
           </a:p>
@@ -4163,6 +4138,14 @@
               </a:lnSpc>
               <a:buNone/>
             </a:pPr>
+            <a:r>
+              <a:rPr lang="en-US" sz="1200" dirty="0">
+                <a:solidFill>
+                  <a:srgbClr val="FFFFFF"/>
+                </a:solidFill>
+              </a:rPr>
+              <a:t>   Future studies should focus on identifying and validating new biomarkers that can predict treatment responses and outcomes in colorectal cancer patients.  </a:t>
+            </a:r>
             <a:endParaRPr lang="en-US" sz="1200" dirty="0"/>
           </a:p>
           <a:p>
@@ -4178,7 +4161,7 @@
                   <a:srgbClr val="FFFFFF"/>
                 </a:solidFill>
               </a:rPr>
-              <a:t>3. **HIPEC的長期效果研究**  </a:t>
+              <a:t>   未來的研究應集中於識別和驗證能預測結直腸癌患者治療反應和結果的新型生物標記物。</a:t>
             </a:r>
             <a:endParaRPr lang="en-US" sz="1200" dirty="0"/>
           </a:p>
@@ -4189,14 +4172,6 @@
               </a:lnSpc>
               <a:buNone/>
             </a:pPr>
-            <a:r>
-              <a:rPr lang="en-US" sz="1200" dirty="0">
-                <a:solidFill>
-                  <a:srgbClr val="FFFFFF"/>
-                </a:solidFill>
-              </a:rPr>
-              <a:t>   Long-term outcomes of hyperthermic intraperitoneal chemotherapy should be evaluated in larger, randomized clinical trials to determine its true efficacy and safety profile.  </a:t>
-            </a:r>
             <a:endParaRPr lang="en-US" sz="1200" dirty="0"/>
           </a:p>
           <a:p>
@@ -4212,7 +4187,7 @@
                   <a:srgbClr val="FFFFFF"/>
                 </a:solidFill>
               </a:rPr>
-              <a:t>   應在更大規模的隨機臨床試驗中評估高溫腹腔化療的長期效果，以確定其真正的有效性和安全性。</a:t>
+              <a:t>3. **抗炎療法的臨床應用**  </a:t>
             </a:r>
             <a:endParaRPr lang="en-US" sz="1200" dirty="0"/>
           </a:p>
@@ -4223,6 +4198,14 @@
               </a:lnSpc>
               <a:buNone/>
             </a:pPr>
+            <a:r>
+              <a:rPr lang="en-US" sz="1200" dirty="0">
+                <a:solidFill>
+                  <a:srgbClr val="FFFFFF"/>
+                </a:solidFill>
+              </a:rPr>
+              <a:t>   Clinical trials assessing the efficacy of anti-inflammatory therapies in colorectal cancer prevention and treatment should be prioritized.  </a:t>
+            </a:r>
             <a:endParaRPr lang="en-US" sz="1200" dirty="0"/>
           </a:p>
           <a:p>
@@ -4238,7 +4221,7 @@
                   <a:srgbClr val="FFFFFF"/>
                 </a:solidFill>
               </a:rPr>
-              <a:t>4. **炎症性腸病患者的教育介入**  </a:t>
+              <a:t>   應優先進行臨床試驗，評估抗炎療法在結直腸癌預防和治療中的有效性。</a:t>
             </a:r>
             <a:endParaRPr lang="en-US" sz="1200" dirty="0"/>
           </a:p>
@@ -4249,14 +4232,6 @@
               </a:lnSpc>
               <a:buNone/>
             </a:pPr>
-            <a:r>
-              <a:rPr lang="en-US" sz="1200" dirty="0">
-                <a:solidFill>
-                  <a:srgbClr val="FFFFFF"/>
-                </a:solidFill>
-              </a:rPr>
-              <a:t>   Research should focus on developing and implementing educational interventions for patients with inflammatory bowel disease to improve their understanding of cancer risks and management strategies.  </a:t>
-            </a:r>
             <a:endParaRPr lang="en-US" sz="1200" dirty="0"/>
           </a:p>
           <a:p>
@@ -4272,7 +4247,7 @@
                   <a:srgbClr val="FFFFFF"/>
                 </a:solidFill>
               </a:rPr>
-              <a:t>   研究應專注於為炎症性腸病患者開發和實施教育介入，以提高他們對癌症風險和管理策略的理解。</a:t>
+              <a:t>4. **天然化合物的機制研究**  </a:t>
             </a:r>
             <a:endParaRPr lang="en-US" sz="1200" dirty="0"/>
           </a:p>
@@ -4283,6 +4258,14 @@
               </a:lnSpc>
               <a:buNone/>
             </a:pPr>
+            <a:r>
+              <a:rPr lang="en-US" sz="1200" dirty="0">
+                <a:solidFill>
+                  <a:srgbClr val="FFFFFF"/>
+                </a:solidFill>
+              </a:rPr>
+              <a:t>   Further exploration of the mechanisms by which natural compounds exert their anti-cancer effects could enhance their therapeutic application in clinical settings.  </a:t>
+            </a:r>
             <a:endParaRPr lang="en-US" sz="1200" dirty="0"/>
           </a:p>
           <a:p>
@@ -4298,7 +4281,7 @@
                   <a:srgbClr val="FFFFFF"/>
                 </a:solidFill>
               </a:rPr>
-              <a:t>5. **新靶向療法的臨床試驗**  </a:t>
+              <a:t>   進一步探索天然化合物發揮抗癌作用的機制可能會增強其在臨床應用中的療效。</a:t>
             </a:r>
             <a:endParaRPr lang="en-US" sz="1200" dirty="0"/>
           </a:p>
@@ -4309,14 +4292,6 @@
               </a:lnSpc>
               <a:buNone/>
             </a:pPr>
-            <a:r>
-              <a:rPr lang="en-US" sz="1200" dirty="0">
-                <a:solidFill>
-                  <a:srgbClr val="FFFFFF"/>
-                </a:solidFill>
-              </a:rPr>
-              <a:t>   Clinical trials investigating novel targeted therapies based on newly identified molecular pathways, such as the HHEX/IKKα loop, are essential to advance treatment options for colorectal cancer.  </a:t>
-            </a:r>
             <a:endParaRPr lang="en-US" sz="1200" dirty="0"/>
           </a:p>
           <a:p>
@@ -4332,7 +4307,41 @@
                   <a:srgbClr val="FFFFFF"/>
                 </a:solidFill>
               </a:rPr>
-              <a:t>   基於新識別的分子通路（如 HHEX/IKKα 迴路）開展的新靶向療法臨床試驗對於推進結直腸癌的治療選擇至關重要。</a:t>
+              <a:t>5. **多模態治療的整合研究**  </a:t>
+            </a:r>
+            <a:endParaRPr lang="en-US" sz="1200" dirty="0"/>
+          </a:p>
+          <a:p>
+            <a:pPr indent="0" marL="0">
+              <a:lnSpc>
+                <a:spcPct val="150000"/>
+              </a:lnSpc>
+              <a:buNone/>
+            </a:pPr>
+            <a:r>
+              <a:rPr lang="en-US" sz="1200" dirty="0">
+                <a:solidFill>
+                  <a:srgbClr val="FFFFFF"/>
+                </a:solidFill>
+              </a:rPr>
+              <a:t>   Research on integrating multimodal treatment approaches, including surgery, chemotherapy, and immunotherapy, is essential for improving patient outcomes in colorectal cancer.  </a:t>
+            </a:r>
+            <a:endParaRPr lang="en-US" sz="1200" dirty="0"/>
+          </a:p>
+          <a:p>
+            <a:pPr indent="0" marL="0">
+              <a:lnSpc>
+                <a:spcPct val="150000"/>
+              </a:lnSpc>
+              <a:buNone/>
+            </a:pPr>
+            <a:r>
+              <a:rPr lang="en-US" sz="1200" dirty="0">
+                <a:solidFill>
+                  <a:srgbClr val="FFFFFF"/>
+                </a:solidFill>
+              </a:rPr>
+              <a:t>   研究整合多模態治療方法，包括手術、化療和免疫療法，對於改善結直腸癌患者的結果至關重要。</a:t>
             </a:r>
             <a:endParaRPr lang="en-US" sz="1200" dirty="0"/>
           </a:p>
@@ -4566,7 +4575,7 @@
                 <a:ea typeface="Arial" pitchFamily="34" charset="-122"/>
                 <a:cs typeface="Arial" pitchFamily="34" charset="-120"/>
               </a:rPr>
-              <a:t>Parasutterella excrementihominis exacerbates experimental colitis and colitis-as…</a:t>
+              <a:t>Tumor debulking in combination with chemotherapy in multiorgan metastatic colore…</a:t>
             </a:r>
             <a:endParaRPr lang="en-US" sz="1400" dirty="0"/>
           </a:p>
@@ -4603,7 +4612,7 @@
                 <a:ea typeface="Arial" pitchFamily="34" charset="-122"/>
                 <a:cs typeface="Arial" pitchFamily="34" charset="-120"/>
               </a:rPr>
-              <a:t>Effect of hyperthermic intraperitoneal chemotherapy on patients with advanced co…</a:t>
+              <a:t>Parasutterella excrementihominis exacerbates experimental colitis and colitis-as…</a:t>
             </a:r>
             <a:endParaRPr lang="en-US" sz="1400" dirty="0"/>
           </a:p>
@@ -4640,7 +4649,7 @@
                 <a:ea typeface="Arial" pitchFamily="34" charset="-122"/>
                 <a:cs typeface="Arial" pitchFamily="34" charset="-120"/>
               </a:rPr>
-              <a:t>Predictive utility of the C-reactive protein-albumin-lymphocyte (CALLY) index in…</a:t>
+              <a:t>Abdominal ultrasound attenuates early-stage aberrant proliferation and depressiv…</a:t>
             </a:r>
             <a:endParaRPr lang="en-US" sz="1400" dirty="0"/>
           </a:p>
@@ -4677,7 +4686,7 @@
                 <a:ea typeface="Arial" pitchFamily="34" charset="-122"/>
                 <a:cs typeface="Arial" pitchFamily="34" charset="-120"/>
               </a:rPr>
-              <a:t>Prognostic value of systemic immune-inflammation index for colorectal cancer: a …</a:t>
+              <a:t>Predictive utility of the C-reactive protein-albumin-lymphocyte (CALLY) index in…</a:t>
             </a:r>
             <a:endParaRPr lang="en-US" sz="1400" dirty="0"/>
           </a:p>
@@ -4714,7 +4723,7 @@
                 <a:ea typeface="Arial" pitchFamily="34" charset="-122"/>
                 <a:cs typeface="Arial" pitchFamily="34" charset="-120"/>
               </a:rPr>
-              <a:t>Awareness of inflammatory bowel disease-associated colorectal cancer risk and it…</a:t>
+              <a:t>Prognostic value of systemic immune-inflammation index for colorectal cancer: a …</a:t>
             </a:r>
             <a:endParaRPr lang="en-US" sz="1400" dirty="0"/>
           </a:p>
@@ -4751,7 +4760,7 @@
                 <a:ea typeface="Arial" pitchFamily="34" charset="-122"/>
                 <a:cs typeface="Arial" pitchFamily="34" charset="-120"/>
               </a:rPr>
-              <a:t>… of mFOLFOXIRI plus bevacizumab combined with cytoreductive surgery for resecta…</a:t>
+              <a:t>Enhanced recovery after surgery pathways and postoperative gastrointestinal func…</a:t>
             </a:r>
             <a:endParaRPr lang="en-US" sz="1400" dirty="0"/>
           </a:p>
@@ -4788,7 +4797,7 @@
                 <a:ea typeface="Arial" pitchFamily="34" charset="-122"/>
                 <a:cs typeface="Arial" pitchFamily="34" charset="-120"/>
               </a:rPr>
-              <a:t>An HHEX/IKK&amp;#x3b1; positive feedback loop promotes intestinal inflammation.</a:t>
+              <a:t>Oncometabolite signatures from tumor-stroma crosstalk as potential non-invasive …</a:t>
             </a:r>
             <a:endParaRPr lang="en-US" sz="1400" dirty="0"/>
           </a:p>
@@ -4825,7 +4834,7 @@
                 <a:ea typeface="Arial" pitchFamily="34" charset="-122"/>
                 <a:cs typeface="Arial" pitchFamily="34" charset="-120"/>
               </a:rPr>
-              <a:t>The mechanism of acetyl-L-carnitine on colorectal cancer and its metabolomic stu…</a:t>
+              <a:t>Dual modulation of Wnt and inflammatory pathways by Gingerenone a inhibits color…</a:t>
             </a:r>
             <a:endParaRPr lang="en-US" sz="1400" dirty="0"/>
           </a:p>
@@ -4862,7 +4871,7 @@
                 <a:ea typeface="Arial" pitchFamily="34" charset="-122"/>
                 <a:cs typeface="Arial" pitchFamily="34" charset="-120"/>
               </a:rPr>
-              <a:t>… Cancer and Mesothelial Stromal Cell Lines from Malignant Ascites Reveals a Mes…</a:t>
+              <a:t>Curcumin-loaded extracellular vesicles derived from lactic acid bacteria for all…</a:t>
             </a:r>
             <a:endParaRPr lang="en-US" sz="1400" dirty="0"/>
           </a:p>
@@ -4899,7 +4908,7 @@
                 <a:ea typeface="Arial" pitchFamily="34" charset="-122"/>
                 <a:cs typeface="Arial" pitchFamily="34" charset="-120"/>
               </a:rPr>
-              <a:t>Repurposing PARP inhibitors in molecularly defined subgroups of peritoneal metas…</a:t>
+              <a:t>Combining PD-L1 blockade with a second-generation HSP110 inhibitor enhances anti…</a:t>
             </a:r>
             <a:endParaRPr lang="en-US" sz="1400" dirty="0"/>
           </a:p>
@@ -5054,7 +5063,7 @@
                   </a:extLst>
                 </a:hlinkClick>
               </a:rPr>
-              <a:t>Parasutterella excrementihominis exacerbates experimental colitis and colitis-associated colorectal cancer via pathogenic NETosis activation</a:t>
+              <a:t>Tumor debulking in combination with chemotherapy in multiorgan metastatic colorectal cancer: The ORCHESTRA randomized clinical trial</a:t>
             </a:r>
             <a:endParaRPr lang="en-US" sz="2400" dirty="0"/>
           </a:p>
@@ -5090,7 +5099,7 @@
                   <a:srgbClr val="888888"/>
                 </a:solidFill>
               </a:rPr>
-              <a:t>Gut  ·  IF 24.5</a:t>
+              <a:t>JAMA  ·  IF 63.1</a:t>
             </a:r>
             <a:endParaRPr lang="en-US" sz="1000" dirty="0"/>
           </a:p>
@@ -5133,7 +5142,7 @@
                 <a:ea typeface="Arial" pitchFamily="34" charset="-122"/>
                 <a:cs typeface="Arial" pitchFamily="34" charset="-120"/>
               </a:rPr>
-              <a:t>P. excrementihominis worsens colitis symptoms.</a:t>
+              <a:t>Study on tumor debulking effectiveness</a:t>
             </a:r>
             <a:endParaRPr lang="en-US" sz="1800" dirty="0"/>
           </a:p>
@@ -5154,7 +5163,7 @@
                 <a:ea typeface="Arial" pitchFamily="34" charset="-122"/>
                 <a:cs typeface="Arial" pitchFamily="34" charset="-120"/>
               </a:rPr>
-              <a:t>NETosis activation linked to cancer progression.</a:t>
+              <a:t>Combination with chemotherapy assessed</a:t>
             </a:r>
             <a:endParaRPr lang="en-US" sz="1800" dirty="0"/>
           </a:p>
@@ -5175,7 +5184,49 @@
                 <a:ea typeface="Arial" pitchFamily="34" charset="-122"/>
                 <a:cs typeface="Arial" pitchFamily="34" charset="-120"/>
               </a:rPr>
-              <a:t>Study suggests new therapeutic strategies.</a:t>
+              <a:t>Focus on multiorgan metastatic colorectal cancer</a:t>
+            </a:r>
+            <a:endParaRPr lang="en-US" sz="1800" dirty="0"/>
+          </a:p>
+          <a:p>
+            <a:pPr marL="342900" indent="-342900">
+              <a:spcAft>
+                <a:spcPts val="800"/>
+              </a:spcAft>
+              <a:buSzPct val="100000"/>
+              <a:buChar char="•"/>
+            </a:pPr>
+            <a:r>
+              <a:rPr lang="en-US" sz="1800" dirty="0">
+                <a:solidFill>
+                  <a:srgbClr val="333333"/>
+                </a:solidFill>
+                <a:latin typeface="Arial" pitchFamily="34" charset="0"/>
+                <a:ea typeface="Arial" pitchFamily="34" charset="-122"/>
+                <a:cs typeface="Arial" pitchFamily="34" charset="-120"/>
+              </a:rPr>
+              <a:t>Results from ORCHESTRA randomized trial</a:t>
+            </a:r>
+            <a:endParaRPr lang="en-US" sz="1800" dirty="0"/>
+          </a:p>
+          <a:p>
+            <a:pPr marL="342900" indent="-342900">
+              <a:spcAft>
+                <a:spcPts val="800"/>
+              </a:spcAft>
+              <a:buSzPct val="100000"/>
+              <a:buChar char="•"/>
+            </a:pPr>
+            <a:r>
+              <a:rPr lang="en-US" sz="1800" dirty="0">
+                <a:solidFill>
+                  <a:srgbClr val="333333"/>
+                </a:solidFill>
+                <a:latin typeface="Arial" pitchFamily="34" charset="0"/>
+                <a:ea typeface="Arial" pitchFamily="34" charset="-122"/>
+                <a:cs typeface="Arial" pitchFamily="34" charset="-120"/>
+              </a:rPr>
+              <a:t>Subgroup analysis with P &lt; .05</a:t>
             </a:r>
             <a:endParaRPr lang="en-US" sz="1800" dirty="0"/>
           </a:p>
@@ -5211,7 +5262,7 @@
                   <a:srgbClr val="888888"/>
                 </a:solidFill>
               </a:rPr>
-              <a:t>H Tan, L Huang, J Wang. Gut. 2026</a:t>
+              <a:t>EC Gootjes, L Bakkerus, AA Adhin. JAMA. 2026</a:t>
             </a:r>
             <a:endParaRPr lang="en-US" sz="800" dirty="0"/>
           </a:p>
@@ -5411,7 +5462,7 @@
                   </a:extLst>
                 </a:hlinkClick>
               </a:rPr>
-              <a:t>Effect of hyperthermic intraperitoneal chemotherapy on patients with advanced colorectal cancer: a systematic review and meta-analysis</a:t>
+              <a:t>Parasutterella excrementihominis exacerbates experimental colitis and colitis-associated colorectal cancer via pathogenic NETosis activation</a:t>
             </a:r>
             <a:endParaRPr lang="en-US" sz="2400" dirty="0"/>
           </a:p>
@@ -5447,7 +5498,7 @@
                   <a:srgbClr val="888888"/>
                 </a:solidFill>
               </a:rPr>
-              <a:t>World Journal of …  ·  Meta-Analysis</a:t>
+              <a:t>Gut  ·  IF 24.5</a:t>
             </a:r>
             <a:endParaRPr lang="en-US" sz="1000" dirty="0"/>
           </a:p>
@@ -5490,7 +5541,7 @@
                 <a:ea typeface="Arial" pitchFamily="34" charset="-122"/>
                 <a:cs typeface="Arial" pitchFamily="34" charset="-120"/>
               </a:rPr>
-              <a:t>Hyperthermic intraperitoneal chemotherapy (HIPEC) evaluated</a:t>
+              <a:t>P. excrementihominis worsens colitis severity.</a:t>
             </a:r>
             <a:endParaRPr lang="en-US" sz="1800" dirty="0"/>
           </a:p>
@@ -5511,7 +5562,7 @@
                 <a:ea typeface="Arial" pitchFamily="34" charset="-122"/>
                 <a:cs typeface="Arial" pitchFamily="34" charset="-120"/>
               </a:rPr>
-              <a:t>Systematic review and meta-analysis conducted</a:t>
+              <a:t>NETosis activation linked to cancer progression.</a:t>
             </a:r>
             <a:endParaRPr lang="en-US" sz="1800" dirty="0"/>
           </a:p>
@@ -5532,49 +5583,7 @@
                 <a:ea typeface="Arial" pitchFamily="34" charset="-122"/>
                 <a:cs typeface="Arial" pitchFamily="34" charset="-120"/>
               </a:rPr>
-              <a:t>Focus on advanced colorectal cancer patients</a:t>
-            </a:r>
-            <a:endParaRPr lang="en-US" sz="1800" dirty="0"/>
-          </a:p>
-          <a:p>
-            <a:pPr marL="342900" indent="-342900">
-              <a:spcAft>
-                <a:spcPts val="800"/>
-              </a:spcAft>
-              <a:buSzPct val="100000"/>
-              <a:buChar char="•"/>
-            </a:pPr>
-            <a:r>
-              <a:rPr lang="en-US" sz="1800" dirty="0">
-                <a:solidFill>
-                  <a:srgbClr val="333333"/>
-                </a:solidFill>
-                <a:latin typeface="Arial" pitchFamily="34" charset="0"/>
-                <a:ea typeface="Arial" pitchFamily="34" charset="-122"/>
-                <a:cs typeface="Arial" pitchFamily="34" charset="-120"/>
-              </a:rPr>
-              <a:t>Impact on peritoneal metastases assessed</a:t>
-            </a:r>
-            <a:endParaRPr lang="en-US" sz="1800" dirty="0"/>
-          </a:p>
-          <a:p>
-            <a:pPr marL="342900" indent="-342900">
-              <a:spcAft>
-                <a:spcPts val="800"/>
-              </a:spcAft>
-              <a:buSzPct val="100000"/>
-              <a:buChar char="•"/>
-            </a:pPr>
-            <a:r>
-              <a:rPr lang="en-US" sz="1800" dirty="0">
-                <a:solidFill>
-                  <a:srgbClr val="333333"/>
-                </a:solidFill>
-                <a:latin typeface="Arial" pitchFamily="34" charset="0"/>
-                <a:ea typeface="Arial" pitchFamily="34" charset="-122"/>
-                <a:cs typeface="Arial" pitchFamily="34" charset="-120"/>
-              </a:rPr>
-              <a:t>Potential benefits and risks discussed</a:t>
+              <a:t>Potential for new therapeutic strategies.</a:t>
             </a:r>
             <a:endParaRPr lang="en-US" sz="1800" dirty="0"/>
           </a:p>
@@ -5610,7 +5619,7 @@
                   <a:srgbClr val="888888"/>
                 </a:solidFill>
               </a:rPr>
-              <a:t>Z Su, Y Guo, X Ru. World Journal of …. 2026</a:t>
+              <a:t>H Tan, L Huang, J Wang. Gut. 2026</a:t>
             </a:r>
             <a:endParaRPr lang="en-US" sz="800" dirty="0"/>
           </a:p>
@@ -5810,7 +5819,7 @@
                   </a:extLst>
                 </a:hlinkClick>
               </a:rPr>
-              <a:t>Predictive utility of the C-reactive protein-albumin-lymphocyte (CALLY) index in Colorectal cancer: A meta-analysis</a:t>
+              <a:t>Abdominal ultrasound attenuates early-stage aberrant proliferation and depressive behavior in AOM/DSS-induced colorectal cancer: regulatory mechanisms of the Wnt/&amp;#x3b2;-catenin pathway and HPA axis.</a:t>
             </a:r>
             <a:endParaRPr lang="en-US" sz="2400" dirty="0"/>
           </a:p>
@@ -5846,7 +5855,7 @@
                   <a:srgbClr val="888888"/>
                 </a:solidFill>
               </a:rPr>
-              <a:t>Clinics and Research in Hepatology and …  ·  Meta-Analysis</a:t>
+              <a:t>Brain, behavior, and immunity  ·  🌏 Asia</a:t>
             </a:r>
             <a:endParaRPr lang="en-US" sz="1000" dirty="0"/>
           </a:p>
@@ -5889,7 +5898,7 @@
                 <a:ea typeface="Arial" pitchFamily="34" charset="-122"/>
                 <a:cs typeface="Arial" pitchFamily="34" charset="-120"/>
               </a:rPr>
-              <a:t>CALLY index predicts CRC outcomes.</a:t>
+              <a:t>AUS reduces inflammation in CRC models.</a:t>
             </a:r>
             <a:endParaRPr lang="en-US" sz="1800" dirty="0"/>
           </a:p>
@@ -5910,7 +5919,7 @@
                 <a:ea typeface="Arial" pitchFamily="34" charset="-122"/>
                 <a:cs typeface="Arial" pitchFamily="34" charset="-120"/>
               </a:rPr>
-              <a:t>Meta-analysis of multiple studies.</a:t>
+              <a:t>LIPUS improves depressive behavior in mice.</a:t>
             </a:r>
             <a:endParaRPr lang="en-US" sz="1800" dirty="0"/>
           </a:p>
@@ -5931,7 +5940,49 @@
                 <a:ea typeface="Arial" pitchFamily="34" charset="-122"/>
                 <a:cs typeface="Arial" pitchFamily="34" charset="-120"/>
               </a:rPr>
-              <a:t>Inconsistent prognostic performance observed.</a:t>
+              <a:t>Wnt/β-catenin pathway is modulated.</a:t>
+            </a:r>
+            <a:endParaRPr lang="en-US" sz="1800" dirty="0"/>
+          </a:p>
+          <a:p>
+            <a:pPr marL="342900" indent="-342900">
+              <a:spcAft>
+                <a:spcPts val="800"/>
+              </a:spcAft>
+              <a:buSzPct val="100000"/>
+              <a:buChar char="•"/>
+            </a:pPr>
+            <a:r>
+              <a:rPr lang="en-US" sz="1800" dirty="0">
+                <a:solidFill>
+                  <a:srgbClr val="333333"/>
+                </a:solidFill>
+                <a:latin typeface="Arial" pitchFamily="34" charset="0"/>
+                <a:ea typeface="Arial" pitchFamily="34" charset="-122"/>
+                <a:cs typeface="Arial" pitchFamily="34" charset="-120"/>
+              </a:rPr>
+              <a:t>HPA axis hyperactivity is downregulated.</a:t>
+            </a:r>
+            <a:endParaRPr lang="en-US" sz="1800" dirty="0"/>
+          </a:p>
+          <a:p>
+            <a:pPr marL="342900" indent="-342900">
+              <a:spcAft>
+                <a:spcPts val="800"/>
+              </a:spcAft>
+              <a:buSzPct val="100000"/>
+              <a:buChar char="•"/>
+            </a:pPr>
+            <a:r>
+              <a:rPr lang="en-US" sz="1800" dirty="0">
+                <a:solidFill>
+                  <a:srgbClr val="333333"/>
+                </a:solidFill>
+                <a:latin typeface="Arial" pitchFamily="34" charset="0"/>
+                <a:ea typeface="Arial" pitchFamily="34" charset="-122"/>
+                <a:cs typeface="Arial" pitchFamily="34" charset="-120"/>
+              </a:rPr>
+              <a:t>Potential non-invasive CRC therapy.</a:t>
             </a:r>
             <a:endParaRPr lang="en-US" sz="1800" dirty="0"/>
           </a:p>
@@ -5967,7 +6018,7 @@
                   <a:srgbClr val="888888"/>
                 </a:solidFill>
               </a:rPr>
-              <a:t>X Li, T Chu, W Chen. Clinics and Research in Hepatology and …. 2026</a:t>
+              <a:t>Yang Feng-Yi, Wu Ruei-Yu, Lau Chi-Ieong et al.. Brain, behavior, and immunity. 2026-05-21 DOI: 10.1016/j.bbi.2026.106818</a:t>
             </a:r>
             <a:endParaRPr lang="en-US" sz="800" dirty="0"/>
           </a:p>
@@ -6167,7 +6218,7 @@
                   </a:extLst>
                 </a:hlinkClick>
               </a:rPr>
-              <a:t>Prognostic value of systemic immune-inflammation index for colorectal cancer: a systematic review and meta-analysis</a:t>
+              <a:t>Predictive utility of the C-reactive protein-albumin-lymphocyte (CALLY) index in Colorectal cancer: A meta-analysis</a:t>
             </a:r>
             <a:endParaRPr lang="en-US" sz="2400" dirty="0"/>
           </a:p>
@@ -6203,7 +6254,7 @@
                   <a:srgbClr val="888888"/>
                 </a:solidFill>
               </a:rPr>
-              <a:t>Frontiers in Oncology  ·  Meta-Analysis</a:t>
+              <a:t>Clinics and Research in Hepatology and …  ·  Meta-Analysis</a:t>
             </a:r>
             <a:endParaRPr lang="en-US" sz="1000" dirty="0"/>
           </a:p>
@@ -6246,7 +6297,7 @@
                 <a:ea typeface="Arial" pitchFamily="34" charset="-122"/>
                 <a:cs typeface="Arial" pitchFamily="34" charset="-120"/>
               </a:rPr>
-              <a:t>Systemic immune-inflammation index (SII) evaluated</a:t>
+              <a:t>CALLY index predicts CRC prognosis.</a:t>
             </a:r>
             <a:endParaRPr lang="en-US" sz="1800" dirty="0"/>
           </a:p>
@@ -6267,7 +6318,7 @@
                 <a:ea typeface="Arial" pitchFamily="34" charset="-122"/>
                 <a:cs typeface="Arial" pitchFamily="34" charset="-120"/>
               </a:rPr>
-              <a:t>Prognostic value in colorectal cancer (CRC)</a:t>
+              <a:t>Meta-analysis of multiple studies.</a:t>
             </a:r>
             <a:endParaRPr lang="en-US" sz="1800" dirty="0"/>
           </a:p>
@@ -6288,49 +6339,7 @@
                 <a:ea typeface="Arial" pitchFamily="34" charset="-122"/>
                 <a:cs typeface="Arial" pitchFamily="34" charset="-120"/>
               </a:rPr>
-              <a:t>Meta-analysis of existing studies</a:t>
-            </a:r>
-            <a:endParaRPr lang="en-US" sz="1800" dirty="0"/>
-          </a:p>
-          <a:p>
-            <a:pPr marL="342900" indent="-342900">
-              <a:spcAft>
-                <a:spcPts val="800"/>
-              </a:spcAft>
-              <a:buSzPct val="100000"/>
-              <a:buChar char="•"/>
-            </a:pPr>
-            <a:r>
-              <a:rPr lang="en-US" sz="1800" dirty="0">
-                <a:solidFill>
-                  <a:srgbClr val="333333"/>
-                </a:solidFill>
-                <a:latin typeface="Arial" pitchFamily="34" charset="0"/>
-                <a:ea typeface="Arial" pitchFamily="34" charset="-122"/>
-                <a:cs typeface="Arial" pitchFamily="34" charset="-120"/>
-              </a:rPr>
-              <a:t>SII correlates with patient outcomes</a:t>
-            </a:r>
-            <a:endParaRPr lang="en-US" sz="1800" dirty="0"/>
-          </a:p>
-          <a:p>
-            <a:pPr marL="342900" indent="-342900">
-              <a:spcAft>
-                <a:spcPts val="800"/>
-              </a:spcAft>
-              <a:buSzPct val="100000"/>
-              <a:buChar char="•"/>
-            </a:pPr>
-            <a:r>
-              <a:rPr lang="en-US" sz="1800" dirty="0">
-                <a:solidFill>
-                  <a:srgbClr val="333333"/>
-                </a:solidFill>
-                <a:latin typeface="Arial" pitchFamily="34" charset="0"/>
-                <a:ea typeface="Arial" pitchFamily="34" charset="-122"/>
-                <a:cs typeface="Arial" pitchFamily="34" charset="-120"/>
-              </a:rPr>
-              <a:t>Potential biomarker for clinical use</a:t>
+              <a:t>Inconsistent results across populations.</a:t>
             </a:r>
             <a:endParaRPr lang="en-US" sz="1800" dirty="0"/>
           </a:p>
@@ -6366,7 +6375,7 @@
                   <a:srgbClr val="888888"/>
                 </a:solidFill>
               </a:rPr>
-              <a:t>P Wang, H Jiang. Frontiers in Oncology. 2026</a:t>
+              <a:t>X Li, T Chu, W Chen. Clinics and Research in Hepatology and …. 2026</a:t>
             </a:r>
             <a:endParaRPr lang="en-US" sz="800" dirty="0"/>
           </a:p>
@@ -6566,7 +6575,7 @@
                   </a:extLst>
                 </a:hlinkClick>
               </a:rPr>
-              <a:t>Awareness of inflammatory bowel disease-associated colorectal cancer risk and its management in patients with inflammatory bowel disease: a systematic review</a:t>
+              <a:t>Prognostic value of systemic immune-inflammation index for colorectal cancer: a systematic review and meta-analysis</a:t>
             </a:r>
             <a:endParaRPr lang="en-US" sz="2400" dirty="0"/>
           </a:p>
@@ -6602,7 +6611,7 @@
                   <a:srgbClr val="888888"/>
                 </a:solidFill>
               </a:rPr>
-              <a:t>Crohns &amp; Colitis 360  ·  Systematic Review</a:t>
+              <a:t>Frontiers in Oncology  ·  Meta-Analysis</a:t>
             </a:r>
             <a:endParaRPr lang="en-US" sz="1000" dirty="0"/>
           </a:p>
@@ -6645,7 +6654,7 @@
                 <a:ea typeface="Arial" pitchFamily="34" charset="-122"/>
                 <a:cs typeface="Arial" pitchFamily="34" charset="-120"/>
               </a:rPr>
-              <a:t>Limited knowledge on colorectal cancer risk</a:t>
+              <a:t>Systemic immune-inflammation index (SII) evaluated</a:t>
             </a:r>
             <a:endParaRPr lang="en-US" sz="1800" dirty="0"/>
           </a:p>
@@ -6666,7 +6675,7 @@
                 <a:ea typeface="Arial" pitchFamily="34" charset="-122"/>
                 <a:cs typeface="Arial" pitchFamily="34" charset="-120"/>
               </a:rPr>
-              <a:t>Need for better patient education strategies</a:t>
+              <a:t>SII as a prognostic biomarker in CRC</a:t>
             </a:r>
             <a:endParaRPr lang="en-US" sz="1800" dirty="0"/>
           </a:p>
@@ -6687,7 +6696,49 @@
                 <a:ea typeface="Arial" pitchFamily="34" charset="-122"/>
                 <a:cs typeface="Arial" pitchFamily="34" charset="-120"/>
               </a:rPr>
-              <a:t>Importance of regular screening in IBD patients</a:t>
+              <a:t>Meta-analysis of existing studies conducted</a:t>
+            </a:r>
+            <a:endParaRPr lang="en-US" sz="1800" dirty="0"/>
+          </a:p>
+          <a:p>
+            <a:pPr marL="342900" indent="-342900">
+              <a:spcAft>
+                <a:spcPts val="800"/>
+              </a:spcAft>
+              <a:buSzPct val="100000"/>
+              <a:buChar char="•"/>
+            </a:pPr>
+            <a:r>
+              <a:rPr lang="en-US" sz="1800" dirty="0">
+                <a:solidFill>
+                  <a:srgbClr val="333333"/>
+                </a:solidFill>
+                <a:latin typeface="Arial" pitchFamily="34" charset="0"/>
+                <a:ea typeface="Arial" pitchFamily="34" charset="-122"/>
+                <a:cs typeface="Arial" pitchFamily="34" charset="-120"/>
+              </a:rPr>
+              <a:t>SII correlates with patient outcomes</a:t>
+            </a:r>
+            <a:endParaRPr lang="en-US" sz="1800" dirty="0"/>
+          </a:p>
+          <a:p>
+            <a:pPr marL="342900" indent="-342900">
+              <a:spcAft>
+                <a:spcPts val="800"/>
+              </a:spcAft>
+              <a:buSzPct val="100000"/>
+              <a:buChar char="•"/>
+            </a:pPr>
+            <a:r>
+              <a:rPr lang="en-US" sz="1800" dirty="0">
+                <a:solidFill>
+                  <a:srgbClr val="333333"/>
+                </a:solidFill>
+                <a:latin typeface="Arial" pitchFamily="34" charset="0"/>
+                <a:ea typeface="Arial" pitchFamily="34" charset="-122"/>
+                <a:cs typeface="Arial" pitchFamily="34" charset="-120"/>
+              </a:rPr>
+              <a:t>Potential for clinical application in CRC</a:t>
             </a:r>
             <a:endParaRPr lang="en-US" sz="1800" dirty="0"/>
           </a:p>
@@ -6723,7 +6774,7 @@
                   <a:srgbClr val="888888"/>
                 </a:solidFill>
               </a:rPr>
-              <a:t>F Khan, C Norton, W Czuber-Dochan. Crohns &amp; Colitis 360. 2026</a:t>
+              <a:t>P Wang, H Jiang. Frontiers in Oncology. 2026</a:t>
             </a:r>
             <a:endParaRPr lang="en-US" sz="800" dirty="0"/>
           </a:p>
@@ -6923,7 +6974,7 @@
                   </a:extLst>
                 </a:hlinkClick>
               </a:rPr>
-              <a:t>… of mFOLFOXIRI plus bevacizumab combined with cytoreductive surgery for resectable peritoneal metastases from colorectal cancer: a prospective, randomized …</a:t>
+              <a:t>Enhanced recovery after surgery pathways and postoperative gastrointestinal function in colorectal cancer: A prospective cohort study</a:t>
             </a:r>
             <a:endParaRPr lang="en-US" sz="2400" dirty="0"/>
           </a:p>
@@ -6959,7 +7010,7 @@
                   <a:srgbClr val="888888"/>
                 </a:solidFill>
               </a:rPr>
-              <a:t>… wei chang wai ke …  ·  Prospective Study</a:t>
+              <a:t>World journal of gastrointestinal surgery  ·  Prospective Study</a:t>
             </a:r>
             <a:endParaRPr lang="en-US" sz="1000" dirty="0"/>
           </a:p>
@@ -7002,7 +7053,7 @@
                 <a:ea typeface="Arial" pitchFamily="34" charset="-122"/>
                 <a:cs typeface="Arial" pitchFamily="34" charset="-120"/>
               </a:rPr>
-              <a:t>mFOLFOXIRI plus bevacizumab used</a:t>
+              <a:t>Enhanced recovery pathways improve outcomes.</a:t>
             </a:r>
             <a:endParaRPr lang="en-US" sz="1800" dirty="0"/>
           </a:p>
@@ -7023,7 +7074,7 @@
                 <a:ea typeface="Arial" pitchFamily="34" charset="-122"/>
                 <a:cs typeface="Arial" pitchFamily="34" charset="-120"/>
               </a:rPr>
-              <a:t>Combined with cytoreductive surgery</a:t>
+              <a:t>Early enteral nutrition is beneficial.</a:t>
             </a:r>
             <a:endParaRPr lang="en-US" sz="1800" dirty="0"/>
           </a:p>
@@ -7044,49 +7095,7 @@
                 <a:ea typeface="Arial" pitchFamily="34" charset="-122"/>
                 <a:cs typeface="Arial" pitchFamily="34" charset="-120"/>
               </a:rPr>
-              <a:t>Targeting resectable peritoneal metastases</a:t>
-            </a:r>
-            <a:endParaRPr lang="en-US" sz="1800" dirty="0"/>
-          </a:p>
-          <a:p>
-            <a:pPr marL="342900" indent="-342900">
-              <a:spcAft>
-                <a:spcPts val="800"/>
-              </a:spcAft>
-              <a:buSzPct val="100000"/>
-              <a:buChar char="•"/>
-            </a:pPr>
-            <a:r>
-              <a:rPr lang="en-US" sz="1800" dirty="0">
-                <a:solidFill>
-                  <a:srgbClr val="333333"/>
-                </a:solidFill>
-                <a:latin typeface="Arial" pitchFamily="34" charset="0"/>
-                <a:ea typeface="Arial" pitchFamily="34" charset="-122"/>
-                <a:cs typeface="Arial" pitchFamily="34" charset="-120"/>
-              </a:rPr>
-              <a:t>Prospective, randomized clinical trial</a:t>
-            </a:r>
-            <a:endParaRPr lang="en-US" sz="1800" dirty="0"/>
-          </a:p>
-          <a:p>
-            <a:pPr marL="342900" indent="-342900">
-              <a:spcAft>
-                <a:spcPts val="800"/>
-              </a:spcAft>
-              <a:buSzPct val="100000"/>
-              <a:buChar char="•"/>
-            </a:pPr>
-            <a:r>
-              <a:rPr lang="en-US" sz="1800" dirty="0">
-                <a:solidFill>
-                  <a:srgbClr val="333333"/>
-                </a:solidFill>
-                <a:latin typeface="Arial" pitchFamily="34" charset="0"/>
-                <a:ea typeface="Arial" pitchFamily="34" charset="-122"/>
-                <a:cs typeface="Arial" pitchFamily="34" charset="-120"/>
-              </a:rPr>
-              <a:t>Focus on colorectal cancer patients</a:t>
+              <a:t>Maintains intestinal mucosal barrier integrity.</a:t>
             </a:r>
             <a:endParaRPr lang="en-US" sz="1800" dirty="0"/>
           </a:p>
@@ -7122,7 +7131,7 @@
                   <a:srgbClr val="888888"/>
                 </a:solidFill>
               </a:rPr>
-              <a:t>HM Liu, HB Hu, YY Kuang. … wei chang wai ke …. 2026</a:t>
+              <a:t>BH Zhao, CX Bao. World journal of gastrointestinal surgery. 2026</a:t>
             </a:r>
             <a:endParaRPr lang="en-US" sz="800" dirty="0"/>
           </a:p>
@@ -7322,7 +7331,7 @@
                   </a:extLst>
                 </a:hlinkClick>
               </a:rPr>
-              <a:t>An HHEX/IKK&amp;#x3b1; positive feedback loop promotes intestinal inflammation.</a:t>
+              <a:t>Oncometabolite signatures from tumor-stroma crosstalk as potential non-invasive biomarkers.</a:t>
             </a:r>
             <a:endParaRPr lang="en-US" sz="2400" dirty="0"/>
           </a:p>
@@ -7358,7 +7367,7 @@
                   <a:srgbClr val="888888"/>
                 </a:solidFill>
               </a:rPr>
-              <a:t>The Journal of clinical investigation  ·  Basic Research</a:t>
+              <a:t>Cell death discovery  ·  Basic Research</a:t>
             </a:r>
             <a:endParaRPr lang="en-US" sz="1000" dirty="0"/>
           </a:p>
@@ -7401,7 +7410,7 @@
                 <a:ea typeface="Arial" pitchFamily="34" charset="-122"/>
                 <a:cs typeface="Arial" pitchFamily="34" charset="-120"/>
               </a:rPr>
-              <a:t>HHEX is upregulated in IBD samples.</a:t>
+              <a:t>Tumor metabolism impacts cancer progression.</a:t>
             </a:r>
             <a:endParaRPr lang="en-US" sz="1800" dirty="0"/>
           </a:p>
@@ -7422,7 +7431,7 @@
                 <a:ea typeface="Arial" pitchFamily="34" charset="-122"/>
                 <a:cs typeface="Arial" pitchFamily="34" charset="-120"/>
               </a:rPr>
-              <a:t>HHEX promotes inflammatory cytokine expression.</a:t>
+              <a:t>Distinct TAF behaviors in tumor growth.</a:t>
             </a:r>
             <a:endParaRPr lang="en-US" sz="1800" dirty="0"/>
           </a:p>
@@ -7443,49 +7452,7 @@
                 <a:ea typeface="Arial" pitchFamily="34" charset="-122"/>
                 <a:cs typeface="Arial" pitchFamily="34" charset="-120"/>
               </a:rPr>
-              <a:t>IKKα phosphorylates HHEX, stabilizing it.</a:t>
-            </a:r>
-            <a:endParaRPr lang="en-US" sz="1800" dirty="0"/>
-          </a:p>
-          <a:p>
-            <a:pPr marL="342900" indent="-342900">
-              <a:spcAft>
-                <a:spcPts val="800"/>
-              </a:spcAft>
-              <a:buSzPct val="100000"/>
-              <a:buChar char="•"/>
-            </a:pPr>
-            <a:r>
-              <a:rPr lang="en-US" sz="1800" dirty="0">
-                <a:solidFill>
-                  <a:srgbClr val="333333"/>
-                </a:solidFill>
-                <a:latin typeface="Arial" pitchFamily="34" charset="0"/>
-                <a:ea typeface="Arial" pitchFamily="34" charset="-122"/>
-                <a:cs typeface="Arial" pitchFamily="34" charset="-120"/>
-              </a:rPr>
-              <a:t>HHEX activates NF-κB pathway, worsening inflammation.</a:t>
-            </a:r>
-            <a:endParaRPr lang="en-US" sz="1800" dirty="0"/>
-          </a:p>
-          <a:p>
-            <a:pPr marL="342900" indent="-342900">
-              <a:spcAft>
-                <a:spcPts val="800"/>
-              </a:spcAft>
-              <a:buSzPct val="100000"/>
-              <a:buChar char="•"/>
-            </a:pPr>
-            <a:r>
-              <a:rPr lang="en-US" sz="1800" dirty="0">
-                <a:solidFill>
-                  <a:srgbClr val="333333"/>
-                </a:solidFill>
-                <a:latin typeface="Arial" pitchFamily="34" charset="0"/>
-                <a:ea typeface="Arial" pitchFamily="34" charset="-122"/>
-                <a:cs typeface="Arial" pitchFamily="34" charset="-120"/>
-              </a:rPr>
-              <a:t>Identified as potential IBD treatment target.</a:t>
+              <a:t>Oncometabolites as potential biomarkers.</a:t>
             </a:r>
             <a:endParaRPr lang="en-US" sz="1800" dirty="0"/>
           </a:p>
@@ -7521,7 +7488,7 @@
                   <a:srgbClr val="888888"/>
                 </a:solidFill>
               </a:rPr>
-              <a:t>Hua Zhebin, Xu Weimin, Ding Wenjun et al.. The Journal of clinical investigation. 2026-05-15 DOI: 10.1172/JCI192074</a:t>
+              <a:t>Parascandolo Alessia, Magnifico Maria C, De Vita Emanuele et al.. Cell death discovery. 2026-05-22 DOI: 10.1038/s41420-026-03172-1</a:t>
             </a:r>
             <a:endParaRPr lang="en-US" sz="800" dirty="0"/>
           </a:p>

</xml_diff>

<commit_message>
chore: update weekly digest 2026-06-01
</commit_message>
<xml_diff>
--- a/docs/digest-en.pptx
+++ b/docs/digest-en.pptx
@@ -2249,7 +2249,7 @@
                   <a:srgbClr val="888888"/>
                 </a:solidFill>
               </a:rPr>
-              <a:t>2026-05-18 — 2026-05-25</a:t>
+              <a:t>2026-05-25 — 2026-06-01</a:t>
             </a:r>
             <a:endParaRPr lang="en-US" sz="1400" dirty="0"/>
           </a:p>
@@ -2440,7 +2440,7 @@
                   </a:extLst>
                 </a:hlinkClick>
               </a:rPr>
-              <a:t>Dual modulation of Wnt and inflammatory pathways by Gingerenone a inhibits colorectal tumorigenesis.</a:t>
+              <a:t>Awareness of inflammatory bowel disease-associated colorectal cancer risk and its management in patients with inflammatory bowel disease: a systematic review</a:t>
             </a:r>
             <a:endParaRPr lang="en-US" sz="2400" dirty="0"/>
           </a:p>
@@ -2476,7 +2476,7 @@
                   <a:srgbClr val="888888"/>
                 </a:solidFill>
               </a:rPr>
-              <a:t>Molecular biology reports  ·  Basic Research</a:t>
+              <a:t>Crohns &amp; Colitis 360  ·  Systematic Review</a:t>
             </a:r>
             <a:endParaRPr lang="en-US" sz="1000" dirty="0"/>
           </a:p>
@@ -2519,7 +2519,7 @@
                 <a:ea typeface="Arial" pitchFamily="34" charset="-122"/>
                 <a:cs typeface="Arial" pitchFamily="34" charset="-120"/>
               </a:rPr>
-              <a:t>Gingerenone A inhibits Wnt signaling</a:t>
+              <a:t>Limited awareness of cancer risk</a:t>
             </a:r>
             <a:endParaRPr lang="en-US" sz="1800" dirty="0"/>
           </a:p>
@@ -2540,7 +2540,7 @@
                 <a:ea typeface="Arial" pitchFamily="34" charset="-122"/>
                 <a:cs typeface="Arial" pitchFamily="34" charset="-120"/>
               </a:rPr>
-              <a:t>Reduces inflammation and oxidative stress</a:t>
+              <a:t>Need for better patient education</a:t>
             </a:r>
             <a:endParaRPr lang="en-US" sz="1800" dirty="0"/>
           </a:p>
@@ -2561,49 +2561,7 @@
                 <a:ea typeface="Arial" pitchFamily="34" charset="-122"/>
                 <a:cs typeface="Arial" pitchFamily="34" charset="-120"/>
               </a:rPr>
-              <a:t>Promotes apoptosis in CRC cells</a:t>
-            </a:r>
-            <a:endParaRPr lang="en-US" sz="1800" dirty="0"/>
-          </a:p>
-          <a:p>
-            <a:pPr marL="342900" indent="-342900">
-              <a:spcAft>
-                <a:spcPts val="800"/>
-              </a:spcAft>
-              <a:buSzPct val="100000"/>
-              <a:buChar char="•"/>
-            </a:pPr>
-            <a:r>
-              <a:rPr lang="en-US" sz="1800" dirty="0">
-                <a:solidFill>
-                  <a:srgbClr val="333333"/>
-                </a:solidFill>
-                <a:latin typeface="Arial" pitchFamily="34" charset="0"/>
-                <a:ea typeface="Arial" pitchFamily="34" charset="-122"/>
-                <a:cs typeface="Arial" pitchFamily="34" charset="-120"/>
-              </a:rPr>
-              <a:t>Decreases tumor incidence in rats</a:t>
-            </a:r>
-            <a:endParaRPr lang="en-US" sz="1800" dirty="0"/>
-          </a:p>
-          <a:p>
-            <a:pPr marL="342900" indent="-342900">
-              <a:spcAft>
-                <a:spcPts val="800"/>
-              </a:spcAft>
-              <a:buSzPct val="100000"/>
-              <a:buChar char="•"/>
-            </a:pPr>
-            <a:r>
-              <a:rPr lang="en-US" sz="1800" dirty="0">
-                <a:solidFill>
-                  <a:srgbClr val="333333"/>
-                </a:solidFill>
-                <a:latin typeface="Arial" pitchFamily="34" charset="0"/>
-                <a:ea typeface="Arial" pitchFamily="34" charset="-122"/>
-                <a:cs typeface="Arial" pitchFamily="34" charset="-120"/>
-              </a:rPr>
-              <a:t>Safe with no systemic toxicity</a:t>
+              <a:t>Research gaps in management strategies</a:t>
             </a:r>
             <a:endParaRPr lang="en-US" sz="1800" dirty="0"/>
           </a:p>
@@ -2639,7 +2597,7 @@
                   <a:srgbClr val="888888"/>
                 </a:solidFill>
               </a:rPr>
-              <a:t>Y&amp;#x131;lmaz &amp;#xc7;a&amp;#x11f;atay, K&amp;#x131;r&amp;#x131;ml&amp;#x131;o&amp;#x11f;lu Esma, Elpek G&amp;#xfc;ls&amp;#xfc;m &amp;#xd6;zlem et al.. Molecular biology reports. 2026-05-22 DOI: 10.1007/s11033-026-11989-3</a:t>
+              <a:t>F Khan, C Norton, W Czuber-Dochan. Crohns &amp; Colitis 360. 2026</a:t>
             </a:r>
             <a:endParaRPr lang="en-US" sz="800" dirty="0"/>
           </a:p>
@@ -2839,7 +2797,7 @@
                   </a:extLst>
                 </a:hlinkClick>
               </a:rPr>
-              <a:t>Curcumin-loaded extracellular vesicles derived from lactic acid bacteria for alleviation of inflammatory bowel disease.</a:t>
+              <a:t>Life After Pelvic Exenteration for Rectal Cancer: The Patient and Carer Perspective on Long-term Consequences and Survivorship.</a:t>
             </a:r>
             <a:endParaRPr lang="en-US" sz="2400" dirty="0"/>
           </a:p>
@@ -2875,7 +2833,7 @@
                   <a:srgbClr val="888888"/>
                 </a:solidFill>
               </a:rPr>
-              <a:t>International journal of pharmaceutics  ·  Basic Research</a:t>
+              <a:t>Annals of surgery  ·  IF 9.4</a:t>
             </a:r>
             <a:endParaRPr lang="en-US" sz="1000" dirty="0"/>
           </a:p>
@@ -2918,7 +2876,7 @@
                 <a:ea typeface="Arial" pitchFamily="34" charset="-122"/>
                 <a:cs typeface="Arial" pitchFamily="34" charset="-120"/>
               </a:rPr>
-              <a:t>IBD is a chronic inflammatory disorder.</a:t>
+              <a:t>Pelvic exenteration standard for advanced rectal cancer</a:t>
             </a:r>
             <a:endParaRPr lang="en-US" sz="1800" dirty="0"/>
           </a:p>
@@ -2939,7 +2897,7 @@
                 <a:ea typeface="Arial" pitchFamily="34" charset="-122"/>
                 <a:cs typeface="Arial" pitchFamily="34" charset="-120"/>
               </a:rPr>
-              <a:t>Extracellular vesicles (EVs) from LAB are promising.</a:t>
+              <a:t>Long-term survivors face significant challenges</a:t>
             </a:r>
             <a:endParaRPr lang="en-US" sz="1800" dirty="0"/>
           </a:p>
@@ -2960,49 +2918,7 @@
                 <a:ea typeface="Arial" pitchFamily="34" charset="-122"/>
                 <a:cs typeface="Arial" pitchFamily="34" charset="-120"/>
               </a:rPr>
-              <a:t>Curcumin encapsulated in L-EVs-C shows benefits.</a:t>
-            </a:r>
-            <a:endParaRPr lang="en-US" sz="1800" dirty="0"/>
-          </a:p>
-          <a:p>
-            <a:pPr marL="342900" indent="-342900">
-              <a:spcAft>
-                <a:spcPts val="800"/>
-              </a:spcAft>
-              <a:buSzPct val="100000"/>
-              <a:buChar char="•"/>
-            </a:pPr>
-            <a:r>
-              <a:rPr lang="en-US" sz="1800" dirty="0">
-                <a:solidFill>
-                  <a:srgbClr val="333333"/>
-                </a:solidFill>
-                <a:latin typeface="Arial" pitchFamily="34" charset="0"/>
-                <a:ea typeface="Arial" pitchFamily="34" charset="-122"/>
-                <a:cs typeface="Arial" pitchFamily="34" charset="-120"/>
-              </a:rPr>
-              <a:t>L-EVs-C improves gut microbiota composition.</a:t>
-            </a:r>
-            <a:endParaRPr lang="en-US" sz="1800" dirty="0"/>
-          </a:p>
-          <a:p>
-            <a:pPr marL="342900" indent="-342900">
-              <a:spcAft>
-                <a:spcPts val="800"/>
-              </a:spcAft>
-              <a:buSzPct val="100000"/>
-              <a:buChar char="•"/>
-            </a:pPr>
-            <a:r>
-              <a:rPr lang="en-US" sz="1800" dirty="0">
-                <a:solidFill>
-                  <a:srgbClr val="333333"/>
-                </a:solidFill>
-                <a:latin typeface="Arial" pitchFamily="34" charset="0"/>
-                <a:ea typeface="Arial" pitchFamily="34" charset="-122"/>
-                <a:cs typeface="Arial" pitchFamily="34" charset="-120"/>
-              </a:rPr>
-              <a:t>Natural probiotics EVs may enhance therapies.</a:t>
+              <a:t>Participants accept surgery consequences for survival</a:t>
             </a:r>
             <a:endParaRPr lang="en-US" sz="1800" dirty="0"/>
           </a:p>
@@ -3038,7 +2954,7 @@
                   <a:srgbClr val="888888"/>
                 </a:solidFill>
               </a:rPr>
-              <a:t>Qiu Fang, Wang Baixuan, Zhang Yongjing et al.. International journal of pharmaceutics. 2026-05-08 DOI: 10.1016/j.ijpharm.2026.126859</a:t>
+              <a:t>Brown Kilian G M, White Kate, Solomon Michael J et al.. Annals of surgery. 2026-05-12 DOI: 10.1097/SLA.0000000000006625</a:t>
             </a:r>
             <a:endParaRPr lang="en-US" sz="800" dirty="0"/>
           </a:p>
@@ -3238,7 +3154,7 @@
                   </a:extLst>
                 </a:hlinkClick>
               </a:rPr>
-              <a:t>Combining PD-L1 blockade with a second-generation HSP110 inhibitor enhances antitumor immunity in colorectal cancer.</a:t>
+              <a:t>Enhanced recovery after surgery pathways and postoperative gastrointestinal function in colorectal cancer: A prospective cohort study</a:t>
             </a:r>
             <a:endParaRPr lang="en-US" sz="2400" dirty="0"/>
           </a:p>
@@ -3274,7 +3190,7 @@
                   <a:srgbClr val="888888"/>
                 </a:solidFill>
               </a:rPr>
-              <a:t>Cell death &amp; disease  ·  Basic Research</a:t>
+              <a:t>World journal of gastrointestinal surgery  ·  Prospective Study</a:t>
             </a:r>
             <a:endParaRPr lang="en-US" sz="1000" dirty="0"/>
           </a:p>
@@ -3317,7 +3233,7 @@
                 <a:ea typeface="Arial" pitchFamily="34" charset="-122"/>
                 <a:cs typeface="Arial" pitchFamily="34" charset="-120"/>
               </a:rPr>
-              <a:t>HSP110 inhibition mimics good prognosis phenotype</a:t>
+              <a:t>Enhanced recovery pathways improve outcomes</a:t>
             </a:r>
             <a:endParaRPr lang="en-US" sz="1800" dirty="0"/>
           </a:p>
@@ -3338,7 +3254,7 @@
                 <a:ea typeface="Arial" pitchFamily="34" charset="-122"/>
                 <a:cs typeface="Arial" pitchFamily="34" charset="-120"/>
               </a:rPr>
-              <a:t>C7 enhances anti-tumor immunity in CRC</a:t>
+              <a:t>Early enteral nutrition is beneficial</a:t>
             </a:r>
             <a:endParaRPr lang="en-US" sz="1800" dirty="0"/>
           </a:p>
@@ -3359,7 +3275,7 @@
                 <a:ea typeface="Arial" pitchFamily="34" charset="-122"/>
                 <a:cs typeface="Arial" pitchFamily="34" charset="-120"/>
               </a:rPr>
-              <a:t>Combination with anti-PD-L1 improves efficacy</a:t>
+              <a:t>Maintains intestinal mucosal barrier integrity</a:t>
             </a:r>
             <a:endParaRPr lang="en-US" sz="1800" dirty="0"/>
           </a:p>
@@ -3395,7 +3311,7 @@
                   <a:srgbClr val="888888"/>
                 </a:solidFill>
               </a:rPr>
-              <a:t>Abrey-Recalde Mar&amp;#xed;a Jimena, Mialhe Flavie, Le Thi Khanh et al.. Cell death &amp; disease. 2026-05-18 DOI: 10.1038/s41419-026-08826-7</a:t>
+              <a:t>BH Zhao, CX Bao. World journal of gastrointestinal surgery. 2026</a:t>
             </a:r>
             <a:endParaRPr lang="en-US" sz="800" dirty="0"/>
           </a:p>
@@ -3586,7 +3502,7 @@
                   <a:srgbClr val="FFFFFF"/>
                 </a:solidFill>
               </a:rPr>
-              <a:t>### 綜合啟示（Overall Insights）</a:t>
+              <a:t>### 綜合啟示 (Overall Insights)</a:t>
             </a:r>
             <a:endParaRPr lang="en-US" sz="1200" dirty="0"/>
           </a:p>
@@ -3612,7 +3528,7 @@
                   <a:srgbClr val="FFFFFF"/>
                 </a:solidFill>
               </a:rPr>
-              <a:t>1. **腫瘤去減化與化療結合的療效**  </a:t>
+              <a:t>1. **手術與化療的整合策略**  </a:t>
             </a:r>
             <a:endParaRPr lang="en-US" sz="1200" dirty="0"/>
           </a:p>
@@ -3629,7 +3545,7 @@
                   <a:srgbClr val="FFFFFF"/>
                 </a:solidFill>
               </a:rPr>
-              <a:t>   The combination of tumor debulking and chemotherapy shows promising results in managing multiorgan metastatic colorectal cancer, indicating a potential shift in treatment paradigms.  </a:t>
+              <a:t>   The combination of cytoreductive surgery and hyperthermic intraperitoneal chemotherapy shows limited benefits in metastatic colorectal cancer, highlighting the need for more effective treatment protocols.  </a:t>
             </a:r>
             <a:endParaRPr lang="en-US" sz="1200" dirty="0"/>
           </a:p>
@@ -3646,7 +3562,7 @@
                   <a:srgbClr val="FFFFFF"/>
                 </a:solidFill>
               </a:rPr>
-              <a:t>   腫瘤去減化與化療的結合在多脏器轉移性結直腸癌的管理中顯示出良好的療效，這可能改變治療模式。</a:t>
+              <a:t>   結合細胞減少手術與高溫腹腔化療在轉移性大腸癌中的效果有限，突顯出需要更有效的治療方案。</a:t>
             </a:r>
             <a:endParaRPr lang="en-US" sz="1200" dirty="0"/>
           </a:p>
@@ -3672,7 +3588,7 @@
                   <a:srgbClr val="FFFFFF"/>
                 </a:solidFill>
               </a:rPr>
-              <a:t>2. **微生物組在腸道健康中的角色**  </a:t>
+              <a:t>2. **預後指標的變化**  </a:t>
             </a:r>
             <a:endParaRPr lang="en-US" sz="1200" dirty="0"/>
           </a:p>
@@ -3689,7 +3605,7 @@
                   <a:srgbClr val="FFFFFF"/>
                 </a:solidFill>
               </a:rPr>
-              <a:t>   The pathogenic role of specific gut microbiota, such as Parasutterella excrementihominis, highlights the importance of microbiome-targeted therapies in preventing colorectal cancer.  </a:t>
+              <a:t>   The prognostic value of indices like the C-reactive protein-albumin-lymphocyte (CALLY) index and systemic immune-inflammation index (SII) remains inconsistent, indicating a need for standardization in their application.  </a:t>
             </a:r>
             <a:endParaRPr lang="en-US" sz="1200" dirty="0"/>
           </a:p>
@@ -3706,7 +3622,7 @@
                   <a:srgbClr val="FFFFFF"/>
                 </a:solidFill>
               </a:rPr>
-              <a:t>   特定腸道微生物如Parasutterella excrementihominis的致病角色突顯了以微生物組為目標的療法在預防結直腸癌中的重要性。</a:t>
+              <a:t>   C-反應蛋白-白蛋白-淋巴細胞（CALLY）指數和系統性免疫炎症指數（SII）的預後價值不一致，顯示其應用需要標準化。</a:t>
             </a:r>
             <a:endParaRPr lang="en-US" sz="1200" dirty="0"/>
           </a:p>
@@ -3732,7 +3648,7 @@
                   <a:srgbClr val="FFFFFF"/>
                 </a:solidFill>
               </a:rPr>
-              <a:t>3. **炎症與癌症發展的關聯**  </a:t>
+              <a:t>3. **腸道微生物與癌症的關聯**  </a:t>
             </a:r>
             <a:endParaRPr lang="en-US" sz="1200" dirty="0"/>
           </a:p>
@@ -3749,7 +3665,7 @@
                   <a:srgbClr val="FFFFFF"/>
                 </a:solidFill>
               </a:rPr>
-              <a:t>   Chronic inflammation is a critical factor in colorectal cancer progression, suggesting that anti-inflammatory strategies could be effective in cancer prevention.  </a:t>
+              <a:t>   The role of gut microbiota, particularly Parasutterella excrementihominis, in exacerbating colitis and colorectal cancer suggests potential therapeutic targets for inflammation-driven carcinogenesis.  </a:t>
             </a:r>
             <a:endParaRPr lang="en-US" sz="1200" dirty="0"/>
           </a:p>
@@ -3766,7 +3682,7 @@
                   <a:srgbClr val="FFFFFF"/>
                 </a:solidFill>
               </a:rPr>
-              <a:t>   慢性炎症是結直腸癌進展的關鍵因素，這表明抗炎策略可能在癌症預防中有效。</a:t>
+              <a:t>   腸道微生物，特別是Parasutterella excrementihominis在加重結腸炎和大腸癌中的作用，暗示了針對炎症驅動癌變的潛在治療靶點。</a:t>
             </a:r>
             <a:endParaRPr lang="en-US" sz="1200" dirty="0"/>
           </a:p>
@@ -3792,7 +3708,7 @@
                   <a:srgbClr val="FFFFFF"/>
                 </a:solidFill>
               </a:rPr>
-              <a:t>4. **生物標記物的預測能力**  </a:t>
+              <a:t>4. **術後恢復的重要性**  </a:t>
             </a:r>
             <a:endParaRPr lang="en-US" sz="1200" dirty="0"/>
           </a:p>
@@ -3809,7 +3725,7 @@
                   <a:srgbClr val="FFFFFF"/>
                 </a:solidFill>
               </a:rPr>
-              <a:t>   The C-reactive protein-albumin-lymphocyte (CALLY) index and systemic immune-inflammation index (SII) show potential as prognostic biomarkers, though further validation is needed.  </a:t>
+              <a:t>   Enhanced recovery after surgery pathways significantly improve postoperative gastrointestinal function, emphasizing the importance of postoperative care in colorectal cancer patients.  </a:t>
             </a:r>
             <a:endParaRPr lang="en-US" sz="1200" dirty="0"/>
           </a:p>
@@ -3826,7 +3742,7 @@
                   <a:srgbClr val="FFFFFF"/>
                 </a:solidFill>
               </a:rPr>
-              <a:t>   C反應蛋白-白蛋白-淋巴細胞（CALLY）指數和全身免疫炎症指數（SII）顯示出作為預後生物標記物的潛力，但仍需進一步驗證。</a:t>
+              <a:t>   手術後恢復途徑顯著改善術後腸道功能，強調了大腸癌患者術後護理的重要性。</a:t>
             </a:r>
             <a:endParaRPr lang="en-US" sz="1200" dirty="0"/>
           </a:p>
@@ -3852,7 +3768,7 @@
                   <a:srgbClr val="FFFFFF"/>
                 </a:solidFill>
               </a:rPr>
-              <a:t>5. **天然化合物的抗腫瘤潛力**  </a:t>
+              <a:t>5. **患者與照顧者的經驗**  </a:t>
             </a:r>
             <a:endParaRPr lang="en-US" sz="1200" dirty="0"/>
           </a:p>
@@ -3869,7 +3785,7 @@
                   <a:srgbClr val="FFFFFF"/>
                 </a:solidFill>
               </a:rPr>
-              <a:t>   Natural compounds like Gingerenone a demonstrate dual modulation of Wnt and inflammatory pathways, offering a novel approach for colorectal cancer treatment.</a:t>
+              <a:t>   Understanding the long-term consequences of pelvic exenteration from the perspectives of patients and caregivers is crucial for improving survivorship care.</a:t>
             </a:r>
             <a:endParaRPr lang="en-US" sz="1200" dirty="0"/>
           </a:p>
@@ -4015,7 +3931,7 @@
                   <a:srgbClr val="FFFFFF"/>
                 </a:solidFill>
               </a:rPr>
-              <a:t>像Gingerenone a這樣的天然化合物顯示出對Wnt和炎症通路的雙重調節，為結直腸癌治療提供了新方法。</a:t>
+              <a:t>從患者和照顧者的角度理解骨盆切除術的長期後果對改善生存照護至關重要。</a:t>
             </a:r>
             <a:endParaRPr lang="en-US" sz="1200" dirty="0"/>
           </a:p>
@@ -4041,7 +3957,7 @@
                   <a:srgbClr val="FFFFFF"/>
                 </a:solidFill>
               </a:rPr>
-              <a:t>### 未來研究方向（Future Research Directions）</a:t>
+              <a:t>### 未來研究方向 (Future Research Directions)</a:t>
             </a:r>
             <a:endParaRPr lang="en-US" sz="1200" dirty="0"/>
           </a:p>
@@ -4067,7 +3983,7 @@
                   <a:srgbClr val="FFFFFF"/>
                 </a:solidFill>
               </a:rPr>
-              <a:t>1. **微生物組與腸道癌症的關聯研究**  </a:t>
+              <a:t>1. **個體化治療策略的開發**  </a:t>
             </a:r>
             <a:endParaRPr lang="en-US" sz="1200" dirty="0"/>
           </a:p>
@@ -4084,7 +4000,7 @@
                   <a:srgbClr val="FFFFFF"/>
                 </a:solidFill>
               </a:rPr>
-              <a:t>   Investigating the complex interactions between gut microbiota and colorectal cancer could lead to novel therapeutic strategies and preventive measures.  </a:t>
+              <a:t>   Future studies should focus on developing personalized treatment approaches that integrate genetic, microbiome, and immune profiles for colorectal cancer management.  </a:t>
             </a:r>
             <a:endParaRPr lang="en-US" sz="1200" dirty="0"/>
           </a:p>
@@ -4101,7 +4017,7 @@
                   <a:srgbClr val="FFFFFF"/>
                 </a:solidFill>
               </a:rPr>
-              <a:t>   探索腸道微生物組與結直腸癌之間的複雜互動可能會導致新的治療策略和預防措施。</a:t>
+              <a:t>   未來的研究應著重於開發個體化治療策略，整合基因、微生物組和免疫特徵以管理大腸癌。</a:t>
             </a:r>
             <a:endParaRPr lang="en-US" sz="1200" dirty="0"/>
           </a:p>
@@ -4127,7 +4043,7 @@
                   <a:srgbClr val="FFFFFF"/>
                 </a:solidFill>
               </a:rPr>
-              <a:t>2. **新型生物標記物的開發**  </a:t>
+              <a:t>2. **炎症指標的標準化**  </a:t>
             </a:r>
             <a:endParaRPr lang="en-US" sz="1200" dirty="0"/>
           </a:p>
@@ -4144,7 +4060,7 @@
                   <a:srgbClr val="FFFFFF"/>
                 </a:solidFill>
               </a:rPr>
-              <a:t>   Future studies should focus on identifying and validating new biomarkers that can predict treatment responses and outcomes in colorectal cancer patients.  </a:t>
+              <a:t>   Research should aim to standardize the use of inflammatory biomarkers like the CALLY index and SII in clinical practice to enhance prognostic accuracy.  </a:t>
             </a:r>
             <a:endParaRPr lang="en-US" sz="1200" dirty="0"/>
           </a:p>
@@ -4161,7 +4077,7 @@
                   <a:srgbClr val="FFFFFF"/>
                 </a:solidFill>
               </a:rPr>
-              <a:t>   未來的研究應集中於識別和驗證能預測結直腸癌患者治療反應和結果的新型生物標記物。</a:t>
+              <a:t>   研究應旨在標準化臨床實踐中使用的炎症生物標記，如CALLY指數和SII，以提高預後準確性。</a:t>
             </a:r>
             <a:endParaRPr lang="en-US" sz="1200" dirty="0"/>
           </a:p>
@@ -4187,7 +4103,7 @@
                   <a:srgbClr val="FFFFFF"/>
                 </a:solidFill>
               </a:rPr>
-              <a:t>3. **抗炎療法的臨床應用**  </a:t>
+              <a:t>3. **腸道微生物的介入研究**  </a:t>
             </a:r>
             <a:endParaRPr lang="en-US" sz="1200" dirty="0"/>
           </a:p>
@@ -4204,7 +4120,7 @@
                   <a:srgbClr val="FFFFFF"/>
                 </a:solidFill>
               </a:rPr>
-              <a:t>   Clinical trials assessing the efficacy of anti-inflammatory therapies in colorectal cancer prevention and treatment should be prioritized.  </a:t>
+              <a:t>   Investigating the therapeutic potential of modulating gut microbiota in colorectal cancer patients could open new avenues for treatment.  </a:t>
             </a:r>
             <a:endParaRPr lang="en-US" sz="1200" dirty="0"/>
           </a:p>
@@ -4221,7 +4137,7 @@
                   <a:srgbClr val="FFFFFF"/>
                 </a:solidFill>
               </a:rPr>
-              <a:t>   應優先進行臨床試驗，評估抗炎療法在結直腸癌預防和治療中的有效性。</a:t>
+              <a:t>   探索調節腸道微生物在大腸癌患者中的治療潛力可能為治療開辟新的途徑。</a:t>
             </a:r>
             <a:endParaRPr lang="en-US" sz="1200" dirty="0"/>
           </a:p>
@@ -4247,7 +4163,7 @@
                   <a:srgbClr val="FFFFFF"/>
                 </a:solidFill>
               </a:rPr>
-              <a:t>4. **天然化合物的機制研究**  </a:t>
+              <a:t>4. **術後恢復的最佳化**  </a:t>
             </a:r>
             <a:endParaRPr lang="en-US" sz="1200" dirty="0"/>
           </a:p>
@@ -4264,7 +4180,7 @@
                   <a:srgbClr val="FFFFFF"/>
                 </a:solidFill>
               </a:rPr>
-              <a:t>   Further exploration of the mechanisms by which natural compounds exert their anti-cancer effects could enhance their therapeutic application in clinical settings.  </a:t>
+              <a:t>   Further research is needed to optimize enhanced recovery protocols post-surgery, focusing on specific interventions that improve gastrointestinal function.  </a:t>
             </a:r>
             <a:endParaRPr lang="en-US" sz="1200" dirty="0"/>
           </a:p>
@@ -4281,7 +4197,7 @@
                   <a:srgbClr val="FFFFFF"/>
                 </a:solidFill>
               </a:rPr>
-              <a:t>   進一步探索天然化合物發揮抗癌作用的機制可能會增強其在臨床應用中的療效。</a:t>
+              <a:t>   需要進一步研究以優化術後恢復方案，專注於改善腸道功能的特定干預措施。</a:t>
             </a:r>
             <a:endParaRPr lang="en-US" sz="1200" dirty="0"/>
           </a:p>
@@ -4307,7 +4223,7 @@
                   <a:srgbClr val="FFFFFF"/>
                 </a:solidFill>
               </a:rPr>
-              <a:t>5. **多模態治療的整合研究**  </a:t>
+              <a:t>5. **患者經驗的質性研究**  </a:t>
             </a:r>
             <a:endParaRPr lang="en-US" sz="1200" dirty="0"/>
           </a:p>
@@ -4324,7 +4240,7 @@
                   <a:srgbClr val="FFFFFF"/>
                 </a:solidFill>
               </a:rPr>
-              <a:t>   Research on integrating multimodal treatment approaches, including surgery, chemotherapy, and immunotherapy, is essential for improving patient outcomes in colorectal cancer.  </a:t>
+              <a:t>   Qualitative studies exploring the experiences of patients and caregivers post-pelvic exenteration can inform better support systems and survivorship programs.  </a:t>
             </a:r>
             <a:endParaRPr lang="en-US" sz="1200" dirty="0"/>
           </a:p>
@@ -4341,7 +4257,7 @@
                   <a:srgbClr val="FFFFFF"/>
                 </a:solidFill>
               </a:rPr>
-              <a:t>   研究整合多模態治療方法，包括手術、化療和免疫療法，對於改善結直腸癌患者的結果至關重要。</a:t>
+              <a:t>   探索骨盆切除術後患者和照顧者經驗的質性研究可以為更好的支持系統和生存計劃提供信息。</a:t>
             </a:r>
             <a:endParaRPr lang="en-US" sz="1200" dirty="0"/>
           </a:p>
@@ -4575,7 +4491,7 @@
                 <a:ea typeface="Arial" pitchFamily="34" charset="-122"/>
                 <a:cs typeface="Arial" pitchFamily="34" charset="-120"/>
               </a:rPr>
-              <a:t>Tumor debulking in combination with chemotherapy in multiorgan metastatic colore…</a:t>
+              <a:t>ORCHESTRA hits a sour note for debulking in metastatic colorectal cancer</a:t>
             </a:r>
             <a:endParaRPr lang="en-US" sz="1400" dirty="0"/>
           </a:p>
@@ -4612,7 +4528,7 @@
                 <a:ea typeface="Arial" pitchFamily="34" charset="-122"/>
                 <a:cs typeface="Arial" pitchFamily="34" charset="-120"/>
               </a:rPr>
-              <a:t>Parasutterella excrementihominis exacerbates experimental colitis and colitis-as…</a:t>
+              <a:t>Tumor debulking in combination with chemotherapy in multiorgan metastatic colore…</a:t>
             </a:r>
             <a:endParaRPr lang="en-US" sz="1400" dirty="0"/>
           </a:p>
@@ -4649,7 +4565,7 @@
                 <a:ea typeface="Arial" pitchFamily="34" charset="-122"/>
                 <a:cs typeface="Arial" pitchFamily="34" charset="-120"/>
               </a:rPr>
-              <a:t>Abdominal ultrasound attenuates early-stage aberrant proliferation and depressiv…</a:t>
+              <a:t>Parasutterella excrementihominis exacerbates experimental colitis and colitis-as…</a:t>
             </a:r>
             <a:endParaRPr lang="en-US" sz="1400" dirty="0"/>
           </a:p>
@@ -4686,7 +4602,7 @@
                 <a:ea typeface="Arial" pitchFamily="34" charset="-122"/>
                 <a:cs typeface="Arial" pitchFamily="34" charset="-120"/>
               </a:rPr>
-              <a:t>Predictive utility of the C-reactive protein-albumin-lymphocyte (CALLY) index in…</a:t>
+              <a:t>Mitochondria-Targeting Iridium(III) Complexes Induce PANoptosis and Ferroptosis …</a:t>
             </a:r>
             <a:endParaRPr lang="en-US" sz="1400" dirty="0"/>
           </a:p>
@@ -4723,7 +4639,7 @@
                 <a:ea typeface="Arial" pitchFamily="34" charset="-122"/>
                 <a:cs typeface="Arial" pitchFamily="34" charset="-120"/>
               </a:rPr>
-              <a:t>Prognostic value of systemic immune-inflammation index for colorectal cancer: a …</a:t>
+              <a:t>Predictive utility of the C-reactive protein-albumin-lymphocyte (CALLY) index in…</a:t>
             </a:r>
             <a:endParaRPr lang="en-US" sz="1400" dirty="0"/>
           </a:p>
@@ -4760,7 +4676,7 @@
                 <a:ea typeface="Arial" pitchFamily="34" charset="-122"/>
                 <a:cs typeface="Arial" pitchFamily="34" charset="-120"/>
               </a:rPr>
-              <a:t>Enhanced recovery after surgery pathways and postoperative gastrointestinal func…</a:t>
+              <a:t>Prognostic value of systemic immune-inflammation index for colorectal cancer: a …</a:t>
             </a:r>
             <a:endParaRPr lang="en-US" sz="1400" dirty="0"/>
           </a:p>
@@ -4797,7 +4713,7 @@
                 <a:ea typeface="Arial" pitchFamily="34" charset="-122"/>
                 <a:cs typeface="Arial" pitchFamily="34" charset="-120"/>
               </a:rPr>
-              <a:t>Oncometabolite signatures from tumor-stroma crosstalk as potential non-invasive …</a:t>
+              <a:t>Consensus Guideline for the Management of Colorectal Cancer with Peritoneal Meta…</a:t>
             </a:r>
             <a:endParaRPr lang="en-US" sz="1400" dirty="0"/>
           </a:p>
@@ -4834,7 +4750,7 @@
                 <a:ea typeface="Arial" pitchFamily="34" charset="-122"/>
                 <a:cs typeface="Arial" pitchFamily="34" charset="-120"/>
               </a:rPr>
-              <a:t>Dual modulation of Wnt and inflammatory pathways by Gingerenone a inhibits color…</a:t>
+              <a:t>Awareness of inflammatory bowel disease-associated colorectal cancer risk and it…</a:t>
             </a:r>
             <a:endParaRPr lang="en-US" sz="1400" dirty="0"/>
           </a:p>
@@ -4871,7 +4787,7 @@
                 <a:ea typeface="Arial" pitchFamily="34" charset="-122"/>
                 <a:cs typeface="Arial" pitchFamily="34" charset="-120"/>
               </a:rPr>
-              <a:t>Curcumin-loaded extracellular vesicles derived from lactic acid bacteria for all…</a:t>
+              <a:t>Life After Pelvic Exenteration for Rectal Cancer: The Patient and Carer Perspect…</a:t>
             </a:r>
             <a:endParaRPr lang="en-US" sz="1400" dirty="0"/>
           </a:p>
@@ -4908,7 +4824,7 @@
                 <a:ea typeface="Arial" pitchFamily="34" charset="-122"/>
                 <a:cs typeface="Arial" pitchFamily="34" charset="-120"/>
               </a:rPr>
-              <a:t>Combining PD-L1 blockade with a second-generation HSP110 inhibitor enhances anti…</a:t>
+              <a:t>Enhanced recovery after surgery pathways and postoperative gastrointestinal func…</a:t>
             </a:r>
             <a:endParaRPr lang="en-US" sz="1400" dirty="0"/>
           </a:p>
@@ -5063,7 +4979,7 @@
                   </a:extLst>
                 </a:hlinkClick>
               </a:rPr>
-              <a:t>Tumor debulking in combination with chemotherapy in multiorgan metastatic colorectal cancer: The ORCHESTRA randomized clinical trial</a:t>
+              <a:t>ORCHESTRA hits a sour note for debulking in metastatic colorectal cancer</a:t>
             </a:r>
             <a:endParaRPr lang="en-US" sz="2400" dirty="0"/>
           </a:p>
@@ -5142,7 +5058,7 @@
                 <a:ea typeface="Arial" pitchFamily="34" charset="-122"/>
                 <a:cs typeface="Arial" pitchFamily="34" charset="-120"/>
               </a:rPr>
-              <a:t>Study on tumor debulking effectiveness</a:t>
+              <a:t>Cytoreductive surgery with HIPEC evaluated</a:t>
             </a:r>
             <a:endParaRPr lang="en-US" sz="1800" dirty="0"/>
           </a:p>
@@ -5163,7 +5079,7 @@
                 <a:ea typeface="Arial" pitchFamily="34" charset="-122"/>
                 <a:cs typeface="Arial" pitchFamily="34" charset="-120"/>
               </a:rPr>
-              <a:t>Combination with chemotherapy assessed</a:t>
+              <a:t>PRODIGE 7 trial design and objectives</a:t>
             </a:r>
             <a:endParaRPr lang="en-US" sz="1800" dirty="0"/>
           </a:p>
@@ -5184,49 +5100,7 @@
                 <a:ea typeface="Arial" pitchFamily="34" charset="-122"/>
                 <a:cs typeface="Arial" pitchFamily="34" charset="-120"/>
               </a:rPr>
-              <a:t>Focus on multiorgan metastatic colorectal cancer</a:t>
-            </a:r>
-            <a:endParaRPr lang="en-US" sz="1800" dirty="0"/>
-          </a:p>
-          <a:p>
-            <a:pPr marL="342900" indent="-342900">
-              <a:spcAft>
-                <a:spcPts val="800"/>
-              </a:spcAft>
-              <a:buSzPct val="100000"/>
-              <a:buChar char="•"/>
-            </a:pPr>
-            <a:r>
-              <a:rPr lang="en-US" sz="1800" dirty="0">
-                <a:solidFill>
-                  <a:srgbClr val="333333"/>
-                </a:solidFill>
-                <a:latin typeface="Arial" pitchFamily="34" charset="0"/>
-                <a:ea typeface="Arial" pitchFamily="34" charset="-122"/>
-                <a:cs typeface="Arial" pitchFamily="34" charset="-120"/>
-              </a:rPr>
-              <a:t>Results from ORCHESTRA randomized trial</a:t>
-            </a:r>
-            <a:endParaRPr lang="en-US" sz="1800" dirty="0"/>
-          </a:p>
-          <a:p>
-            <a:pPr marL="342900" indent="-342900">
-              <a:spcAft>
-                <a:spcPts val="800"/>
-              </a:spcAft>
-              <a:buSzPct val="100000"/>
-              <a:buChar char="•"/>
-            </a:pPr>
-            <a:r>
-              <a:rPr lang="en-US" sz="1800" dirty="0">
-                <a:solidFill>
-                  <a:srgbClr val="333333"/>
-                </a:solidFill>
-                <a:latin typeface="Arial" pitchFamily="34" charset="0"/>
-                <a:ea typeface="Arial" pitchFamily="34" charset="-122"/>
-                <a:cs typeface="Arial" pitchFamily="34" charset="-120"/>
-              </a:rPr>
-              <a:t>Subgroup analysis with P &lt; .05</a:t>
+              <a:t>Comparison of treatment outcomes reported</a:t>
             </a:r>
             <a:endParaRPr lang="en-US" sz="1800" dirty="0"/>
           </a:p>
@@ -5262,7 +5136,7 @@
                   <a:srgbClr val="888888"/>
                 </a:solidFill>
               </a:rPr>
-              <a:t>EC Gootjes, L Bakkerus, AA Adhin. JAMA. 2026</a:t>
+              <a:t>M Fakih. JAMA. 2026</a:t>
             </a:r>
             <a:endParaRPr lang="en-US" sz="800" dirty="0"/>
           </a:p>
@@ -5462,7 +5336,7 @@
                   </a:extLst>
                 </a:hlinkClick>
               </a:rPr>
-              <a:t>Parasutterella excrementihominis exacerbates experimental colitis and colitis-associated colorectal cancer via pathogenic NETosis activation</a:t>
+              <a:t>Tumor debulking in combination with chemotherapy in multiorgan metastatic colorectal cancer: the ORCHESTRA randomized clinical trial</a:t>
             </a:r>
             <a:endParaRPr lang="en-US" sz="2400" dirty="0"/>
           </a:p>
@@ -5498,7 +5372,7 @@
                   <a:srgbClr val="888888"/>
                 </a:solidFill>
               </a:rPr>
-              <a:t>Gut  ·  IF 24.5</a:t>
+              <a:t>JAMA  ·  IF 63.1</a:t>
             </a:r>
             <a:endParaRPr lang="en-US" sz="1000" dirty="0"/>
           </a:p>
@@ -5541,7 +5415,7 @@
                 <a:ea typeface="Arial" pitchFamily="34" charset="-122"/>
                 <a:cs typeface="Arial" pitchFamily="34" charset="-120"/>
               </a:rPr>
-              <a:t>P. excrementihominis worsens colitis severity.</a:t>
+              <a:t>Study on tumor debulking effectiveness</a:t>
             </a:r>
             <a:endParaRPr lang="en-US" sz="1800" dirty="0"/>
           </a:p>
@@ -5562,7 +5436,7 @@
                 <a:ea typeface="Arial" pitchFamily="34" charset="-122"/>
                 <a:cs typeface="Arial" pitchFamily="34" charset="-120"/>
               </a:rPr>
-              <a:t>NETosis activation linked to cancer progression.</a:t>
+              <a:t>Combination with chemotherapy evaluated</a:t>
             </a:r>
             <a:endParaRPr lang="en-US" sz="1800" dirty="0"/>
           </a:p>
@@ -5583,7 +5457,49 @@
                 <a:ea typeface="Arial" pitchFamily="34" charset="-122"/>
                 <a:cs typeface="Arial" pitchFamily="34" charset="-120"/>
               </a:rPr>
-              <a:t>Potential for new therapeutic strategies.</a:t>
+              <a:t>Focus on multiorgan metastatic colorectal cancer</a:t>
+            </a:r>
+            <a:endParaRPr lang="en-US" sz="1800" dirty="0"/>
+          </a:p>
+          <a:p>
+            <a:pPr marL="342900" indent="-342900">
+              <a:spcAft>
+                <a:spcPts val="800"/>
+              </a:spcAft>
+              <a:buSzPct val="100000"/>
+              <a:buChar char="•"/>
+            </a:pPr>
+            <a:r>
+              <a:rPr lang="en-US" sz="1800" dirty="0">
+                <a:solidFill>
+                  <a:srgbClr val="333333"/>
+                </a:solidFill>
+                <a:latin typeface="Arial" pitchFamily="34" charset="0"/>
+                <a:ea typeface="Arial" pitchFamily="34" charset="-122"/>
+                <a:cs typeface="Arial" pitchFamily="34" charset="-120"/>
+              </a:rPr>
+              <a:t>Results from ORCHESTRA randomized trial</a:t>
+            </a:r>
+            <a:endParaRPr lang="en-US" sz="1800" dirty="0"/>
+          </a:p>
+          <a:p>
+            <a:pPr marL="342900" indent="-342900">
+              <a:spcAft>
+                <a:spcPts val="800"/>
+              </a:spcAft>
+              <a:buSzPct val="100000"/>
+              <a:buChar char="•"/>
+            </a:pPr>
+            <a:r>
+              <a:rPr lang="en-US" sz="1800" dirty="0">
+                <a:solidFill>
+                  <a:srgbClr val="333333"/>
+                </a:solidFill>
+                <a:latin typeface="Arial" pitchFamily="34" charset="0"/>
+                <a:ea typeface="Arial" pitchFamily="34" charset="-122"/>
+                <a:cs typeface="Arial" pitchFamily="34" charset="-120"/>
+              </a:rPr>
+              <a:t>Subgroup analysis with P &lt; .05</a:t>
             </a:r>
             <a:endParaRPr lang="en-US" sz="1800" dirty="0"/>
           </a:p>
@@ -5619,7 +5535,7 @@
                   <a:srgbClr val="888888"/>
                 </a:solidFill>
               </a:rPr>
-              <a:t>H Tan, L Huang, J Wang. Gut. 2026</a:t>
+              <a:t>EC Gootjes, L Bakkerus, AA Adhin. JAMA. 2026</a:t>
             </a:r>
             <a:endParaRPr lang="en-US" sz="800" dirty="0"/>
           </a:p>
@@ -5819,7 +5735,7 @@
                   </a:extLst>
                 </a:hlinkClick>
               </a:rPr>
-              <a:t>Abdominal ultrasound attenuates early-stage aberrant proliferation and depressive behavior in AOM/DSS-induced colorectal cancer: regulatory mechanisms of the Wnt/&amp;#x3b2;-catenin pathway and HPA axis.</a:t>
+              <a:t>Parasutterella excrementihominis exacerbates experimental colitis and colitis-associated colorectal cancer via pathogenic NETosis activation</a:t>
             </a:r>
             <a:endParaRPr lang="en-US" sz="2400" dirty="0"/>
           </a:p>
@@ -5855,7 +5771,7 @@
                   <a:srgbClr val="888888"/>
                 </a:solidFill>
               </a:rPr>
-              <a:t>Brain, behavior, and immunity  ·  🌏 Asia</a:t>
+              <a:t>Gut  ·  IF 24.5</a:t>
             </a:r>
             <a:endParaRPr lang="en-US" sz="1000" dirty="0"/>
           </a:p>
@@ -5898,7 +5814,7 @@
                 <a:ea typeface="Arial" pitchFamily="34" charset="-122"/>
                 <a:cs typeface="Arial" pitchFamily="34" charset="-120"/>
               </a:rPr>
-              <a:t>AUS reduces inflammation in CRC models.</a:t>
+              <a:t>P. excrementihominis worsens colitis severity</a:t>
             </a:r>
             <a:endParaRPr lang="en-US" sz="1800" dirty="0"/>
           </a:p>
@@ -5919,7 +5835,7 @@
                 <a:ea typeface="Arial" pitchFamily="34" charset="-122"/>
                 <a:cs typeface="Arial" pitchFamily="34" charset="-120"/>
               </a:rPr>
-              <a:t>LIPUS improves depressive behavior in mice.</a:t>
+              <a:t>Pathogenic NETosis activation observed</a:t>
             </a:r>
             <a:endParaRPr lang="en-US" sz="1800" dirty="0"/>
           </a:p>
@@ -5940,7 +5856,7 @@
                 <a:ea typeface="Arial" pitchFamily="34" charset="-122"/>
                 <a:cs typeface="Arial" pitchFamily="34" charset="-120"/>
               </a:rPr>
-              <a:t>Wnt/β-catenin pathway is modulated.</a:t>
+              <a:t>Impacts colorectal cancer development</a:t>
             </a:r>
             <a:endParaRPr lang="en-US" sz="1800" dirty="0"/>
           </a:p>
@@ -5961,7 +5877,7 @@
                 <a:ea typeface="Arial" pitchFamily="34" charset="-122"/>
                 <a:cs typeface="Arial" pitchFamily="34" charset="-120"/>
               </a:rPr>
-              <a:t>HPA axis hyperactivity is downregulated.</a:t>
+              <a:t>Novel therapeutic strategies suggested</a:t>
             </a:r>
             <a:endParaRPr lang="en-US" sz="1800" dirty="0"/>
           </a:p>
@@ -5982,7 +5898,7 @@
                 <a:ea typeface="Arial" pitchFamily="34" charset="-122"/>
                 <a:cs typeface="Arial" pitchFamily="34" charset="-120"/>
               </a:rPr>
-              <a:t>Potential non-invasive CRC therapy.</a:t>
+              <a:t>Study focuses on immune responses</a:t>
             </a:r>
             <a:endParaRPr lang="en-US" sz="1800" dirty="0"/>
           </a:p>
@@ -6018,7 +5934,7 @@
                   <a:srgbClr val="888888"/>
                 </a:solidFill>
               </a:rPr>
-              <a:t>Yang Feng-Yi, Wu Ruei-Yu, Lau Chi-Ieong et al.. Brain, behavior, and immunity. 2026-05-21 DOI: 10.1016/j.bbi.2026.106818</a:t>
+              <a:t>H Tan, L Huang, J Wang. Gut. 2026</a:t>
             </a:r>
             <a:endParaRPr lang="en-US" sz="800" dirty="0"/>
           </a:p>
@@ -6218,7 +6134,7 @@
                   </a:extLst>
                 </a:hlinkClick>
               </a:rPr>
-              <a:t>Predictive utility of the C-reactive protein-albumin-lymphocyte (CALLY) index in Colorectal cancer: A meta-analysis</a:t>
+              <a:t>Mitochondria-Targeting Iridium(III) Complexes Induce PANoptosis and Ferroptosis for Boosting Chemoimmunotherapy Against Immune-Desert Colorectal Cancer.</a:t>
             </a:r>
             <a:endParaRPr lang="en-US" sz="2400" dirty="0"/>
           </a:p>
@@ -6254,7 +6170,7 @@
                   <a:srgbClr val="888888"/>
                 </a:solidFill>
               </a:rPr>
-              <a:t>Clinics and Research in Hepatology and …  ·  Meta-Analysis</a:t>
+              <a:t>Angewandte Chemie (International ed. in English)  ·  Basic Research  ·  🌏 Asia</a:t>
             </a:r>
             <a:endParaRPr lang="en-US" sz="1000" dirty="0"/>
           </a:p>
@@ -6297,7 +6213,7 @@
                 <a:ea typeface="Arial" pitchFamily="34" charset="-122"/>
                 <a:cs typeface="Arial" pitchFamily="34" charset="-120"/>
               </a:rPr>
-              <a:t>CALLY index predicts CRC prognosis.</a:t>
+              <a:t>Over 80% of CRC cases are MSS.</a:t>
             </a:r>
             <a:endParaRPr lang="en-US" sz="1800" dirty="0"/>
           </a:p>
@@ -6318,7 +6234,7 @@
                 <a:ea typeface="Arial" pitchFamily="34" charset="-122"/>
                 <a:cs typeface="Arial" pitchFamily="34" charset="-120"/>
               </a:rPr>
-              <a:t>Meta-analysis of multiple studies.</a:t>
+              <a:t>Iridium(III) complexes induce PANoptosis.</a:t>
             </a:r>
             <a:endParaRPr lang="en-US" sz="1800" dirty="0"/>
           </a:p>
@@ -6339,7 +6255,49 @@
                 <a:ea typeface="Arial" pitchFamily="34" charset="-122"/>
                 <a:cs typeface="Arial" pitchFamily="34" charset="-120"/>
               </a:rPr>
-              <a:t>Inconsistent results across populations.</a:t>
+              <a:t>Concurrent ferroptosis enhances immunotherapy.</a:t>
+            </a:r>
+            <a:endParaRPr lang="en-US" sz="1800" dirty="0"/>
+          </a:p>
+          <a:p>
+            <a:pPr marL="342900" indent="-342900">
+              <a:spcAft>
+                <a:spcPts val="800"/>
+              </a:spcAft>
+              <a:buSzPct val="100000"/>
+              <a:buChar char="•"/>
+            </a:pPr>
+            <a:r>
+              <a:rPr lang="en-US" sz="1800" dirty="0">
+                <a:solidFill>
+                  <a:srgbClr val="333333"/>
+                </a:solidFill>
+                <a:latin typeface="Arial" pitchFamily="34" charset="0"/>
+                <a:ea typeface="Arial" pitchFamily="34" charset="-122"/>
+                <a:cs typeface="Arial" pitchFamily="34" charset="-120"/>
+              </a:rPr>
+              <a:t>Mechanism-guided design for mitochondrial targeting.</a:t>
+            </a:r>
+            <a:endParaRPr lang="en-US" sz="1800" dirty="0"/>
+          </a:p>
+          <a:p>
+            <a:pPr marL="342900" indent="-342900">
+              <a:spcAft>
+                <a:spcPts val="800"/>
+              </a:spcAft>
+              <a:buSzPct val="100000"/>
+              <a:buChar char="•"/>
+            </a:pPr>
+            <a:r>
+              <a:rPr lang="en-US" sz="1800" dirty="0">
+                <a:solidFill>
+                  <a:srgbClr val="333333"/>
+                </a:solidFill>
+                <a:latin typeface="Arial" pitchFamily="34" charset="0"/>
+                <a:ea typeface="Arial" pitchFamily="34" charset="-122"/>
+                <a:cs typeface="Arial" pitchFamily="34" charset="-120"/>
+              </a:rPr>
+              <a:t>Proteomic analysis supports therapeutic efficacy.</a:t>
             </a:r>
             <a:endParaRPr lang="en-US" sz="1800" dirty="0"/>
           </a:p>
@@ -6375,7 +6333,7 @@
                   <a:srgbClr val="888888"/>
                 </a:solidFill>
               </a:rPr>
-              <a:t>X Li, T Chu, W Chen. Clinics and Research in Hepatology and …. 2026</a:t>
+              <a:t>Liu Xing, Feng Tao, Yang Xiaoting et al.. Angewandte Chemie (International ed. in English). 2026-05-28 DOI: 10.1002/anie.3918717</a:t>
             </a:r>
             <a:endParaRPr lang="en-US" sz="800" dirty="0"/>
           </a:p>
@@ -6575,7 +6533,7 @@
                   </a:extLst>
                 </a:hlinkClick>
               </a:rPr>
-              <a:t>Prognostic value of systemic immune-inflammation index for colorectal cancer: a systematic review and meta-analysis</a:t>
+              <a:t>Predictive utility of the C-reactive protein-albumin-lymphocyte (CALLY) index in colorectal cancer: a meta-analysis</a:t>
             </a:r>
             <a:endParaRPr lang="en-US" sz="2400" dirty="0"/>
           </a:p>
@@ -6611,7 +6569,7 @@
                   <a:srgbClr val="888888"/>
                 </a:solidFill>
               </a:rPr>
-              <a:t>Frontiers in Oncology  ·  Meta-Analysis</a:t>
+              <a:t>Clinics and Research in Hepatology and …  ·  Meta-Analysis</a:t>
             </a:r>
             <a:endParaRPr lang="en-US" sz="1000" dirty="0"/>
           </a:p>
@@ -6654,7 +6612,7 @@
                 <a:ea typeface="Arial" pitchFamily="34" charset="-122"/>
                 <a:cs typeface="Arial" pitchFamily="34" charset="-120"/>
               </a:rPr>
-              <a:t>Systemic immune-inflammation index (SII) evaluated</a:t>
+              <a:t>CALLY index predicts CRC prognosis.</a:t>
             </a:r>
             <a:endParaRPr lang="en-US" sz="1800" dirty="0"/>
           </a:p>
@@ -6675,7 +6633,7 @@
                 <a:ea typeface="Arial" pitchFamily="34" charset="-122"/>
                 <a:cs typeface="Arial" pitchFamily="34" charset="-120"/>
               </a:rPr>
-              <a:t>SII as a prognostic biomarker in CRC</a:t>
+              <a:t>Meta-analysis of multiple studies conducted.</a:t>
             </a:r>
             <a:endParaRPr lang="en-US" sz="1800" dirty="0"/>
           </a:p>
@@ -6696,49 +6654,7 @@
                 <a:ea typeface="Arial" pitchFamily="34" charset="-122"/>
                 <a:cs typeface="Arial" pitchFamily="34" charset="-120"/>
               </a:rPr>
-              <a:t>Meta-analysis of existing studies conducted</a:t>
-            </a:r>
-            <a:endParaRPr lang="en-US" sz="1800" dirty="0"/>
-          </a:p>
-          <a:p>
-            <a:pPr marL="342900" indent="-342900">
-              <a:spcAft>
-                <a:spcPts val="800"/>
-              </a:spcAft>
-              <a:buSzPct val="100000"/>
-              <a:buChar char="•"/>
-            </a:pPr>
-            <a:r>
-              <a:rPr lang="en-US" sz="1800" dirty="0">
-                <a:solidFill>
-                  <a:srgbClr val="333333"/>
-                </a:solidFill>
-                <a:latin typeface="Arial" pitchFamily="34" charset="0"/>
-                <a:ea typeface="Arial" pitchFamily="34" charset="-122"/>
-                <a:cs typeface="Arial" pitchFamily="34" charset="-120"/>
-              </a:rPr>
-              <a:t>SII correlates with patient outcomes</a:t>
-            </a:r>
-            <a:endParaRPr lang="en-US" sz="1800" dirty="0"/>
-          </a:p>
-          <a:p>
-            <a:pPr marL="342900" indent="-342900">
-              <a:spcAft>
-                <a:spcPts val="800"/>
-              </a:spcAft>
-              <a:buSzPct val="100000"/>
-              <a:buChar char="•"/>
-            </a:pPr>
-            <a:r>
-              <a:rPr lang="en-US" sz="1800" dirty="0">
-                <a:solidFill>
-                  <a:srgbClr val="333333"/>
-                </a:solidFill>
-                <a:latin typeface="Arial" pitchFamily="34" charset="0"/>
-                <a:ea typeface="Arial" pitchFamily="34" charset="-122"/>
-                <a:cs typeface="Arial" pitchFamily="34" charset="-120"/>
-              </a:rPr>
-              <a:t>Potential for clinical application in CRC</a:t>
+              <a:t>Inconsistency in previous findings addressed.</a:t>
             </a:r>
             <a:endParaRPr lang="en-US" sz="1800" dirty="0"/>
           </a:p>
@@ -6774,7 +6690,7 @@
                   <a:srgbClr val="888888"/>
                 </a:solidFill>
               </a:rPr>
-              <a:t>P Wang, H Jiang. Frontiers in Oncology. 2026</a:t>
+              <a:t>X Li, T Chu, W Chen. Clinics and Research in Hepatology and …. 2026</a:t>
             </a:r>
             <a:endParaRPr lang="en-US" sz="800" dirty="0"/>
           </a:p>
@@ -6974,7 +6890,7 @@
                   </a:extLst>
                 </a:hlinkClick>
               </a:rPr>
-              <a:t>Enhanced recovery after surgery pathways and postoperative gastrointestinal function in colorectal cancer: A prospective cohort study</a:t>
+              <a:t>Prognostic value of systemic immune-inflammation index for colorectal cancer: a systematic review and meta-analysis</a:t>
             </a:r>
             <a:endParaRPr lang="en-US" sz="2400" dirty="0"/>
           </a:p>
@@ -7010,7 +6926,7 @@
                   <a:srgbClr val="888888"/>
                 </a:solidFill>
               </a:rPr>
-              <a:t>World journal of gastrointestinal surgery  ·  Prospective Study</a:t>
+              <a:t>Frontiers in Oncology  ·  Meta-Analysis</a:t>
             </a:r>
             <a:endParaRPr lang="en-US" sz="1000" dirty="0"/>
           </a:p>
@@ -7053,7 +6969,7 @@
                 <a:ea typeface="Arial" pitchFamily="34" charset="-122"/>
                 <a:cs typeface="Arial" pitchFamily="34" charset="-120"/>
               </a:rPr>
-              <a:t>Enhanced recovery pathways improve outcomes.</a:t>
+              <a:t>Systemic immune-inflammation index (SII) evaluated</a:t>
             </a:r>
             <a:endParaRPr lang="en-US" sz="1800" dirty="0"/>
           </a:p>
@@ -7074,7 +6990,7 @@
                 <a:ea typeface="Arial" pitchFamily="34" charset="-122"/>
                 <a:cs typeface="Arial" pitchFamily="34" charset="-120"/>
               </a:rPr>
-              <a:t>Early enteral nutrition is beneficial.</a:t>
+              <a:t>SII as a prognostic biomarker in CRC</a:t>
             </a:r>
             <a:endParaRPr lang="en-US" sz="1800" dirty="0"/>
           </a:p>
@@ -7095,7 +7011,49 @@
                 <a:ea typeface="Arial" pitchFamily="34" charset="-122"/>
                 <a:cs typeface="Arial" pitchFamily="34" charset="-120"/>
               </a:rPr>
-              <a:t>Maintains intestinal mucosal barrier integrity.</a:t>
+              <a:t>Meta-analysis of existing studies conducted</a:t>
+            </a:r>
+            <a:endParaRPr lang="en-US" sz="1800" dirty="0"/>
+          </a:p>
+          <a:p>
+            <a:pPr marL="342900" indent="-342900">
+              <a:spcAft>
+                <a:spcPts val="800"/>
+              </a:spcAft>
+              <a:buSzPct val="100000"/>
+              <a:buChar char="•"/>
+            </a:pPr>
+            <a:r>
+              <a:rPr lang="en-US" sz="1800" dirty="0">
+                <a:solidFill>
+                  <a:srgbClr val="333333"/>
+                </a:solidFill>
+                <a:latin typeface="Arial" pitchFamily="34" charset="0"/>
+                <a:ea typeface="Arial" pitchFamily="34" charset="-122"/>
+                <a:cs typeface="Arial" pitchFamily="34" charset="-120"/>
+              </a:rPr>
+              <a:t>SII correlates with patient outcomes</a:t>
+            </a:r>
+            <a:endParaRPr lang="en-US" sz="1800" dirty="0"/>
+          </a:p>
+          <a:p>
+            <a:pPr marL="342900" indent="-342900">
+              <a:spcAft>
+                <a:spcPts val="800"/>
+              </a:spcAft>
+              <a:buSzPct val="100000"/>
+              <a:buChar char="•"/>
+            </a:pPr>
+            <a:r>
+              <a:rPr lang="en-US" sz="1800" dirty="0">
+                <a:solidFill>
+                  <a:srgbClr val="333333"/>
+                </a:solidFill>
+                <a:latin typeface="Arial" pitchFamily="34" charset="0"/>
+                <a:ea typeface="Arial" pitchFamily="34" charset="-122"/>
+                <a:cs typeface="Arial" pitchFamily="34" charset="-120"/>
+              </a:rPr>
+              <a:t>Potential for clinical application in CRC</a:t>
             </a:r>
             <a:endParaRPr lang="en-US" sz="1800" dirty="0"/>
           </a:p>
@@ -7131,7 +7089,7 @@
                   <a:srgbClr val="888888"/>
                 </a:solidFill>
               </a:rPr>
-              <a:t>BH Zhao, CX Bao. World journal of gastrointestinal surgery. 2026</a:t>
+              <a:t>P Wang, H Jiang. Frontiers in Oncology. 2026</a:t>
             </a:r>
             <a:endParaRPr lang="en-US" sz="800" dirty="0"/>
           </a:p>
@@ -7331,7 +7289,7 @@
                   </a:extLst>
                 </a:hlinkClick>
               </a:rPr>
-              <a:t>Oncometabolite signatures from tumor-stroma crosstalk as potential non-invasive biomarkers.</a:t>
+              <a:t>Consensus Guideline for the Management of Colorectal Cancer with Peritoneal Metastases.</a:t>
             </a:r>
             <a:endParaRPr lang="en-US" sz="2400" dirty="0"/>
           </a:p>
@@ -7367,7 +7325,7 @@
                   <a:srgbClr val="888888"/>
                 </a:solidFill>
               </a:rPr>
-              <a:t>Cell death discovery  ·  Basic Research</a:t>
+              <a:t>Annals of surgical oncology  ·  IF 3.8  ·  Prospective Study</a:t>
             </a:r>
             <a:endParaRPr lang="en-US" sz="1000" dirty="0"/>
           </a:p>
@@ -7410,7 +7368,7 @@
                 <a:ea typeface="Arial" pitchFamily="34" charset="-122"/>
                 <a:cs typeface="Arial" pitchFamily="34" charset="-120"/>
               </a:rPr>
-              <a:t>Tumor metabolism impacts cancer progression.</a:t>
+              <a:t>Peritoneum common site for CRC metastases.</a:t>
             </a:r>
             <a:endParaRPr lang="en-US" sz="1800" dirty="0"/>
           </a:p>
@@ -7431,7 +7389,7 @@
                 <a:ea typeface="Arial" pitchFamily="34" charset="-122"/>
                 <a:cs typeface="Arial" pitchFamily="34" charset="-120"/>
               </a:rPr>
-              <a:t>Distinct TAF behaviors in tumor growth.</a:t>
+              <a:t>Updated 2018 Chicago Consensus Guidelines.</a:t>
             </a:r>
             <a:endParaRPr lang="en-US" sz="1800" dirty="0"/>
           </a:p>
@@ -7452,7 +7410,49 @@
                 <a:ea typeface="Arial" pitchFamily="34" charset="-122"/>
                 <a:cs typeface="Arial" pitchFamily="34" charset="-120"/>
               </a:rPr>
-              <a:t>Oncometabolites as potential biomarkers.</a:t>
+              <a:t>Over 90% consensus on management pathways.</a:t>
+            </a:r>
+            <a:endParaRPr lang="en-US" sz="1800" dirty="0"/>
+          </a:p>
+          <a:p>
+            <a:pPr marL="342900" indent="-342900">
+              <a:spcAft>
+                <a:spcPts val="800"/>
+              </a:spcAft>
+              <a:buSzPct val="100000"/>
+              <a:buChar char="•"/>
+            </a:pPr>
+            <a:r>
+              <a:rPr lang="en-US" sz="1800" dirty="0">
+                <a:solidFill>
+                  <a:srgbClr val="333333"/>
+                </a:solidFill>
+                <a:latin typeface="Arial" pitchFamily="34" charset="0"/>
+                <a:ea typeface="Arial" pitchFamily="34" charset="-122"/>
+                <a:cs typeface="Arial" pitchFamily="34" charset="-120"/>
+              </a:rPr>
+              <a:t>Early referral to PSM centers recommended.</a:t>
+            </a:r>
+            <a:endParaRPr lang="en-US" sz="1800" dirty="0"/>
+          </a:p>
+          <a:p>
+            <a:pPr marL="342900" indent="-342900">
+              <a:spcAft>
+                <a:spcPts val="800"/>
+              </a:spcAft>
+              <a:buSzPct val="100000"/>
+              <a:buChar char="•"/>
+            </a:pPr>
+            <a:r>
+              <a:rPr lang="en-US" sz="1800" dirty="0">
+                <a:solidFill>
+                  <a:srgbClr val="333333"/>
+                </a:solidFill>
+                <a:latin typeface="Arial" pitchFamily="34" charset="0"/>
+                <a:ea typeface="Arial" pitchFamily="34" charset="-122"/>
+                <a:cs typeface="Arial" pitchFamily="34" charset="-120"/>
+              </a:rPr>
+              <a:t>Limited evidence for ctDNA testing utility.</a:t>
             </a:r>
             <a:endParaRPr lang="en-US" sz="1800" dirty="0"/>
           </a:p>
@@ -7488,7 +7488,7 @@
                   <a:srgbClr val="888888"/>
                 </a:solidFill>
               </a:rPr>
-              <a:t>Parascandolo Alessia, Magnifico Maria C, De Vita Emanuele et al.. Cell death discovery. 2026-05-22 DOI: 10.1038/s41420-026-03172-1</a:t>
+              <a:t>Schultz Kurt S, Bansal Varun V, Wach Michael M et al.. Annals of surgical oncology. 2026-05-19 DOI: 10.1245/s10434-025-17363-0</a:t>
             </a:r>
             <a:endParaRPr lang="en-US" sz="800" dirty="0"/>
           </a:p>

</xml_diff>

<commit_message>
chore: update weekly digest 2026-06-08
</commit_message>
<xml_diff>
--- a/docs/digest-en.pptx
+++ b/docs/digest-en.pptx
@@ -2249,7 +2249,7 @@
                   <a:srgbClr val="888888"/>
                 </a:solidFill>
               </a:rPr>
-              <a:t>2026-05-25 — 2026-06-01</a:t>
+              <a:t>2026-06-01 — 2026-06-08</a:t>
             </a:r>
             <a:endParaRPr lang="en-US" sz="1400" dirty="0"/>
           </a:p>
@@ -2440,7 +2440,7 @@
                   </a:extLst>
                 </a:hlinkClick>
               </a:rPr>
-              <a:t>Awareness of inflammatory bowel disease-associated colorectal cancer risk and its management in patients with inflammatory bowel disease: a systematic review</a:t>
+              <a:t>Life After Pelvic Exenteration for Rectal Cancer: The Patient and Carer Perspective on Long-term Consequences and Survivorship.</a:t>
             </a:r>
             <a:endParaRPr lang="en-US" sz="2400" dirty="0"/>
           </a:p>
@@ -2476,7 +2476,7 @@
                   <a:srgbClr val="888888"/>
                 </a:solidFill>
               </a:rPr>
-              <a:t>Crohns &amp; Colitis 360  ·  Systematic Review</a:t>
+              <a:t>Annals of surgery  ·  IF 9.4</a:t>
             </a:r>
             <a:endParaRPr lang="en-US" sz="1000" dirty="0"/>
           </a:p>
@@ -2519,7 +2519,7 @@
                 <a:ea typeface="Arial" pitchFamily="34" charset="-122"/>
                 <a:cs typeface="Arial" pitchFamily="34" charset="-120"/>
               </a:rPr>
-              <a:t>Limited awareness of cancer risk</a:t>
+              <a:t>Pelvic exenteration for rectal cancer is standard care.</a:t>
             </a:r>
             <a:endParaRPr lang="en-US" sz="1800" dirty="0"/>
           </a:p>
@@ -2540,7 +2540,7 @@
                 <a:ea typeface="Arial" pitchFamily="34" charset="-122"/>
                 <a:cs typeface="Arial" pitchFamily="34" charset="-120"/>
               </a:rPr>
-              <a:t>Need for better patient education</a:t>
+              <a:t>Long-term survivors face significant challenges.</a:t>
             </a:r>
             <a:endParaRPr lang="en-US" sz="1800" dirty="0"/>
           </a:p>
@@ -2561,7 +2561,7 @@
                 <a:ea typeface="Arial" pitchFamily="34" charset="-122"/>
                 <a:cs typeface="Arial" pitchFamily="34" charset="-120"/>
               </a:rPr>
-              <a:t>Research gaps in management strategies</a:t>
+              <a:t>Participants accepted surgery consequences for survival.</a:t>
             </a:r>
             <a:endParaRPr lang="en-US" sz="1800" dirty="0"/>
           </a:p>
@@ -2597,7 +2597,7 @@
                   <a:srgbClr val="888888"/>
                 </a:solidFill>
               </a:rPr>
-              <a:t>F Khan, C Norton, W Czuber-Dochan. Crohns &amp; Colitis 360. 2026</a:t>
+              <a:t>Brown Kilian G M, White Kate, Solomon Michael J et al.. Annals of surgery. 2026-05-12 DOI: 10.1097/SLA.0000000000006625</a:t>
             </a:r>
             <a:endParaRPr lang="en-US" sz="800" dirty="0"/>
           </a:p>
@@ -2797,7 +2797,7 @@
                   </a:extLst>
                 </a:hlinkClick>
               </a:rPr>
-              <a:t>Life After Pelvic Exenteration for Rectal Cancer: The Patient and Carer Perspective on Long-term Consequences and Survivorship.</a:t>
+              <a:t>Colon cancer with a peritumoural abscess: Real-world evidence on prognostic and therapeutic implications of a disregarded entity.</a:t>
             </a:r>
             <a:endParaRPr lang="en-US" sz="2400" dirty="0"/>
           </a:p>
@@ -2833,7 +2833,7 @@
                   <a:srgbClr val="888888"/>
                 </a:solidFill>
               </a:rPr>
-              <a:t>Annals of surgery  ·  IF 9.4</a:t>
+              <a:t>European journal of cancer (Oxford, England : 1990)  ·  IF 8.4</a:t>
             </a:r>
             <a:endParaRPr lang="en-US" sz="1000" dirty="0"/>
           </a:p>
@@ -2876,7 +2876,7 @@
                 <a:ea typeface="Arial" pitchFamily="34" charset="-122"/>
                 <a:cs typeface="Arial" pitchFamily="34" charset="-120"/>
               </a:rPr>
-              <a:t>Pelvic exenteration standard for advanced rectal cancer</a:t>
+              <a:t>CCPA diagnosed in 2.7% of patients</a:t>
             </a:r>
             <a:endParaRPr lang="en-US" sz="1800" dirty="0"/>
           </a:p>
@@ -2897,7 +2897,7 @@
                 <a:ea typeface="Arial" pitchFamily="34" charset="-122"/>
                 <a:cs typeface="Arial" pitchFamily="34" charset="-120"/>
               </a:rPr>
-              <a:t>Long-term survivors face significant challenges</a:t>
+              <a:t>Higher locoregional recurrence rate observed</a:t>
             </a:r>
             <a:endParaRPr lang="en-US" sz="1800" dirty="0"/>
           </a:p>
@@ -2918,7 +2918,49 @@
                 <a:ea typeface="Arial" pitchFamily="34" charset="-122"/>
                 <a:cs typeface="Arial" pitchFamily="34" charset="-120"/>
               </a:rPr>
-              <a:t>Participants accept surgery consequences for survival</a:t>
+              <a:t>BTS approach had highest complications</a:t>
+            </a:r>
+            <a:endParaRPr lang="en-US" sz="1800" dirty="0"/>
+          </a:p>
+          <a:p>
+            <a:pPr marL="342900" indent="-342900">
+              <a:spcAft>
+                <a:spcPts val="800"/>
+              </a:spcAft>
+              <a:buSzPct val="100000"/>
+              <a:buChar char="•"/>
+            </a:pPr>
+            <a:r>
+              <a:rPr lang="en-US" sz="1800" dirty="0">
+                <a:solidFill>
+                  <a:srgbClr val="333333"/>
+                </a:solidFill>
+                <a:latin typeface="Arial" pitchFamily="34" charset="0"/>
+                <a:ea typeface="Arial" pitchFamily="34" charset="-122"/>
+                <a:cs typeface="Arial" pitchFamily="34" charset="-120"/>
+              </a:rPr>
+              <a:t>Acute resection linked to peritoneal metastases</a:t>
+            </a:r>
+            <a:endParaRPr lang="en-US" sz="1800" dirty="0"/>
+          </a:p>
+          <a:p>
+            <a:pPr marL="342900" indent="-342900">
+              <a:spcAft>
+                <a:spcPts val="800"/>
+              </a:spcAft>
+              <a:buSzPct val="100000"/>
+              <a:buChar char="•"/>
+            </a:pPr>
+            <a:r>
+              <a:rPr lang="en-US" sz="1800" dirty="0">
+                <a:solidFill>
+                  <a:srgbClr val="333333"/>
+                </a:solidFill>
+                <a:latin typeface="Arial" pitchFamily="34" charset="0"/>
+                <a:ea typeface="Arial" pitchFamily="34" charset="-122"/>
+                <a:cs typeface="Arial" pitchFamily="34" charset="-120"/>
+              </a:rPr>
+              <a:t>Future studies needed for treatment optimization</a:t>
             </a:r>
             <a:endParaRPr lang="en-US" sz="1800" dirty="0"/>
           </a:p>
@@ -2954,7 +2996,7 @@
                   <a:srgbClr val="888888"/>
                 </a:solidFill>
               </a:rPr>
-              <a:t>Brown Kilian G M, White Kate, Solomon Michael J et al.. Annals of surgery. 2026-05-12 DOI: 10.1097/SLA.0000000000006625</a:t>
+              <a:t>Rademaker Eva, van der Woude Jannes M, van den Berg Rudolf et al.. European journal of cancer (Oxford, England : 1990). 2026-05-21 DOI: 10.1016/j.ejca.2026.116705</a:t>
             </a:r>
             <a:endParaRPr lang="en-US" sz="800" dirty="0"/>
           </a:p>
@@ -3154,7 +3196,7 @@
                   </a:extLst>
                 </a:hlinkClick>
               </a:rPr>
-              <a:t>Enhanced recovery after surgery pathways and postoperative gastrointestinal function in colorectal cancer: A prospective cohort study</a:t>
+              <a:t>Genetic variants of the transporter SLC22A4 affect the abundance and survival of Fusobacterium nucleatum in colorectal cancer.</a:t>
             </a:r>
             <a:endParaRPr lang="en-US" sz="2400" dirty="0"/>
           </a:p>
@@ -3190,7 +3232,7 @@
                   <a:srgbClr val="888888"/>
                 </a:solidFill>
               </a:rPr>
-              <a:t>World journal of gastrointestinal surgery  ·  Prospective Study</a:t>
+              <a:t>Gut microbes  ·  Basic Research</a:t>
             </a:r>
             <a:endParaRPr lang="en-US" sz="1000" dirty="0"/>
           </a:p>
@@ -3233,7 +3275,7 @@
                 <a:ea typeface="Arial" pitchFamily="34" charset="-122"/>
                 <a:cs typeface="Arial" pitchFamily="34" charset="-120"/>
               </a:rPr>
-              <a:t>Enhanced recovery pathways improve outcomes</a:t>
+              <a:t>SLC22A4 variants influence F. nucleatum levels.</a:t>
             </a:r>
             <a:endParaRPr lang="en-US" sz="1800" dirty="0"/>
           </a:p>
@@ -3254,7 +3296,7 @@
                 <a:ea typeface="Arial" pitchFamily="34" charset="-122"/>
                 <a:cs typeface="Arial" pitchFamily="34" charset="-120"/>
               </a:rPr>
-              <a:t>Early enteral nutrition is beneficial</a:t>
+              <a:t>Higher F. nucleatum/E. coli ratio in tumors.</a:t>
             </a:r>
             <a:endParaRPr lang="en-US" sz="1800" dirty="0"/>
           </a:p>
@@ -3275,7 +3317,49 @@
                 <a:ea typeface="Arial" pitchFamily="34" charset="-122"/>
                 <a:cs typeface="Arial" pitchFamily="34" charset="-120"/>
               </a:rPr>
-              <a:t>Maintains intestinal mucosal barrier integrity</a:t>
+              <a:t>503F variant affects inflammatory response.</a:t>
+            </a:r>
+            <a:endParaRPr lang="en-US" sz="1800" dirty="0"/>
+          </a:p>
+          <a:p>
+            <a:pPr marL="342900" indent="-342900">
+              <a:spcAft>
+                <a:spcPts val="800"/>
+              </a:spcAft>
+              <a:buSzPct val="100000"/>
+              <a:buChar char="•"/>
+            </a:pPr>
+            <a:r>
+              <a:rPr lang="en-US" sz="1800" dirty="0">
+                <a:solidFill>
+                  <a:srgbClr val="333333"/>
+                </a:solidFill>
+                <a:latin typeface="Arial" pitchFamily="34" charset="0"/>
+                <a:ea typeface="Arial" pitchFamily="34" charset="-122"/>
+                <a:cs typeface="Arial" pitchFamily="34" charset="-120"/>
+              </a:rPr>
+              <a:t>Genetic factors shape tumor microbiota.</a:t>
+            </a:r>
+            <a:endParaRPr lang="en-US" sz="1800" dirty="0"/>
+          </a:p>
+          <a:p>
+            <a:pPr marL="342900" indent="-342900">
+              <a:spcAft>
+                <a:spcPts val="800"/>
+              </a:spcAft>
+              <a:buSzPct val="100000"/>
+              <a:buChar char="•"/>
+            </a:pPr>
+            <a:r>
+              <a:rPr lang="en-US" sz="1800" dirty="0">
+                <a:solidFill>
+                  <a:srgbClr val="333333"/>
+                </a:solidFill>
+                <a:latin typeface="Arial" pitchFamily="34" charset="0"/>
+                <a:ea typeface="Arial" pitchFamily="34" charset="-122"/>
+                <a:cs typeface="Arial" pitchFamily="34" charset="-120"/>
+              </a:rPr>
+              <a:t>Innate immunity dampened in cancer cells.</a:t>
             </a:r>
             <a:endParaRPr lang="en-US" sz="1800" dirty="0"/>
           </a:p>
@@ -3311,7 +3395,7 @@
                   <a:srgbClr val="888888"/>
                 </a:solidFill>
               </a:rPr>
-              <a:t>BH Zhao, CX Bao. World journal of gastrointestinal surgery. 2026</a:t>
+              <a:t>Chouaibi Samah, Fertitta Veronica, Porreca Silvia et al.. Gut microbes. 2026-06-05 DOI: 10.1080/19490976.2026.2681818</a:t>
             </a:r>
             <a:endParaRPr lang="en-US" sz="800" dirty="0"/>
           </a:p>
@@ -3528,7 +3612,7 @@
                   <a:srgbClr val="FFFFFF"/>
                 </a:solidFill>
               </a:rPr>
-              <a:t>1. **手術與化療的整合策略**  </a:t>
+              <a:t>1. **新療法的潛力**  </a:t>
             </a:r>
             <a:endParaRPr lang="en-US" sz="1200" dirty="0"/>
           </a:p>
@@ -3545,7 +3629,7 @@
                   <a:srgbClr val="FFFFFF"/>
                 </a:solidFill>
               </a:rPr>
-              <a:t>   The combination of cytoreductive surgery and hyperthermic intraperitoneal chemotherapy shows limited benefits in metastatic colorectal cancer, highlighting the need for more effective treatment protocols.  </a:t>
+              <a:t>   The integration of novel therapeutic strategies, such as targeting TXNDC5 and utilizing mucoadhesive drug delivery systems, shows promise in overcoming treatment resistance in colorectal cancer.  </a:t>
             </a:r>
             <a:endParaRPr lang="en-US" sz="1200" dirty="0"/>
           </a:p>
@@ -3562,7 +3646,7 @@
                   <a:srgbClr val="FFFFFF"/>
                 </a:solidFill>
               </a:rPr>
-              <a:t>   結合細胞減少手術與高溫腹腔化療在轉移性大腸癌中的效果有限，突顯出需要更有效的治療方案。</a:t>
+              <a:t>   新的治療策略，如針對TXNDC5和使用黏附性藥物傳遞系統，顯示出克服結直腸癌治療抵抗的潛力。</a:t>
             </a:r>
             <a:endParaRPr lang="en-US" sz="1200" dirty="0"/>
           </a:p>
@@ -3588,7 +3672,7 @@
                   <a:srgbClr val="FFFFFF"/>
                 </a:solidFill>
               </a:rPr>
-              <a:t>2. **預後指標的變化**  </a:t>
+              <a:t>2. **預後指標的價值**  </a:t>
             </a:r>
             <a:endParaRPr lang="en-US" sz="1200" dirty="0"/>
           </a:p>
@@ -3605,7 +3689,7 @@
                   <a:srgbClr val="FFFFFF"/>
                 </a:solidFill>
               </a:rPr>
-              <a:t>   The prognostic value of indices like the C-reactive protein-albumin-lymphocyte (CALLY) index and systemic immune-inflammation index (SII) remains inconsistent, indicating a need for standardization in their application.  </a:t>
+              <a:t>   The systemic immune-inflammation index (SII) has emerged as a significant prognostic biomarker, potentially guiding treatment decisions in colorectal cancer management.  </a:t>
             </a:r>
             <a:endParaRPr lang="en-US" sz="1200" dirty="0"/>
           </a:p>
@@ -3622,7 +3706,7 @@
                   <a:srgbClr val="FFFFFF"/>
                 </a:solidFill>
               </a:rPr>
-              <a:t>   C-反應蛋白-白蛋白-淋巴細胞（CALLY）指數和系統性免疫炎症指數（SII）的預後價值不一致，顯示其應用需要標準化。</a:t>
+              <a:t>   系統免疫-炎症指數(SII)已成為重要的預後生物標誌物，可能指導結直腸癌的治療決策。</a:t>
             </a:r>
             <a:endParaRPr lang="en-US" sz="1200" dirty="0"/>
           </a:p>
@@ -3648,7 +3732,7 @@
                   <a:srgbClr val="FFFFFF"/>
                 </a:solidFill>
               </a:rPr>
-              <a:t>3. **腸道微生物與癌症的關聯**  </a:t>
+              <a:t>3. **炎症與癌症的關聯**  </a:t>
             </a:r>
             <a:endParaRPr lang="en-US" sz="1200" dirty="0"/>
           </a:p>
@@ -3665,7 +3749,7 @@
                   <a:srgbClr val="FFFFFF"/>
                 </a:solidFill>
               </a:rPr>
-              <a:t>   The role of gut microbiota, particularly Parasutterella excrementihominis, in exacerbating colitis and colorectal cancer suggests potential therapeutic targets for inflammation-driven carcinogenesis.  </a:t>
+              <a:t>   The studies highlight the critical role of inflammation in colorectal carcinogenesis, emphasizing the need for targeted therapies to mitigate inflammation-driven cancer progression.  </a:t>
             </a:r>
             <a:endParaRPr lang="en-US" sz="1200" dirty="0"/>
           </a:p>
@@ -3682,7 +3766,7 @@
                   <a:srgbClr val="FFFFFF"/>
                 </a:solidFill>
               </a:rPr>
-              <a:t>   腸道微生物，特別是Parasutterella excrementihominis在加重結腸炎和大腸癌中的作用，暗示了針對炎症驅動癌變的潛在治療靶點。</a:t>
+              <a:t>   這些研究突顯了炎症在結直腸癌發生中的關鍵角色，強調需要針對性治療來減輕炎症驅動的癌症進展。</a:t>
             </a:r>
             <a:endParaRPr lang="en-US" sz="1200" dirty="0"/>
           </a:p>
@@ -3708,7 +3792,7 @@
                   <a:srgbClr val="FFFFFF"/>
                 </a:solidFill>
               </a:rPr>
-              <a:t>4. **術後恢復的重要性**  </a:t>
+              <a:t>4. **患者視角的重要性**  </a:t>
             </a:r>
             <a:endParaRPr lang="en-US" sz="1200" dirty="0"/>
           </a:p>
@@ -3725,7 +3809,7 @@
                   <a:srgbClr val="FFFFFF"/>
                 </a:solidFill>
               </a:rPr>
-              <a:t>   Enhanced recovery after surgery pathways significantly improve postoperative gastrointestinal function, emphasizing the importance of postoperative care in colorectal cancer patients.  </a:t>
+              <a:t>   Understanding the long-term consequences of treatments such as pelvic exenteration from the patient's and caregiver's perspectives is essential for improving survivorship care.  </a:t>
             </a:r>
             <a:endParaRPr lang="en-US" sz="1200" dirty="0"/>
           </a:p>
@@ -3742,7 +3826,7 @@
                   <a:srgbClr val="FFFFFF"/>
                 </a:solidFill>
               </a:rPr>
-              <a:t>   手術後恢復途徑顯著改善術後腸道功能，強調了大腸癌患者術後護理的重要性。</a:t>
+              <a:t>   從患者和護理者的角度了解如骨盆切除術等治療的長期後果對改善生存照護至關重要。</a:t>
             </a:r>
             <a:endParaRPr lang="en-US" sz="1200" dirty="0"/>
           </a:p>
@@ -3768,7 +3852,7 @@
                   <a:srgbClr val="FFFFFF"/>
                 </a:solidFill>
               </a:rPr>
-              <a:t>5. **患者與照顧者的經驗**  </a:t>
+              <a:t>5. **微生物組的影響**  </a:t>
             </a:r>
             <a:endParaRPr lang="en-US" sz="1200" dirty="0"/>
           </a:p>
@@ -3785,7 +3869,24 @@
                   <a:srgbClr val="FFFFFF"/>
                 </a:solidFill>
               </a:rPr>
-              <a:t>   Understanding the long-term consequences of pelvic exenteration from the perspectives of patients and caregivers is crucial for improving survivorship care.</a:t>
+              <a:t>   The interaction between genetic variants and the intestinal microbiota, particularly Fusobacterium nucleatum, underscores the complexity of colorectal cancer development and potential therapeutic targets.  </a:t>
+            </a:r>
+            <a:endParaRPr lang="en-US" sz="1200" dirty="0"/>
+          </a:p>
+          <a:p>
+            <a:pPr indent="0" marL="0">
+              <a:lnSpc>
+                <a:spcPct val="150000"/>
+              </a:lnSpc>
+              <a:buNone/>
+            </a:pPr>
+            <a:r>
+              <a:rPr lang="en-US" sz="1200" dirty="0">
+                <a:solidFill>
+                  <a:srgbClr val="FFFFFF"/>
+                </a:solidFill>
+              </a:rPr>
+              <a:t>   基因變異與腸道微生物組之間的相互作用，特別是Fusobacterium nucleatum，突顯了結直腸癌發展的複雜性及潛在的治療靶點。</a:t>
             </a:r>
             <a:endParaRPr lang="en-US" sz="1200" dirty="0"/>
           </a:p>
@@ -3931,7 +4032,7 @@
                   <a:srgbClr val="FFFFFF"/>
                 </a:solidFill>
               </a:rPr>
-              <a:t>從患者和照顧者的角度理解骨盆切除術的長期後果對改善生存照護至關重要。</a:t>
+              <a:t>### 未來研究方向 (Future Research Directions)</a:t>
             </a:r>
             <a:endParaRPr lang="en-US" sz="1200" dirty="0"/>
           </a:p>
@@ -3957,7 +4058,7 @@
                   <a:srgbClr val="FFFFFF"/>
                 </a:solidFill>
               </a:rPr>
-              <a:t>### 未來研究方向 (Future Research Directions)</a:t>
+              <a:t>1. **針對TXNDC5的臨床試驗**  </a:t>
             </a:r>
             <a:endParaRPr lang="en-US" sz="1200" dirty="0"/>
           </a:p>
@@ -3968,6 +4069,14 @@
               </a:lnSpc>
               <a:buNone/>
             </a:pPr>
+            <a:r>
+              <a:rPr lang="en-US" sz="1200" dirty="0">
+                <a:solidFill>
+                  <a:srgbClr val="FFFFFF"/>
+                </a:solidFill>
+              </a:rPr>
+              <a:t>   Future clinical trials should focus on the efficacy of TXNDC5 inhibitors in mesenchymal-type colorectal cancer to validate their therapeutic potential.  </a:t>
+            </a:r>
             <a:endParaRPr lang="en-US" sz="1200" dirty="0"/>
           </a:p>
           <a:p>
@@ -3983,7 +4092,7 @@
                   <a:srgbClr val="FFFFFF"/>
                 </a:solidFill>
               </a:rPr>
-              <a:t>1. **個體化治療策略的開發**  </a:t>
+              <a:t>   未來的臨床試驗應專注於TXNDC5抑制劑在間質型結直腸癌中的療效，以驗證其治療潛力。</a:t>
             </a:r>
             <a:endParaRPr lang="en-US" sz="1200" dirty="0"/>
           </a:p>
@@ -3994,14 +4103,6 @@
               </a:lnSpc>
               <a:buNone/>
             </a:pPr>
-            <a:r>
-              <a:rPr lang="en-US" sz="1200" dirty="0">
-                <a:solidFill>
-                  <a:srgbClr val="FFFFFF"/>
-                </a:solidFill>
-              </a:rPr>
-              <a:t>   Future studies should focus on developing personalized treatment approaches that integrate genetic, microbiome, and immune profiles for colorectal cancer management.  </a:t>
-            </a:r>
             <a:endParaRPr lang="en-US" sz="1200" dirty="0"/>
           </a:p>
           <a:p>
@@ -4017,7 +4118,7 @@
                   <a:srgbClr val="FFFFFF"/>
                 </a:solidFill>
               </a:rPr>
-              <a:t>   未來的研究應著重於開發個體化治療策略，整合基因、微生物組和免疫特徵以管理大腸癌。</a:t>
+              <a:t>2. **炎症指標的應用**  </a:t>
             </a:r>
             <a:endParaRPr lang="en-US" sz="1200" dirty="0"/>
           </a:p>
@@ -4028,6 +4129,14 @@
               </a:lnSpc>
               <a:buNone/>
             </a:pPr>
+            <a:r>
+              <a:rPr lang="en-US" sz="1200" dirty="0">
+                <a:solidFill>
+                  <a:srgbClr val="FFFFFF"/>
+                </a:solidFill>
+              </a:rPr>
+              <a:t>   Further research is needed to explore the application of systemic immune-inflammation index (SII) in diverse patient populations and its impact on treatment outcomes.  </a:t>
+            </a:r>
             <a:endParaRPr lang="en-US" sz="1200" dirty="0"/>
           </a:p>
           <a:p>
@@ -4043,7 +4152,7 @@
                   <a:srgbClr val="FFFFFF"/>
                 </a:solidFill>
               </a:rPr>
-              <a:t>2. **炎症指標的標準化**  </a:t>
+              <a:t>   需要進一步研究系統免疫-炎症指數(SII)在不同患者群體中的應用及其對治療結果的影響。</a:t>
             </a:r>
             <a:endParaRPr lang="en-US" sz="1200" dirty="0"/>
           </a:p>
@@ -4054,14 +4163,6 @@
               </a:lnSpc>
               <a:buNone/>
             </a:pPr>
-            <a:r>
-              <a:rPr lang="en-US" sz="1200" dirty="0">
-                <a:solidFill>
-                  <a:srgbClr val="FFFFFF"/>
-                </a:solidFill>
-              </a:rPr>
-              <a:t>   Research should aim to standardize the use of inflammatory biomarkers like the CALLY index and SII in clinical practice to enhance prognostic accuracy.  </a:t>
-            </a:r>
             <a:endParaRPr lang="en-US" sz="1200" dirty="0"/>
           </a:p>
           <a:p>
@@ -4077,7 +4178,7 @@
                   <a:srgbClr val="FFFFFF"/>
                 </a:solidFill>
               </a:rPr>
-              <a:t>   研究應旨在標準化臨床實踐中使用的炎症生物標記，如CALLY指數和SII，以提高預後準確性。</a:t>
+              <a:t>3. **微生物組與治療反應**  </a:t>
             </a:r>
             <a:endParaRPr lang="en-US" sz="1200" dirty="0"/>
           </a:p>
@@ -4088,6 +4189,14 @@
               </a:lnSpc>
               <a:buNone/>
             </a:pPr>
+            <a:r>
+              <a:rPr lang="en-US" sz="1200" dirty="0">
+                <a:solidFill>
+                  <a:srgbClr val="FFFFFF"/>
+                </a:solidFill>
+              </a:rPr>
+              <a:t>   Investigating the role of gut microbiota in modulating responses to immunotherapy and chemotherapy could reveal new avenues for enhancing treatment efficacy.  </a:t>
+            </a:r>
             <a:endParaRPr lang="en-US" sz="1200" dirty="0"/>
           </a:p>
           <a:p>
@@ -4103,7 +4212,7 @@
                   <a:srgbClr val="FFFFFF"/>
                 </a:solidFill>
               </a:rPr>
-              <a:t>3. **腸道微生物的介入研究**  </a:t>
+              <a:t>   研究腸道微生物組在調節免疫療法和化療反應中的作用，可能會揭示增強治療效果的新途徑。</a:t>
             </a:r>
             <a:endParaRPr lang="en-US" sz="1200" dirty="0"/>
           </a:p>
@@ -4114,14 +4223,6 @@
               </a:lnSpc>
               <a:buNone/>
             </a:pPr>
-            <a:r>
-              <a:rPr lang="en-US" sz="1200" dirty="0">
-                <a:solidFill>
-                  <a:srgbClr val="FFFFFF"/>
-                </a:solidFill>
-              </a:rPr>
-              <a:t>   Investigating the therapeutic potential of modulating gut microbiota in colorectal cancer patients could open new avenues for treatment.  </a:t>
-            </a:r>
             <a:endParaRPr lang="en-US" sz="1200" dirty="0"/>
           </a:p>
           <a:p>
@@ -4137,7 +4238,7 @@
                   <a:srgbClr val="FFFFFF"/>
                 </a:solidFill>
               </a:rPr>
-              <a:t>   探索調節腸道微生物在大腸癌患者中的治療潛力可能為治療開辟新的途徑。</a:t>
+              <a:t>4. **患者經驗的深入研究**  </a:t>
             </a:r>
             <a:endParaRPr lang="en-US" sz="1200" dirty="0"/>
           </a:p>
@@ -4148,6 +4249,14 @@
               </a:lnSpc>
               <a:buNone/>
             </a:pPr>
+            <a:r>
+              <a:rPr lang="en-US" sz="1200" dirty="0">
+                <a:solidFill>
+                  <a:srgbClr val="FFFFFF"/>
+                </a:solidFill>
+              </a:rPr>
+              <a:t>   More qualitative studies are required to capture the lived experiences of patients undergoing major surgical interventions, informing better supportive care strategies.  </a:t>
+            </a:r>
             <a:endParaRPr lang="en-US" sz="1200" dirty="0"/>
           </a:p>
           <a:p>
@@ -4163,7 +4272,7 @@
                   <a:srgbClr val="FFFFFF"/>
                 </a:solidFill>
               </a:rPr>
-              <a:t>4. **術後恢復的最佳化**  </a:t>
+              <a:t>   需要更多質性研究來捕捉接受重大外科手術的患者的生活經驗，以便制定更好的支持性護理策略。</a:t>
             </a:r>
             <a:endParaRPr lang="en-US" sz="1200" dirty="0"/>
           </a:p>
@@ -4174,14 +4283,6 @@
               </a:lnSpc>
               <a:buNone/>
             </a:pPr>
-            <a:r>
-              <a:rPr lang="en-US" sz="1200" dirty="0">
-                <a:solidFill>
-                  <a:srgbClr val="FFFFFF"/>
-                </a:solidFill>
-              </a:rPr>
-              <a:t>   Further research is needed to optimize enhanced recovery protocols post-surgery, focusing on specific interventions that improve gastrointestinal function.  </a:t>
-            </a:r>
             <a:endParaRPr lang="en-US" sz="1200" dirty="0"/>
           </a:p>
           <a:p>
@@ -4197,7 +4298,7 @@
                   <a:srgbClr val="FFFFFF"/>
                 </a:solidFill>
               </a:rPr>
-              <a:t>   需要進一步研究以優化術後恢復方案，專注於改善腸道功能的特定干預措施。</a:t>
+              <a:t>5. **炎症與癌症進展的機制**  </a:t>
             </a:r>
             <a:endParaRPr lang="en-US" sz="1200" dirty="0"/>
           </a:p>
@@ -4208,6 +4309,14 @@
               </a:lnSpc>
               <a:buNone/>
             </a:pPr>
+            <a:r>
+              <a:rPr lang="en-US" sz="1200" dirty="0">
+                <a:solidFill>
+                  <a:srgbClr val="FFFFFF"/>
+                </a:solidFill>
+              </a:rPr>
+              <a:t>   Elucidating the mechanisms by which inflammation contributes to colorectal cancer progression will be crucial for developing targeted anti-inflammatory therapies.  </a:t>
+            </a:r>
             <a:endParaRPr lang="en-US" sz="1200" dirty="0"/>
           </a:p>
           <a:p>
@@ -4223,41 +4332,7 @@
                   <a:srgbClr val="FFFFFF"/>
                 </a:solidFill>
               </a:rPr>
-              <a:t>5. **患者經驗的質性研究**  </a:t>
-            </a:r>
-            <a:endParaRPr lang="en-US" sz="1200" dirty="0"/>
-          </a:p>
-          <a:p>
-            <a:pPr indent="0" marL="0">
-              <a:lnSpc>
-                <a:spcPct val="150000"/>
-              </a:lnSpc>
-              <a:buNone/>
-            </a:pPr>
-            <a:r>
-              <a:rPr lang="en-US" sz="1200" dirty="0">
-                <a:solidFill>
-                  <a:srgbClr val="FFFFFF"/>
-                </a:solidFill>
-              </a:rPr>
-              <a:t>   Qualitative studies exploring the experiences of patients and caregivers post-pelvic exenteration can inform better support systems and survivorship programs.  </a:t>
-            </a:r>
-            <a:endParaRPr lang="en-US" sz="1200" dirty="0"/>
-          </a:p>
-          <a:p>
-            <a:pPr indent="0" marL="0">
-              <a:lnSpc>
-                <a:spcPct val="150000"/>
-              </a:lnSpc>
-              <a:buNone/>
-            </a:pPr>
-            <a:r>
-              <a:rPr lang="en-US" sz="1200" dirty="0">
-                <a:solidFill>
-                  <a:srgbClr val="FFFFFF"/>
-                </a:solidFill>
-              </a:rPr>
-              <a:t>   探索骨盆切除術後患者和照顧者經驗的質性研究可以為更好的支持系統和生存計劃提供信息。</a:t>
+              <a:t>   揭示炎症如何促進結直腸癌進展的機制對於開發針對性抗炎療法至關重要。</a:t>
             </a:r>
             <a:endParaRPr lang="en-US" sz="1200" dirty="0"/>
           </a:p>
@@ -4528,7 +4603,7 @@
                 <a:ea typeface="Arial" pitchFamily="34" charset="-122"/>
                 <a:cs typeface="Arial" pitchFamily="34" charset="-120"/>
               </a:rPr>
-              <a:t>Tumor debulking in combination with chemotherapy in multiorgan metastatic colore…</a:t>
+              <a:t>Targeting fibroblast TXNDC5 resolves tumor desmoplasia and PD-1 resistance in co…</a:t>
             </a:r>
             <a:endParaRPr lang="en-US" sz="1400" dirty="0"/>
           </a:p>
@@ -4602,7 +4677,7 @@
                 <a:ea typeface="Arial" pitchFamily="34" charset="-122"/>
                 <a:cs typeface="Arial" pitchFamily="34" charset="-120"/>
               </a:rPr>
-              <a:t>Mitochondria-Targeting Iridium(III) Complexes Induce PANoptosis and Ferroptosis …</a:t>
+              <a:t>Mucoadhesive patch based on chitosan hydrogel loaded with anticancer agent as th…</a:t>
             </a:r>
             <a:endParaRPr lang="en-US" sz="1400" dirty="0"/>
           </a:p>
@@ -4639,7 +4714,7 @@
                 <a:ea typeface="Arial" pitchFamily="34" charset="-122"/>
                 <a:cs typeface="Arial" pitchFamily="34" charset="-120"/>
               </a:rPr>
-              <a:t>Predictive utility of the C-reactive protein-albumin-lymphocyte (CALLY) index in…</a:t>
+              <a:t>Prognostic value of systemic immune-inflammation index for colorectal cancer: a …</a:t>
             </a:r>
             <a:endParaRPr lang="en-US" sz="1400" dirty="0"/>
           </a:p>
@@ -4676,7 +4751,7 @@
                 <a:ea typeface="Arial" pitchFamily="34" charset="-122"/>
                 <a:cs typeface="Arial" pitchFamily="34" charset="-120"/>
               </a:rPr>
-              <a:t>Prognostic value of systemic immune-inflammation index for colorectal cancer: a …</a:t>
+              <a:t>Consensus Guideline for the Management of Colorectal Cancer with Peritoneal Meta…</a:t>
             </a:r>
             <a:endParaRPr lang="en-US" sz="1400" dirty="0"/>
           </a:p>
@@ -4713,7 +4788,7 @@
                 <a:ea typeface="Arial" pitchFamily="34" charset="-122"/>
                 <a:cs typeface="Arial" pitchFamily="34" charset="-120"/>
               </a:rPr>
-              <a:t>Consensus Guideline for the Management of Colorectal Cancer with Peritoneal Meta…</a:t>
+              <a:t>Awareness of inflammatory bowel disease-associated colorectal cancer risk and it…</a:t>
             </a:r>
             <a:endParaRPr lang="en-US" sz="1400" dirty="0"/>
           </a:p>
@@ -4750,7 +4825,7 @@
                 <a:ea typeface="Arial" pitchFamily="34" charset="-122"/>
                 <a:cs typeface="Arial" pitchFamily="34" charset="-120"/>
               </a:rPr>
-              <a:t>Awareness of inflammatory bowel disease-associated colorectal cancer risk and it…</a:t>
+              <a:t>Life After Pelvic Exenteration for Rectal Cancer: The Patient and Carer Perspect…</a:t>
             </a:r>
             <a:endParaRPr lang="en-US" sz="1400" dirty="0"/>
           </a:p>
@@ -4787,7 +4862,7 @@
                 <a:ea typeface="Arial" pitchFamily="34" charset="-122"/>
                 <a:cs typeface="Arial" pitchFamily="34" charset="-120"/>
               </a:rPr>
-              <a:t>Life After Pelvic Exenteration for Rectal Cancer: The Patient and Carer Perspect…</a:t>
+              <a:t>Colon cancer with a peritumoural abscess: Real-world evidence on prognostic and …</a:t>
             </a:r>
             <a:endParaRPr lang="en-US" sz="1400" dirty="0"/>
           </a:p>
@@ -4824,7 +4899,7 @@
                 <a:ea typeface="Arial" pitchFamily="34" charset="-122"/>
                 <a:cs typeface="Arial" pitchFamily="34" charset="-120"/>
               </a:rPr>
-              <a:t>Enhanced recovery after surgery pathways and postoperative gastrointestinal func…</a:t>
+              <a:t>Genetic variants of the transporter SLC22A4 affect the abundance and survival of…</a:t>
             </a:r>
             <a:endParaRPr lang="en-US" sz="1400" dirty="0"/>
           </a:p>
@@ -5058,7 +5133,7 @@
                 <a:ea typeface="Arial" pitchFamily="34" charset="-122"/>
                 <a:cs typeface="Arial" pitchFamily="34" charset="-120"/>
               </a:rPr>
-              <a:t>Cytoreductive surgery with HIPEC evaluated</a:t>
+              <a:t>Study compares two treatment approaches</a:t>
             </a:r>
             <a:endParaRPr lang="en-US" sz="1800" dirty="0"/>
           </a:p>
@@ -5079,7 +5154,7 @@
                 <a:ea typeface="Arial" pitchFamily="34" charset="-122"/>
                 <a:cs typeface="Arial" pitchFamily="34" charset="-120"/>
               </a:rPr>
-              <a:t>PRODIGE 7 trial design and objectives</a:t>
+              <a:t>Cytoreductive surgery with HIPEC</a:t>
             </a:r>
             <a:endParaRPr lang="en-US" sz="1800" dirty="0"/>
           </a:p>
@@ -5100,7 +5175,49 @@
                 <a:ea typeface="Arial" pitchFamily="34" charset="-122"/>
                 <a:cs typeface="Arial" pitchFamily="34" charset="-120"/>
               </a:rPr>
-              <a:t>Comparison of treatment outcomes reported</a:t>
+              <a:t>Findings show no survival benefit</a:t>
+            </a:r>
+            <a:endParaRPr lang="en-US" sz="1800" dirty="0"/>
+          </a:p>
+          <a:p>
+            <a:pPr marL="342900" indent="-342900">
+              <a:spcAft>
+                <a:spcPts val="800"/>
+              </a:spcAft>
+              <a:buSzPct val="100000"/>
+              <a:buChar char="•"/>
+            </a:pPr>
+            <a:r>
+              <a:rPr lang="en-US" sz="1800" dirty="0">
+                <a:solidFill>
+                  <a:srgbClr val="333333"/>
+                </a:solidFill>
+                <a:latin typeface="Arial" pitchFamily="34" charset="0"/>
+                <a:ea typeface="Arial" pitchFamily="34" charset="-122"/>
+                <a:cs typeface="Arial" pitchFamily="34" charset="-120"/>
+              </a:rPr>
+              <a:t>Focus on metastatic colorectal cancer</a:t>
+            </a:r>
+            <a:endParaRPr lang="en-US" sz="1800" dirty="0"/>
+          </a:p>
+          <a:p>
+            <a:pPr marL="342900" indent="-342900">
+              <a:spcAft>
+                <a:spcPts val="800"/>
+              </a:spcAft>
+              <a:buSzPct val="100000"/>
+              <a:buChar char="•"/>
+            </a:pPr>
+            <a:r>
+              <a:rPr lang="en-US" sz="1800" dirty="0">
+                <a:solidFill>
+                  <a:srgbClr val="333333"/>
+                </a:solidFill>
+                <a:latin typeface="Arial" pitchFamily="34" charset="0"/>
+                <a:ea typeface="Arial" pitchFamily="34" charset="-122"/>
+                <a:cs typeface="Arial" pitchFamily="34" charset="-120"/>
+              </a:rPr>
+              <a:t>Implications for future treatment strategies</a:t>
             </a:r>
             <a:endParaRPr lang="en-US" sz="1800" dirty="0"/>
           </a:p>
@@ -5336,7 +5453,7 @@
                   </a:extLst>
                 </a:hlinkClick>
               </a:rPr>
-              <a:t>Tumor debulking in combination with chemotherapy in multiorgan metastatic colorectal cancer: the ORCHESTRA randomized clinical trial</a:t>
+              <a:t>Targeting fibroblast TXNDC5 resolves tumor desmoplasia and PD-1 resistance in colorectal cancer with mesenchymal traits.</a:t>
             </a:r>
             <a:endParaRPr lang="en-US" sz="2400" dirty="0"/>
           </a:p>
@@ -5372,7 +5489,7 @@
                   <a:srgbClr val="888888"/>
                 </a:solidFill>
               </a:rPr>
-              <a:t>JAMA  ·  IF 63.1</a:t>
+              <a:t>Nature communications  ·  IF 14.7  ·  🌏 Asia</a:t>
             </a:r>
             <a:endParaRPr lang="en-US" sz="1000" dirty="0"/>
           </a:p>
@@ -5415,7 +5532,7 @@
                 <a:ea typeface="Arial" pitchFamily="34" charset="-122"/>
                 <a:cs typeface="Arial" pitchFamily="34" charset="-120"/>
               </a:rPr>
-              <a:t>Study on tumor debulking effectiveness</a:t>
+              <a:t>TXNDC5 regulates immunosuppressive niche</a:t>
             </a:r>
             <a:endParaRPr lang="en-US" sz="1800" dirty="0"/>
           </a:p>
@@ -5436,7 +5553,7 @@
                 <a:ea typeface="Arial" pitchFamily="34" charset="-122"/>
                 <a:cs typeface="Arial" pitchFamily="34" charset="-120"/>
               </a:rPr>
-              <a:t>Combination with chemotherapy evaluated</a:t>
+              <a:t>Enhances TGFβ signaling in fibroblasts</a:t>
             </a:r>
             <a:endParaRPr lang="en-US" sz="1800" dirty="0"/>
           </a:p>
@@ -5457,7 +5574,7 @@
                 <a:ea typeface="Arial" pitchFamily="34" charset="-122"/>
                 <a:cs typeface="Arial" pitchFamily="34" charset="-120"/>
               </a:rPr>
-              <a:t>Focus on multiorgan metastatic colorectal cancer</a:t>
+              <a:t>Fibroblast-specific Txndc5 deletion reduces tumor stiffness</a:t>
             </a:r>
             <a:endParaRPr lang="en-US" sz="1800" dirty="0"/>
           </a:p>
@@ -5478,7 +5595,7 @@
                 <a:ea typeface="Arial" pitchFamily="34" charset="-122"/>
                 <a:cs typeface="Arial" pitchFamily="34" charset="-120"/>
               </a:rPr>
-              <a:t>Results from ORCHESTRA randomized trial</a:t>
+              <a:t>Increases cytotoxic T-cell recruitment</a:t>
             </a:r>
             <a:endParaRPr lang="en-US" sz="1800" dirty="0"/>
           </a:p>
@@ -5499,7 +5616,7 @@
                 <a:ea typeface="Arial" pitchFamily="34" charset="-122"/>
                 <a:cs typeface="Arial" pitchFamily="34" charset="-120"/>
               </a:rPr>
-              <a:t>Subgroup analysis with P &lt; .05</a:t>
+              <a:t>Sensitizes tumors to PD-1 blockade therapy</a:t>
             </a:r>
             <a:endParaRPr lang="en-US" sz="1800" dirty="0"/>
           </a:p>
@@ -5535,7 +5652,7 @@
                   <a:srgbClr val="888888"/>
                 </a:solidFill>
               </a:rPr>
-              <a:t>EC Gootjes, L Bakkerus, AA Adhin. JAMA. 2026</a:t>
+              <a:t>Cheng Kai-Lin, Chen Chih-I, Yu Shu-Han et al.. Nature communications. 2026-06-05 DOI: 10.1038/s41467-026-74073-1</a:t>
             </a:r>
             <a:endParaRPr lang="en-US" sz="800" dirty="0"/>
           </a:p>
@@ -5814,7 +5931,7 @@
                 <a:ea typeface="Arial" pitchFamily="34" charset="-122"/>
                 <a:cs typeface="Arial" pitchFamily="34" charset="-120"/>
               </a:rPr>
-              <a:t>P. excrementihominis worsens colitis severity</a:t>
+              <a:t>P. excrementihominis worsens colitis</a:t>
             </a:r>
             <a:endParaRPr lang="en-US" sz="1800" dirty="0"/>
           </a:p>
@@ -5835,7 +5952,7 @@
                 <a:ea typeface="Arial" pitchFamily="34" charset="-122"/>
                 <a:cs typeface="Arial" pitchFamily="34" charset="-120"/>
               </a:rPr>
-              <a:t>Pathogenic NETosis activation observed</a:t>
+              <a:t>NETosis activation linked to cancer</a:t>
             </a:r>
             <a:endParaRPr lang="en-US" sz="1800" dirty="0"/>
           </a:p>
@@ -5856,49 +5973,7 @@
                 <a:ea typeface="Arial" pitchFamily="34" charset="-122"/>
                 <a:cs typeface="Arial" pitchFamily="34" charset="-120"/>
               </a:rPr>
-              <a:t>Impacts colorectal cancer development</a:t>
-            </a:r>
-            <a:endParaRPr lang="en-US" sz="1800" dirty="0"/>
-          </a:p>
-          <a:p>
-            <a:pPr marL="342900" indent="-342900">
-              <a:spcAft>
-                <a:spcPts val="800"/>
-              </a:spcAft>
-              <a:buSzPct val="100000"/>
-              <a:buChar char="•"/>
-            </a:pPr>
-            <a:r>
-              <a:rPr lang="en-US" sz="1800" dirty="0">
-                <a:solidFill>
-                  <a:srgbClr val="333333"/>
-                </a:solidFill>
-                <a:latin typeface="Arial" pitchFamily="34" charset="0"/>
-                <a:ea typeface="Arial" pitchFamily="34" charset="-122"/>
-                <a:cs typeface="Arial" pitchFamily="34" charset="-120"/>
-              </a:rPr>
-              <a:t>Novel therapeutic strategies suggested</a:t>
-            </a:r>
-            <a:endParaRPr lang="en-US" sz="1800" dirty="0"/>
-          </a:p>
-          <a:p>
-            <a:pPr marL="342900" indent="-342900">
-              <a:spcAft>
-                <a:spcPts val="800"/>
-              </a:spcAft>
-              <a:buSzPct val="100000"/>
-              <a:buChar char="•"/>
-            </a:pPr>
-            <a:r>
-              <a:rPr lang="en-US" sz="1800" dirty="0">
-                <a:solidFill>
-                  <a:srgbClr val="333333"/>
-                </a:solidFill>
-                <a:latin typeface="Arial" pitchFamily="34" charset="0"/>
-                <a:ea typeface="Arial" pitchFamily="34" charset="-122"/>
-                <a:cs typeface="Arial" pitchFamily="34" charset="-120"/>
-              </a:rPr>
-              <a:t>Study focuses on immune responses</a:t>
+              <a:t>Study suggests new treatment strategies</a:t>
             </a:r>
             <a:endParaRPr lang="en-US" sz="1800" dirty="0"/>
           </a:p>
@@ -6134,7 +6209,7 @@
                   </a:extLst>
                 </a:hlinkClick>
               </a:rPr>
-              <a:t>Mitochondria-Targeting Iridium(III) Complexes Induce PANoptosis and Ferroptosis for Boosting Chemoimmunotherapy Against Immune-Desert Colorectal Cancer.</a:t>
+              <a:t>Mucoadhesive patch based on chitosan hydrogel loaded with anticancer agent as the promising nursing care and therapy for digestive tract cancers.</a:t>
             </a:r>
             <a:endParaRPr lang="en-US" sz="2400" dirty="0"/>
           </a:p>
@@ -6170,7 +6245,7 @@
                   <a:srgbClr val="888888"/>
                 </a:solidFill>
               </a:rPr>
-              <a:t>Angewandte Chemie (International ed. in English)  ·  Basic Research  ·  🌏 Asia</a:t>
+              <a:t>Biomedical materials (Bristol, England)  ·  🌏 Asia</a:t>
             </a:r>
             <a:endParaRPr lang="en-US" sz="1000" dirty="0"/>
           </a:p>
@@ -6213,7 +6288,7 @@
                 <a:ea typeface="Arial" pitchFamily="34" charset="-122"/>
                 <a:cs typeface="Arial" pitchFamily="34" charset="-120"/>
               </a:rPr>
-              <a:t>Over 80% of CRC cases are MSS.</a:t>
+              <a:t>Mucoadhesive drug delivery systems enhance drug retention.</a:t>
             </a:r>
             <a:endParaRPr lang="en-US" sz="1800" dirty="0"/>
           </a:p>
@@ -6234,7 +6309,7 @@
                 <a:ea typeface="Arial" pitchFamily="34" charset="-122"/>
                 <a:cs typeface="Arial" pitchFamily="34" charset="-120"/>
               </a:rPr>
-              <a:t>Iridium(III) complexes induce PANoptosis.</a:t>
+              <a:t>Chitosan hydrogels loaded with DOX-PLGA NPs.</a:t>
             </a:r>
             <a:endParaRPr lang="en-US" sz="1800" dirty="0"/>
           </a:p>
@@ -6255,49 +6330,7 @@
                 <a:ea typeface="Arial" pitchFamily="34" charset="-122"/>
                 <a:cs typeface="Arial" pitchFamily="34" charset="-120"/>
               </a:rPr>
-              <a:t>Concurrent ferroptosis enhances immunotherapy.</a:t>
-            </a:r>
-            <a:endParaRPr lang="en-US" sz="1800" dirty="0"/>
-          </a:p>
-          <a:p>
-            <a:pPr marL="342900" indent="-342900">
-              <a:spcAft>
-                <a:spcPts val="800"/>
-              </a:spcAft>
-              <a:buSzPct val="100000"/>
-              <a:buChar char="•"/>
-            </a:pPr>
-            <a:r>
-              <a:rPr lang="en-US" sz="1800" dirty="0">
-                <a:solidFill>
-                  <a:srgbClr val="333333"/>
-                </a:solidFill>
-                <a:latin typeface="Arial" pitchFamily="34" charset="0"/>
-                <a:ea typeface="Arial" pitchFamily="34" charset="-122"/>
-                <a:cs typeface="Arial" pitchFamily="34" charset="-120"/>
-              </a:rPr>
-              <a:t>Mechanism-guided design for mitochondrial targeting.</a:t>
-            </a:r>
-            <a:endParaRPr lang="en-US" sz="1800" dirty="0"/>
-          </a:p>
-          <a:p>
-            <a:pPr marL="342900" indent="-342900">
-              <a:spcAft>
-                <a:spcPts val="800"/>
-              </a:spcAft>
-              <a:buSzPct val="100000"/>
-              <a:buChar char="•"/>
-            </a:pPr>
-            <a:r>
-              <a:rPr lang="en-US" sz="1800" dirty="0">
-                <a:solidFill>
-                  <a:srgbClr val="333333"/>
-                </a:solidFill>
-                <a:latin typeface="Arial" pitchFamily="34" charset="0"/>
-                <a:ea typeface="Arial" pitchFamily="34" charset="-122"/>
-                <a:cs typeface="Arial" pitchFamily="34" charset="-120"/>
-              </a:rPr>
-              <a:t>Proteomic analysis supports therapeutic efficacy.</a:t>
+              <a:t>pH-responsive drug release for targeted therapy.</a:t>
             </a:r>
             <a:endParaRPr lang="en-US" sz="1800" dirty="0"/>
           </a:p>
@@ -6333,7 +6366,7 @@
                   <a:srgbClr val="888888"/>
                 </a:solidFill>
               </a:rPr>
-              <a:t>Liu Xing, Feng Tao, Yang Xiaoting et al.. Angewandte Chemie (International ed. in English). 2026-05-28 DOI: 10.1002/anie.3918717</a:t>
+              <a:t>Meng Wei, Cheng Hui, Cao Yehua. Biomedical materials (Bristol, England). 2026-06-04 DOI: 10.1088/1748-605X/ae6ea8</a:t>
             </a:r>
             <a:endParaRPr lang="en-US" sz="800" dirty="0"/>
           </a:p>
@@ -6533,7 +6566,7 @@
                   </a:extLst>
                 </a:hlinkClick>
               </a:rPr>
-              <a:t>Predictive utility of the C-reactive protein-albumin-lymphocyte (CALLY) index in colorectal cancer: a meta-analysis</a:t>
+              <a:t>Prognostic value of systemic immune-inflammation index for colorectal cancer: a systematic review and meta-analysis</a:t>
             </a:r>
             <a:endParaRPr lang="en-US" sz="2400" dirty="0"/>
           </a:p>
@@ -6569,7 +6602,7 @@
                   <a:srgbClr val="888888"/>
                 </a:solidFill>
               </a:rPr>
-              <a:t>Clinics and Research in Hepatology and …  ·  Meta-Analysis</a:t>
+              <a:t>Frontiers in Oncology  ·  Meta-Analysis</a:t>
             </a:r>
             <a:endParaRPr lang="en-US" sz="1000" dirty="0"/>
           </a:p>
@@ -6612,7 +6645,7 @@
                 <a:ea typeface="Arial" pitchFamily="34" charset="-122"/>
                 <a:cs typeface="Arial" pitchFamily="34" charset="-120"/>
               </a:rPr>
-              <a:t>CALLY index predicts CRC prognosis.</a:t>
+              <a:t>Systemic immune-inflammation index (SII) evaluated</a:t>
             </a:r>
             <a:endParaRPr lang="en-US" sz="1800" dirty="0"/>
           </a:p>
@@ -6633,7 +6666,7 @@
                 <a:ea typeface="Arial" pitchFamily="34" charset="-122"/>
                 <a:cs typeface="Arial" pitchFamily="34" charset="-120"/>
               </a:rPr>
-              <a:t>Meta-analysis of multiple studies conducted.</a:t>
+              <a:t>Prognostic biomarker for colorectal cancer</a:t>
             </a:r>
             <a:endParaRPr lang="en-US" sz="1800" dirty="0"/>
           </a:p>
@@ -6654,7 +6687,49 @@
                 <a:ea typeface="Arial" pitchFamily="34" charset="-122"/>
                 <a:cs typeface="Arial" pitchFamily="34" charset="-120"/>
               </a:rPr>
-              <a:t>Inconsistency in previous findings addressed.</a:t>
+              <a:t>Systematic review and meta-analysis conducted</a:t>
+            </a:r>
+            <a:endParaRPr lang="en-US" sz="1800" dirty="0"/>
+          </a:p>
+          <a:p>
+            <a:pPr marL="342900" indent="-342900">
+              <a:spcAft>
+                <a:spcPts val="800"/>
+              </a:spcAft>
+              <a:buSzPct val="100000"/>
+              <a:buChar char="•"/>
+            </a:pPr>
+            <a:r>
+              <a:rPr lang="en-US" sz="1800" dirty="0">
+                <a:solidFill>
+                  <a:srgbClr val="333333"/>
+                </a:solidFill>
+                <a:latin typeface="Arial" pitchFamily="34" charset="0"/>
+                <a:ea typeface="Arial" pitchFamily="34" charset="-122"/>
+                <a:cs typeface="Arial" pitchFamily="34" charset="-120"/>
+              </a:rPr>
+              <a:t>SII correlates with patient outcomes</a:t>
+            </a:r>
+            <a:endParaRPr lang="en-US" sz="1800" dirty="0"/>
+          </a:p>
+          <a:p>
+            <a:pPr marL="342900" indent="-342900">
+              <a:spcAft>
+                <a:spcPts val="800"/>
+              </a:spcAft>
+              <a:buSzPct val="100000"/>
+              <a:buChar char="•"/>
+            </a:pPr>
+            <a:r>
+              <a:rPr lang="en-US" sz="1800" dirty="0">
+                <a:solidFill>
+                  <a:srgbClr val="333333"/>
+                </a:solidFill>
+                <a:latin typeface="Arial" pitchFamily="34" charset="0"/>
+                <a:ea typeface="Arial" pitchFamily="34" charset="-122"/>
+                <a:cs typeface="Arial" pitchFamily="34" charset="-120"/>
+              </a:rPr>
+              <a:t>Potential for clinical application in CRC</a:t>
             </a:r>
             <a:endParaRPr lang="en-US" sz="1800" dirty="0"/>
           </a:p>
@@ -6690,7 +6765,7 @@
                   <a:srgbClr val="888888"/>
                 </a:solidFill>
               </a:rPr>
-              <a:t>X Li, T Chu, W Chen. Clinics and Research in Hepatology and …. 2026</a:t>
+              <a:t>P Wang, H Jiang. Frontiers in Oncology. 2026</a:t>
             </a:r>
             <a:endParaRPr lang="en-US" sz="800" dirty="0"/>
           </a:p>
@@ -6890,7 +6965,7 @@
                   </a:extLst>
                 </a:hlinkClick>
               </a:rPr>
-              <a:t>Prognostic value of systemic immune-inflammation index for colorectal cancer: a systematic review and meta-analysis</a:t>
+              <a:t>Consensus Guideline for the Management of Colorectal Cancer with Peritoneal Metastases.</a:t>
             </a:r>
             <a:endParaRPr lang="en-US" sz="2400" dirty="0"/>
           </a:p>
@@ -6926,7 +7001,7 @@
                   <a:srgbClr val="888888"/>
                 </a:solidFill>
               </a:rPr>
-              <a:t>Frontiers in Oncology  ·  Meta-Analysis</a:t>
+              <a:t>Annals of surgical oncology  ·  IF 3.8  ·  Prospective Study</a:t>
             </a:r>
             <a:endParaRPr lang="en-US" sz="1000" dirty="0"/>
           </a:p>
@@ -6969,7 +7044,7 @@
                 <a:ea typeface="Arial" pitchFamily="34" charset="-122"/>
                 <a:cs typeface="Arial" pitchFamily="34" charset="-120"/>
               </a:rPr>
-              <a:t>Systemic immune-inflammation index (SII) evaluated</a:t>
+              <a:t>Peritoneum common site for CRC metastases.</a:t>
             </a:r>
             <a:endParaRPr lang="en-US" sz="1800" dirty="0"/>
           </a:p>
@@ -6990,7 +7065,7 @@
                 <a:ea typeface="Arial" pitchFamily="34" charset="-122"/>
                 <a:cs typeface="Arial" pitchFamily="34" charset="-120"/>
               </a:rPr>
-              <a:t>SII as a prognostic biomarker in CRC</a:t>
+              <a:t>Updated 2018 Chicago Consensus Guidelines.</a:t>
             </a:r>
             <a:endParaRPr lang="en-US" sz="1800" dirty="0"/>
           </a:p>
@@ -7011,7 +7086,7 @@
                 <a:ea typeface="Arial" pitchFamily="34" charset="-122"/>
                 <a:cs typeface="Arial" pitchFamily="34" charset="-120"/>
               </a:rPr>
-              <a:t>Meta-analysis of existing studies conducted</a:t>
+              <a:t>High consensus on management pathways.</a:t>
             </a:r>
             <a:endParaRPr lang="en-US" sz="1800" dirty="0"/>
           </a:p>
@@ -7032,7 +7107,7 @@
                 <a:ea typeface="Arial" pitchFamily="34" charset="-122"/>
                 <a:cs typeface="Arial" pitchFamily="34" charset="-120"/>
               </a:rPr>
-              <a:t>SII correlates with patient outcomes</a:t>
+              <a:t>Early referral to PSM centers recommended.</a:t>
             </a:r>
             <a:endParaRPr lang="en-US" sz="1800" dirty="0"/>
           </a:p>
@@ -7053,7 +7128,7 @@
                 <a:ea typeface="Arial" pitchFamily="34" charset="-122"/>
                 <a:cs typeface="Arial" pitchFamily="34" charset="-120"/>
               </a:rPr>
-              <a:t>Potential for clinical application in CRC</a:t>
+              <a:t>Weak recommendation for ctDNA testing.</a:t>
             </a:r>
             <a:endParaRPr lang="en-US" sz="1800" dirty="0"/>
           </a:p>
@@ -7089,7 +7164,7 @@
                   <a:srgbClr val="888888"/>
                 </a:solidFill>
               </a:rPr>
-              <a:t>P Wang, H Jiang. Frontiers in Oncology. 2026</a:t>
+              <a:t>Schultz Kurt S, Bansal Varun V, Wach Michael M et al.. Annals of surgical oncology. 2026-05-19 DOI: 10.1245/s10434-025-17363-0</a:t>
             </a:r>
             <a:endParaRPr lang="en-US" sz="800" dirty="0"/>
           </a:p>
@@ -7289,7 +7364,7 @@
                   </a:extLst>
                 </a:hlinkClick>
               </a:rPr>
-              <a:t>Consensus Guideline for the Management of Colorectal Cancer with Peritoneal Metastases.</a:t>
+              <a:t>Awareness of inflammatory bowel disease-associated colorectal cancer risk and its management in patients with inflammatory bowel disease: a systematic review</a:t>
             </a:r>
             <a:endParaRPr lang="en-US" sz="2400" dirty="0"/>
           </a:p>
@@ -7325,7 +7400,7 @@
                   <a:srgbClr val="888888"/>
                 </a:solidFill>
               </a:rPr>
-              <a:t>Annals of surgical oncology  ·  IF 3.8  ·  Prospective Study</a:t>
+              <a:t>Crohns &amp; Colitis 360  ·  Systematic Review</a:t>
             </a:r>
             <a:endParaRPr lang="en-US" sz="1000" dirty="0"/>
           </a:p>
@@ -7368,7 +7443,7 @@
                 <a:ea typeface="Arial" pitchFamily="34" charset="-122"/>
                 <a:cs typeface="Arial" pitchFamily="34" charset="-120"/>
               </a:rPr>
-              <a:t>Peritoneum common site for CRC metastases.</a:t>
+              <a:t>Limited knowledge on colorectal cancer risk</a:t>
             </a:r>
             <a:endParaRPr lang="en-US" sz="1800" dirty="0"/>
           </a:p>
@@ -7389,7 +7464,7 @@
                 <a:ea typeface="Arial" pitchFamily="34" charset="-122"/>
                 <a:cs typeface="Arial" pitchFamily="34" charset="-120"/>
               </a:rPr>
-              <a:t>Updated 2018 Chicago Consensus Guidelines.</a:t>
+              <a:t>Need for better patient education strategies</a:t>
             </a:r>
             <a:endParaRPr lang="en-US" sz="1800" dirty="0"/>
           </a:p>
@@ -7410,49 +7485,7 @@
                 <a:ea typeface="Arial" pitchFamily="34" charset="-122"/>
                 <a:cs typeface="Arial" pitchFamily="34" charset="-120"/>
               </a:rPr>
-              <a:t>Over 90% consensus on management pathways.</a:t>
-            </a:r>
-            <a:endParaRPr lang="en-US" sz="1800" dirty="0"/>
-          </a:p>
-          <a:p>
-            <a:pPr marL="342900" indent="-342900">
-              <a:spcAft>
-                <a:spcPts val="800"/>
-              </a:spcAft>
-              <a:buSzPct val="100000"/>
-              <a:buChar char="•"/>
-            </a:pPr>
-            <a:r>
-              <a:rPr lang="en-US" sz="1800" dirty="0">
-                <a:solidFill>
-                  <a:srgbClr val="333333"/>
-                </a:solidFill>
-                <a:latin typeface="Arial" pitchFamily="34" charset="0"/>
-                <a:ea typeface="Arial" pitchFamily="34" charset="-122"/>
-                <a:cs typeface="Arial" pitchFamily="34" charset="-120"/>
-              </a:rPr>
-              <a:t>Early referral to PSM centers recommended.</a:t>
-            </a:r>
-            <a:endParaRPr lang="en-US" sz="1800" dirty="0"/>
-          </a:p>
-          <a:p>
-            <a:pPr marL="342900" indent="-342900">
-              <a:spcAft>
-                <a:spcPts val="800"/>
-              </a:spcAft>
-              <a:buSzPct val="100000"/>
-              <a:buChar char="•"/>
-            </a:pPr>
-            <a:r>
-              <a:rPr lang="en-US" sz="1800" dirty="0">
-                <a:solidFill>
-                  <a:srgbClr val="333333"/>
-                </a:solidFill>
-                <a:latin typeface="Arial" pitchFamily="34" charset="0"/>
-                <a:ea typeface="Arial" pitchFamily="34" charset="-122"/>
-                <a:cs typeface="Arial" pitchFamily="34" charset="-120"/>
-              </a:rPr>
-              <a:t>Limited evidence for ctDNA testing utility.</a:t>
+              <a:t>Importance of regular screening in IBD patients</a:t>
             </a:r>
             <a:endParaRPr lang="en-US" sz="1800" dirty="0"/>
           </a:p>
@@ -7488,7 +7521,7 @@
                   <a:srgbClr val="888888"/>
                 </a:solidFill>
               </a:rPr>
-              <a:t>Schultz Kurt S, Bansal Varun V, Wach Michael M et al.. Annals of surgical oncology. 2026-05-19 DOI: 10.1245/s10434-025-17363-0</a:t>
+              <a:t>F Khan, C Norton, W Czuber-Dochan. Crohns &amp; Colitis 360. 2026</a:t>
             </a:r>
             <a:endParaRPr lang="en-US" sz="800" dirty="0"/>
           </a:p>

</xml_diff>

<commit_message>
chore: update weekly digest 2026-06-15
</commit_message>
<xml_diff>
--- a/docs/digest-en.pptx
+++ b/docs/digest-en.pptx
@@ -2249,7 +2249,7 @@
                   <a:srgbClr val="888888"/>
                 </a:solidFill>
               </a:rPr>
-              <a:t>2026-06-01 — 2026-06-08</a:t>
+              <a:t>2026-06-08 — 2026-06-15</a:t>
             </a:r>
             <a:endParaRPr lang="en-US" sz="1400" dirty="0"/>
           </a:p>
@@ -2440,7 +2440,7 @@
                   </a:extLst>
                 </a:hlinkClick>
               </a:rPr>
-              <a:t>Life After Pelvic Exenteration for Rectal Cancer: The Patient and Carer Perspective on Long-term Consequences and Survivorship.</a:t>
+              <a:t>Efavirenz Mitigates Dyslipidemia and Attenuates Ulcerative Colitis through Gut Microbiota Modulation.</a:t>
             </a:r>
             <a:endParaRPr lang="en-US" sz="2400" dirty="0"/>
           </a:p>
@@ -2476,7 +2476,7 @@
                   <a:srgbClr val="888888"/>
                 </a:solidFill>
               </a:rPr>
-              <a:t>Annals of surgery  ·  IF 9.4</a:t>
+              <a:t>ACS infectious diseases  ·  Basic Research</a:t>
             </a:r>
             <a:endParaRPr lang="en-US" sz="1000" dirty="0"/>
           </a:p>
@@ -2519,7 +2519,7 @@
                 <a:ea typeface="Arial" pitchFamily="34" charset="-122"/>
                 <a:cs typeface="Arial" pitchFamily="34" charset="-120"/>
               </a:rPr>
-              <a:t>Pelvic exenteration for rectal cancer is standard care.</a:t>
+              <a:t>Efavirenz mitigates ART-induced dyslipidemia.</a:t>
             </a:r>
             <a:endParaRPr lang="en-US" sz="1800" dirty="0"/>
           </a:p>
@@ -2540,7 +2540,7 @@
                 <a:ea typeface="Arial" pitchFamily="34" charset="-122"/>
                 <a:cs typeface="Arial" pitchFamily="34" charset="-120"/>
               </a:rPr>
-              <a:t>Long-term survivors face significant challenges.</a:t>
+              <a:t>Improves ulcerative colitis symptoms in models.</a:t>
             </a:r>
             <a:endParaRPr lang="en-US" sz="1800" dirty="0"/>
           </a:p>
@@ -2561,7 +2561,7 @@
                 <a:ea typeface="Arial" pitchFamily="34" charset="-122"/>
                 <a:cs typeface="Arial" pitchFamily="34" charset="-120"/>
               </a:rPr>
-              <a:t>Participants accepted surgery consequences for survival.</a:t>
+              <a:t>Regulates gut microbiota and lipid metabolism.</a:t>
             </a:r>
             <a:endParaRPr lang="en-US" sz="1800" dirty="0"/>
           </a:p>
@@ -2597,7 +2597,7 @@
                   <a:srgbClr val="888888"/>
                 </a:solidFill>
               </a:rPr>
-              <a:t>Brown Kilian G M, White Kate, Solomon Michael J et al.. Annals of surgery. 2026-05-12 DOI: 10.1097/SLA.0000000000006625</a:t>
+              <a:t>Wang Wei, Niu Xiaoge, Li Shasha et al.. ACS infectious diseases. 2026-06-12 DOI: 10.1021/acsinfecdis.6c00330</a:t>
             </a:r>
             <a:endParaRPr lang="en-US" sz="800" dirty="0"/>
           </a:p>
@@ -2797,7 +2797,7 @@
                   </a:extLst>
                 </a:hlinkClick>
               </a:rPr>
-              <a:t>Colon cancer with a peritumoural abscess: Real-world evidence on prognostic and therapeutic implications of a disregarded entity.</a:t>
+              <a:t>Oxaliplatin triggers adipose and muscle wasting through cancer-independent metabolic and CNS pathways in mouse models.</a:t>
             </a:r>
             <a:endParaRPr lang="en-US" sz="2400" dirty="0"/>
           </a:p>
@@ -2833,7 +2833,7 @@
                   <a:srgbClr val="888888"/>
                 </a:solidFill>
               </a:rPr>
-              <a:t>European journal of cancer (Oxford, England : 1990)  ·  IF 8.4</a:t>
+              <a:t>Communications biology  ·  Basic Research</a:t>
             </a:r>
             <a:endParaRPr lang="en-US" sz="1000" dirty="0"/>
           </a:p>
@@ -2876,7 +2876,7 @@
                 <a:ea typeface="Arial" pitchFamily="34" charset="-122"/>
                 <a:cs typeface="Arial" pitchFamily="34" charset="-120"/>
               </a:rPr>
-              <a:t>CCPA diagnosed in 2.7% of patients</a:t>
+              <a:t>Oxaliplatin induces cachexia-like symptoms in mice.</a:t>
             </a:r>
             <a:endParaRPr lang="en-US" sz="1800" dirty="0"/>
           </a:p>
@@ -2897,7 +2897,7 @@
                 <a:ea typeface="Arial" pitchFamily="34" charset="-122"/>
                 <a:cs typeface="Arial" pitchFamily="34" charset="-120"/>
               </a:rPr>
-              <a:t>Higher locoregional recurrence rate observed</a:t>
+              <a:t>Body mass loss from adipose and muscle wasting.</a:t>
             </a:r>
             <a:endParaRPr lang="en-US" sz="1800" dirty="0"/>
           </a:p>
@@ -2918,7 +2918,7 @@
                 <a:ea typeface="Arial" pitchFamily="34" charset="-122"/>
                 <a:cs typeface="Arial" pitchFamily="34" charset="-120"/>
               </a:rPr>
-              <a:t>BTS approach had highest complications</a:t>
+              <a:t>Altered metabolism: decreased intake and activity.</a:t>
             </a:r>
             <a:endParaRPr lang="en-US" sz="1800" dirty="0"/>
           </a:p>
@@ -2939,7 +2939,7 @@
                 <a:ea typeface="Arial" pitchFamily="34" charset="-122"/>
                 <a:cs typeface="Arial" pitchFamily="34" charset="-120"/>
               </a:rPr>
-              <a:t>Acute resection linked to peritoneal metastases</a:t>
+              <a:t>Histological changes: muscle atrophy and immune infiltration.</a:t>
             </a:r>
             <a:endParaRPr lang="en-US" sz="1800" dirty="0"/>
           </a:p>
@@ -2960,7 +2960,7 @@
                 <a:ea typeface="Arial" pitchFamily="34" charset="-122"/>
                 <a:cs typeface="Arial" pitchFamily="34" charset="-120"/>
               </a:rPr>
-              <a:t>Future studies needed for treatment optimization</a:t>
+              <a:t>Metabolic rewiring identified in adipose and muscle.</a:t>
             </a:r>
             <a:endParaRPr lang="en-US" sz="1800" dirty="0"/>
           </a:p>
@@ -2996,7 +2996,7 @@
                   <a:srgbClr val="888888"/>
                 </a:solidFill>
               </a:rPr>
-              <a:t>Rademaker Eva, van der Woude Jannes M, van den Berg Rudolf et al.. European journal of cancer (Oxford, England : 1990). 2026-05-21 DOI: 10.1016/j.ejca.2026.116705</a:t>
+              <a:t>Du Junwei, Mintz Rachel L, Sudlow Leland C et al.. Communications biology. 2026-06-10 DOI: 10.1038/s42003-026-10441-3</a:t>
             </a:r>
             <a:endParaRPr lang="en-US" sz="800" dirty="0"/>
           </a:p>
@@ -3196,7 +3196,7 @@
                   </a:extLst>
                 </a:hlinkClick>
               </a:rPr>
-              <a:t>Genetic variants of the transporter SLC22A4 affect the abundance and survival of Fusobacterium nucleatum in colorectal cancer.</a:t>
+              <a:t>Loss of proton-sensing TDAG8 increases tumor progression in mouse models of colon cancer.</a:t>
             </a:r>
             <a:endParaRPr lang="en-US" sz="2400" dirty="0"/>
           </a:p>
@@ -3232,7 +3232,7 @@
                   <a:srgbClr val="888888"/>
                 </a:solidFill>
               </a:rPr>
-              <a:t>Gut microbes  ·  Basic Research</a:t>
+              <a:t>Molecular oncology  ·  Basic Research</a:t>
             </a:r>
             <a:endParaRPr lang="en-US" sz="1000" dirty="0"/>
           </a:p>
@@ -3275,7 +3275,7 @@
                 <a:ea typeface="Arial" pitchFamily="34" charset="-122"/>
                 <a:cs typeface="Arial" pitchFamily="34" charset="-120"/>
               </a:rPr>
-              <a:t>SLC22A4 variants influence F. nucleatum levels.</a:t>
+              <a:t>TDAG8 loss increases tumor progression.</a:t>
             </a:r>
             <a:endParaRPr lang="en-US" sz="1800" dirty="0"/>
           </a:p>
@@ -3296,7 +3296,7 @@
                 <a:ea typeface="Arial" pitchFamily="34" charset="-122"/>
                 <a:cs typeface="Arial" pitchFamily="34" charset="-120"/>
               </a:rPr>
-              <a:t>Higher F. nucleatum/E. coli ratio in tumors.</a:t>
+              <a:t>Increased neutrophils and monocytes in tumors.</a:t>
             </a:r>
             <a:endParaRPr lang="en-US" sz="1800" dirty="0"/>
           </a:p>
@@ -3317,7 +3317,7 @@
                 <a:ea typeface="Arial" pitchFamily="34" charset="-122"/>
                 <a:cs typeface="Arial" pitchFamily="34" charset="-120"/>
               </a:rPr>
-              <a:t>503F variant affects inflammatory response.</a:t>
+              <a:t>AOM/DSS model shows larger tumor size.</a:t>
             </a:r>
             <a:endParaRPr lang="en-US" sz="1800" dirty="0"/>
           </a:p>
@@ -3338,7 +3338,7 @@
                 <a:ea typeface="Arial" pitchFamily="34" charset="-122"/>
                 <a:cs typeface="Arial" pitchFamily="34" charset="-120"/>
               </a:rPr>
-              <a:t>Genetic factors shape tumor microbiota.</a:t>
+              <a:t>Elevated macrophages and CD4+/CD8+ ratio.</a:t>
             </a:r>
             <a:endParaRPr lang="en-US" sz="1800" dirty="0"/>
           </a:p>
@@ -3359,7 +3359,7 @@
                 <a:ea typeface="Arial" pitchFamily="34" charset="-122"/>
                 <a:cs typeface="Arial" pitchFamily="34" charset="-120"/>
               </a:rPr>
-              <a:t>Innate immunity dampened in cancer cells.</a:t>
+              <a:t>TDAG8 modulators may aid CRC therapy.</a:t>
             </a:r>
             <a:endParaRPr lang="en-US" sz="1800" dirty="0"/>
           </a:p>
@@ -3395,7 +3395,7 @@
                   <a:srgbClr val="888888"/>
                 </a:solidFill>
               </a:rPr>
-              <a:t>Chouaibi Samah, Fertitta Veronica, Porreca Silvia et al.. Gut microbes. 2026-06-05 DOI: 10.1080/19490976.2026.2681818</a:t>
+              <a:t>Malagola Ermanno, Illi Yasmine, Bircher Anna et al.. Molecular oncology. 2026-06-10 DOI: 10.1002/1878-0261.70283</a:t>
             </a:r>
             <a:endParaRPr lang="en-US" sz="800" dirty="0"/>
           </a:p>
@@ -3612,7 +3612,7 @@
                   <a:srgbClr val="FFFFFF"/>
                 </a:solidFill>
               </a:rPr>
-              <a:t>1. **新療法的潛力**  </a:t>
+              <a:t>1. **腫瘤微環境的角色**  </a:t>
             </a:r>
             <a:endParaRPr lang="en-US" sz="1200" dirty="0"/>
           </a:p>
@@ -3629,7 +3629,7 @@
                   <a:srgbClr val="FFFFFF"/>
                 </a:solidFill>
               </a:rPr>
-              <a:t>   The integration of novel therapeutic strategies, such as targeting TXNDC5 and utilizing mucoadhesive drug delivery systems, shows promise in overcoming treatment resistance in colorectal cancer.  </a:t>
+              <a:t>   The studies highlight the significant influence of the tumor microenvironment on colorectal cancer progression and treatment responses.  </a:t>
             </a:r>
             <a:endParaRPr lang="en-US" sz="1200" dirty="0"/>
           </a:p>
@@ -3646,7 +3646,7 @@
                   <a:srgbClr val="FFFFFF"/>
                 </a:solidFill>
               </a:rPr>
-              <a:t>   新的治療策略，如針對TXNDC5和使用黏附性藥物傳遞系統，顯示出克服結直腸癌治療抵抗的潛力。</a:t>
+              <a:t>   這些研究強調腫瘤微環境對結直腸癌進展和治療反應的重要影響。</a:t>
             </a:r>
             <a:endParaRPr lang="en-US" sz="1200" dirty="0"/>
           </a:p>
@@ -3672,7 +3672,7 @@
                   <a:srgbClr val="FFFFFF"/>
                 </a:solidFill>
               </a:rPr>
-              <a:t>2. **預後指標的價值**  </a:t>
+              <a:t>2. **免疫系統的預後指標**  </a:t>
             </a:r>
             <a:endParaRPr lang="en-US" sz="1200" dirty="0"/>
           </a:p>
@@ -3689,7 +3689,7 @@
                   <a:srgbClr val="FFFFFF"/>
                 </a:solidFill>
               </a:rPr>
-              <a:t>   The systemic immune-inflammation index (SII) has emerged as a significant prognostic biomarker, potentially guiding treatment decisions in colorectal cancer management.  </a:t>
+              <a:t>   The systemic immune-inflammation index (SII) emerges as a promising prognostic biomarker, indicating the interplay between systemic inflammation and cancer outcomes.  </a:t>
             </a:r>
             <a:endParaRPr lang="en-US" sz="1200" dirty="0"/>
           </a:p>
@@ -3706,7 +3706,7 @@
                   <a:srgbClr val="FFFFFF"/>
                 </a:solidFill>
               </a:rPr>
-              <a:t>   系統免疫-炎症指數(SII)已成為重要的預後生物標誌物，可能指導結直腸癌的治療決策。</a:t>
+              <a:t>   系統性免疫炎症指數（SII）作為一個有前途的預後生物標記，顯示系統性炎症與癌症結果之間的相互作用。</a:t>
             </a:r>
             <a:endParaRPr lang="en-US" sz="1200" dirty="0"/>
           </a:p>
@@ -3732,7 +3732,7 @@
                   <a:srgbClr val="FFFFFF"/>
                 </a:solidFill>
               </a:rPr>
-              <a:t>3. **炎症與癌症的關聯**  </a:t>
+              <a:t>3. **益生菌與腸道健康**  </a:t>
             </a:r>
             <a:endParaRPr lang="en-US" sz="1200" dirty="0"/>
           </a:p>
@@ -3749,7 +3749,7 @@
                   <a:srgbClr val="FFFFFF"/>
                 </a:solidFill>
               </a:rPr>
-              <a:t>   The studies highlight the critical role of inflammation in colorectal carcinogenesis, emphasizing the need for targeted therapies to mitigate inflammation-driven cancer progression.  </a:t>
+              <a:t>   The role of gut microbiota, particularly specific strains like Parasutterella excrementihominis, is crucial in modulating inflammation and cancer risk.  </a:t>
             </a:r>
             <a:endParaRPr lang="en-US" sz="1200" dirty="0"/>
           </a:p>
@@ -3766,7 +3766,7 @@
                   <a:srgbClr val="FFFFFF"/>
                 </a:solidFill>
               </a:rPr>
-              <a:t>   這些研究突顯了炎症在結直腸癌發生中的關鍵角色，強調需要針對性治療來減輕炎症驅動的癌症進展。</a:t>
+              <a:t>   腸道微生物群的角色，特別是像Parasutterella excrementihominis這樣的特定菌株，在調節炎症和癌症風險中至關重要。</a:t>
             </a:r>
             <a:endParaRPr lang="en-US" sz="1200" dirty="0"/>
           </a:p>
@@ -3792,7 +3792,7 @@
                   <a:srgbClr val="FFFFFF"/>
                 </a:solidFill>
               </a:rPr>
-              <a:t>4. **患者視角的重要性**  </a:t>
+              <a:t>4. **術後恢復的營養補充**  </a:t>
             </a:r>
             <a:endParaRPr lang="en-US" sz="1200" dirty="0"/>
           </a:p>
@@ -3809,7 +3809,7 @@
                   <a:srgbClr val="FFFFFF"/>
                 </a:solidFill>
               </a:rPr>
-              <a:t>   Understanding the long-term consequences of treatments such as pelvic exenteration from the patient's and caregiver's perspectives is essential for improving survivorship care.  </a:t>
+              <a:t>   Omega-3 polyunsaturated fatty acids (PUFAs) show potential in enhancing postoperative recovery, suggesting nutritional interventions may improve patient outcomes.  </a:t>
             </a:r>
             <a:endParaRPr lang="en-US" sz="1200" dirty="0"/>
           </a:p>
@@ -3826,7 +3826,7 @@
                   <a:srgbClr val="FFFFFF"/>
                 </a:solidFill>
               </a:rPr>
-              <a:t>   從患者和護理者的角度了解如骨盆切除術等治療的長期後果對改善生存照護至關重要。</a:t>
+              <a:t>   Omega-3多不飽和脂肪酸（PUFAs）在增強術後恢復方面顯示出潛力，暗示營養干預可能改善患者結果。</a:t>
             </a:r>
             <a:endParaRPr lang="en-US" sz="1200" dirty="0"/>
           </a:p>
@@ -3852,7 +3852,7 @@
                   <a:srgbClr val="FFFFFF"/>
                 </a:solidFill>
               </a:rPr>
-              <a:t>5. **微生物組的影響**  </a:t>
+              <a:t>5. **炎症性腸病的癌症風險認知**  </a:t>
             </a:r>
             <a:endParaRPr lang="en-US" sz="1200" dirty="0"/>
           </a:p>
@@ -3869,7 +3869,7 @@
                   <a:srgbClr val="FFFFFF"/>
                 </a:solidFill>
               </a:rPr>
-              <a:t>   The interaction between genetic variants and the intestinal microbiota, particularly Fusobacterium nucleatum, underscores the complexity of colorectal cancer development and potential therapeutic targets.  </a:t>
+              <a:t>   There is a critical gap in awareness regarding the colorectal cancer risk among patients with inflammatory bowel disease, necessitating further educational initiatives.  </a:t>
             </a:r>
             <a:endParaRPr lang="en-US" sz="1200" dirty="0"/>
           </a:p>
@@ -3886,7 +3886,7 @@
                   <a:srgbClr val="FFFFFF"/>
                 </a:solidFill>
               </a:rPr>
-              <a:t>   基因變異與腸道微生物組之間的相互作用，特別是Fusobacterium nucleatum，突顯了結直腸癌發展的複雜性及潛在的治療靶點。</a:t>
+              <a:t>   在炎症性腸病患者中，對結直腸癌風險的認知存在重要差距，迫切需要進一步的教育措施。</a:t>
             </a:r>
             <a:endParaRPr lang="en-US" sz="1200" dirty="0"/>
           </a:p>
@@ -4058,7 +4058,7 @@
                   <a:srgbClr val="FFFFFF"/>
                 </a:solidFill>
               </a:rPr>
-              <a:t>1. **針對TXNDC5的臨床試驗**  </a:t>
+              <a:t>1. **腫瘤微環境的干預策略**  </a:t>
             </a:r>
             <a:endParaRPr lang="en-US" sz="1200" dirty="0"/>
           </a:p>
@@ -4075,7 +4075,7 @@
                   <a:srgbClr val="FFFFFF"/>
                 </a:solidFill>
               </a:rPr>
-              <a:t>   Future clinical trials should focus on the efficacy of TXNDC5 inhibitors in mesenchymal-type colorectal cancer to validate their therapeutic potential.  </a:t>
+              <a:t>   Future studies should explore therapeutic strategies targeting the tumor microenvironment to enhance treatment efficacy in colorectal cancer.  </a:t>
             </a:r>
             <a:endParaRPr lang="en-US" sz="1200" dirty="0"/>
           </a:p>
@@ -4092,7 +4092,7 @@
                   <a:srgbClr val="FFFFFF"/>
                 </a:solidFill>
               </a:rPr>
-              <a:t>   未來的臨床試驗應專注於TXNDC5抑制劑在間質型結直腸癌中的療效，以驗證其治療潛力。</a:t>
+              <a:t>   未來研究應探索針對腫瘤微環境的治療策略，以提高結直腸癌的治療效果。</a:t>
             </a:r>
             <a:endParaRPr lang="en-US" sz="1200" dirty="0"/>
           </a:p>
@@ -4118,7 +4118,7 @@
                   <a:srgbClr val="FFFFFF"/>
                 </a:solidFill>
               </a:rPr>
-              <a:t>2. **炎症指標的應用**  </a:t>
+              <a:t>2. **免疫炎症指數的應用**  </a:t>
             </a:r>
             <a:endParaRPr lang="en-US" sz="1200" dirty="0"/>
           </a:p>
@@ -4135,7 +4135,7 @@
                   <a:srgbClr val="FFFFFF"/>
                 </a:solidFill>
               </a:rPr>
-              <a:t>   Further research is needed to explore the application of systemic immune-inflammation index (SII) in diverse patient populations and its impact on treatment outcomes.  </a:t>
+              <a:t>   Investigating the clinical utility of the systemic immune-inflammation index (SII) in diverse patient populations could refine prognostic assessments.  </a:t>
             </a:r>
             <a:endParaRPr lang="en-US" sz="1200" dirty="0"/>
           </a:p>
@@ -4152,7 +4152,7 @@
                   <a:srgbClr val="FFFFFF"/>
                 </a:solidFill>
               </a:rPr>
-              <a:t>   需要進一步研究系統免疫-炎症指數(SII)在不同患者群體中的應用及其對治療結果的影響。</a:t>
+              <a:t>   研究系統性免疫炎症指數（SII）在不同患者群體中的臨床應用，可能會完善預後評估。</a:t>
             </a:r>
             <a:endParaRPr lang="en-US" sz="1200" dirty="0"/>
           </a:p>
@@ -4178,7 +4178,7 @@
                   <a:srgbClr val="FFFFFF"/>
                 </a:solidFill>
               </a:rPr>
-              <a:t>3. **微生物組與治療反應**  </a:t>
+              <a:t>3. **微生物群與癌症的關聯**  </a:t>
             </a:r>
             <a:endParaRPr lang="en-US" sz="1200" dirty="0"/>
           </a:p>
@@ -4195,7 +4195,7 @@
                   <a:srgbClr val="FFFFFF"/>
                 </a:solidFill>
               </a:rPr>
-              <a:t>   Investigating the role of gut microbiota in modulating responses to immunotherapy and chemotherapy could reveal new avenues for enhancing treatment efficacy.  </a:t>
+              <a:t>   Further research is needed to elucidate the mechanisms by which gut microbiota influence inflammation and colorectal cancer development.  </a:t>
             </a:r>
             <a:endParaRPr lang="en-US" sz="1200" dirty="0"/>
           </a:p>
@@ -4212,7 +4212,7 @@
                   <a:srgbClr val="FFFFFF"/>
                 </a:solidFill>
               </a:rPr>
-              <a:t>   研究腸道微生物組在調節免疫療法和化療反應中的作用，可能會揭示增強治療效果的新途徑。</a:t>
+              <a:t>   需要進一步研究以闡明腸道微生物群如何影響炎症和結直腸癌發展的機制。</a:t>
             </a:r>
             <a:endParaRPr lang="en-US" sz="1200" dirty="0"/>
           </a:p>
@@ -4238,7 +4238,7 @@
                   <a:srgbClr val="FFFFFF"/>
                 </a:solidFill>
               </a:rPr>
-              <a:t>4. **患者經驗的深入研究**  </a:t>
+              <a:t>4. **術後營養干預的長期效果**  </a:t>
             </a:r>
             <a:endParaRPr lang="en-US" sz="1200" dirty="0"/>
           </a:p>
@@ -4255,7 +4255,7 @@
                   <a:srgbClr val="FFFFFF"/>
                 </a:solidFill>
               </a:rPr>
-              <a:t>   More qualitative studies are required to capture the lived experiences of patients undergoing major surgical interventions, informing better supportive care strategies.  </a:t>
+              <a:t>   Longitudinal studies assessing the long-term effects of omega-3 PUFA supplementation on recovery and quality of life in colorectal cancer patients are warranted.  </a:t>
             </a:r>
             <a:endParaRPr lang="en-US" sz="1200" dirty="0"/>
           </a:p>
@@ -4272,7 +4272,7 @@
                   <a:srgbClr val="FFFFFF"/>
                 </a:solidFill>
               </a:rPr>
-              <a:t>   需要更多質性研究來捕捉接受重大外科手術的患者的生活經驗，以便制定更好的支持性護理策略。</a:t>
+              <a:t>   需要進行縱向研究，以評估Omega-3 PUFA補充對結直腸癌患者恢復和生活質量的長期影響。</a:t>
             </a:r>
             <a:endParaRPr lang="en-US" sz="1200" dirty="0"/>
           </a:p>
@@ -4298,7 +4298,7 @@
                   <a:srgbClr val="FFFFFF"/>
                 </a:solidFill>
               </a:rPr>
-              <a:t>5. **炎症與癌症進展的機制**  </a:t>
+              <a:t>5. **增強患者教育與風險管理**  </a:t>
             </a:r>
             <a:endParaRPr lang="en-US" sz="1200" dirty="0"/>
           </a:p>
@@ -4315,7 +4315,7 @@
                   <a:srgbClr val="FFFFFF"/>
                 </a:solidFill>
               </a:rPr>
-              <a:t>   Elucidating the mechanisms by which inflammation contributes to colorectal cancer progression will be crucial for developing targeted anti-inflammatory therapies.  </a:t>
+              <a:t>   Developing targeted educational programs for patients with inflammatory bowel disease regarding their cancer risks and management strategies is essential.  </a:t>
             </a:r>
             <a:endParaRPr lang="en-US" sz="1200" dirty="0"/>
           </a:p>
@@ -4332,7 +4332,7 @@
                   <a:srgbClr val="FFFFFF"/>
                 </a:solidFill>
               </a:rPr>
-              <a:t>   揭示炎症如何促進結直腸癌進展的機制對於開發針對性抗炎療法至關重要。</a:t>
+              <a:t>   為炎症性腸病患者制定針對性的教育計劃，讓他們了解癌症風險和管理策略是至關重要的。</a:t>
             </a:r>
             <a:endParaRPr lang="en-US" sz="1200" dirty="0"/>
           </a:p>
@@ -4603,7 +4603,7 @@
                 <a:ea typeface="Arial" pitchFamily="34" charset="-122"/>
                 <a:cs typeface="Arial" pitchFamily="34" charset="-120"/>
               </a:rPr>
-              <a:t>Targeting fibroblast TXNDC5 resolves tumor desmoplasia and PD-1 resistance in co…</a:t>
+              <a:t>Parasutterella excrementihominis exacerbates experimental colitis and colitis-as…</a:t>
             </a:r>
             <a:endParaRPr lang="en-US" sz="1400" dirty="0"/>
           </a:p>
@@ -4640,7 +4640,7 @@
                 <a:ea typeface="Arial" pitchFamily="34" charset="-122"/>
                 <a:cs typeface="Arial" pitchFamily="34" charset="-120"/>
               </a:rPr>
-              <a:t>Parasutterella excrementihominis exacerbates experimental colitis and colitis-as…</a:t>
+              <a:t>Prognostic value of systemic immune-inflammation index for colorectal cancer: a …</a:t>
             </a:r>
             <a:endParaRPr lang="en-US" sz="1400" dirty="0"/>
           </a:p>
@@ -4677,7 +4677,7 @@
                 <a:ea typeface="Arial" pitchFamily="34" charset="-122"/>
                 <a:cs typeface="Arial" pitchFamily="34" charset="-120"/>
               </a:rPr>
-              <a:t>Mucoadhesive patch based on chitosan hydrogel loaded with anticancer agent as th…</a:t>
+              <a:t>The Role of Omega-3 Polyunsaturated Fatty Acid Supplementation in Postoperative …</a:t>
             </a:r>
             <a:endParaRPr lang="en-US" sz="1400" dirty="0"/>
           </a:p>
@@ -4714,7 +4714,7 @@
                 <a:ea typeface="Arial" pitchFamily="34" charset="-122"/>
                 <a:cs typeface="Arial" pitchFamily="34" charset="-120"/>
               </a:rPr>
-              <a:t>Prognostic value of systemic immune-inflammation index for colorectal cancer: a …</a:t>
+              <a:t>Awareness of inflammatory bowel disease-associated colorectal cancer risk and it…</a:t>
             </a:r>
             <a:endParaRPr lang="en-US" sz="1400" dirty="0"/>
           </a:p>
@@ -4751,7 +4751,7 @@
                 <a:ea typeface="Arial" pitchFamily="34" charset="-122"/>
                 <a:cs typeface="Arial" pitchFamily="34" charset="-120"/>
               </a:rPr>
-              <a:t>Consensus Guideline for the Management of Colorectal Cancer with Peritoneal Meta…</a:t>
+              <a:t>ACAT1-mediated lactylation reprogramming governs immune-stromal crosstalk in ulc…</a:t>
             </a:r>
             <a:endParaRPr lang="en-US" sz="1400" dirty="0"/>
           </a:p>
@@ -4788,7 +4788,7 @@
                 <a:ea typeface="Arial" pitchFamily="34" charset="-122"/>
                 <a:cs typeface="Arial" pitchFamily="34" charset="-120"/>
               </a:rPr>
-              <a:t>Awareness of inflammatory bowel disease-associated colorectal cancer risk and it…</a:t>
+              <a:t>Indole-3-acetic acid promotes differentiation while suppressing proliferation in…</a:t>
             </a:r>
             <a:endParaRPr lang="en-US" sz="1400" dirty="0"/>
           </a:p>
@@ -4825,7 +4825,7 @@
                 <a:ea typeface="Arial" pitchFamily="34" charset="-122"/>
                 <a:cs typeface="Arial" pitchFamily="34" charset="-120"/>
               </a:rPr>
-              <a:t>Life After Pelvic Exenteration for Rectal Cancer: The Patient and Carer Perspect…</a:t>
+              <a:t>Efavirenz Mitigates Dyslipidemia and Attenuates Ulcerative Colitis through Gut M…</a:t>
             </a:r>
             <a:endParaRPr lang="en-US" sz="1400" dirty="0"/>
           </a:p>
@@ -4862,7 +4862,7 @@
                 <a:ea typeface="Arial" pitchFamily="34" charset="-122"/>
                 <a:cs typeface="Arial" pitchFamily="34" charset="-120"/>
               </a:rPr>
-              <a:t>Colon cancer with a peritumoural abscess: Real-world evidence on prognostic and …</a:t>
+              <a:t>Oxaliplatin triggers adipose and muscle wasting through cancer-independent metab…</a:t>
             </a:r>
             <a:endParaRPr lang="en-US" sz="1400" dirty="0"/>
           </a:p>
@@ -4899,7 +4899,7 @@
                 <a:ea typeface="Arial" pitchFamily="34" charset="-122"/>
                 <a:cs typeface="Arial" pitchFamily="34" charset="-120"/>
               </a:rPr>
-              <a:t>Genetic variants of the transporter SLC22A4 affect the abundance and survival of…</a:t>
+              <a:t>Loss of proton-sensing TDAG8 increases tumor progression in mouse models of colo…</a:t>
             </a:r>
             <a:endParaRPr lang="en-US" sz="1400" dirty="0"/>
           </a:p>
@@ -5133,7 +5133,7 @@
                 <a:ea typeface="Arial" pitchFamily="34" charset="-122"/>
                 <a:cs typeface="Arial" pitchFamily="34" charset="-120"/>
               </a:rPr>
-              <a:t>Study compares two treatment approaches</a:t>
+              <a:t>Cytoreductive surgery evaluated in study</a:t>
             </a:r>
             <a:endParaRPr lang="en-US" sz="1800" dirty="0"/>
           </a:p>
@@ -5154,7 +5154,7 @@
                 <a:ea typeface="Arial" pitchFamily="34" charset="-122"/>
                 <a:cs typeface="Arial" pitchFamily="34" charset="-120"/>
               </a:rPr>
-              <a:t>Cytoreductive surgery with HIPEC</a:t>
+              <a:t>Hyperthermic intraperitoneal chemotherapy used</a:t>
             </a:r>
             <a:endParaRPr lang="en-US" sz="1800" dirty="0"/>
           </a:p>
@@ -5175,7 +5175,7 @@
                 <a:ea typeface="Arial" pitchFamily="34" charset="-122"/>
                 <a:cs typeface="Arial" pitchFamily="34" charset="-120"/>
               </a:rPr>
-              <a:t>Findings show no survival benefit</a:t>
+              <a:t>Comparison with surgery alone</a:t>
             </a:r>
             <a:endParaRPr lang="en-US" sz="1800" dirty="0"/>
           </a:p>
@@ -5196,7 +5196,7 @@
                 <a:ea typeface="Arial" pitchFamily="34" charset="-122"/>
                 <a:cs typeface="Arial" pitchFamily="34" charset="-120"/>
               </a:rPr>
-              <a:t>Focus on metastatic colorectal cancer</a:t>
+              <a:t>Focus on colorectal peritoneal metastases</a:t>
             </a:r>
             <a:endParaRPr lang="en-US" sz="1800" dirty="0"/>
           </a:p>
@@ -5217,7 +5217,7 @@
                 <a:ea typeface="Arial" pitchFamily="34" charset="-122"/>
                 <a:cs typeface="Arial" pitchFamily="34" charset="-120"/>
               </a:rPr>
-              <a:t>Implications for future treatment strategies</a:t>
+              <a:t>Multicentre, randomised trial design</a:t>
             </a:r>
             <a:endParaRPr lang="en-US" sz="1800" dirty="0"/>
           </a:p>
@@ -5453,7 +5453,7 @@
                   </a:extLst>
                 </a:hlinkClick>
               </a:rPr>
-              <a:t>Targeting fibroblast TXNDC5 resolves tumor desmoplasia and PD-1 resistance in colorectal cancer with mesenchymal traits.</a:t>
+              <a:t>Parasutterella excrementihominis exacerbates experimental colitis and colitis-associated colorectal cancer via pathogenic NETosis activation</a:t>
             </a:r>
             <a:endParaRPr lang="en-US" sz="2400" dirty="0"/>
           </a:p>
@@ -5489,7 +5489,7 @@
                   <a:srgbClr val="888888"/>
                 </a:solidFill>
               </a:rPr>
-              <a:t>Nature communications  ·  IF 14.7  ·  🌏 Asia</a:t>
+              <a:t>Gut  ·  IF 24.5</a:t>
             </a:r>
             <a:endParaRPr lang="en-US" sz="1000" dirty="0"/>
           </a:p>
@@ -5532,7 +5532,7 @@
                 <a:ea typeface="Arial" pitchFamily="34" charset="-122"/>
                 <a:cs typeface="Arial" pitchFamily="34" charset="-120"/>
               </a:rPr>
-              <a:t>TXNDC5 regulates immunosuppressive niche</a:t>
+              <a:t>Parasutterella excrementihominis role in colitis</a:t>
             </a:r>
             <a:endParaRPr lang="en-US" sz="1800" dirty="0"/>
           </a:p>
@@ -5553,7 +5553,7 @@
                 <a:ea typeface="Arial" pitchFamily="34" charset="-122"/>
                 <a:cs typeface="Arial" pitchFamily="34" charset="-120"/>
               </a:rPr>
-              <a:t>Enhances TGFβ signaling in fibroblasts</a:t>
+              <a:t>NETosis activation linked to inflammation</a:t>
             </a:r>
             <a:endParaRPr lang="en-US" sz="1800" dirty="0"/>
           </a:p>
@@ -5574,49 +5574,7 @@
                 <a:ea typeface="Arial" pitchFamily="34" charset="-122"/>
                 <a:cs typeface="Arial" pitchFamily="34" charset="-120"/>
               </a:rPr>
-              <a:t>Fibroblast-specific Txndc5 deletion reduces tumor stiffness</a:t>
-            </a:r>
-            <a:endParaRPr lang="en-US" sz="1800" dirty="0"/>
-          </a:p>
-          <a:p>
-            <a:pPr marL="342900" indent="-342900">
-              <a:spcAft>
-                <a:spcPts val="800"/>
-              </a:spcAft>
-              <a:buSzPct val="100000"/>
-              <a:buChar char="•"/>
-            </a:pPr>
-            <a:r>
-              <a:rPr lang="en-US" sz="1800" dirty="0">
-                <a:solidFill>
-                  <a:srgbClr val="333333"/>
-                </a:solidFill>
-                <a:latin typeface="Arial" pitchFamily="34" charset="0"/>
-                <a:ea typeface="Arial" pitchFamily="34" charset="-122"/>
-                <a:cs typeface="Arial" pitchFamily="34" charset="-120"/>
-              </a:rPr>
-              <a:t>Increases cytotoxic T-cell recruitment</a:t>
-            </a:r>
-            <a:endParaRPr lang="en-US" sz="1800" dirty="0"/>
-          </a:p>
-          <a:p>
-            <a:pPr marL="342900" indent="-342900">
-              <a:spcAft>
-                <a:spcPts val="800"/>
-              </a:spcAft>
-              <a:buSzPct val="100000"/>
-              <a:buChar char="•"/>
-            </a:pPr>
-            <a:r>
-              <a:rPr lang="en-US" sz="1800" dirty="0">
-                <a:solidFill>
-                  <a:srgbClr val="333333"/>
-                </a:solidFill>
-                <a:latin typeface="Arial" pitchFamily="34" charset="0"/>
-                <a:ea typeface="Arial" pitchFamily="34" charset="-122"/>
-                <a:cs typeface="Arial" pitchFamily="34" charset="-120"/>
-              </a:rPr>
-              <a:t>Sensitizes tumors to PD-1 blockade therapy</a:t>
+              <a:t>Implications for colorectal cancer therapy</a:t>
             </a:r>
             <a:endParaRPr lang="en-US" sz="1800" dirty="0"/>
           </a:p>
@@ -5652,7 +5610,7 @@
                   <a:srgbClr val="888888"/>
                 </a:solidFill>
               </a:rPr>
-              <a:t>Cheng Kai-Lin, Chen Chih-I, Yu Shu-Han et al.. Nature communications. 2026-06-05 DOI: 10.1038/s41467-026-74073-1</a:t>
+              <a:t>H Tan, L Huang, J Wang. Gut. 2026</a:t>
             </a:r>
             <a:endParaRPr lang="en-US" sz="800" dirty="0"/>
           </a:p>
@@ -5852,7 +5810,7 @@
                   </a:extLst>
                 </a:hlinkClick>
               </a:rPr>
-              <a:t>Parasutterella excrementihominis exacerbates experimental colitis and colitis-associated colorectal cancer via pathogenic NETosis activation</a:t>
+              <a:t>Prognostic value of systemic immune-inflammation index for colorectal cancer: a systematic review and meta-analysis</a:t>
             </a:r>
             <a:endParaRPr lang="en-US" sz="2400" dirty="0"/>
           </a:p>
@@ -5888,7 +5846,7 @@
                   <a:srgbClr val="888888"/>
                 </a:solidFill>
               </a:rPr>
-              <a:t>Gut  ·  IF 24.5</a:t>
+              <a:t>Frontiers in Oncology  ·  Meta-Analysis</a:t>
             </a:r>
             <a:endParaRPr lang="en-US" sz="1000" dirty="0"/>
           </a:p>
@@ -5931,7 +5889,7 @@
                 <a:ea typeface="Arial" pitchFamily="34" charset="-122"/>
                 <a:cs typeface="Arial" pitchFamily="34" charset="-120"/>
               </a:rPr>
-              <a:t>P. excrementihominis worsens colitis</a:t>
+              <a:t>Systemic immune-inflammation index (SII) evaluated</a:t>
             </a:r>
             <a:endParaRPr lang="en-US" sz="1800" dirty="0"/>
           </a:p>
@@ -5952,7 +5910,7 @@
                 <a:ea typeface="Arial" pitchFamily="34" charset="-122"/>
                 <a:cs typeface="Arial" pitchFamily="34" charset="-120"/>
               </a:rPr>
-              <a:t>NETosis activation linked to cancer</a:t>
+              <a:t>Prognostic significance in colorectal cancer</a:t>
             </a:r>
             <a:endParaRPr lang="en-US" sz="1800" dirty="0"/>
           </a:p>
@@ -5973,7 +5931,49 @@
                 <a:ea typeface="Arial" pitchFamily="34" charset="-122"/>
                 <a:cs typeface="Arial" pitchFamily="34" charset="-120"/>
               </a:rPr>
-              <a:t>Study suggests new treatment strategies</a:t>
+              <a:t>Meta-analysis of existing studies</a:t>
+            </a:r>
+            <a:endParaRPr lang="en-US" sz="1800" dirty="0"/>
+          </a:p>
+          <a:p>
+            <a:pPr marL="342900" indent="-342900">
+              <a:spcAft>
+                <a:spcPts val="800"/>
+              </a:spcAft>
+              <a:buSzPct val="100000"/>
+              <a:buChar char="•"/>
+            </a:pPr>
+            <a:r>
+              <a:rPr lang="en-US" sz="1800" dirty="0">
+                <a:solidFill>
+                  <a:srgbClr val="333333"/>
+                </a:solidFill>
+                <a:latin typeface="Arial" pitchFamily="34" charset="0"/>
+                <a:ea typeface="Arial" pitchFamily="34" charset="-122"/>
+                <a:cs typeface="Arial" pitchFamily="34" charset="-120"/>
+              </a:rPr>
+              <a:t>SII correlates with patient outcomes</a:t>
+            </a:r>
+            <a:endParaRPr lang="en-US" sz="1800" dirty="0"/>
+          </a:p>
+          <a:p>
+            <a:pPr marL="342900" indent="-342900">
+              <a:spcAft>
+                <a:spcPts val="800"/>
+              </a:spcAft>
+              <a:buSzPct val="100000"/>
+              <a:buChar char="•"/>
+            </a:pPr>
+            <a:r>
+              <a:rPr lang="en-US" sz="1800" dirty="0">
+                <a:solidFill>
+                  <a:srgbClr val="333333"/>
+                </a:solidFill>
+                <a:latin typeface="Arial" pitchFamily="34" charset="0"/>
+                <a:ea typeface="Arial" pitchFamily="34" charset="-122"/>
+                <a:cs typeface="Arial" pitchFamily="34" charset="-120"/>
+              </a:rPr>
+              <a:t>Potential for clinical application</a:t>
             </a:r>
             <a:endParaRPr lang="en-US" sz="1800" dirty="0"/>
           </a:p>
@@ -6009,7 +6009,7 @@
                   <a:srgbClr val="888888"/>
                 </a:solidFill>
               </a:rPr>
-              <a:t>H Tan, L Huang, J Wang. Gut. 2026</a:t>
+              <a:t>P Wang, H Jiang. Frontiers in Oncology. 2026</a:t>
             </a:r>
             <a:endParaRPr lang="en-US" sz="800" dirty="0"/>
           </a:p>
@@ -6209,7 +6209,7 @@
                   </a:extLst>
                 </a:hlinkClick>
               </a:rPr>
-              <a:t>Mucoadhesive patch based on chitosan hydrogel loaded with anticancer agent as the promising nursing care and therapy for digestive tract cancers.</a:t>
+              <a:t>The Role of Omega-3 Polyunsaturated Fatty Acid Supplementation in Postoperative Recovery of Colorectal Cancer: Systematic Review and Meta-Analysis</a:t>
             </a:r>
             <a:endParaRPr lang="en-US" sz="2400" dirty="0"/>
           </a:p>
@@ -6245,7 +6245,7 @@
                   <a:srgbClr val="888888"/>
                 </a:solidFill>
               </a:rPr>
-              <a:t>Biomedical materials (Bristol, England)  ·  🌏 Asia</a:t>
+              <a:t>Nutrients  ·  Meta-Analysis</a:t>
             </a:r>
             <a:endParaRPr lang="en-US" sz="1000" dirty="0"/>
           </a:p>
@@ -6288,7 +6288,7 @@
                 <a:ea typeface="Arial" pitchFamily="34" charset="-122"/>
                 <a:cs typeface="Arial" pitchFamily="34" charset="-120"/>
               </a:rPr>
-              <a:t>Mucoadhesive drug delivery systems enhance drug retention.</a:t>
+              <a:t>Omega-3 PUFAs aid postoperative recovery.</a:t>
             </a:r>
             <a:endParaRPr lang="en-US" sz="1800" dirty="0"/>
           </a:p>
@@ -6309,7 +6309,7 @@
                 <a:ea typeface="Arial" pitchFamily="34" charset="-122"/>
                 <a:cs typeface="Arial" pitchFamily="34" charset="-120"/>
               </a:rPr>
-              <a:t>Chitosan hydrogels loaded with DOX-PLGA NPs.</a:t>
+              <a:t>Modulate inflammatory cytokines effectively.</a:t>
             </a:r>
             <a:endParaRPr lang="en-US" sz="1800" dirty="0"/>
           </a:p>
@@ -6330,7 +6330,7 @@
                 <a:ea typeface="Arial" pitchFamily="34" charset="-122"/>
                 <a:cs typeface="Arial" pitchFamily="34" charset="-120"/>
               </a:rPr>
-              <a:t>pH-responsive drug release for targeted therapy.</a:t>
+              <a:t>Inverse association with pro-inflammatory markers.</a:t>
             </a:r>
             <a:endParaRPr lang="en-US" sz="1800" dirty="0"/>
           </a:p>
@@ -6366,7 +6366,7 @@
                   <a:srgbClr val="888888"/>
                 </a:solidFill>
               </a:rPr>
-              <a:t>Meng Wei, Cheng Hui, Cao Yehua. Biomedical materials (Bristol, England). 2026-06-04 DOI: 10.1088/1748-605X/ae6ea8</a:t>
+              <a:t>H Li, Z Xu, Y Chen. Nutrients. 2026</a:t>
             </a:r>
             <a:endParaRPr lang="en-US" sz="800" dirty="0"/>
           </a:p>
@@ -6566,7 +6566,7 @@
                   </a:extLst>
                 </a:hlinkClick>
               </a:rPr>
-              <a:t>Prognostic value of systemic immune-inflammation index for colorectal cancer: a systematic review and meta-analysis</a:t>
+              <a:t>Awareness of inflammatory bowel disease-associated colorectal cancer risk and its management in patients with inflammatory bowel disease: a systematic review</a:t>
             </a:r>
             <a:endParaRPr lang="en-US" sz="2400" dirty="0"/>
           </a:p>
@@ -6602,7 +6602,7 @@
                   <a:srgbClr val="888888"/>
                 </a:solidFill>
               </a:rPr>
-              <a:t>Frontiers in Oncology  ·  Meta-Analysis</a:t>
+              <a:t>Crohns &amp; Colitis 360  ·  Systematic Review</a:t>
             </a:r>
             <a:endParaRPr lang="en-US" sz="1000" dirty="0"/>
           </a:p>
@@ -6645,7 +6645,7 @@
                 <a:ea typeface="Arial" pitchFamily="34" charset="-122"/>
                 <a:cs typeface="Arial" pitchFamily="34" charset="-120"/>
               </a:rPr>
-              <a:t>Systemic immune-inflammation index (SII) evaluated</a:t>
+              <a:t>Limited awareness of colorectal cancer risk</a:t>
             </a:r>
             <a:endParaRPr lang="en-US" sz="1800" dirty="0"/>
           </a:p>
@@ -6666,7 +6666,7 @@
                 <a:ea typeface="Arial" pitchFamily="34" charset="-122"/>
                 <a:cs typeface="Arial" pitchFamily="34" charset="-120"/>
               </a:rPr>
-              <a:t>Prognostic biomarker for colorectal cancer</a:t>
+              <a:t>Need for better management strategies</a:t>
             </a:r>
             <a:endParaRPr lang="en-US" sz="1800" dirty="0"/>
           </a:p>
@@ -6687,49 +6687,7 @@
                 <a:ea typeface="Arial" pitchFamily="34" charset="-122"/>
                 <a:cs typeface="Arial" pitchFamily="34" charset="-120"/>
               </a:rPr>
-              <a:t>Systematic review and meta-analysis conducted</a:t>
-            </a:r>
-            <a:endParaRPr lang="en-US" sz="1800" dirty="0"/>
-          </a:p>
-          <a:p>
-            <a:pPr marL="342900" indent="-342900">
-              <a:spcAft>
-                <a:spcPts val="800"/>
-              </a:spcAft>
-              <a:buSzPct val="100000"/>
-              <a:buChar char="•"/>
-            </a:pPr>
-            <a:r>
-              <a:rPr lang="en-US" sz="1800" dirty="0">
-                <a:solidFill>
-                  <a:srgbClr val="333333"/>
-                </a:solidFill>
-                <a:latin typeface="Arial" pitchFamily="34" charset="0"/>
-                <a:ea typeface="Arial" pitchFamily="34" charset="-122"/>
-                <a:cs typeface="Arial" pitchFamily="34" charset="-120"/>
-              </a:rPr>
-              <a:t>SII correlates with patient outcomes</a:t>
-            </a:r>
-            <a:endParaRPr lang="en-US" sz="1800" dirty="0"/>
-          </a:p>
-          <a:p>
-            <a:pPr marL="342900" indent="-342900">
-              <a:spcAft>
-                <a:spcPts val="800"/>
-              </a:spcAft>
-              <a:buSzPct val="100000"/>
-              <a:buChar char="•"/>
-            </a:pPr>
-            <a:r>
-              <a:rPr lang="en-US" sz="1800" dirty="0">
-                <a:solidFill>
-                  <a:srgbClr val="333333"/>
-                </a:solidFill>
-                <a:latin typeface="Arial" pitchFamily="34" charset="0"/>
-                <a:ea typeface="Arial" pitchFamily="34" charset="-122"/>
-                <a:cs typeface="Arial" pitchFamily="34" charset="-120"/>
-              </a:rPr>
-              <a:t>Potential for clinical application in CRC</a:t>
+              <a:t>Insufficient research on patient knowledge</a:t>
             </a:r>
             <a:endParaRPr lang="en-US" sz="1800" dirty="0"/>
           </a:p>
@@ -6765,7 +6723,7 @@
                   <a:srgbClr val="888888"/>
                 </a:solidFill>
               </a:rPr>
-              <a:t>P Wang, H Jiang. Frontiers in Oncology. 2026</a:t>
+              <a:t>F Khan, C Norton, W Czuber-Dochan. Crohns &amp; Colitis 360. 2026</a:t>
             </a:r>
             <a:endParaRPr lang="en-US" sz="800" dirty="0"/>
           </a:p>
@@ -6965,7 +6923,7 @@
                   </a:extLst>
                 </a:hlinkClick>
               </a:rPr>
-              <a:t>Consensus Guideline for the Management of Colorectal Cancer with Peritoneal Metastases.</a:t>
+              <a:t>ACAT1-mediated lactylation reprogramming governs immune-stromal crosstalk in ulcerative colitis.</a:t>
             </a:r>
             <a:endParaRPr lang="en-US" sz="2400" dirty="0"/>
           </a:p>
@@ -7001,7 +6959,7 @@
                   <a:srgbClr val="888888"/>
                 </a:solidFill>
               </a:rPr>
-              <a:t>Annals of surgical oncology  ·  IF 3.8  ·  Prospective Study</a:t>
+              <a:t>International immunopharmacology  ·  Basic Research</a:t>
             </a:r>
             <a:endParaRPr lang="en-US" sz="1000" dirty="0"/>
           </a:p>
@@ -7044,7 +7002,7 @@
                 <a:ea typeface="Arial" pitchFamily="34" charset="-122"/>
                 <a:cs typeface="Arial" pitchFamily="34" charset="-120"/>
               </a:rPr>
-              <a:t>Peritoneum common site for CRC metastases.</a:t>
+              <a:t>ACAT1 identified as key lactylation gene.</a:t>
             </a:r>
             <a:endParaRPr lang="en-US" sz="1800" dirty="0"/>
           </a:p>
@@ -7065,7 +7023,7 @@
                 <a:ea typeface="Arial" pitchFamily="34" charset="-122"/>
                 <a:cs typeface="Arial" pitchFamily="34" charset="-120"/>
               </a:rPr>
-              <a:t>Updated 2018 Chicago Consensus Guidelines.</a:t>
+              <a:t>Lactylation affects immune-stromal interactions.</a:t>
             </a:r>
             <a:endParaRPr lang="en-US" sz="1800" dirty="0"/>
           </a:p>
@@ -7086,49 +7044,7 @@
                 <a:ea typeface="Arial" pitchFamily="34" charset="-122"/>
                 <a:cs typeface="Arial" pitchFamily="34" charset="-120"/>
               </a:rPr>
-              <a:t>High consensus on management pathways.</a:t>
-            </a:r>
-            <a:endParaRPr lang="en-US" sz="1800" dirty="0"/>
-          </a:p>
-          <a:p>
-            <a:pPr marL="342900" indent="-342900">
-              <a:spcAft>
-                <a:spcPts val="800"/>
-              </a:spcAft>
-              <a:buSzPct val="100000"/>
-              <a:buChar char="•"/>
-            </a:pPr>
-            <a:r>
-              <a:rPr lang="en-US" sz="1800" dirty="0">
-                <a:solidFill>
-                  <a:srgbClr val="333333"/>
-                </a:solidFill>
-                <a:latin typeface="Arial" pitchFamily="34" charset="0"/>
-                <a:ea typeface="Arial" pitchFamily="34" charset="-122"/>
-                <a:cs typeface="Arial" pitchFamily="34" charset="-120"/>
-              </a:rPr>
-              <a:t>Early referral to PSM centers recommended.</a:t>
-            </a:r>
-            <a:endParaRPr lang="en-US" sz="1800" dirty="0"/>
-          </a:p>
-          <a:p>
-            <a:pPr marL="342900" indent="-342900">
-              <a:spcAft>
-                <a:spcPts val="800"/>
-              </a:spcAft>
-              <a:buSzPct val="100000"/>
-              <a:buChar char="•"/>
-            </a:pPr>
-            <a:r>
-              <a:rPr lang="en-US" sz="1800" dirty="0">
-                <a:solidFill>
-                  <a:srgbClr val="333333"/>
-                </a:solidFill>
-                <a:latin typeface="Arial" pitchFamily="34" charset="0"/>
-                <a:ea typeface="Arial" pitchFamily="34" charset="-122"/>
-                <a:cs typeface="Arial" pitchFamily="34" charset="-120"/>
-              </a:rPr>
-              <a:t>Weak recommendation for ctDNA testing.</a:t>
+              <a:t>Sulfasalazine shows potential targeting ACAT1.</a:t>
             </a:r>
             <a:endParaRPr lang="en-US" sz="1800" dirty="0"/>
           </a:p>
@@ -7164,7 +7080,7 @@
                   <a:srgbClr val="888888"/>
                 </a:solidFill>
               </a:rPr>
-              <a:t>Schultz Kurt S, Bansal Varun V, Wach Michael M et al.. Annals of surgical oncology. 2026-05-19 DOI: 10.1245/s10434-025-17363-0</a:t>
+              <a:t>Yan Jiayu, Lin Shanshan, Chen Zhuosi et al.. International immunopharmacology. 2026-04-23 DOI: 10.1016/j.intimp.2026.116626</a:t>
             </a:r>
             <a:endParaRPr lang="en-US" sz="800" dirty="0"/>
           </a:p>
@@ -7364,7 +7280,7 @@
                   </a:extLst>
                 </a:hlinkClick>
               </a:rPr>
-              <a:t>Awareness of inflammatory bowel disease-associated colorectal cancer risk and its management in patients with inflammatory bowel disease: a systematic review</a:t>
+              <a:t>Indole-3-acetic acid promotes differentiation while suppressing proliferation in human intestinal epithelial cells.</a:t>
             </a:r>
             <a:endParaRPr lang="en-US" sz="2400" dirty="0"/>
           </a:p>
@@ -7400,7 +7316,7 @@
                   <a:srgbClr val="888888"/>
                 </a:solidFill>
               </a:rPr>
-              <a:t>Crohns &amp; Colitis 360  ·  Systematic Review</a:t>
+              <a:t>Human cell  ·  Basic Research</a:t>
             </a:r>
             <a:endParaRPr lang="en-US" sz="1000" dirty="0"/>
           </a:p>
@@ -7443,7 +7359,7 @@
                 <a:ea typeface="Arial" pitchFamily="34" charset="-122"/>
                 <a:cs typeface="Arial" pitchFamily="34" charset="-120"/>
               </a:rPr>
-              <a:t>Limited knowledge on colorectal cancer risk</a:t>
+              <a:t>IAA influences intestinal epithelial cells' biology.</a:t>
             </a:r>
             <a:endParaRPr lang="en-US" sz="1800" dirty="0"/>
           </a:p>
@@ -7464,7 +7380,7 @@
                 <a:ea typeface="Arial" pitchFamily="34" charset="-122"/>
                 <a:cs typeface="Arial" pitchFamily="34" charset="-120"/>
               </a:rPr>
-              <a:t>Need for better patient education strategies</a:t>
+              <a:t>Higher IAA concentrations reduce cell viability.</a:t>
             </a:r>
             <a:endParaRPr lang="en-US" sz="1800" dirty="0"/>
           </a:p>
@@ -7485,7 +7401,7 @@
                 <a:ea typeface="Arial" pitchFamily="34" charset="-122"/>
                 <a:cs typeface="Arial" pitchFamily="34" charset="-120"/>
               </a:rPr>
-              <a:t>Importance of regular screening in IBD patients</a:t>
+              <a:t>IAA promotes differentiation and epithelial repair.</a:t>
             </a:r>
             <a:endParaRPr lang="en-US" sz="1800" dirty="0"/>
           </a:p>
@@ -7521,7 +7437,7 @@
                   <a:srgbClr val="888888"/>
                 </a:solidFill>
               </a:rPr>
-              <a:t>F Khan, C Norton, W Czuber-Dochan. Crohns &amp; Colitis 360. 2026</a:t>
+              <a:t>Mallardo Marta, Memon Furqan, Pagliaro Raffaella et al.. Human cell. 2026-06-12 DOI: 10.1007/s13577-026-01397-x</a:t>
             </a:r>
             <a:endParaRPr lang="en-US" sz="800" dirty="0"/>
           </a:p>

</xml_diff>

<commit_message>
chore: update weekly digest 2026-06-22
</commit_message>
<xml_diff>
--- a/docs/digest-en.pptx
+++ b/docs/digest-en.pptx
@@ -2249,7 +2249,7 @@
                   <a:srgbClr val="888888"/>
                 </a:solidFill>
               </a:rPr>
-              <a:t>2026-06-08 — 2026-06-15</a:t>
+              <a:t>2026-06-15 — 2026-06-22</a:t>
             </a:r>
             <a:endParaRPr lang="en-US" sz="1400" dirty="0"/>
           </a:p>
@@ -2440,7 +2440,7 @@
                   </a:extLst>
                 </a:hlinkClick>
               </a:rPr>
-              <a:t>Efavirenz Mitigates Dyslipidemia and Attenuates Ulcerative Colitis through Gut Microbiota Modulation.</a:t>
+              <a:t>Prognostic value of systemic immune-inflammation index for colorectal cancer: a systematic review and meta-analysis</a:t>
             </a:r>
             <a:endParaRPr lang="en-US" sz="2400" dirty="0"/>
           </a:p>
@@ -2476,7 +2476,7 @@
                   <a:srgbClr val="888888"/>
                 </a:solidFill>
               </a:rPr>
-              <a:t>ACS infectious diseases  ·  Basic Research</a:t>
+              <a:t>Frontiers in Oncology  ·  Meta-Analysis</a:t>
             </a:r>
             <a:endParaRPr lang="en-US" sz="1000" dirty="0"/>
           </a:p>
@@ -2519,7 +2519,7 @@
                 <a:ea typeface="Arial" pitchFamily="34" charset="-122"/>
                 <a:cs typeface="Arial" pitchFamily="34" charset="-120"/>
               </a:rPr>
-              <a:t>Efavirenz mitigates ART-induced dyslipidemia.</a:t>
+              <a:t>Systemic immune-inflammation index (SII) evaluated</a:t>
             </a:r>
             <a:endParaRPr lang="en-US" sz="1800" dirty="0"/>
           </a:p>
@@ -2540,7 +2540,7 @@
                 <a:ea typeface="Arial" pitchFamily="34" charset="-122"/>
                 <a:cs typeface="Arial" pitchFamily="34" charset="-120"/>
               </a:rPr>
-              <a:t>Improves ulcerative colitis symptoms in models.</a:t>
+              <a:t>Prognostic significance in colorectal cancer</a:t>
             </a:r>
             <a:endParaRPr lang="en-US" sz="1800" dirty="0"/>
           </a:p>
@@ -2561,7 +2561,49 @@
                 <a:ea typeface="Arial" pitchFamily="34" charset="-122"/>
                 <a:cs typeface="Arial" pitchFamily="34" charset="-120"/>
               </a:rPr>
-              <a:t>Regulates gut microbiota and lipid metabolism.</a:t>
+              <a:t>Meta-analysis of existing studies</a:t>
+            </a:r>
+            <a:endParaRPr lang="en-US" sz="1800" dirty="0"/>
+          </a:p>
+          <a:p>
+            <a:pPr marL="342900" indent="-342900">
+              <a:spcAft>
+                <a:spcPts val="800"/>
+              </a:spcAft>
+              <a:buSzPct val="100000"/>
+              <a:buChar char="•"/>
+            </a:pPr>
+            <a:r>
+              <a:rPr lang="en-US" sz="1800" dirty="0">
+                <a:solidFill>
+                  <a:srgbClr val="333333"/>
+                </a:solidFill>
+                <a:latin typeface="Arial" pitchFamily="34" charset="0"/>
+                <a:ea typeface="Arial" pitchFamily="34" charset="-122"/>
+                <a:cs typeface="Arial" pitchFamily="34" charset="-120"/>
+              </a:rPr>
+              <a:t>SII correlates with patient outcomes</a:t>
+            </a:r>
+            <a:endParaRPr lang="en-US" sz="1800" dirty="0"/>
+          </a:p>
+          <a:p>
+            <a:pPr marL="342900" indent="-342900">
+              <a:spcAft>
+                <a:spcPts val="800"/>
+              </a:spcAft>
+              <a:buSzPct val="100000"/>
+              <a:buChar char="•"/>
+            </a:pPr>
+            <a:r>
+              <a:rPr lang="en-US" sz="1800" dirty="0">
+                <a:solidFill>
+                  <a:srgbClr val="333333"/>
+                </a:solidFill>
+                <a:latin typeface="Arial" pitchFamily="34" charset="0"/>
+                <a:ea typeface="Arial" pitchFamily="34" charset="-122"/>
+                <a:cs typeface="Arial" pitchFamily="34" charset="-120"/>
+              </a:rPr>
+              <a:t>Potential biomarker for clinical use</a:t>
             </a:r>
             <a:endParaRPr lang="en-US" sz="1800" dirty="0"/>
           </a:p>
@@ -2597,7 +2639,7 @@
                   <a:srgbClr val="888888"/>
                 </a:solidFill>
               </a:rPr>
-              <a:t>Wang Wei, Niu Xiaoge, Li Shasha et al.. ACS infectious diseases. 2026-06-12 DOI: 10.1021/acsinfecdis.6c00330</a:t>
+              <a:t>P Wang, H Jiang. Frontiers in Oncology. 2026</a:t>
             </a:r>
             <a:endParaRPr lang="en-US" sz="800" dirty="0"/>
           </a:p>
@@ -2797,7 +2839,7 @@
                   </a:extLst>
                 </a:hlinkClick>
               </a:rPr>
-              <a:t>Oxaliplatin triggers adipose and muscle wasting through cancer-independent metabolic and CNS pathways in mouse models.</a:t>
+              <a:t>Awareness of inflammatory bowel disease-associated colorectal cancer risk and its management in patients with inflammatory bowel disease: a systematic review</a:t>
             </a:r>
             <a:endParaRPr lang="en-US" sz="2400" dirty="0"/>
           </a:p>
@@ -2833,7 +2875,7 @@
                   <a:srgbClr val="888888"/>
                 </a:solidFill>
               </a:rPr>
-              <a:t>Communications biology  ·  Basic Research</a:t>
+              <a:t>Crohns &amp; Colitis 360  ·  Systematic Review</a:t>
             </a:r>
             <a:endParaRPr lang="en-US" sz="1000" dirty="0"/>
           </a:p>
@@ -2876,7 +2918,7 @@
                 <a:ea typeface="Arial" pitchFamily="34" charset="-122"/>
                 <a:cs typeface="Arial" pitchFamily="34" charset="-120"/>
               </a:rPr>
-              <a:t>Oxaliplatin induces cachexia-like symptoms in mice.</a:t>
+              <a:t>Limited awareness of cancer risk</a:t>
             </a:r>
             <a:endParaRPr lang="en-US" sz="1800" dirty="0"/>
           </a:p>
@@ -2897,7 +2939,7 @@
                 <a:ea typeface="Arial" pitchFamily="34" charset="-122"/>
                 <a:cs typeface="Arial" pitchFamily="34" charset="-120"/>
               </a:rPr>
-              <a:t>Body mass loss from adipose and muscle wasting.</a:t>
+              <a:t>Need for patient education</a:t>
             </a:r>
             <a:endParaRPr lang="en-US" sz="1800" dirty="0"/>
           </a:p>
@@ -2918,49 +2960,7 @@
                 <a:ea typeface="Arial" pitchFamily="34" charset="-122"/>
                 <a:cs typeface="Arial" pitchFamily="34" charset="-120"/>
               </a:rPr>
-              <a:t>Altered metabolism: decreased intake and activity.</a:t>
-            </a:r>
-            <a:endParaRPr lang="en-US" sz="1800" dirty="0"/>
-          </a:p>
-          <a:p>
-            <a:pPr marL="342900" indent="-342900">
-              <a:spcAft>
-                <a:spcPts val="800"/>
-              </a:spcAft>
-              <a:buSzPct val="100000"/>
-              <a:buChar char="•"/>
-            </a:pPr>
-            <a:r>
-              <a:rPr lang="en-US" sz="1800" dirty="0">
-                <a:solidFill>
-                  <a:srgbClr val="333333"/>
-                </a:solidFill>
-                <a:latin typeface="Arial" pitchFamily="34" charset="0"/>
-                <a:ea typeface="Arial" pitchFamily="34" charset="-122"/>
-                <a:cs typeface="Arial" pitchFamily="34" charset="-120"/>
-              </a:rPr>
-              <a:t>Histological changes: muscle atrophy and immune infiltration.</a:t>
-            </a:r>
-            <a:endParaRPr lang="en-US" sz="1800" dirty="0"/>
-          </a:p>
-          <a:p>
-            <a:pPr marL="342900" indent="-342900">
-              <a:spcAft>
-                <a:spcPts val="800"/>
-              </a:spcAft>
-              <a:buSzPct val="100000"/>
-              <a:buChar char="•"/>
-            </a:pPr>
-            <a:r>
-              <a:rPr lang="en-US" sz="1800" dirty="0">
-                <a:solidFill>
-                  <a:srgbClr val="333333"/>
-                </a:solidFill>
-                <a:latin typeface="Arial" pitchFamily="34" charset="0"/>
-                <a:ea typeface="Arial" pitchFamily="34" charset="-122"/>
-                <a:cs typeface="Arial" pitchFamily="34" charset="-120"/>
-              </a:rPr>
-              <a:t>Metabolic rewiring identified in adipose and muscle.</a:t>
+              <a:t>Lack of comprehensive studies</a:t>
             </a:r>
             <a:endParaRPr lang="en-US" sz="1800" dirty="0"/>
           </a:p>
@@ -2996,7 +2996,7 @@
                   <a:srgbClr val="888888"/>
                 </a:solidFill>
               </a:rPr>
-              <a:t>Du Junwei, Mintz Rachel L, Sudlow Leland C et al.. Communications biology. 2026-06-10 DOI: 10.1038/s42003-026-10441-3</a:t>
+              <a:t>F Khan, C Norton, W Czuber-Dochan. Crohns &amp; Colitis 360. 2026</a:t>
             </a:r>
             <a:endParaRPr lang="en-US" sz="800" dirty="0"/>
           </a:p>
@@ -3196,7 +3196,7 @@
                   </a:extLst>
                 </a:hlinkClick>
               </a:rPr>
-              <a:t>Loss of proton-sensing TDAG8 increases tumor progression in mouse models of colon cancer.</a:t>
+              <a:t>Brominated Flame Retardants: UQCRC1 and NR3C2 as Potential Targets in IBD and CRC.</a:t>
             </a:r>
             <a:endParaRPr lang="en-US" sz="2400" dirty="0"/>
           </a:p>
@@ -3232,7 +3232,7 @@
                   <a:srgbClr val="888888"/>
                 </a:solidFill>
               </a:rPr>
-              <a:t>Molecular oncology  ·  Basic Research</a:t>
+              <a:t>Food and chemical toxicology : an international journal published for the British Industrial Biological Research Association  ·  Basic Research</a:t>
             </a:r>
             <a:endParaRPr lang="en-US" sz="1000" dirty="0"/>
           </a:p>
@@ -3275,7 +3275,7 @@
                 <a:ea typeface="Arial" pitchFamily="34" charset="-122"/>
                 <a:cs typeface="Arial" pitchFamily="34" charset="-120"/>
               </a:rPr>
-              <a:t>TDAG8 loss increases tumor progression.</a:t>
+              <a:t>Brominated flame retardants linked to health risks.</a:t>
             </a:r>
             <a:endParaRPr lang="en-US" sz="1800" dirty="0"/>
           </a:p>
@@ -3296,7 +3296,7 @@
                 <a:ea typeface="Arial" pitchFamily="34" charset="-122"/>
                 <a:cs typeface="Arial" pitchFamily="34" charset="-120"/>
               </a:rPr>
-              <a:t>Increased neutrophils and monocytes in tumors.</a:t>
+              <a:t>Identified UQCRC1 and NR3C2 as core targets.</a:t>
             </a:r>
             <a:endParaRPr lang="en-US" sz="1800" dirty="0"/>
           </a:p>
@@ -3317,7 +3317,7 @@
                 <a:ea typeface="Arial" pitchFamily="34" charset="-122"/>
                 <a:cs typeface="Arial" pitchFamily="34" charset="-120"/>
               </a:rPr>
-              <a:t>AOM/DSS model shows larger tumor size.</a:t>
+              <a:t>Low expression predicts poor prognosis in CRC.</a:t>
             </a:r>
             <a:endParaRPr lang="en-US" sz="1800" dirty="0"/>
           </a:p>
@@ -3338,7 +3338,7 @@
                 <a:ea typeface="Arial" pitchFamily="34" charset="-122"/>
                 <a:cs typeface="Arial" pitchFamily="34" charset="-120"/>
               </a:rPr>
-              <a:t>Elevated macrophages and CD4+/CD8+ ratio.</a:t>
+              <a:t>BFR exposure promotes CRC cell proliferation.</a:t>
             </a:r>
             <a:endParaRPr lang="en-US" sz="1800" dirty="0"/>
           </a:p>
@@ -3359,7 +3359,7 @@
                 <a:ea typeface="Arial" pitchFamily="34" charset="-122"/>
                 <a:cs typeface="Arial" pitchFamily="34" charset="-120"/>
               </a:rPr>
-              <a:t>TDAG8 modulators may aid CRC therapy.</a:t>
+              <a:t>BFR affects intestinal barrier and cytokine levels.</a:t>
             </a:r>
             <a:endParaRPr lang="en-US" sz="1800" dirty="0"/>
           </a:p>
@@ -3395,7 +3395,7 @@
                   <a:srgbClr val="888888"/>
                 </a:solidFill>
               </a:rPr>
-              <a:t>Malagola Ermanno, Illi Yasmine, Bircher Anna et al.. Molecular oncology. 2026-06-10 DOI: 10.1002/1878-0261.70283</a:t>
+              <a:t>Wu Jianhai, Li Haoran, Wu Chongying et al.. Food and chemical toxicology : an international journal published for the British Industrial Biological Research Association. 2026-06-18 DOI: 10.1016/j.fct.2026.116230</a:t>
             </a:r>
             <a:endParaRPr lang="en-US" sz="800" dirty="0"/>
           </a:p>
@@ -3586,7 +3586,7 @@
                   <a:srgbClr val="FFFFFF"/>
                 </a:solidFill>
               </a:rPr>
-              <a:t>### 綜合啟示 (Overall Insights)</a:t>
+              <a:t>### 綜合啟示（Overall Insights）</a:t>
             </a:r>
             <a:endParaRPr lang="en-US" sz="1200" dirty="0"/>
           </a:p>
@@ -3612,7 +3612,7 @@
                   <a:srgbClr val="FFFFFF"/>
                 </a:solidFill>
               </a:rPr>
-              <a:t>1. **腫瘤微環境的角色**  </a:t>
+              <a:t>1. **炎症微環境與腫瘤進展的關聯性**  </a:t>
             </a:r>
             <a:endParaRPr lang="en-US" sz="1200" dirty="0"/>
           </a:p>
@@ -3629,7 +3629,7 @@
                   <a:srgbClr val="FFFFFF"/>
                 </a:solidFill>
               </a:rPr>
-              <a:t>   The studies highlight the significant influence of the tumor microenvironment on colorectal cancer progression and treatment responses.  </a:t>
+              <a:t>   The chronic inflammatory microenvironment plays a crucial role in colorectal cancer (CRC) initiation and progression, highlighting the need for targeted therapies that address inflammation.  </a:t>
             </a:r>
             <a:endParaRPr lang="en-US" sz="1200" dirty="0"/>
           </a:p>
@@ -3646,7 +3646,7 @@
                   <a:srgbClr val="FFFFFF"/>
                 </a:solidFill>
               </a:rPr>
-              <a:t>   這些研究強調腫瘤微環境對結直腸癌進展和治療反應的重要影響。</a:t>
+              <a:t>   慢性炎症微環境在大腸癌（CRC）的發生和進展中扮演著關鍵角色，強調需要針對炎症的治療策略。</a:t>
             </a:r>
             <a:endParaRPr lang="en-US" sz="1200" dirty="0"/>
           </a:p>
@@ -3672,7 +3672,7 @@
                   <a:srgbClr val="FFFFFF"/>
                 </a:solidFill>
               </a:rPr>
-              <a:t>2. **免疫系統的預後指標**  </a:t>
+              <a:t>2. **脂質代謝在腫瘤中的重要性**  </a:t>
             </a:r>
             <a:endParaRPr lang="en-US" sz="1200" dirty="0"/>
           </a:p>
@@ -3689,7 +3689,7 @@
                   <a:srgbClr val="FFFFFF"/>
                 </a:solidFill>
               </a:rPr>
-              <a:t>   The systemic immune-inflammation index (SII) emerges as a promising prognostic biomarker, indicating the interplay between systemic inflammation and cancer outcomes.  </a:t>
+              <a:t>   The accumulation of dietary polyunsaturated fatty acids (PUFAs) in CRC suggests that lipid metabolism is a significant factor in tumor biology, warranting further investigation into its therapeutic implications.  </a:t>
             </a:r>
             <a:endParaRPr lang="en-US" sz="1200" dirty="0"/>
           </a:p>
@@ -3706,7 +3706,7 @@
                   <a:srgbClr val="FFFFFF"/>
                 </a:solidFill>
               </a:rPr>
-              <a:t>   系統性免疫炎症指數（SII）作為一個有前途的預後生物標記，顯示系統性炎症與癌症結果之間的相互作用。</a:t>
+              <a:t>   膳食多不飽和脂肪酸（PUFAs）在CRC中的積累表明脂質代謝在腫瘤生物學中是一個重要因素，值得進一步研究其治療意義。</a:t>
             </a:r>
             <a:endParaRPr lang="en-US" sz="1200" dirty="0"/>
           </a:p>
@@ -3732,7 +3732,7 @@
                   <a:srgbClr val="FFFFFF"/>
                 </a:solidFill>
               </a:rPr>
-              <a:t>3. **益生菌與腸道健康**  </a:t>
+              <a:t>3. **癌症相關成纖維細胞的異質性**  </a:t>
             </a:r>
             <a:endParaRPr lang="en-US" sz="1200" dirty="0"/>
           </a:p>
@@ -3749,7 +3749,7 @@
                   <a:srgbClr val="FFFFFF"/>
                 </a:solidFill>
               </a:rPr>
-              <a:t>   The role of gut microbiota, particularly specific strains like Parasutterella excrementihominis, is crucial in modulating inflammation and cancer risk.  </a:t>
+              <a:t>   The phenotypic plasticity of cancer-associated fibroblasts (CAFs) indicates that different CAF subtypes contribute uniquely to tumor dynamics, suggesting potential targets for intervention.  </a:t>
             </a:r>
             <a:endParaRPr lang="en-US" sz="1200" dirty="0"/>
           </a:p>
@@ -3766,7 +3766,7 @@
                   <a:srgbClr val="FFFFFF"/>
                 </a:solidFill>
               </a:rPr>
-              <a:t>   腸道微生物群的角色，特別是像Parasutterella excrementihominis這樣的特定菌株，在調節炎症和癌症風險中至關重要。</a:t>
+              <a:t>   癌症相關成纖維細胞（CAFs）的表型可塑性表明不同的CAF亞型對腫瘤動態有獨特貢獻，暗示了潛在的干預靶點。</a:t>
             </a:r>
             <a:endParaRPr lang="en-US" sz="1200" dirty="0"/>
           </a:p>
@@ -3792,7 +3792,7 @@
                   <a:srgbClr val="FFFFFF"/>
                 </a:solidFill>
               </a:rPr>
-              <a:t>4. **術後恢復的營養補充**  </a:t>
+              <a:t>4. **系統性免疫-炎症指數的預後價值**  </a:t>
             </a:r>
             <a:endParaRPr lang="en-US" sz="1200" dirty="0"/>
           </a:p>
@@ -3809,7 +3809,7 @@
                   <a:srgbClr val="FFFFFF"/>
                 </a:solidFill>
               </a:rPr>
-              <a:t>   Omega-3 polyunsaturated fatty acids (PUFAs) show potential in enhancing postoperative recovery, suggesting nutritional interventions may improve patient outcomes.  </a:t>
+              <a:t>   The systemic immune-inflammation index (SII) has emerged as a promising prognostic biomarker in CRC, emphasizing the interplay between immune response and cancer outcomes.  </a:t>
             </a:r>
             <a:endParaRPr lang="en-US" sz="1200" dirty="0"/>
           </a:p>
@@ -3826,7 +3826,7 @@
                   <a:srgbClr val="FFFFFF"/>
                 </a:solidFill>
               </a:rPr>
-              <a:t>   Omega-3多不飽和脂肪酸（PUFAs）在增強術後恢復方面顯示出潛力，暗示營養干預可能改善患者結果。</a:t>
+              <a:t>   系統性免疫-炎症指數（SII）已成為CRC中一個有前途的預後生物標誌物，強調免疫反應與癌症結果之間的相互作用。</a:t>
             </a:r>
             <a:endParaRPr lang="en-US" sz="1200" dirty="0"/>
           </a:p>
@@ -3852,7 +3852,7 @@
                   <a:srgbClr val="FFFFFF"/>
                 </a:solidFill>
               </a:rPr>
-              <a:t>5. **炎症性腸病的癌症風險認知**  </a:t>
+              <a:t>5. **新型治療策略的開發**  </a:t>
             </a:r>
             <a:endParaRPr lang="en-US" sz="1200" dirty="0"/>
           </a:p>
@@ -3869,24 +3869,7 @@
                   <a:srgbClr val="FFFFFF"/>
                 </a:solidFill>
               </a:rPr>
-              <a:t>   There is a critical gap in awareness regarding the colorectal cancer risk among patients with inflammatory bowel disease, necessitating further educational initiatives.  </a:t>
-            </a:r>
-            <a:endParaRPr lang="en-US" sz="1200" dirty="0"/>
-          </a:p>
-          <a:p>
-            <a:pPr indent="0" marL="0">
-              <a:lnSpc>
-                <a:spcPct val="150000"/>
-              </a:lnSpc>
-              <a:buNone/>
-            </a:pPr>
-            <a:r>
-              <a:rPr lang="en-US" sz="1200" dirty="0">
-                <a:solidFill>
-                  <a:srgbClr val="FFFFFF"/>
-                </a:solidFill>
-              </a:rPr>
-              <a:t>   在炎症性腸病患者中，對結直腸癌風險的認知存在重要差距，迫切需要進一步的教育措施。</a:t>
+              <a:t>   Innovative approaches, such as engineered bacteria for targeted drug delivery, present new avenues for enhancing therapeutic efficacy in CRC treatment.</a:t>
             </a:r>
             <a:endParaRPr lang="en-US" sz="1200" dirty="0"/>
           </a:p>
@@ -4032,7 +4015,7 @@
                   <a:srgbClr val="FFFFFF"/>
                 </a:solidFill>
               </a:rPr>
-              <a:t>### 未來研究方向 (Future Research Directions)</a:t>
+              <a:t>創新方法，如工程化細菌的靶向藥物遞送，為提高CRC治療的療效提供了新的途徑。</a:t>
             </a:r>
             <a:endParaRPr lang="en-US" sz="1200" dirty="0"/>
           </a:p>
@@ -4058,7 +4041,7 @@
                   <a:srgbClr val="FFFFFF"/>
                 </a:solidFill>
               </a:rPr>
-              <a:t>1. **腫瘤微環境的干預策略**  </a:t>
+              <a:t>### 未來研究方向（Future Research Directions）</a:t>
             </a:r>
             <a:endParaRPr lang="en-US" sz="1200" dirty="0"/>
           </a:p>
@@ -4069,14 +4052,6 @@
               </a:lnSpc>
               <a:buNone/>
             </a:pPr>
-            <a:r>
-              <a:rPr lang="en-US" sz="1200" dirty="0">
-                <a:solidFill>
-                  <a:srgbClr val="FFFFFF"/>
-                </a:solidFill>
-              </a:rPr>
-              <a:t>   Future studies should explore therapeutic strategies targeting the tumor microenvironment to enhance treatment efficacy in colorectal cancer.  </a:t>
-            </a:r>
             <a:endParaRPr lang="en-US" sz="1200" dirty="0"/>
           </a:p>
           <a:p>
@@ -4092,7 +4067,7 @@
                   <a:srgbClr val="FFFFFF"/>
                 </a:solidFill>
               </a:rPr>
-              <a:t>   未來研究應探索針對腫瘤微環境的治療策略，以提高結直腸癌的治療效果。</a:t>
+              <a:t>1. **探索脂質代謝與腫瘤微環境的相互作用**  </a:t>
             </a:r>
             <a:endParaRPr lang="en-US" sz="1200" dirty="0"/>
           </a:p>
@@ -4103,6 +4078,14 @@
               </a:lnSpc>
               <a:buNone/>
             </a:pPr>
+            <a:r>
+              <a:rPr lang="en-US" sz="1200" dirty="0">
+                <a:solidFill>
+                  <a:srgbClr val="FFFFFF"/>
+                </a:solidFill>
+              </a:rPr>
+              <a:t>   Future studies should focus on elucidating the mechanisms by which lipid metabolism influences the tumor microenvironment and its implications for CRC progression.  </a:t>
+            </a:r>
             <a:endParaRPr lang="en-US" sz="1200" dirty="0"/>
           </a:p>
           <a:p>
@@ -4118,7 +4101,7 @@
                   <a:srgbClr val="FFFFFF"/>
                 </a:solidFill>
               </a:rPr>
-              <a:t>2. **免疫炎症指數的應用**  </a:t>
+              <a:t>   未來的研究應集中於闡明脂質代謝如何影響腫瘤微環境及其對CRC進展的影響機制。</a:t>
             </a:r>
             <a:endParaRPr lang="en-US" sz="1200" dirty="0"/>
           </a:p>
@@ -4129,14 +4112,6 @@
               </a:lnSpc>
               <a:buNone/>
             </a:pPr>
-            <a:r>
-              <a:rPr lang="en-US" sz="1200" dirty="0">
-                <a:solidFill>
-                  <a:srgbClr val="FFFFFF"/>
-                </a:solidFill>
-              </a:rPr>
-              <a:t>   Investigating the clinical utility of the systemic immune-inflammation index (SII) in diverse patient populations could refine prognostic assessments.  </a:t>
-            </a:r>
             <a:endParaRPr lang="en-US" sz="1200" dirty="0"/>
           </a:p>
           <a:p>
@@ -4152,7 +4127,7 @@
                   <a:srgbClr val="FFFFFF"/>
                 </a:solidFill>
               </a:rPr>
-              <a:t>   研究系統性免疫炎症指數（SII）在不同患者群體中的臨床應用，可能會完善預後評估。</a:t>
+              <a:t>2. **癌症相關成纖維細胞的功能研究**  </a:t>
             </a:r>
             <a:endParaRPr lang="en-US" sz="1200" dirty="0"/>
           </a:p>
@@ -4163,6 +4138,14 @@
               </a:lnSpc>
               <a:buNone/>
             </a:pPr>
+            <a:r>
+              <a:rPr lang="en-US" sz="1200" dirty="0">
+                <a:solidFill>
+                  <a:srgbClr val="FFFFFF"/>
+                </a:solidFill>
+              </a:rPr>
+              <a:t>   Investigating the functional roles of different CAF subtypes in CRC could reveal novel therapeutic targets and strategies for intervention.  </a:t>
+            </a:r>
             <a:endParaRPr lang="en-US" sz="1200" dirty="0"/>
           </a:p>
           <a:p>
@@ -4178,7 +4161,7 @@
                   <a:srgbClr val="FFFFFF"/>
                 </a:solidFill>
               </a:rPr>
-              <a:t>3. **微生物群與癌症的關聯**  </a:t>
+              <a:t>   研究不同CAF亞型在CRC中的功能角色可能揭示新的治療靶點和干預策略。</a:t>
             </a:r>
             <a:endParaRPr lang="en-US" sz="1200" dirty="0"/>
           </a:p>
@@ -4189,14 +4172,6 @@
               </a:lnSpc>
               <a:buNone/>
             </a:pPr>
-            <a:r>
-              <a:rPr lang="en-US" sz="1200" dirty="0">
-                <a:solidFill>
-                  <a:srgbClr val="FFFFFF"/>
-                </a:solidFill>
-              </a:rPr>
-              <a:t>   Further research is needed to elucidate the mechanisms by which gut microbiota influence inflammation and colorectal cancer development.  </a:t>
-            </a:r>
             <a:endParaRPr lang="en-US" sz="1200" dirty="0"/>
           </a:p>
           <a:p>
@@ -4212,7 +4187,7 @@
                   <a:srgbClr val="FFFFFF"/>
                 </a:solidFill>
               </a:rPr>
-              <a:t>   需要進一步研究以闡明腸道微生物群如何影響炎症和結直腸癌發展的機制。</a:t>
+              <a:t>3. **系統性免疫-炎症指數的臨床應用**  </a:t>
             </a:r>
             <a:endParaRPr lang="en-US" sz="1200" dirty="0"/>
           </a:p>
@@ -4223,6 +4198,14 @@
               </a:lnSpc>
               <a:buNone/>
             </a:pPr>
+            <a:r>
+              <a:rPr lang="en-US" sz="1200" dirty="0">
+                <a:solidFill>
+                  <a:srgbClr val="FFFFFF"/>
+                </a:solidFill>
+              </a:rPr>
+              <a:t>   Further validation of the systemic immune-inflammation index (SII) in diverse CRC populations could enhance its utility as a prognostic tool in clinical settings.  </a:t>
+            </a:r>
             <a:endParaRPr lang="en-US" sz="1200" dirty="0"/>
           </a:p>
           <a:p>
@@ -4238,7 +4221,7 @@
                   <a:srgbClr val="FFFFFF"/>
                 </a:solidFill>
               </a:rPr>
-              <a:t>4. **術後營養干預的長期效果**  </a:t>
+              <a:t>   在不同CRC人群中進一步驗證系統性免疫-炎症指數（SII）可以增強其作為臨床預後工具的實用性。</a:t>
             </a:r>
             <a:endParaRPr lang="en-US" sz="1200" dirty="0"/>
           </a:p>
@@ -4249,14 +4232,6 @@
               </a:lnSpc>
               <a:buNone/>
             </a:pPr>
-            <a:r>
-              <a:rPr lang="en-US" sz="1200" dirty="0">
-                <a:solidFill>
-                  <a:srgbClr val="FFFFFF"/>
-                </a:solidFill>
-              </a:rPr>
-              <a:t>   Longitudinal studies assessing the long-term effects of omega-3 PUFA supplementation on recovery and quality of life in colorectal cancer patients are warranted.  </a:t>
-            </a:r>
             <a:endParaRPr lang="en-US" sz="1200" dirty="0"/>
           </a:p>
           <a:p>
@@ -4272,7 +4247,7 @@
                   <a:srgbClr val="FFFFFF"/>
                 </a:solidFill>
               </a:rPr>
-              <a:t>   需要進行縱向研究，以評估Omega-3 PUFA補充對結直腸癌患者恢復和生活質量的長期影響。</a:t>
+              <a:t>4. **炎症與癌症之間的交互作用**  </a:t>
             </a:r>
             <a:endParaRPr lang="en-US" sz="1200" dirty="0"/>
           </a:p>
@@ -4283,6 +4258,14 @@
               </a:lnSpc>
               <a:buNone/>
             </a:pPr>
+            <a:r>
+              <a:rPr lang="en-US" sz="1200" dirty="0">
+                <a:solidFill>
+                  <a:srgbClr val="FFFFFF"/>
+                </a:solidFill>
+              </a:rPr>
+              <a:t>   More research is needed to understand the complex interactions between inflammation, immune responses, and colorectal carcinogenesis, which may lead to better prevention strategies.  </a:t>
+            </a:r>
             <a:endParaRPr lang="en-US" sz="1200" dirty="0"/>
           </a:p>
           <a:p>
@@ -4298,7 +4281,7 @@
                   <a:srgbClr val="FFFFFF"/>
                 </a:solidFill>
               </a:rPr>
-              <a:t>5. **增強患者教育與風險管理**  </a:t>
+              <a:t>   需要更多研究來理解炎症、免疫反應與大腸癌發生之間的複雜相互作用，這可能導致更好的預防策略。</a:t>
             </a:r>
             <a:endParaRPr lang="en-US" sz="1200" dirty="0"/>
           </a:p>
@@ -4309,14 +4292,6 @@
               </a:lnSpc>
               <a:buNone/>
             </a:pPr>
-            <a:r>
-              <a:rPr lang="en-US" sz="1200" dirty="0">
-                <a:solidFill>
-                  <a:srgbClr val="FFFFFF"/>
-                </a:solidFill>
-              </a:rPr>
-              <a:t>   Developing targeted educational programs for patients with inflammatory bowel disease regarding their cancer risks and management strategies is essential.  </a:t>
-            </a:r>
             <a:endParaRPr lang="en-US" sz="1200" dirty="0"/>
           </a:p>
           <a:p>
@@ -4332,7 +4307,41 @@
                   <a:srgbClr val="FFFFFF"/>
                 </a:solidFill>
               </a:rPr>
-              <a:t>   為炎症性腸病患者制定針對性的教育計劃，讓他們了解癌症風險和管理策略是至關重要的。</a:t>
+              <a:t>5. **新型治療平台的開發與評估**  </a:t>
+            </a:r>
+            <a:endParaRPr lang="en-US" sz="1200" dirty="0"/>
+          </a:p>
+          <a:p>
+            <a:pPr indent="0" marL="0">
+              <a:lnSpc>
+                <a:spcPct val="150000"/>
+              </a:lnSpc>
+              <a:buNone/>
+            </a:pPr>
+            <a:r>
+              <a:rPr lang="en-US" sz="1200" dirty="0">
+                <a:solidFill>
+                  <a:srgbClr val="FFFFFF"/>
+                </a:solidFill>
+              </a:rPr>
+              <a:t>   The development and evaluation of novel therapeutic platforms, such as engineered bacteria and nanotechnology, could revolutionize treatment approaches for CRC.  </a:t>
+            </a:r>
+            <a:endParaRPr lang="en-US" sz="1200" dirty="0"/>
+          </a:p>
+          <a:p>
+            <a:pPr indent="0" marL="0">
+              <a:lnSpc>
+                <a:spcPct val="150000"/>
+              </a:lnSpc>
+              <a:buNone/>
+            </a:pPr>
+            <a:r>
+              <a:rPr lang="en-US" sz="1200" dirty="0">
+                <a:solidFill>
+                  <a:srgbClr val="FFFFFF"/>
+                </a:solidFill>
+              </a:rPr>
+              <a:t>   新型治療平台的開發與評估，如工程化細菌和納米技術，可能會徹底改變CRC的治療方法。</a:t>
             </a:r>
             <a:endParaRPr lang="en-US" sz="1200" dirty="0"/>
           </a:p>
@@ -4603,7 +4612,7 @@
                 <a:ea typeface="Arial" pitchFamily="34" charset="-122"/>
                 <a:cs typeface="Arial" pitchFamily="34" charset="-120"/>
               </a:rPr>
-              <a:t>Parasutterella excrementihominis exacerbates experimental colitis and colitis-as…</a:t>
+              <a:t>Extrinsic lipids are absorbed and accumulate in colorectal cancer.</a:t>
             </a:r>
             <a:endParaRPr lang="en-US" sz="1400" dirty="0"/>
           </a:p>
@@ -4640,7 +4649,7 @@
                 <a:ea typeface="Arial" pitchFamily="34" charset="-122"/>
                 <a:cs typeface="Arial" pitchFamily="34" charset="-120"/>
               </a:rPr>
-              <a:t>Prognostic value of systemic immune-inflammation index for colorectal cancer: a …</a:t>
+              <a:t>Parasutterella excrementihominis exacerbates experimental colitis and colitis-as…</a:t>
             </a:r>
             <a:endParaRPr lang="en-US" sz="1400" dirty="0"/>
           </a:p>
@@ -4677,7 +4686,7 @@
                 <a:ea typeface="Arial" pitchFamily="34" charset="-122"/>
                 <a:cs typeface="Arial" pitchFamily="34" charset="-120"/>
               </a:rPr>
-              <a:t>The Role of Omega-3 Polyunsaturated Fatty Acid Supplementation in Postoperative …</a:t>
+              <a:t>PI3K and MAPK Signaling Nodes Serve as Divergent Drivers of Phenotypic Plasticit…</a:t>
             </a:r>
             <a:endParaRPr lang="en-US" sz="1400" dirty="0"/>
           </a:p>
@@ -4714,7 +4723,7 @@
                 <a:ea typeface="Arial" pitchFamily="34" charset="-122"/>
                 <a:cs typeface="Arial" pitchFamily="34" charset="-120"/>
               </a:rPr>
-              <a:t>Awareness of inflammatory bowel disease-associated colorectal cancer risk and it…</a:t>
+              <a:t>Integrin CD11b/CD18 reprograms macrophage polarization by suppressing ERK/STAT3 …</a:t>
             </a:r>
             <a:endParaRPr lang="en-US" sz="1400" dirty="0"/>
           </a:p>
@@ -4751,7 +4760,7 @@
                 <a:ea typeface="Arial" pitchFamily="34" charset="-122"/>
                 <a:cs typeface="Arial" pitchFamily="34" charset="-120"/>
               </a:rPr>
-              <a:t>ACAT1-mediated lactylation reprogramming governs immune-stromal crosstalk in ulc…</a:t>
+              <a:t>Engineered Salmonella delivering the NMDAR antagonist conantokin G synergizes wi…</a:t>
             </a:r>
             <a:endParaRPr lang="en-US" sz="1400" dirty="0"/>
           </a:p>
@@ -4788,7 +4797,7 @@
                 <a:ea typeface="Arial" pitchFamily="34" charset="-122"/>
                 <a:cs typeface="Arial" pitchFamily="34" charset="-120"/>
               </a:rPr>
-              <a:t>Indole-3-acetic acid promotes differentiation while suppressing proliferation in…</a:t>
+              <a:t>Harnessing Tolypothrix sp. A-8 for biogenic synthesis of silver oxide nanopartic…</a:t>
             </a:r>
             <a:endParaRPr lang="en-US" sz="1400" dirty="0"/>
           </a:p>
@@ -4825,7 +4834,7 @@
                 <a:ea typeface="Arial" pitchFamily="34" charset="-122"/>
                 <a:cs typeface="Arial" pitchFamily="34" charset="-120"/>
               </a:rPr>
-              <a:t>Efavirenz Mitigates Dyslipidemia and Attenuates Ulcerative Colitis through Gut M…</a:t>
+              <a:t>Prognostic value of systemic immune-inflammation index for colorectal cancer: a …</a:t>
             </a:r>
             <a:endParaRPr lang="en-US" sz="1400" dirty="0"/>
           </a:p>
@@ -4862,7 +4871,7 @@
                 <a:ea typeface="Arial" pitchFamily="34" charset="-122"/>
                 <a:cs typeface="Arial" pitchFamily="34" charset="-120"/>
               </a:rPr>
-              <a:t>Oxaliplatin triggers adipose and muscle wasting through cancer-independent metab…</a:t>
+              <a:t>Awareness of inflammatory bowel disease-associated colorectal cancer risk and it…</a:t>
             </a:r>
             <a:endParaRPr lang="en-US" sz="1400" dirty="0"/>
           </a:p>
@@ -4899,7 +4908,7 @@
                 <a:ea typeface="Arial" pitchFamily="34" charset="-122"/>
                 <a:cs typeface="Arial" pitchFamily="34" charset="-120"/>
               </a:rPr>
-              <a:t>Loss of proton-sensing TDAG8 increases tumor progression in mouse models of colo…</a:t>
+              <a:t>Brominated Flame Retardants: UQCRC1 and NR3C2 as Potential Targets in IBD and CR…</a:t>
             </a:r>
             <a:endParaRPr lang="en-US" sz="1400" dirty="0"/>
           </a:p>
@@ -5133,7 +5142,7 @@
                 <a:ea typeface="Arial" pitchFamily="34" charset="-122"/>
                 <a:cs typeface="Arial" pitchFamily="34" charset="-120"/>
               </a:rPr>
-              <a:t>Cytoreductive surgery evaluated in study</a:t>
+              <a:t>ORCHESTRA trial evaluates debulking surgery</a:t>
             </a:r>
             <a:endParaRPr lang="en-US" sz="1800" dirty="0"/>
           </a:p>
@@ -5154,7 +5163,7 @@
                 <a:ea typeface="Arial" pitchFamily="34" charset="-122"/>
                 <a:cs typeface="Arial" pitchFamily="34" charset="-120"/>
               </a:rPr>
-              <a:t>Hyperthermic intraperitoneal chemotherapy used</a:t>
+              <a:t>Focus on metastatic colorectal cancer patients</a:t>
             </a:r>
             <a:endParaRPr lang="en-US" sz="1800" dirty="0"/>
           </a:p>
@@ -5175,7 +5184,7 @@
                 <a:ea typeface="Arial" pitchFamily="34" charset="-122"/>
                 <a:cs typeface="Arial" pitchFamily="34" charset="-120"/>
               </a:rPr>
-              <a:t>Comparison with surgery alone</a:t>
+              <a:t>Results show limited survival benefits</a:t>
             </a:r>
             <a:endParaRPr lang="en-US" sz="1800" dirty="0"/>
           </a:p>
@@ -5196,7 +5205,7 @@
                 <a:ea typeface="Arial" pitchFamily="34" charset="-122"/>
                 <a:cs typeface="Arial" pitchFamily="34" charset="-120"/>
               </a:rPr>
-              <a:t>Focus on colorectal peritoneal metastases</a:t>
+              <a:t>Concerns over surgical complications</a:t>
             </a:r>
             <a:endParaRPr lang="en-US" sz="1800" dirty="0"/>
           </a:p>
@@ -5217,7 +5226,7 @@
                 <a:ea typeface="Arial" pitchFamily="34" charset="-122"/>
                 <a:cs typeface="Arial" pitchFamily="34" charset="-120"/>
               </a:rPr>
-              <a:t>Multicentre, randomised trial design</a:t>
+              <a:t>Need for alternative treatment strategies</a:t>
             </a:r>
             <a:endParaRPr lang="en-US" sz="1800" dirty="0"/>
           </a:p>
@@ -5453,7 +5462,7 @@
                   </a:extLst>
                 </a:hlinkClick>
               </a:rPr>
-              <a:t>Parasutterella excrementihominis exacerbates experimental colitis and colitis-associated colorectal cancer via pathogenic NETosis activation</a:t>
+              <a:t>Extrinsic lipids are absorbed and accumulate in colorectal cancer.</a:t>
             </a:r>
             <a:endParaRPr lang="en-US" sz="2400" dirty="0"/>
           </a:p>
@@ -5532,7 +5541,7 @@
                 <a:ea typeface="Arial" pitchFamily="34" charset="-122"/>
                 <a:cs typeface="Arial" pitchFamily="34" charset="-120"/>
               </a:rPr>
-              <a:t>Parasutterella excrementihominis role in colitis</a:t>
+              <a:t>Colorectal cancer shows increased PUFAs uptake.</a:t>
             </a:r>
             <a:endParaRPr lang="en-US" sz="1800" dirty="0"/>
           </a:p>
@@ -5553,7 +5562,7 @@
                 <a:ea typeface="Arial" pitchFamily="34" charset="-122"/>
                 <a:cs typeface="Arial" pitchFamily="34" charset="-120"/>
               </a:rPr>
-              <a:t>NETosis activation linked to inflammation</a:t>
+              <a:t>Extrinsic long chain PUFAs accumulate in tumors.</a:t>
             </a:r>
             <a:endParaRPr lang="en-US" sz="1800" dirty="0"/>
           </a:p>
@@ -5574,7 +5583,49 @@
                 <a:ea typeface="Arial" pitchFamily="34" charset="-122"/>
                 <a:cs typeface="Arial" pitchFamily="34" charset="-120"/>
               </a:rPr>
-              <a:t>Implications for colorectal cancer therapy</a:t>
+              <a:t>FA absorption linked to tumor progression.</a:t>
+            </a:r>
+            <a:endParaRPr lang="en-US" sz="1800" dirty="0"/>
+          </a:p>
+          <a:p>
+            <a:pPr marL="342900" indent="-342900">
+              <a:spcAft>
+                <a:spcPts val="800"/>
+              </a:spcAft>
+              <a:buSzPct val="100000"/>
+              <a:buChar char="•"/>
+            </a:pPr>
+            <a:r>
+              <a:rPr lang="en-US" sz="1800" dirty="0">
+                <a:solidFill>
+                  <a:srgbClr val="333333"/>
+                </a:solidFill>
+                <a:latin typeface="Arial" pitchFamily="34" charset="0"/>
+                <a:ea typeface="Arial" pitchFamily="34" charset="-122"/>
+                <a:cs typeface="Arial" pitchFamily="34" charset="-120"/>
+              </a:rPr>
+              <a:t>Microbiome absence reduces tumor development.</a:t>
+            </a:r>
+            <a:endParaRPr lang="en-US" sz="1800" dirty="0"/>
+          </a:p>
+          <a:p>
+            <a:pPr marL="342900" indent="-342900">
+              <a:spcAft>
+                <a:spcPts val="800"/>
+              </a:spcAft>
+              <a:buSzPct val="100000"/>
+              <a:buChar char="•"/>
+            </a:pPr>
+            <a:r>
+              <a:rPr lang="en-US" sz="1800" dirty="0">
+                <a:solidFill>
+                  <a:srgbClr val="333333"/>
+                </a:solidFill>
+                <a:latin typeface="Arial" pitchFamily="34" charset="0"/>
+                <a:ea typeface="Arial" pitchFamily="34" charset="-122"/>
+                <a:cs typeface="Arial" pitchFamily="34" charset="-120"/>
+              </a:rPr>
+              <a:t>Targeting FA pathways may offer new therapies.</a:t>
             </a:r>
             <a:endParaRPr lang="en-US" sz="1800" dirty="0"/>
           </a:p>
@@ -5610,7 +5661,7 @@
                   <a:srgbClr val="888888"/>
                 </a:solidFill>
               </a:rPr>
-              <a:t>H Tan, L Huang, J Wang. Gut. 2026</a:t>
+              <a:t>Janssen Klaus Peter, Basic Marijana, Bolsega Silvia et al.. Gut. 2026-06-17 DOI: 10.1136/gutjnl-2025-336377</a:t>
             </a:r>
             <a:endParaRPr lang="en-US" sz="800" dirty="0"/>
           </a:p>
@@ -5810,7 +5861,7 @@
                   </a:extLst>
                 </a:hlinkClick>
               </a:rPr>
-              <a:t>Prognostic value of systemic immune-inflammation index for colorectal cancer: a systematic review and meta-analysis</a:t>
+              <a:t>Parasutterella excrementihominis exacerbates experimental colitis and colitis-associated colorectal cancer via pathogenic NETosis activation</a:t>
             </a:r>
             <a:endParaRPr lang="en-US" sz="2400" dirty="0"/>
           </a:p>
@@ -5846,7 +5897,7 @@
                   <a:srgbClr val="888888"/>
                 </a:solidFill>
               </a:rPr>
-              <a:t>Frontiers in Oncology  ·  Meta-Analysis</a:t>
+              <a:t>Gut  ·  IF 24.5</a:t>
             </a:r>
             <a:endParaRPr lang="en-US" sz="1000" dirty="0"/>
           </a:p>
@@ -5889,7 +5940,7 @@
                 <a:ea typeface="Arial" pitchFamily="34" charset="-122"/>
                 <a:cs typeface="Arial" pitchFamily="34" charset="-120"/>
               </a:rPr>
-              <a:t>Systemic immune-inflammation index (SII) evaluated</a:t>
+              <a:t>P. excrementihominis worsens colitis severity.</a:t>
             </a:r>
             <a:endParaRPr lang="en-US" sz="1800" dirty="0"/>
           </a:p>
@@ -5910,7 +5961,7 @@
                 <a:ea typeface="Arial" pitchFamily="34" charset="-122"/>
                 <a:cs typeface="Arial" pitchFamily="34" charset="-120"/>
               </a:rPr>
-              <a:t>Prognostic significance in colorectal cancer</a:t>
+              <a:t>NETosis activation linked to cancer progression.</a:t>
             </a:r>
             <a:endParaRPr lang="en-US" sz="1800" dirty="0"/>
           </a:p>
@@ -5931,49 +5982,7 @@
                 <a:ea typeface="Arial" pitchFamily="34" charset="-122"/>
                 <a:cs typeface="Arial" pitchFamily="34" charset="-120"/>
               </a:rPr>
-              <a:t>Meta-analysis of existing studies</a:t>
-            </a:r>
-            <a:endParaRPr lang="en-US" sz="1800" dirty="0"/>
-          </a:p>
-          <a:p>
-            <a:pPr marL="342900" indent="-342900">
-              <a:spcAft>
-                <a:spcPts val="800"/>
-              </a:spcAft>
-              <a:buSzPct val="100000"/>
-              <a:buChar char="•"/>
-            </a:pPr>
-            <a:r>
-              <a:rPr lang="en-US" sz="1800" dirty="0">
-                <a:solidFill>
-                  <a:srgbClr val="333333"/>
-                </a:solidFill>
-                <a:latin typeface="Arial" pitchFamily="34" charset="0"/>
-                <a:ea typeface="Arial" pitchFamily="34" charset="-122"/>
-                <a:cs typeface="Arial" pitchFamily="34" charset="-120"/>
-              </a:rPr>
-              <a:t>SII correlates with patient outcomes</a:t>
-            </a:r>
-            <a:endParaRPr lang="en-US" sz="1800" dirty="0"/>
-          </a:p>
-          <a:p>
-            <a:pPr marL="342900" indent="-342900">
-              <a:spcAft>
-                <a:spcPts val="800"/>
-              </a:spcAft>
-              <a:buSzPct val="100000"/>
-              <a:buChar char="•"/>
-            </a:pPr>
-            <a:r>
-              <a:rPr lang="en-US" sz="1800" dirty="0">
-                <a:solidFill>
-                  <a:srgbClr val="333333"/>
-                </a:solidFill>
-                <a:latin typeface="Arial" pitchFamily="34" charset="0"/>
-                <a:ea typeface="Arial" pitchFamily="34" charset="-122"/>
-                <a:cs typeface="Arial" pitchFamily="34" charset="-120"/>
-              </a:rPr>
-              <a:t>Potential for clinical application</a:t>
+              <a:t>Study suggests new therapeutic strategies.</a:t>
             </a:r>
             <a:endParaRPr lang="en-US" sz="1800" dirty="0"/>
           </a:p>
@@ -6009,7 +6018,7 @@
                   <a:srgbClr val="888888"/>
                 </a:solidFill>
               </a:rPr>
-              <a:t>P Wang, H Jiang. Frontiers in Oncology. 2026</a:t>
+              <a:t>H Tan, L Huang, J Wang. Gut. 2026</a:t>
             </a:r>
             <a:endParaRPr lang="en-US" sz="800" dirty="0"/>
           </a:p>
@@ -6209,7 +6218,7 @@
                   </a:extLst>
                 </a:hlinkClick>
               </a:rPr>
-              <a:t>The Role of Omega-3 Polyunsaturated Fatty Acid Supplementation in Postoperative Recovery of Colorectal Cancer: Systematic Review and Meta-Analysis</a:t>
+              <a:t>PI3K and MAPK Signaling Nodes Serve as Divergent Drivers of Phenotypic Plasticity in Cancer-Associated Fibroblasts in Colorectal Cancer.</a:t>
             </a:r>
             <a:endParaRPr lang="en-US" sz="2400" dirty="0"/>
           </a:p>
@@ -6245,7 +6254,7 @@
                   <a:srgbClr val="888888"/>
                 </a:solidFill>
               </a:rPr>
-              <a:t>Nutrients  ·  Meta-Analysis</a:t>
+              <a:t>Cancer research  ·  IF 12.7  ·  Basic Research</a:t>
             </a:r>
             <a:endParaRPr lang="en-US" sz="1000" dirty="0"/>
           </a:p>
@@ -6288,7 +6297,7 @@
                 <a:ea typeface="Arial" pitchFamily="34" charset="-122"/>
                 <a:cs typeface="Arial" pitchFamily="34" charset="-120"/>
               </a:rPr>
-              <a:t>Omega-3 PUFAs aid postoperative recovery.</a:t>
+              <a:t>CAF phenotypic heterogeneity impacts tumor progression.</a:t>
             </a:r>
             <a:endParaRPr lang="en-US" sz="1800" dirty="0"/>
           </a:p>
@@ -6309,7 +6318,7 @@
                 <a:ea typeface="Arial" pitchFamily="34" charset="-122"/>
                 <a:cs typeface="Arial" pitchFamily="34" charset="-120"/>
               </a:rPr>
-              <a:t>Modulate inflammatory cytokines effectively.</a:t>
+              <a:t>PI3K/mTOR and MAPK/ERK pathways drive CAF subtypes.</a:t>
             </a:r>
             <a:endParaRPr lang="en-US" sz="1800" dirty="0"/>
           </a:p>
@@ -6330,7 +6339,49 @@
                 <a:ea typeface="Arial" pitchFamily="34" charset="-122"/>
                 <a:cs typeface="Arial" pitchFamily="34" charset="-120"/>
               </a:rPr>
-              <a:t>Inverse association with pro-inflammatory markers.</a:t>
+              <a:t>iCAF promotes tumor growth via cytokine secretion.</a:t>
+            </a:r>
+            <a:endParaRPr lang="en-US" sz="1800" dirty="0"/>
+          </a:p>
+          <a:p>
+            <a:pPr marL="342900" indent="-342900">
+              <a:spcAft>
+                <a:spcPts val="800"/>
+              </a:spcAft>
+              <a:buSzPct val="100000"/>
+              <a:buChar char="•"/>
+            </a:pPr>
+            <a:r>
+              <a:rPr lang="en-US" sz="1800" dirty="0">
+                <a:solidFill>
+                  <a:srgbClr val="333333"/>
+                </a:solidFill>
+                <a:latin typeface="Arial" pitchFamily="34" charset="0"/>
+                <a:ea typeface="Arial" pitchFamily="34" charset="-122"/>
+                <a:cs typeface="Arial" pitchFamily="34" charset="-120"/>
+              </a:rPr>
+              <a:t>myCAF enhances ECM production and tumor colony formation.</a:t>
+            </a:r>
+            <a:endParaRPr lang="en-US" sz="1800" dirty="0"/>
+          </a:p>
+          <a:p>
+            <a:pPr marL="342900" indent="-342900">
+              <a:spcAft>
+                <a:spcPts val="800"/>
+              </a:spcAft>
+              <a:buSzPct val="100000"/>
+              <a:buChar char="•"/>
+            </a:pPr>
+            <a:r>
+              <a:rPr lang="en-US" sz="1800" dirty="0">
+                <a:solidFill>
+                  <a:srgbClr val="333333"/>
+                </a:solidFill>
+                <a:latin typeface="Arial" pitchFamily="34" charset="0"/>
+                <a:ea typeface="Arial" pitchFamily="34" charset="-122"/>
+                <a:cs typeface="Arial" pitchFamily="34" charset="-120"/>
+              </a:rPr>
+              <a:t>Targeted therapies influence CAF plasticity in CRC.</a:t>
             </a:r>
             <a:endParaRPr lang="en-US" sz="1800" dirty="0"/>
           </a:p>
@@ -6366,7 +6417,7 @@
                   <a:srgbClr val="888888"/>
                 </a:solidFill>
               </a:rPr>
-              <a:t>H Li, Z Xu, Y Chen. Nutrients. 2026</a:t>
+              <a:t>Xia Zihan, De Vuyst Felix, Ernst Sam et al.. Cancer research. 2026-06-15 DOI: 10.1158/0008-5472.CAN-25-0766</a:t>
             </a:r>
             <a:endParaRPr lang="en-US" sz="800" dirty="0"/>
           </a:p>
@@ -6566,7 +6617,7 @@
                   </a:extLst>
                 </a:hlinkClick>
               </a:rPr>
-              <a:t>Awareness of inflammatory bowel disease-associated colorectal cancer risk and its management in patients with inflammatory bowel disease: a systematic review</a:t>
+              <a:t>Integrin CD11b/CD18 reprograms macrophage polarization by suppressing ERK/STAT3 signaling to enhance antitumor immunity in colitis-associated colorectal cancer.</a:t>
             </a:r>
             <a:endParaRPr lang="en-US" sz="2400" dirty="0"/>
           </a:p>
@@ -6602,7 +6653,7 @@
                   <a:srgbClr val="888888"/>
                 </a:solidFill>
               </a:rPr>
-              <a:t>Crohns &amp; Colitis 360  ·  Systematic Review</a:t>
+              <a:t>Journal for immunotherapy of cancer  ·  IF 10.9  ·  Basic Research</a:t>
             </a:r>
             <a:endParaRPr lang="en-US" sz="1000" dirty="0"/>
           </a:p>
@@ -6645,7 +6696,7 @@
                 <a:ea typeface="Arial" pitchFamily="34" charset="-122"/>
                 <a:cs typeface="Arial" pitchFamily="34" charset="-120"/>
               </a:rPr>
-              <a:t>Limited awareness of colorectal cancer risk</a:t>
+              <a:t>CD11b/CD18 regulates macrophage polarization.</a:t>
             </a:r>
             <a:endParaRPr lang="en-US" sz="1800" dirty="0"/>
           </a:p>
@@ -6666,7 +6717,7 @@
                 <a:ea typeface="Arial" pitchFamily="34" charset="-122"/>
                 <a:cs typeface="Arial" pitchFamily="34" charset="-120"/>
               </a:rPr>
-              <a:t>Need for better management strategies</a:t>
+              <a:t>Deficiency exacerbates tumor progression in CAC.</a:t>
             </a:r>
             <a:endParaRPr lang="en-US" sz="1800" dirty="0"/>
           </a:p>
@@ -6687,7 +6738,7 @@
                 <a:ea typeface="Arial" pitchFamily="34" charset="-122"/>
                 <a:cs typeface="Arial" pitchFamily="34" charset="-120"/>
               </a:rPr>
-              <a:t>Insufficient research on patient knowledge</a:t>
+              <a:t>TAN-TAM crosstalk influences tumor immunity.</a:t>
             </a:r>
             <a:endParaRPr lang="en-US" sz="1800" dirty="0"/>
           </a:p>
@@ -6723,7 +6774,7 @@
                   <a:srgbClr val="888888"/>
                 </a:solidFill>
               </a:rPr>
-              <a:t>F Khan, C Norton, W Czuber-Dochan. Crohns &amp; Colitis 360. 2026</a:t>
+              <a:t>Lin Ying, Liu Yuan-Kun, Mi Peng et al.. Journal for immunotherapy of cancer. 2026-06-18 DOI: 10.1136/jitc-2025-014026</a:t>
             </a:r>
             <a:endParaRPr lang="en-US" sz="800" dirty="0"/>
           </a:p>
@@ -6923,7 +6974,7 @@
                   </a:extLst>
                 </a:hlinkClick>
               </a:rPr>
-              <a:t>ACAT1-mediated lactylation reprogramming governs immune-stromal crosstalk in ulcerative colitis.</a:t>
+              <a:t>Engineered Salmonella delivering the NMDAR antagonist conantokin G synergizes with PD-L1 blockade to enhance colorectal cancer regression.</a:t>
             </a:r>
             <a:endParaRPr lang="en-US" sz="2400" dirty="0"/>
           </a:p>
@@ -6959,7 +7010,7 @@
                   <a:srgbClr val="888888"/>
                 </a:solidFill>
               </a:rPr>
-              <a:t>International immunopharmacology  ·  Basic Research</a:t>
+              <a:t>Experimental hematology &amp; oncology  ·  Basic Research  ·  🌏 Asia</a:t>
             </a:r>
             <a:endParaRPr lang="en-US" sz="1000" dirty="0"/>
           </a:p>
@@ -7002,7 +7053,7 @@
                 <a:ea typeface="Arial" pitchFamily="34" charset="-122"/>
                 <a:cs typeface="Arial" pitchFamily="34" charset="-120"/>
               </a:rPr>
-              <a:t>ACAT1 identified as key lactylation gene.</a:t>
+              <a:t>Engineered Salmonella targets tumors effectively.</a:t>
             </a:r>
             <a:endParaRPr lang="en-US" sz="1800" dirty="0"/>
           </a:p>
@@ -7023,7 +7074,7 @@
                 <a:ea typeface="Arial" pitchFamily="34" charset="-122"/>
                 <a:cs typeface="Arial" pitchFamily="34" charset="-120"/>
               </a:rPr>
-              <a:t>Lactylation affects immune-stromal interactions.</a:t>
+              <a:t>Conantokin G induces colorectal cancer cell death.</a:t>
             </a:r>
             <a:endParaRPr lang="en-US" sz="1800" dirty="0"/>
           </a:p>
@@ -7044,7 +7095,7 @@
                 <a:ea typeface="Arial" pitchFamily="34" charset="-122"/>
                 <a:cs typeface="Arial" pitchFamily="34" charset="-120"/>
               </a:rPr>
-              <a:t>Sulfasalazine shows potential targeting ACAT1.</a:t>
+              <a:t>Combination with PD-L1 blockade enhances treatment.</a:t>
             </a:r>
             <a:endParaRPr lang="en-US" sz="1800" dirty="0"/>
           </a:p>
@@ -7080,7 +7131,7 @@
                   <a:srgbClr val="888888"/>
                 </a:solidFill>
               </a:rPr>
-              <a:t>Yan Jiayu, Lin Shanshan, Chen Zhuosi et al.. International immunopharmacology. 2026-04-23 DOI: 10.1016/j.intimp.2026.116626</a:t>
+              <a:t>Kim Solbi, Kang Sora, Kim Eunji et al.. Experimental hematology &amp; oncology. 2026-06-16 DOI: 10.1186/s40164-026-00794-0</a:t>
             </a:r>
             <a:endParaRPr lang="en-US" sz="800" dirty="0"/>
           </a:p>
@@ -7280,7 +7331,7 @@
                   </a:extLst>
                 </a:hlinkClick>
               </a:rPr>
-              <a:t>Indole-3-acetic acid promotes differentiation while suppressing proliferation in human intestinal epithelial cells.</a:t>
+              <a:t>Harnessing Tolypothrix sp. A-8 for biogenic synthesis of silver oxide nanoparticles (AgONPs) for multifunctional biomedical applications.</a:t>
             </a:r>
             <a:endParaRPr lang="en-US" sz="2400" dirty="0"/>
           </a:p>
@@ -7316,7 +7367,7 @@
                   <a:srgbClr val="888888"/>
                 </a:solidFill>
               </a:rPr>
-              <a:t>Human cell  ·  Basic Research</a:t>
+              <a:t>Discover nano  ·  🌏 Asia</a:t>
             </a:r>
             <a:endParaRPr lang="en-US" sz="1000" dirty="0"/>
           </a:p>
@@ -7359,7 +7410,7 @@
                 <a:ea typeface="Arial" pitchFamily="34" charset="-122"/>
                 <a:cs typeface="Arial" pitchFamily="34" charset="-120"/>
               </a:rPr>
-              <a:t>IAA influences intestinal epithelial cells' biology.</a:t>
+              <a:t>Phyco-synthesis of AgONPs using Tolypothrix sp. A-8</a:t>
             </a:r>
             <a:endParaRPr lang="en-US" sz="1800" dirty="0"/>
           </a:p>
@@ -7380,7 +7431,7 @@
                 <a:ea typeface="Arial" pitchFamily="34" charset="-122"/>
                 <a:cs typeface="Arial" pitchFamily="34" charset="-120"/>
               </a:rPr>
-              <a:t>Higher IAA concentrations reduce cell viability.</a:t>
+              <a:t>Significant anti-leishmanial activity demonstrated</a:t>
             </a:r>
             <a:endParaRPr lang="en-US" sz="1800" dirty="0"/>
           </a:p>
@@ -7401,7 +7452,49 @@
                 <a:ea typeface="Arial" pitchFamily="34" charset="-122"/>
                 <a:cs typeface="Arial" pitchFamily="34" charset="-120"/>
               </a:rPr>
-              <a:t>IAA promotes differentiation and epithelial repair.</a:t>
+              <a:t>Notable antioxidant and anti-inflammatory potential</a:t>
+            </a:r>
+            <a:endParaRPr lang="en-US" sz="1800" dirty="0"/>
+          </a:p>
+          <a:p>
+            <a:pPr marL="342900" indent="-342900">
+              <a:spcAft>
+                <a:spcPts val="800"/>
+              </a:spcAft>
+              <a:buSzPct val="100000"/>
+              <a:buChar char="•"/>
+            </a:pPr>
+            <a:r>
+              <a:rPr lang="en-US" sz="1800" dirty="0">
+                <a:solidFill>
+                  <a:srgbClr val="333333"/>
+                </a:solidFill>
+                <a:latin typeface="Arial" pitchFamily="34" charset="0"/>
+                <a:ea typeface="Arial" pitchFamily="34" charset="-122"/>
+                <a:cs typeface="Arial" pitchFamily="34" charset="-120"/>
+              </a:rPr>
+              <a:t>High biocompatibility with low hemolysis rates</a:t>
+            </a:r>
+            <a:endParaRPr lang="en-US" sz="1800" dirty="0"/>
+          </a:p>
+          <a:p>
+            <a:pPr marL="342900" indent="-342900">
+              <a:spcAft>
+                <a:spcPts val="800"/>
+              </a:spcAft>
+              <a:buSzPct val="100000"/>
+              <a:buChar char="•"/>
+            </a:pPr>
+            <a:r>
+              <a:rPr lang="en-US" sz="1800" dirty="0">
+                <a:solidFill>
+                  <a:srgbClr val="333333"/>
+                </a:solidFill>
+                <a:latin typeface="Arial" pitchFamily="34" charset="0"/>
+                <a:ea typeface="Arial" pitchFamily="34" charset="-122"/>
+                <a:cs typeface="Arial" pitchFamily="34" charset="-120"/>
+              </a:rPr>
+              <a:t>Potential applications in nanotherapeutics and wound healing</a:t>
             </a:r>
             <a:endParaRPr lang="en-US" sz="1800" dirty="0"/>
           </a:p>
@@ -7437,7 +7530,7 @@
                   <a:srgbClr val="888888"/>
                 </a:solidFill>
               </a:rPr>
-              <a:t>Mallardo Marta, Memon Furqan, Pagliaro Raffaella et al.. Human cell. 2026-06-12 DOI: 10.1007/s13577-026-01397-x</a:t>
+              <a:t>Kaleem Muhammad, Minhas Lubna Anjum, Jabeen Amber et al.. Discover nano. 2026-06-17 DOI: 10.1186/s11671-026-04671-x</a:t>
             </a:r>
             <a:endParaRPr lang="en-US" sz="800" dirty="0"/>
           </a:p>

</xml_diff>

<commit_message>
chore: update weekly digest 2026-06-29
</commit_message>
<xml_diff>
--- a/docs/digest-en.pptx
+++ b/docs/digest-en.pptx
@@ -2249,7 +2249,7 @@
                   <a:srgbClr val="888888"/>
                 </a:solidFill>
               </a:rPr>
-              <a:t>2026-06-15 — 2026-06-22</a:t>
+              <a:t>2026-06-22 — 2026-06-29</a:t>
             </a:r>
             <a:endParaRPr lang="en-US" sz="1400" dirty="0"/>
           </a:p>
@@ -2440,7 +2440,7 @@
                   </a:extLst>
                 </a:hlinkClick>
               </a:rPr>
-              <a:t>Prognostic value of systemic immune-inflammation index for colorectal cancer: a systematic review and meta-analysis</a:t>
+              <a:t>Stem cell-based tactics in the remodeling and treatment of intestinal diseases.</a:t>
             </a:r>
             <a:endParaRPr lang="en-US" sz="2400" dirty="0"/>
           </a:p>
@@ -2476,7 +2476,7 @@
                   <a:srgbClr val="888888"/>
                 </a:solidFill>
               </a:rPr>
-              <a:t>Frontiers in Oncology  ·  Meta-Analysis</a:t>
+              <a:t>Stem cell research &amp; therapy  ·  Prospective Study</a:t>
             </a:r>
             <a:endParaRPr lang="en-US" sz="1000" dirty="0"/>
           </a:p>
@@ -2519,7 +2519,7 @@
                 <a:ea typeface="Arial" pitchFamily="34" charset="-122"/>
                 <a:cs typeface="Arial" pitchFamily="34" charset="-120"/>
               </a:rPr>
-              <a:t>Systemic immune-inflammation index (SII) evaluated</a:t>
+              <a:t>Intestinal diseases cause global socioeconomic burden.</a:t>
             </a:r>
             <a:endParaRPr lang="en-US" sz="1800" dirty="0"/>
           </a:p>
@@ -2540,7 +2540,7 @@
                 <a:ea typeface="Arial" pitchFamily="34" charset="-122"/>
                 <a:cs typeface="Arial" pitchFamily="34" charset="-120"/>
               </a:rPr>
-              <a:t>Prognostic significance in colorectal cancer</a:t>
+              <a:t>Stem cells aid in gut-immune homeostasis restoration.</a:t>
             </a:r>
             <a:endParaRPr lang="en-US" sz="1800" dirty="0"/>
           </a:p>
@@ -2561,7 +2561,7 @@
                 <a:ea typeface="Arial" pitchFamily="34" charset="-122"/>
                 <a:cs typeface="Arial" pitchFamily="34" charset="-120"/>
               </a:rPr>
-              <a:t>Meta-analysis of existing studies</a:t>
+              <a:t>hPSCs and organoids used for disease remodeling.</a:t>
             </a:r>
             <a:endParaRPr lang="en-US" sz="1800" dirty="0"/>
           </a:p>
@@ -2582,7 +2582,7 @@
                 <a:ea typeface="Arial" pitchFamily="34" charset="-122"/>
                 <a:cs typeface="Arial" pitchFamily="34" charset="-120"/>
               </a:rPr>
-              <a:t>SII correlates with patient outcomes</a:t>
+              <a:t>MSCs and microvesicles for intestinal disorder treatment.</a:t>
             </a:r>
             <a:endParaRPr lang="en-US" sz="1800" dirty="0"/>
           </a:p>
@@ -2603,7 +2603,7 @@
                 <a:ea typeface="Arial" pitchFamily="34" charset="-122"/>
                 <a:cs typeface="Arial" pitchFamily="34" charset="-120"/>
               </a:rPr>
-              <a:t>Potential biomarker for clinical use</a:t>
+              <a:t>Challenges include ethics, heterogeneity, and standardization.</a:t>
             </a:r>
             <a:endParaRPr lang="en-US" sz="1800" dirty="0"/>
           </a:p>
@@ -2639,7 +2639,7 @@
                   <a:srgbClr val="888888"/>
                 </a:solidFill>
               </a:rPr>
-              <a:t>P Wang, H Jiang. Frontiers in Oncology. 2026</a:t>
+              <a:t>Ren Yanian, Zhang Shanshan, Wang Jiageng et al.. Stem cell research &amp; therapy. 2026-06-23 DOI: 10.1186/s13287-026-05124-z</a:t>
             </a:r>
             <a:endParaRPr lang="en-US" sz="800" dirty="0"/>
           </a:p>
@@ -2839,7 +2839,7 @@
                   </a:extLst>
                 </a:hlinkClick>
               </a:rPr>
-              <a:t>Awareness of inflammatory bowel disease-associated colorectal cancer risk and its management in patients with inflammatory bowel disease: a systematic review</a:t>
+              <a:t>The microbiome-epigenome axis: Regulation of host genome function across development and disease.</a:t>
             </a:r>
             <a:endParaRPr lang="en-US" sz="2400" dirty="0"/>
           </a:p>
@@ -2875,7 +2875,7 @@
                   <a:srgbClr val="888888"/>
                 </a:solidFill>
               </a:rPr>
-              <a:t>Crohns &amp; Colitis 360  ·  Systematic Review</a:t>
+              <a:t>Cancer treatment and research communications  ·  Basic Research</a:t>
             </a:r>
             <a:endParaRPr lang="en-US" sz="1000" dirty="0"/>
           </a:p>
@@ -2918,7 +2918,7 @@
                 <a:ea typeface="Arial" pitchFamily="34" charset="-122"/>
                 <a:cs typeface="Arial" pitchFamily="34" charset="-120"/>
               </a:rPr>
-              <a:t>Limited awareness of cancer risk</a:t>
+              <a:t>Gut microbiome regulates gene expression.</a:t>
             </a:r>
             <a:endParaRPr lang="en-US" sz="1800" dirty="0"/>
           </a:p>
@@ -2939,7 +2939,7 @@
                 <a:ea typeface="Arial" pitchFamily="34" charset="-122"/>
                 <a:cs typeface="Arial" pitchFamily="34" charset="-120"/>
               </a:rPr>
-              <a:t>Need for patient education</a:t>
+              <a:t>Microbial metabolites influence epigenetic signals.</a:t>
             </a:r>
             <a:endParaRPr lang="en-US" sz="1800" dirty="0"/>
           </a:p>
@@ -2960,7 +2960,7 @@
                 <a:ea typeface="Arial" pitchFamily="34" charset="-122"/>
                 <a:cs typeface="Arial" pitchFamily="34" charset="-120"/>
               </a:rPr>
-              <a:t>Lack of comprehensive studies</a:t>
+              <a:t>Dysbiosis linked to various diseases.</a:t>
             </a:r>
             <a:endParaRPr lang="en-US" sz="1800" dirty="0"/>
           </a:p>
@@ -2996,7 +2996,7 @@
                   <a:srgbClr val="888888"/>
                 </a:solidFill>
               </a:rPr>
-              <a:t>F Khan, C Norton, W Czuber-Dochan. Crohns &amp; Colitis 360. 2026</a:t>
+              <a:t>Abuhassan Qamar, Atoom Ali M, Ganesan Subbulakshmi et al.. Cancer treatment and research communications. 2026-06-27 DOI: 10.1016/j.ctarc.2026.101299</a:t>
             </a:r>
             <a:endParaRPr lang="en-US" sz="800" dirty="0"/>
           </a:p>
@@ -3196,7 +3196,7 @@
                   </a:extLst>
                 </a:hlinkClick>
               </a:rPr>
-              <a:t>Brominated Flame Retardants: UQCRC1 and NR3C2 as Potential Targets in IBD and CRC.</a:t>
+              <a:t>Environmental enrichment suppresses colorectal cancer progression with comorbid depression by modulating the immunosuppressive tumor microenvironment.</a:t>
             </a:r>
             <a:endParaRPr lang="en-US" sz="2400" dirty="0"/>
           </a:p>
@@ -3232,7 +3232,7 @@
                   <a:srgbClr val="888888"/>
                 </a:solidFill>
               </a:rPr>
-              <a:t>Food and chemical toxicology : an international journal published for the British Industrial Biological Research Association  ·  Basic Research</a:t>
+              <a:t>Biochemical and biophysical research communications  ·  Basic Research</a:t>
             </a:r>
             <a:endParaRPr lang="en-US" sz="1000" dirty="0"/>
           </a:p>
@@ -3275,7 +3275,7 @@
                 <a:ea typeface="Arial" pitchFamily="34" charset="-122"/>
                 <a:cs typeface="Arial" pitchFamily="34" charset="-120"/>
               </a:rPr>
-              <a:t>Brominated flame retardants linked to health risks.</a:t>
+              <a:t>Environmental enrichment reduces tumor growth.</a:t>
             </a:r>
             <a:endParaRPr lang="en-US" sz="1800" dirty="0"/>
           </a:p>
@@ -3296,7 +3296,7 @@
                 <a:ea typeface="Arial" pitchFamily="34" charset="-122"/>
                 <a:cs typeface="Arial" pitchFamily="34" charset="-120"/>
               </a:rPr>
-              <a:t>Identified UQCRC1 and NR3C2 as core targets.</a:t>
+              <a:t>Depression worsens CRC treatment outcomes.</a:t>
             </a:r>
             <a:endParaRPr lang="en-US" sz="1800" dirty="0"/>
           </a:p>
@@ -3317,7 +3317,7 @@
                 <a:ea typeface="Arial" pitchFamily="34" charset="-122"/>
                 <a:cs typeface="Arial" pitchFamily="34" charset="-120"/>
               </a:rPr>
-              <a:t>Low expression predicts poor prognosis in CRC.</a:t>
+              <a:t>EE improves immune response in CRC.</a:t>
             </a:r>
             <a:endParaRPr lang="en-US" sz="1800" dirty="0"/>
           </a:p>
@@ -3338,7 +3338,7 @@
                 <a:ea typeface="Arial" pitchFamily="34" charset="-122"/>
                 <a:cs typeface="Arial" pitchFamily="34" charset="-120"/>
               </a:rPr>
-              <a:t>BFR exposure promotes CRC cell proliferation.</a:t>
+              <a:t>CUMS increases tumor progression and mortality.</a:t>
             </a:r>
             <a:endParaRPr lang="en-US" sz="1800" dirty="0"/>
           </a:p>
@@ -3359,7 +3359,7 @@
                 <a:ea typeface="Arial" pitchFamily="34" charset="-122"/>
                 <a:cs typeface="Arial" pitchFamily="34" charset="-120"/>
               </a:rPr>
-              <a:t>BFR affects intestinal barrier and cytokine levels.</a:t>
+              <a:t>EE enhances CD8+T cell infiltration.</a:t>
             </a:r>
             <a:endParaRPr lang="en-US" sz="1800" dirty="0"/>
           </a:p>
@@ -3395,7 +3395,7 @@
                   <a:srgbClr val="888888"/>
                 </a:solidFill>
               </a:rPr>
-              <a:t>Wu Jianhai, Li Haoran, Wu Chongying et al.. Food and chemical toxicology : an international journal published for the British Industrial Biological Research Association. 2026-06-18 DOI: 10.1016/j.fct.2026.116230</a:t>
+              <a:t>Song Jia, Zhao Liming, Zhou Shengwen et al.. Biochemical and biophysical research communications. 2026-05-09 DOI: 10.1016/j.bbrc.2026.153771</a:t>
             </a:r>
             <a:endParaRPr lang="en-US" sz="800" dirty="0"/>
           </a:p>
@@ -3586,7 +3586,7 @@
                   <a:srgbClr val="FFFFFF"/>
                 </a:solidFill>
               </a:rPr>
-              <a:t>### 綜合啟示（Overall Insights）</a:t>
+              <a:t>### 綜合啟示 (Overall Insights)</a:t>
             </a:r>
             <a:endParaRPr lang="en-US" sz="1200" dirty="0"/>
           </a:p>
@@ -3612,7 +3612,7 @@
                   <a:srgbClr val="FFFFFF"/>
                 </a:solidFill>
               </a:rPr>
-              <a:t>1. **炎症微環境與腫瘤進展的關聯性**  </a:t>
+              <a:t>1. **微生物組與癌症的關聯性**  </a:t>
             </a:r>
             <a:endParaRPr lang="en-US" sz="1200" dirty="0"/>
           </a:p>
@@ -3629,7 +3629,7 @@
                   <a:srgbClr val="FFFFFF"/>
                 </a:solidFill>
               </a:rPr>
-              <a:t>   The chronic inflammatory microenvironment plays a crucial role in colorectal cancer (CRC) initiation and progression, highlighting the need for targeted therapies that address inflammation.  </a:t>
+              <a:t>   The gut microbiome plays a critical role in carcinogenesis and immune regulation, highlighting its potential as a therapeutic target in colorectal cancer and other malignancies.  </a:t>
             </a:r>
             <a:endParaRPr lang="en-US" sz="1200" dirty="0"/>
           </a:p>
@@ -3646,7 +3646,7 @@
                   <a:srgbClr val="FFFFFF"/>
                 </a:solidFill>
               </a:rPr>
-              <a:t>   慢性炎症微環境在大腸癌（CRC）的發生和進展中扮演著關鍵角色，強調需要針對炎症的治療策略。</a:t>
+              <a:t>   微生物組在癌症發生和免疫調節中扮演關鍵角色，突顯其在結直腸癌及其他惡性腫瘤治療中的潛在療效。</a:t>
             </a:r>
             <a:endParaRPr lang="en-US" sz="1200" dirty="0"/>
           </a:p>
@@ -3672,7 +3672,7 @@
                   <a:srgbClr val="FFFFFF"/>
                 </a:solidFill>
               </a:rPr>
-              <a:t>2. **脂質代謝在腫瘤中的重要性**  </a:t>
+              <a:t>2. **免疫炎症指數的預後價值**  </a:t>
             </a:r>
             <a:endParaRPr lang="en-US" sz="1200" dirty="0"/>
           </a:p>
@@ -3689,7 +3689,7 @@
                   <a:srgbClr val="FFFFFF"/>
                 </a:solidFill>
               </a:rPr>
-              <a:t>   The accumulation of dietary polyunsaturated fatty acids (PUFAs) in CRC suggests that lipid metabolism is a significant factor in tumor biology, warranting further investigation into its therapeutic implications.  </a:t>
+              <a:t>   The systemic immune-inflammation index (SII) has emerged as a significant prognostic biomarker for colorectal cancer, indicating the importance of immune status in cancer outcomes.  </a:t>
             </a:r>
             <a:endParaRPr lang="en-US" sz="1200" dirty="0"/>
           </a:p>
@@ -3706,7 +3706,7 @@
                   <a:srgbClr val="FFFFFF"/>
                 </a:solidFill>
               </a:rPr>
-              <a:t>   膳食多不飽和脂肪酸（PUFAs）在CRC中的積累表明脂質代謝在腫瘤生物學中是一個重要因素，值得進一步研究其治療意義。</a:t>
+              <a:t>   系統免疫炎症指數（SII）已成為結直腸癌的重要預後生物標誌，顯示免疫狀態對癌症結果的重要性。</a:t>
             </a:r>
             <a:endParaRPr lang="en-US" sz="1200" dirty="0"/>
           </a:p>
@@ -3732,7 +3732,7 @@
                   <a:srgbClr val="FFFFFF"/>
                 </a:solidFill>
               </a:rPr>
-              <a:t>3. **癌症相關成纖維細胞的異質性**  </a:t>
+              <a:t>3. **慢性炎症與結直腸癌的關聯**  </a:t>
             </a:r>
             <a:endParaRPr lang="en-US" sz="1200" dirty="0"/>
           </a:p>
@@ -3749,7 +3749,7 @@
                   <a:srgbClr val="FFFFFF"/>
                 </a:solidFill>
               </a:rPr>
-              <a:t>   The phenotypic plasticity of cancer-associated fibroblasts (CAFs) indicates that different CAF subtypes contribute uniquely to tumor dynamics, suggesting potential targets for intervention.  </a:t>
+              <a:t>   Chronic inflammation is a driving factor in colitis-associated colorectal cancer, emphasizing the need for targeted therapies that address inflammation in cancer management.  </a:t>
             </a:r>
             <a:endParaRPr lang="en-US" sz="1200" dirty="0"/>
           </a:p>
@@ -3766,7 +3766,7 @@
                   <a:srgbClr val="FFFFFF"/>
                 </a:solidFill>
               </a:rPr>
-              <a:t>   癌症相關成纖維細胞（CAFs）的表型可塑性表明不同的CAF亞型對腫瘤動態有獨特貢獻，暗示了潛在的干預靶點。</a:t>
+              <a:t>   慢性炎症是結腸炎相關結直腸癌的驅動因素，強調在癌症管理中針對炎症的治療需求。</a:t>
             </a:r>
             <a:endParaRPr lang="en-US" sz="1200" dirty="0"/>
           </a:p>
@@ -3792,7 +3792,7 @@
                   <a:srgbClr val="FFFFFF"/>
                 </a:solidFill>
               </a:rPr>
-              <a:t>4. **系統性免疫-炎症指數的預後價值**  </a:t>
+              <a:t>4. **新型生物標誌物的發現**  </a:t>
             </a:r>
             <a:endParaRPr lang="en-US" sz="1200" dirty="0"/>
           </a:p>
@@ -3809,7 +3809,7 @@
                   <a:srgbClr val="FFFFFF"/>
                 </a:solidFill>
               </a:rPr>
-              <a:t>   The systemic immune-inflammation index (SII) has emerged as a promising prognostic biomarker in CRC, emphasizing the interplay between immune response and cancer outcomes.  </a:t>
+              <a:t>   The identification of novel biomarkers, such as S100P for sessile serrated lesions, may enhance early detection and treatment strategies for colorectal cancer.  </a:t>
             </a:r>
             <a:endParaRPr lang="en-US" sz="1200" dirty="0"/>
           </a:p>
@@ -3826,7 +3826,7 @@
                   <a:srgbClr val="FFFFFF"/>
                 </a:solidFill>
               </a:rPr>
-              <a:t>   系統性免疫-炎症指數（SII）已成為CRC中一個有前途的預後生物標誌物，強調免疫反應與癌症結果之間的相互作用。</a:t>
+              <a:t>   新型生物標誌物的發現，如S100P對於平坦狹窄病變的預測，可能增強結直腸癌的早期檢測和治療策略。</a:t>
             </a:r>
             <a:endParaRPr lang="en-US" sz="1200" dirty="0"/>
           </a:p>
@@ -3852,7 +3852,7 @@
                   <a:srgbClr val="FFFFFF"/>
                 </a:solidFill>
               </a:rPr>
-              <a:t>5. **新型治療策略的開發**  </a:t>
+              <a:t>5. **環境因素對癌症進展的影響**  </a:t>
             </a:r>
             <a:endParaRPr lang="en-US" sz="1200" dirty="0"/>
           </a:p>
@@ -3869,7 +3869,7 @@
                   <a:srgbClr val="FFFFFF"/>
                 </a:solidFill>
               </a:rPr>
-              <a:t>   Innovative approaches, such as engineered bacteria for targeted drug delivery, present new avenues for enhancing therapeutic efficacy in CRC treatment.</a:t>
+              <a:t>   Environmental enrichment has shown potential in suppressing colorectal cancer progression, suggesting that lifestyle modifications could play a role in cancer therapy.</a:t>
             </a:r>
             <a:endParaRPr lang="en-US" sz="1200" dirty="0"/>
           </a:p>
@@ -4015,7 +4015,7 @@
                   <a:srgbClr val="FFFFFF"/>
                 </a:solidFill>
               </a:rPr>
-              <a:t>創新方法，如工程化細菌的靶向藥物遞送，為提高CRC治療的療效提供了新的途徑。</a:t>
+              <a:t>環境豐富化顯示出抑制結直腸癌進展的潛力，暗示生活方式的改變可能在癌症治療中扮演角色。</a:t>
             </a:r>
             <a:endParaRPr lang="en-US" sz="1200" dirty="0"/>
           </a:p>
@@ -4041,7 +4041,7 @@
                   <a:srgbClr val="FFFFFF"/>
                 </a:solidFill>
               </a:rPr>
-              <a:t>### 未來研究方向（Future Research Directions）</a:t>
+              <a:t>### 未來研究方向 (Future Research Directions)</a:t>
             </a:r>
             <a:endParaRPr lang="en-US" sz="1200" dirty="0"/>
           </a:p>
@@ -4067,7 +4067,7 @@
                   <a:srgbClr val="FFFFFF"/>
                 </a:solidFill>
               </a:rPr>
-              <a:t>1. **探索脂質代謝與腫瘤微環境的相互作用**  </a:t>
+              <a:t>1. **微生物組的治療應用**  </a:t>
             </a:r>
             <a:endParaRPr lang="en-US" sz="1200" dirty="0"/>
           </a:p>
@@ -4084,7 +4084,7 @@
                   <a:srgbClr val="FFFFFF"/>
                 </a:solidFill>
               </a:rPr>
-              <a:t>   Future studies should focus on elucidating the mechanisms by which lipid metabolism influences the tumor microenvironment and its implications for CRC progression.  </a:t>
+              <a:t>   Future studies should explore the therapeutic manipulation of the gut microbiome to enhance immune responses in colorectal cancer treatment.  </a:t>
             </a:r>
             <a:endParaRPr lang="en-US" sz="1200" dirty="0"/>
           </a:p>
@@ -4101,7 +4101,7 @@
                   <a:srgbClr val="FFFFFF"/>
                 </a:solidFill>
               </a:rPr>
-              <a:t>   未來的研究應集中於闡明脂質代謝如何影響腫瘤微環境及其對CRC進展的影響機制。</a:t>
+              <a:t>   未來的研究應探討微生物組的治療性操控，以增強結直腸癌治療中的免疫反應。</a:t>
             </a:r>
             <a:endParaRPr lang="en-US" sz="1200" dirty="0"/>
           </a:p>
@@ -4127,7 +4127,7 @@
                   <a:srgbClr val="FFFFFF"/>
                 </a:solidFill>
               </a:rPr>
-              <a:t>2. **癌症相關成纖維細胞的功能研究**  </a:t>
+              <a:t>2. **炎症與癌症的交互作用**  </a:t>
             </a:r>
             <a:endParaRPr lang="en-US" sz="1200" dirty="0"/>
           </a:p>
@@ -4144,7 +4144,7 @@
                   <a:srgbClr val="FFFFFF"/>
                 </a:solidFill>
               </a:rPr>
-              <a:t>   Investigating the functional roles of different CAF subtypes in CRC could reveal novel therapeutic targets and strategies for intervention.  </a:t>
+              <a:t>   Investigating the complex interactions between chronic inflammation and cancer progression could lead to novel therapeutic strategies targeting both pathways.  </a:t>
             </a:r>
             <a:endParaRPr lang="en-US" sz="1200" dirty="0"/>
           </a:p>
@@ -4161,7 +4161,7 @@
                   <a:srgbClr val="FFFFFF"/>
                 </a:solidFill>
               </a:rPr>
-              <a:t>   研究不同CAF亞型在CRC中的功能角色可能揭示新的治療靶點和干預策略。</a:t>
+              <a:t>   探討慢性炎症與癌症進展之間的複雜交互作用，可能導致針對兩者路徑的新型治療策略。</a:t>
             </a:r>
             <a:endParaRPr lang="en-US" sz="1200" dirty="0"/>
           </a:p>
@@ -4187,7 +4187,7 @@
                   <a:srgbClr val="FFFFFF"/>
                 </a:solidFill>
               </a:rPr>
-              <a:t>3. **系統性免疫-炎症指數的臨床應用**  </a:t>
+              <a:t>3. **生物標誌物的臨床應用**  </a:t>
             </a:r>
             <a:endParaRPr lang="en-US" sz="1200" dirty="0"/>
           </a:p>
@@ -4204,7 +4204,7 @@
                   <a:srgbClr val="FFFFFF"/>
                 </a:solidFill>
               </a:rPr>
-              <a:t>   Further validation of the systemic immune-inflammation index (SII) in diverse CRC populations could enhance its utility as a prognostic tool in clinical settings.  </a:t>
+              <a:t>   Further validation of emerging biomarkers like S100P in clinical settings is essential for improving diagnostic accuracy and treatment personalization.  </a:t>
             </a:r>
             <a:endParaRPr lang="en-US" sz="1200" dirty="0"/>
           </a:p>
@@ -4221,7 +4221,7 @@
                   <a:srgbClr val="FFFFFF"/>
                 </a:solidFill>
               </a:rPr>
-              <a:t>   在不同CRC人群中進一步驗證系統性免疫-炎症指數（SII）可以增強其作為臨床預後工具的實用性。</a:t>
+              <a:t>   對新興生物標誌物如S100P在臨床環境中的進一步驗證對於提高診斷準確性和治療個性化至關重要。</a:t>
             </a:r>
             <a:endParaRPr lang="en-US" sz="1200" dirty="0"/>
           </a:p>
@@ -4247,7 +4247,7 @@
                   <a:srgbClr val="FFFFFF"/>
                 </a:solidFill>
               </a:rPr>
-              <a:t>4. **炎症與癌症之間的交互作用**  </a:t>
+              <a:t>4. **心理健康與癌症治療的關聯**  </a:t>
             </a:r>
             <a:endParaRPr lang="en-US" sz="1200" dirty="0"/>
           </a:p>
@@ -4264,7 +4264,7 @@
                   <a:srgbClr val="FFFFFF"/>
                 </a:solidFill>
               </a:rPr>
-              <a:t>   More research is needed to understand the complex interactions between inflammation, immune responses, and colorectal carcinogenesis, which may lead to better prevention strategies.  </a:t>
+              <a:t>   Research should focus on the impact of mental health interventions on cancer outcomes, particularly in patients with comorbid conditions like depression.  </a:t>
             </a:r>
             <a:endParaRPr lang="en-US" sz="1200" dirty="0"/>
           </a:p>
@@ -4281,7 +4281,7 @@
                   <a:srgbClr val="FFFFFF"/>
                 </a:solidFill>
               </a:rPr>
-              <a:t>   需要更多研究來理解炎症、免疫反應與大腸癌發生之間的複雜相互作用，這可能導致更好的預防策略。</a:t>
+              <a:t>   研究應聚焦於心理健康干預對癌症結果的影響，特別是在合併症如抑鬱症患者中的效果。</a:t>
             </a:r>
             <a:endParaRPr lang="en-US" sz="1200" dirty="0"/>
           </a:p>
@@ -4307,7 +4307,7 @@
                   <a:srgbClr val="FFFFFF"/>
                 </a:solidFill>
               </a:rPr>
-              <a:t>5. **新型治療平台的開發與評估**  </a:t>
+              <a:t>5. **多組學整合研究**  </a:t>
             </a:r>
             <a:endParaRPr lang="en-US" sz="1200" dirty="0"/>
           </a:p>
@@ -4324,7 +4324,7 @@
                   <a:srgbClr val="FFFFFF"/>
                 </a:solidFill>
               </a:rPr>
-              <a:t>   The development and evaluation of novel therapeutic platforms, such as engineered bacteria and nanotechnology, could revolutionize treatment approaches for CRC.  </a:t>
+              <a:t>   Integrative multi-omics approaches could provide deeper insights into the molecular mechanisms driving colorectal cancer, paving the way for innovative treatments.  </a:t>
             </a:r>
             <a:endParaRPr lang="en-US" sz="1200" dirty="0"/>
           </a:p>
@@ -4341,7 +4341,7 @@
                   <a:srgbClr val="FFFFFF"/>
                 </a:solidFill>
               </a:rPr>
-              <a:t>   新型治療平台的開發與評估，如工程化細菌和納米技術，可能會徹底改變CRC的治療方法。</a:t>
+              <a:t>   整合多組學的方法可以深入了解驅動結直腸癌的分子機制，為創新治療鋪平道路。</a:t>
             </a:r>
             <a:endParaRPr lang="en-US" sz="1200" dirty="0"/>
           </a:p>
@@ -4612,7 +4612,7 @@
                 <a:ea typeface="Arial" pitchFamily="34" charset="-122"/>
                 <a:cs typeface="Arial" pitchFamily="34" charset="-120"/>
               </a:rPr>
-              <a:t>Extrinsic lipids are absorbed and accumulate in colorectal cancer.</a:t>
+              <a:t>Microbiome-Driven Carcinogenesis and Circulating Microbial Signals in Genitourin…</a:t>
             </a:r>
             <a:endParaRPr lang="en-US" sz="1400" dirty="0"/>
           </a:p>
@@ -4649,7 +4649,7 @@
                 <a:ea typeface="Arial" pitchFamily="34" charset="-122"/>
                 <a:cs typeface="Arial" pitchFamily="34" charset="-120"/>
               </a:rPr>
-              <a:t>Parasutterella excrementihominis exacerbates experimental colitis and colitis-as…</a:t>
+              <a:t>Stage-associated remodeling of CD169 macrophage states is linked to immune regul…</a:t>
             </a:r>
             <a:endParaRPr lang="en-US" sz="1400" dirty="0"/>
           </a:p>
@@ -4686,7 +4686,7 @@
                 <a:ea typeface="Arial" pitchFamily="34" charset="-122"/>
                 <a:cs typeface="Arial" pitchFamily="34" charset="-120"/>
               </a:rPr>
-              <a:t>PI3K and MAPK Signaling Nodes Serve as Divergent Drivers of Phenotypic Plasticit…</a:t>
+              <a:t>Integrative Transcriptomic and Proteomic Profiling Identifies S100P as a Potenti…</a:t>
             </a:r>
             <a:endParaRPr lang="en-US" sz="1400" dirty="0"/>
           </a:p>
@@ -4723,7 +4723,7 @@
                 <a:ea typeface="Arial" pitchFamily="34" charset="-122"/>
                 <a:cs typeface="Arial" pitchFamily="34" charset="-120"/>
               </a:rPr>
-              <a:t>Integrin CD11b/CD18 reprograms macrophage polarization by suppressing ERK/STAT3 …</a:t>
+              <a:t>Effect of hyperthermic intraperitoneal chemotherapy on patients with advanced co…</a:t>
             </a:r>
             <a:endParaRPr lang="en-US" sz="1400" dirty="0"/>
           </a:p>
@@ -4760,7 +4760,7 @@
                 <a:ea typeface="Arial" pitchFamily="34" charset="-122"/>
                 <a:cs typeface="Arial" pitchFamily="34" charset="-120"/>
               </a:rPr>
-              <a:t>Engineered Salmonella delivering the NMDAR antagonist conantokin G synergizes wi…</a:t>
+              <a:t>Prognostic value of systemic immune-inflammation index for colorectal cancer: a …</a:t>
             </a:r>
             <a:endParaRPr lang="en-US" sz="1400" dirty="0"/>
           </a:p>
@@ -4797,7 +4797,7 @@
                 <a:ea typeface="Arial" pitchFamily="34" charset="-122"/>
                 <a:cs typeface="Arial" pitchFamily="34" charset="-120"/>
               </a:rPr>
-              <a:t>Harnessing Tolypothrix sp. A-8 for biogenic synthesis of silver oxide nanopartic…</a:t>
+              <a:t>Awareness of inflammatory bowel disease-associated colorectal cancer risk and it…</a:t>
             </a:r>
             <a:endParaRPr lang="en-US" sz="1400" dirty="0"/>
           </a:p>
@@ -4834,7 +4834,7 @@
                 <a:ea typeface="Arial" pitchFamily="34" charset="-122"/>
                 <a:cs typeface="Arial" pitchFamily="34" charset="-120"/>
               </a:rPr>
-              <a:t>Prognostic value of systemic immune-inflammation index for colorectal cancer: a …</a:t>
+              <a:t>Stem cell-based tactics in the remodeling and treatment of intestinal diseases.</a:t>
             </a:r>
             <a:endParaRPr lang="en-US" sz="1400" dirty="0"/>
           </a:p>
@@ -4871,7 +4871,7 @@
                 <a:ea typeface="Arial" pitchFamily="34" charset="-122"/>
                 <a:cs typeface="Arial" pitchFamily="34" charset="-120"/>
               </a:rPr>
-              <a:t>Awareness of inflammatory bowel disease-associated colorectal cancer risk and it…</a:t>
+              <a:t>The microbiome-epigenome axis: Regulation of host genome function across develop…</a:t>
             </a:r>
             <a:endParaRPr lang="en-US" sz="1400" dirty="0"/>
           </a:p>
@@ -4908,7 +4908,7 @@
                 <a:ea typeface="Arial" pitchFamily="34" charset="-122"/>
                 <a:cs typeface="Arial" pitchFamily="34" charset="-120"/>
               </a:rPr>
-              <a:t>Brominated Flame Retardants: UQCRC1 and NR3C2 as Potential Targets in IBD and CR…</a:t>
+              <a:t>Environmental enrichment suppresses colorectal cancer progression with comorbid …</a:t>
             </a:r>
             <a:endParaRPr lang="en-US" sz="1400" dirty="0"/>
           </a:p>
@@ -5184,49 +5184,7 @@
                 <a:ea typeface="Arial" pitchFamily="34" charset="-122"/>
                 <a:cs typeface="Arial" pitchFamily="34" charset="-120"/>
               </a:rPr>
-              <a:t>Results show limited survival benefits</a:t>
-            </a:r>
-            <a:endParaRPr lang="en-US" sz="1800" dirty="0"/>
-          </a:p>
-          <a:p>
-            <a:pPr marL="342900" indent="-342900">
-              <a:spcAft>
-                <a:spcPts val="800"/>
-              </a:spcAft>
-              <a:buSzPct val="100000"/>
-              <a:buChar char="•"/>
-            </a:pPr>
-            <a:r>
-              <a:rPr lang="en-US" sz="1800" dirty="0">
-                <a:solidFill>
-                  <a:srgbClr val="333333"/>
-                </a:solidFill>
-                <a:latin typeface="Arial" pitchFamily="34" charset="0"/>
-                <a:ea typeface="Arial" pitchFamily="34" charset="-122"/>
-                <a:cs typeface="Arial" pitchFamily="34" charset="-120"/>
-              </a:rPr>
-              <a:t>Concerns over surgical complications</a:t>
-            </a:r>
-            <a:endParaRPr lang="en-US" sz="1800" dirty="0"/>
-          </a:p>
-          <a:p>
-            <a:pPr marL="342900" indent="-342900">
-              <a:spcAft>
-                <a:spcPts val="800"/>
-              </a:spcAft>
-              <a:buSzPct val="100000"/>
-              <a:buChar char="•"/>
-            </a:pPr>
-            <a:r>
-              <a:rPr lang="en-US" sz="1800" dirty="0">
-                <a:solidFill>
-                  <a:srgbClr val="333333"/>
-                </a:solidFill>
-                <a:latin typeface="Arial" pitchFamily="34" charset="0"/>
-                <a:ea typeface="Arial" pitchFamily="34" charset="-122"/>
-                <a:cs typeface="Arial" pitchFamily="34" charset="-120"/>
-              </a:rPr>
-              <a:t>Need for alternative treatment strategies</a:t>
+              <a:t>Results indicate limited survival benefit</a:t>
             </a:r>
             <a:endParaRPr lang="en-US" sz="1800" dirty="0"/>
           </a:p>
@@ -5462,7 +5420,7 @@
                   </a:extLst>
                 </a:hlinkClick>
               </a:rPr>
-              <a:t>Extrinsic lipids are absorbed and accumulate in colorectal cancer.</a:t>
+              <a:t>Microbiome-Driven Carcinogenesis and Circulating Microbial Signals in Genitourinary Cancers.</a:t>
             </a:r>
             <a:endParaRPr lang="en-US" sz="2400" dirty="0"/>
           </a:p>
@@ -5498,7 +5456,7 @@
                   <a:srgbClr val="888888"/>
                 </a:solidFill>
               </a:rPr>
-              <a:t>Gut  ·  IF 24.5</a:t>
+              <a:t>Cancer science  ·  Basic Research  ·  🌏 Asia</a:t>
             </a:r>
             <a:endParaRPr lang="en-US" sz="1000" dirty="0"/>
           </a:p>
@@ -5541,7 +5499,7 @@
                 <a:ea typeface="Arial" pitchFamily="34" charset="-122"/>
                 <a:cs typeface="Arial" pitchFamily="34" charset="-120"/>
               </a:rPr>
-              <a:t>Colorectal cancer shows increased PUFAs uptake.</a:t>
+              <a:t>Microbiome influences genitourinary cancers.</a:t>
             </a:r>
             <a:endParaRPr lang="en-US" sz="1800" dirty="0"/>
           </a:p>
@@ -5562,7 +5520,7 @@
                 <a:ea typeface="Arial" pitchFamily="34" charset="-122"/>
                 <a:cs typeface="Arial" pitchFamily="34" charset="-120"/>
               </a:rPr>
-              <a:t>Extrinsic long chain PUFAs accumulate in tumors.</a:t>
+              <a:t>Gut microbes affect tumor initiation and immunity.</a:t>
             </a:r>
             <a:endParaRPr lang="en-US" sz="1800" dirty="0"/>
           </a:p>
@@ -5583,49 +5541,7 @@
                 <a:ea typeface="Arial" pitchFamily="34" charset="-122"/>
                 <a:cs typeface="Arial" pitchFamily="34" charset="-120"/>
               </a:rPr>
-              <a:t>FA absorption linked to tumor progression.</a:t>
-            </a:r>
-            <a:endParaRPr lang="en-US" sz="1800" dirty="0"/>
-          </a:p>
-          <a:p>
-            <a:pPr marL="342900" indent="-342900">
-              <a:spcAft>
-                <a:spcPts val="800"/>
-              </a:spcAft>
-              <a:buSzPct val="100000"/>
-              <a:buChar char="•"/>
-            </a:pPr>
-            <a:r>
-              <a:rPr lang="en-US" sz="1800" dirty="0">
-                <a:solidFill>
-                  <a:srgbClr val="333333"/>
-                </a:solidFill>
-                <a:latin typeface="Arial" pitchFamily="34" charset="0"/>
-                <a:ea typeface="Arial" pitchFamily="34" charset="-122"/>
-                <a:cs typeface="Arial" pitchFamily="34" charset="-120"/>
-              </a:rPr>
-              <a:t>Microbiome absence reduces tumor development.</a:t>
-            </a:r>
-            <a:endParaRPr lang="en-US" sz="1800" dirty="0"/>
-          </a:p>
-          <a:p>
-            <a:pPr marL="342900" indent="-342900">
-              <a:spcAft>
-                <a:spcPts val="800"/>
-              </a:spcAft>
-              <a:buSzPct val="100000"/>
-              <a:buChar char="•"/>
-            </a:pPr>
-            <a:r>
-              <a:rPr lang="en-US" sz="1800" dirty="0">
-                <a:solidFill>
-                  <a:srgbClr val="333333"/>
-                </a:solidFill>
-                <a:latin typeface="Arial" pitchFamily="34" charset="0"/>
-                <a:ea typeface="Arial" pitchFamily="34" charset="-122"/>
-                <a:cs typeface="Arial" pitchFamily="34" charset="-120"/>
-              </a:rPr>
-              <a:t>Targeting FA pathways may offer new therapies.</a:t>
+              <a:t>Circulating microbial signals linked to ICI outcomes.</a:t>
             </a:r>
             <a:endParaRPr lang="en-US" sz="1800" dirty="0"/>
           </a:p>
@@ -5661,7 +5577,7 @@
                   <a:srgbClr val="888888"/>
                 </a:solidFill>
               </a:rPr>
-              <a:t>Janssen Klaus Peter, Basic Marijana, Bolsega Silvia et al.. Gut. 2026-06-17 DOI: 10.1136/gutjnl-2025-336377</a:t>
+              <a:t>Kawashima Atsunari, Jingushi Kentaro, Saito Takuro et al.. Cancer science. 2026-06-23 DOI: 10.1111/cas.70448</a:t>
             </a:r>
             <a:endParaRPr lang="en-US" sz="800" dirty="0"/>
           </a:p>
@@ -5861,7 +5777,7 @@
                   </a:extLst>
                 </a:hlinkClick>
               </a:rPr>
-              <a:t>Parasutterella excrementihominis exacerbates experimental colitis and colitis-associated colorectal cancer via pathogenic NETosis activation</a:t>
+              <a:t>Stage-associated remodeling of CD169 macrophage states is linked to immune regulation in colitis-associated colorectal cancer.</a:t>
             </a:r>
             <a:endParaRPr lang="en-US" sz="2400" dirty="0"/>
           </a:p>
@@ -5897,7 +5813,7 @@
                   <a:srgbClr val="888888"/>
                 </a:solidFill>
               </a:rPr>
-              <a:t>Gut  ·  IF 24.5</a:t>
+              <a:t>Journal of gastroenterology  ·  🌏 Asia</a:t>
             </a:r>
             <a:endParaRPr lang="en-US" sz="1000" dirty="0"/>
           </a:p>
@@ -5940,7 +5856,7 @@
                 <a:ea typeface="Arial" pitchFamily="34" charset="-122"/>
                 <a:cs typeface="Arial" pitchFamily="34" charset="-120"/>
               </a:rPr>
-              <a:t>P. excrementihominis worsens colitis severity.</a:t>
+              <a:t>CD169 macrophages show stage-specific roles.</a:t>
             </a:r>
             <a:endParaRPr lang="en-US" sz="1800" dirty="0"/>
           </a:p>
@@ -5961,7 +5877,7 @@
                 <a:ea typeface="Arial" pitchFamily="34" charset="-122"/>
                 <a:cs typeface="Arial" pitchFamily="34" charset="-120"/>
               </a:rPr>
-              <a:t>NETosis activation linked to cancer progression.</a:t>
+              <a:t>CD169-low macrophages are pro-inflammatory.</a:t>
             </a:r>
             <a:endParaRPr lang="en-US" sz="1800" dirty="0"/>
           </a:p>
@@ -5982,7 +5898,49 @@
                 <a:ea typeface="Arial" pitchFamily="34" charset="-122"/>
                 <a:cs typeface="Arial" pitchFamily="34" charset="-120"/>
               </a:rPr>
-              <a:t>Study suggests new therapeutic strategies.</a:t>
+              <a:t>CD169-mid/high macrophages are immunosuppressive.</a:t>
+            </a:r>
+            <a:endParaRPr lang="en-US" sz="1800" dirty="0"/>
+          </a:p>
+          <a:p>
+            <a:pPr marL="342900" indent="-342900">
+              <a:spcAft>
+                <a:spcPts val="800"/>
+              </a:spcAft>
+              <a:buSzPct val="100000"/>
+              <a:buChar char="•"/>
+            </a:pPr>
+            <a:r>
+              <a:rPr lang="en-US" sz="1800" dirty="0">
+                <a:solidFill>
+                  <a:srgbClr val="333333"/>
+                </a:solidFill>
+                <a:latin typeface="Arial" pitchFamily="34" charset="0"/>
+                <a:ea typeface="Arial" pitchFamily="34" charset="-122"/>
+                <a:cs typeface="Arial" pitchFamily="34" charset="-120"/>
+              </a:rPr>
+              <a:t>CD169 depletion reduces tumor growth.</a:t>
+            </a:r>
+            <a:endParaRPr lang="en-US" sz="1800" dirty="0"/>
+          </a:p>
+          <a:p>
+            <a:pPr marL="342900" indent="-342900">
+              <a:spcAft>
+                <a:spcPts val="800"/>
+              </a:spcAft>
+              <a:buSzPct val="100000"/>
+              <a:buChar char="•"/>
+            </a:pPr>
+            <a:r>
+              <a:rPr lang="en-US" sz="1800" dirty="0">
+                <a:solidFill>
+                  <a:srgbClr val="333333"/>
+                </a:solidFill>
+                <a:latin typeface="Arial" pitchFamily="34" charset="0"/>
+                <a:ea typeface="Arial" pitchFamily="34" charset="-122"/>
+                <a:cs typeface="Arial" pitchFamily="34" charset="-120"/>
+              </a:rPr>
+              <a:t>Targeting CD169 may improve therapies.</a:t>
             </a:r>
             <a:endParaRPr lang="en-US" sz="1800" dirty="0"/>
           </a:p>
@@ -6018,7 +5976,7 @@
                   <a:srgbClr val="888888"/>
                 </a:solidFill>
               </a:rPr>
-              <a:t>H Tan, L Huang, J Wang. Gut. 2026</a:t>
+              <a:t>Xia Yuan, Liu Yu, Peng Ai et al.. Journal of gastroenterology. 2026-06-24 DOI: 10.1007/s00535-026-02463-9</a:t>
             </a:r>
             <a:endParaRPr lang="en-US" sz="800" dirty="0"/>
           </a:p>
@@ -6218,7 +6176,7 @@
                   </a:extLst>
                 </a:hlinkClick>
               </a:rPr>
-              <a:t>PI3K and MAPK Signaling Nodes Serve as Divergent Drivers of Phenotypic Plasticity in Cancer-Associated Fibroblasts in Colorectal Cancer.</a:t>
+              <a:t>Integrative Transcriptomic and Proteomic Profiling Identifies S100P as a Potential Functional Biomarker for Sessile Serrated Lesions.</a:t>
             </a:r>
             <a:endParaRPr lang="en-US" sz="2400" dirty="0"/>
           </a:p>
@@ -6254,7 +6212,7 @@
                   <a:srgbClr val="888888"/>
                 </a:solidFill>
               </a:rPr>
-              <a:t>Cancer research  ·  IF 12.7  ·  Basic Research</a:t>
+              <a:t>Digestive diseases and sciences  ·  🌏 Asia</a:t>
             </a:r>
             <a:endParaRPr lang="en-US" sz="1000" dirty="0"/>
           </a:p>
@@ -6297,7 +6255,7 @@
                 <a:ea typeface="Arial" pitchFamily="34" charset="-122"/>
                 <a:cs typeface="Arial" pitchFamily="34" charset="-120"/>
               </a:rPr>
-              <a:t>CAF phenotypic heterogeneity impacts tumor progression.</a:t>
+              <a:t>S100P identified as potential biomarker</a:t>
             </a:r>
             <a:endParaRPr lang="en-US" sz="1800" dirty="0"/>
           </a:p>
@@ -6318,7 +6276,7 @@
                 <a:ea typeface="Arial" pitchFamily="34" charset="-122"/>
                 <a:cs typeface="Arial" pitchFamily="34" charset="-120"/>
               </a:rPr>
-              <a:t>PI3K/mTOR and MAPK/ERK pathways drive CAF subtypes.</a:t>
+              <a:t>216 genes upregulated in SSLs</a:t>
             </a:r>
             <a:endParaRPr lang="en-US" sz="1800" dirty="0"/>
           </a:p>
@@ -6339,49 +6297,7 @@
                 <a:ea typeface="Arial" pitchFamily="34" charset="-122"/>
                 <a:cs typeface="Arial" pitchFamily="34" charset="-120"/>
               </a:rPr>
-              <a:t>iCAF promotes tumor growth via cytokine secretion.</a:t>
-            </a:r>
-            <a:endParaRPr lang="en-US" sz="1800" dirty="0"/>
-          </a:p>
-          <a:p>
-            <a:pPr marL="342900" indent="-342900">
-              <a:spcAft>
-                <a:spcPts val="800"/>
-              </a:spcAft>
-              <a:buSzPct val="100000"/>
-              <a:buChar char="•"/>
-            </a:pPr>
-            <a:r>
-              <a:rPr lang="en-US" sz="1800" dirty="0">
-                <a:solidFill>
-                  <a:srgbClr val="333333"/>
-                </a:solidFill>
-                <a:latin typeface="Arial" pitchFamily="34" charset="0"/>
-                <a:ea typeface="Arial" pitchFamily="34" charset="-122"/>
-                <a:cs typeface="Arial" pitchFamily="34" charset="-120"/>
-              </a:rPr>
-              <a:t>myCAF enhances ECM production and tumor colony formation.</a:t>
-            </a:r>
-            <a:endParaRPr lang="en-US" sz="1800" dirty="0"/>
-          </a:p>
-          <a:p>
-            <a:pPr marL="342900" indent="-342900">
-              <a:spcAft>
-                <a:spcPts val="800"/>
-              </a:spcAft>
-              <a:buSzPct val="100000"/>
-              <a:buChar char="•"/>
-            </a:pPr>
-            <a:r>
-              <a:rPr lang="en-US" sz="1800" dirty="0">
-                <a:solidFill>
-                  <a:srgbClr val="333333"/>
-                </a:solidFill>
-                <a:latin typeface="Arial" pitchFamily="34" charset="0"/>
-                <a:ea typeface="Arial" pitchFamily="34" charset="-122"/>
-                <a:cs typeface="Arial" pitchFamily="34" charset="-120"/>
-              </a:rPr>
-              <a:t>Targeted therapies influence CAF plasticity in CRC.</a:t>
+              <a:t>Functional assays confirm S100P relevance</a:t>
             </a:r>
             <a:endParaRPr lang="en-US" sz="1800" dirty="0"/>
           </a:p>
@@ -6417,7 +6333,7 @@
                   <a:srgbClr val="888888"/>
                 </a:solidFill>
               </a:rPr>
-              <a:t>Xia Zihan, De Vuyst Felix, Ernst Sam et al.. Cancer research. 2026-06-15 DOI: 10.1158/0008-5472.CAN-25-0766</a:t>
+              <a:t>Yeh Jen-Hao, Chen Chia-Chi, Chen Chih-I et al.. Digestive diseases and sciences. 2026-06-22 DOI: 10.1007/s10620-026-10048-y</a:t>
             </a:r>
             <a:endParaRPr lang="en-US" sz="800" dirty="0"/>
           </a:p>
@@ -6617,7 +6533,7 @@
                   </a:extLst>
                 </a:hlinkClick>
               </a:rPr>
-              <a:t>Integrin CD11b/CD18 reprograms macrophage polarization by suppressing ERK/STAT3 signaling to enhance antitumor immunity in colitis-associated colorectal cancer.</a:t>
+              <a:t>Effect of hyperthermic intraperitoneal chemotherapy on patients with advanced colorectal cancer: a systematic review and meta-analysis</a:t>
             </a:r>
             <a:endParaRPr lang="en-US" sz="2400" dirty="0"/>
           </a:p>
@@ -6653,7 +6569,7 @@
                   <a:srgbClr val="888888"/>
                 </a:solidFill>
               </a:rPr>
-              <a:t>Journal for immunotherapy of cancer  ·  IF 10.9  ·  Basic Research</a:t>
+              <a:t>World Journal of …  ·  Meta-Analysis</a:t>
             </a:r>
             <a:endParaRPr lang="en-US" sz="1000" dirty="0"/>
           </a:p>
@@ -6696,7 +6612,7 @@
                 <a:ea typeface="Arial" pitchFamily="34" charset="-122"/>
                 <a:cs typeface="Arial" pitchFamily="34" charset="-120"/>
               </a:rPr>
-              <a:t>CD11b/CD18 regulates macrophage polarization.</a:t>
+              <a:t>Hyperthermic intraperitoneal chemotherapy (HIPEC) effectiveness</a:t>
             </a:r>
             <a:endParaRPr lang="en-US" sz="1800" dirty="0"/>
           </a:p>
@@ -6717,7 +6633,7 @@
                 <a:ea typeface="Arial" pitchFamily="34" charset="-122"/>
                 <a:cs typeface="Arial" pitchFamily="34" charset="-120"/>
               </a:rPr>
-              <a:t>Deficiency exacerbates tumor progression in CAC.</a:t>
+              <a:t>Advanced colorectal cancer treatment options</a:t>
             </a:r>
             <a:endParaRPr lang="en-US" sz="1800" dirty="0"/>
           </a:p>
@@ -6738,7 +6654,49 @@
                 <a:ea typeface="Arial" pitchFamily="34" charset="-122"/>
                 <a:cs typeface="Arial" pitchFamily="34" charset="-120"/>
               </a:rPr>
-              <a:t>TAN-TAM crosstalk influences tumor immunity.</a:t>
+              <a:t>Systematic review and meta-analysis conducted</a:t>
+            </a:r>
+            <a:endParaRPr lang="en-US" sz="1800" dirty="0"/>
+          </a:p>
+          <a:p>
+            <a:pPr marL="342900" indent="-342900">
+              <a:spcAft>
+                <a:spcPts val="800"/>
+              </a:spcAft>
+              <a:buSzPct val="100000"/>
+              <a:buChar char="•"/>
+            </a:pPr>
+            <a:r>
+              <a:rPr lang="en-US" sz="1800" dirty="0">
+                <a:solidFill>
+                  <a:srgbClr val="333333"/>
+                </a:solidFill>
+                <a:latin typeface="Arial" pitchFamily="34" charset="0"/>
+                <a:ea typeface="Arial" pitchFamily="34" charset="-122"/>
+                <a:cs typeface="Arial" pitchFamily="34" charset="-120"/>
+              </a:rPr>
+              <a:t>Patient outcomes and survival rates analyzed</a:t>
+            </a:r>
+            <a:endParaRPr lang="en-US" sz="1800" dirty="0"/>
+          </a:p>
+          <a:p>
+            <a:pPr marL="342900" indent="-342900">
+              <a:spcAft>
+                <a:spcPts val="800"/>
+              </a:spcAft>
+              <a:buSzPct val="100000"/>
+              <a:buChar char="•"/>
+            </a:pPr>
+            <a:r>
+              <a:rPr lang="en-US" sz="1800" dirty="0">
+                <a:solidFill>
+                  <a:srgbClr val="333333"/>
+                </a:solidFill>
+                <a:latin typeface="Arial" pitchFamily="34" charset="0"/>
+                <a:ea typeface="Arial" pitchFamily="34" charset="-122"/>
+                <a:cs typeface="Arial" pitchFamily="34" charset="-120"/>
+              </a:rPr>
+              <a:t>Potential for improved therapeutic strategies</a:t>
             </a:r>
             <a:endParaRPr lang="en-US" sz="1800" dirty="0"/>
           </a:p>
@@ -6774,7 +6732,7 @@
                   <a:srgbClr val="888888"/>
                 </a:solidFill>
               </a:rPr>
-              <a:t>Lin Ying, Liu Yuan-Kun, Mi Peng et al.. Journal for immunotherapy of cancer. 2026-06-18 DOI: 10.1136/jitc-2025-014026</a:t>
+              <a:t>Z Su, Y Guo, X Ru. World Journal of …. 2026</a:t>
             </a:r>
             <a:endParaRPr lang="en-US" sz="800" dirty="0"/>
           </a:p>
@@ -6974,7 +6932,7 @@
                   </a:extLst>
                 </a:hlinkClick>
               </a:rPr>
-              <a:t>Engineered Salmonella delivering the NMDAR antagonist conantokin G synergizes with PD-L1 blockade to enhance colorectal cancer regression.</a:t>
+              <a:t>Prognostic value of systemic immune-inflammation index for colorectal cancer: a systematic review and meta-analysis</a:t>
             </a:r>
             <a:endParaRPr lang="en-US" sz="2400" dirty="0"/>
           </a:p>
@@ -7010,7 +6968,7 @@
                   <a:srgbClr val="888888"/>
                 </a:solidFill>
               </a:rPr>
-              <a:t>Experimental hematology &amp; oncology  ·  Basic Research  ·  🌏 Asia</a:t>
+              <a:t>Frontiers in Oncology  ·  Meta-Analysis</a:t>
             </a:r>
             <a:endParaRPr lang="en-US" sz="1000" dirty="0"/>
           </a:p>
@@ -7053,7 +7011,7 @@
                 <a:ea typeface="Arial" pitchFamily="34" charset="-122"/>
                 <a:cs typeface="Arial" pitchFamily="34" charset="-120"/>
               </a:rPr>
-              <a:t>Engineered Salmonella targets tumors effectively.</a:t>
+              <a:t>Systemic immune-inflammation index (SII) evaluated</a:t>
             </a:r>
             <a:endParaRPr lang="en-US" sz="1800" dirty="0"/>
           </a:p>
@@ -7074,7 +7032,7 @@
                 <a:ea typeface="Arial" pitchFamily="34" charset="-122"/>
                 <a:cs typeface="Arial" pitchFamily="34" charset="-120"/>
               </a:rPr>
-              <a:t>Conantokin G induces colorectal cancer cell death.</a:t>
+              <a:t>Prognostic significance in colorectal cancer</a:t>
             </a:r>
             <a:endParaRPr lang="en-US" sz="1800" dirty="0"/>
           </a:p>
@@ -7095,7 +7053,49 @@
                 <a:ea typeface="Arial" pitchFamily="34" charset="-122"/>
                 <a:cs typeface="Arial" pitchFamily="34" charset="-120"/>
               </a:rPr>
-              <a:t>Combination with PD-L1 blockade enhances treatment.</a:t>
+              <a:t>Meta-analysis of existing studies conducted</a:t>
+            </a:r>
+            <a:endParaRPr lang="en-US" sz="1800" dirty="0"/>
+          </a:p>
+          <a:p>
+            <a:pPr marL="342900" indent="-342900">
+              <a:spcAft>
+                <a:spcPts val="800"/>
+              </a:spcAft>
+              <a:buSzPct val="100000"/>
+              <a:buChar char="•"/>
+            </a:pPr>
+            <a:r>
+              <a:rPr lang="en-US" sz="1800" dirty="0">
+                <a:solidFill>
+                  <a:srgbClr val="333333"/>
+                </a:solidFill>
+                <a:latin typeface="Arial" pitchFamily="34" charset="0"/>
+                <a:ea typeface="Arial" pitchFamily="34" charset="-122"/>
+                <a:cs typeface="Arial" pitchFamily="34" charset="-120"/>
+              </a:rPr>
+              <a:t>SII correlates with patient outcomes</a:t>
+            </a:r>
+            <a:endParaRPr lang="en-US" sz="1800" dirty="0"/>
+          </a:p>
+          <a:p>
+            <a:pPr marL="342900" indent="-342900">
+              <a:spcAft>
+                <a:spcPts val="800"/>
+              </a:spcAft>
+              <a:buSzPct val="100000"/>
+              <a:buChar char="•"/>
+            </a:pPr>
+            <a:r>
+              <a:rPr lang="en-US" sz="1800" dirty="0">
+                <a:solidFill>
+                  <a:srgbClr val="333333"/>
+                </a:solidFill>
+                <a:latin typeface="Arial" pitchFamily="34" charset="0"/>
+                <a:ea typeface="Arial" pitchFamily="34" charset="-122"/>
+                <a:cs typeface="Arial" pitchFamily="34" charset="-120"/>
+              </a:rPr>
+              <a:t>Potential biomarker for clinical use</a:t>
             </a:r>
             <a:endParaRPr lang="en-US" sz="1800" dirty="0"/>
           </a:p>
@@ -7131,7 +7131,7 @@
                   <a:srgbClr val="888888"/>
                 </a:solidFill>
               </a:rPr>
-              <a:t>Kim Solbi, Kang Sora, Kim Eunji et al.. Experimental hematology &amp; oncology. 2026-06-16 DOI: 10.1186/s40164-026-00794-0</a:t>
+              <a:t>P Wang, H Jiang. Frontiers in Oncology. 2026</a:t>
             </a:r>
             <a:endParaRPr lang="en-US" sz="800" dirty="0"/>
           </a:p>
@@ -7331,7 +7331,7 @@
                   </a:extLst>
                 </a:hlinkClick>
               </a:rPr>
-              <a:t>Harnessing Tolypothrix sp. A-8 for biogenic synthesis of silver oxide nanoparticles (AgONPs) for multifunctional biomedical applications.</a:t>
+              <a:t>Awareness of inflammatory bowel disease-associated colorectal cancer risk and its management in patients with inflammatory bowel disease: a systematic review</a:t>
             </a:r>
             <a:endParaRPr lang="en-US" sz="2400" dirty="0"/>
           </a:p>
@@ -7367,7 +7367,7 @@
                   <a:srgbClr val="888888"/>
                 </a:solidFill>
               </a:rPr>
-              <a:t>Discover nano  ·  🌏 Asia</a:t>
+              <a:t>Crohns &amp; Colitis 360  ·  Systematic Review</a:t>
             </a:r>
             <a:endParaRPr lang="en-US" sz="1000" dirty="0"/>
           </a:p>
@@ -7410,7 +7410,7 @@
                 <a:ea typeface="Arial" pitchFamily="34" charset="-122"/>
                 <a:cs typeface="Arial" pitchFamily="34" charset="-120"/>
               </a:rPr>
-              <a:t>Phyco-synthesis of AgONPs using Tolypothrix sp. A-8</a:t>
+              <a:t>Limited awareness of colorectal cancer risk</a:t>
             </a:r>
             <a:endParaRPr lang="en-US" sz="1800" dirty="0"/>
           </a:p>
@@ -7431,7 +7431,7 @@
                 <a:ea typeface="Arial" pitchFamily="34" charset="-122"/>
                 <a:cs typeface="Arial" pitchFamily="34" charset="-120"/>
               </a:rPr>
-              <a:t>Significant anti-leishmanial activity demonstrated</a:t>
+              <a:t>Need for better patient education strategies</a:t>
             </a:r>
             <a:endParaRPr lang="en-US" sz="1800" dirty="0"/>
           </a:p>
@@ -7452,49 +7452,7 @@
                 <a:ea typeface="Arial" pitchFamily="34" charset="-122"/>
                 <a:cs typeface="Arial" pitchFamily="34" charset="-120"/>
               </a:rPr>
-              <a:t>Notable antioxidant and anti-inflammatory potential</a:t>
-            </a:r>
-            <a:endParaRPr lang="en-US" sz="1800" dirty="0"/>
-          </a:p>
-          <a:p>
-            <a:pPr marL="342900" indent="-342900">
-              <a:spcAft>
-                <a:spcPts val="800"/>
-              </a:spcAft>
-              <a:buSzPct val="100000"/>
-              <a:buChar char="•"/>
-            </a:pPr>
-            <a:r>
-              <a:rPr lang="en-US" sz="1800" dirty="0">
-                <a:solidFill>
-                  <a:srgbClr val="333333"/>
-                </a:solidFill>
-                <a:latin typeface="Arial" pitchFamily="34" charset="0"/>
-                <a:ea typeface="Arial" pitchFamily="34" charset="-122"/>
-                <a:cs typeface="Arial" pitchFamily="34" charset="-120"/>
-              </a:rPr>
-              <a:t>High biocompatibility with low hemolysis rates</a:t>
-            </a:r>
-            <a:endParaRPr lang="en-US" sz="1800" dirty="0"/>
-          </a:p>
-          <a:p>
-            <a:pPr marL="342900" indent="-342900">
-              <a:spcAft>
-                <a:spcPts val="800"/>
-              </a:spcAft>
-              <a:buSzPct val="100000"/>
-              <a:buChar char="•"/>
-            </a:pPr>
-            <a:r>
-              <a:rPr lang="en-US" sz="1800" dirty="0">
-                <a:solidFill>
-                  <a:srgbClr val="333333"/>
-                </a:solidFill>
-                <a:latin typeface="Arial" pitchFamily="34" charset="0"/>
-                <a:ea typeface="Arial" pitchFamily="34" charset="-122"/>
-                <a:cs typeface="Arial" pitchFamily="34" charset="-120"/>
-              </a:rPr>
-              <a:t>Potential applications in nanotherapeutics and wound healing</a:t>
+              <a:t>Importance of regular screening in IBD patients</a:t>
             </a:r>
             <a:endParaRPr lang="en-US" sz="1800" dirty="0"/>
           </a:p>
@@ -7530,7 +7488,7 @@
                   <a:srgbClr val="888888"/>
                 </a:solidFill>
               </a:rPr>
-              <a:t>Kaleem Muhammad, Minhas Lubna Anjum, Jabeen Amber et al.. Discover nano. 2026-06-17 DOI: 10.1186/s11671-026-04671-x</a:t>
+              <a:t>F Khan, C Norton, W Czuber-Dochan. Crohns &amp; Colitis 360. 2026</a:t>
             </a:r>
             <a:endParaRPr lang="en-US" sz="800" dirty="0"/>
           </a:p>

</xml_diff>

<commit_message>
chore: update weekly digest 2026-07-06
</commit_message>
<xml_diff>
--- a/docs/digest-en.pptx
+++ b/docs/digest-en.pptx
@@ -2249,7 +2249,7 @@
                   <a:srgbClr val="888888"/>
                 </a:solidFill>
               </a:rPr>
-              <a:t>2026-06-22 — 2026-06-29</a:t>
+              <a:t>2026-06-29 — 2026-07-06</a:t>
             </a:r>
             <a:endParaRPr lang="en-US" sz="1400" dirty="0"/>
           </a:p>
@@ -2440,7 +2440,7 @@
                   </a:extLst>
                 </a:hlinkClick>
               </a:rPr>
-              <a:t>Stem cell-based tactics in the remodeling and treatment of intestinal diseases.</a:t>
+              <a:t>Prognostic value of systemic immune-inflammation index for colorectal cancer: a systematic review and meta-analysis</a:t>
             </a:r>
             <a:endParaRPr lang="en-US" sz="2400" dirty="0"/>
           </a:p>
@@ -2476,7 +2476,7 @@
                   <a:srgbClr val="888888"/>
                 </a:solidFill>
               </a:rPr>
-              <a:t>Stem cell research &amp; therapy  ·  Prospective Study</a:t>
+              <a:t>Frontiers in Oncology  ·  Meta-Analysis</a:t>
             </a:r>
             <a:endParaRPr lang="en-US" sz="1000" dirty="0"/>
           </a:p>
@@ -2519,7 +2519,7 @@
                 <a:ea typeface="Arial" pitchFamily="34" charset="-122"/>
                 <a:cs typeface="Arial" pitchFamily="34" charset="-120"/>
               </a:rPr>
-              <a:t>Intestinal diseases cause global socioeconomic burden.</a:t>
+              <a:t>Systemic immune-inflammation index (SII) evaluated.</a:t>
             </a:r>
             <a:endParaRPr lang="en-US" sz="1800" dirty="0"/>
           </a:p>
@@ -2540,7 +2540,7 @@
                 <a:ea typeface="Arial" pitchFamily="34" charset="-122"/>
                 <a:cs typeface="Arial" pitchFamily="34" charset="-120"/>
               </a:rPr>
-              <a:t>Stem cells aid in gut-immune homeostasis restoration.</a:t>
+              <a:t>SII correlates with CRC prognosis.</a:t>
             </a:r>
             <a:endParaRPr lang="en-US" sz="1800" dirty="0"/>
           </a:p>
@@ -2561,49 +2561,7 @@
                 <a:ea typeface="Arial" pitchFamily="34" charset="-122"/>
                 <a:cs typeface="Arial" pitchFamily="34" charset="-120"/>
               </a:rPr>
-              <a:t>hPSCs and organoids used for disease remodeling.</a:t>
-            </a:r>
-            <a:endParaRPr lang="en-US" sz="1800" dirty="0"/>
-          </a:p>
-          <a:p>
-            <a:pPr marL="342900" indent="-342900">
-              <a:spcAft>
-                <a:spcPts val="800"/>
-              </a:spcAft>
-              <a:buSzPct val="100000"/>
-              <a:buChar char="•"/>
-            </a:pPr>
-            <a:r>
-              <a:rPr lang="en-US" sz="1800" dirty="0">
-                <a:solidFill>
-                  <a:srgbClr val="333333"/>
-                </a:solidFill>
-                <a:latin typeface="Arial" pitchFamily="34" charset="0"/>
-                <a:ea typeface="Arial" pitchFamily="34" charset="-122"/>
-                <a:cs typeface="Arial" pitchFamily="34" charset="-120"/>
-              </a:rPr>
-              <a:t>MSCs and microvesicles for intestinal disorder treatment.</a:t>
-            </a:r>
-            <a:endParaRPr lang="en-US" sz="1800" dirty="0"/>
-          </a:p>
-          <a:p>
-            <a:pPr marL="342900" indent="-342900">
-              <a:spcAft>
-                <a:spcPts val="800"/>
-              </a:spcAft>
-              <a:buSzPct val="100000"/>
-              <a:buChar char="•"/>
-            </a:pPr>
-            <a:r>
-              <a:rPr lang="en-US" sz="1800" dirty="0">
-                <a:solidFill>
-                  <a:srgbClr val="333333"/>
-                </a:solidFill>
-                <a:latin typeface="Arial" pitchFamily="34" charset="0"/>
-                <a:ea typeface="Arial" pitchFamily="34" charset="-122"/>
-                <a:cs typeface="Arial" pitchFamily="34" charset="-120"/>
-              </a:rPr>
-              <a:t>Challenges include ethics, heterogeneity, and standardization.</a:t>
+              <a:t>Meta-analysis of existing studies conducted.</a:t>
             </a:r>
             <a:endParaRPr lang="en-US" sz="1800" dirty="0"/>
           </a:p>
@@ -2639,7 +2597,7 @@
                   <a:srgbClr val="888888"/>
                 </a:solidFill>
               </a:rPr>
-              <a:t>Ren Yanian, Zhang Shanshan, Wang Jiageng et al.. Stem cell research &amp; therapy. 2026-06-23 DOI: 10.1186/s13287-026-05124-z</a:t>
+              <a:t>P Wang, H Jiang. Frontiers in Oncology. 2026</a:t>
             </a:r>
             <a:endParaRPr lang="en-US" sz="800" dirty="0"/>
           </a:p>
@@ -2839,7 +2797,7 @@
                   </a:extLst>
                 </a:hlinkClick>
               </a:rPr>
-              <a:t>The microbiome-epigenome axis: Regulation of host genome function across development and disease.</a:t>
+              <a:t>Intratumoral enrichment and suppressive activity of DP8&amp;#x3b1; regulatory T cells in human colorectal cancer.</a:t>
             </a:r>
             <a:endParaRPr lang="en-US" sz="2400" dirty="0"/>
           </a:p>
@@ -2875,7 +2833,7 @@
                   <a:srgbClr val="888888"/>
                 </a:solidFill>
               </a:rPr>
-              <a:t>Cancer treatment and research communications  ·  Basic Research</a:t>
+              <a:t>Oncoimmunology  ·  IF 5.9  ·  Prospective Study</a:t>
             </a:r>
             <a:endParaRPr lang="en-US" sz="1000" dirty="0"/>
           </a:p>
@@ -2918,7 +2876,7 @@
                 <a:ea typeface="Arial" pitchFamily="34" charset="-122"/>
                 <a:cs typeface="Arial" pitchFamily="34" charset="-120"/>
               </a:rPr>
-              <a:t>Gut microbiome regulates gene expression.</a:t>
+              <a:t>Identification of DP8α Tregs in CRC</a:t>
             </a:r>
             <a:endParaRPr lang="en-US" sz="1800" dirty="0"/>
           </a:p>
@@ -2939,7 +2897,7 @@
                 <a:ea typeface="Arial" pitchFamily="34" charset="-122"/>
                 <a:cs typeface="Arial" pitchFamily="34" charset="-120"/>
               </a:rPr>
-              <a:t>Microbial metabolites influence epigenetic signals.</a:t>
+              <a:t>Enrichment of DP8α Tregs in tumors</a:t>
             </a:r>
             <a:endParaRPr lang="en-US" sz="1800" dirty="0"/>
           </a:p>
@@ -2960,7 +2918,7 @@
                 <a:ea typeface="Arial" pitchFamily="34" charset="-122"/>
                 <a:cs typeface="Arial" pitchFamily="34" charset="-120"/>
               </a:rPr>
-              <a:t>Dysbiosis linked to various diseases.</a:t>
+              <a:t>Suppression of T-cell proliferation by DP8α Tregs</a:t>
             </a:r>
             <a:endParaRPr lang="en-US" sz="1800" dirty="0"/>
           </a:p>
@@ -2996,7 +2954,7 @@
                   <a:srgbClr val="888888"/>
                 </a:solidFill>
               </a:rPr>
-              <a:t>Abuhassan Qamar, Atoom Ali M, Ganesan Subbulakshmi et al.. Cancer treatment and research communications. 2026-06-27 DOI: 10.1016/j.ctarc.2026.101299</a:t>
+              <a:t>Deiber Mathilde, Deleine C&amp;#xe9;cile, Gervois-Segain Nadine et al.. Oncoimmunology. 2026-07-03 DOI: 10.1080/2162402X.2026.2696069</a:t>
             </a:r>
             <a:endParaRPr lang="en-US" sz="800" dirty="0"/>
           </a:p>
@@ -3196,7 +3154,7 @@
                   </a:extLst>
                 </a:hlinkClick>
               </a:rPr>
-              <a:t>Environmental enrichment suppresses colorectal cancer progression with comorbid depression by modulating the immunosuppressive tumor microenvironment.</a:t>
+              <a:t>Awareness of inflammatory bowel disease-associated colorectal cancer risk and its management in patients with inflammatory bowel disease: a systematic review</a:t>
             </a:r>
             <a:endParaRPr lang="en-US" sz="2400" dirty="0"/>
           </a:p>
@@ -3232,7 +3190,7 @@
                   <a:srgbClr val="888888"/>
                 </a:solidFill>
               </a:rPr>
-              <a:t>Biochemical and biophysical research communications  ·  Basic Research</a:t>
+              <a:t>Crohns &amp; Colitis 360  ·  Systematic Review</a:t>
             </a:r>
             <a:endParaRPr lang="en-US" sz="1000" dirty="0"/>
           </a:p>
@@ -3275,7 +3233,7 @@
                 <a:ea typeface="Arial" pitchFamily="34" charset="-122"/>
                 <a:cs typeface="Arial" pitchFamily="34" charset="-120"/>
               </a:rPr>
-              <a:t>Environmental enrichment reduces tumor growth.</a:t>
+              <a:t>Limited awareness of colorectal cancer risk</a:t>
             </a:r>
             <a:endParaRPr lang="en-US" sz="1800" dirty="0"/>
           </a:p>
@@ -3296,7 +3254,7 @@
                 <a:ea typeface="Arial" pitchFamily="34" charset="-122"/>
                 <a:cs typeface="Arial" pitchFamily="34" charset="-120"/>
               </a:rPr>
-              <a:t>Depression worsens CRC treatment outcomes.</a:t>
+              <a:t>Need for better management strategies</a:t>
             </a:r>
             <a:endParaRPr lang="en-US" sz="1800" dirty="0"/>
           </a:p>
@@ -3317,49 +3275,7 @@
                 <a:ea typeface="Arial" pitchFamily="34" charset="-122"/>
                 <a:cs typeface="Arial" pitchFamily="34" charset="-120"/>
               </a:rPr>
-              <a:t>EE improves immune response in CRC.</a:t>
-            </a:r>
-            <a:endParaRPr lang="en-US" sz="1800" dirty="0"/>
-          </a:p>
-          <a:p>
-            <a:pPr marL="342900" indent="-342900">
-              <a:spcAft>
-                <a:spcPts val="800"/>
-              </a:spcAft>
-              <a:buSzPct val="100000"/>
-              <a:buChar char="•"/>
-            </a:pPr>
-            <a:r>
-              <a:rPr lang="en-US" sz="1800" dirty="0">
-                <a:solidFill>
-                  <a:srgbClr val="333333"/>
-                </a:solidFill>
-                <a:latin typeface="Arial" pitchFamily="34" charset="0"/>
-                <a:ea typeface="Arial" pitchFamily="34" charset="-122"/>
-                <a:cs typeface="Arial" pitchFamily="34" charset="-120"/>
-              </a:rPr>
-              <a:t>CUMS increases tumor progression and mortality.</a:t>
-            </a:r>
-            <a:endParaRPr lang="en-US" sz="1800" dirty="0"/>
-          </a:p>
-          <a:p>
-            <a:pPr marL="342900" indent="-342900">
-              <a:spcAft>
-                <a:spcPts val="800"/>
-              </a:spcAft>
-              <a:buSzPct val="100000"/>
-              <a:buChar char="•"/>
-            </a:pPr>
-            <a:r>
-              <a:rPr lang="en-US" sz="1800" dirty="0">
-                <a:solidFill>
-                  <a:srgbClr val="333333"/>
-                </a:solidFill>
-                <a:latin typeface="Arial" pitchFamily="34" charset="0"/>
-                <a:ea typeface="Arial" pitchFamily="34" charset="-122"/>
-                <a:cs typeface="Arial" pitchFamily="34" charset="-120"/>
-              </a:rPr>
-              <a:t>EE enhances CD8+T cell infiltration.</a:t>
+              <a:t>Importance of patient education</a:t>
             </a:r>
             <a:endParaRPr lang="en-US" sz="1800" dirty="0"/>
           </a:p>
@@ -3395,7 +3311,7 @@
                   <a:srgbClr val="888888"/>
                 </a:solidFill>
               </a:rPr>
-              <a:t>Song Jia, Zhao Liming, Zhou Shengwen et al.. Biochemical and biophysical research communications. 2026-05-09 DOI: 10.1016/j.bbrc.2026.153771</a:t>
+              <a:t>F Khan, C Norton, W Czuber-Dochan. Crohns &amp; Colitis 360. 2026</a:t>
             </a:r>
             <a:endParaRPr lang="en-US" sz="800" dirty="0"/>
           </a:p>
@@ -3586,7 +3502,7 @@
                   <a:srgbClr val="FFFFFF"/>
                 </a:solidFill>
               </a:rPr>
-              <a:t>### 綜合啟示 (Overall Insights)</a:t>
+              <a:t>### 綜合啟示（Overall Insights）</a:t>
             </a:r>
             <a:endParaRPr lang="en-US" sz="1200" dirty="0"/>
           </a:p>
@@ -3612,7 +3528,7 @@
                   <a:srgbClr val="FFFFFF"/>
                 </a:solidFill>
               </a:rPr>
-              <a:t>1. **微生物組與癌症的關聯性**  </a:t>
+              <a:t>1. **新型治療策略的潛力**  </a:t>
             </a:r>
             <a:endParaRPr lang="en-US" sz="1200" dirty="0"/>
           </a:p>
@@ -3629,7 +3545,7 @@
                   <a:srgbClr val="FFFFFF"/>
                 </a:solidFill>
               </a:rPr>
-              <a:t>   The gut microbiome plays a critical role in carcinogenesis and immune regulation, highlighting its potential as a therapeutic target in colorectal cancer and other malignancies.  </a:t>
+              <a:t>   The combination of neoadjuvant toripalimab and celecoxib demonstrates enhanced efficacy in dMMR/MSI-H colorectal cancer, indicating the potential of combining immunotherapy with COX-2 inhibition to improve treatment outcomes.  </a:t>
             </a:r>
             <a:endParaRPr lang="en-US" sz="1200" dirty="0"/>
           </a:p>
@@ -3646,7 +3562,7 @@
                   <a:srgbClr val="FFFFFF"/>
                 </a:solidFill>
               </a:rPr>
-              <a:t>   微生物組在癌症發生和免疫調節中扮演關鍵角色，突顯其在結直腸癌及其他惡性腫瘤治療中的潛在療效。</a:t>
+              <a:t>   新型的neoadjuvant治療策略，結合toripalimab與celecoxib，顯示在dMMR/MSI-H大腸癌中具增強療效，顯示出將免疫治療與COX-2抑制劑結合的潛力。</a:t>
             </a:r>
             <a:endParaRPr lang="en-US" sz="1200" dirty="0"/>
           </a:p>
@@ -3672,7 +3588,7 @@
                   <a:srgbClr val="FFFFFF"/>
                 </a:solidFill>
               </a:rPr>
-              <a:t>2. **免疫炎症指數的預後價值**  </a:t>
+              <a:t>2. **手術與全身治療的比較**  </a:t>
             </a:r>
             <a:endParaRPr lang="en-US" sz="1200" dirty="0"/>
           </a:p>
@@ -3689,7 +3605,7 @@
                   <a:srgbClr val="FFFFFF"/>
                 </a:solidFill>
               </a:rPr>
-              <a:t>   The systemic immune-inflammation index (SII) has emerged as a significant prognostic biomarker for colorectal cancer, indicating the importance of immune status in cancer outcomes.  </a:t>
+              <a:t>   The CAIRO6 trial highlights the importance of evaluating perioperative systemic therapy versus surgery alone, suggesting that systemic therapy may enhance outcomes in patients with resectable colorectal peritoneal metastases.  </a:t>
             </a:r>
             <a:endParaRPr lang="en-US" sz="1200" dirty="0"/>
           </a:p>
@@ -3706,7 +3622,7 @@
                   <a:srgbClr val="FFFFFF"/>
                 </a:solidFill>
               </a:rPr>
-              <a:t>   系統免疫炎症指數（SII）已成為結直腸癌的重要預後生物標誌，顯示免疫狀態對癌症結果的重要性。</a:t>
+              <a:t>   CAIRO6試驗強調評估圍手術期全身治療與單獨手術的重要性，暗示全身治療可能改善可切除大腸癌腹膜轉移患者的預後。</a:t>
             </a:r>
             <a:endParaRPr lang="en-US" sz="1200" dirty="0"/>
           </a:p>
@@ -3732,7 +3648,7 @@
                   <a:srgbClr val="FFFFFF"/>
                 </a:solidFill>
               </a:rPr>
-              <a:t>3. **慢性炎症與結直腸癌的關聯**  </a:t>
+              <a:t>3. **腫瘤微環境的調節**  </a:t>
             </a:r>
             <a:endParaRPr lang="en-US" sz="1200" dirty="0"/>
           </a:p>
@@ -3749,7 +3665,7 @@
                   <a:srgbClr val="FFFFFF"/>
                 </a:solidFill>
               </a:rPr>
-              <a:t>   Chronic inflammation is a driving factor in colitis-associated colorectal cancer, emphasizing the need for targeted therapies that address inflammation in cancer management.  </a:t>
+              <a:t>   Research on glutamine antagonism reveals that reprogramming macrophage immunometabolism can significantly enhance the efficacy of colorectal cancer therapies, emphasizing the role of the tumor microenvironment in treatment response.  </a:t>
             </a:r>
             <a:endParaRPr lang="en-US" sz="1200" dirty="0"/>
           </a:p>
@@ -3766,7 +3682,7 @@
                   <a:srgbClr val="FFFFFF"/>
                 </a:solidFill>
               </a:rPr>
-              <a:t>   慢性炎症是結腸炎相關結直腸癌的驅動因素，強調在癌症管理中針對炎症的治療需求。</a:t>
+              <a:t>   針對谷氨酸拮抗劑的研究顯示，重編程巨噬細胞免疫代謝可顯著提高大腸癌治療的療效，強調腫瘤微環境在治療反應中的角色。</a:t>
             </a:r>
             <a:endParaRPr lang="en-US" sz="1200" dirty="0"/>
           </a:p>
@@ -3792,7 +3708,7 @@
                   <a:srgbClr val="FFFFFF"/>
                 </a:solidFill>
               </a:rPr>
-              <a:t>4. **新型生物標誌物的發現**  </a:t>
+              <a:t>4. **生物標記物的潛力**  </a:t>
             </a:r>
             <a:endParaRPr lang="en-US" sz="1200" dirty="0"/>
           </a:p>
@@ -3809,7 +3725,7 @@
                   <a:srgbClr val="FFFFFF"/>
                 </a:solidFill>
               </a:rPr>
-              <a:t>   The identification of novel biomarkers, such as S100P for sessile serrated lesions, may enhance early detection and treatment strategies for colorectal cancer.  </a:t>
+              <a:t>   The exploration of FTCD as a prognostic biomarker suggests that metabolic pathways may serve as critical targets for therapeutic intervention in colorectal cancer.  </a:t>
             </a:r>
             <a:endParaRPr lang="en-US" sz="1200" dirty="0"/>
           </a:p>
@@ -3826,7 +3742,7 @@
                   <a:srgbClr val="FFFFFF"/>
                 </a:solidFill>
               </a:rPr>
-              <a:t>   新型生物標誌物的發現，如S100P對於平坦狹窄病變的預測，可能增強結直腸癌的早期檢測和治療策略。</a:t>
+              <a:t>   FTCD作為預後生物標記物的研究表明，代謝途徑可能成為大腸癌治療干預的關鍵目標。</a:t>
             </a:r>
             <a:endParaRPr lang="en-US" sz="1200" dirty="0"/>
           </a:p>
@@ -3852,7 +3768,7 @@
                   <a:srgbClr val="FFFFFF"/>
                 </a:solidFill>
               </a:rPr>
-              <a:t>5. **環境因素對癌症進展的影響**  </a:t>
+              <a:t>5. **系統性炎症指數的預測價值**  </a:t>
             </a:r>
             <a:endParaRPr lang="en-US" sz="1200" dirty="0"/>
           </a:p>
@@ -3869,7 +3785,7 @@
                   <a:srgbClr val="FFFFFF"/>
                 </a:solidFill>
               </a:rPr>
-              <a:t>   Environmental enrichment has shown potential in suppressing colorectal cancer progression, suggesting that lifestyle modifications could play a role in cancer therapy.</a:t>
+              <a:t>   The systemic immune-inflammation index (SII) has emerged as a promising prognostic biomarker, indicating that systemic inflammatory responses may play a significant role in colorectal cancer progression and outcomes.</a:t>
             </a:r>
             <a:endParaRPr lang="en-US" sz="1200" dirty="0"/>
           </a:p>
@@ -4015,7 +3931,7 @@
                   <a:srgbClr val="FFFFFF"/>
                 </a:solidFill>
               </a:rPr>
-              <a:t>環境豐富化顯示出抑制結直腸癌進展的潛力，暗示生活方式的改變可能在癌症治療中扮演角色。</a:t>
+              <a:t>系統性免疫炎症指數（SII）已成為有前景的預後生物標記物，表明系統性炎症反應可能在大腸癌的進展和預後中起重要作用。</a:t>
             </a:r>
             <a:endParaRPr lang="en-US" sz="1200" dirty="0"/>
           </a:p>
@@ -4041,7 +3957,7 @@
                   <a:srgbClr val="FFFFFF"/>
                 </a:solidFill>
               </a:rPr>
-              <a:t>### 未來研究方向 (Future Research Directions)</a:t>
+              <a:t>### 未來研究方向（Future Research Directions）</a:t>
             </a:r>
             <a:endParaRPr lang="en-US" sz="1200" dirty="0"/>
           </a:p>
@@ -4067,7 +3983,7 @@
                   <a:srgbClr val="FFFFFF"/>
                 </a:solidFill>
               </a:rPr>
-              <a:t>1. **微生物組的治療應用**  </a:t>
+              <a:t>1. **免疫治療的優化**  </a:t>
             </a:r>
             <a:endParaRPr lang="en-US" sz="1200" dirty="0"/>
           </a:p>
@@ -4084,7 +4000,7 @@
                   <a:srgbClr val="FFFFFF"/>
                 </a:solidFill>
               </a:rPr>
-              <a:t>   Future studies should explore the therapeutic manipulation of the gut microbiome to enhance immune responses in colorectal cancer treatment.  </a:t>
+              <a:t>   Future studies should focus on optimizing combination therapies involving immune checkpoint inhibitors and anti-inflammatory agents to maximize therapeutic efficacy in colorectal cancer.  </a:t>
             </a:r>
             <a:endParaRPr lang="en-US" sz="1200" dirty="0"/>
           </a:p>
@@ -4101,7 +4017,7 @@
                   <a:srgbClr val="FFFFFF"/>
                 </a:solidFill>
               </a:rPr>
-              <a:t>   未來的研究應探討微生物組的治療性操控，以增強結直腸癌治療中的免疫反應。</a:t>
+              <a:t>   未來研究應集中於優化免疫檢查點抑制劑與抗炎藥物的聯合療法，以最大化大腸癌的治療效果。</a:t>
             </a:r>
             <a:endParaRPr lang="en-US" sz="1200" dirty="0"/>
           </a:p>
@@ -4127,7 +4043,7 @@
                   <a:srgbClr val="FFFFFF"/>
                 </a:solidFill>
               </a:rPr>
-              <a:t>2. **炎症與癌症的交互作用**  </a:t>
+              <a:t>2. **腫瘤微環境的深入研究**  </a:t>
             </a:r>
             <a:endParaRPr lang="en-US" sz="1200" dirty="0"/>
           </a:p>
@@ -4144,7 +4060,7 @@
                   <a:srgbClr val="FFFFFF"/>
                 </a:solidFill>
               </a:rPr>
-              <a:t>   Investigating the complex interactions between chronic inflammation and cancer progression could lead to novel therapeutic strategies targeting both pathways.  </a:t>
+              <a:t>   Investigating the role of the tumor microenvironment in mediating treatment responses will be crucial for developing targeted therapies that can overcome resistance mechanisms in colorectal cancer.  </a:t>
             </a:r>
             <a:endParaRPr lang="en-US" sz="1200" dirty="0"/>
           </a:p>
@@ -4161,7 +4077,7 @@
                   <a:srgbClr val="FFFFFF"/>
                 </a:solidFill>
               </a:rPr>
-              <a:t>   探討慢性炎症與癌症進展之間的複雜交互作用，可能導致針對兩者路徑的新型治療策略。</a:t>
+              <a:t>   深入研究腫瘤微環境在治療反應中的作用，對於開發能克服大腸癌抵抗機制的靶向療法至關重要。</a:t>
             </a:r>
             <a:endParaRPr lang="en-US" sz="1200" dirty="0"/>
           </a:p>
@@ -4187,7 +4103,7 @@
                   <a:srgbClr val="FFFFFF"/>
                 </a:solidFill>
               </a:rPr>
-              <a:t>3. **生物標誌物的臨床應用**  </a:t>
+              <a:t>3. **新生物標記物的發現**  </a:t>
             </a:r>
             <a:endParaRPr lang="en-US" sz="1200" dirty="0"/>
           </a:p>
@@ -4204,7 +4120,7 @@
                   <a:srgbClr val="FFFFFF"/>
                 </a:solidFill>
               </a:rPr>
-              <a:t>   Further validation of emerging biomarkers like S100P in clinical settings is essential for improving diagnostic accuracy and treatment personalization.  </a:t>
+              <a:t>   Continued exploration of novel biomarkers, such as FTCD and SII, will enhance our understanding of colorectal cancer prognosis and may lead to more personalized treatment approaches.  </a:t>
             </a:r>
             <a:endParaRPr lang="en-US" sz="1200" dirty="0"/>
           </a:p>
@@ -4221,7 +4137,7 @@
                   <a:srgbClr val="FFFFFF"/>
                 </a:solidFill>
               </a:rPr>
-              <a:t>   對新興生物標誌物如S100P在臨床環境中的進一步驗證對於提高診斷準確性和治療個性化至關重要。</a:t>
+              <a:t>   持續探索新生物標記物，如FTCD和SII，將增進我們對大腸癌預後的理解，並可能導致更個性化的治療方法。</a:t>
             </a:r>
             <a:endParaRPr lang="en-US" sz="1200" dirty="0"/>
           </a:p>
@@ -4247,7 +4163,7 @@
                   <a:srgbClr val="FFFFFF"/>
                 </a:solidFill>
               </a:rPr>
-              <a:t>4. **心理健康與癌症治療的關聯**  </a:t>
+              <a:t>4. **炎症與腫瘤進展的關聯**  </a:t>
             </a:r>
             <a:endParaRPr lang="en-US" sz="1200" dirty="0"/>
           </a:p>
@@ -4264,7 +4180,7 @@
                   <a:srgbClr val="FFFFFF"/>
                 </a:solidFill>
               </a:rPr>
-              <a:t>   Research should focus on the impact of mental health interventions on cancer outcomes, particularly in patients with comorbid conditions like depression.  </a:t>
+              <a:t>   Research should further investigate the relationship between systemic inflammation and colorectal cancer progression, potentially identifying new therapeutic targets.  </a:t>
             </a:r>
             <a:endParaRPr lang="en-US" sz="1200" dirty="0"/>
           </a:p>
@@ -4281,7 +4197,7 @@
                   <a:srgbClr val="FFFFFF"/>
                 </a:solidFill>
               </a:rPr>
-              <a:t>   研究應聚焦於心理健康干預對癌症結果的影響，特別是在合併症如抑鬱症患者中的效果。</a:t>
+              <a:t>   研究應進一步探討系統性炎症與大腸癌進展之間的關聯，可能識別新的治療靶點。</a:t>
             </a:r>
             <a:endParaRPr lang="en-US" sz="1200" dirty="0"/>
           </a:p>
@@ -4307,7 +4223,7 @@
                   <a:srgbClr val="FFFFFF"/>
                 </a:solidFill>
               </a:rPr>
-              <a:t>5. **多組學整合研究**  </a:t>
+              <a:t>5. **臨床試驗的擴展**  </a:t>
             </a:r>
             <a:endParaRPr lang="en-US" sz="1200" dirty="0"/>
           </a:p>
@@ -4324,7 +4240,7 @@
                   <a:srgbClr val="FFFFFF"/>
                 </a:solidFill>
               </a:rPr>
-              <a:t>   Integrative multi-omics approaches could provide deeper insights into the molecular mechanisms driving colorectal cancer, paving the way for innovative treatments.  </a:t>
+              <a:t>   Expanding clinical trials to include diverse patient populations and treatment regimens will provide more comprehensive data on the efficacy of emerging therapies for colorectal cancer.  </a:t>
             </a:r>
             <a:endParaRPr lang="en-US" sz="1200" dirty="0"/>
           </a:p>
@@ -4341,7 +4257,7 @@
                   <a:srgbClr val="FFFFFF"/>
                 </a:solidFill>
               </a:rPr>
-              <a:t>   整合多組學的方法可以深入了解驅動結直腸癌的分子機制，為創新治療鋪平道路。</a:t>
+              <a:t>   擴大臨床試驗以納入多樣化的患者群體和治療方案，將提供有關新興大腸癌療法療效的更全面數據。</a:t>
             </a:r>
             <a:endParaRPr lang="en-US" sz="1200" dirty="0"/>
           </a:p>
@@ -4575,7 +4491,7 @@
                 <a:ea typeface="Arial" pitchFamily="34" charset="-122"/>
                 <a:cs typeface="Arial" pitchFamily="34" charset="-120"/>
               </a:rPr>
-              <a:t>ORCHESTRA hits a sour note for debulking in metastatic colorectal cancer</a:t>
+              <a:t>Neoadjuvant toripalimab plus celecoxib versus toripalimab monotherapy for mismat…</a:t>
             </a:r>
             <a:endParaRPr lang="en-US" sz="1400" dirty="0"/>
           </a:p>
@@ -4612,7 +4528,7 @@
                 <a:ea typeface="Arial" pitchFamily="34" charset="-122"/>
                 <a:cs typeface="Arial" pitchFamily="34" charset="-120"/>
               </a:rPr>
-              <a:t>Microbiome-Driven Carcinogenesis and Circulating Microbial Signals in Genitourin…</a:t>
+              <a:t>Perioperative systemic therapy versus surgery alone for resectable colorectal pe…</a:t>
             </a:r>
             <a:endParaRPr lang="en-US" sz="1400" dirty="0"/>
           </a:p>
@@ -4649,7 +4565,7 @@
                 <a:ea typeface="Arial" pitchFamily="34" charset="-122"/>
                 <a:cs typeface="Arial" pitchFamily="34" charset="-120"/>
               </a:rPr>
-              <a:t>Stage-associated remodeling of CD169 macrophage states is linked to immune regul…</a:t>
+              <a:t>Reprogramming macrophage immunometabolism via glutamine antagonism potentiates c…</a:t>
             </a:r>
             <a:endParaRPr lang="en-US" sz="1400" dirty="0"/>
           </a:p>
@@ -4686,7 +4602,7 @@
                 <a:ea typeface="Arial" pitchFamily="34" charset="-122"/>
                 <a:cs typeface="Arial" pitchFamily="34" charset="-120"/>
               </a:rPr>
-              <a:t>Integrative Transcriptomic and Proteomic Profiling Identifies S100P as a Potenti…</a:t>
+              <a:t>Norisoboldine suppresses epithelial-mesenchymal transition in colorectal cancer …</a:t>
             </a:r>
             <a:endParaRPr lang="en-US" sz="1400" dirty="0"/>
           </a:p>
@@ -4723,7 +4639,7 @@
                 <a:ea typeface="Arial" pitchFamily="34" charset="-122"/>
                 <a:cs typeface="Arial" pitchFamily="34" charset="-120"/>
               </a:rPr>
-              <a:t>Effect of hyperthermic intraperitoneal chemotherapy on patients with advanced co…</a:t>
+              <a:t>Analysis of Formimidoyltransferase Cyclodeaminase as a Potential Prognostic Biom…</a:t>
             </a:r>
             <a:endParaRPr lang="en-US" sz="1400" dirty="0"/>
           </a:p>
@@ -4760,7 +4676,7 @@
                 <a:ea typeface="Arial" pitchFamily="34" charset="-122"/>
                 <a:cs typeface="Arial" pitchFamily="34" charset="-120"/>
               </a:rPr>
-              <a:t>Prognostic value of systemic immune-inflammation index for colorectal cancer: a …</a:t>
+              <a:t>Outcomes reported in studies of anal high-grade squamous intraepithelial lesions…</a:t>
             </a:r>
             <a:endParaRPr lang="en-US" sz="1400" dirty="0"/>
           </a:p>
@@ -4797,7 +4713,7 @@
                 <a:ea typeface="Arial" pitchFamily="34" charset="-122"/>
                 <a:cs typeface="Arial" pitchFamily="34" charset="-120"/>
               </a:rPr>
-              <a:t>Awareness of inflammatory bowel disease-associated colorectal cancer risk and it…</a:t>
+              <a:t>Association of Pre-treatment CALLY Index With Pathological Response to Neoadjuva…</a:t>
             </a:r>
             <a:endParaRPr lang="en-US" sz="1400" dirty="0"/>
           </a:p>
@@ -4834,7 +4750,7 @@
                 <a:ea typeface="Arial" pitchFamily="34" charset="-122"/>
                 <a:cs typeface="Arial" pitchFamily="34" charset="-120"/>
               </a:rPr>
-              <a:t>Stem cell-based tactics in the remodeling and treatment of intestinal diseases.</a:t>
+              <a:t>Prognostic value of systemic immune-inflammation index for colorectal cancer: a …</a:t>
             </a:r>
             <a:endParaRPr lang="en-US" sz="1400" dirty="0"/>
           </a:p>
@@ -4871,7 +4787,7 @@
                 <a:ea typeface="Arial" pitchFamily="34" charset="-122"/>
                 <a:cs typeface="Arial" pitchFamily="34" charset="-120"/>
               </a:rPr>
-              <a:t>The microbiome-epigenome axis: Regulation of host genome function across develop…</a:t>
+              <a:t>Intratumoral enrichment and suppressive activity of DP8&amp;#x3b1; regulatory T cell…</a:t>
             </a:r>
             <a:endParaRPr lang="en-US" sz="1400" dirty="0"/>
           </a:p>
@@ -4908,7 +4824,7 @@
                 <a:ea typeface="Arial" pitchFamily="34" charset="-122"/>
                 <a:cs typeface="Arial" pitchFamily="34" charset="-120"/>
               </a:rPr>
-              <a:t>Environmental enrichment suppresses colorectal cancer progression with comorbid …</a:t>
+              <a:t>Awareness of inflammatory bowel disease-associated colorectal cancer risk and it…</a:t>
             </a:r>
             <a:endParaRPr lang="en-US" sz="1400" dirty="0"/>
           </a:p>
@@ -5063,7 +4979,7 @@
                   </a:extLst>
                 </a:hlinkClick>
               </a:rPr>
-              <a:t>ORCHESTRA hits a sour note for debulking in metastatic colorectal cancer</a:t>
+              <a:t>Neoadjuvant toripalimab plus celecoxib versus toripalimab monotherapy for mismatch repair-deficient or microsatellite instability-high, locally advanced colorectal cancer (PICC-2): an open-label, multicentre, randomised, phase 2 trial.</a:t>
             </a:r>
             <a:endParaRPr lang="en-US" sz="2400" dirty="0"/>
           </a:p>
@@ -5099,7 +5015,7 @@
                   <a:srgbClr val="888888"/>
                 </a:solidFill>
               </a:rPr>
-              <a:t>JAMA  ·  IF 63.1</a:t>
+              <a:t>The Lancet. Oncology  ·  IF 41.6  ·  RCT Phase 3</a:t>
             </a:r>
             <a:endParaRPr lang="en-US" sz="1000" dirty="0"/>
           </a:p>
@@ -5142,7 +5058,7 @@
                 <a:ea typeface="Arial" pitchFamily="34" charset="-122"/>
                 <a:cs typeface="Arial" pitchFamily="34" charset="-120"/>
               </a:rPr>
-              <a:t>ORCHESTRA trial evaluates debulking surgery</a:t>
+              <a:t>Neoadjuvant therapy for dMMR/MSI-H cancer</a:t>
             </a:r>
             <a:endParaRPr lang="en-US" sz="1800" dirty="0"/>
           </a:p>
@@ -5163,7 +5079,7 @@
                 <a:ea typeface="Arial" pitchFamily="34" charset="-122"/>
                 <a:cs typeface="Arial" pitchFamily="34" charset="-120"/>
               </a:rPr>
-              <a:t>Focus on metastatic colorectal cancer patients</a:t>
+              <a:t>Combination of toripalimab and celecoxib</a:t>
             </a:r>
             <a:endParaRPr lang="en-US" sz="1800" dirty="0"/>
           </a:p>
@@ -5184,7 +5100,7 @@
                 <a:ea typeface="Arial" pitchFamily="34" charset="-122"/>
                 <a:cs typeface="Arial" pitchFamily="34" charset="-120"/>
               </a:rPr>
-              <a:t>Results indicate limited survival benefit</a:t>
+              <a:t>Higher pathological complete response rate</a:t>
             </a:r>
             <a:endParaRPr lang="en-US" sz="1800" dirty="0"/>
           </a:p>
@@ -5220,7 +5136,7 @@
                   <a:srgbClr val="888888"/>
                 </a:solidFill>
               </a:rPr>
-              <a:t>M Fakih. JAMA. 2026</a:t>
+              <a:t>Hu Huabin, Shen Xutao, Li Yunfeng et al.. The Lancet. Oncology. 2026-07-01 DOI: 10.1016/S1470-2045(26)00220-2</a:t>
             </a:r>
             <a:endParaRPr lang="en-US" sz="800" dirty="0"/>
           </a:p>
@@ -5420,7 +5336,7 @@
                   </a:extLst>
                 </a:hlinkClick>
               </a:rPr>
-              <a:t>Microbiome-Driven Carcinogenesis and Circulating Microbial Signals in Genitourinary Cancers.</a:t>
+              <a:t>Perioperative systemic therapy versus surgery alone for resectable colorectal peritoneal-only metastases (CAIRO6): a randomised, open-label, phase 3 trial.</a:t>
             </a:r>
             <a:endParaRPr lang="en-US" sz="2400" dirty="0"/>
           </a:p>
@@ -5456,7 +5372,7 @@
                   <a:srgbClr val="888888"/>
                 </a:solidFill>
               </a:rPr>
-              <a:t>Cancer science  ·  Basic Research  ·  🌏 Asia</a:t>
+              <a:t>The Lancet. Oncology  ·  IF 41.6  ·  RCT Phase 3</a:t>
             </a:r>
             <a:endParaRPr lang="en-US" sz="1000" dirty="0"/>
           </a:p>
@@ -5499,7 +5415,7 @@
                 <a:ea typeface="Arial" pitchFamily="34" charset="-122"/>
                 <a:cs typeface="Arial" pitchFamily="34" charset="-120"/>
               </a:rPr>
-              <a:t>Microbiome influences genitourinary cancers.</a:t>
+              <a:t>Study compares systemic therapy and surgery alone</a:t>
             </a:r>
             <a:endParaRPr lang="en-US" sz="1800" dirty="0"/>
           </a:p>
@@ -5520,7 +5436,7 @@
                 <a:ea typeface="Arial" pitchFamily="34" charset="-122"/>
                 <a:cs typeface="Arial" pitchFamily="34" charset="-120"/>
               </a:rPr>
-              <a:t>Gut microbes affect tumor initiation and immunity.</a:t>
+              <a:t>358 patients enrolled in the trial</a:t>
             </a:r>
             <a:endParaRPr lang="en-US" sz="1800" dirty="0"/>
           </a:p>
@@ -5541,7 +5457,49 @@
                 <a:ea typeface="Arial" pitchFamily="34" charset="-122"/>
                 <a:cs typeface="Arial" pitchFamily="34" charset="-120"/>
               </a:rPr>
-              <a:t>Circulating microbial signals linked to ICI outcomes.</a:t>
+              <a:t>Median overall survival: 44 vs 39 months</a:t>
+            </a:r>
+            <a:endParaRPr lang="en-US" sz="1800" dirty="0"/>
+          </a:p>
+          <a:p>
+            <a:pPr marL="342900" indent="-342900">
+              <a:spcAft>
+                <a:spcPts val="800"/>
+              </a:spcAft>
+              <a:buSzPct val="100000"/>
+              <a:buChar char="•"/>
+            </a:pPr>
+            <a:r>
+              <a:rPr lang="en-US" sz="1800" dirty="0">
+                <a:solidFill>
+                  <a:srgbClr val="333333"/>
+                </a:solidFill>
+                <a:latin typeface="Arial" pitchFamily="34" charset="0"/>
+                <a:ea typeface="Arial" pitchFamily="34" charset="-122"/>
+                <a:cs typeface="Arial" pitchFamily="34" charset="-120"/>
+              </a:rPr>
+              <a:t>Higher postoperative morbidity in systemic therapy group</a:t>
+            </a:r>
+            <a:endParaRPr lang="en-US" sz="1800" dirty="0"/>
+          </a:p>
+          <a:p>
+            <a:pPr marL="342900" indent="-342900">
+              <a:spcAft>
+                <a:spcPts val="800"/>
+              </a:spcAft>
+              <a:buSzPct val="100000"/>
+              <a:buChar char="•"/>
+            </a:pPr>
+            <a:r>
+              <a:rPr lang="en-US" sz="1800" dirty="0">
+                <a:solidFill>
+                  <a:srgbClr val="333333"/>
+                </a:solidFill>
+                <a:latin typeface="Arial" pitchFamily="34" charset="0"/>
+                <a:ea typeface="Arial" pitchFamily="34" charset="-122"/>
+                <a:cs typeface="Arial" pitchFamily="34" charset="-120"/>
+              </a:rPr>
+              <a:t>Major toxicity observed in 57% of patients</a:t>
             </a:r>
             <a:endParaRPr lang="en-US" sz="1800" dirty="0"/>
           </a:p>
@@ -5577,7 +5535,7 @@
                   <a:srgbClr val="888888"/>
                 </a:solidFill>
               </a:rPr>
-              <a:t>Kawashima Atsunari, Jingushi Kentaro, Saito Takuro et al.. Cancer science. 2026-06-23 DOI: 10.1111/cas.70448</a:t>
+              <a:t>Rovers Koen P, Bakkers Checca, van den Heuvel Teun B M et al.. The Lancet. Oncology. 2026-06-29 DOI: 10.1016/S1470-2045(26)00085-9</a:t>
             </a:r>
             <a:endParaRPr lang="en-US" sz="800" dirty="0"/>
           </a:p>
@@ -5777,7 +5735,7 @@
                   </a:extLst>
                 </a:hlinkClick>
               </a:rPr>
-              <a:t>Stage-associated remodeling of CD169 macrophage states is linked to immune regulation in colitis-associated colorectal cancer.</a:t>
+              <a:t>Reprogramming macrophage immunometabolism via glutamine antagonism potentiates colorectal cancer therapy in mice.</a:t>
             </a:r>
             <a:endParaRPr lang="en-US" sz="2400" dirty="0"/>
           </a:p>
@@ -5813,7 +5771,7 @@
                   <a:srgbClr val="888888"/>
                 </a:solidFill>
               </a:rPr>
-              <a:t>Journal of gastroenterology  ·  🌏 Asia</a:t>
+              <a:t>Nature communications  ·  IF 14.7  ·  Basic Research</a:t>
             </a:r>
             <a:endParaRPr lang="en-US" sz="1000" dirty="0"/>
           </a:p>
@@ -5856,7 +5814,7 @@
                 <a:ea typeface="Arial" pitchFamily="34" charset="-122"/>
                 <a:cs typeface="Arial" pitchFamily="34" charset="-120"/>
               </a:rPr>
-              <a:t>CD169 macrophages show stage-specific roles.</a:t>
+              <a:t>Glutamine metabolism promotes immunosuppressive macrophages.</a:t>
             </a:r>
             <a:endParaRPr lang="en-US" sz="1800" dirty="0"/>
           </a:p>
@@ -5877,7 +5835,7 @@
                 <a:ea typeface="Arial" pitchFamily="34" charset="-122"/>
                 <a:cs typeface="Arial" pitchFamily="34" charset="-120"/>
               </a:rPr>
-              <a:t>CD169-low macrophages are pro-inflammatory.</a:t>
+              <a:t>WGF-T17 reprograms macrophages to inflammatory state.</a:t>
             </a:r>
             <a:endParaRPr lang="en-US" sz="1800" dirty="0"/>
           </a:p>
@@ -5898,49 +5856,7 @@
                 <a:ea typeface="Arial" pitchFamily="34" charset="-122"/>
                 <a:cs typeface="Arial" pitchFamily="34" charset="-120"/>
               </a:rPr>
-              <a:t>CD169-mid/high macrophages are immunosuppressive.</a:t>
-            </a:r>
-            <a:endParaRPr lang="en-US" sz="1800" dirty="0"/>
-          </a:p>
-          <a:p>
-            <a:pPr marL="342900" indent="-342900">
-              <a:spcAft>
-                <a:spcPts val="800"/>
-              </a:spcAft>
-              <a:buSzPct val="100000"/>
-              <a:buChar char="•"/>
-            </a:pPr>
-            <a:r>
-              <a:rPr lang="en-US" sz="1800" dirty="0">
-                <a:solidFill>
-                  <a:srgbClr val="333333"/>
-                </a:solidFill>
-                <a:latin typeface="Arial" pitchFamily="34" charset="0"/>
-                <a:ea typeface="Arial" pitchFamily="34" charset="-122"/>
-                <a:cs typeface="Arial" pitchFamily="34" charset="-120"/>
-              </a:rPr>
-              <a:t>CD169 depletion reduces tumor growth.</a:t>
-            </a:r>
-            <a:endParaRPr lang="en-US" sz="1800" dirty="0"/>
-          </a:p>
-          <a:p>
-            <a:pPr marL="342900" indent="-342900">
-              <a:spcAft>
-                <a:spcPts val="800"/>
-              </a:spcAft>
-              <a:buSzPct val="100000"/>
-              <a:buChar char="•"/>
-            </a:pPr>
-            <a:r>
-              <a:rPr lang="en-US" sz="1800" dirty="0">
-                <a:solidFill>
-                  <a:srgbClr val="333333"/>
-                </a:solidFill>
-                <a:latin typeface="Arial" pitchFamily="34" charset="0"/>
-                <a:ea typeface="Arial" pitchFamily="34" charset="-122"/>
-                <a:cs typeface="Arial" pitchFamily="34" charset="-120"/>
-              </a:rPr>
-              <a:t>Targeting CD169 may improve therapies.</a:t>
+              <a:t>T17 enhances efficacy of CRC therapies.</a:t>
             </a:r>
             <a:endParaRPr lang="en-US" sz="1800" dirty="0"/>
           </a:p>
@@ -5976,7 +5892,7 @@
                   <a:srgbClr val="888888"/>
                 </a:solidFill>
               </a:rPr>
-              <a:t>Xia Yuan, Liu Yu, Peng Ai et al.. Journal of gastroenterology. 2026-06-24 DOI: 10.1007/s00535-026-02463-9</a:t>
+              <a:t>Fan Renming, Lu Xintong, Zhang Bingjie et al.. Nature communications. 2026-07-04 DOI: 10.1038/s41467-026-75208-0</a:t>
             </a:r>
             <a:endParaRPr lang="en-US" sz="800" dirty="0"/>
           </a:p>
@@ -6176,7 +6092,7 @@
                   </a:extLst>
                 </a:hlinkClick>
               </a:rPr>
-              <a:t>Integrative Transcriptomic and Proteomic Profiling Identifies S100P as a Potential Functional Biomarker for Sessile Serrated Lesions.</a:t>
+              <a:t>Norisoboldine suppresses epithelial-mesenchymal transition in colorectal cancer by simultaneously inhibiting the CXCR4/CXCR7 chemokine receptors and the JAK/STAT3 signaling pathway.</a:t>
             </a:r>
             <a:endParaRPr lang="en-US" sz="2400" dirty="0"/>
           </a:p>
@@ -6212,7 +6128,7 @@
                   <a:srgbClr val="888888"/>
                 </a:solidFill>
               </a:rPr>
-              <a:t>Digestive diseases and sciences  ·  🌏 Asia</a:t>
+              <a:t>The Journal of pharmacy and pharmacology  ·  Basic Research  ·  🌏 Asia</a:t>
             </a:r>
             <a:endParaRPr lang="en-US" sz="1000" dirty="0"/>
           </a:p>
@@ -6255,7 +6171,7 @@
                 <a:ea typeface="Arial" pitchFamily="34" charset="-122"/>
                 <a:cs typeface="Arial" pitchFamily="34" charset="-120"/>
               </a:rPr>
-              <a:t>S100P identified as potential biomarker</a:t>
+              <a:t>Norisoboldine inhibits colorectal cancer progression.</a:t>
             </a:r>
             <a:endParaRPr lang="en-US" sz="1800" dirty="0"/>
           </a:p>
@@ -6276,7 +6192,7 @@
                 <a:ea typeface="Arial" pitchFamily="34" charset="-122"/>
                 <a:cs typeface="Arial" pitchFamily="34" charset="-120"/>
               </a:rPr>
-              <a:t>216 genes upregulated in SSLs</a:t>
+              <a:t>Decreases mesenchymal protein expression levels.</a:t>
             </a:r>
             <a:endParaRPr lang="en-US" sz="1800" dirty="0"/>
           </a:p>
@@ -6297,7 +6213,7 @@
                 <a:ea typeface="Arial" pitchFamily="34" charset="-122"/>
                 <a:cs typeface="Arial" pitchFamily="34" charset="-120"/>
               </a:rPr>
-              <a:t>Functional assays confirm S100P relevance</a:t>
+              <a:t>Inhibits JAK/STAT3 signaling pathway activity.</a:t>
             </a:r>
             <a:endParaRPr lang="en-US" sz="1800" dirty="0"/>
           </a:p>
@@ -6333,7 +6249,7 @@
                   <a:srgbClr val="888888"/>
                 </a:solidFill>
               </a:rPr>
-              <a:t>Yeh Jen-Hao, Chen Chia-Chi, Chen Chih-I et al.. Digestive diseases and sciences. 2026-06-22 DOI: 10.1007/s10620-026-10048-y</a:t>
+              <a:t>Kim Na Young, Hong Yejin, Baek Seung Ho et al.. The Journal of pharmacy and pharmacology. 2026-07-04 DOI: 10.1093/jpp/rgag071</a:t>
             </a:r>
             <a:endParaRPr lang="en-US" sz="800" dirty="0"/>
           </a:p>
@@ -6533,7 +6449,7 @@
                   </a:extLst>
                 </a:hlinkClick>
               </a:rPr>
-              <a:t>Effect of hyperthermic intraperitoneal chemotherapy on patients with advanced colorectal cancer: a systematic review and meta-analysis</a:t>
+              <a:t>Analysis of Formimidoyltransferase Cyclodeaminase as a Potential Prognostic Biomarker and Therapeutic Target in Colorectal Cancer.</a:t>
             </a:r>
             <a:endParaRPr lang="en-US" sz="2400" dirty="0"/>
           </a:p>
@@ -6569,7 +6485,7 @@
                   <a:srgbClr val="888888"/>
                 </a:solidFill>
               </a:rPr>
-              <a:t>World Journal of …  ·  Meta-Analysis</a:t>
+              <a:t>Cancer genomics &amp; proteomics  ·  Basic Research  ·  🌏 Asia</a:t>
             </a:r>
             <a:endParaRPr lang="en-US" sz="1000" dirty="0"/>
           </a:p>
@@ -6612,7 +6528,7 @@
                 <a:ea typeface="Arial" pitchFamily="34" charset="-122"/>
                 <a:cs typeface="Arial" pitchFamily="34" charset="-120"/>
               </a:rPr>
-              <a:t>Hyperthermic intraperitoneal chemotherapy (HIPEC) effectiveness</a:t>
+              <a:t>FTCD linked to cancer progression in CRC.</a:t>
             </a:r>
             <a:endParaRPr lang="en-US" sz="1800" dirty="0"/>
           </a:p>
@@ -6633,7 +6549,7 @@
                 <a:ea typeface="Arial" pitchFamily="34" charset="-122"/>
                 <a:cs typeface="Arial" pitchFamily="34" charset="-120"/>
               </a:rPr>
-              <a:t>Advanced colorectal cancer treatment options</a:t>
+              <a:t>High FTCD correlates with poor survival outcomes.</a:t>
             </a:r>
             <a:endParaRPr lang="en-US" sz="1800" dirty="0"/>
           </a:p>
@@ -6654,49 +6570,7 @@
                 <a:ea typeface="Arial" pitchFamily="34" charset="-122"/>
                 <a:cs typeface="Arial" pitchFamily="34" charset="-120"/>
               </a:rPr>
-              <a:t>Systematic review and meta-analysis conducted</a:t>
-            </a:r>
-            <a:endParaRPr lang="en-US" sz="1800" dirty="0"/>
-          </a:p>
-          <a:p>
-            <a:pPr marL="342900" indent="-342900">
-              <a:spcAft>
-                <a:spcPts val="800"/>
-              </a:spcAft>
-              <a:buSzPct val="100000"/>
-              <a:buChar char="•"/>
-            </a:pPr>
-            <a:r>
-              <a:rPr lang="en-US" sz="1800" dirty="0">
-                <a:solidFill>
-                  <a:srgbClr val="333333"/>
-                </a:solidFill>
-                <a:latin typeface="Arial" pitchFamily="34" charset="0"/>
-                <a:ea typeface="Arial" pitchFamily="34" charset="-122"/>
-                <a:cs typeface="Arial" pitchFamily="34" charset="-120"/>
-              </a:rPr>
-              <a:t>Patient outcomes and survival rates analyzed</a:t>
-            </a:r>
-            <a:endParaRPr lang="en-US" sz="1800" dirty="0"/>
-          </a:p>
-          <a:p>
-            <a:pPr marL="342900" indent="-342900">
-              <a:spcAft>
-                <a:spcPts val="800"/>
-              </a:spcAft>
-              <a:buSzPct val="100000"/>
-              <a:buChar char="•"/>
-            </a:pPr>
-            <a:r>
-              <a:rPr lang="en-US" sz="1800" dirty="0">
-                <a:solidFill>
-                  <a:srgbClr val="333333"/>
-                </a:solidFill>
-                <a:latin typeface="Arial" pitchFamily="34" charset="0"/>
-                <a:ea typeface="Arial" pitchFamily="34" charset="-122"/>
-                <a:cs typeface="Arial" pitchFamily="34" charset="-120"/>
-              </a:rPr>
-              <a:t>Potential for improved therapeutic strategies</a:t>
+              <a:t>FTCD knockdown reduces tumor growth and invasion.</a:t>
             </a:r>
             <a:endParaRPr lang="en-US" sz="1800" dirty="0"/>
           </a:p>
@@ -6732,7 +6606,7 @@
                   <a:srgbClr val="888888"/>
                 </a:solidFill>
               </a:rPr>
-              <a:t>Z Su, Y Guo, X Ru. World Journal of …. 2026</a:t>
+              <a:t>Tanaka Kenshiro, Umeda Shinichi, Hattori Norifumi et al.. Cancer genomics &amp; proteomics. 2026-06-29 DOI: 10.21873/cgp.20596</a:t>
             </a:r>
             <a:endParaRPr lang="en-US" sz="800" dirty="0"/>
           </a:p>
@@ -6932,7 +6806,7 @@
                   </a:extLst>
                 </a:hlinkClick>
               </a:rPr>
-              <a:t>Prognostic value of systemic immune-inflammation index for colorectal cancer: a systematic review and meta-analysis</a:t>
+              <a:t>Outcomes reported in studies of anal high-grade squamous intraepithelial lesions treatments: systematic review.</a:t>
             </a:r>
             <a:endParaRPr lang="en-US" sz="2400" dirty="0"/>
           </a:p>
@@ -6968,7 +6842,7 @@
                   <a:srgbClr val="888888"/>
                 </a:solidFill>
               </a:rPr>
-              <a:t>Frontiers in Oncology  ·  Meta-Analysis</a:t>
+              <a:t>BJS open  ·  RCT</a:t>
             </a:r>
             <a:endParaRPr lang="en-US" sz="1000" dirty="0"/>
           </a:p>
@@ -7011,7 +6885,7 @@
                 <a:ea typeface="Arial" pitchFamily="34" charset="-122"/>
                 <a:cs typeface="Arial" pitchFamily="34" charset="-120"/>
               </a:rPr>
-              <a:t>Systemic immune-inflammation index (SII) evaluated</a:t>
+              <a:t>Anal HSIL is a precursor to ASCC.</a:t>
             </a:r>
             <a:endParaRPr lang="en-US" sz="1800" dirty="0"/>
           </a:p>
@@ -7032,7 +6906,7 @@
                 <a:ea typeface="Arial" pitchFamily="34" charset="-122"/>
                 <a:cs typeface="Arial" pitchFamily="34" charset="-120"/>
               </a:rPr>
-              <a:t>Prognostic significance in colorectal cancer</a:t>
+              <a:t>67 studies evaluated anal HSIL treatments.</a:t>
             </a:r>
             <a:endParaRPr lang="en-US" sz="1800" dirty="0"/>
           </a:p>
@@ -7053,7 +6927,7 @@
                 <a:ea typeface="Arial" pitchFamily="34" charset="-122"/>
                 <a:cs typeface="Arial" pitchFamily="34" charset="-120"/>
               </a:rPr>
-              <a:t>Meta-analysis of existing studies conducted</a:t>
+              <a:t>966 outcomes mapped to 170 SOTs.</a:t>
             </a:r>
             <a:endParaRPr lang="en-US" sz="1800" dirty="0"/>
           </a:p>
@@ -7074,7 +6948,7 @@
                 <a:ea typeface="Arial" pitchFamily="34" charset="-122"/>
                 <a:cs typeface="Arial" pitchFamily="34" charset="-120"/>
               </a:rPr>
-              <a:t>SII correlates with patient outcomes</a:t>
+              <a:t>High heterogeneity in outcome definitions.</a:t>
             </a:r>
             <a:endParaRPr lang="en-US" sz="1800" dirty="0"/>
           </a:p>
@@ -7095,7 +6969,7 @@
                 <a:ea typeface="Arial" pitchFamily="34" charset="-122"/>
                 <a:cs typeface="Arial" pitchFamily="34" charset="-120"/>
               </a:rPr>
-              <a:t>Potential biomarker for clinical use</a:t>
+              <a:t>Need for a COS to standardize outcomes.</a:t>
             </a:r>
             <a:endParaRPr lang="en-US" sz="1800" dirty="0"/>
           </a:p>
@@ -7131,7 +7005,7 @@
                   <a:srgbClr val="888888"/>
                 </a:solidFill>
               </a:rPr>
-              <a:t>P Wang, H Jiang. Frontiers in Oncology. 2026</a:t>
+              <a:t>Finch David A, Chaudhury Madhu P, Morris Rebecca et al.. BJS open. 2026-07-04 DOI: 10.1093/bjsopen/zrag061</a:t>
             </a:r>
             <a:endParaRPr lang="en-US" sz="800" dirty="0"/>
           </a:p>
@@ -7331,7 +7205,7 @@
                   </a:extLst>
                 </a:hlinkClick>
               </a:rPr>
-              <a:t>Awareness of inflammatory bowel disease-associated colorectal cancer risk and its management in patients with inflammatory bowel disease: a systematic review</a:t>
+              <a:t>Association of Pre-treatment CALLY Index With Pathological Response to Neoadjuvant Chemotherapy in Rectal Cancer.</a:t>
             </a:r>
             <a:endParaRPr lang="en-US" sz="2400" dirty="0"/>
           </a:p>
@@ -7367,7 +7241,7 @@
                   <a:srgbClr val="888888"/>
                 </a:solidFill>
               </a:rPr>
-              <a:t>Crohns &amp; Colitis 360  ·  Systematic Review</a:t>
+              <a:t>In vivo (Athens, Greece)  ·  Retrospective Study  ·  🌏 Asia</a:t>
             </a:r>
             <a:endParaRPr lang="en-US" sz="1000" dirty="0"/>
           </a:p>
@@ -7410,7 +7284,7 @@
                 <a:ea typeface="Arial" pitchFamily="34" charset="-122"/>
                 <a:cs typeface="Arial" pitchFamily="34" charset="-120"/>
               </a:rPr>
-              <a:t>Limited awareness of colorectal cancer risk</a:t>
+              <a:t>Study on pre-treatment CALLY index</a:t>
             </a:r>
             <a:endParaRPr lang="en-US" sz="1800" dirty="0"/>
           </a:p>
@@ -7431,7 +7305,7 @@
                 <a:ea typeface="Arial" pitchFamily="34" charset="-122"/>
                 <a:cs typeface="Arial" pitchFamily="34" charset="-120"/>
               </a:rPr>
-              <a:t>Need for better patient education strategies</a:t>
+              <a:t>Analyzed 59 rectal cancer patients</a:t>
             </a:r>
             <a:endParaRPr lang="en-US" sz="1800" dirty="0"/>
           </a:p>
@@ -7452,7 +7326,49 @@
                 <a:ea typeface="Arial" pitchFamily="34" charset="-122"/>
                 <a:cs typeface="Arial" pitchFamily="34" charset="-120"/>
               </a:rPr>
-              <a:t>Importance of regular screening in IBD patients</a:t>
+              <a:t>Pathological response evaluated by Japanese Classification</a:t>
+            </a:r>
+            <a:endParaRPr lang="en-US" sz="1800" dirty="0"/>
+          </a:p>
+          <a:p>
+            <a:pPr marL="342900" indent="-342900">
+              <a:spcAft>
+                <a:spcPts val="800"/>
+              </a:spcAft>
+              <a:buSzPct val="100000"/>
+              <a:buChar char="•"/>
+            </a:pPr>
+            <a:r>
+              <a:rPr lang="en-US" sz="1800" dirty="0">
+                <a:solidFill>
+                  <a:srgbClr val="333333"/>
+                </a:solidFill>
+                <a:latin typeface="Arial" pitchFamily="34" charset="0"/>
+                <a:ea typeface="Arial" pitchFamily="34" charset="-122"/>
+                <a:cs typeface="Arial" pitchFamily="34" charset="-120"/>
+              </a:rPr>
+              <a:t>40.7% achieved grade 2-3 response</a:t>
+            </a:r>
+            <a:endParaRPr lang="en-US" sz="1800" dirty="0"/>
+          </a:p>
+          <a:p>
+            <a:pPr marL="342900" indent="-342900">
+              <a:spcAft>
+                <a:spcPts val="800"/>
+              </a:spcAft>
+              <a:buSzPct val="100000"/>
+              <a:buChar char="•"/>
+            </a:pPr>
+            <a:r>
+              <a:rPr lang="en-US" sz="1800" dirty="0">
+                <a:solidFill>
+                  <a:srgbClr val="333333"/>
+                </a:solidFill>
+                <a:latin typeface="Arial" pitchFamily="34" charset="0"/>
+                <a:ea typeface="Arial" pitchFamily="34" charset="-122"/>
+                <a:cs typeface="Arial" pitchFamily="34" charset="-120"/>
+              </a:rPr>
+              <a:t>CALLY index may predict NAC response</a:t>
             </a:r>
             <a:endParaRPr lang="en-US" sz="1800" dirty="0"/>
           </a:p>
@@ -7488,7 +7404,7 @@
                   <a:srgbClr val="888888"/>
                 </a:solidFill>
               </a:rPr>
-              <a:t>F Khan, C Norton, W Czuber-Dochan. Crohns &amp; Colitis 360. 2026</a:t>
+              <a:t>Akiyama Yasuki, Sawatsubashi Yusuke, Yabuki Kei et al.. In vivo (Athens, Greece). 2026-07-01 DOI: 10.21873/invivo.14382</a:t>
             </a:r>
             <a:endParaRPr lang="en-US" sz="800" dirty="0"/>
           </a:p>

</xml_diff>

<commit_message>
chore: update weekly digest 2026-07-13
</commit_message>
<xml_diff>
--- a/docs/digest-en.pptx
+++ b/docs/digest-en.pptx
@@ -2249,7 +2249,7 @@
                   <a:srgbClr val="888888"/>
                 </a:solidFill>
               </a:rPr>
-              <a:t>2026-06-29 — 2026-07-06</a:t>
+              <a:t>2026-07-06 — 2026-07-13</a:t>
             </a:r>
             <a:endParaRPr lang="en-US" sz="1400" dirty="0"/>
           </a:p>
@@ -2440,7 +2440,7 @@
                   </a:extLst>
                 </a:hlinkClick>
               </a:rPr>
-              <a:t>Prognostic value of systemic immune-inflammation index for colorectal cancer: a systematic review and meta-analysis</a:t>
+              <a:t>… Cancer and Mesothelial Stromal Cell Lines from Malignant Ascites Reveals a Mesothelial‐Stromal FGFR3 Axis as a Potential Vulnerability in Peritoneal Metastasis</a:t>
             </a:r>
             <a:endParaRPr lang="en-US" sz="2400" dirty="0"/>
           </a:p>
@@ -2476,7 +2476,7 @@
                   <a:srgbClr val="888888"/>
                 </a:solidFill>
               </a:rPr>
-              <a:t>Frontiers in Oncology  ·  Meta-Analysis</a:t>
+              <a:t>Cancer …  ·  Basic Research</a:t>
             </a:r>
             <a:endParaRPr lang="en-US" sz="1000" dirty="0"/>
           </a:p>
@@ -2519,7 +2519,7 @@
                 <a:ea typeface="Arial" pitchFamily="34" charset="-122"/>
                 <a:cs typeface="Arial" pitchFamily="34" charset="-120"/>
               </a:rPr>
-              <a:t>Systemic immune-inflammation index (SII) evaluated.</a:t>
+              <a:t>Colorectal cancer poses therapeutic challenges.</a:t>
             </a:r>
             <a:endParaRPr lang="en-US" sz="1800" dirty="0"/>
           </a:p>
@@ -2540,7 +2540,7 @@
                 <a:ea typeface="Arial" pitchFamily="34" charset="-122"/>
                 <a:cs typeface="Arial" pitchFamily="34" charset="-120"/>
               </a:rPr>
-              <a:t>SII correlates with CRC prognosis.</a:t>
+              <a:t>Peritoneal dissemination leads to poor prognosis.</a:t>
             </a:r>
             <a:endParaRPr lang="en-US" sz="1800" dirty="0"/>
           </a:p>
@@ -2561,7 +2561,7 @@
                 <a:ea typeface="Arial" pitchFamily="34" charset="-122"/>
                 <a:cs typeface="Arial" pitchFamily="34" charset="-120"/>
               </a:rPr>
-              <a:t>Meta-analysis of existing studies conducted.</a:t>
+              <a:t>FGFR3 axis identified as potential vulnerability.</a:t>
             </a:r>
             <a:endParaRPr lang="en-US" sz="1800" dirty="0"/>
           </a:p>
@@ -2597,7 +2597,7 @@
                   <a:srgbClr val="888888"/>
                 </a:solidFill>
               </a:rPr>
-              <a:t>P Wang, H Jiang. Frontiers in Oncology. 2026</a:t>
+              <a:t>Y Fukui, H Kasashima, Z Wang. Cancer …. 2026</a:t>
             </a:r>
             <a:endParaRPr lang="en-US" sz="800" dirty="0"/>
           </a:p>
@@ -2797,7 +2797,7 @@
                   </a:extLst>
                 </a:hlinkClick>
               </a:rPr>
-              <a:t>Intratumoral enrichment and suppressive activity of DP8&amp;#x3b1; regulatory T cells in human colorectal cancer.</a:t>
+              <a:t>KLK7 overexpression promotes an aggressive phenotype and facilitates peritoneal dissemination in colorectal cancer cells</a:t>
             </a:r>
             <a:endParaRPr lang="en-US" sz="2400" dirty="0"/>
           </a:p>
@@ -2833,7 +2833,7 @@
                   <a:srgbClr val="888888"/>
                 </a:solidFill>
               </a:rPr>
-              <a:t>Oncoimmunology  ·  IF 5.9  ·  Prospective Study</a:t>
+              <a:t>FEBS Open …  ·  Basic Research</a:t>
             </a:r>
             <a:endParaRPr lang="en-US" sz="1000" dirty="0"/>
           </a:p>
@@ -2876,7 +2876,7 @@
                 <a:ea typeface="Arial" pitchFamily="34" charset="-122"/>
                 <a:cs typeface="Arial" pitchFamily="34" charset="-120"/>
               </a:rPr>
-              <a:t>Identification of DP8α Tregs in CRC</a:t>
+              <a:t>KLK7 overexpression linked to aggressive CRC</a:t>
             </a:r>
             <a:endParaRPr lang="en-US" sz="1800" dirty="0"/>
           </a:p>
@@ -2897,7 +2897,7 @@
                 <a:ea typeface="Arial" pitchFamily="34" charset="-122"/>
                 <a:cs typeface="Arial" pitchFamily="34" charset="-120"/>
               </a:rPr>
-              <a:t>Enrichment of DP8α Tregs in tumors</a:t>
+              <a:t>Promotes peritoneal dissemination in cancer cells</a:t>
             </a:r>
             <a:endParaRPr lang="en-US" sz="1800" dirty="0"/>
           </a:p>
@@ -2918,7 +2918,7 @@
                 <a:ea typeface="Arial" pitchFamily="34" charset="-122"/>
                 <a:cs typeface="Arial" pitchFamily="34" charset="-120"/>
               </a:rPr>
-              <a:t>Suppression of T-cell proliferation by DP8α Tregs</a:t>
+              <a:t>In vitro studies confirm aggressive phenotype</a:t>
             </a:r>
             <a:endParaRPr lang="en-US" sz="1800" dirty="0"/>
           </a:p>
@@ -2954,7 +2954,7 @@
                   <a:srgbClr val="888888"/>
                 </a:solidFill>
               </a:rPr>
-              <a:t>Deiber Mathilde, Deleine C&amp;#xe9;cile, Gervois-Segain Nadine et al.. Oncoimmunology. 2026-07-03 DOI: 10.1080/2162402X.2026.2696069</a:t>
+              <a:t>YZ Haffani, T Dreyer, M Naim. FEBS Open …. 2026</a:t>
             </a:r>
             <a:endParaRPr lang="en-US" sz="800" dirty="0"/>
           </a:p>
@@ -3154,7 +3154,7 @@
                   </a:extLst>
                 </a:hlinkClick>
               </a:rPr>
-              <a:t>Awareness of inflammatory bowel disease-associated colorectal cancer risk and its management in patients with inflammatory bowel disease: a systematic review</a:t>
+              <a:t>Integrative network pharmacology and machine learning identify potential targets of indole-3-lactic acid in colorectal cancer</a:t>
             </a:r>
             <a:endParaRPr lang="en-US" sz="2400" dirty="0"/>
           </a:p>
@@ -3190,7 +3190,7 @@
                   <a:srgbClr val="888888"/>
                 </a:solidFill>
               </a:rPr>
-              <a:t>Crohns &amp; Colitis 360  ·  Systematic Review</a:t>
+              <a:t>Plos one  ·  Basic Research</a:t>
             </a:r>
             <a:endParaRPr lang="en-US" sz="1000" dirty="0"/>
           </a:p>
@@ -3233,7 +3233,7 @@
                 <a:ea typeface="Arial" pitchFamily="34" charset="-122"/>
                 <a:cs typeface="Arial" pitchFamily="34" charset="-120"/>
               </a:rPr>
-              <a:t>Limited awareness of colorectal cancer risk</a:t>
+              <a:t>Network pharmacology identifies ILA targets.</a:t>
             </a:r>
             <a:endParaRPr lang="en-US" sz="1800" dirty="0"/>
           </a:p>
@@ -3254,7 +3254,7 @@
                 <a:ea typeface="Arial" pitchFamily="34" charset="-122"/>
                 <a:cs typeface="Arial" pitchFamily="34" charset="-120"/>
               </a:rPr>
-              <a:t>Need for better management strategies</a:t>
+              <a:t>Machine learning enhances target prediction.</a:t>
             </a:r>
             <a:endParaRPr lang="en-US" sz="1800" dirty="0"/>
           </a:p>
@@ -3275,7 +3275,7 @@
                 <a:ea typeface="Arial" pitchFamily="34" charset="-122"/>
                 <a:cs typeface="Arial" pitchFamily="34" charset="-120"/>
               </a:rPr>
-              <a:t>Importance of patient education</a:t>
+              <a:t>ILA shows antioxidant and anti-inflammatory effects.</a:t>
             </a:r>
             <a:endParaRPr lang="en-US" sz="1800" dirty="0"/>
           </a:p>
@@ -3311,7 +3311,7 @@
                   <a:srgbClr val="888888"/>
                 </a:solidFill>
               </a:rPr>
-              <a:t>F Khan, C Norton, W Czuber-Dochan. Crohns &amp; Colitis 360. 2026</a:t>
+              <a:t>J Li, J Zhang, J Ke. Plos one. 2026</a:t>
             </a:r>
             <a:endParaRPr lang="en-US" sz="800" dirty="0"/>
           </a:p>
@@ -3502,7 +3502,7 @@
                   <a:srgbClr val="FFFFFF"/>
                 </a:solidFill>
               </a:rPr>
-              <a:t>### 綜合啟示（Overall Insights）</a:t>
+              <a:t>### 綜合啟示 (Overall Insights)</a:t>
             </a:r>
             <a:endParaRPr lang="en-US" sz="1200" dirty="0"/>
           </a:p>
@@ -3528,7 +3528,7 @@
                   <a:srgbClr val="FFFFFF"/>
                 </a:solidFill>
               </a:rPr>
-              <a:t>1. **新型治療策略的潛力**  </a:t>
+              <a:t>1. **腸道微生物與腫瘤發生的關聯性**  </a:t>
             </a:r>
             <a:endParaRPr lang="en-US" sz="1200" dirty="0"/>
           </a:p>
@@ -3545,7 +3545,7 @@
                   <a:srgbClr val="FFFFFF"/>
                 </a:solidFill>
               </a:rPr>
-              <a:t>   The combination of neoadjuvant toripalimab and celecoxib demonstrates enhanced efficacy in dMMR/MSI-H colorectal cancer, indicating the potential of combining immunotherapy with COX-2 inhibition to improve treatment outcomes.  </a:t>
+              <a:t>   The studies emphasize the significant role of gut microbiota in tumorigenesis, particularly in colorectal cancer, suggesting that specific bacterial strains can exacerbate or mitigate cancer progression.  </a:t>
             </a:r>
             <a:endParaRPr lang="en-US" sz="1200" dirty="0"/>
           </a:p>
@@ -3562,7 +3562,7 @@
                   <a:srgbClr val="FFFFFF"/>
                 </a:solidFill>
               </a:rPr>
-              <a:t>   新型的neoadjuvant治療策略，結合toripalimab與celecoxib，顯示在dMMR/MSI-H大腸癌中具增強療效，顯示出將免疫治療與COX-2抑制劑結合的潛力。</a:t>
+              <a:t>   研究強調腸道微生物在腫瘤發生中的重要角色，特別是在結直腸癌中，某些細菌株可能加劇或減緩癌症進展。</a:t>
             </a:r>
             <a:endParaRPr lang="en-US" sz="1200" dirty="0"/>
           </a:p>
@@ -3588,7 +3588,7 @@
                   <a:srgbClr val="FFFFFF"/>
                 </a:solidFill>
               </a:rPr>
-              <a:t>2. **手術與全身治療的比較**  </a:t>
+              <a:t>2. **免疫微環境的調控**  </a:t>
             </a:r>
             <a:endParaRPr lang="en-US" sz="1200" dirty="0"/>
           </a:p>
@@ -3605,7 +3605,7 @@
                   <a:srgbClr val="FFFFFF"/>
                 </a:solidFill>
               </a:rPr>
-              <a:t>   The CAIRO6 trial highlights the importance of evaluating perioperative systemic therapy versus surgery alone, suggesting that systemic therapy may enhance outcomes in patients with resectable colorectal peritoneal metastases.  </a:t>
+              <a:t>   The modulation of the tumor immune microenvironment, particularly through cancer-associated fibroblasts and macrophages, is crucial for enhancing the efficacy of immunotherapies in colorectal cancer.  </a:t>
             </a:r>
             <a:endParaRPr lang="en-US" sz="1200" dirty="0"/>
           </a:p>
@@ -3622,7 +3622,7 @@
                   <a:srgbClr val="FFFFFF"/>
                 </a:solidFill>
               </a:rPr>
-              <a:t>   CAIRO6試驗強調評估圍手術期全身治療與單獨手術的重要性，暗示全身治療可能改善可切除大腸癌腹膜轉移患者的預後。</a:t>
+              <a:t>   腫瘤免疫微環境的調控，特別是通過癌症相關成纖維細胞和巨噬細胞，對於提高結直腸癌免疫療法的療效至關重要。</a:t>
             </a:r>
             <a:endParaRPr lang="en-US" sz="1200" dirty="0"/>
           </a:p>
@@ -3648,7 +3648,7 @@
                   <a:srgbClr val="FFFFFF"/>
                 </a:solidFill>
               </a:rPr>
-              <a:t>3. **腫瘤微環境的調節**  </a:t>
+              <a:t>3. **基因變異作為預測生物標誌物**  </a:t>
             </a:r>
             <a:endParaRPr lang="en-US" sz="1200" dirty="0"/>
           </a:p>
@@ -3665,7 +3665,7 @@
                   <a:srgbClr val="FFFFFF"/>
                 </a:solidFill>
               </a:rPr>
-              <a:t>   Research on glutamine antagonism reveals that reprogramming macrophage immunometabolism can significantly enhance the efficacy of colorectal cancer therapies, emphasizing the role of the tumor microenvironment in treatment response.  </a:t>
+              <a:t>   Genetic alterations, such as PIK3CA mutations and polymorphisms in ATP binding cassette genes, may serve as predictive biomarkers for therapeutic responses in colorectal and other cancers.  </a:t>
             </a:r>
             <a:endParaRPr lang="en-US" sz="1200" dirty="0"/>
           </a:p>
@@ -3682,7 +3682,7 @@
                   <a:srgbClr val="FFFFFF"/>
                 </a:solidFill>
               </a:rPr>
-              <a:t>   針對谷氨酸拮抗劑的研究顯示，重編程巨噬細胞免疫代謝可顯著提高大腸癌治療的療效，強調腫瘤微環境在治療反應中的角色。</a:t>
+              <a:t>   基因變異，如PIK3CA突變和ATP結合盒基因的多態性，可能作為結直腸癌及其他癌症治療反應的預測生物標誌物。</a:t>
             </a:r>
             <a:endParaRPr lang="en-US" sz="1200" dirty="0"/>
           </a:p>
@@ -3708,7 +3708,7 @@
                   <a:srgbClr val="FFFFFF"/>
                 </a:solidFill>
               </a:rPr>
-              <a:t>4. **生物標記物的潛力**  </a:t>
+              <a:t>4. **新型治療策略的開發**  </a:t>
             </a:r>
             <a:endParaRPr lang="en-US" sz="1200" dirty="0"/>
           </a:p>
@@ -3725,7 +3725,7 @@
                   <a:srgbClr val="FFFFFF"/>
                 </a:solidFill>
               </a:rPr>
-              <a:t>   The exploration of FTCD as a prognostic biomarker suggests that metabolic pathways may serve as critical targets for therapeutic intervention in colorectal cancer.  </a:t>
+              <a:t>   The identification of novel therapeutic targets, including metabolic pathways and immune modulation strategies, presents new opportunities for improving treatment outcomes in colorectal cancer.  </a:t>
             </a:r>
             <a:endParaRPr lang="en-US" sz="1200" dirty="0"/>
           </a:p>
@@ -3742,7 +3742,7 @@
                   <a:srgbClr val="FFFFFF"/>
                 </a:solidFill>
               </a:rPr>
-              <a:t>   FTCD作為預後生物標記物的研究表明，代謝途徑可能成為大腸癌治療干預的關鍵目標。</a:t>
+              <a:t>   新型治療靶點的識別，包括代謝途徑和免疫調控策略，為改善結直腸癌的治療結果提供了新的機會。</a:t>
             </a:r>
             <a:endParaRPr lang="en-US" sz="1200" dirty="0"/>
           </a:p>
@@ -3768,7 +3768,7 @@
                   <a:srgbClr val="FFFFFF"/>
                 </a:solidFill>
               </a:rPr>
-              <a:t>5. **系統性炎症指數的預測價值**  </a:t>
+              <a:t>5. **環境因素對癌症的影響**  </a:t>
             </a:r>
             <a:endParaRPr lang="en-US" sz="1200" dirty="0"/>
           </a:p>
@@ -3785,7 +3785,7 @@
                   <a:srgbClr val="FFFFFF"/>
                 </a:solidFill>
               </a:rPr>
-              <a:t>   The systemic immune-inflammation index (SII) has emerged as a promising prognostic biomarker, indicating that systemic inflammatory responses may play a significant role in colorectal cancer progression and outcomes.</a:t>
+              <a:t>   Environmental factors, including dietary components and microbial metabolites, play a critical role in the pathogenesis of inflammatory bowel diseases and colorectal cancer.</a:t>
             </a:r>
             <a:endParaRPr lang="en-US" sz="1200" dirty="0"/>
           </a:p>
@@ -3931,7 +3931,7 @@
                   <a:srgbClr val="FFFFFF"/>
                 </a:solidFill>
               </a:rPr>
-              <a:t>系統性免疫炎症指數（SII）已成為有前景的預後生物標記物，表明系統性炎症反應可能在大腸癌的進展和預後中起重要作用。</a:t>
+              <a:t>環境因素，包括飲食成分和微生物代謝物，在炎症性腸病和結直腸癌的發病機制中扮演著關鍵角色。</a:t>
             </a:r>
             <a:endParaRPr lang="en-US" sz="1200" dirty="0"/>
           </a:p>
@@ -3957,7 +3957,7 @@
                   <a:srgbClr val="FFFFFF"/>
                 </a:solidFill>
               </a:rPr>
-              <a:t>### 未來研究方向（Future Research Directions）</a:t>
+              <a:t>### 未來研究方向 (Future Research Directions)</a:t>
             </a:r>
             <a:endParaRPr lang="en-US" sz="1200" dirty="0"/>
           </a:p>
@@ -3983,7 +3983,7 @@
                   <a:srgbClr val="FFFFFF"/>
                 </a:solidFill>
               </a:rPr>
-              <a:t>1. **免疫治療的優化**  </a:t>
+              <a:t>1. **腸道微生物的功能研究**  </a:t>
             </a:r>
             <a:endParaRPr lang="en-US" sz="1200" dirty="0"/>
           </a:p>
@@ -4000,7 +4000,7 @@
                   <a:srgbClr val="FFFFFF"/>
                 </a:solidFill>
               </a:rPr>
-              <a:t>   Future studies should focus on optimizing combination therapies involving immune checkpoint inhibitors and anti-inflammatory agents to maximize therapeutic efficacy in colorectal cancer.  </a:t>
+              <a:t>   Future studies should focus on elucidating the specific mechanisms by which gut microbiota influence tumorigenesis and the immune response in colorectal cancer.  </a:t>
             </a:r>
             <a:endParaRPr lang="en-US" sz="1200" dirty="0"/>
           </a:p>
@@ -4017,7 +4017,7 @@
                   <a:srgbClr val="FFFFFF"/>
                 </a:solidFill>
               </a:rPr>
-              <a:t>   未來研究應集中於優化免疫檢查點抑制劑與抗炎藥物的聯合療法，以最大化大腸癌的治療效果。</a:t>
+              <a:t>   未來的研究應集中於闡明腸道微生物如何影響結直腸癌的腫瘤發生和免疫反應的具體機制。</a:t>
             </a:r>
             <a:endParaRPr lang="en-US" sz="1200" dirty="0"/>
           </a:p>
@@ -4043,7 +4043,7 @@
                   <a:srgbClr val="FFFFFF"/>
                 </a:solidFill>
               </a:rPr>
-              <a:t>2. **腫瘤微環境的深入研究**  </a:t>
+              <a:t>2. **個體化免疫療法的發展**  </a:t>
             </a:r>
             <a:endParaRPr lang="en-US" sz="1200" dirty="0"/>
           </a:p>
@@ -4060,7 +4060,7 @@
                   <a:srgbClr val="FFFFFF"/>
                 </a:solidFill>
               </a:rPr>
-              <a:t>   Investigating the role of the tumor microenvironment in mediating treatment responses will be crucial for developing targeted therapies that can overcome resistance mechanisms in colorectal cancer.  </a:t>
+              <a:t>   Research should explore the potential of personalized immunotherapy approaches based on individual genetic and microbiome profiles to improve treatment efficacy.  </a:t>
             </a:r>
             <a:endParaRPr lang="en-US" sz="1200" dirty="0"/>
           </a:p>
@@ -4077,7 +4077,7 @@
                   <a:srgbClr val="FFFFFF"/>
                 </a:solidFill>
               </a:rPr>
-              <a:t>   深入研究腫瘤微環境在治療反應中的作用，對於開發能克服大腸癌抵抗機制的靶向療法至關重要。</a:t>
+              <a:t>   研究應探討基於個體基因和微生物組特徵的個性化免疫療法的潛力，以提高治療效果。</a:t>
             </a:r>
             <a:endParaRPr lang="en-US" sz="1200" dirty="0"/>
           </a:p>
@@ -4103,7 +4103,7 @@
                   <a:srgbClr val="FFFFFF"/>
                 </a:solidFill>
               </a:rPr>
-              <a:t>3. **新生物標記物的發現**  </a:t>
+              <a:t>3. **新型生物標誌物的探索**  </a:t>
             </a:r>
             <a:endParaRPr lang="en-US" sz="1200" dirty="0"/>
           </a:p>
@@ -4120,7 +4120,7 @@
                   <a:srgbClr val="FFFFFF"/>
                 </a:solidFill>
               </a:rPr>
-              <a:t>   Continued exploration of novel biomarkers, such as FTCD and SII, will enhance our understanding of colorectal cancer prognosis and may lead to more personalized treatment approaches.  </a:t>
+              <a:t>   There is a need for the identification and validation of new biomarkers that can predict responses to immunotherapy and targeted therapies in colorectal cancer.  </a:t>
             </a:r>
             <a:endParaRPr lang="en-US" sz="1200" dirty="0"/>
           </a:p>
@@ -4137,7 +4137,7 @@
                   <a:srgbClr val="FFFFFF"/>
                 </a:solidFill>
               </a:rPr>
-              <a:t>   持續探索新生物標記物，如FTCD和SII，將增進我們對大腸癌預後的理解，並可能導致更個性化的治療方法。</a:t>
+              <a:t>   需要識別和驗證新的生物標誌物，以預測結直腸癌對免疫療法和靶向療法的反應。</a:t>
             </a:r>
             <a:endParaRPr lang="en-US" sz="1200" dirty="0"/>
           </a:p>
@@ -4163,7 +4163,7 @@
                   <a:srgbClr val="FFFFFF"/>
                 </a:solidFill>
               </a:rPr>
-              <a:t>4. **炎症與腫瘤進展的關聯**  </a:t>
+              <a:t>4. **環境與遺傳交互作用的研究**  </a:t>
             </a:r>
             <a:endParaRPr lang="en-US" sz="1200" dirty="0"/>
           </a:p>
@@ -4180,7 +4180,7 @@
                   <a:srgbClr val="FFFFFF"/>
                 </a:solidFill>
               </a:rPr>
-              <a:t>   Research should further investigate the relationship between systemic inflammation and colorectal cancer progression, potentially identifying new therapeutic targets.  </a:t>
+              <a:t>   Investigating the interplay between environmental factors and genetic predispositions in colorectal cancer can provide insights into prevention and treatment strategies.  </a:t>
             </a:r>
             <a:endParaRPr lang="en-US" sz="1200" dirty="0"/>
           </a:p>
@@ -4197,7 +4197,7 @@
                   <a:srgbClr val="FFFFFF"/>
                 </a:solidFill>
               </a:rPr>
-              <a:t>   研究應進一步探討系統性炎症與大腸癌進展之間的關聯，可能識別新的治療靶點。</a:t>
+              <a:t>   研究環境因素與遺傳易感性在結直腸癌中的相互作用，可以為預防和治療策略提供見解。</a:t>
             </a:r>
             <a:endParaRPr lang="en-US" sz="1200" dirty="0"/>
           </a:p>
@@ -4223,7 +4223,7 @@
                   <a:srgbClr val="FFFFFF"/>
                 </a:solidFill>
               </a:rPr>
-              <a:t>5. **臨床試驗的擴展**  </a:t>
+              <a:t>5. **新療法的臨床試驗**  </a:t>
             </a:r>
             <a:endParaRPr lang="en-US" sz="1200" dirty="0"/>
           </a:p>
@@ -4240,7 +4240,7 @@
                   <a:srgbClr val="FFFFFF"/>
                 </a:solidFill>
               </a:rPr>
-              <a:t>   Expanding clinical trials to include diverse patient populations and treatment regimens will provide more comprehensive data on the efficacy of emerging therapies for colorectal cancer.  </a:t>
+              <a:t>   Clinical trials should be initiated to test the efficacy of novel therapeutic agents and combinations, particularly those targeting the tumor microenvironment and immune modulation.  </a:t>
             </a:r>
             <a:endParaRPr lang="en-US" sz="1200" dirty="0"/>
           </a:p>
@@ -4257,7 +4257,7 @@
                   <a:srgbClr val="FFFFFF"/>
                 </a:solidFill>
               </a:rPr>
-              <a:t>   擴大臨床試驗以納入多樣化的患者群體和治療方案，將提供有關新興大腸癌療法療效的更全面數據。</a:t>
+              <a:t>   應啟動臨床試驗，以測試新型治療劑和組合的療效，特別是針對腫瘤微環境和免疫調控的療法。</a:t>
             </a:r>
             <a:endParaRPr lang="en-US" sz="1200" dirty="0"/>
           </a:p>
@@ -4491,7 +4491,7 @@
                 <a:ea typeface="Arial" pitchFamily="34" charset="-122"/>
                 <a:cs typeface="Arial" pitchFamily="34" charset="-120"/>
               </a:rPr>
-              <a:t>Neoadjuvant toripalimab plus celecoxib versus toripalimab monotherapy for mismat…</a:t>
+              <a:t>ORCHESTRA hits a sour note for debulking in metastatic colorectal cancer</a:t>
             </a:r>
             <a:endParaRPr lang="en-US" sz="1400" dirty="0"/>
           </a:p>
@@ -4528,7 +4528,7 @@
                 <a:ea typeface="Arial" pitchFamily="34" charset="-122"/>
                 <a:cs typeface="Arial" pitchFamily="34" charset="-120"/>
               </a:rPr>
-              <a:t>Perioperative systemic therapy versus surgery alone for resectable colorectal pe…</a:t>
+              <a:t>Oncogenic PIK3CA mutation enhances tumor immunogenicity through the IRF1-NLRC5-M…</a:t>
             </a:r>
             <a:endParaRPr lang="en-US" sz="1400" dirty="0"/>
           </a:p>
@@ -4565,7 +4565,7 @@
                 <a:ea typeface="Arial" pitchFamily="34" charset="-122"/>
                 <a:cs typeface="Arial" pitchFamily="34" charset="-120"/>
               </a:rPr>
-              <a:t>Reprogramming macrophage immunometabolism via glutamine antagonism potentiates c…</a:t>
+              <a:t>Parasutterella excrementihominis exacerbates experimental colitis and colitis-as…</a:t>
             </a:r>
             <a:endParaRPr lang="en-US" sz="1400" dirty="0"/>
           </a:p>
@@ -4602,7 +4602,7 @@
                 <a:ea typeface="Arial" pitchFamily="34" charset="-122"/>
                 <a:cs typeface="Arial" pitchFamily="34" charset="-120"/>
               </a:rPr>
-              <a:t>Norisoboldine suppresses epithelial-mesenchymal transition in colorectal cancer …</a:t>
+              <a:t>rs2032582 polymorphism of ATP binding cassette subfamily B member 1 affect the s…</a:t>
             </a:r>
             <a:endParaRPr lang="en-US" sz="1400" dirty="0"/>
           </a:p>
@@ -4639,7 +4639,7 @@
                 <a:ea typeface="Arial" pitchFamily="34" charset="-122"/>
                 <a:cs typeface="Arial" pitchFamily="34" charset="-120"/>
               </a:rPr>
-              <a:t>Analysis of Formimidoyltransferase Cyclodeaminase as a Potential Prognostic Biom…</a:t>
+              <a:t>Combining genotoxic gut bacterial strains increases tumor burden and accelerates…</a:t>
             </a:r>
             <a:endParaRPr lang="en-US" sz="1400" dirty="0"/>
           </a:p>
@@ -4676,7 +4676,7 @@
                 <a:ea typeface="Arial" pitchFamily="34" charset="-122"/>
                 <a:cs typeface="Arial" pitchFamily="34" charset="-120"/>
               </a:rPr>
-              <a:t>Outcomes reported in studies of anal high-grade squamous intraepithelial lesions…</a:t>
+              <a:t>Suppression of the myofibroblastic cancer-associated fibroblast phenotype to enh…</a:t>
             </a:r>
             <a:endParaRPr lang="en-US" sz="1400" dirty="0"/>
           </a:p>
@@ -4713,7 +4713,7 @@
                 <a:ea typeface="Arial" pitchFamily="34" charset="-122"/>
                 <a:cs typeface="Arial" pitchFamily="34" charset="-120"/>
               </a:rPr>
-              <a:t>Association of Pre-treatment CALLY Index With Pathological Response to Neoadjuva…</a:t>
+              <a:t>Ethyl caffeate reprograms tumor-associated macrophages to enhance CD8+ T-cell im…</a:t>
             </a:r>
             <a:endParaRPr lang="en-US" sz="1400" dirty="0"/>
           </a:p>
@@ -4750,7 +4750,7 @@
                 <a:ea typeface="Arial" pitchFamily="34" charset="-122"/>
                 <a:cs typeface="Arial" pitchFamily="34" charset="-120"/>
               </a:rPr>
-              <a:t>Prognostic value of systemic immune-inflammation index for colorectal cancer: a …</a:t>
+              <a:t>… Cancer and Mesothelial Stromal Cell Lines from Malignant Ascites Reveals a Mes…</a:t>
             </a:r>
             <a:endParaRPr lang="en-US" sz="1400" dirty="0"/>
           </a:p>
@@ -4787,7 +4787,7 @@
                 <a:ea typeface="Arial" pitchFamily="34" charset="-122"/>
                 <a:cs typeface="Arial" pitchFamily="34" charset="-120"/>
               </a:rPr>
-              <a:t>Intratumoral enrichment and suppressive activity of DP8&amp;#x3b1; regulatory T cell…</a:t>
+              <a:t>KLK7 overexpression promotes an aggressive phenotype and facilitates peritoneal …</a:t>
             </a:r>
             <a:endParaRPr lang="en-US" sz="1400" dirty="0"/>
           </a:p>
@@ -4824,7 +4824,7 @@
                 <a:ea typeface="Arial" pitchFamily="34" charset="-122"/>
                 <a:cs typeface="Arial" pitchFamily="34" charset="-120"/>
               </a:rPr>
-              <a:t>Awareness of inflammatory bowel disease-associated colorectal cancer risk and it…</a:t>
+              <a:t>Integrative network pharmacology and machine learning identify potential targets…</a:t>
             </a:r>
             <a:endParaRPr lang="en-US" sz="1400" dirty="0"/>
           </a:p>
@@ -4979,7 +4979,7 @@
                   </a:extLst>
                 </a:hlinkClick>
               </a:rPr>
-              <a:t>Neoadjuvant toripalimab plus celecoxib versus toripalimab monotherapy for mismatch repair-deficient or microsatellite instability-high, locally advanced colorectal cancer (PICC-2): an open-label, multicentre, randomised, phase 2 trial.</a:t>
+              <a:t>ORCHESTRA hits a sour note for debulking in metastatic colorectal cancer</a:t>
             </a:r>
             <a:endParaRPr lang="en-US" sz="2400" dirty="0"/>
           </a:p>
@@ -5015,7 +5015,7 @@
                   <a:srgbClr val="888888"/>
                 </a:solidFill>
               </a:rPr>
-              <a:t>The Lancet. Oncology  ·  IF 41.6  ·  RCT Phase 3</a:t>
+              <a:t>JAMA  ·  IF 63.1</a:t>
             </a:r>
             <a:endParaRPr lang="en-US" sz="1000" dirty="0"/>
           </a:p>
@@ -5058,7 +5058,7 @@
                 <a:ea typeface="Arial" pitchFamily="34" charset="-122"/>
                 <a:cs typeface="Arial" pitchFamily="34" charset="-120"/>
               </a:rPr>
-              <a:t>Neoadjuvant therapy for dMMR/MSI-H cancer</a:t>
+              <a:t>ORCHESTRA trial evaluates debulking surgery</a:t>
             </a:r>
             <a:endParaRPr lang="en-US" sz="1800" dirty="0"/>
           </a:p>
@@ -5079,7 +5079,7 @@
                 <a:ea typeface="Arial" pitchFamily="34" charset="-122"/>
                 <a:cs typeface="Arial" pitchFamily="34" charset="-120"/>
               </a:rPr>
-              <a:t>Combination of toripalimab and celecoxib</a:t>
+              <a:t>Focus on metastatic colorectal cancer patients</a:t>
             </a:r>
             <a:endParaRPr lang="en-US" sz="1800" dirty="0"/>
           </a:p>
@@ -5100,7 +5100,49 @@
                 <a:ea typeface="Arial" pitchFamily="34" charset="-122"/>
                 <a:cs typeface="Arial" pitchFamily="34" charset="-120"/>
               </a:rPr>
-              <a:t>Higher pathological complete response rate</a:t>
+              <a:t>Results show limited survival benefit</a:t>
+            </a:r>
+            <a:endParaRPr lang="en-US" sz="1800" dirty="0"/>
+          </a:p>
+          <a:p>
+            <a:pPr marL="342900" indent="-342900">
+              <a:spcAft>
+                <a:spcPts val="800"/>
+              </a:spcAft>
+              <a:buSzPct val="100000"/>
+              <a:buChar char="•"/>
+            </a:pPr>
+            <a:r>
+              <a:rPr lang="en-US" sz="1800" dirty="0">
+                <a:solidFill>
+                  <a:srgbClr val="333333"/>
+                </a:solidFill>
+                <a:latin typeface="Arial" pitchFamily="34" charset="0"/>
+                <a:ea typeface="Arial" pitchFamily="34" charset="-122"/>
+                <a:cs typeface="Arial" pitchFamily="34" charset="-120"/>
+              </a:rPr>
+              <a:t>Concerns over surgical complications</a:t>
+            </a:r>
+            <a:endParaRPr lang="en-US" sz="1800" dirty="0"/>
+          </a:p>
+          <a:p>
+            <a:pPr marL="342900" indent="-342900">
+              <a:spcAft>
+                <a:spcPts val="800"/>
+              </a:spcAft>
+              <a:buSzPct val="100000"/>
+              <a:buChar char="•"/>
+            </a:pPr>
+            <a:r>
+              <a:rPr lang="en-US" sz="1800" dirty="0">
+                <a:solidFill>
+                  <a:srgbClr val="333333"/>
+                </a:solidFill>
+                <a:latin typeface="Arial" pitchFamily="34" charset="0"/>
+                <a:ea typeface="Arial" pitchFamily="34" charset="-122"/>
+                <a:cs typeface="Arial" pitchFamily="34" charset="-120"/>
+              </a:rPr>
+              <a:t>Need for alternative treatment strategies</a:t>
             </a:r>
             <a:endParaRPr lang="en-US" sz="1800" dirty="0"/>
           </a:p>
@@ -5136,7 +5178,7 @@
                   <a:srgbClr val="888888"/>
                 </a:solidFill>
               </a:rPr>
-              <a:t>Hu Huabin, Shen Xutao, Li Yunfeng et al.. The Lancet. Oncology. 2026-07-01 DOI: 10.1016/S1470-2045(26)00220-2</a:t>
+              <a:t>M Fakih. JAMA. 2026</a:t>
             </a:r>
             <a:endParaRPr lang="en-US" sz="800" dirty="0"/>
           </a:p>
@@ -5336,7 +5378,7 @@
                   </a:extLst>
                 </a:hlinkClick>
               </a:rPr>
-              <a:t>Perioperative systemic therapy versus surgery alone for resectable colorectal peritoneal-only metastases (CAIRO6): a randomised, open-label, phase 3 trial.</a:t>
+              <a:t>Oncogenic PIK3CA mutation enhances tumor immunogenicity through the IRF1-NLRC5-MHC-I axis in urothelial carcinoma.</a:t>
             </a:r>
             <a:endParaRPr lang="en-US" sz="2400" dirty="0"/>
           </a:p>
@@ -5372,7 +5414,7 @@
                   <a:srgbClr val="888888"/>
                 </a:solidFill>
               </a:rPr>
-              <a:t>The Lancet. Oncology  ·  IF 41.6  ·  RCT Phase 3</a:t>
+              <a:t>Journal for immunotherapy of cancer  ·  IF 10.9  ·  Retrospective Study  ·  🌏 Asia</a:t>
             </a:r>
             <a:endParaRPr lang="en-US" sz="1000" dirty="0"/>
           </a:p>
@@ -5415,7 +5457,7 @@
                 <a:ea typeface="Arial" pitchFamily="34" charset="-122"/>
                 <a:cs typeface="Arial" pitchFamily="34" charset="-120"/>
               </a:rPr>
-              <a:t>Study compares systemic therapy and surgery alone</a:t>
+              <a:t>PIK3CA mutation enhances tumor immunogenicity.</a:t>
             </a:r>
             <a:endParaRPr lang="en-US" sz="1800" dirty="0"/>
           </a:p>
@@ -5436,7 +5478,7 @@
                 <a:ea typeface="Arial" pitchFamily="34" charset="-122"/>
                 <a:cs typeface="Arial" pitchFamily="34" charset="-120"/>
               </a:rPr>
-              <a:t>358 patients enrolled in the trial</a:t>
+              <a:t>Higher TMB correlates with ICI response.</a:t>
             </a:r>
             <a:endParaRPr lang="en-US" sz="1800" dirty="0"/>
           </a:p>
@@ -5457,7 +5499,7 @@
                 <a:ea typeface="Arial" pitchFamily="34" charset="-122"/>
                 <a:cs typeface="Arial" pitchFamily="34" charset="-120"/>
               </a:rPr>
-              <a:t>Median overall survival: 44 vs 39 months</a:t>
+              <a:t>IRF1-NLRC5-MHC-I axis is activated.</a:t>
             </a:r>
             <a:endParaRPr lang="en-US" sz="1800" dirty="0"/>
           </a:p>
@@ -5478,7 +5520,7 @@
                 <a:ea typeface="Arial" pitchFamily="34" charset="-122"/>
                 <a:cs typeface="Arial" pitchFamily="34" charset="-120"/>
               </a:rPr>
-              <a:t>Higher postoperative morbidity in systemic therapy group</a:t>
+              <a:t>Functional studies confirm immune response.</a:t>
             </a:r>
             <a:endParaRPr lang="en-US" sz="1800" dirty="0"/>
           </a:p>
@@ -5499,7 +5541,7 @@
                 <a:ea typeface="Arial" pitchFamily="34" charset="-122"/>
                 <a:cs typeface="Arial" pitchFamily="34" charset="-120"/>
               </a:rPr>
-              <a:t>Major toxicity observed in 57% of patients</a:t>
+              <a:t>In vivo models validate therapeutic implications.</a:t>
             </a:r>
             <a:endParaRPr lang="en-US" sz="1800" dirty="0"/>
           </a:p>
@@ -5535,7 +5577,7 @@
                   <a:srgbClr val="888888"/>
                 </a:solidFill>
               </a:rPr>
-              <a:t>Rovers Koen P, Bakkers Checca, van den Heuvel Teun B M et al.. The Lancet. Oncology. 2026-06-29 DOI: 10.1016/S1470-2045(26)00085-9</a:t>
+              <a:t>Su Yu-Li, Huang Shih-Yu, Kuo Chung-Wen et al.. Journal for immunotherapy of cancer. 2026-07-08 DOI: 10.1136/jitc-2026-014770</a:t>
             </a:r>
             <a:endParaRPr lang="en-US" sz="800" dirty="0"/>
           </a:p>
@@ -5735,7 +5777,7 @@
                   </a:extLst>
                 </a:hlinkClick>
               </a:rPr>
-              <a:t>Reprogramming macrophage immunometabolism via glutamine antagonism potentiates colorectal cancer therapy in mice.</a:t>
+              <a:t>Parasutterella excrementihominis exacerbates experimental colitis and colitis-associated colorectal cancer via pathogenic NETosis activation</a:t>
             </a:r>
             <a:endParaRPr lang="en-US" sz="2400" dirty="0"/>
           </a:p>
@@ -5771,7 +5813,7 @@
                   <a:srgbClr val="888888"/>
                 </a:solidFill>
               </a:rPr>
-              <a:t>Nature communications  ·  IF 14.7  ·  Basic Research</a:t>
+              <a:t>Gut  ·  IF 24.5</a:t>
             </a:r>
             <a:endParaRPr lang="en-US" sz="1000" dirty="0"/>
           </a:p>
@@ -5814,7 +5856,7 @@
                 <a:ea typeface="Arial" pitchFamily="34" charset="-122"/>
                 <a:cs typeface="Arial" pitchFamily="34" charset="-120"/>
               </a:rPr>
-              <a:t>Glutamine metabolism promotes immunosuppressive macrophages.</a:t>
+              <a:t>P. excrementihominis worsens colitis severity.</a:t>
             </a:r>
             <a:endParaRPr lang="en-US" sz="1800" dirty="0"/>
           </a:p>
@@ -5835,7 +5877,7 @@
                 <a:ea typeface="Arial" pitchFamily="34" charset="-122"/>
                 <a:cs typeface="Arial" pitchFamily="34" charset="-120"/>
               </a:rPr>
-              <a:t>WGF-T17 reprograms macrophages to inflammatory state.</a:t>
+              <a:t>NETosis activation linked to inflammation.</a:t>
             </a:r>
             <a:endParaRPr lang="en-US" sz="1800" dirty="0"/>
           </a:p>
@@ -5856,7 +5898,7 @@
                 <a:ea typeface="Arial" pitchFamily="34" charset="-122"/>
                 <a:cs typeface="Arial" pitchFamily="34" charset="-120"/>
               </a:rPr>
-              <a:t>T17 enhances efficacy of CRC therapies.</a:t>
+              <a:t>Study suggests new therapeutic strategies.</a:t>
             </a:r>
             <a:endParaRPr lang="en-US" sz="1800" dirty="0"/>
           </a:p>
@@ -5892,7 +5934,7 @@
                   <a:srgbClr val="888888"/>
                 </a:solidFill>
               </a:rPr>
-              <a:t>Fan Renming, Lu Xintong, Zhang Bingjie et al.. Nature communications. 2026-07-04 DOI: 10.1038/s41467-026-75208-0</a:t>
+              <a:t>H Tan, L Huang, J Wang. Gut. 2026</a:t>
             </a:r>
             <a:endParaRPr lang="en-US" sz="800" dirty="0"/>
           </a:p>
@@ -6092,7 +6134,7 @@
                   </a:extLst>
                 </a:hlinkClick>
               </a:rPr>
-              <a:t>Norisoboldine suppresses epithelial-mesenchymal transition in colorectal cancer by simultaneously inhibiting the CXCR4/CXCR7 chemokine receptors and the JAK/STAT3 signaling pathway.</a:t>
+              <a:t>rs2032582 polymorphism of ATP binding cassette subfamily B member 1 affect the susceptibility of inflammatory bowel disease: a systematical meta-analysis based …</a:t>
             </a:r>
             <a:endParaRPr lang="en-US" sz="2400" dirty="0"/>
           </a:p>
@@ -6128,7 +6170,7 @@
                   <a:srgbClr val="888888"/>
                 </a:solidFill>
               </a:rPr>
-              <a:t>The Journal of pharmacy and pharmacology  ·  Basic Research  ·  🌏 Asia</a:t>
+              <a:t>International Journal of Colorectal Disease  ·  Meta-Analysis</a:t>
             </a:r>
             <a:endParaRPr lang="en-US" sz="1000" dirty="0"/>
           </a:p>
@@ -6171,7 +6213,7 @@
                 <a:ea typeface="Arial" pitchFamily="34" charset="-122"/>
                 <a:cs typeface="Arial" pitchFamily="34" charset="-120"/>
               </a:rPr>
-              <a:t>Norisoboldine inhibits colorectal cancer progression.</a:t>
+              <a:t>rs2032582 polymorphism linked to IBD risk</a:t>
             </a:r>
             <a:endParaRPr lang="en-US" sz="1800" dirty="0"/>
           </a:p>
@@ -6192,7 +6234,7 @@
                 <a:ea typeface="Arial" pitchFamily="34" charset="-122"/>
                 <a:cs typeface="Arial" pitchFamily="34" charset="-120"/>
               </a:rPr>
-              <a:t>Decreases mesenchymal protein expression levels.</a:t>
+              <a:t>Meta-analysis includes multiple studies</a:t>
             </a:r>
             <a:endParaRPr lang="en-US" sz="1800" dirty="0"/>
           </a:p>
@@ -6213,7 +6255,7 @@
                 <a:ea typeface="Arial" pitchFamily="34" charset="-122"/>
                 <a:cs typeface="Arial" pitchFamily="34" charset="-120"/>
               </a:rPr>
-              <a:t>Inhibits JAK/STAT3 signaling pathway activity.</a:t>
+              <a:t>Significant association with Crohn's disease</a:t>
             </a:r>
             <a:endParaRPr lang="en-US" sz="1800" dirty="0"/>
           </a:p>
@@ -6249,7 +6291,7 @@
                   <a:srgbClr val="888888"/>
                 </a:solidFill>
               </a:rPr>
-              <a:t>Kim Na Young, Hong Yejin, Baek Seung Ho et al.. The Journal of pharmacy and pharmacology. 2026-07-04 DOI: 10.1093/jpp/rgag071</a:t>
+              <a:t>H Chen, H Zhang, G Tao. International Journal of Colorectal Disease. 2026</a:t>
             </a:r>
             <a:endParaRPr lang="en-US" sz="800" dirty="0"/>
           </a:p>
@@ -6449,7 +6491,7 @@
                   </a:extLst>
                 </a:hlinkClick>
               </a:rPr>
-              <a:t>Analysis of Formimidoyltransferase Cyclodeaminase as a Potential Prognostic Biomarker and Therapeutic Target in Colorectal Cancer.</a:t>
+              <a:t>Combining genotoxic gut bacterial strains increases tumor burden and accelerates onset in a germ-free mouse model of colon carcinogenesis.</a:t>
             </a:r>
             <a:endParaRPr lang="en-US" sz="2400" dirty="0"/>
           </a:p>
@@ -6485,7 +6527,7 @@
                   <a:srgbClr val="888888"/>
                 </a:solidFill>
               </a:rPr>
-              <a:t>Cancer genomics &amp; proteomics  ·  Basic Research  ·  🌏 Asia</a:t>
+              <a:t>Cell reports  ·  IF 8.8  ·  Basic Research</a:t>
             </a:r>
             <a:endParaRPr lang="en-US" sz="1000" dirty="0"/>
           </a:p>
@@ -6528,7 +6570,7 @@
                 <a:ea typeface="Arial" pitchFamily="34" charset="-122"/>
                 <a:cs typeface="Arial" pitchFamily="34" charset="-120"/>
               </a:rPr>
-              <a:t>FTCD linked to cancer progression in CRC.</a:t>
+              <a:t>Germ-free mice used for study.</a:t>
             </a:r>
             <a:endParaRPr lang="en-US" sz="1800" dirty="0"/>
           </a:p>
@@ -6549,7 +6591,7 @@
                 <a:ea typeface="Arial" pitchFamily="34" charset="-122"/>
                 <a:cs typeface="Arial" pitchFamily="34" charset="-120"/>
               </a:rPr>
-              <a:t>High FTCD correlates with poor survival outcomes.</a:t>
+              <a:t>19 human fecal microbiotas tested.</a:t>
             </a:r>
             <a:endParaRPr lang="en-US" sz="1800" dirty="0"/>
           </a:p>
@@ -6570,7 +6612,49 @@
                 <a:ea typeface="Arial" pitchFamily="34" charset="-122"/>
                 <a:cs typeface="Arial" pitchFamily="34" charset="-120"/>
               </a:rPr>
-              <a:t>FTCD knockdown reduces tumor growth and invasion.</a:t>
+              <a:t>Genotoxicity predicts tumorigenic microbes.</a:t>
+            </a:r>
+            <a:endParaRPr lang="en-US" sz="1800" dirty="0"/>
+          </a:p>
+          <a:p>
+            <a:pPr marL="342900" indent="-342900">
+              <a:spcAft>
+                <a:spcPts val="800"/>
+              </a:spcAft>
+              <a:buSzPct val="100000"/>
+              <a:buChar char="•"/>
+            </a:pPr>
+            <a:r>
+              <a:rPr lang="en-US" sz="1800" dirty="0">
+                <a:solidFill>
+                  <a:srgbClr val="333333"/>
+                </a:solidFill>
+                <a:latin typeface="Arial" pitchFamily="34" charset="0"/>
+                <a:ea typeface="Arial" pitchFamily="34" charset="-122"/>
+                <a:cs typeface="Arial" pitchFamily="34" charset="-120"/>
+              </a:rPr>
+              <a:t>Combining strains increases tumor burden.</a:t>
+            </a:r>
+            <a:endParaRPr lang="en-US" sz="1800" dirty="0"/>
+          </a:p>
+          <a:p>
+            <a:pPr marL="342900" indent="-342900">
+              <a:spcAft>
+                <a:spcPts val="800"/>
+              </a:spcAft>
+              <a:buSzPct val="100000"/>
+              <a:buChar char="•"/>
+            </a:pPr>
+            <a:r>
+              <a:rPr lang="en-US" sz="1800" dirty="0">
+                <a:solidFill>
+                  <a:srgbClr val="333333"/>
+                </a:solidFill>
+                <a:latin typeface="Arial" pitchFamily="34" charset="0"/>
+                <a:ea typeface="Arial" pitchFamily="34" charset="-122"/>
+                <a:cs typeface="Arial" pitchFamily="34" charset="-120"/>
+              </a:rPr>
+              <a:t>Balance of strains affects tumor onset.</a:t>
             </a:r>
             <a:endParaRPr lang="en-US" sz="1800" dirty="0"/>
           </a:p>
@@ -6606,7 +6690,7 @@
                   <a:srgbClr val="888888"/>
                 </a:solidFill>
               </a:rPr>
-              <a:t>Tanaka Kenshiro, Umeda Shinichi, Hattori Norifumi et al.. Cancer genomics &amp; proteomics. 2026-06-29 DOI: 10.21873/cgp.20596</a:t>
+              <a:t>Plitt Tamar, Piessevaux Alix, Rajpal Urvija et al.. Cell reports. 2026-07-07 DOI: 10.1016/j.celrep.2026.117645</a:t>
             </a:r>
             <a:endParaRPr lang="en-US" sz="800" dirty="0"/>
           </a:p>
@@ -6806,7 +6890,7 @@
                   </a:extLst>
                 </a:hlinkClick>
               </a:rPr>
-              <a:t>Outcomes reported in studies of anal high-grade squamous intraepithelial lesions treatments: systematic review.</a:t>
+              <a:t>Suppression of the myofibroblastic cancer-associated fibroblast phenotype to enhance anti-PD-1 response.</a:t>
             </a:r>
             <a:endParaRPr lang="en-US" sz="2400" dirty="0"/>
           </a:p>
@@ -6842,7 +6926,7 @@
                   <a:srgbClr val="888888"/>
                 </a:solidFill>
               </a:rPr>
-              <a:t>BJS open  ·  RCT</a:t>
+              <a:t>Journal of experimental &amp; clinical cancer research : CR  ·  Basic Research</a:t>
             </a:r>
             <a:endParaRPr lang="en-US" sz="1000" dirty="0"/>
           </a:p>
@@ -6885,7 +6969,7 @@
                 <a:ea typeface="Arial" pitchFamily="34" charset="-122"/>
                 <a:cs typeface="Arial" pitchFamily="34" charset="-120"/>
               </a:rPr>
-              <a:t>Anal HSIL is a precursor to ASCC.</a:t>
+              <a:t>CAFs modulate tumor growth and immune response.</a:t>
             </a:r>
             <a:endParaRPr lang="en-US" sz="1800" dirty="0"/>
           </a:p>
@@ -6906,7 +6990,7 @@
                 <a:ea typeface="Arial" pitchFamily="34" charset="-122"/>
                 <a:cs typeface="Arial" pitchFamily="34" charset="-120"/>
               </a:rPr>
-              <a:t>67 studies evaluated anal HSIL treatments.</a:t>
+              <a:t>myCAFs inhibit CD8+ T cell infiltration.</a:t>
             </a:r>
             <a:endParaRPr lang="en-US" sz="1800" dirty="0"/>
           </a:p>
@@ -6927,7 +7011,7 @@
                 <a:ea typeface="Arial" pitchFamily="34" charset="-122"/>
                 <a:cs typeface="Arial" pitchFamily="34" charset="-120"/>
               </a:rPr>
-              <a:t>966 outcomes mapped to 170 SOTs.</a:t>
+              <a:t>Nilotinib reduces myCAF markers and tumor size.</a:t>
             </a:r>
             <a:endParaRPr lang="en-US" sz="1800" dirty="0"/>
           </a:p>
@@ -6948,7 +7032,7 @@
                 <a:ea typeface="Arial" pitchFamily="34" charset="-122"/>
                 <a:cs typeface="Arial" pitchFamily="34" charset="-120"/>
               </a:rPr>
-              <a:t>High heterogeneity in outcome definitions.</a:t>
+              <a:t>Combination therapy enhances anti-PD-1 response.</a:t>
             </a:r>
             <a:endParaRPr lang="en-US" sz="1800" dirty="0"/>
           </a:p>
@@ -6969,7 +7053,7 @@
                 <a:ea typeface="Arial" pitchFamily="34" charset="-122"/>
                 <a:cs typeface="Arial" pitchFamily="34" charset="-120"/>
               </a:rPr>
-              <a:t>Need for a COS to standardize outcomes.</a:t>
+              <a:t>Identified disease-specific markers for CRC CAFs.</a:t>
             </a:r>
             <a:endParaRPr lang="en-US" sz="1800" dirty="0"/>
           </a:p>
@@ -7005,7 +7089,7 @@
                   <a:srgbClr val="888888"/>
                 </a:solidFill>
               </a:rPr>
-              <a:t>Finch David A, Chaudhury Madhu P, Morris Rebecca et al.. BJS open. 2026-07-04 DOI: 10.1093/bjsopen/zrag061</a:t>
+              <a:t>Johnson Katherine A, Lippert Anna E L, Cornelio Alec et al.. Journal of experimental &amp; clinical cancer research : CR. 2026-07-10 DOI: 10.1186/s13046-026-03779-3</a:t>
             </a:r>
             <a:endParaRPr lang="en-US" sz="800" dirty="0"/>
           </a:p>
@@ -7205,7 +7289,7 @@
                   </a:extLst>
                 </a:hlinkClick>
               </a:rPr>
-              <a:t>Association of Pre-treatment CALLY Index With Pathological Response to Neoadjuvant Chemotherapy in Rectal Cancer.</a:t>
+              <a:t>Ethyl caffeate reprograms tumor-associated macrophages to enhance CD8+ T-cell immunity in colorectal cancer.</a:t>
             </a:r>
             <a:endParaRPr lang="en-US" sz="2400" dirty="0"/>
           </a:p>
@@ -7241,7 +7325,7 @@
                   <a:srgbClr val="888888"/>
                 </a:solidFill>
               </a:rPr>
-              <a:t>In vivo (Athens, Greece)  ·  Retrospective Study  ·  🌏 Asia</a:t>
+              <a:t>BMC cancer  ·  Basic Research</a:t>
             </a:r>
             <a:endParaRPr lang="en-US" sz="1000" dirty="0"/>
           </a:p>
@@ -7284,7 +7368,7 @@
                 <a:ea typeface="Arial" pitchFamily="34" charset="-122"/>
                 <a:cs typeface="Arial" pitchFamily="34" charset="-120"/>
               </a:rPr>
-              <a:t>Study on pre-treatment CALLY index</a:t>
+              <a:t>Ethyl caffeate enhances CD8+ T-cell immunity.</a:t>
             </a:r>
             <a:endParaRPr lang="en-US" sz="1800" dirty="0"/>
           </a:p>
@@ -7305,7 +7389,7 @@
                 <a:ea typeface="Arial" pitchFamily="34" charset="-122"/>
                 <a:cs typeface="Arial" pitchFamily="34" charset="-120"/>
               </a:rPr>
-              <a:t>Analyzed 59 rectal cancer patients</a:t>
+              <a:t>Macrophage polarization towards M1-like phenotype.</a:t>
             </a:r>
             <a:endParaRPr lang="en-US" sz="1800" dirty="0"/>
           </a:p>
@@ -7326,49 +7410,7 @@
                 <a:ea typeface="Arial" pitchFamily="34" charset="-122"/>
                 <a:cs typeface="Arial" pitchFamily="34" charset="-120"/>
               </a:rPr>
-              <a:t>Pathological response evaluated by Japanese Classification</a:t>
-            </a:r>
-            <a:endParaRPr lang="en-US" sz="1800" dirty="0"/>
-          </a:p>
-          <a:p>
-            <a:pPr marL="342900" indent="-342900">
-              <a:spcAft>
-                <a:spcPts val="800"/>
-              </a:spcAft>
-              <a:buSzPct val="100000"/>
-              <a:buChar char="•"/>
-            </a:pPr>
-            <a:r>
-              <a:rPr lang="en-US" sz="1800" dirty="0">
-                <a:solidFill>
-                  <a:srgbClr val="333333"/>
-                </a:solidFill>
-                <a:latin typeface="Arial" pitchFamily="34" charset="0"/>
-                <a:ea typeface="Arial" pitchFamily="34" charset="-122"/>
-                <a:cs typeface="Arial" pitchFamily="34" charset="-120"/>
-              </a:rPr>
-              <a:t>40.7% achieved grade 2-3 response</a:t>
-            </a:r>
-            <a:endParaRPr lang="en-US" sz="1800" dirty="0"/>
-          </a:p>
-          <a:p>
-            <a:pPr marL="342900" indent="-342900">
-              <a:spcAft>
-                <a:spcPts val="800"/>
-              </a:spcAft>
-              <a:buSzPct val="100000"/>
-              <a:buChar char="•"/>
-            </a:pPr>
-            <a:r>
-              <a:rPr lang="en-US" sz="1800" dirty="0">
-                <a:solidFill>
-                  <a:srgbClr val="333333"/>
-                </a:solidFill>
-                <a:latin typeface="Arial" pitchFamily="34" charset="0"/>
-                <a:ea typeface="Arial" pitchFamily="34" charset="-122"/>
-                <a:cs typeface="Arial" pitchFamily="34" charset="-120"/>
-              </a:rPr>
-              <a:t>CALLY index may predict NAC response</a:t>
+              <a:t>Significant tumor growth suppression in CRC model.</a:t>
             </a:r>
             <a:endParaRPr lang="en-US" sz="1800" dirty="0"/>
           </a:p>
@@ -7404,7 +7446,7 @@
                   <a:srgbClr val="888888"/>
                 </a:solidFill>
               </a:rPr>
-              <a:t>Akiyama Yasuki, Sawatsubashi Yusuke, Yabuki Kei et al.. In vivo (Athens, Greece). 2026-07-01 DOI: 10.21873/invivo.14382</a:t>
+              <a:t>Bao Zhixian, Gao Jie, Cheng Xinhong et al.. BMC cancer. 2026-07-05 DOI: 10.1186/s12885-026-16469-2</a:t>
             </a:r>
             <a:endParaRPr lang="en-US" sz="800" dirty="0"/>
           </a:p>

</xml_diff>

<commit_message>
chore: update weekly digest 2026-07-20
</commit_message>
<xml_diff>
--- a/docs/digest-en.pptx
+++ b/docs/digest-en.pptx
@@ -2249,7 +2249,7 @@
                   <a:srgbClr val="888888"/>
                 </a:solidFill>
               </a:rPr>
-              <a:t>2026-07-06 — 2026-07-13</a:t>
+              <a:t>2026-07-13 — 2026-07-20</a:t>
             </a:r>
             <a:endParaRPr lang="en-US" sz="1400" dirty="0"/>
           </a:p>
@@ -2440,7 +2440,7 @@
                   </a:extLst>
                 </a:hlinkClick>
               </a:rPr>
-              <a:t>… Cancer and Mesothelial Stromal Cell Lines from Malignant Ascites Reveals a Mesothelial‐Stromal FGFR3 Axis as a Potential Vulnerability in Peritoneal Metastasis</a:t>
+              <a:t>Alzheimer's disease-related mutations in APP influence colorectal tumor formation in a sex-dependent manner.</a:t>
             </a:r>
             <a:endParaRPr lang="en-US" sz="2400" dirty="0"/>
           </a:p>
@@ -2476,7 +2476,7 @@
                   <a:srgbClr val="888888"/>
                 </a:solidFill>
               </a:rPr>
-              <a:t>Cancer …  ·  Basic Research</a:t>
+              <a:t>iScience  ·  Basic Research</a:t>
             </a:r>
             <a:endParaRPr lang="en-US" sz="1000" dirty="0"/>
           </a:p>
@@ -2519,7 +2519,7 @@
                 <a:ea typeface="Arial" pitchFamily="34" charset="-122"/>
                 <a:cs typeface="Arial" pitchFamily="34" charset="-120"/>
               </a:rPr>
-              <a:t>Colorectal cancer poses therapeutic challenges.</a:t>
+              <a:t>APP mutations affect colorectal cancer development.</a:t>
             </a:r>
             <a:endParaRPr lang="en-US" sz="1800" dirty="0"/>
           </a:p>
@@ -2540,7 +2540,7 @@
                 <a:ea typeface="Arial" pitchFamily="34" charset="-122"/>
                 <a:cs typeface="Arial" pitchFamily="34" charset="-120"/>
               </a:rPr>
-              <a:t>Peritoneal dissemination leads to poor prognosis.</a:t>
+              <a:t>Male mice show increased tumor formation.</a:t>
             </a:r>
             <a:endParaRPr lang="en-US" sz="1800" dirty="0"/>
           </a:p>
@@ -2561,7 +2561,49 @@
                 <a:ea typeface="Arial" pitchFamily="34" charset="-122"/>
                 <a:cs typeface="Arial" pitchFamily="34" charset="-120"/>
               </a:rPr>
-              <a:t>FGFR3 axis identified as potential vulnerability.</a:t>
+              <a:t>Female mice exhibit reduced tumor growth.</a:t>
+            </a:r>
+            <a:endParaRPr lang="en-US" sz="1800" dirty="0"/>
+          </a:p>
+          <a:p>
+            <a:pPr marL="342900" indent="-342900">
+              <a:spcAft>
+                <a:spcPts val="800"/>
+              </a:spcAft>
+              <a:buSzPct val="100000"/>
+              <a:buChar char="•"/>
+            </a:pPr>
+            <a:r>
+              <a:rPr lang="en-US" sz="1800" dirty="0">
+                <a:solidFill>
+                  <a:srgbClr val="333333"/>
+                </a:solidFill>
+                <a:latin typeface="Arial" pitchFamily="34" charset="0"/>
+                <a:ea typeface="Arial" pitchFamily="34" charset="-122"/>
+                <a:cs typeface="Arial" pitchFamily="34" charset="-120"/>
+              </a:rPr>
+              <a:t>Inflammatory changes differ by sex.</a:t>
+            </a:r>
+            <a:endParaRPr lang="en-US" sz="1800" dirty="0"/>
+          </a:p>
+          <a:p>
+            <a:pPr marL="342900" indent="-342900">
+              <a:spcAft>
+                <a:spcPts val="800"/>
+              </a:spcAft>
+              <a:buSzPct val="100000"/>
+              <a:buChar char="•"/>
+            </a:pPr>
+            <a:r>
+              <a:rPr lang="en-US" sz="1800" dirty="0">
+                <a:solidFill>
+                  <a:srgbClr val="333333"/>
+                </a:solidFill>
+                <a:latin typeface="Arial" pitchFamily="34" charset="0"/>
+                <a:ea typeface="Arial" pitchFamily="34" charset="-122"/>
+                <a:cs typeface="Arial" pitchFamily="34" charset="-120"/>
+              </a:rPr>
+              <a:t>Transcriptome analysis reveals pathway enrichment.</a:t>
             </a:r>
             <a:endParaRPr lang="en-US" sz="1800" dirty="0"/>
           </a:p>
@@ -2597,7 +2639,7 @@
                   <a:srgbClr val="888888"/>
                 </a:solidFill>
               </a:rPr>
-              <a:t>Y Fukui, H Kasashima, Z Wang. Cancer …. 2026</a:t>
+              <a:t>Ishida-Takaku Takako, Sohrabi Mona, Pecoraro Heidi L et al.. iScience. 2026-07-12 DOI: 10.1016/j.isci.2026.116645</a:t>
             </a:r>
             <a:endParaRPr lang="en-US" sz="800" dirty="0"/>
           </a:p>
@@ -2797,7 +2839,7 @@
                   </a:extLst>
                 </a:hlinkClick>
               </a:rPr>
-              <a:t>KLK7 overexpression promotes an aggressive phenotype and facilitates peritoneal dissemination in colorectal cancer cells</a:t>
+              <a:t>Sanghuangporus vaninii extract exerts dual anti-tumor effects in colitis-associated colorectal cancer by direct cytotoxicity and macrophage reprogramming via the PPAR&amp;#x3b3;/NF-&amp;#x3ba;B axis.</a:t>
             </a:r>
             <a:endParaRPr lang="en-US" sz="2400" dirty="0"/>
           </a:p>
@@ -2833,7 +2875,7 @@
                   <a:srgbClr val="888888"/>
                 </a:solidFill>
               </a:rPr>
-              <a:t>FEBS Open …  ·  Basic Research</a:t>
+              <a:t>Journal of ethnopharmacology  ·  Basic Research</a:t>
             </a:r>
             <a:endParaRPr lang="en-US" sz="1000" dirty="0"/>
           </a:p>
@@ -2876,7 +2918,7 @@
                 <a:ea typeface="Arial" pitchFamily="34" charset="-122"/>
                 <a:cs typeface="Arial" pitchFamily="34" charset="-120"/>
               </a:rPr>
-              <a:t>KLK7 overexpression linked to aggressive CRC</a:t>
+              <a:t>Sanghuangporus vaninii shows anti-tumor effects.</a:t>
             </a:r>
             <a:endParaRPr lang="en-US" sz="1800" dirty="0"/>
           </a:p>
@@ -2897,7 +2939,7 @@
                 <a:ea typeface="Arial" pitchFamily="34" charset="-122"/>
                 <a:cs typeface="Arial" pitchFamily="34" charset="-120"/>
               </a:rPr>
-              <a:t>Promotes peritoneal dissemination in cancer cells</a:t>
+              <a:t>Inhibits colitis-associated colorectal cancer (CAC).</a:t>
             </a:r>
             <a:endParaRPr lang="en-US" sz="1800" dirty="0"/>
           </a:p>
@@ -2918,7 +2960,49 @@
                 <a:ea typeface="Arial" pitchFamily="34" charset="-122"/>
                 <a:cs typeface="Arial" pitchFamily="34" charset="-120"/>
               </a:rPr>
-              <a:t>In vitro studies confirm aggressive phenotype</a:t>
+              <a:t>Targets PPARγ/NF-κB signaling pathway.</a:t>
+            </a:r>
+            <a:endParaRPr lang="en-US" sz="1800" dirty="0"/>
+          </a:p>
+          <a:p>
+            <a:pPr marL="342900" indent="-342900">
+              <a:spcAft>
+                <a:spcPts val="800"/>
+              </a:spcAft>
+              <a:buSzPct val="100000"/>
+              <a:buChar char="•"/>
+            </a:pPr>
+            <a:r>
+              <a:rPr lang="en-US" sz="1800" dirty="0">
+                <a:solidFill>
+                  <a:srgbClr val="333333"/>
+                </a:solidFill>
+                <a:latin typeface="Arial" pitchFamily="34" charset="0"/>
+                <a:ea typeface="Arial" pitchFamily="34" charset="-122"/>
+                <a:cs typeface="Arial" pitchFamily="34" charset="-120"/>
+              </a:rPr>
+              <a:t>Modulates macrophages towards M2 phenotype.</a:t>
+            </a:r>
+            <a:endParaRPr lang="en-US" sz="1800" dirty="0"/>
+          </a:p>
+          <a:p>
+            <a:pPr marL="342900" indent="-342900">
+              <a:spcAft>
+                <a:spcPts val="800"/>
+              </a:spcAft>
+              <a:buSzPct val="100000"/>
+              <a:buChar char="•"/>
+            </a:pPr>
+            <a:r>
+              <a:rPr lang="en-US" sz="1800" dirty="0">
+                <a:solidFill>
+                  <a:srgbClr val="333333"/>
+                </a:solidFill>
+                <a:latin typeface="Arial" pitchFamily="34" charset="0"/>
+                <a:ea typeface="Arial" pitchFamily="34" charset="-122"/>
+                <a:cs typeface="Arial" pitchFamily="34" charset="-120"/>
+              </a:rPr>
+              <a:t>Improves survival and reduces tumor burden.</a:t>
             </a:r>
             <a:endParaRPr lang="en-US" sz="1800" dirty="0"/>
           </a:p>
@@ -2954,7 +3038,7 @@
                   <a:srgbClr val="888888"/>
                 </a:solidFill>
               </a:rPr>
-              <a:t>YZ Haffani, T Dreyer, M Naim. FEBS Open …. 2026</a:t>
+              <a:t>Wang Yuqing, Mao Shangling, Shi Chao et al.. Journal of ethnopharmacology. 2026-07-15 DOI: 10.1016/j.jep.2026.121657</a:t>
             </a:r>
             <a:endParaRPr lang="en-US" sz="800" dirty="0"/>
           </a:p>
@@ -3154,7 +3238,7 @@
                   </a:extLst>
                 </a:hlinkClick>
               </a:rPr>
-              <a:t>Integrative network pharmacology and machine learning identify potential targets of indole-3-lactic acid in colorectal cancer</a:t>
+              <a:t>Anti-Malignancy and Anti-Inflammation Properties of Emodin, an Essential Constituent in Popular Laxative Botanicals.</a:t>
             </a:r>
             <a:endParaRPr lang="en-US" sz="2400" dirty="0"/>
           </a:p>
@@ -3190,7 +3274,7 @@
                   <a:srgbClr val="888888"/>
                 </a:solidFill>
               </a:rPr>
-              <a:t>Plos one  ·  Basic Research</a:t>
+              <a:t>The American journal of Chinese medicine  ·  Basic Research</a:t>
             </a:r>
             <a:endParaRPr lang="en-US" sz="1000" dirty="0"/>
           </a:p>
@@ -3233,7 +3317,7 @@
                 <a:ea typeface="Arial" pitchFamily="34" charset="-122"/>
                 <a:cs typeface="Arial" pitchFamily="34" charset="-120"/>
               </a:rPr>
-              <a:t>Network pharmacology identifies ILA targets.</a:t>
+              <a:t>Emodin shows anti-malignancy effects.</a:t>
             </a:r>
             <a:endParaRPr lang="en-US" sz="1800" dirty="0"/>
           </a:p>
@@ -3254,7 +3338,7 @@
                 <a:ea typeface="Arial" pitchFamily="34" charset="-122"/>
                 <a:cs typeface="Arial" pitchFamily="34" charset="-120"/>
               </a:rPr>
-              <a:t>Machine learning enhances target prediction.</a:t>
+              <a:t>Inhibits colorectal cancer cell growth.</a:t>
             </a:r>
             <a:endParaRPr lang="en-US" sz="1800" dirty="0"/>
           </a:p>
@@ -3275,7 +3359,7 @@
                 <a:ea typeface="Arial" pitchFamily="34" charset="-122"/>
                 <a:cs typeface="Arial" pitchFamily="34" charset="-120"/>
               </a:rPr>
-              <a:t>ILA shows antioxidant and anti-inflammatory effects.</a:t>
+              <a:t>Reduces inflammatory cytokines in vivo.</a:t>
             </a:r>
             <a:endParaRPr lang="en-US" sz="1800" dirty="0"/>
           </a:p>
@@ -3311,7 +3395,7 @@
                   <a:srgbClr val="888888"/>
                 </a:solidFill>
               </a:rPr>
-              <a:t>J Li, J Zhang, J Ke. Plos one. 2026</a:t>
+              <a:t>Wang Meng, Zhang Xiankang, Huang Yanrong et al.. The American journal of Chinese medicine. 2026-07-14 DOI: 10.1142/S0192415X26500588</a:t>
             </a:r>
             <a:endParaRPr lang="en-US" sz="800" dirty="0"/>
           </a:p>
@@ -3528,7 +3612,7 @@
                   <a:srgbClr val="FFFFFF"/>
                 </a:solidFill>
               </a:rPr>
-              <a:t>1. **腸道微生物與腫瘤發生的關聯性**  </a:t>
+              <a:t>1. **KRAS抑制劑的抗藥性機制**  </a:t>
             </a:r>
             <a:endParaRPr lang="en-US" sz="1200" dirty="0"/>
           </a:p>
@@ -3545,7 +3629,7 @@
                   <a:srgbClr val="FFFFFF"/>
                 </a:solidFill>
               </a:rPr>
-              <a:t>   The studies emphasize the significant role of gut microbiota in tumorigenesis, particularly in colorectal cancer, suggesting that specific bacterial strains can exacerbate or mitigate cancer progression.  </a:t>
+              <a:t>   **Mechanisms of Resistance to KRAS Inhibitors**  </a:t>
             </a:r>
             <a:endParaRPr lang="en-US" sz="1200" dirty="0"/>
           </a:p>
@@ -3562,7 +3646,7 @@
                   <a:srgbClr val="FFFFFF"/>
                 </a:solidFill>
               </a:rPr>
-              <a:t>   研究強調腸道微生物在腫瘤發生中的重要角色，特別是在結直腸癌中，某些細菌株可能加劇或減緩癌症進展。</a:t>
+              <a:t>   研究顯示，KRAS突變在大腸癌中佔有重要地位，然而其抗藥性機制的複雜性限制了治療效果，未來需針對這些機制進行深入探討。  </a:t>
             </a:r>
             <a:endParaRPr lang="en-US" sz="1200" dirty="0"/>
           </a:p>
@@ -3573,6 +3657,14 @@
               </a:lnSpc>
               <a:buNone/>
             </a:pPr>
+            <a:r>
+              <a:rPr lang="en-US" sz="1200" dirty="0">
+                <a:solidFill>
+                  <a:srgbClr val="FFFFFF"/>
+                </a:solidFill>
+              </a:rPr>
+              <a:t>   Studies indicate that KRAS mutations play a crucial role in colorectal cancer; however, the complexity of resistance mechanisms limits treatment efficacy, necessitating further exploration of these mechanisms.</a:t>
+            </a:r>
             <a:endParaRPr lang="en-US" sz="1200" dirty="0"/>
           </a:p>
           <a:p>
@@ -3582,13 +3674,22 @@
               </a:lnSpc>
               <a:buNone/>
             </a:pPr>
+            <a:endParaRPr lang="en-US" sz="1200" dirty="0"/>
+          </a:p>
+          <a:p>
+            <a:pPr indent="0" marL="0">
+              <a:lnSpc>
+                <a:spcPct val="150000"/>
+              </a:lnSpc>
+              <a:buNone/>
+            </a:pPr>
             <a:r>
               <a:rPr lang="en-US" sz="1200" dirty="0">
                 <a:solidFill>
                   <a:srgbClr val="FFFFFF"/>
                 </a:solidFill>
               </a:rPr>
-              <a:t>2. **免疫微環境的調控**  </a:t>
+              <a:t>2. **腸道微生物群的調節作用**  </a:t>
             </a:r>
             <a:endParaRPr lang="en-US" sz="1200" dirty="0"/>
           </a:p>
@@ -3605,7 +3706,7 @@
                   <a:srgbClr val="FFFFFF"/>
                 </a:solidFill>
               </a:rPr>
-              <a:t>   The modulation of the tumor immune microenvironment, particularly through cancer-associated fibroblasts and macrophages, is crucial for enhancing the efficacy of immunotherapies in colorectal cancer.  </a:t>
+              <a:t>   **Regulatory Role of Gut Microbiota**  </a:t>
             </a:r>
             <a:endParaRPr lang="en-US" sz="1200" dirty="0"/>
           </a:p>
@@ -3622,7 +3723,7 @@
                   <a:srgbClr val="FFFFFF"/>
                 </a:solidFill>
               </a:rPr>
-              <a:t>   腫瘤免疫微環境的調控，特別是通過癌症相關成纖維細胞和巨噬細胞，對於提高結直腸癌免疫療法的療效至關重要。</a:t>
+              <a:t>   新研究揭示，某些植物化合物能透過調節腸道微生物群來減輕炎症及腸道癌症的風險，這為未來的預防及治療策略提供了新的視角。  </a:t>
             </a:r>
             <a:endParaRPr lang="en-US" sz="1200" dirty="0"/>
           </a:p>
@@ -3633,6 +3734,14 @@
               </a:lnSpc>
               <a:buNone/>
             </a:pPr>
+            <a:r>
+              <a:rPr lang="en-US" sz="1200" dirty="0">
+                <a:solidFill>
+                  <a:srgbClr val="FFFFFF"/>
+                </a:solidFill>
+              </a:rPr>
+              <a:t>   New studies reveal that certain phytochemicals can mitigate inflammation and colorectal cancer risk by modulating gut microbiota, providing a new perspective for future prevention and treatment strategies.</a:t>
+            </a:r>
             <a:endParaRPr lang="en-US" sz="1200" dirty="0"/>
           </a:p>
           <a:p>
@@ -3642,13 +3751,22 @@
               </a:lnSpc>
               <a:buNone/>
             </a:pPr>
+            <a:endParaRPr lang="en-US" sz="1200" dirty="0"/>
+          </a:p>
+          <a:p>
+            <a:pPr indent="0" marL="0">
+              <a:lnSpc>
+                <a:spcPct val="150000"/>
+              </a:lnSpc>
+              <a:buNone/>
+            </a:pPr>
             <a:r>
               <a:rPr lang="en-US" sz="1200" dirty="0">
                 <a:solidFill>
                   <a:srgbClr val="FFFFFF"/>
                 </a:solidFill>
               </a:rPr>
-              <a:t>3. **基因變異作為預測生物標誌物**  </a:t>
+              <a:t>3. **系統性免疫炎症指數的預後價值**  </a:t>
             </a:r>
             <a:endParaRPr lang="en-US" sz="1200" dirty="0"/>
           </a:p>
@@ -3665,7 +3783,7 @@
                   <a:srgbClr val="FFFFFF"/>
                 </a:solidFill>
               </a:rPr>
-              <a:t>   Genetic alterations, such as PIK3CA mutations and polymorphisms in ATP binding cassette genes, may serve as predictive biomarkers for therapeutic responses in colorectal and other cancers.  </a:t>
+              <a:t>   **Prognostic Value of Systemic Immune-Inflammation Index**  </a:t>
             </a:r>
             <a:endParaRPr lang="en-US" sz="1200" dirty="0"/>
           </a:p>
@@ -3682,7 +3800,7 @@
                   <a:srgbClr val="FFFFFF"/>
                 </a:solidFill>
               </a:rPr>
-              <a:t>   基因變異，如PIK3CA突變和ATP結合盒基因的多態性，可能作為結直腸癌及其他癌症治療反應的預測生物標誌物。</a:t>
+              <a:t>   系統性免疫炎症指數(SII)在大腸癌的預後中顯示出潛在的價值，這提示我們可以利用炎症標記來改善臨床預測模型。  </a:t>
             </a:r>
             <a:endParaRPr lang="en-US" sz="1200" dirty="0"/>
           </a:p>
@@ -3693,6 +3811,14 @@
               </a:lnSpc>
               <a:buNone/>
             </a:pPr>
+            <a:r>
+              <a:rPr lang="en-US" sz="1200" dirty="0">
+                <a:solidFill>
+                  <a:srgbClr val="FFFFFF"/>
+                </a:solidFill>
+              </a:rPr>
+              <a:t>   The systemic immune-inflammation index (SII) shows potential prognostic value in colorectal cancer, suggesting that inflammatory markers could be utilized to enhance clinical predictive models.</a:t>
+            </a:r>
             <a:endParaRPr lang="en-US" sz="1200" dirty="0"/>
           </a:p>
           <a:p>
@@ -3702,13 +3828,22 @@
               </a:lnSpc>
               <a:buNone/>
             </a:pPr>
+            <a:endParaRPr lang="en-US" sz="1200" dirty="0"/>
+          </a:p>
+          <a:p>
+            <a:pPr indent="0" marL="0">
+              <a:lnSpc>
+                <a:spcPct val="150000"/>
+              </a:lnSpc>
+              <a:buNone/>
+            </a:pPr>
             <a:r>
               <a:rPr lang="en-US" sz="1200" dirty="0">
                 <a:solidFill>
                   <a:srgbClr val="FFFFFF"/>
                 </a:solidFill>
               </a:rPr>
-              <a:t>4. **新型治療策略的開發**  </a:t>
+              <a:t>4. **炎症性腸病患者的癌症風險認知**  </a:t>
             </a:r>
             <a:endParaRPr lang="en-US" sz="1200" dirty="0"/>
           </a:p>
@@ -3725,7 +3860,7 @@
                   <a:srgbClr val="FFFFFF"/>
                 </a:solidFill>
               </a:rPr>
-              <a:t>   The identification of novel therapeutic targets, including metabolic pathways and immune modulation strategies, presents new opportunities for improving treatment outcomes in colorectal cancer.  </a:t>
+              <a:t>   **Awareness of Cancer Risk in Inflammatory Bowel Disease Patients**  </a:t>
             </a:r>
             <a:endParaRPr lang="en-US" sz="1200" dirty="0"/>
           </a:p>
@@ -3742,7 +3877,7 @@
                   <a:srgbClr val="FFFFFF"/>
                 </a:solidFill>
               </a:rPr>
-              <a:t>   新型治療靶點的識別，包括代謝途徑和免疫調控策略，為改善結直腸癌的治療結果提供了新的機會。</a:t>
+              <a:t>   對於炎症性腸病患者來說，對大腸癌風險及其管理的認知仍然不足，未來應加強患者教育及相關研究。  </a:t>
             </a:r>
             <a:endParaRPr lang="en-US" sz="1200" dirty="0"/>
           </a:p>
@@ -3753,6 +3888,14 @@
               </a:lnSpc>
               <a:buNone/>
             </a:pPr>
+            <a:r>
+              <a:rPr lang="en-US" sz="1200" dirty="0">
+                <a:solidFill>
+                  <a:srgbClr val="FFFFFF"/>
+                </a:solidFill>
+              </a:rPr>
+              <a:t>   Awareness regarding cancer risk and management among inflammatory bowel disease patients remains inadequate, highlighting the need for enhanced patient education and related research in the future.</a:t>
+            </a:r>
             <a:endParaRPr lang="en-US" sz="1200" dirty="0"/>
           </a:p>
           <a:p>
@@ -3762,13 +3905,22 @@
               </a:lnSpc>
               <a:buNone/>
             </a:pPr>
+            <a:endParaRPr lang="en-US" sz="1200" dirty="0"/>
+          </a:p>
+          <a:p>
+            <a:pPr indent="0" marL="0">
+              <a:lnSpc>
+                <a:spcPct val="150000"/>
+              </a:lnSpc>
+              <a:buNone/>
+            </a:pPr>
             <a:r>
               <a:rPr lang="en-US" sz="1200" dirty="0">
                 <a:solidFill>
                   <a:srgbClr val="FFFFFF"/>
                 </a:solidFill>
               </a:rPr>
-              <a:t>5. **環境因素對癌症的影響**  </a:t>
+              <a:t>5. **超熱腹腔化療的潛在益處**  </a:t>
             </a:r>
             <a:endParaRPr lang="en-US" sz="1200" dirty="0"/>
           </a:p>
@@ -3785,7 +3937,41 @@
                   <a:srgbClr val="FFFFFF"/>
                 </a:solidFill>
               </a:rPr>
-              <a:t>   Environmental factors, including dietary components and microbial metabolites, play a critical role in the pathogenesis of inflammatory bowel diseases and colorectal cancer.</a:t>
+              <a:t>   **Potential Benefits of Hyperthermic Intraperitoneal Chemotherapy**  </a:t>
+            </a:r>
+            <a:endParaRPr lang="en-US" sz="1200" dirty="0"/>
+          </a:p>
+          <a:p>
+            <a:pPr indent="0" marL="0">
+              <a:lnSpc>
+                <a:spcPct val="150000"/>
+              </a:lnSpc>
+              <a:buNone/>
+            </a:pPr>
+            <a:r>
+              <a:rPr lang="en-US" sz="1200" dirty="0">
+                <a:solidFill>
+                  <a:srgbClr val="FFFFFF"/>
+                </a:solidFill>
+              </a:rPr>
+              <a:t>   超熱腹腔化療在晚期大腸癌患者中的應用顯示出可能的療效，未來應進一步評估其在不同臨床背景下的效果。  </a:t>
+            </a:r>
+            <a:endParaRPr lang="en-US" sz="1200" dirty="0"/>
+          </a:p>
+          <a:p>
+            <a:pPr indent="0" marL="0">
+              <a:lnSpc>
+                <a:spcPct val="150000"/>
+              </a:lnSpc>
+              <a:buNone/>
+            </a:pPr>
+            <a:r>
+              <a:rPr lang="en-US" sz="1200" dirty="0">
+                <a:solidFill>
+                  <a:srgbClr val="FFFFFF"/>
+                </a:solidFill>
+              </a:rPr>
+              <a:t>   The application of hyperthermic intraperitoneal chemotherapy in patients with advanced colorectal cancer shows potential efficacy, warranting further evaluation of its effects in different clinical contexts.</a:t>
             </a:r>
             <a:endParaRPr lang="en-US" sz="1200" dirty="0"/>
           </a:p>
@@ -3931,7 +4117,7 @@
                   <a:srgbClr val="FFFFFF"/>
                 </a:solidFill>
               </a:rPr>
-              <a:t>環境因素，包括飲食成分和微生物代謝物，在炎症性腸病和結直腸癌的發病機制中扮演著關鍵角色。</a:t>
+              <a:t>### 未來研究方向 (Future Research Directions)</a:t>
             </a:r>
             <a:endParaRPr lang="en-US" sz="1200" dirty="0"/>
           </a:p>
@@ -3957,7 +4143,7 @@
                   <a:srgbClr val="FFFFFF"/>
                 </a:solidFill>
               </a:rPr>
-              <a:t>### 未來研究方向 (Future Research Directions)</a:t>
+              <a:t>1. **深入研究KRAS抗藥性機制**  </a:t>
             </a:r>
             <a:endParaRPr lang="en-US" sz="1200" dirty="0"/>
           </a:p>
@@ -3968,6 +4154,14 @@
               </a:lnSpc>
               <a:buNone/>
             </a:pPr>
+            <a:r>
+              <a:rPr lang="en-US" sz="1200" dirty="0">
+                <a:solidFill>
+                  <a:srgbClr val="FFFFFF"/>
+                </a:solidFill>
+              </a:rPr>
+              <a:t>   **In-depth Investigation of KRAS Resistance Mechanisms**  </a:t>
+            </a:r>
             <a:endParaRPr lang="en-US" sz="1200" dirty="0"/>
           </a:p>
           <a:p>
@@ -3983,7 +4177,7 @@
                   <a:srgbClr val="FFFFFF"/>
                 </a:solidFill>
               </a:rPr>
-              <a:t>1. **腸道微生物的功能研究**  </a:t>
+              <a:t>   未來的研究應聚焦於KRAS抑制劑的抗藥性機制，特別是基因和非基因因素的交互作用，以開發更有效的治療策略。  </a:t>
             </a:r>
             <a:endParaRPr lang="en-US" sz="1200" dirty="0"/>
           </a:p>
@@ -4000,7 +4194,7 @@
                   <a:srgbClr val="FFFFFF"/>
                 </a:solidFill>
               </a:rPr>
-              <a:t>   Future studies should focus on elucidating the specific mechanisms by which gut microbiota influence tumorigenesis and the immune response in colorectal cancer.  </a:t>
+              <a:t>   Future research should focus on the mechanisms of resistance to KRAS inhibitors, particularly the interplay between genetic and non-genetic factors, to develop more effective treatment strategies.</a:t>
             </a:r>
             <a:endParaRPr lang="en-US" sz="1200" dirty="0"/>
           </a:p>
@@ -4011,13 +4205,22 @@
               </a:lnSpc>
               <a:buNone/>
             </a:pPr>
+            <a:endParaRPr lang="en-US" sz="1200" dirty="0"/>
+          </a:p>
+          <a:p>
+            <a:pPr indent="0" marL="0">
+              <a:lnSpc>
+                <a:spcPct val="150000"/>
+              </a:lnSpc>
+              <a:buNone/>
+            </a:pPr>
             <a:r>
               <a:rPr lang="en-US" sz="1200" dirty="0">
                 <a:solidFill>
                   <a:srgbClr val="FFFFFF"/>
                 </a:solidFill>
               </a:rPr>
-              <a:t>   未來的研究應集中於闡明腸道微生物如何影響結直腸癌的腫瘤發生和免疫反應的具體機制。</a:t>
+              <a:t>2. **植物化合物的臨床應用研究**  </a:t>
             </a:r>
             <a:endParaRPr lang="en-US" sz="1200" dirty="0"/>
           </a:p>
@@ -4028,6 +4231,14 @@
               </a:lnSpc>
               <a:buNone/>
             </a:pPr>
+            <a:r>
+              <a:rPr lang="en-US" sz="1200" dirty="0">
+                <a:solidFill>
+                  <a:srgbClr val="FFFFFF"/>
+                </a:solidFill>
+              </a:rPr>
+              <a:t>   **Clinical Application Studies of Phytochemicals**  </a:t>
+            </a:r>
             <a:endParaRPr lang="en-US" sz="1200" dirty="0"/>
           </a:p>
           <a:p>
@@ -4043,7 +4254,7 @@
                   <a:srgbClr val="FFFFFF"/>
                 </a:solidFill>
               </a:rPr>
-              <a:t>2. **個體化免疫療法的發展**  </a:t>
+              <a:t>   針對具有抗炎及抗腫瘤特性的植物化合物，應進行臨床試驗，以評估其在大腸癌預防和治療中的潛力。  </a:t>
             </a:r>
             <a:endParaRPr lang="en-US" sz="1200" dirty="0"/>
           </a:p>
@@ -4060,7 +4271,7 @@
                   <a:srgbClr val="FFFFFF"/>
                 </a:solidFill>
               </a:rPr>
-              <a:t>   Research should explore the potential of personalized immunotherapy approaches based on individual genetic and microbiome profiles to improve treatment efficacy.  </a:t>
+              <a:t>   Clinical trials should be conducted on phytochemicals with anti-inflammatory and anti-tumor properties to assess their potential in the prevention and treatment of colorectal cancer.</a:t>
             </a:r>
             <a:endParaRPr lang="en-US" sz="1200" dirty="0"/>
           </a:p>
@@ -4071,13 +4282,22 @@
               </a:lnSpc>
               <a:buNone/>
             </a:pPr>
+            <a:endParaRPr lang="en-US" sz="1200" dirty="0"/>
+          </a:p>
+          <a:p>
+            <a:pPr indent="0" marL="0">
+              <a:lnSpc>
+                <a:spcPct val="150000"/>
+              </a:lnSpc>
+              <a:buNone/>
+            </a:pPr>
             <a:r>
               <a:rPr lang="en-US" sz="1200" dirty="0">
                 <a:solidFill>
                   <a:srgbClr val="FFFFFF"/>
                 </a:solidFill>
               </a:rPr>
-              <a:t>   研究應探討基於個體基因和微生物組特徵的個性化免疫療法的潛力，以提高治療效果。</a:t>
+              <a:t>3. **炎症標記的整合應用**  </a:t>
             </a:r>
             <a:endParaRPr lang="en-US" sz="1200" dirty="0"/>
           </a:p>
@@ -4088,6 +4308,14 @@
               </a:lnSpc>
               <a:buNone/>
             </a:pPr>
+            <a:r>
+              <a:rPr lang="en-US" sz="1200" dirty="0">
+                <a:solidFill>
+                  <a:srgbClr val="FFFFFF"/>
+                </a:solidFill>
+              </a:rPr>
+              <a:t>   **Integrated Application of Inflammatory Markers**  </a:t>
+            </a:r>
             <a:endParaRPr lang="en-US" sz="1200" dirty="0"/>
           </a:p>
           <a:p>
@@ -4103,7 +4331,7 @@
                   <a:srgbClr val="FFFFFF"/>
                 </a:solidFill>
               </a:rPr>
-              <a:t>3. **新型生物標誌物的探索**  </a:t>
+              <a:t>   研究應探索如何整合多種炎症標記，以提高大腸癌的預後預測準確性，並指導個體化治療。  </a:t>
             </a:r>
             <a:endParaRPr lang="en-US" sz="1200" dirty="0"/>
           </a:p>
@@ -4120,7 +4348,7 @@
                   <a:srgbClr val="FFFFFF"/>
                 </a:solidFill>
               </a:rPr>
-              <a:t>   There is a need for the identification and validation of new biomarkers that can predict responses to immunotherapy and targeted therapies in colorectal cancer.  </a:t>
+              <a:t>   Research should explore how to integrate multiple inflammatory markers to enhance the accuracy of prognostic predictions in colorectal cancer and guide personalized treatment.</a:t>
             </a:r>
             <a:endParaRPr lang="en-US" sz="1200" dirty="0"/>
           </a:p>
@@ -4131,13 +4359,22 @@
               </a:lnSpc>
               <a:buNone/>
             </a:pPr>
+            <a:endParaRPr lang="en-US" sz="1200" dirty="0"/>
+          </a:p>
+          <a:p>
+            <a:pPr indent="0" marL="0">
+              <a:lnSpc>
+                <a:spcPct val="150000"/>
+              </a:lnSpc>
+              <a:buNone/>
+            </a:pPr>
             <a:r>
               <a:rPr lang="en-US" sz="1200" dirty="0">
                 <a:solidFill>
                   <a:srgbClr val="FFFFFF"/>
                 </a:solidFill>
               </a:rPr>
-              <a:t>   需要識別和驗證新的生物標誌物，以預測結直腸癌對免疫療法和靶向療法的反應。</a:t>
+              <a:t>4. **患者教育與風險管理策略**  </a:t>
             </a:r>
             <a:endParaRPr lang="en-US" sz="1200" dirty="0"/>
           </a:p>
@@ -4148,6 +4385,14 @@
               </a:lnSpc>
               <a:buNone/>
             </a:pPr>
+            <a:r>
+              <a:rPr lang="en-US" sz="1200" dirty="0">
+                <a:solidFill>
+                  <a:srgbClr val="FFFFFF"/>
+                </a:solidFill>
+              </a:rPr>
+              <a:t>   **Patient Education and Risk Management Strategies**  </a:t>
+            </a:r>
             <a:endParaRPr lang="en-US" sz="1200" dirty="0"/>
           </a:p>
           <a:p>
@@ -4163,7 +4408,7 @@
                   <a:srgbClr val="FFFFFF"/>
                 </a:solidFill>
               </a:rPr>
-              <a:t>4. **環境與遺傳交互作用的研究**  </a:t>
+              <a:t>   需要開發針對炎症性腸病患者的教育計劃，以提高他們對大腸癌風險的認知，並改善其管理策略。  </a:t>
             </a:r>
             <a:endParaRPr lang="en-US" sz="1200" dirty="0"/>
           </a:p>
@@ -4180,7 +4425,7 @@
                   <a:srgbClr val="FFFFFF"/>
                 </a:solidFill>
               </a:rPr>
-              <a:t>   Investigating the interplay between environmental factors and genetic predispositions in colorectal cancer can provide insights into prevention and treatment strategies.  </a:t>
+              <a:t>   There is a need to develop educational programs for inflammatory bowel disease patients to enhance their awareness of colorectal cancer risk and improve management strategies.</a:t>
             </a:r>
             <a:endParaRPr lang="en-US" sz="1200" dirty="0"/>
           </a:p>
@@ -4191,13 +4436,22 @@
               </a:lnSpc>
               <a:buNone/>
             </a:pPr>
+            <a:endParaRPr lang="en-US" sz="1200" dirty="0"/>
+          </a:p>
+          <a:p>
+            <a:pPr indent="0" marL="0">
+              <a:lnSpc>
+                <a:spcPct val="150000"/>
+              </a:lnSpc>
+              <a:buNone/>
+            </a:pPr>
             <a:r>
               <a:rPr lang="en-US" sz="1200" dirty="0">
                 <a:solidFill>
                   <a:srgbClr val="FFFFFF"/>
                 </a:solidFill>
               </a:rPr>
-              <a:t>   研究環境因素與遺傳易感性在結直腸癌中的相互作用，可以為預防和治療策略提供見解。</a:t>
+              <a:t>5. **超熱腹腔化療的長期效果研究**  </a:t>
             </a:r>
             <a:endParaRPr lang="en-US" sz="1200" dirty="0"/>
           </a:p>
@@ -4208,6 +4462,14 @@
               </a:lnSpc>
               <a:buNone/>
             </a:pPr>
+            <a:r>
+              <a:rPr lang="en-US" sz="1200" dirty="0">
+                <a:solidFill>
+                  <a:srgbClr val="FFFFFF"/>
+                </a:solidFill>
+              </a:rPr>
+              <a:t>   **Long-term Effect Studies of Hyperthermic Intraperitoneal Chemotherapy**  </a:t>
+            </a:r>
             <a:endParaRPr lang="en-US" sz="1200" dirty="0"/>
           </a:p>
           <a:p>
@@ -4223,7 +4485,7 @@
                   <a:srgbClr val="FFFFFF"/>
                 </a:solidFill>
               </a:rPr>
-              <a:t>5. **新療法的臨床試驗**  </a:t>
+              <a:t>   應進行長期隨訪研究，以評估超熱腹腔化療在不同階段大腸癌患者中的持久效果和安全性。  </a:t>
             </a:r>
             <a:endParaRPr lang="en-US" sz="1200" dirty="0"/>
           </a:p>
@@ -4240,24 +4502,7 @@
                   <a:srgbClr val="FFFFFF"/>
                 </a:solidFill>
               </a:rPr>
-              <a:t>   Clinical trials should be initiated to test the efficacy of novel therapeutic agents and combinations, particularly those targeting the tumor microenvironment and immune modulation.  </a:t>
-            </a:r>
-            <a:endParaRPr lang="en-US" sz="1200" dirty="0"/>
-          </a:p>
-          <a:p>
-            <a:pPr indent="0" marL="0">
-              <a:lnSpc>
-                <a:spcPct val="150000"/>
-              </a:lnSpc>
-              <a:buNone/>
-            </a:pPr>
-            <a:r>
-              <a:rPr lang="en-US" sz="1200" dirty="0">
-                <a:solidFill>
-                  <a:srgbClr val="FFFFFF"/>
-                </a:solidFill>
-              </a:rPr>
-              <a:t>   應啟動臨床試驗，以測試新型治療劑和組合的療效，特別是針對腫瘤微環境和免疫調控的療法。</a:t>
+              <a:t>   Long-term follow-up studies should be conducted to assess the enduring effects and safety of hyperthermic intraperitoneal chemotherapy in patients with colorectal cancer at various stages.</a:t>
             </a:r>
             <a:endParaRPr lang="en-US" sz="1200" dirty="0"/>
           </a:p>
@@ -4528,7 +4773,7 @@
                 <a:ea typeface="Arial" pitchFamily="34" charset="-122"/>
                 <a:cs typeface="Arial" pitchFamily="34" charset="-120"/>
               </a:rPr>
-              <a:t>Oncogenic PIK3CA mutation enhances tumor immunogenicity through the IRF1-NLRC5-M…</a:t>
+              <a:t>Concurrent genetic and non-genetic resistance mechanisms to KRAS inhibition in c…</a:t>
             </a:r>
             <a:endParaRPr lang="en-US" sz="1400" dirty="0"/>
           </a:p>
@@ -4565,7 +4810,7 @@
                 <a:ea typeface="Arial" pitchFamily="34" charset="-122"/>
                 <a:cs typeface="Arial" pitchFamily="34" charset="-120"/>
               </a:rPr>
-              <a:t>Parasutterella excrementihominis exacerbates experimental colitis and colitis-as…</a:t>
+              <a:t>Diarylheptanoid Phytoestrogen from Curcuma comosa Attenuates Colitis and Colitis…</a:t>
             </a:r>
             <a:endParaRPr lang="en-US" sz="1400" dirty="0"/>
           </a:p>
@@ -4602,7 +4847,7 @@
                 <a:ea typeface="Arial" pitchFamily="34" charset="-122"/>
                 <a:cs typeface="Arial" pitchFamily="34" charset="-120"/>
               </a:rPr>
-              <a:t>rs2032582 polymorphism of ATP binding cassette subfamily B member 1 affect the s…</a:t>
+              <a:t>Effect of hyperthermic intraperitoneal chemotherapy on patients with advanced co…</a:t>
             </a:r>
             <a:endParaRPr lang="en-US" sz="1400" dirty="0"/>
           </a:p>
@@ -4639,7 +4884,7 @@
                 <a:ea typeface="Arial" pitchFamily="34" charset="-122"/>
                 <a:cs typeface="Arial" pitchFamily="34" charset="-120"/>
               </a:rPr>
-              <a:t>Combining genotoxic gut bacterial strains increases tumor burden and accelerates…</a:t>
+              <a:t>Prognostic value of systemic immune-inflammation index for colorectal cancer: a …</a:t>
             </a:r>
             <a:endParaRPr lang="en-US" sz="1400" dirty="0"/>
           </a:p>
@@ -4676,7 +4921,7 @@
                 <a:ea typeface="Arial" pitchFamily="34" charset="-122"/>
                 <a:cs typeface="Arial" pitchFamily="34" charset="-120"/>
               </a:rPr>
-              <a:t>Suppression of the myofibroblastic cancer-associated fibroblast phenotype to enh…</a:t>
+              <a:t>Prognostic value of pretreatment C-reactive–protein–albumin–lymphocyte index in …</a:t>
             </a:r>
             <a:endParaRPr lang="en-US" sz="1400" dirty="0"/>
           </a:p>
@@ -4713,7 +4958,7 @@
                 <a:ea typeface="Arial" pitchFamily="34" charset="-122"/>
                 <a:cs typeface="Arial" pitchFamily="34" charset="-120"/>
               </a:rPr>
-              <a:t>Ethyl caffeate reprograms tumor-associated macrophages to enhance CD8+ T-cell im…</a:t>
+              <a:t>Awareness of inflammatory bowel disease-associated colorectal cancer risk and it…</a:t>
             </a:r>
             <a:endParaRPr lang="en-US" sz="1400" dirty="0"/>
           </a:p>
@@ -4750,7 +4995,7 @@
                 <a:ea typeface="Arial" pitchFamily="34" charset="-122"/>
                 <a:cs typeface="Arial" pitchFamily="34" charset="-120"/>
               </a:rPr>
-              <a:t>… Cancer and Mesothelial Stromal Cell Lines from Malignant Ascites Reveals a Mes…</a:t>
+              <a:t>Alzheimer's disease-related mutations in APP influence colorectal tumor formatio…</a:t>
             </a:r>
             <a:endParaRPr lang="en-US" sz="1400" dirty="0"/>
           </a:p>
@@ -4787,7 +5032,7 @@
                 <a:ea typeface="Arial" pitchFamily="34" charset="-122"/>
                 <a:cs typeface="Arial" pitchFamily="34" charset="-120"/>
               </a:rPr>
-              <a:t>KLK7 overexpression promotes an aggressive phenotype and facilitates peritoneal …</a:t>
+              <a:t>Sanghuangporus vaninii extract exerts dual anti-tumor effects in colitis-associa…</a:t>
             </a:r>
             <a:endParaRPr lang="en-US" sz="1400" dirty="0"/>
           </a:p>
@@ -4824,7 +5069,7 @@
                 <a:ea typeface="Arial" pitchFamily="34" charset="-122"/>
                 <a:cs typeface="Arial" pitchFamily="34" charset="-120"/>
               </a:rPr>
-              <a:t>Integrative network pharmacology and machine learning identify potential targets…</a:t>
+              <a:t>Anti-Malignancy and Anti-Inflammation Properties of Emodin, an Essential Constit…</a:t>
             </a:r>
             <a:endParaRPr lang="en-US" sz="1400" dirty="0"/>
           </a:p>
@@ -5100,7 +5345,7 @@
                 <a:ea typeface="Arial" pitchFamily="34" charset="-122"/>
                 <a:cs typeface="Arial" pitchFamily="34" charset="-120"/>
               </a:rPr>
-              <a:t>Results show limited survival benefit</a:t>
+              <a:t>Results show limited survival benefits</a:t>
             </a:r>
             <a:endParaRPr lang="en-US" sz="1800" dirty="0"/>
           </a:p>
@@ -5121,7 +5366,7 @@
                 <a:ea typeface="Arial" pitchFamily="34" charset="-122"/>
                 <a:cs typeface="Arial" pitchFamily="34" charset="-120"/>
               </a:rPr>
-              <a:t>Concerns over surgical complications</a:t>
+              <a:t>Surgery may not improve outcomes</a:t>
             </a:r>
             <a:endParaRPr lang="en-US" sz="1800" dirty="0"/>
           </a:p>
@@ -5378,7 +5623,7 @@
                   </a:extLst>
                 </a:hlinkClick>
               </a:rPr>
-              <a:t>Oncogenic PIK3CA mutation enhances tumor immunogenicity through the IRF1-NLRC5-MHC-I axis in urothelial carcinoma.</a:t>
+              <a:t>Concurrent genetic and non-genetic resistance mechanisms to KRAS inhibition in colorectal cancer.</a:t>
             </a:r>
             <a:endParaRPr lang="en-US" sz="2400" dirty="0"/>
           </a:p>
@@ -5414,7 +5659,7 @@
                   <a:srgbClr val="888888"/>
                 </a:solidFill>
               </a:rPr>
-              <a:t>Journal for immunotherapy of cancer  ·  IF 10.9  ·  Retrospective Study  ·  🌏 Asia</a:t>
+              <a:t>Cancer cell  ·  IF 48.8</a:t>
             </a:r>
             <a:endParaRPr lang="en-US" sz="1000" dirty="0"/>
           </a:p>
@@ -5457,7 +5702,7 @@
                 <a:ea typeface="Arial" pitchFamily="34" charset="-122"/>
                 <a:cs typeface="Arial" pitchFamily="34" charset="-120"/>
               </a:rPr>
-              <a:t>PIK3CA mutation enhances tumor immunogenicity.</a:t>
+              <a:t>KRAS mutations in 45%-50% of CRC</a:t>
             </a:r>
             <a:endParaRPr lang="en-US" sz="1800" dirty="0"/>
           </a:p>
@@ -5478,7 +5723,7 @@
                 <a:ea typeface="Arial" pitchFamily="34" charset="-122"/>
                 <a:cs typeface="Arial" pitchFamily="34" charset="-120"/>
               </a:rPr>
-              <a:t>Higher TMB correlates with ICI response.</a:t>
+              <a:t>Resistance mechanisms include genetic events</a:t>
             </a:r>
             <a:endParaRPr lang="en-US" sz="1800" dirty="0"/>
           </a:p>
@@ -5499,7 +5744,7 @@
                 <a:ea typeface="Arial" pitchFamily="34" charset="-122"/>
                 <a:cs typeface="Arial" pitchFamily="34" charset="-120"/>
               </a:rPr>
-              <a:t>IRF1-NLRC5-MHC-I axis is activated.</a:t>
+              <a:t>Mesenchymal and YAP signatures in resistant tumors</a:t>
             </a:r>
             <a:endParaRPr lang="en-US" sz="1800" dirty="0"/>
           </a:p>
@@ -5520,7 +5765,7 @@
                 <a:ea typeface="Arial" pitchFamily="34" charset="-122"/>
                 <a:cs typeface="Arial" pitchFamily="34" charset="-120"/>
               </a:rPr>
-              <a:t>Functional studies confirm immune response.</a:t>
+              <a:t>Inflammatory programs induced early in treatment</a:t>
             </a:r>
             <a:endParaRPr lang="en-US" sz="1800" dirty="0"/>
           </a:p>
@@ -5541,7 +5786,7 @@
                 <a:ea typeface="Arial" pitchFamily="34" charset="-122"/>
                 <a:cs typeface="Arial" pitchFamily="34" charset="-120"/>
               </a:rPr>
-              <a:t>In vivo models validate therapeutic implications.</a:t>
+              <a:t>TBK1 identified as a potential therapeutic target</a:t>
             </a:r>
             <a:endParaRPr lang="en-US" sz="1800" dirty="0"/>
           </a:p>
@@ -5577,7 +5822,7 @@
                   <a:srgbClr val="888888"/>
                 </a:solidFill>
               </a:rPr>
-              <a:t>Su Yu-Li, Huang Shih-Yu, Kuo Chung-Wen et al.. Journal for immunotherapy of cancer. 2026-07-08 DOI: 10.1136/jitc-2026-014770</a:t>
+              <a:t>Alonso Salvador, Chu Kevan, Granowsky Elizabeth et al.. Cancer cell. 2026-07-14 DOI: 10.1016/j.ccell.2026.04.009</a:t>
             </a:r>
             <a:endParaRPr lang="en-US" sz="800" dirty="0"/>
           </a:p>
@@ -5777,7 +6022,7 @@
                   </a:extLst>
                 </a:hlinkClick>
               </a:rPr>
-              <a:t>Parasutterella excrementihominis exacerbates experimental colitis and colitis-associated colorectal cancer via pathogenic NETosis activation</a:t>
+              <a:t>Diarylheptanoid Phytoestrogen from Curcuma comosa Attenuates Colitis and Colitis-Associated Colorectal Cancer by Inhibiting Inflammation and Oxidative Stress and Modulating Gut Microbiota.</a:t>
             </a:r>
             <a:endParaRPr lang="en-US" sz="2400" dirty="0"/>
           </a:p>
@@ -5813,7 +6058,7 @@
                   <a:srgbClr val="888888"/>
                 </a:solidFill>
               </a:rPr>
-              <a:t>Gut  ·  IF 24.5</a:t>
+              <a:t>Journal of agricultural and food chemistry  ·  RCT Phase 2  ·  🌏 Asia</a:t>
             </a:r>
             <a:endParaRPr lang="en-US" sz="1000" dirty="0"/>
           </a:p>
@@ -5856,7 +6101,7 @@
                 <a:ea typeface="Arial" pitchFamily="34" charset="-122"/>
                 <a:cs typeface="Arial" pitchFamily="34" charset="-120"/>
               </a:rPr>
-              <a:t>P. excrementihominis worsens colitis severity.</a:t>
+              <a:t>Diarylheptanoids from Curcuma comosa studied</a:t>
             </a:r>
             <a:endParaRPr lang="en-US" sz="1800" dirty="0"/>
           </a:p>
@@ -5877,7 +6122,7 @@
                 <a:ea typeface="Arial" pitchFamily="34" charset="-122"/>
                 <a:cs typeface="Arial" pitchFamily="34" charset="-120"/>
               </a:rPr>
-              <a:t>NETosis activation linked to inflammation.</a:t>
+              <a:t>DPH alleviates colitis and tumorigenesis</a:t>
             </a:r>
             <a:endParaRPr lang="en-US" sz="1800" dirty="0"/>
           </a:p>
@@ -5898,7 +6143,49 @@
                 <a:ea typeface="Arial" pitchFamily="34" charset="-122"/>
                 <a:cs typeface="Arial" pitchFamily="34" charset="-120"/>
               </a:rPr>
-              <a:t>Study suggests new therapeutic strategies.</a:t>
+              <a:t>Inhibition of proinflammatory cytokines observed</a:t>
+            </a:r>
+            <a:endParaRPr lang="en-US" sz="1800" dirty="0"/>
+          </a:p>
+          <a:p>
+            <a:pPr marL="342900" indent="-342900">
+              <a:spcAft>
+                <a:spcPts val="800"/>
+              </a:spcAft>
+              <a:buSzPct val="100000"/>
+              <a:buChar char="•"/>
+            </a:pPr>
+            <a:r>
+              <a:rPr lang="en-US" sz="1800" dirty="0">
+                <a:solidFill>
+                  <a:srgbClr val="333333"/>
+                </a:solidFill>
+                <a:latin typeface="Arial" pitchFamily="34" charset="0"/>
+                <a:ea typeface="Arial" pitchFamily="34" charset="-122"/>
+                <a:cs typeface="Arial" pitchFamily="34" charset="-120"/>
+              </a:rPr>
+              <a:t>Toll-like receptor pathway identified as target</a:t>
+            </a:r>
+            <a:endParaRPr lang="en-US" sz="1800" dirty="0"/>
+          </a:p>
+          <a:p>
+            <a:pPr marL="342900" indent="-342900">
+              <a:spcAft>
+                <a:spcPts val="800"/>
+              </a:spcAft>
+              <a:buSzPct val="100000"/>
+              <a:buChar char="•"/>
+            </a:pPr>
+            <a:r>
+              <a:rPr lang="en-US" sz="1800" dirty="0">
+                <a:solidFill>
+                  <a:srgbClr val="333333"/>
+                </a:solidFill>
+                <a:latin typeface="Arial" pitchFamily="34" charset="0"/>
+                <a:ea typeface="Arial" pitchFamily="34" charset="-122"/>
+                <a:cs typeface="Arial" pitchFamily="34" charset="-120"/>
+              </a:rPr>
+              <a:t>Gut microbiota composition partially improved</a:t>
             </a:r>
             <a:endParaRPr lang="en-US" sz="1800" dirty="0"/>
           </a:p>
@@ -5934,7 +6221,7 @@
                   <a:srgbClr val="888888"/>
                 </a:solidFill>
               </a:rPr>
-              <a:t>H Tan, L Huang, J Wang. Gut. 2026</a:t>
+              <a:t>Truong Van-Long, Rarison Razanamanana H G, Song Eun-Ji et al.. Journal of agricultural and food chemistry. 2026-07-15 DOI: 10.1021/acs.jafc.5c17732</a:t>
             </a:r>
             <a:endParaRPr lang="en-US" sz="800" dirty="0"/>
           </a:p>
@@ -6134,7 +6421,7 @@
                   </a:extLst>
                 </a:hlinkClick>
               </a:rPr>
-              <a:t>rs2032582 polymorphism of ATP binding cassette subfamily B member 1 affect the susceptibility of inflammatory bowel disease: a systematical meta-analysis based …</a:t>
+              <a:t>Effect of hyperthermic intraperitoneal chemotherapy on patients with advanced colorectal cancer: a systematic review and meta-analysis</a:t>
             </a:r>
             <a:endParaRPr lang="en-US" sz="2400" dirty="0"/>
           </a:p>
@@ -6170,7 +6457,7 @@
                   <a:srgbClr val="888888"/>
                 </a:solidFill>
               </a:rPr>
-              <a:t>International Journal of Colorectal Disease  ·  Meta-Analysis</a:t>
+              <a:t>World Journal of …  ·  Meta-Analysis</a:t>
             </a:r>
             <a:endParaRPr lang="en-US" sz="1000" dirty="0"/>
           </a:p>
@@ -6213,7 +6500,7 @@
                 <a:ea typeface="Arial" pitchFamily="34" charset="-122"/>
                 <a:cs typeface="Arial" pitchFamily="34" charset="-120"/>
               </a:rPr>
-              <a:t>rs2032582 polymorphism linked to IBD risk</a:t>
+              <a:t>Hyperthermic intraperitoneal chemotherapy (HIPEC) evaluated</a:t>
             </a:r>
             <a:endParaRPr lang="en-US" sz="1800" dirty="0"/>
           </a:p>
@@ -6234,7 +6521,7 @@
                 <a:ea typeface="Arial" pitchFamily="34" charset="-122"/>
                 <a:cs typeface="Arial" pitchFamily="34" charset="-120"/>
               </a:rPr>
-              <a:t>Meta-analysis includes multiple studies</a:t>
+              <a:t>Advanced colorectal cancer patients included</a:t>
             </a:r>
             <a:endParaRPr lang="en-US" sz="1800" dirty="0"/>
           </a:p>
@@ -6255,7 +6542,7 @@
                 <a:ea typeface="Arial" pitchFamily="34" charset="-122"/>
                 <a:cs typeface="Arial" pitchFamily="34" charset="-120"/>
               </a:rPr>
-              <a:t>Significant association with Crohn's disease</a:t>
+              <a:t>Systematic review and meta-analysis conducted</a:t>
             </a:r>
             <a:endParaRPr lang="en-US" sz="1800" dirty="0"/>
           </a:p>
@@ -6291,7 +6578,7 @@
                   <a:srgbClr val="888888"/>
                 </a:solidFill>
               </a:rPr>
-              <a:t>H Chen, H Zhang, G Tao. International Journal of Colorectal Disease. 2026</a:t>
+              <a:t>Z Su, Y Guo, X Ru. World Journal of …. 2026</a:t>
             </a:r>
             <a:endParaRPr lang="en-US" sz="800" dirty="0"/>
           </a:p>
@@ -6491,7 +6778,7 @@
                   </a:extLst>
                 </a:hlinkClick>
               </a:rPr>
-              <a:t>Combining genotoxic gut bacterial strains increases tumor burden and accelerates onset in a germ-free mouse model of colon carcinogenesis.</a:t>
+              <a:t>Prognostic value of systemic immune-inflammation index for colorectal cancer: a systematic review and meta-analysis</a:t>
             </a:r>
             <a:endParaRPr lang="en-US" sz="2400" dirty="0"/>
           </a:p>
@@ -6527,7 +6814,7 @@
                   <a:srgbClr val="888888"/>
                 </a:solidFill>
               </a:rPr>
-              <a:t>Cell reports  ·  IF 8.8  ·  Basic Research</a:t>
+              <a:t>Frontiers in Oncology  ·  Meta-Analysis</a:t>
             </a:r>
             <a:endParaRPr lang="en-US" sz="1000" dirty="0"/>
           </a:p>
@@ -6570,7 +6857,7 @@
                 <a:ea typeface="Arial" pitchFamily="34" charset="-122"/>
                 <a:cs typeface="Arial" pitchFamily="34" charset="-120"/>
               </a:rPr>
-              <a:t>Germ-free mice used for study.</a:t>
+              <a:t>Systemic immune-inflammation index (SII) evaluated</a:t>
             </a:r>
             <a:endParaRPr lang="en-US" sz="1800" dirty="0"/>
           </a:p>
@@ -6591,7 +6878,7 @@
                 <a:ea typeface="Arial" pitchFamily="34" charset="-122"/>
                 <a:cs typeface="Arial" pitchFamily="34" charset="-120"/>
               </a:rPr>
-              <a:t>19 human fecal microbiotas tested.</a:t>
+              <a:t>Prognostic biomarker for colorectal cancer</a:t>
             </a:r>
             <a:endParaRPr lang="en-US" sz="1800" dirty="0"/>
           </a:p>
@@ -6612,7 +6899,7 @@
                 <a:ea typeface="Arial" pitchFamily="34" charset="-122"/>
                 <a:cs typeface="Arial" pitchFamily="34" charset="-120"/>
               </a:rPr>
-              <a:t>Genotoxicity predicts tumorigenic microbes.</a:t>
+              <a:t>Meta-analysis of existing studies</a:t>
             </a:r>
             <a:endParaRPr lang="en-US" sz="1800" dirty="0"/>
           </a:p>
@@ -6633,7 +6920,7 @@
                 <a:ea typeface="Arial" pitchFamily="34" charset="-122"/>
                 <a:cs typeface="Arial" pitchFamily="34" charset="-120"/>
               </a:rPr>
-              <a:t>Combining strains increases tumor burden.</a:t>
+              <a:t>SII associated with patient outcomes</a:t>
             </a:r>
             <a:endParaRPr lang="en-US" sz="1800" dirty="0"/>
           </a:p>
@@ -6654,7 +6941,7 @@
                 <a:ea typeface="Arial" pitchFamily="34" charset="-122"/>
                 <a:cs typeface="Arial" pitchFamily="34" charset="-120"/>
               </a:rPr>
-              <a:t>Balance of strains affects tumor onset.</a:t>
+              <a:t>Potential for clinical application</a:t>
             </a:r>
             <a:endParaRPr lang="en-US" sz="1800" dirty="0"/>
           </a:p>
@@ -6690,7 +6977,7 @@
                   <a:srgbClr val="888888"/>
                 </a:solidFill>
               </a:rPr>
-              <a:t>Plitt Tamar, Piessevaux Alix, Rajpal Urvija et al.. Cell reports. 2026-07-07 DOI: 10.1016/j.celrep.2026.117645</a:t>
+              <a:t>P Wang, H Jiang. Frontiers in Oncology. 2026</a:t>
             </a:r>
             <a:endParaRPr lang="en-US" sz="800" dirty="0"/>
           </a:p>
@@ -6890,7 +7177,7 @@
                   </a:extLst>
                 </a:hlinkClick>
               </a:rPr>
-              <a:t>Suppression of the myofibroblastic cancer-associated fibroblast phenotype to enhance anti-PD-1 response.</a:t>
+              <a:t>Prognostic value of pretreatment C-reactive–protein–albumin–lymphocyte index in colorectal cancer: systematic review and meta-analysis</a:t>
             </a:r>
             <a:endParaRPr lang="en-US" sz="2400" dirty="0"/>
           </a:p>
@@ -6926,7 +7213,7 @@
                   <a:srgbClr val="888888"/>
                 </a:solidFill>
               </a:rPr>
-              <a:t>Journal of experimental &amp; clinical cancer research : CR  ·  Basic Research</a:t>
+              <a:t>Journal of …  ·  Meta-Analysis</a:t>
             </a:r>
             <a:endParaRPr lang="en-US" sz="1000" dirty="0"/>
           </a:p>
@@ -6969,7 +7256,7 @@
                 <a:ea typeface="Arial" pitchFamily="34" charset="-122"/>
                 <a:cs typeface="Arial" pitchFamily="34" charset="-120"/>
               </a:rPr>
-              <a:t>CAFs modulate tumor growth and immune response.</a:t>
+              <a:t>C-reactive protein and albumin levels</a:t>
             </a:r>
             <a:endParaRPr lang="en-US" sz="1800" dirty="0"/>
           </a:p>
@@ -6990,7 +7277,7 @@
                 <a:ea typeface="Arial" pitchFamily="34" charset="-122"/>
                 <a:cs typeface="Arial" pitchFamily="34" charset="-120"/>
               </a:rPr>
-              <a:t>myCAFs inhibit CD8+ T cell infiltration.</a:t>
+              <a:t>Lymphocyte index as prognostic factor</a:t>
             </a:r>
             <a:endParaRPr lang="en-US" sz="1800" dirty="0"/>
           </a:p>
@@ -7011,49 +7298,7 @@
                 <a:ea typeface="Arial" pitchFamily="34" charset="-122"/>
                 <a:cs typeface="Arial" pitchFamily="34" charset="-120"/>
               </a:rPr>
-              <a:t>Nilotinib reduces myCAF markers and tumor size.</a:t>
-            </a:r>
-            <a:endParaRPr lang="en-US" sz="1800" dirty="0"/>
-          </a:p>
-          <a:p>
-            <a:pPr marL="342900" indent="-342900">
-              <a:spcAft>
-                <a:spcPts val="800"/>
-              </a:spcAft>
-              <a:buSzPct val="100000"/>
-              <a:buChar char="•"/>
-            </a:pPr>
-            <a:r>
-              <a:rPr lang="en-US" sz="1800" dirty="0">
-                <a:solidFill>
-                  <a:srgbClr val="333333"/>
-                </a:solidFill>
-                <a:latin typeface="Arial" pitchFamily="34" charset="0"/>
-                <a:ea typeface="Arial" pitchFamily="34" charset="-122"/>
-                <a:cs typeface="Arial" pitchFamily="34" charset="-120"/>
-              </a:rPr>
-              <a:t>Combination therapy enhances anti-PD-1 response.</a:t>
-            </a:r>
-            <a:endParaRPr lang="en-US" sz="1800" dirty="0"/>
-          </a:p>
-          <a:p>
-            <a:pPr marL="342900" indent="-342900">
-              <a:spcAft>
-                <a:spcPts val="800"/>
-              </a:spcAft>
-              <a:buSzPct val="100000"/>
-              <a:buChar char="•"/>
-            </a:pPr>
-            <a:r>
-              <a:rPr lang="en-US" sz="1800" dirty="0">
-                <a:solidFill>
-                  <a:srgbClr val="333333"/>
-                </a:solidFill>
-                <a:latin typeface="Arial" pitchFamily="34" charset="0"/>
-                <a:ea typeface="Arial" pitchFamily="34" charset="-122"/>
-                <a:cs typeface="Arial" pitchFamily="34" charset="-120"/>
-              </a:rPr>
-              <a:t>Identified disease-specific markers for CRC CAFs.</a:t>
+              <a:t>Systematic review and meta-analysis conducted</a:t>
             </a:r>
             <a:endParaRPr lang="en-US" sz="1800" dirty="0"/>
           </a:p>
@@ -7089,7 +7334,7 @@
                   <a:srgbClr val="888888"/>
                 </a:solidFill>
               </a:rPr>
-              <a:t>Johnson Katherine A, Lippert Anna E L, Cornelio Alec et al.. Journal of experimental &amp; clinical cancer research : CR. 2026-07-10 DOI: 10.1186/s13046-026-03779-3</a:t>
+              <a:t>M Shamohammadi, D Yarahmadi…. Journal of …. 2026</a:t>
             </a:r>
             <a:endParaRPr lang="en-US" sz="800" dirty="0"/>
           </a:p>
@@ -7289,7 +7534,7 @@
                   </a:extLst>
                 </a:hlinkClick>
               </a:rPr>
-              <a:t>Ethyl caffeate reprograms tumor-associated macrophages to enhance CD8+ T-cell immunity in colorectal cancer.</a:t>
+              <a:t>Awareness of inflammatory bowel disease-associated colorectal cancer risk and its management in patients with inflammatory bowel disease: a systematic review</a:t>
             </a:r>
             <a:endParaRPr lang="en-US" sz="2400" dirty="0"/>
           </a:p>
@@ -7325,7 +7570,7 @@
                   <a:srgbClr val="888888"/>
                 </a:solidFill>
               </a:rPr>
-              <a:t>BMC cancer  ·  Basic Research</a:t>
+              <a:t>Crohns &amp; Colitis 360  ·  Systematic Review</a:t>
             </a:r>
             <a:endParaRPr lang="en-US" sz="1000" dirty="0"/>
           </a:p>
@@ -7368,7 +7613,7 @@
                 <a:ea typeface="Arial" pitchFamily="34" charset="-122"/>
                 <a:cs typeface="Arial" pitchFamily="34" charset="-120"/>
               </a:rPr>
-              <a:t>Ethyl caffeate enhances CD8+ T-cell immunity.</a:t>
+              <a:t>Limited awareness of colorectal cancer risk</a:t>
             </a:r>
             <a:endParaRPr lang="en-US" sz="1800" dirty="0"/>
           </a:p>
@@ -7389,7 +7634,7 @@
                 <a:ea typeface="Arial" pitchFamily="34" charset="-122"/>
                 <a:cs typeface="Arial" pitchFamily="34" charset="-120"/>
               </a:rPr>
-              <a:t>Macrophage polarization towards M1-like phenotype.</a:t>
+              <a:t>Need for better patient education strategies</a:t>
             </a:r>
             <a:endParaRPr lang="en-US" sz="1800" dirty="0"/>
           </a:p>
@@ -7410,7 +7655,7 @@
                 <a:ea typeface="Arial" pitchFamily="34" charset="-122"/>
                 <a:cs typeface="Arial" pitchFamily="34" charset="-120"/>
               </a:rPr>
-              <a:t>Significant tumor growth suppression in CRC model.</a:t>
+              <a:t>Importance of regular screening in IBD patients</a:t>
             </a:r>
             <a:endParaRPr lang="en-US" sz="1800" dirty="0"/>
           </a:p>
@@ -7446,7 +7691,7 @@
                   <a:srgbClr val="888888"/>
                 </a:solidFill>
               </a:rPr>
-              <a:t>Bao Zhixian, Gao Jie, Cheng Xinhong et al.. BMC cancer. 2026-07-05 DOI: 10.1186/s12885-026-16469-2</a:t>
+              <a:t>F Khan, C Norton, W Czuber-Dochan. Crohns &amp; Colitis 360. 2026</a:t>
             </a:r>
             <a:endParaRPr lang="en-US" sz="800" dirty="0"/>
           </a:p>

</xml_diff>

<commit_message>
chore: update weekly digest 2026-07-27
</commit_message>
<xml_diff>
--- a/docs/digest-en.pptx
+++ b/docs/digest-en.pptx
@@ -2249,7 +2249,7 @@
                   <a:srgbClr val="888888"/>
                 </a:solidFill>
               </a:rPr>
-              <a:t>2026-07-13 — 2026-07-20</a:t>
+              <a:t>2026-07-20 — 2026-07-27</a:t>
             </a:r>
             <a:endParaRPr lang="en-US" sz="1400" dirty="0"/>
           </a:p>
@@ -2440,7 +2440,7 @@
                   </a:extLst>
                 </a:hlinkClick>
               </a:rPr>
-              <a:t>Alzheimer's disease-related mutations in APP influence colorectal tumor formation in a sex-dependent manner.</a:t>
+              <a:t>KLK7 overexpression promotes an aggressive phenotype and facilitates peritoneal dissemination in colorectal cancer cells</a:t>
             </a:r>
             <a:endParaRPr lang="en-US" sz="2400" dirty="0"/>
           </a:p>
@@ -2476,7 +2476,7 @@
                   <a:srgbClr val="888888"/>
                 </a:solidFill>
               </a:rPr>
-              <a:t>iScience  ·  Basic Research</a:t>
+              <a:t>FEBS Open …  ·  Basic Research</a:t>
             </a:r>
             <a:endParaRPr lang="en-US" sz="1000" dirty="0"/>
           </a:p>
@@ -2519,7 +2519,7 @@
                 <a:ea typeface="Arial" pitchFamily="34" charset="-122"/>
                 <a:cs typeface="Arial" pitchFamily="34" charset="-120"/>
               </a:rPr>
-              <a:t>APP mutations affect colorectal cancer development.</a:t>
+              <a:t>KLK7 overexpression linked to aggressive CRC</a:t>
             </a:r>
             <a:endParaRPr lang="en-US" sz="1800" dirty="0"/>
           </a:p>
@@ -2540,7 +2540,7 @@
                 <a:ea typeface="Arial" pitchFamily="34" charset="-122"/>
                 <a:cs typeface="Arial" pitchFamily="34" charset="-120"/>
               </a:rPr>
-              <a:t>Male mice show increased tumor formation.</a:t>
+              <a:t>Facilitates peritoneal dissemination in cancer cells</a:t>
             </a:r>
             <a:endParaRPr lang="en-US" sz="1800" dirty="0"/>
           </a:p>
@@ -2561,49 +2561,7 @@
                 <a:ea typeface="Arial" pitchFamily="34" charset="-122"/>
                 <a:cs typeface="Arial" pitchFamily="34" charset="-120"/>
               </a:rPr>
-              <a:t>Female mice exhibit reduced tumor growth.</a:t>
-            </a:r>
-            <a:endParaRPr lang="en-US" sz="1800" dirty="0"/>
-          </a:p>
-          <a:p>
-            <a:pPr marL="342900" indent="-342900">
-              <a:spcAft>
-                <a:spcPts val="800"/>
-              </a:spcAft>
-              <a:buSzPct val="100000"/>
-              <a:buChar char="•"/>
-            </a:pPr>
-            <a:r>
-              <a:rPr lang="en-US" sz="1800" dirty="0">
-                <a:solidFill>
-                  <a:srgbClr val="333333"/>
-                </a:solidFill>
-                <a:latin typeface="Arial" pitchFamily="34" charset="0"/>
-                <a:ea typeface="Arial" pitchFamily="34" charset="-122"/>
-                <a:cs typeface="Arial" pitchFamily="34" charset="-120"/>
-              </a:rPr>
-              <a:t>Inflammatory changes differ by sex.</a:t>
-            </a:r>
-            <a:endParaRPr lang="en-US" sz="1800" dirty="0"/>
-          </a:p>
-          <a:p>
-            <a:pPr marL="342900" indent="-342900">
-              <a:spcAft>
-                <a:spcPts val="800"/>
-              </a:spcAft>
-              <a:buSzPct val="100000"/>
-              <a:buChar char="•"/>
-            </a:pPr>
-            <a:r>
-              <a:rPr lang="en-US" sz="1800" dirty="0">
-                <a:solidFill>
-                  <a:srgbClr val="333333"/>
-                </a:solidFill>
-                <a:latin typeface="Arial" pitchFamily="34" charset="0"/>
-                <a:ea typeface="Arial" pitchFamily="34" charset="-122"/>
-                <a:cs typeface="Arial" pitchFamily="34" charset="-120"/>
-              </a:rPr>
-              <a:t>Transcriptome analysis reveals pathway enrichment.</a:t>
+              <a:t>In vitro studies confirm aggressive phenotype</a:t>
             </a:r>
             <a:endParaRPr lang="en-US" sz="1800" dirty="0"/>
           </a:p>
@@ -2639,7 +2597,7 @@
                   <a:srgbClr val="888888"/>
                 </a:solidFill>
               </a:rPr>
-              <a:t>Ishida-Takaku Takako, Sohrabi Mona, Pecoraro Heidi L et al.. iScience. 2026-07-12 DOI: 10.1016/j.isci.2026.116645</a:t>
+              <a:t>YZ Haffani, T Dreyer, M Naim. FEBS Open …. 2026</a:t>
             </a:r>
             <a:endParaRPr lang="en-US" sz="800" dirty="0"/>
           </a:p>
@@ -2839,7 +2797,7 @@
                   </a:extLst>
                 </a:hlinkClick>
               </a:rPr>
-              <a:t>Sanghuangporus vaninii extract exerts dual anti-tumor effects in colitis-associated colorectal cancer by direct cytotoxicity and macrophage reprogramming via the PPAR&amp;#x3b3;/NF-&amp;#x3ba;B axis.</a:t>
+              <a:t>The barrier–microbiota–inflammation axis in colorectal cancer: Mechanisms and emerging diagnostic &amp; therapeutic strategies</a:t>
             </a:r>
             <a:endParaRPr lang="en-US" sz="2400" dirty="0"/>
           </a:p>
@@ -2875,7 +2833,7 @@
                   <a:srgbClr val="888888"/>
                 </a:solidFill>
               </a:rPr>
-              <a:t>Journal of ethnopharmacology  ·  Basic Research</a:t>
+              <a:t>Cancers  ·  Basic Research</a:t>
             </a:r>
             <a:endParaRPr lang="en-US" sz="1000" dirty="0"/>
           </a:p>
@@ -2918,7 +2876,7 @@
                 <a:ea typeface="Arial" pitchFamily="34" charset="-122"/>
                 <a:cs typeface="Arial" pitchFamily="34" charset="-120"/>
               </a:rPr>
-              <a:t>Sanghuangporus vaninii shows anti-tumor effects.</a:t>
+              <a:t>LPS triggers pro-inflammatory cytokines secretion.</a:t>
             </a:r>
             <a:endParaRPr lang="en-US" sz="1800" dirty="0"/>
           </a:p>
@@ -2939,7 +2897,7 @@
                 <a:ea typeface="Arial" pitchFamily="34" charset="-122"/>
                 <a:cs typeface="Arial" pitchFamily="34" charset="-120"/>
               </a:rPr>
-              <a:t>Inhibits colitis-associated colorectal cancer (CAC).</a:t>
+              <a:t>Tight junction proteins are downregulated.</a:t>
             </a:r>
             <a:endParaRPr lang="en-US" sz="1800" dirty="0"/>
           </a:p>
@@ -2960,7 +2918,7 @@
                 <a:ea typeface="Arial" pitchFamily="34" charset="-122"/>
                 <a:cs typeface="Arial" pitchFamily="34" charset="-120"/>
               </a:rPr>
-              <a:t>Targets PPARγ/NF-κB signaling pathway.</a:t>
+              <a:t>Epithelial cell migration is promoted.</a:t>
             </a:r>
             <a:endParaRPr lang="en-US" sz="1800" dirty="0"/>
           </a:p>
@@ -2981,7 +2939,7 @@
                 <a:ea typeface="Arial" pitchFamily="34" charset="-122"/>
                 <a:cs typeface="Arial" pitchFamily="34" charset="-120"/>
               </a:rPr>
-              <a:t>Modulates macrophages towards M2 phenotype.</a:t>
+              <a:t>Microbiota influences inflammation in cancer.</a:t>
             </a:r>
             <a:endParaRPr lang="en-US" sz="1800" dirty="0"/>
           </a:p>
@@ -3002,7 +2960,7 @@
                 <a:ea typeface="Arial" pitchFamily="34" charset="-122"/>
                 <a:cs typeface="Arial" pitchFamily="34" charset="-120"/>
               </a:rPr>
-              <a:t>Improves survival and reduces tumor burden.</a:t>
+              <a:t>Emerging strategies for diagnosis and therapy.</a:t>
             </a:r>
             <a:endParaRPr lang="en-US" sz="1800" dirty="0"/>
           </a:p>
@@ -3038,7 +2996,7 @@
                   <a:srgbClr val="888888"/>
                 </a:solidFill>
               </a:rPr>
-              <a:t>Wang Yuqing, Mao Shangling, Shi Chao et al.. Journal of ethnopharmacology. 2026-07-15 DOI: 10.1016/j.jep.2026.121657</a:t>
+              <a:t>X Dong, J Yang, L He. Cancers. 2026</a:t>
             </a:r>
             <a:endParaRPr lang="en-US" sz="800" dirty="0"/>
           </a:p>
@@ -3238,7 +3196,7 @@
                   </a:extLst>
                 </a:hlinkClick>
               </a:rPr>
-              <a:t>Anti-Malignancy and Anti-Inflammation Properties of Emodin, an Essential Constituent in Popular Laxative Botanicals.</a:t>
+              <a:t>The Mechanism of Acetyl-L-Carnitine on Colorectal Cancer and Its Metabolomic Study</a:t>
             </a:r>
             <a:endParaRPr lang="en-US" sz="2400" dirty="0"/>
           </a:p>
@@ -3274,7 +3232,7 @@
                   <a:srgbClr val="888888"/>
                 </a:solidFill>
               </a:rPr>
-              <a:t>The American journal of Chinese medicine  ·  Basic Research</a:t>
+              <a:t>Journal of Pharmaceutical and …  ·  Basic Research</a:t>
             </a:r>
             <a:endParaRPr lang="en-US" sz="1000" dirty="0"/>
           </a:p>
@@ -3317,7 +3275,7 @@
                 <a:ea typeface="Arial" pitchFamily="34" charset="-122"/>
                 <a:cs typeface="Arial" pitchFamily="34" charset="-120"/>
               </a:rPr>
-              <a:t>Emodin shows anti-malignancy effects.</a:t>
+              <a:t>Acetyl-L-Carnitine inhibits tumor growth</a:t>
             </a:r>
             <a:endParaRPr lang="en-US" sz="1800" dirty="0"/>
           </a:p>
@@ -3338,7 +3296,7 @@
                 <a:ea typeface="Arial" pitchFamily="34" charset="-122"/>
                 <a:cs typeface="Arial" pitchFamily="34" charset="-120"/>
               </a:rPr>
-              <a:t>Inhibits colorectal cancer cell growth.</a:t>
+              <a:t>In vivo studies confirm effectiveness</a:t>
             </a:r>
             <a:endParaRPr lang="en-US" sz="1800" dirty="0"/>
           </a:p>
@@ -3359,7 +3317,7 @@
                 <a:ea typeface="Arial" pitchFamily="34" charset="-122"/>
                 <a:cs typeface="Arial" pitchFamily="34" charset="-120"/>
               </a:rPr>
-              <a:t>Reduces inflammatory cytokines in vivo.</a:t>
+              <a:t>Metabolomic analysis reveals mechanisms</a:t>
             </a:r>
             <a:endParaRPr lang="en-US" sz="1800" dirty="0"/>
           </a:p>
@@ -3395,7 +3353,7 @@
                   <a:srgbClr val="888888"/>
                 </a:solidFill>
               </a:rPr>
-              <a:t>Wang Meng, Zhang Xiankang, Huang Yanrong et al.. The American journal of Chinese medicine. 2026-07-14 DOI: 10.1142/S0192415X26500588</a:t>
+              <a:t>J Ning, C Cai, X Fan. Journal of Pharmaceutical and …. 2026</a:t>
             </a:r>
             <a:endParaRPr lang="en-US" sz="800" dirty="0"/>
           </a:p>
@@ -3612,7 +3570,7 @@
                   <a:srgbClr val="FFFFFF"/>
                 </a:solidFill>
               </a:rPr>
-              <a:t>1. **KRAS抑制劑的抗藥性機制**  </a:t>
+              <a:t>1. **新療法的潛力**  </a:t>
             </a:r>
             <a:endParaRPr lang="en-US" sz="1200" dirty="0"/>
           </a:p>
@@ -3629,7 +3587,7 @@
                   <a:srgbClr val="FFFFFF"/>
                 </a:solidFill>
               </a:rPr>
-              <a:t>   **Mechanisms of Resistance to KRAS Inhibitors**  </a:t>
+              <a:t>   **The potential of novel therapies**  </a:t>
             </a:r>
             <a:endParaRPr lang="en-US" sz="1200" dirty="0"/>
           </a:p>
@@ -3646,7 +3604,7 @@
                   <a:srgbClr val="FFFFFF"/>
                 </a:solidFill>
               </a:rPr>
-              <a:t>   研究顯示，KRAS突變在大腸癌中佔有重要地位，然而其抗藥性機制的複雜性限制了治療效果，未來需針對這些機制進行深入探討。  </a:t>
+              <a:t>   本週的研究顯示，使用超熱腹腔化學療法（HIPEC）結合細胞減少手術對於轉移性結直腸癌的患者可能不如單獨手術有效，提示需要重新評估目前的治療標準。  </a:t>
             </a:r>
             <a:endParaRPr lang="en-US" sz="1200" dirty="0"/>
           </a:p>
@@ -3663,7 +3621,7 @@
                   <a:srgbClr val="FFFFFF"/>
                 </a:solidFill>
               </a:rPr>
-              <a:t>   Studies indicate that KRAS mutations play a crucial role in colorectal cancer; however, the complexity of resistance mechanisms limits treatment efficacy, necessitating further exploration of these mechanisms.</a:t>
+              <a:t>   This week’s studies indicate that hyperthermic intraperitoneal chemotherapy (HIPEC) combined with cytoreductive surgery may be less effective than surgery alone for patients with metastatic colorectal cancer, suggesting a need to reevaluate current treatment standards.</a:t>
             </a:r>
             <a:endParaRPr lang="en-US" sz="1200" dirty="0"/>
           </a:p>
@@ -3689,7 +3647,7 @@
                   <a:srgbClr val="FFFFFF"/>
                 </a:solidFill>
               </a:rPr>
-              <a:t>2. **腸道微生物群的調節作用**  </a:t>
+              <a:t>2. **生物標記的預測價值**  </a:t>
             </a:r>
             <a:endParaRPr lang="en-US" sz="1200" dirty="0"/>
           </a:p>
@@ -3706,7 +3664,7 @@
                   <a:srgbClr val="FFFFFF"/>
                 </a:solidFill>
               </a:rPr>
-              <a:t>   **Regulatory Role of Gut Microbiota**  </a:t>
+              <a:t>   **The prognostic value of biomarkers**  </a:t>
             </a:r>
             <a:endParaRPr lang="en-US" sz="1200" dirty="0"/>
           </a:p>
@@ -3723,7 +3681,7 @@
                   <a:srgbClr val="FFFFFF"/>
                 </a:solidFill>
               </a:rPr>
-              <a:t>   新研究揭示，某些植物化合物能透過調節腸道微生物群來減輕炎症及腸道癌症的風險，這為未來的預防及治療策略提供了新的視角。  </a:t>
+              <a:t>   系統性免疫炎症指數（SII）被證實在結直腸癌中具有預測性，這為臨床上風險評估和個體化治療提供了新的指導。  </a:t>
             </a:r>
             <a:endParaRPr lang="en-US" sz="1200" dirty="0"/>
           </a:p>
@@ -3740,7 +3698,7 @@
                   <a:srgbClr val="FFFFFF"/>
                 </a:solidFill>
               </a:rPr>
-              <a:t>   New studies reveal that certain phytochemicals can mitigate inflammation and colorectal cancer risk by modulating gut microbiota, providing a new perspective for future prevention and treatment strategies.</a:t>
+              <a:t>   The systemic immune-inflammation index (SII) has been validated as a prognostic marker in colorectal cancer, offering new guidance for risk assessment and personalized treatment in clinical settings.</a:t>
             </a:r>
             <a:endParaRPr lang="en-US" sz="1200" dirty="0"/>
           </a:p>
@@ -3766,7 +3724,7 @@
                   <a:srgbClr val="FFFFFF"/>
                 </a:solidFill>
               </a:rPr>
-              <a:t>3. **系統性免疫炎症指數的預後價值**  </a:t>
+              <a:t>3. **氧化壓力與炎症的交互作用**  </a:t>
             </a:r>
             <a:endParaRPr lang="en-US" sz="1200" dirty="0"/>
           </a:p>
@@ -3783,7 +3741,7 @@
                   <a:srgbClr val="FFFFFF"/>
                 </a:solidFill>
               </a:rPr>
-              <a:t>   **Prognostic Value of Systemic Immune-Inflammation Index**  </a:t>
+              <a:t>   **Crosstalk between oxidative stress and inflammation**  </a:t>
             </a:r>
             <a:endParaRPr lang="en-US" sz="1200" dirty="0"/>
           </a:p>
@@ -3800,7 +3758,7 @@
                   <a:srgbClr val="FFFFFF"/>
                 </a:solidFill>
               </a:rPr>
-              <a:t>   系統性免疫炎症指數(SII)在大腸癌的預後中顯示出潛在的價值，這提示我們可以利用炎症標記來改善臨床預測模型。  </a:t>
+              <a:t>   研究強調氧化壓力與炎症在結直腸癌生物學中的中心角色，這一發現可能為未來的治療策略提供新的靶點。  </a:t>
             </a:r>
             <a:endParaRPr lang="en-US" sz="1200" dirty="0"/>
           </a:p>
@@ -3817,161 +3775,7 @@
                   <a:srgbClr val="FFFFFF"/>
                 </a:solidFill>
               </a:rPr>
-              <a:t>   The systemic immune-inflammation index (SII) shows potential prognostic value in colorectal cancer, suggesting that inflammatory markers could be utilized to enhance clinical predictive models.</a:t>
-            </a:r>
-            <a:endParaRPr lang="en-US" sz="1200" dirty="0"/>
-          </a:p>
-          <a:p>
-            <a:pPr indent="0" marL="0">
-              <a:lnSpc>
-                <a:spcPct val="150000"/>
-              </a:lnSpc>
-              <a:buNone/>
-            </a:pPr>
-            <a:endParaRPr lang="en-US" sz="1200" dirty="0"/>
-          </a:p>
-          <a:p>
-            <a:pPr indent="0" marL="0">
-              <a:lnSpc>
-                <a:spcPct val="150000"/>
-              </a:lnSpc>
-              <a:buNone/>
-            </a:pPr>
-            <a:r>
-              <a:rPr lang="en-US" sz="1200" dirty="0">
-                <a:solidFill>
-                  <a:srgbClr val="FFFFFF"/>
-                </a:solidFill>
-              </a:rPr>
-              <a:t>4. **炎症性腸病患者的癌症風險認知**  </a:t>
-            </a:r>
-            <a:endParaRPr lang="en-US" sz="1200" dirty="0"/>
-          </a:p>
-          <a:p>
-            <a:pPr indent="0" marL="0">
-              <a:lnSpc>
-                <a:spcPct val="150000"/>
-              </a:lnSpc>
-              <a:buNone/>
-            </a:pPr>
-            <a:r>
-              <a:rPr lang="en-US" sz="1200" dirty="0">
-                <a:solidFill>
-                  <a:srgbClr val="FFFFFF"/>
-                </a:solidFill>
-              </a:rPr>
-              <a:t>   **Awareness of Cancer Risk in Inflammatory Bowel Disease Patients**  </a:t>
-            </a:r>
-            <a:endParaRPr lang="en-US" sz="1200" dirty="0"/>
-          </a:p>
-          <a:p>
-            <a:pPr indent="0" marL="0">
-              <a:lnSpc>
-                <a:spcPct val="150000"/>
-              </a:lnSpc>
-              <a:buNone/>
-            </a:pPr>
-            <a:r>
-              <a:rPr lang="en-US" sz="1200" dirty="0">
-                <a:solidFill>
-                  <a:srgbClr val="FFFFFF"/>
-                </a:solidFill>
-              </a:rPr>
-              <a:t>   對於炎症性腸病患者來說，對大腸癌風險及其管理的認知仍然不足，未來應加強患者教育及相關研究。  </a:t>
-            </a:r>
-            <a:endParaRPr lang="en-US" sz="1200" dirty="0"/>
-          </a:p>
-          <a:p>
-            <a:pPr indent="0" marL="0">
-              <a:lnSpc>
-                <a:spcPct val="150000"/>
-              </a:lnSpc>
-              <a:buNone/>
-            </a:pPr>
-            <a:r>
-              <a:rPr lang="en-US" sz="1200" dirty="0">
-                <a:solidFill>
-                  <a:srgbClr val="FFFFFF"/>
-                </a:solidFill>
-              </a:rPr>
-              <a:t>   Awareness regarding cancer risk and management among inflammatory bowel disease patients remains inadequate, highlighting the need for enhanced patient education and related research in the future.</a:t>
-            </a:r>
-            <a:endParaRPr lang="en-US" sz="1200" dirty="0"/>
-          </a:p>
-          <a:p>
-            <a:pPr indent="0" marL="0">
-              <a:lnSpc>
-                <a:spcPct val="150000"/>
-              </a:lnSpc>
-              <a:buNone/>
-            </a:pPr>
-            <a:endParaRPr lang="en-US" sz="1200" dirty="0"/>
-          </a:p>
-          <a:p>
-            <a:pPr indent="0" marL="0">
-              <a:lnSpc>
-                <a:spcPct val="150000"/>
-              </a:lnSpc>
-              <a:buNone/>
-            </a:pPr>
-            <a:r>
-              <a:rPr lang="en-US" sz="1200" dirty="0">
-                <a:solidFill>
-                  <a:srgbClr val="FFFFFF"/>
-                </a:solidFill>
-              </a:rPr>
-              <a:t>5. **超熱腹腔化療的潛在益處**  </a:t>
-            </a:r>
-            <a:endParaRPr lang="en-US" sz="1200" dirty="0"/>
-          </a:p>
-          <a:p>
-            <a:pPr indent="0" marL="0">
-              <a:lnSpc>
-                <a:spcPct val="150000"/>
-              </a:lnSpc>
-              <a:buNone/>
-            </a:pPr>
-            <a:r>
-              <a:rPr lang="en-US" sz="1200" dirty="0">
-                <a:solidFill>
-                  <a:srgbClr val="FFFFFF"/>
-                </a:solidFill>
-              </a:rPr>
-              <a:t>   **Potential Benefits of Hyperthermic Intraperitoneal Chemotherapy**  </a:t>
-            </a:r>
-            <a:endParaRPr lang="en-US" sz="1200" dirty="0"/>
-          </a:p>
-          <a:p>
-            <a:pPr indent="0" marL="0">
-              <a:lnSpc>
-                <a:spcPct val="150000"/>
-              </a:lnSpc>
-              <a:buNone/>
-            </a:pPr>
-            <a:r>
-              <a:rPr lang="en-US" sz="1200" dirty="0">
-                <a:solidFill>
-                  <a:srgbClr val="FFFFFF"/>
-                </a:solidFill>
-              </a:rPr>
-              <a:t>   超熱腹腔化療在晚期大腸癌患者中的應用顯示出可能的療效，未來應進一步評估其在不同臨床背景下的效果。  </a:t>
-            </a:r>
-            <a:endParaRPr lang="en-US" sz="1200" dirty="0"/>
-          </a:p>
-          <a:p>
-            <a:pPr indent="0" marL="0">
-              <a:lnSpc>
-                <a:spcPct val="150000"/>
-              </a:lnSpc>
-              <a:buNone/>
-            </a:pPr>
-            <a:r>
-              <a:rPr lang="en-US" sz="1200" dirty="0">
-                <a:solidFill>
-                  <a:srgbClr val="FFFFFF"/>
-                </a:solidFill>
-              </a:rPr>
-              <a:t>   The application of hyperthermic intraperitoneal chemotherapy in patients with advanced colorectal cancer shows potential efficacy, warranting further evaluation of its effects in different clinical contexts.</a:t>
+              <a:t>   Research highlights the central role of oxidative stress and inflammation in colorectal cancer biology, which may provide new targets for future therapeutic strategies.</a:t>
             </a:r>
             <a:endParaRPr lang="en-US" sz="1200" dirty="0"/>
           </a:p>
@@ -4143,7 +3947,7 @@
                   <a:srgbClr val="FFFFFF"/>
                 </a:solidFill>
               </a:rPr>
-              <a:t>1. **深入研究KRAS抗藥性機制**  </a:t>
+              <a:t>1. **個體化化療策略的發展**  </a:t>
             </a:r>
             <a:endParaRPr lang="en-US" sz="1200" dirty="0"/>
           </a:p>
@@ -4160,7 +3964,7 @@
                   <a:srgbClr val="FFFFFF"/>
                 </a:solidFill>
               </a:rPr>
-              <a:t>   **In-depth Investigation of KRAS Resistance Mechanisms**  </a:t>
+              <a:t>   **Development of personalized chemotherapy strategies**  </a:t>
             </a:r>
             <a:endParaRPr lang="en-US" sz="1200" dirty="0"/>
           </a:p>
@@ -4177,7 +3981,7 @@
                   <a:srgbClr val="FFFFFF"/>
                 </a:solidFill>
               </a:rPr>
-              <a:t>   未來的研究應聚焦於KRAS抑制劑的抗藥性機制，特別是基因和非基因因素的交互作用，以開發更有效的治療策略。  </a:t>
+              <a:t>   需要進一步研究基於患者來源的器官類器官的藥物篩選平台，以制定針對結直腸癌腹膜轉移的個體化化療方案。  </a:t>
             </a:r>
             <a:endParaRPr lang="en-US" sz="1200" dirty="0"/>
           </a:p>
@@ -4194,7 +3998,7 @@
                   <a:srgbClr val="FFFFFF"/>
                 </a:solidFill>
               </a:rPr>
-              <a:t>   Future research should focus on the mechanisms of resistance to KRAS inhibitors, particularly the interplay between genetic and non-genetic factors, to develop more effective treatment strategies.</a:t>
+              <a:t>   Further studies are needed to develop personalized chemotherapy strategies based on drug screening platforms using patient-derived organoids for colorectal cancer peritoneal metastases.</a:t>
             </a:r>
             <a:endParaRPr lang="en-US" sz="1200" dirty="0"/>
           </a:p>
@@ -4220,7 +4024,7 @@
                   <a:srgbClr val="FFFFFF"/>
                 </a:solidFill>
               </a:rPr>
-              <a:t>2. **植物化合物的臨床應用研究**  </a:t>
+              <a:t>2. **炎症性腸病與結直腸癌風險的認知**  </a:t>
             </a:r>
             <a:endParaRPr lang="en-US" sz="1200" dirty="0"/>
           </a:p>
@@ -4237,7 +4041,7 @@
                   <a:srgbClr val="FFFFFF"/>
                 </a:solidFill>
               </a:rPr>
-              <a:t>   **Clinical Application Studies of Phytochemicals**  </a:t>
+              <a:t>   **Awareness of inflammatory bowel disease and colorectal cancer risk**  </a:t>
             </a:r>
             <a:endParaRPr lang="en-US" sz="1200" dirty="0"/>
           </a:p>
@@ -4254,7 +4058,7 @@
                   <a:srgbClr val="FFFFFF"/>
                 </a:solidFill>
               </a:rPr>
-              <a:t>   針對具有抗炎及抗腫瘤特性的植物化合物，應進行臨床試驗，以評估其在大腸癌預防和治療中的潛力。  </a:t>
+              <a:t>   針對炎症性腸病患者對結直腸癌風險及其管理的認知進行深入調查，以促進患者教育和早期干預。  </a:t>
             </a:r>
             <a:endParaRPr lang="en-US" sz="1200" dirty="0"/>
           </a:p>
@@ -4271,7 +4075,7 @@
                   <a:srgbClr val="FFFFFF"/>
                 </a:solidFill>
               </a:rPr>
-              <a:t>   Clinical trials should be conducted on phytochemicals with anti-inflammatory and anti-tumor properties to assess their potential in the prevention and treatment of colorectal cancer.</a:t>
+              <a:t>   In-depth investigations on the awareness of colorectal cancer risk and management among patients with inflammatory bowel disease are necessary to enhance patient education and early intervention.</a:t>
             </a:r>
             <a:endParaRPr lang="en-US" sz="1200" dirty="0"/>
           </a:p>
@@ -4297,7 +4101,7 @@
                   <a:srgbClr val="FFFFFF"/>
                 </a:solidFill>
               </a:rPr>
-              <a:t>3. **炎症標記的整合應用**  </a:t>
+              <a:t>3. **新型治療策略的探索**  </a:t>
             </a:r>
             <a:endParaRPr lang="en-US" sz="1200" dirty="0"/>
           </a:p>
@@ -4314,7 +4118,7 @@
                   <a:srgbClr val="FFFFFF"/>
                 </a:solidFill>
               </a:rPr>
-              <a:t>   **Integrated Application of Inflammatory Markers**  </a:t>
+              <a:t>   **Exploration of novel therapeutic strategies**  </a:t>
             </a:r>
             <a:endParaRPr lang="en-US" sz="1200" dirty="0"/>
           </a:p>
@@ -4331,7 +4135,7 @@
                   <a:srgbClr val="FFFFFF"/>
                 </a:solidFill>
               </a:rPr>
-              <a:t>   研究應探索如何整合多種炎症標記，以提高大腸癌的預後預測準確性，並指導個體化治療。  </a:t>
+              <a:t>   研究如阿莫西林等新型藥物對結直腸癌的潛在療效，尤其是其在氧化壓力和炎症交互作用中的角色。  </a:t>
             </a:r>
             <a:endParaRPr lang="en-US" sz="1200" dirty="0"/>
           </a:p>
@@ -4348,161 +4152,7 @@
                   <a:srgbClr val="FFFFFF"/>
                 </a:solidFill>
               </a:rPr>
-              <a:t>   Research should explore how to integrate multiple inflammatory markers to enhance the accuracy of prognostic predictions in colorectal cancer and guide personalized treatment.</a:t>
-            </a:r>
-            <a:endParaRPr lang="en-US" sz="1200" dirty="0"/>
-          </a:p>
-          <a:p>
-            <a:pPr indent="0" marL="0">
-              <a:lnSpc>
-                <a:spcPct val="150000"/>
-              </a:lnSpc>
-              <a:buNone/>
-            </a:pPr>
-            <a:endParaRPr lang="en-US" sz="1200" dirty="0"/>
-          </a:p>
-          <a:p>
-            <a:pPr indent="0" marL="0">
-              <a:lnSpc>
-                <a:spcPct val="150000"/>
-              </a:lnSpc>
-              <a:buNone/>
-            </a:pPr>
-            <a:r>
-              <a:rPr lang="en-US" sz="1200" dirty="0">
-                <a:solidFill>
-                  <a:srgbClr val="FFFFFF"/>
-                </a:solidFill>
-              </a:rPr>
-              <a:t>4. **患者教育與風險管理策略**  </a:t>
-            </a:r>
-            <a:endParaRPr lang="en-US" sz="1200" dirty="0"/>
-          </a:p>
-          <a:p>
-            <a:pPr indent="0" marL="0">
-              <a:lnSpc>
-                <a:spcPct val="150000"/>
-              </a:lnSpc>
-              <a:buNone/>
-            </a:pPr>
-            <a:r>
-              <a:rPr lang="en-US" sz="1200" dirty="0">
-                <a:solidFill>
-                  <a:srgbClr val="FFFFFF"/>
-                </a:solidFill>
-              </a:rPr>
-              <a:t>   **Patient Education and Risk Management Strategies**  </a:t>
-            </a:r>
-            <a:endParaRPr lang="en-US" sz="1200" dirty="0"/>
-          </a:p>
-          <a:p>
-            <a:pPr indent="0" marL="0">
-              <a:lnSpc>
-                <a:spcPct val="150000"/>
-              </a:lnSpc>
-              <a:buNone/>
-            </a:pPr>
-            <a:r>
-              <a:rPr lang="en-US" sz="1200" dirty="0">
-                <a:solidFill>
-                  <a:srgbClr val="FFFFFF"/>
-                </a:solidFill>
-              </a:rPr>
-              <a:t>   需要開發針對炎症性腸病患者的教育計劃，以提高他們對大腸癌風險的認知，並改善其管理策略。  </a:t>
-            </a:r>
-            <a:endParaRPr lang="en-US" sz="1200" dirty="0"/>
-          </a:p>
-          <a:p>
-            <a:pPr indent="0" marL="0">
-              <a:lnSpc>
-                <a:spcPct val="150000"/>
-              </a:lnSpc>
-              <a:buNone/>
-            </a:pPr>
-            <a:r>
-              <a:rPr lang="en-US" sz="1200" dirty="0">
-                <a:solidFill>
-                  <a:srgbClr val="FFFFFF"/>
-                </a:solidFill>
-              </a:rPr>
-              <a:t>   There is a need to develop educational programs for inflammatory bowel disease patients to enhance their awareness of colorectal cancer risk and improve management strategies.</a:t>
-            </a:r>
-            <a:endParaRPr lang="en-US" sz="1200" dirty="0"/>
-          </a:p>
-          <a:p>
-            <a:pPr indent="0" marL="0">
-              <a:lnSpc>
-                <a:spcPct val="150000"/>
-              </a:lnSpc>
-              <a:buNone/>
-            </a:pPr>
-            <a:endParaRPr lang="en-US" sz="1200" dirty="0"/>
-          </a:p>
-          <a:p>
-            <a:pPr indent="0" marL="0">
-              <a:lnSpc>
-                <a:spcPct val="150000"/>
-              </a:lnSpc>
-              <a:buNone/>
-            </a:pPr>
-            <a:r>
-              <a:rPr lang="en-US" sz="1200" dirty="0">
-                <a:solidFill>
-                  <a:srgbClr val="FFFFFF"/>
-                </a:solidFill>
-              </a:rPr>
-              <a:t>5. **超熱腹腔化療的長期效果研究**  </a:t>
-            </a:r>
-            <a:endParaRPr lang="en-US" sz="1200" dirty="0"/>
-          </a:p>
-          <a:p>
-            <a:pPr indent="0" marL="0">
-              <a:lnSpc>
-                <a:spcPct val="150000"/>
-              </a:lnSpc>
-              <a:buNone/>
-            </a:pPr>
-            <a:r>
-              <a:rPr lang="en-US" sz="1200" dirty="0">
-                <a:solidFill>
-                  <a:srgbClr val="FFFFFF"/>
-                </a:solidFill>
-              </a:rPr>
-              <a:t>   **Long-term Effect Studies of Hyperthermic Intraperitoneal Chemotherapy**  </a:t>
-            </a:r>
-            <a:endParaRPr lang="en-US" sz="1200" dirty="0"/>
-          </a:p>
-          <a:p>
-            <a:pPr indent="0" marL="0">
-              <a:lnSpc>
-                <a:spcPct val="150000"/>
-              </a:lnSpc>
-              <a:buNone/>
-            </a:pPr>
-            <a:r>
-              <a:rPr lang="en-US" sz="1200" dirty="0">
-                <a:solidFill>
-                  <a:srgbClr val="FFFFFF"/>
-                </a:solidFill>
-              </a:rPr>
-              <a:t>   應進行長期隨訪研究，以評估超熱腹腔化療在不同階段大腸癌患者中的持久效果和安全性。  </a:t>
-            </a:r>
-            <a:endParaRPr lang="en-US" sz="1200" dirty="0"/>
-          </a:p>
-          <a:p>
-            <a:pPr indent="0" marL="0">
-              <a:lnSpc>
-                <a:spcPct val="150000"/>
-              </a:lnSpc>
-              <a:buNone/>
-            </a:pPr>
-            <a:r>
-              <a:rPr lang="en-US" sz="1200" dirty="0">
-                <a:solidFill>
-                  <a:srgbClr val="FFFFFF"/>
-                </a:solidFill>
-              </a:rPr>
-              <a:t>   Long-term follow-up studies should be conducted to assess the enduring effects and safety of hyperthermic intraperitoneal chemotherapy in patients with colorectal cancer at various stages.</a:t>
+              <a:t>   Investigating the potential efficacy of novel drugs such as artemisinin in colorectal cancer, particularly their roles in oxidative stress and inflammation crosstalk, is warranted.</a:t>
             </a:r>
             <a:endParaRPr lang="en-US" sz="1200" dirty="0"/>
           </a:p>
@@ -4773,7 +4423,7 @@
                 <a:ea typeface="Arial" pitchFamily="34" charset="-122"/>
                 <a:cs typeface="Arial" pitchFamily="34" charset="-120"/>
               </a:rPr>
-              <a:t>Concurrent genetic and non-genetic resistance mechanisms to KRAS inhibition in c…</a:t>
+              <a:t>Effect of hyperthermic intraperitoneal chemotherapy on patients with advanced co…</a:t>
             </a:r>
             <a:endParaRPr lang="en-US" sz="1400" dirty="0"/>
           </a:p>
@@ -4810,7 +4460,7 @@
                 <a:ea typeface="Arial" pitchFamily="34" charset="-122"/>
                 <a:cs typeface="Arial" pitchFamily="34" charset="-120"/>
               </a:rPr>
-              <a:t>Diarylheptanoid Phytoestrogen from Curcuma comosa Attenuates Colitis and Colitis…</a:t>
+              <a:t>Prognostic value of systemic immune-inflammation index for colorectal cancer: a …</a:t>
             </a:r>
             <a:endParaRPr lang="en-US" sz="1400" dirty="0"/>
           </a:p>
@@ -4847,7 +4497,7 @@
                 <a:ea typeface="Arial" pitchFamily="34" charset="-122"/>
                 <a:cs typeface="Arial" pitchFamily="34" charset="-120"/>
               </a:rPr>
-              <a:t>Effect of hyperthermic intraperitoneal chemotherapy on patients with advanced co…</a:t>
+              <a:t>Anticancer and Anti-Inflammatory Potential of Betalains: A Systematic Review on …</a:t>
             </a:r>
             <a:endParaRPr lang="en-US" sz="1400" dirty="0"/>
           </a:p>
@@ -4884,7 +4534,7 @@
                 <a:ea typeface="Arial" pitchFamily="34" charset="-122"/>
                 <a:cs typeface="Arial" pitchFamily="34" charset="-120"/>
               </a:rPr>
-              <a:t>Prognostic value of systemic immune-inflammation index for colorectal cancer: a …</a:t>
+              <a:t>Oxidative Stress and Inflammation in Colorectal Cancer–Redox–Immune Crosstalk, B…</a:t>
             </a:r>
             <a:endParaRPr lang="en-US" sz="1400" dirty="0"/>
           </a:p>
@@ -4921,7 +4571,7 @@
                 <a:ea typeface="Arial" pitchFamily="34" charset="-122"/>
                 <a:cs typeface="Arial" pitchFamily="34" charset="-120"/>
               </a:rPr>
-              <a:t>Prognostic value of pretreatment C-reactive–protein–albumin–lymphocyte index in …</a:t>
+              <a:t>Awareness of inflammatory bowel disease-associated colorectal cancer risk and it…</a:t>
             </a:r>
             <a:endParaRPr lang="en-US" sz="1400" dirty="0"/>
           </a:p>
@@ -4958,7 +4608,7 @@
                 <a:ea typeface="Arial" pitchFamily="34" charset="-122"/>
                 <a:cs typeface="Arial" pitchFamily="34" charset="-120"/>
               </a:rPr>
-              <a:t>Awareness of inflammatory bowel disease-associated colorectal cancer risk and it…</a:t>
+              <a:t>Mechanistic Insights Into Dose-Dependent Alleviation of Colorectal Cancer Throug…</a:t>
             </a:r>
             <a:endParaRPr lang="en-US" sz="1400" dirty="0"/>
           </a:p>
@@ -4995,7 +4645,7 @@
                 <a:ea typeface="Arial" pitchFamily="34" charset="-122"/>
                 <a:cs typeface="Arial" pitchFamily="34" charset="-120"/>
               </a:rPr>
-              <a:t>Alzheimer's disease-related mutations in APP influence colorectal tumor formatio…</a:t>
+              <a:t>KLK7 overexpression promotes an aggressive phenotype and facilitates peritoneal …</a:t>
             </a:r>
             <a:endParaRPr lang="en-US" sz="1400" dirty="0"/>
           </a:p>
@@ -5032,7 +4682,7 @@
                 <a:ea typeface="Arial" pitchFamily="34" charset="-122"/>
                 <a:cs typeface="Arial" pitchFamily="34" charset="-120"/>
               </a:rPr>
-              <a:t>Sanghuangporus vaninii extract exerts dual anti-tumor effects in colitis-associa…</a:t>
+              <a:t>The barrier–microbiota–inflammation axis in colorectal cancer: Mechanisms and em…</a:t>
             </a:r>
             <a:endParaRPr lang="en-US" sz="1400" dirty="0"/>
           </a:p>
@@ -5069,7 +4719,7 @@
                 <a:ea typeface="Arial" pitchFamily="34" charset="-122"/>
                 <a:cs typeface="Arial" pitchFamily="34" charset="-120"/>
               </a:rPr>
-              <a:t>Anti-Malignancy and Anti-Inflammation Properties of Emodin, an Essential Constit…</a:t>
+              <a:t>The Mechanism of Acetyl-L-Carnitine on Colorectal Cancer and Its Metabolomic Stu…</a:t>
             </a:r>
             <a:endParaRPr lang="en-US" sz="1400" dirty="0"/>
           </a:p>
@@ -5303,7 +4953,7 @@
                 <a:ea typeface="Arial" pitchFamily="34" charset="-122"/>
                 <a:cs typeface="Arial" pitchFamily="34" charset="-120"/>
               </a:rPr>
-              <a:t>ORCHESTRA trial evaluates debulking surgery</a:t>
+              <a:t>Cytoreductive surgery evaluated in study</a:t>
             </a:r>
             <a:endParaRPr lang="en-US" sz="1800" dirty="0"/>
           </a:p>
@@ -5324,7 +4974,7 @@
                 <a:ea typeface="Arial" pitchFamily="34" charset="-122"/>
                 <a:cs typeface="Arial" pitchFamily="34" charset="-120"/>
               </a:rPr>
-              <a:t>Focus on metastatic colorectal cancer patients</a:t>
+              <a:t>Hyperthermic intraperitoneal chemotherapy added</a:t>
             </a:r>
             <a:endParaRPr lang="en-US" sz="1800" dirty="0"/>
           </a:p>
@@ -5345,7 +4995,7 @@
                 <a:ea typeface="Arial" pitchFamily="34" charset="-122"/>
                 <a:cs typeface="Arial" pitchFamily="34" charset="-120"/>
               </a:rPr>
-              <a:t>Results show limited survival benefits</a:t>
+              <a:t>Focus on colorectal peritoneal metastases</a:t>
             </a:r>
             <a:endParaRPr lang="en-US" sz="1800" dirty="0"/>
           </a:p>
@@ -5366,7 +5016,7 @@
                 <a:ea typeface="Arial" pitchFamily="34" charset="-122"/>
                 <a:cs typeface="Arial" pitchFamily="34" charset="-120"/>
               </a:rPr>
-              <a:t>Surgery may not improve outcomes</a:t>
+              <a:t>Multicentre, randomised trial design</a:t>
             </a:r>
             <a:endParaRPr lang="en-US" sz="1800" dirty="0"/>
           </a:p>
@@ -5387,7 +5037,7 @@
                 <a:ea typeface="Arial" pitchFamily="34" charset="-122"/>
                 <a:cs typeface="Arial" pitchFamily="34" charset="-120"/>
               </a:rPr>
-              <a:t>Need for alternative treatment strategies</a:t>
+              <a:t>Results show no significant benefit</a:t>
             </a:r>
             <a:endParaRPr lang="en-US" sz="1800" dirty="0"/>
           </a:p>
@@ -5623,7 +5273,7 @@
                   </a:extLst>
                 </a:hlinkClick>
               </a:rPr>
-              <a:t>Concurrent genetic and non-genetic resistance mechanisms to KRAS inhibition in colorectal cancer.</a:t>
+              <a:t>Effect of hyperthermic intraperitoneal chemotherapy on patients with advanced colorectal cancer: a systematic review and meta-analysis</a:t>
             </a:r>
             <a:endParaRPr lang="en-US" sz="2400" dirty="0"/>
           </a:p>
@@ -5659,7 +5309,7 @@
                   <a:srgbClr val="888888"/>
                 </a:solidFill>
               </a:rPr>
-              <a:t>Cancer cell  ·  IF 48.8</a:t>
+              <a:t>World Journal of …  ·  Meta-Analysis</a:t>
             </a:r>
             <a:endParaRPr lang="en-US" sz="1000" dirty="0"/>
           </a:p>
@@ -5702,7 +5352,7 @@
                 <a:ea typeface="Arial" pitchFamily="34" charset="-122"/>
                 <a:cs typeface="Arial" pitchFamily="34" charset="-120"/>
               </a:rPr>
-              <a:t>KRAS mutations in 45%-50% of CRC</a:t>
+              <a:t>Hyperthermic intraperitoneal chemotherapy (HIPEC) evaluated</a:t>
             </a:r>
             <a:endParaRPr lang="en-US" sz="1800" dirty="0"/>
           </a:p>
@@ -5723,7 +5373,7 @@
                 <a:ea typeface="Arial" pitchFamily="34" charset="-122"/>
                 <a:cs typeface="Arial" pitchFamily="34" charset="-120"/>
               </a:rPr>
-              <a:t>Resistance mechanisms include genetic events</a:t>
+              <a:t>Advanced colorectal cancer patients included</a:t>
             </a:r>
             <a:endParaRPr lang="en-US" sz="1800" dirty="0"/>
           </a:p>
@@ -5744,7 +5394,7 @@
                 <a:ea typeface="Arial" pitchFamily="34" charset="-122"/>
                 <a:cs typeface="Arial" pitchFamily="34" charset="-120"/>
               </a:rPr>
-              <a:t>Mesenchymal and YAP signatures in resistant tumors</a:t>
+              <a:t>Systematic review and meta-analysis conducted</a:t>
             </a:r>
             <a:endParaRPr lang="en-US" sz="1800" dirty="0"/>
           </a:p>
@@ -5765,7 +5415,7 @@
                 <a:ea typeface="Arial" pitchFamily="34" charset="-122"/>
                 <a:cs typeface="Arial" pitchFamily="34" charset="-120"/>
               </a:rPr>
-              <a:t>Inflammatory programs induced early in treatment</a:t>
+              <a:t>Improved survival rates observed</a:t>
             </a:r>
             <a:endParaRPr lang="en-US" sz="1800" dirty="0"/>
           </a:p>
@@ -5786,7 +5436,7 @@
                 <a:ea typeface="Arial" pitchFamily="34" charset="-122"/>
                 <a:cs typeface="Arial" pitchFamily="34" charset="-120"/>
               </a:rPr>
-              <a:t>TBK1 identified as a potential therapeutic target</a:t>
+              <a:t>Potential for personalized treatment strategies</a:t>
             </a:r>
             <a:endParaRPr lang="en-US" sz="1800" dirty="0"/>
           </a:p>
@@ -5822,7 +5472,7 @@
                   <a:srgbClr val="888888"/>
                 </a:solidFill>
               </a:rPr>
-              <a:t>Alonso Salvador, Chu Kevan, Granowsky Elizabeth et al.. Cancer cell. 2026-07-14 DOI: 10.1016/j.ccell.2026.04.009</a:t>
+              <a:t>Z Su, Y Guo, X Ru. World Journal of …. 2026</a:t>
             </a:r>
             <a:endParaRPr lang="en-US" sz="800" dirty="0"/>
           </a:p>
@@ -6022,7 +5672,7 @@
                   </a:extLst>
                 </a:hlinkClick>
               </a:rPr>
-              <a:t>Diarylheptanoid Phytoestrogen from Curcuma comosa Attenuates Colitis and Colitis-Associated Colorectal Cancer by Inhibiting Inflammation and Oxidative Stress and Modulating Gut Microbiota.</a:t>
+              <a:t>Prognostic value of systemic immune-inflammation index for colorectal cancer: a systematic review and meta-analysis</a:t>
             </a:r>
             <a:endParaRPr lang="en-US" sz="2400" dirty="0"/>
           </a:p>
@@ -6058,7 +5708,7 @@
                   <a:srgbClr val="888888"/>
                 </a:solidFill>
               </a:rPr>
-              <a:t>Journal of agricultural and food chemistry  ·  RCT Phase 2  ·  🌏 Asia</a:t>
+              <a:t>Frontiers in Oncology  ·  Meta-Analysis</a:t>
             </a:r>
             <a:endParaRPr lang="en-US" sz="1000" dirty="0"/>
           </a:p>
@@ -6101,7 +5751,7 @@
                 <a:ea typeface="Arial" pitchFamily="34" charset="-122"/>
                 <a:cs typeface="Arial" pitchFamily="34" charset="-120"/>
               </a:rPr>
-              <a:t>Diarylheptanoids from Curcuma comosa studied</a:t>
+              <a:t>Systemic immune-inflammation index (SII) evaluated</a:t>
             </a:r>
             <a:endParaRPr lang="en-US" sz="1800" dirty="0"/>
           </a:p>
@@ -6122,7 +5772,7 @@
                 <a:ea typeface="Arial" pitchFamily="34" charset="-122"/>
                 <a:cs typeface="Arial" pitchFamily="34" charset="-120"/>
               </a:rPr>
-              <a:t>DPH alleviates colitis and tumorigenesis</a:t>
+              <a:t>Prognostic biomarker for colorectal cancer</a:t>
             </a:r>
             <a:endParaRPr lang="en-US" sz="1800" dirty="0"/>
           </a:p>
@@ -6143,7 +5793,7 @@
                 <a:ea typeface="Arial" pitchFamily="34" charset="-122"/>
                 <a:cs typeface="Arial" pitchFamily="34" charset="-120"/>
               </a:rPr>
-              <a:t>Inhibition of proinflammatory cytokines observed</a:t>
+              <a:t>Meta-analysis of existing studies</a:t>
             </a:r>
             <a:endParaRPr lang="en-US" sz="1800" dirty="0"/>
           </a:p>
@@ -6164,7 +5814,7 @@
                 <a:ea typeface="Arial" pitchFamily="34" charset="-122"/>
                 <a:cs typeface="Arial" pitchFamily="34" charset="-120"/>
               </a:rPr>
-              <a:t>Toll-like receptor pathway identified as target</a:t>
+              <a:t>SII correlates with patient outcomes</a:t>
             </a:r>
             <a:endParaRPr lang="en-US" sz="1800" dirty="0"/>
           </a:p>
@@ -6185,7 +5835,7 @@
                 <a:ea typeface="Arial" pitchFamily="34" charset="-122"/>
                 <a:cs typeface="Arial" pitchFamily="34" charset="-120"/>
               </a:rPr>
-              <a:t>Gut microbiota composition partially improved</a:t>
+              <a:t>Potential for clinical application</a:t>
             </a:r>
             <a:endParaRPr lang="en-US" sz="1800" dirty="0"/>
           </a:p>
@@ -6221,7 +5871,7 @@
                   <a:srgbClr val="888888"/>
                 </a:solidFill>
               </a:rPr>
-              <a:t>Truong Van-Long, Rarison Razanamanana H G, Song Eun-Ji et al.. Journal of agricultural and food chemistry. 2026-07-15 DOI: 10.1021/acs.jafc.5c17732</a:t>
+              <a:t>P Wang, H Jiang. Frontiers in Oncology. 2026</a:t>
             </a:r>
             <a:endParaRPr lang="en-US" sz="800" dirty="0"/>
           </a:p>
@@ -6421,7 +6071,7 @@
                   </a:extLst>
                 </a:hlinkClick>
               </a:rPr>
-              <a:t>Effect of hyperthermic intraperitoneal chemotherapy on patients with advanced colorectal cancer: a systematic review and meta-analysis</a:t>
+              <a:t>Anticancer and Anti-Inflammatory Potential of Betalains: A Systematic Review on Preclinical Studies.</a:t>
             </a:r>
             <a:endParaRPr lang="en-US" sz="2400" dirty="0"/>
           </a:p>
@@ -6457,7 +6107,7 @@
                   <a:srgbClr val="888888"/>
                 </a:solidFill>
               </a:rPr>
-              <a:t>World Journal of …  ·  Meta-Analysis</a:t>
+              <a:t>Food science &amp; nutrition  ·  Systematic Review</a:t>
             </a:r>
             <a:endParaRPr lang="en-US" sz="1000" dirty="0"/>
           </a:p>
@@ -6500,7 +6150,7 @@
                 <a:ea typeface="Arial" pitchFamily="34" charset="-122"/>
                 <a:cs typeface="Arial" pitchFamily="34" charset="-120"/>
               </a:rPr>
-              <a:t>Hyperthermic intraperitoneal chemotherapy (HIPEC) evaluated</a:t>
+              <a:t>Betalains show anticancer properties.</a:t>
             </a:r>
             <a:endParaRPr lang="en-US" sz="1800" dirty="0"/>
           </a:p>
@@ -6521,7 +6171,7 @@
                 <a:ea typeface="Arial" pitchFamily="34" charset="-122"/>
                 <a:cs typeface="Arial" pitchFamily="34" charset="-120"/>
               </a:rPr>
-              <a:t>Advanced colorectal cancer patients included</a:t>
+              <a:t>Inhibit colorectal cancer cell growth.</a:t>
             </a:r>
             <a:endParaRPr lang="en-US" sz="1800" dirty="0"/>
           </a:p>
@@ -6542,7 +6192,49 @@
                 <a:ea typeface="Arial" pitchFamily="34" charset="-122"/>
                 <a:cs typeface="Arial" pitchFamily="34" charset="-120"/>
               </a:rPr>
-              <a:t>Systematic review and meta-analysis conducted</a:t>
+              <a:t>Induce apoptosis via caspase activation.</a:t>
+            </a:r>
+            <a:endParaRPr lang="en-US" sz="1800" dirty="0"/>
+          </a:p>
+          <a:p>
+            <a:pPr marL="342900" indent="-342900">
+              <a:spcAft>
+                <a:spcPts val="800"/>
+              </a:spcAft>
+              <a:buSzPct val="100000"/>
+              <a:buChar char="•"/>
+            </a:pPr>
+            <a:r>
+              <a:rPr lang="en-US" sz="1800" dirty="0">
+                <a:solidFill>
+                  <a:srgbClr val="333333"/>
+                </a:solidFill>
+                <a:latin typeface="Arial" pitchFamily="34" charset="0"/>
+                <a:ea typeface="Arial" pitchFamily="34" charset="-122"/>
+                <a:cs typeface="Arial" pitchFamily="34" charset="-120"/>
+              </a:rPr>
+              <a:t>Suppress inflammatory signaling pathways.</a:t>
+            </a:r>
+            <a:endParaRPr lang="en-US" sz="1800" dirty="0"/>
+          </a:p>
+          <a:p>
+            <a:pPr marL="342900" indent="-342900">
+              <a:spcAft>
+                <a:spcPts val="800"/>
+              </a:spcAft>
+              <a:buSzPct val="100000"/>
+              <a:buChar char="•"/>
+            </a:pPr>
+            <a:r>
+              <a:rPr lang="en-US" sz="1800" dirty="0">
+                <a:solidFill>
+                  <a:srgbClr val="333333"/>
+                </a:solidFill>
+                <a:latin typeface="Arial" pitchFamily="34" charset="0"/>
+                <a:ea typeface="Arial" pitchFamily="34" charset="-122"/>
+                <a:cs typeface="Arial" pitchFamily="34" charset="-120"/>
+              </a:rPr>
+              <a:t>Low risk of bias in studies.</a:t>
             </a:r>
             <a:endParaRPr lang="en-US" sz="1800" dirty="0"/>
           </a:p>
@@ -6578,7 +6270,7 @@
                   <a:srgbClr val="888888"/>
                 </a:solidFill>
               </a:rPr>
-              <a:t>Z Su, Y Guo, X Ru. World Journal of …. 2026</a:t>
+              <a:t>Fatima Aroob, Sultan Muhammad Tauseef, Awlqadr Farhang Hameed et al.. Food science &amp; nutrition. 2026-07-25 DOI: 10.1002/fsn3.72133</a:t>
             </a:r>
             <a:endParaRPr lang="en-US" sz="800" dirty="0"/>
           </a:p>
@@ -6778,7 +6470,7 @@
                   </a:extLst>
                 </a:hlinkClick>
               </a:rPr>
-              <a:t>Prognostic value of systemic immune-inflammation index for colorectal cancer: a systematic review and meta-analysis</a:t>
+              <a:t>Oxidative Stress and Inflammation in Colorectal Cancer–Redox–Immune Crosstalk, Biomarkers, and Translational Implications: A Qualitative Systematic Review</a:t>
             </a:r>
             <a:endParaRPr lang="en-US" sz="2400" dirty="0"/>
           </a:p>
@@ -6814,7 +6506,7 @@
                   <a:srgbClr val="888888"/>
                 </a:solidFill>
               </a:rPr>
-              <a:t>Frontiers in Oncology  ·  Meta-Analysis</a:t>
+              <a:t>Life  ·  Systematic Review</a:t>
             </a:r>
             <a:endParaRPr lang="en-US" sz="1000" dirty="0"/>
           </a:p>
@@ -6857,7 +6549,7 @@
                 <a:ea typeface="Arial" pitchFamily="34" charset="-122"/>
                 <a:cs typeface="Arial" pitchFamily="34" charset="-120"/>
               </a:rPr>
-              <a:t>Systemic immune-inflammation index (SII) evaluated</a:t>
+              <a:t>Oxidative stress links to inflammation</a:t>
             </a:r>
             <a:endParaRPr lang="en-US" sz="1800" dirty="0"/>
           </a:p>
@@ -6878,7 +6570,7 @@
                 <a:ea typeface="Arial" pitchFamily="34" charset="-122"/>
                 <a:cs typeface="Arial" pitchFamily="34" charset="-120"/>
               </a:rPr>
-              <a:t>Prognostic biomarker for colorectal cancer</a:t>
+              <a:t>Redox-inflammation interplay in CRC</a:t>
             </a:r>
             <a:endParaRPr lang="en-US" sz="1800" dirty="0"/>
           </a:p>
@@ -6899,49 +6591,7 @@
                 <a:ea typeface="Arial" pitchFamily="34" charset="-122"/>
                 <a:cs typeface="Arial" pitchFamily="34" charset="-120"/>
               </a:rPr>
-              <a:t>Meta-analysis of existing studies</a:t>
-            </a:r>
-            <a:endParaRPr lang="en-US" sz="1800" dirty="0"/>
-          </a:p>
-          <a:p>
-            <a:pPr marL="342900" indent="-342900">
-              <a:spcAft>
-                <a:spcPts val="800"/>
-              </a:spcAft>
-              <a:buSzPct val="100000"/>
-              <a:buChar char="•"/>
-            </a:pPr>
-            <a:r>
-              <a:rPr lang="en-US" sz="1800" dirty="0">
-                <a:solidFill>
-                  <a:srgbClr val="333333"/>
-                </a:solidFill>
-                <a:latin typeface="Arial" pitchFamily="34" charset="0"/>
-                <a:ea typeface="Arial" pitchFamily="34" charset="-122"/>
-                <a:cs typeface="Arial" pitchFamily="34" charset="-120"/>
-              </a:rPr>
-              <a:t>SII associated with patient outcomes</a:t>
-            </a:r>
-            <a:endParaRPr lang="en-US" sz="1800" dirty="0"/>
-          </a:p>
-          <a:p>
-            <a:pPr marL="342900" indent="-342900">
-              <a:spcAft>
-                <a:spcPts val="800"/>
-              </a:spcAft>
-              <a:buSzPct val="100000"/>
-              <a:buChar char="•"/>
-            </a:pPr>
-            <a:r>
-              <a:rPr lang="en-US" sz="1800" dirty="0">
-                <a:solidFill>
-                  <a:srgbClr val="333333"/>
-                </a:solidFill>
-                <a:latin typeface="Arial" pitchFamily="34" charset="0"/>
-                <a:ea typeface="Arial" pitchFamily="34" charset="-122"/>
-                <a:cs typeface="Arial" pitchFamily="34" charset="-120"/>
-              </a:rPr>
-              <a:t>Potential for clinical application</a:t>
+              <a:t>Potential biomarkers for CRC detection</a:t>
             </a:r>
             <a:endParaRPr lang="en-US" sz="1800" dirty="0"/>
           </a:p>
@@ -6977,7 +6627,7 @@
                   <a:srgbClr val="888888"/>
                 </a:solidFill>
               </a:rPr>
-              <a:t>P Wang, H Jiang. Frontiers in Oncology. 2026</a:t>
+              <a:t>R Marinescu, D Marinescu, D Preda. Life. 2026</a:t>
             </a:r>
             <a:endParaRPr lang="en-US" sz="800" dirty="0"/>
           </a:p>
@@ -7177,7 +6827,7 @@
                   </a:extLst>
                 </a:hlinkClick>
               </a:rPr>
-              <a:t>Prognostic value of pretreatment C-reactive–protein–albumin–lymphocyte index in colorectal cancer: systematic review and meta-analysis</a:t>
+              <a:t>Awareness of inflammatory bowel disease-associated colorectal cancer risk and its management in patients with inflammatory bowel disease: a systematic review</a:t>
             </a:r>
             <a:endParaRPr lang="en-US" sz="2400" dirty="0"/>
           </a:p>
@@ -7213,7 +6863,7 @@
                   <a:srgbClr val="888888"/>
                 </a:solidFill>
               </a:rPr>
-              <a:t>Journal of …  ·  Meta-Analysis</a:t>
+              <a:t>Crohns &amp; Colitis 360  ·  Systematic Review</a:t>
             </a:r>
             <a:endParaRPr lang="en-US" sz="1000" dirty="0"/>
           </a:p>
@@ -7256,7 +6906,7 @@
                 <a:ea typeface="Arial" pitchFamily="34" charset="-122"/>
                 <a:cs typeface="Arial" pitchFamily="34" charset="-120"/>
               </a:rPr>
-              <a:t>C-reactive protein and albumin levels</a:t>
+              <a:t>Limited awareness of colorectal cancer risk</a:t>
             </a:r>
             <a:endParaRPr lang="en-US" sz="1800" dirty="0"/>
           </a:p>
@@ -7277,7 +6927,7 @@
                 <a:ea typeface="Arial" pitchFamily="34" charset="-122"/>
                 <a:cs typeface="Arial" pitchFamily="34" charset="-120"/>
               </a:rPr>
-              <a:t>Lymphocyte index as prognostic factor</a:t>
+              <a:t>Need for better patient education strategies</a:t>
             </a:r>
             <a:endParaRPr lang="en-US" sz="1800" dirty="0"/>
           </a:p>
@@ -7298,7 +6948,7 @@
                 <a:ea typeface="Arial" pitchFamily="34" charset="-122"/>
                 <a:cs typeface="Arial" pitchFamily="34" charset="-120"/>
               </a:rPr>
-              <a:t>Systematic review and meta-analysis conducted</a:t>
+              <a:t>Research gaps in management practices</a:t>
             </a:r>
             <a:endParaRPr lang="en-US" sz="1800" dirty="0"/>
           </a:p>
@@ -7334,7 +6984,7 @@
                   <a:srgbClr val="888888"/>
                 </a:solidFill>
               </a:rPr>
-              <a:t>M Shamohammadi, D Yarahmadi…. Journal of …. 2026</a:t>
+              <a:t>F Khan, C Norton, W Czuber-Dochan. Crohns &amp; Colitis 360. 2026</a:t>
             </a:r>
             <a:endParaRPr lang="en-US" sz="800" dirty="0"/>
           </a:p>
@@ -7534,7 +7184,7 @@
                   </a:extLst>
                 </a:hlinkClick>
               </a:rPr>
-              <a:t>Awareness of inflammatory bowel disease-associated colorectal cancer risk and its management in patients with inflammatory bowel disease: a systematic review</a:t>
+              <a:t>Mechanistic Insights Into Dose-Dependent Alleviation of Colorectal Cancer Through Artemisinin-Loaded Mesoporous Silica Nanoparticles in 1,2-Dimethylhydrazine-Induced Albino Wistar Rats.</a:t>
             </a:r>
             <a:endParaRPr lang="en-US" sz="2400" dirty="0"/>
           </a:p>
@@ -7570,7 +7220,7 @@
                   <a:srgbClr val="888888"/>
                 </a:solidFill>
               </a:rPr>
-              <a:t>Crohns &amp; Colitis 360  ·  Systematic Review</a:t>
+              <a:t>Dose-response : a publication of International Hormesis Society  ·  Basic Research</a:t>
             </a:r>
             <a:endParaRPr lang="en-US" sz="1000" dirty="0"/>
           </a:p>
@@ -7613,7 +7263,7 @@
                 <a:ea typeface="Arial" pitchFamily="34" charset="-122"/>
                 <a:cs typeface="Arial" pitchFamily="34" charset="-120"/>
               </a:rPr>
-              <a:t>Limited awareness of colorectal cancer risk</a:t>
+              <a:t>Artemisinin-loaded MSNPs synthesized via sol-gel method.</a:t>
             </a:r>
             <a:endParaRPr lang="en-US" sz="1800" dirty="0"/>
           </a:p>
@@ -7634,7 +7284,7 @@
                 <a:ea typeface="Arial" pitchFamily="34" charset="-122"/>
                 <a:cs typeface="Arial" pitchFamily="34" charset="-120"/>
               </a:rPr>
-              <a:t>Need for better patient education strategies</a:t>
+              <a:t>In vivo study on DMH-induced colorectal tumors.</a:t>
             </a:r>
             <a:endParaRPr lang="en-US" sz="1800" dirty="0"/>
           </a:p>
@@ -7655,7 +7305,49 @@
                 <a:ea typeface="Arial" pitchFamily="34" charset="-122"/>
                 <a:cs typeface="Arial" pitchFamily="34" charset="-120"/>
               </a:rPr>
-              <a:t>Importance of regular screening in IBD patients</a:t>
+              <a:t>Significant tumor suppression at 100 mg/kg dose.</a:t>
+            </a:r>
+            <a:endParaRPr lang="en-US" sz="1800" dirty="0"/>
+          </a:p>
+          <a:p>
+            <a:pPr marL="342900" indent="-342900">
+              <a:spcAft>
+                <a:spcPts val="800"/>
+              </a:spcAft>
+              <a:buSzPct val="100000"/>
+              <a:buChar char="•"/>
+            </a:pPr>
+            <a:r>
+              <a:rPr lang="en-US" sz="1800" dirty="0">
+                <a:solidFill>
+                  <a:srgbClr val="333333"/>
+                </a:solidFill>
+                <a:latin typeface="Arial" pitchFamily="34" charset="0"/>
+                <a:ea typeface="Arial" pitchFamily="34" charset="-122"/>
+                <a:cs typeface="Arial" pitchFamily="34" charset="-120"/>
+              </a:rPr>
+              <a:t>Controlled drug release observed in vitro.</a:t>
+            </a:r>
+            <a:endParaRPr lang="en-US" sz="1800" dirty="0"/>
+          </a:p>
+          <a:p>
+            <a:pPr marL="342900" indent="-342900">
+              <a:spcAft>
+                <a:spcPts val="800"/>
+              </a:spcAft>
+              <a:buSzPct val="100000"/>
+              <a:buChar char="•"/>
+            </a:pPr>
+            <a:r>
+              <a:rPr lang="en-US" sz="1800" dirty="0">
+                <a:solidFill>
+                  <a:srgbClr val="333333"/>
+                </a:solidFill>
+                <a:latin typeface="Arial" pitchFamily="34" charset="0"/>
+                <a:ea typeface="Arial" pitchFamily="34" charset="-122"/>
+                <a:cs typeface="Arial" pitchFamily="34" charset="-120"/>
+              </a:rPr>
+              <a:t>Potential for targeted colorectal cancer therapy.</a:t>
             </a:r>
             <a:endParaRPr lang="en-US" sz="1800" dirty="0"/>
           </a:p>
@@ -7691,7 +7383,7 @@
                   <a:srgbClr val="888888"/>
                 </a:solidFill>
               </a:rPr>
-              <a:t>F Khan, C Norton, W Czuber-Dochan. Crohns &amp; Colitis 360. 2026</a:t>
+              <a:t>Zahid Fatima, Ilyas Umair, Zahid Sara et al.. Dose-response : a publication of International Hormesis Society. 2026-07-25 DOI: 10.1177/15593258261472123</a:t>
             </a:r>
             <a:endParaRPr lang="en-US" sz="800" dirty="0"/>
           </a:p>

</xml_diff>

<commit_message>
chore: update weekly digest 2026-08-03
</commit_message>
<xml_diff>
--- a/docs/digest-en.pptx
+++ b/docs/digest-en.pptx
@@ -2249,7 +2249,7 @@
                   <a:srgbClr val="888888"/>
                 </a:solidFill>
               </a:rPr>
-              <a:t>2026-07-20 — 2026-07-27</a:t>
+              <a:t>2026-07-27 — 2026-08-03</a:t>
             </a:r>
             <a:endParaRPr lang="en-US" sz="1400" dirty="0"/>
           </a:p>
@@ -2440,7 +2440,7 @@
                   </a:extLst>
                 </a:hlinkClick>
               </a:rPr>
-              <a:t>KLK7 overexpression promotes an aggressive phenotype and facilitates peritoneal dissemination in colorectal cancer cells</a:t>
+              <a:t>Combining genotoxic gut bacterial strains increases tumor burden and accelerates onset in a germ-free mouse model of colon carcinogenesis.</a:t>
             </a:r>
             <a:endParaRPr lang="en-US" sz="2400" dirty="0"/>
           </a:p>
@@ -2476,7 +2476,7 @@
                   <a:srgbClr val="888888"/>
                 </a:solidFill>
               </a:rPr>
-              <a:t>FEBS Open …  ·  Basic Research</a:t>
+              <a:t>Cell reports  ·  IF 8.8  ·  Basic Research</a:t>
             </a:r>
             <a:endParaRPr lang="en-US" sz="1000" dirty="0"/>
           </a:p>
@@ -2519,7 +2519,7 @@
                 <a:ea typeface="Arial" pitchFamily="34" charset="-122"/>
                 <a:cs typeface="Arial" pitchFamily="34" charset="-120"/>
               </a:rPr>
-              <a:t>KLK7 overexpression linked to aggressive CRC</a:t>
+              <a:t>Germ-free mice colonized with 19 microbiotas</a:t>
             </a:r>
             <a:endParaRPr lang="en-US" sz="1800" dirty="0"/>
           </a:p>
@@ -2540,7 +2540,7 @@
                 <a:ea typeface="Arial" pitchFamily="34" charset="-122"/>
                 <a:cs typeface="Arial" pitchFamily="34" charset="-120"/>
               </a:rPr>
-              <a:t>Facilitates peritoneal dissemination in cancer cells</a:t>
+              <a:t>Tumor counts vary by donor microbiota</a:t>
             </a:r>
             <a:endParaRPr lang="en-US" sz="1800" dirty="0"/>
           </a:p>
@@ -2561,7 +2561,49 @@
                 <a:ea typeface="Arial" pitchFamily="34" charset="-122"/>
                 <a:cs typeface="Arial" pitchFamily="34" charset="-120"/>
               </a:rPr>
-              <a:t>In vitro studies confirm aggressive phenotype</a:t>
+              <a:t>Genotoxicity predicts tumorigenic microbes</a:t>
+            </a:r>
+            <a:endParaRPr lang="en-US" sz="1800" dirty="0"/>
+          </a:p>
+          <a:p>
+            <a:pPr marL="342900" indent="-342900">
+              <a:spcAft>
+                <a:spcPts val="800"/>
+              </a:spcAft>
+              <a:buSzPct val="100000"/>
+              <a:buChar char="•"/>
+            </a:pPr>
+            <a:r>
+              <a:rPr lang="en-US" sz="1800" dirty="0">
+                <a:solidFill>
+                  <a:srgbClr val="333333"/>
+                </a:solidFill>
+                <a:latin typeface="Arial" pitchFamily="34" charset="0"/>
+                <a:ea typeface="Arial" pitchFamily="34" charset="-122"/>
+                <a:cs typeface="Arial" pitchFamily="34" charset="-120"/>
+              </a:rPr>
+              <a:t>Combining genotoxic strains increases tumors</a:t>
+            </a:r>
+            <a:endParaRPr lang="en-US" sz="1800" dirty="0"/>
+          </a:p>
+          <a:p>
+            <a:pPr marL="342900" indent="-342900">
+              <a:spcAft>
+                <a:spcPts val="800"/>
+              </a:spcAft>
+              <a:buSzPct val="100000"/>
+              <a:buChar char="•"/>
+            </a:pPr>
+            <a:r>
+              <a:rPr lang="en-US" sz="1800" dirty="0">
+                <a:solidFill>
+                  <a:srgbClr val="333333"/>
+                </a:solidFill>
+                <a:latin typeface="Arial" pitchFamily="34" charset="0"/>
+                <a:ea typeface="Arial" pitchFamily="34" charset="-122"/>
+                <a:cs typeface="Arial" pitchFamily="34" charset="-120"/>
+              </a:rPr>
+              <a:t>Balance of strains affects tumor onset</a:t>
             </a:r>
             <a:endParaRPr lang="en-US" sz="1800" dirty="0"/>
           </a:p>
@@ -2597,7 +2639,7 @@
                   <a:srgbClr val="888888"/>
                 </a:solidFill>
               </a:rPr>
-              <a:t>YZ Haffani, T Dreyer, M Naim. FEBS Open …. 2026</a:t>
+              <a:t>Plitt Tamar, Piessevaux Alix, Rajpal Urvija et al.. Cell reports. 2026-07-30 DOI: 10.1016/j.celrep.2026.117645</a:t>
             </a:r>
             <a:endParaRPr lang="en-US" sz="800" dirty="0"/>
           </a:p>
@@ -2797,7 +2839,7 @@
                   </a:extLst>
                 </a:hlinkClick>
               </a:rPr>
-              <a:t>The barrier–microbiota–inflammation axis in colorectal cancer: Mechanisms and emerging diagnostic &amp; therapeutic strategies</a:t>
+              <a:t>Immediate Second Look After Cytoreduction for Colorectal or Ovarian Carcinomatosis: An Invisible Gorilla Effect?</a:t>
             </a:r>
             <a:endParaRPr lang="en-US" sz="2400" dirty="0"/>
           </a:p>
@@ -2833,7 +2875,7 @@
                   <a:srgbClr val="888888"/>
                 </a:solidFill>
               </a:rPr>
-              <a:t>Cancers  ·  Basic Research</a:t>
+              <a:t>Annals of surgical oncology  ·  IF 3.8  ·  Prospective Study</a:t>
             </a:r>
             <a:endParaRPr lang="en-US" sz="1000" dirty="0"/>
           </a:p>
@@ -2876,7 +2918,7 @@
                 <a:ea typeface="Arial" pitchFamily="34" charset="-122"/>
                 <a:cs typeface="Arial" pitchFamily="34" charset="-120"/>
               </a:rPr>
-              <a:t>LPS triggers pro-inflammatory cytokines secretion.</a:t>
+              <a:t>Study on immediate second look after CRS</a:t>
             </a:r>
             <a:endParaRPr lang="en-US" sz="1800" dirty="0"/>
           </a:p>
@@ -2897,7 +2939,7 @@
                 <a:ea typeface="Arial" pitchFamily="34" charset="-122"/>
                 <a:cs typeface="Arial" pitchFamily="34" charset="-120"/>
               </a:rPr>
-              <a:t>Tight junction proteins are downregulated.</a:t>
+              <a:t>172 patients underwent CC0 CRS evaluated</a:t>
             </a:r>
             <a:endParaRPr lang="en-US" sz="1800" dirty="0"/>
           </a:p>
@@ -2918,7 +2960,7 @@
                 <a:ea typeface="Arial" pitchFamily="34" charset="-122"/>
                 <a:cs typeface="Arial" pitchFamily="34" charset="-120"/>
               </a:rPr>
-              <a:t>Epithelial cell migration is promoted.</a:t>
+              <a:t>88.1% had additional nodules resected</a:t>
             </a:r>
             <a:endParaRPr lang="en-US" sz="1800" dirty="0"/>
           </a:p>
@@ -2939,7 +2981,7 @@
                 <a:ea typeface="Arial" pitchFamily="34" charset="-122"/>
                 <a:cs typeface="Arial" pitchFamily="34" charset="-120"/>
               </a:rPr>
-              <a:t>Microbiota influences inflammation in cancer.</a:t>
+              <a:t>47.4% confirmed malignancy in resected nodules</a:t>
             </a:r>
             <a:endParaRPr lang="en-US" sz="1800" dirty="0"/>
           </a:p>
@@ -2960,7 +3002,7 @@
                 <a:ea typeface="Arial" pitchFamily="34" charset="-122"/>
                 <a:cs typeface="Arial" pitchFamily="34" charset="-120"/>
               </a:rPr>
-              <a:t>Emerging strategies for diagnosis and therapy.</a:t>
+              <a:t>High cognitive attention but errors observed</a:t>
             </a:r>
             <a:endParaRPr lang="en-US" sz="1800" dirty="0"/>
           </a:p>
@@ -2996,7 +3038,7 @@
                   <a:srgbClr val="888888"/>
                 </a:solidFill>
               </a:rPr>
-              <a:t>X Dong, J Yang, L He. Cancers. 2026</a:t>
+              <a:t>Dumont Fr&amp;#xe9;d&amp;#xe9;ric, Cosse Lola, Thibaudeau Emilie et al.. Annals of surgical oncology. 2026-07-07 DOI: 10.1245/s10434-026-19493-5</a:t>
             </a:r>
             <a:endParaRPr lang="en-US" sz="800" dirty="0"/>
           </a:p>
@@ -3196,7 +3238,7 @@
                   </a:extLst>
                 </a:hlinkClick>
               </a:rPr>
-              <a:t>The Mechanism of Acetyl-L-Carnitine on Colorectal Cancer and Its Metabolomic Study</a:t>
+              <a:t>Incidence and outcomes of metachronous peritoneal metastasis in the setting of obstructing colon cancer: a systematic review.</a:t>
             </a:r>
             <a:endParaRPr lang="en-US" sz="2400" dirty="0"/>
           </a:p>
@@ -3232,7 +3274,7 @@
                   <a:srgbClr val="888888"/>
                 </a:solidFill>
               </a:rPr>
-              <a:t>Journal of Pharmaceutical and …  ·  Basic Research</a:t>
+              <a:t>European journal of surgical oncology : the journal of the European Society of Surgical Oncology and the British Association of Surgical Oncology  ·  Systematic Review</a:t>
             </a:r>
             <a:endParaRPr lang="en-US" sz="1000" dirty="0"/>
           </a:p>
@@ -3275,7 +3317,7 @@
                 <a:ea typeface="Arial" pitchFamily="34" charset="-122"/>
                 <a:cs typeface="Arial" pitchFamily="34" charset="-120"/>
               </a:rPr>
-              <a:t>Acetyl-L-Carnitine inhibits tumor growth</a:t>
+              <a:t>Colorectal peritoneal metastases are challenging to diagnose.</a:t>
             </a:r>
             <a:endParaRPr lang="en-US" sz="1800" dirty="0"/>
           </a:p>
@@ -3296,7 +3338,7 @@
                 <a:ea typeface="Arial" pitchFamily="34" charset="-122"/>
                 <a:cs typeface="Arial" pitchFamily="34" charset="-120"/>
               </a:rPr>
-              <a:t>In vivo studies confirm effectiveness</a:t>
+              <a:t>Obstruction in colon cancer worsens survival outcomes.</a:t>
             </a:r>
             <a:endParaRPr lang="en-US" sz="1800" dirty="0"/>
           </a:p>
@@ -3317,7 +3359,49 @@
                 <a:ea typeface="Arial" pitchFamily="34" charset="-122"/>
                 <a:cs typeface="Arial" pitchFamily="34" charset="-120"/>
               </a:rPr>
-              <a:t>Metabolomic analysis reveals mechanisms</a:t>
+              <a:t>Metachronous peritoneal metastases rates: 7-21%.</a:t>
+            </a:r>
+            <a:endParaRPr lang="en-US" sz="1800" dirty="0"/>
+          </a:p>
+          <a:p>
+            <a:pPr marL="342900" indent="-342900">
+              <a:spcAft>
+                <a:spcPts val="800"/>
+              </a:spcAft>
+              <a:buSzPct val="100000"/>
+              <a:buChar char="•"/>
+            </a:pPr>
+            <a:r>
+              <a:rPr lang="en-US" sz="1800" dirty="0">
+                <a:solidFill>
+                  <a:srgbClr val="333333"/>
+                </a:solidFill>
+                <a:latin typeface="Arial" pitchFamily="34" charset="0"/>
+                <a:ea typeface="Arial" pitchFamily="34" charset="-122"/>
+                <a:cs typeface="Arial" pitchFamily="34" charset="-120"/>
+              </a:rPr>
+              <a:t>3-year survival: 48-56% with peritoneal disease.</a:t>
+            </a:r>
+            <a:endParaRPr lang="en-US" sz="1800" dirty="0"/>
+          </a:p>
+          <a:p>
+            <a:pPr marL="342900" indent="-342900">
+              <a:spcAft>
+                <a:spcPts val="800"/>
+              </a:spcAft>
+              <a:buSzPct val="100000"/>
+              <a:buChar char="•"/>
+            </a:pPr>
+            <a:r>
+              <a:rPr lang="en-US" sz="1800" dirty="0">
+                <a:solidFill>
+                  <a:srgbClr val="333333"/>
+                </a:solidFill>
+                <a:latin typeface="Arial" pitchFamily="34" charset="0"/>
+                <a:ea typeface="Arial" pitchFamily="34" charset="-122"/>
+                <a:cs typeface="Arial" pitchFamily="34" charset="-120"/>
+              </a:rPr>
+              <a:t>Need for prospective trials to reduce recurrence risk.</a:t>
             </a:r>
             <a:endParaRPr lang="en-US" sz="1800" dirty="0"/>
           </a:p>
@@ -3353,7 +3437,7 @@
                   <a:srgbClr val="888888"/>
                 </a:solidFill>
               </a:rPr>
-              <a:t>J Ning, C Cai, X Fan. Journal of Pharmaceutical and …. 2026</a:t>
+              <a:t>O'Connell L V, McCafferty J, Udayasiri D et al.. European journal of surgical oncology : the journal of the European Society of Surgical Oncology and the British Association of Surgical Oncology. 2026-07-17 DOI: 10.1016/j.ejso.2026.111950</a:t>
             </a:r>
             <a:endParaRPr lang="en-US" sz="800" dirty="0"/>
           </a:p>
@@ -3570,7 +3654,7 @@
                   <a:srgbClr val="FFFFFF"/>
                 </a:solidFill>
               </a:rPr>
-              <a:t>1. **新療法的潛力**  </a:t>
+              <a:t>1. **免疫檢查點抑制劑的潛力**  </a:t>
             </a:r>
             <a:endParaRPr lang="en-US" sz="1200" dirty="0"/>
           </a:p>
@@ -3587,7 +3671,7 @@
                   <a:srgbClr val="FFFFFF"/>
                 </a:solidFill>
               </a:rPr>
-              <a:t>   **The potential of novel therapies**  </a:t>
+              <a:t>   The combination of neoadjuvant toripalimab and celecoxib demonstrates significant efficacy in dMMR/MSI-H locally advanced colorectal cancer, highlighting the potential of immune checkpoint inhibitors in enhancing treatment outcomes.  </a:t>
             </a:r>
             <a:endParaRPr lang="en-US" sz="1200" dirty="0"/>
           </a:p>
@@ -3604,7 +3688,7 @@
                   <a:srgbClr val="FFFFFF"/>
                 </a:solidFill>
               </a:rPr>
-              <a:t>   本週的研究顯示，使用超熱腹腔化學療法（HIPEC）結合細胞減少手術對於轉移性結直腸癌的患者可能不如單獨手術有效，提示需要重新評估目前的治療標準。  </a:t>
+              <a:t>   併用新輔助治療的toripalimab和celecoxib在dMMR/MSI-H的局部晚期結腸直腸癌中顯示出顯著的療效，突顯了免疫檢查點抑制劑在改善治療結果中的潛力。</a:t>
             </a:r>
             <a:endParaRPr lang="en-US" sz="1200" dirty="0"/>
           </a:p>
@@ -3615,14 +3699,6 @@
               </a:lnSpc>
               <a:buNone/>
             </a:pPr>
-            <a:r>
-              <a:rPr lang="en-US" sz="1200" dirty="0">
-                <a:solidFill>
-                  <a:srgbClr val="FFFFFF"/>
-                </a:solidFill>
-              </a:rPr>
-              <a:t>   This week’s studies indicate that hyperthermic intraperitoneal chemotherapy (HIPEC) combined with cytoreductive surgery may be less effective than surgery alone for patients with metastatic colorectal cancer, suggesting a need to reevaluate current treatment standards.</a:t>
-            </a:r>
             <a:endParaRPr lang="en-US" sz="1200" dirty="0"/>
           </a:p>
           <a:p>
@@ -3632,6 +3708,14 @@
               </a:lnSpc>
               <a:buNone/>
             </a:pPr>
+            <a:r>
+              <a:rPr lang="en-US" sz="1200" dirty="0">
+                <a:solidFill>
+                  <a:srgbClr val="FFFFFF"/>
+                </a:solidFill>
+              </a:rPr>
+              <a:t>2. **腸道微生物對癌症的影響**  </a:t>
+            </a:r>
             <a:endParaRPr lang="en-US" sz="1200" dirty="0"/>
           </a:p>
           <a:p>
@@ -3647,7 +3731,7 @@
                   <a:srgbClr val="FFFFFF"/>
                 </a:solidFill>
               </a:rPr>
-              <a:t>2. **生物標記的預測價值**  </a:t>
+              <a:t>   Dysbiosis in the gut microbiota is linked to inflammatory bowel disease and colorectal cancer, suggesting that modulation of gut microbiota could be a viable therapeutic strategy.  </a:t>
             </a:r>
             <a:endParaRPr lang="en-US" sz="1200" dirty="0"/>
           </a:p>
@@ -3664,7 +3748,7 @@
                   <a:srgbClr val="FFFFFF"/>
                 </a:solidFill>
               </a:rPr>
-              <a:t>   **The prognostic value of biomarkers**  </a:t>
+              <a:t>   腸道微生物失調與炎症性腸病和結腸直腸癌有關，這表明調節腸道微生物可能是一種可行的治療策略。</a:t>
             </a:r>
             <a:endParaRPr lang="en-US" sz="1200" dirty="0"/>
           </a:p>
@@ -3675,14 +3759,6 @@
               </a:lnSpc>
               <a:buNone/>
             </a:pPr>
-            <a:r>
-              <a:rPr lang="en-US" sz="1200" dirty="0">
-                <a:solidFill>
-                  <a:srgbClr val="FFFFFF"/>
-                </a:solidFill>
-              </a:rPr>
-              <a:t>   系統性免疫炎症指數（SII）被證實在結直腸癌中具有預測性，這為臨床上風險評估和個體化治療提供了新的指導。  </a:t>
-            </a:r>
             <a:endParaRPr lang="en-US" sz="1200" dirty="0"/>
           </a:p>
           <a:p>
@@ -3698,7 +3774,7 @@
                   <a:srgbClr val="FFFFFF"/>
                 </a:solidFill>
               </a:rPr>
-              <a:t>   The systemic immune-inflammation index (SII) has been validated as a prognostic marker in colorectal cancer, offering new guidance for risk assessment and personalized treatment in clinical settings.</a:t>
+              <a:t>3. **炎症與癌症的關聯**  </a:t>
             </a:r>
             <a:endParaRPr lang="en-US" sz="1200" dirty="0"/>
           </a:p>
@@ -3709,6 +3785,14 @@
               </a:lnSpc>
               <a:buNone/>
             </a:pPr>
+            <a:r>
+              <a:rPr lang="en-US" sz="1200" dirty="0">
+                <a:solidFill>
+                  <a:srgbClr val="FFFFFF"/>
+                </a:solidFill>
+              </a:rPr>
+              <a:t>   The role of inflammation in colorectal cancer is multifaceted, with both promoting and suppressing effects depending on the context, emphasizing the need for targeted therapies that consider the tumor microenvironment.  </a:t>
+            </a:r>
             <a:endParaRPr lang="en-US" sz="1200" dirty="0"/>
           </a:p>
           <a:p>
@@ -3724,7 +3808,7 @@
                   <a:srgbClr val="FFFFFF"/>
                 </a:solidFill>
               </a:rPr>
-              <a:t>3. **氧化壓力與炎症的交互作用**  </a:t>
+              <a:t>   炎症在結腸直腸癌中的作用是多方面的，根據情境的不同可能有促進或抑制的效果，強調需要考慮腫瘤微環境的靶向治療。</a:t>
             </a:r>
             <a:endParaRPr lang="en-US" sz="1200" dirty="0"/>
           </a:p>
@@ -3735,14 +3819,6 @@
               </a:lnSpc>
               <a:buNone/>
             </a:pPr>
-            <a:r>
-              <a:rPr lang="en-US" sz="1200" dirty="0">
-                <a:solidFill>
-                  <a:srgbClr val="FFFFFF"/>
-                </a:solidFill>
-              </a:rPr>
-              <a:t>   **Crosstalk between oxidative stress and inflammation**  </a:t>
-            </a:r>
             <a:endParaRPr lang="en-US" sz="1200" dirty="0"/>
           </a:p>
           <a:p>
@@ -3758,7 +3834,7 @@
                   <a:srgbClr val="FFFFFF"/>
                 </a:solidFill>
               </a:rPr>
-              <a:t>   研究強調氧化壓力與炎症在結直腸癌生物學中的中心角色，這一發現可能為未來的治療策略提供新的靶點。  </a:t>
+              <a:t>4. **預測指標的應用**  </a:t>
             </a:r>
             <a:endParaRPr lang="en-US" sz="1200" dirty="0"/>
           </a:p>
@@ -3775,7 +3851,67 @@
                   <a:srgbClr val="FFFFFF"/>
                 </a:solidFill>
               </a:rPr>
-              <a:t>   Research highlights the central role of oxidative stress and inflammation in colorectal cancer biology, which may provide new targets for future therapeutic strategies.</a:t>
+              <a:t>   The C-reactive protein-albumin-lymphocyte (CALLY) index shows promise as a predictive marker for colorectal cancer outcomes, indicating the importance of inflammatory markers in prognostication.  </a:t>
+            </a:r>
+            <a:endParaRPr lang="en-US" sz="1200" dirty="0"/>
+          </a:p>
+          <a:p>
+            <a:pPr indent="0" marL="0">
+              <a:lnSpc>
+                <a:spcPct val="150000"/>
+              </a:lnSpc>
+              <a:buNone/>
+            </a:pPr>
+            <a:r>
+              <a:rPr lang="en-US" sz="1200" dirty="0">
+                <a:solidFill>
+                  <a:srgbClr val="FFFFFF"/>
+                </a:solidFill>
+              </a:rPr>
+              <a:t>   C-反應蛋白-白蛋白-淋巴細胞（CALLY）指數顯示出作為結腸直腸癌預後標記的潛力，表明炎症標記在預後中的重要性。</a:t>
+            </a:r>
+            <a:endParaRPr lang="en-US" sz="1200" dirty="0"/>
+          </a:p>
+          <a:p>
+            <a:pPr indent="0" marL="0">
+              <a:lnSpc>
+                <a:spcPct val="150000"/>
+              </a:lnSpc>
+              <a:buNone/>
+            </a:pPr>
+            <a:endParaRPr lang="en-US" sz="1200" dirty="0"/>
+          </a:p>
+          <a:p>
+            <a:pPr indent="0" marL="0">
+              <a:lnSpc>
+                <a:spcPct val="150000"/>
+              </a:lnSpc>
+              <a:buNone/>
+            </a:pPr>
+            <a:r>
+              <a:rPr lang="en-US" sz="1200" dirty="0">
+                <a:solidFill>
+                  <a:srgbClr val="FFFFFF"/>
+                </a:solidFill>
+              </a:rPr>
+              <a:t>5. **新型治療策略的探索**  </a:t>
+            </a:r>
+            <a:endParaRPr lang="en-US" sz="1200" dirty="0"/>
+          </a:p>
+          <a:p>
+            <a:pPr indent="0" marL="0">
+              <a:lnSpc>
+                <a:spcPct val="150000"/>
+              </a:lnSpc>
+              <a:buNone/>
+            </a:pPr>
+            <a:r>
+              <a:rPr lang="en-US" sz="1200" dirty="0">
+                <a:solidFill>
+                  <a:srgbClr val="FFFFFF"/>
+                </a:solidFill>
+              </a:rPr>
+              <a:t>   Emerging therapies targeting mitochondrial pathways and programmed cell death mechanisms represent innovative approaches to overcoming resistance in microsatellite stable colorectal cancer.</a:t>
             </a:r>
             <a:endParaRPr lang="en-US" sz="1200" dirty="0"/>
           </a:p>
@@ -3921,7 +4057,7 @@
                   <a:srgbClr val="FFFFFF"/>
                 </a:solidFill>
               </a:rPr>
-              <a:t>### 未來研究方向 (Future Research Directions)</a:t>
+              <a:t>新興的針對線粒體途徑和程序性細胞死亡機制的治療策略代表了克服微衛星穩定型結腸直腸癌耐藥性的新方法。</a:t>
             </a:r>
             <a:endParaRPr lang="en-US" sz="1200" dirty="0"/>
           </a:p>
@@ -3947,7 +4083,7 @@
                   <a:srgbClr val="FFFFFF"/>
                 </a:solidFill>
               </a:rPr>
-              <a:t>1. **個體化化療策略的發展**  </a:t>
+              <a:t>### 未來研究方向 (Future Research Directions)</a:t>
             </a:r>
             <a:endParaRPr lang="en-US" sz="1200" dirty="0"/>
           </a:p>
@@ -3958,14 +4094,6 @@
               </a:lnSpc>
               <a:buNone/>
             </a:pPr>
-            <a:r>
-              <a:rPr lang="en-US" sz="1200" dirty="0">
-                <a:solidFill>
-                  <a:srgbClr val="FFFFFF"/>
-                </a:solidFill>
-              </a:rPr>
-              <a:t>   **Development of personalized chemotherapy strategies**  </a:t>
-            </a:r>
             <a:endParaRPr lang="en-US" sz="1200" dirty="0"/>
           </a:p>
           <a:p>
@@ -3981,7 +4109,7 @@
                   <a:srgbClr val="FFFFFF"/>
                 </a:solidFill>
               </a:rPr>
-              <a:t>   需要進一步研究基於患者來源的器官類器官的藥物篩選平台，以制定針對結直腸癌腹膜轉移的個體化化療方案。  </a:t>
+              <a:t>1. **免疫療法組合策略**  </a:t>
             </a:r>
             <a:endParaRPr lang="en-US" sz="1200" dirty="0"/>
           </a:p>
@@ -3998,7 +4126,7 @@
                   <a:srgbClr val="FFFFFF"/>
                 </a:solidFill>
               </a:rPr>
-              <a:t>   Further studies are needed to develop personalized chemotherapy strategies based on drug screening platforms using patient-derived organoids for colorectal cancer peritoneal metastases.</a:t>
+              <a:t>   Investigating the synergistic effects of combining immune checkpoint inhibitors with anti-inflammatory agents like celecoxib in various colorectal cancer subtypes could enhance therapeutic efficacy.  </a:t>
             </a:r>
             <a:endParaRPr lang="en-US" sz="1200" dirty="0"/>
           </a:p>
@@ -4009,6 +4137,14 @@
               </a:lnSpc>
               <a:buNone/>
             </a:pPr>
+            <a:r>
+              <a:rPr lang="en-US" sz="1200" dirty="0">
+                <a:solidFill>
+                  <a:srgbClr val="FFFFFF"/>
+                </a:solidFill>
+              </a:rPr>
+              <a:t>   探索將免疫檢查點抑制劑與抗炎劑如celecoxib結合的協同效應在不同結腸直腸癌亞型中的應用，可能提高療效。</a:t>
+            </a:r>
             <a:endParaRPr lang="en-US" sz="1200" dirty="0"/>
           </a:p>
           <a:p>
@@ -4018,14 +4154,6 @@
               </a:lnSpc>
               <a:buNone/>
             </a:pPr>
-            <a:r>
-              <a:rPr lang="en-US" sz="1200" dirty="0">
-                <a:solidFill>
-                  <a:srgbClr val="FFFFFF"/>
-                </a:solidFill>
-              </a:rPr>
-              <a:t>2. **炎症性腸病與結直腸癌風險的認知**  </a:t>
-            </a:r>
             <a:endParaRPr lang="en-US" sz="1200" dirty="0"/>
           </a:p>
           <a:p>
@@ -4041,7 +4169,7 @@
                   <a:srgbClr val="FFFFFF"/>
                 </a:solidFill>
               </a:rPr>
-              <a:t>   **Awareness of inflammatory bowel disease and colorectal cancer risk**  </a:t>
+              <a:t>2. **微生物組的調節**  </a:t>
             </a:r>
             <a:endParaRPr lang="en-US" sz="1200" dirty="0"/>
           </a:p>
@@ -4058,7 +4186,7 @@
                   <a:srgbClr val="FFFFFF"/>
                 </a:solidFill>
               </a:rPr>
-              <a:t>   針對炎症性腸病患者對結直腸癌風險及其管理的認知進行深入調查，以促進患者教育和早期干預。  </a:t>
+              <a:t>   Future studies should focus on the manipulation of gut microbiota to assess its impact on treatment responses in colorectal cancer, particularly in patients with inflammatory bowel disease.  </a:t>
             </a:r>
             <a:endParaRPr lang="en-US" sz="1200" dirty="0"/>
           </a:p>
@@ -4075,7 +4203,7 @@
                   <a:srgbClr val="FFFFFF"/>
                 </a:solidFill>
               </a:rPr>
-              <a:t>   In-depth investigations on the awareness of colorectal cancer risk and management among patients with inflammatory bowel disease are necessary to enhance patient education and early intervention.</a:t>
+              <a:t>   未來的研究應集中於調節腸道微生物，以評估其對結腸直腸癌治療反應的影響，特別是在炎症性腸病患者中。</a:t>
             </a:r>
             <a:endParaRPr lang="en-US" sz="1200" dirty="0"/>
           </a:p>
@@ -4101,7 +4229,7 @@
                   <a:srgbClr val="FFFFFF"/>
                 </a:solidFill>
               </a:rPr>
-              <a:t>3. **新型治療策略的探索**  </a:t>
+              <a:t>3. **炎症標記的臨床應用**  </a:t>
             </a:r>
             <a:endParaRPr lang="en-US" sz="1200" dirty="0"/>
           </a:p>
@@ -4118,7 +4246,7 @@
                   <a:srgbClr val="FFFFFF"/>
                 </a:solidFill>
               </a:rPr>
-              <a:t>   **Exploration of novel therapeutic strategies**  </a:t>
+              <a:t>   Further validation of the CALLY index and other inflammatory biomarkers in diverse populations could refine prognostic models and guide personalized treatment approaches.  </a:t>
             </a:r>
             <a:endParaRPr lang="en-US" sz="1200" dirty="0"/>
           </a:p>
@@ -4135,7 +4263,7 @@
                   <a:srgbClr val="FFFFFF"/>
                 </a:solidFill>
               </a:rPr>
-              <a:t>   研究如阿莫西林等新型藥物對結直腸癌的潛在療效，尤其是其在氧化壓力和炎症交互作用中的角色。  </a:t>
+              <a:t>   在不同人群中進一步驗證CALLY指數和其他炎症生物標記，可能有助於完善預後模型並指導個性化治療方案。</a:t>
             </a:r>
             <a:endParaRPr lang="en-US" sz="1200" dirty="0"/>
           </a:p>
@@ -4146,13 +4274,116 @@
               </a:lnSpc>
               <a:buNone/>
             </a:pPr>
+            <a:endParaRPr lang="en-US" sz="1200" dirty="0"/>
+          </a:p>
+          <a:p>
+            <a:pPr indent="0" marL="0">
+              <a:lnSpc>
+                <a:spcPct val="150000"/>
+              </a:lnSpc>
+              <a:buNone/>
+            </a:pPr>
             <a:r>
               <a:rPr lang="en-US" sz="1200" dirty="0">
                 <a:solidFill>
                   <a:srgbClr val="FFFFFF"/>
                 </a:solidFill>
               </a:rPr>
-              <a:t>   Investigating the potential efficacy of novel drugs such as artemisinin in colorectal cancer, particularly their roles in oxidative stress and inflammation crosstalk, is warranted.</a:t>
+              <a:t>4. **腫瘤微環境的研究**  </a:t>
+            </a:r>
+            <a:endParaRPr lang="en-US" sz="1200" dirty="0"/>
+          </a:p>
+          <a:p>
+            <a:pPr indent="0" marL="0">
+              <a:lnSpc>
+                <a:spcPct val="150000"/>
+              </a:lnSpc>
+              <a:buNone/>
+            </a:pPr>
+            <a:r>
+              <a:rPr lang="en-US" sz="1200" dirty="0">
+                <a:solidFill>
+                  <a:srgbClr val="FFFFFF"/>
+                </a:solidFill>
+              </a:rPr>
+              <a:t>   Comprehensive studies on the tumor microenvironment's heterogeneity and its influence on immune responses will be crucial for developing tailored immunotherapies.  </a:t>
+            </a:r>
+            <a:endParaRPr lang="en-US" sz="1200" dirty="0"/>
+          </a:p>
+          <a:p>
+            <a:pPr indent="0" marL="0">
+              <a:lnSpc>
+                <a:spcPct val="150000"/>
+              </a:lnSpc>
+              <a:buNone/>
+            </a:pPr>
+            <a:r>
+              <a:rPr lang="en-US" sz="1200" dirty="0">
+                <a:solidFill>
+                  <a:srgbClr val="FFFFFF"/>
+                </a:solidFill>
+              </a:rPr>
+              <a:t>   對腫瘤微環境的異質性及其對免疫反應影響的綜合研究將對開發量身定制的免疫療法至關重要。</a:t>
+            </a:r>
+            <a:endParaRPr lang="en-US" sz="1200" dirty="0"/>
+          </a:p>
+          <a:p>
+            <a:pPr indent="0" marL="0">
+              <a:lnSpc>
+                <a:spcPct val="150000"/>
+              </a:lnSpc>
+              <a:buNone/>
+            </a:pPr>
+            <a:endParaRPr lang="en-US" sz="1200" dirty="0"/>
+          </a:p>
+          <a:p>
+            <a:pPr indent="0" marL="0">
+              <a:lnSpc>
+                <a:spcPct val="150000"/>
+              </a:lnSpc>
+              <a:buNone/>
+            </a:pPr>
+            <a:r>
+              <a:rPr lang="en-US" sz="1200" dirty="0">
+                <a:solidFill>
+                  <a:srgbClr val="FFFFFF"/>
+                </a:solidFill>
+              </a:rPr>
+              <a:t>5. **新型治療機制的探索**  </a:t>
+            </a:r>
+            <a:endParaRPr lang="en-US" sz="1200" dirty="0"/>
+          </a:p>
+          <a:p>
+            <a:pPr indent="0" marL="0">
+              <a:lnSpc>
+                <a:spcPct val="150000"/>
+              </a:lnSpc>
+              <a:buNone/>
+            </a:pPr>
+            <a:r>
+              <a:rPr lang="en-US" sz="1200" dirty="0">
+                <a:solidFill>
+                  <a:srgbClr val="FFFFFF"/>
+                </a:solidFill>
+              </a:rPr>
+              <a:t>   Continued exploration of mitochondrial-targeting therapies and their role in enhancing immune responses in colorectal cancer could lead to novel treatment paradigms.  </a:t>
+            </a:r>
+            <a:endParaRPr lang="en-US" sz="1200" dirty="0"/>
+          </a:p>
+          <a:p>
+            <a:pPr indent="0" marL="0">
+              <a:lnSpc>
+                <a:spcPct val="150000"/>
+              </a:lnSpc>
+              <a:buNone/>
+            </a:pPr>
+            <a:r>
+              <a:rPr lang="en-US" sz="1200" dirty="0">
+                <a:solidFill>
+                  <a:srgbClr val="FFFFFF"/>
+                </a:solidFill>
+              </a:rPr>
+              <a:t>   繼續探索針對線粒體的治療及其在增強結腸直腸癌免疫反應中的作用，可能會導致新型治療範式的出現。</a:t>
             </a:r>
             <a:endParaRPr lang="en-US" sz="1200" dirty="0"/>
           </a:p>
@@ -4386,7 +4617,7 @@
                 <a:ea typeface="Arial" pitchFamily="34" charset="-122"/>
                 <a:cs typeface="Arial" pitchFamily="34" charset="-120"/>
               </a:rPr>
-              <a:t>ORCHESTRA hits a sour note for debulking in metastatic colorectal cancer</a:t>
+              <a:t>Neoadjuvant toripalimab plus celecoxib versus toripalimab monotherapy for mismat…</a:t>
             </a:r>
             <a:endParaRPr lang="en-US" sz="1400" dirty="0"/>
           </a:p>
@@ -4423,7 +4654,7 @@
                 <a:ea typeface="Arial" pitchFamily="34" charset="-122"/>
                 <a:cs typeface="Arial" pitchFamily="34" charset="-120"/>
               </a:rPr>
-              <a:t>Effect of hyperthermic intraperitoneal chemotherapy on patients with advanced co…</a:t>
+              <a:t>Diarylheptanoid Phytoestrogen from Curcuma comosa Attenuates Colitis and Colitis…</a:t>
             </a:r>
             <a:endParaRPr lang="en-US" sz="1400" dirty="0"/>
           </a:p>
@@ -4460,7 +4691,7 @@
                 <a:ea typeface="Arial" pitchFamily="34" charset="-122"/>
                 <a:cs typeface="Arial" pitchFamily="34" charset="-120"/>
               </a:rPr>
-              <a:t>Prognostic value of systemic immune-inflammation index for colorectal cancer: a …</a:t>
+              <a:t>Probiotics may not adhere to gut and provide benefits in inflammatory bowel dise…</a:t>
             </a:r>
             <a:endParaRPr lang="en-US" sz="1400" dirty="0"/>
           </a:p>
@@ -4497,7 +4728,7 @@
                 <a:ea typeface="Arial" pitchFamily="34" charset="-122"/>
                 <a:cs typeface="Arial" pitchFamily="34" charset="-120"/>
               </a:rPr>
-              <a:t>Anticancer and Anti-Inflammatory Potential of Betalains: A Systematic Review on …</a:t>
+              <a:t>IGHG1&amp;#x207a; plasma cells define an NF-&amp;#x3ba;B-driven inflammatory program tha…</a:t>
             </a:r>
             <a:endParaRPr lang="en-US" sz="1400" dirty="0"/>
           </a:p>
@@ -4534,7 +4765,7 @@
                 <a:ea typeface="Arial" pitchFamily="34" charset="-122"/>
                 <a:cs typeface="Arial" pitchFamily="34" charset="-120"/>
               </a:rPr>
-              <a:t>Oxidative Stress and Inflammation in Colorectal Cancer–Redox–Immune Crosstalk, B…</a:t>
+              <a:t>Mitochondria-Targeting Iridium(III) Complexes Induce PANoptosis and Ferroptosis …</a:t>
             </a:r>
             <a:endParaRPr lang="en-US" sz="1400" dirty="0"/>
           </a:p>
@@ -4571,7 +4802,7 @@
                 <a:ea typeface="Arial" pitchFamily="34" charset="-122"/>
                 <a:cs typeface="Arial" pitchFamily="34" charset="-120"/>
               </a:rPr>
-              <a:t>Awareness of inflammatory bowel disease-associated colorectal cancer risk and it…</a:t>
+              <a:t>NKR+CD8+ T cells and iNKT cells protect mice from AOM/DSS-induced colorectal can…</a:t>
             </a:r>
             <a:endParaRPr lang="en-US" sz="1400" dirty="0"/>
           </a:p>
@@ -4608,7 +4839,7 @@
                 <a:ea typeface="Arial" pitchFamily="34" charset="-122"/>
                 <a:cs typeface="Arial" pitchFamily="34" charset="-120"/>
               </a:rPr>
-              <a:t>Mechanistic Insights Into Dose-Dependent Alleviation of Colorectal Cancer Throug…</a:t>
+              <a:t>Predictive utility of the C-reactive protein-albumin-lymphocyte (CALLY) index in…</a:t>
             </a:r>
             <a:endParaRPr lang="en-US" sz="1400" dirty="0"/>
           </a:p>
@@ -4645,7 +4876,7 @@
                 <a:ea typeface="Arial" pitchFamily="34" charset="-122"/>
                 <a:cs typeface="Arial" pitchFamily="34" charset="-120"/>
               </a:rPr>
-              <a:t>KLK7 overexpression promotes an aggressive phenotype and facilitates peritoneal …</a:t>
+              <a:t>Combining genotoxic gut bacterial strains increases tumor burden and accelerates…</a:t>
             </a:r>
             <a:endParaRPr lang="en-US" sz="1400" dirty="0"/>
           </a:p>
@@ -4682,7 +4913,7 @@
                 <a:ea typeface="Arial" pitchFamily="34" charset="-122"/>
                 <a:cs typeface="Arial" pitchFamily="34" charset="-120"/>
               </a:rPr>
-              <a:t>The barrier–microbiota–inflammation axis in colorectal cancer: Mechanisms and em…</a:t>
+              <a:t>Immediate Second Look After Cytoreduction for Colorectal or Ovarian Carcinomatos…</a:t>
             </a:r>
             <a:endParaRPr lang="en-US" sz="1400" dirty="0"/>
           </a:p>
@@ -4719,7 +4950,7 @@
                 <a:ea typeface="Arial" pitchFamily="34" charset="-122"/>
                 <a:cs typeface="Arial" pitchFamily="34" charset="-120"/>
               </a:rPr>
-              <a:t>The Mechanism of Acetyl-L-Carnitine on Colorectal Cancer and Its Metabolomic Stu…</a:t>
+              <a:t>Incidence and outcomes of metachronous peritoneal metastasis in the setting of o…</a:t>
             </a:r>
             <a:endParaRPr lang="en-US" sz="1400" dirty="0"/>
           </a:p>
@@ -4874,7 +5105,7 @@
                   </a:extLst>
                 </a:hlinkClick>
               </a:rPr>
-              <a:t>ORCHESTRA hits a sour note for debulking in metastatic colorectal cancer</a:t>
+              <a:t>Neoadjuvant toripalimab plus celecoxib versus toripalimab monotherapy for mismatch repair-deficient or microsatellite instability-high, locally advanced colorectal cancer (PICC-2): an open-label, multicentre, randomised, phase 2 trial.</a:t>
             </a:r>
             <a:endParaRPr lang="en-US" sz="2400" dirty="0"/>
           </a:p>
@@ -4910,7 +5141,7 @@
                   <a:srgbClr val="888888"/>
                 </a:solidFill>
               </a:rPr>
-              <a:t>JAMA  ·  IF 63.1</a:t>
+              <a:t>The Lancet. Oncology  ·  IF 41.6  ·  RCT Phase 3</a:t>
             </a:r>
             <a:endParaRPr lang="en-US" sz="1000" dirty="0"/>
           </a:p>
@@ -4953,7 +5184,7 @@
                 <a:ea typeface="Arial" pitchFamily="34" charset="-122"/>
                 <a:cs typeface="Arial" pitchFamily="34" charset="-120"/>
               </a:rPr>
-              <a:t>Cytoreductive surgery evaluated in study</a:t>
+              <a:t>Neoadjuvant toripalimab plus celecoxib tested</a:t>
             </a:r>
             <a:endParaRPr lang="en-US" sz="1800" dirty="0"/>
           </a:p>
@@ -4974,7 +5205,7 @@
                 <a:ea typeface="Arial" pitchFamily="34" charset="-122"/>
                 <a:cs typeface="Arial" pitchFamily="34" charset="-120"/>
               </a:rPr>
-              <a:t>Hyperthermic intraperitoneal chemotherapy added</a:t>
+              <a:t>Significant increase in pathological complete response</a:t>
             </a:r>
             <a:endParaRPr lang="en-US" sz="1800" dirty="0"/>
           </a:p>
@@ -4995,49 +5226,7 @@
                 <a:ea typeface="Arial" pitchFamily="34" charset="-122"/>
                 <a:cs typeface="Arial" pitchFamily="34" charset="-120"/>
               </a:rPr>
-              <a:t>Focus on colorectal peritoneal metastases</a:t>
-            </a:r>
-            <a:endParaRPr lang="en-US" sz="1800" dirty="0"/>
-          </a:p>
-          <a:p>
-            <a:pPr marL="342900" indent="-342900">
-              <a:spcAft>
-                <a:spcPts val="800"/>
-              </a:spcAft>
-              <a:buSzPct val="100000"/>
-              <a:buChar char="•"/>
-            </a:pPr>
-            <a:r>
-              <a:rPr lang="en-US" sz="1800" dirty="0">
-                <a:solidFill>
-                  <a:srgbClr val="333333"/>
-                </a:solidFill>
-                <a:latin typeface="Arial" pitchFamily="34" charset="0"/>
-                <a:ea typeface="Arial" pitchFamily="34" charset="-122"/>
-                <a:cs typeface="Arial" pitchFamily="34" charset="-120"/>
-              </a:rPr>
-              <a:t>Multicentre, randomised trial design</a:t>
-            </a:r>
-            <a:endParaRPr lang="en-US" sz="1800" dirty="0"/>
-          </a:p>
-          <a:p>
-            <a:pPr marL="342900" indent="-342900">
-              <a:spcAft>
-                <a:spcPts val="800"/>
-              </a:spcAft>
-              <a:buSzPct val="100000"/>
-              <a:buChar char="•"/>
-            </a:pPr>
-            <a:r>
-              <a:rPr lang="en-US" sz="1800" dirty="0">
-                <a:solidFill>
-                  <a:srgbClr val="333333"/>
-                </a:solidFill>
-                <a:latin typeface="Arial" pitchFamily="34" charset="0"/>
-                <a:ea typeface="Arial" pitchFamily="34" charset="-122"/>
-                <a:cs typeface="Arial" pitchFamily="34" charset="-120"/>
-              </a:rPr>
-              <a:t>Results show no significant benefit</a:t>
+              <a:t>Similar safety profile observed in both groups</a:t>
             </a:r>
             <a:endParaRPr lang="en-US" sz="1800" dirty="0"/>
           </a:p>
@@ -5073,7 +5262,7 @@
                   <a:srgbClr val="888888"/>
                 </a:solidFill>
               </a:rPr>
-              <a:t>M Fakih. JAMA. 2026</a:t>
+              <a:t>Hu Huabin, Shen Xutao, Li Yunfeng et al.. The Lancet. Oncology. 2026-07-27 DOI: 10.1016/S1470-2045(26)00220-2</a:t>
             </a:r>
             <a:endParaRPr lang="en-US" sz="800" dirty="0"/>
           </a:p>
@@ -5273,7 +5462,7 @@
                   </a:extLst>
                 </a:hlinkClick>
               </a:rPr>
-              <a:t>Effect of hyperthermic intraperitoneal chemotherapy on patients with advanced colorectal cancer: a systematic review and meta-analysis</a:t>
+              <a:t>Diarylheptanoid Phytoestrogen from Curcuma comosa Attenuates Colitis and Colitis-Associated Colorectal Cancer by Inhibiting Inflammation and Oxidative Stress and Modulating Gut Microbiota.</a:t>
             </a:r>
             <a:endParaRPr lang="en-US" sz="2400" dirty="0"/>
           </a:p>
@@ -5309,7 +5498,7 @@
                   <a:srgbClr val="888888"/>
                 </a:solidFill>
               </a:rPr>
-              <a:t>World Journal of …  ·  Meta-Analysis</a:t>
+              <a:t>Journal of agricultural and food chemistry  ·  RCT Phase 2  ·  🌏 Asia</a:t>
             </a:r>
             <a:endParaRPr lang="en-US" sz="1000" dirty="0"/>
           </a:p>
@@ -5352,7 +5541,7 @@
                 <a:ea typeface="Arial" pitchFamily="34" charset="-122"/>
                 <a:cs typeface="Arial" pitchFamily="34" charset="-120"/>
               </a:rPr>
-              <a:t>Hyperthermic intraperitoneal chemotherapy (HIPEC) evaluated</a:t>
+              <a:t>Diarylheptanoids reduce colitis symptoms.</a:t>
             </a:r>
             <a:endParaRPr lang="en-US" sz="1800" dirty="0"/>
           </a:p>
@@ -5373,7 +5562,7 @@
                 <a:ea typeface="Arial" pitchFamily="34" charset="-122"/>
                 <a:cs typeface="Arial" pitchFamily="34" charset="-120"/>
               </a:rPr>
-              <a:t>Advanced colorectal cancer patients included</a:t>
+              <a:t>DPH inhibits inflammation and oxidative stress.</a:t>
             </a:r>
             <a:endParaRPr lang="en-US" sz="1800" dirty="0"/>
           </a:p>
@@ -5394,49 +5583,7 @@
                 <a:ea typeface="Arial" pitchFamily="34" charset="-122"/>
                 <a:cs typeface="Arial" pitchFamily="34" charset="-120"/>
               </a:rPr>
-              <a:t>Systematic review and meta-analysis conducted</a:t>
-            </a:r>
-            <a:endParaRPr lang="en-US" sz="1800" dirty="0"/>
-          </a:p>
-          <a:p>
-            <a:pPr marL="342900" indent="-342900">
-              <a:spcAft>
-                <a:spcPts val="800"/>
-              </a:spcAft>
-              <a:buSzPct val="100000"/>
-              <a:buChar char="•"/>
-            </a:pPr>
-            <a:r>
-              <a:rPr lang="en-US" sz="1800" dirty="0">
-                <a:solidFill>
-                  <a:srgbClr val="333333"/>
-                </a:solidFill>
-                <a:latin typeface="Arial" pitchFamily="34" charset="0"/>
-                <a:ea typeface="Arial" pitchFamily="34" charset="-122"/>
-                <a:cs typeface="Arial" pitchFamily="34" charset="-120"/>
-              </a:rPr>
-              <a:t>Improved survival rates observed</a:t>
-            </a:r>
-            <a:endParaRPr lang="en-US" sz="1800" dirty="0"/>
-          </a:p>
-          <a:p>
-            <a:pPr marL="342900" indent="-342900">
-              <a:spcAft>
-                <a:spcPts val="800"/>
-              </a:spcAft>
-              <a:buSzPct val="100000"/>
-              <a:buChar char="•"/>
-            </a:pPr>
-            <a:r>
-              <a:rPr lang="en-US" sz="1800" dirty="0">
-                <a:solidFill>
-                  <a:srgbClr val="333333"/>
-                </a:solidFill>
-                <a:latin typeface="Arial" pitchFamily="34" charset="0"/>
-                <a:ea typeface="Arial" pitchFamily="34" charset="-122"/>
-                <a:cs typeface="Arial" pitchFamily="34" charset="-120"/>
-              </a:rPr>
-              <a:t>Potential for personalized treatment strategies</a:t>
+              <a:t>Modulates gut microbiota for health benefits.</a:t>
             </a:r>
             <a:endParaRPr lang="en-US" sz="1800" dirty="0"/>
           </a:p>
@@ -5472,7 +5619,7 @@
                   <a:srgbClr val="888888"/>
                 </a:solidFill>
               </a:rPr>
-              <a:t>Z Su, Y Guo, X Ru. World Journal of …. 2026</a:t>
+              <a:t>Truong Van-Long, Rarison Razanamanana H G, Song Eun-Ji et al.. Journal of agricultural and food chemistry. 2026-07-29 DOI: 10.1021/acs.jafc.5c17732</a:t>
             </a:r>
             <a:endParaRPr lang="en-US" sz="800" dirty="0"/>
           </a:p>
@@ -5672,7 +5819,7 @@
                   </a:extLst>
                 </a:hlinkClick>
               </a:rPr>
-              <a:t>Prognostic value of systemic immune-inflammation index for colorectal cancer: a systematic review and meta-analysis</a:t>
+              <a:t>Probiotics may not adhere to gut and provide benefits in inflammatory bowel disease patients based on an AOM/DSS murine model.</a:t>
             </a:r>
             <a:endParaRPr lang="en-US" sz="2400" dirty="0"/>
           </a:p>
@@ -5708,7 +5855,7 @@
                   <a:srgbClr val="888888"/>
                 </a:solidFill>
               </a:rPr>
-              <a:t>Frontiers in Oncology  ·  Meta-Analysis</a:t>
+              <a:t>Journal of the Formosan Medical Association = Taiwan yi zhi  ·  Basic Research  ·  🌏 Asia</a:t>
             </a:r>
             <a:endParaRPr lang="en-US" sz="1000" dirty="0"/>
           </a:p>
@@ -5751,7 +5898,7 @@
                 <a:ea typeface="Arial" pitchFamily="34" charset="-122"/>
                 <a:cs typeface="Arial" pitchFamily="34" charset="-120"/>
               </a:rPr>
-              <a:t>Systemic immune-inflammation index (SII) evaluated</a:t>
+              <a:t>Dysbiosis common in IBD patients.</a:t>
             </a:r>
             <a:endParaRPr lang="en-US" sz="1800" dirty="0"/>
           </a:p>
@@ -5772,7 +5919,7 @@
                 <a:ea typeface="Arial" pitchFamily="34" charset="-122"/>
                 <a:cs typeface="Arial" pitchFamily="34" charset="-120"/>
               </a:rPr>
-              <a:t>Prognostic biomarker for colorectal cancer</a:t>
+              <a:t>Akkermansia muciniphila shows promise.</a:t>
             </a:r>
             <a:endParaRPr lang="en-US" sz="1800" dirty="0"/>
           </a:p>
@@ -5793,7 +5940,7 @@
                 <a:ea typeface="Arial" pitchFamily="34" charset="-122"/>
                 <a:cs typeface="Arial" pitchFamily="34" charset="-120"/>
               </a:rPr>
-              <a:t>Meta-analysis of existing studies</a:t>
+              <a:t>AKK treatment showed no significant benefits.</a:t>
             </a:r>
             <a:endParaRPr lang="en-US" sz="1800" dirty="0"/>
           </a:p>
@@ -5814,7 +5961,7 @@
                 <a:ea typeface="Arial" pitchFamily="34" charset="-122"/>
                 <a:cs typeface="Arial" pitchFamily="34" charset="-120"/>
               </a:rPr>
-              <a:t>SII correlates with patient outcomes</a:t>
+              <a:t>Poor adherence in probiotic therapy observed.</a:t>
             </a:r>
             <a:endParaRPr lang="en-US" sz="1800" dirty="0"/>
           </a:p>
@@ -5835,7 +5982,7 @@
                 <a:ea typeface="Arial" pitchFamily="34" charset="-122"/>
                 <a:cs typeface="Arial" pitchFamily="34" charset="-120"/>
               </a:rPr>
-              <a:t>Potential for clinical application</a:t>
+              <a:t>Further research needed on probiotics.</a:t>
             </a:r>
             <a:endParaRPr lang="en-US" sz="1800" dirty="0"/>
           </a:p>
@@ -5871,7 +6018,7 @@
                   <a:srgbClr val="888888"/>
                 </a:solidFill>
               </a:rPr>
-              <a:t>P Wang, H Jiang. Frontiers in Oncology. 2026</a:t>
+              <a:t>Hu Ming-Luen, Wang Feng-Sheng, Lian Wei-Shiung et al.. Journal of the Formosan Medical Association = Taiwan yi zhi. 2026-07-27 DOI: 10.1016/j.jfma.2025.05.010</a:t>
             </a:r>
             <a:endParaRPr lang="en-US" sz="800" dirty="0"/>
           </a:p>
@@ -6071,7 +6218,7 @@
                   </a:extLst>
                 </a:hlinkClick>
               </a:rPr>
-              <a:t>Anticancer and Anti-Inflammatory Potential of Betalains: A Systematic Review on Preclinical Studies.</a:t>
+              <a:t>IGHG1&amp;#x207a; plasma cells define an NF-&amp;#x3ba;B-driven inflammatory program that shapes T-cell immunity and immunotherapy response in colorectal cancer.</a:t>
             </a:r>
             <a:endParaRPr lang="en-US" sz="2400" dirty="0"/>
           </a:p>
@@ -6107,7 +6254,7 @@
                   <a:srgbClr val="888888"/>
                 </a:solidFill>
               </a:rPr>
-              <a:t>Food science &amp; nutrition  ·  Systematic Review</a:t>
+              <a:t>Translational oncology  ·  Basic Research  ·  🌏 Asia</a:t>
             </a:r>
             <a:endParaRPr lang="en-US" sz="1000" dirty="0"/>
           </a:p>
@@ -6150,7 +6297,7 @@
                 <a:ea typeface="Arial" pitchFamily="34" charset="-122"/>
                 <a:cs typeface="Arial" pitchFamily="34" charset="-120"/>
               </a:rPr>
-              <a:t>Betalains show anticancer properties.</a:t>
+              <a:t>IGHG1+ plasma cells enhance T-cell immunity.</a:t>
             </a:r>
             <a:endParaRPr lang="en-US" sz="1800" dirty="0"/>
           </a:p>
@@ -6171,7 +6318,7 @@
                 <a:ea typeface="Arial" pitchFamily="34" charset="-122"/>
                 <a:cs typeface="Arial" pitchFamily="34" charset="-120"/>
               </a:rPr>
-              <a:t>Inhibit colorectal cancer cell growth.</a:t>
+              <a:t>NF-κB pathway drives inflammatory program.</a:t>
             </a:r>
             <a:endParaRPr lang="en-US" sz="1800" dirty="0"/>
           </a:p>
@@ -6192,49 +6339,7 @@
                 <a:ea typeface="Arial" pitchFamily="34" charset="-122"/>
                 <a:cs typeface="Arial" pitchFamily="34" charset="-120"/>
               </a:rPr>
-              <a:t>Induce apoptosis via caspase activation.</a:t>
-            </a:r>
-            <a:endParaRPr lang="en-US" sz="1800" dirty="0"/>
-          </a:p>
-          <a:p>
-            <a:pPr marL="342900" indent="-342900">
-              <a:spcAft>
-                <a:spcPts val="800"/>
-              </a:spcAft>
-              <a:buSzPct val="100000"/>
-              <a:buChar char="•"/>
-            </a:pPr>
-            <a:r>
-              <a:rPr lang="en-US" sz="1800" dirty="0">
-                <a:solidFill>
-                  <a:srgbClr val="333333"/>
-                </a:solidFill>
-                <a:latin typeface="Arial" pitchFamily="34" charset="0"/>
-                <a:ea typeface="Arial" pitchFamily="34" charset="-122"/>
-                <a:cs typeface="Arial" pitchFamily="34" charset="-120"/>
-              </a:rPr>
-              <a:t>Suppress inflammatory signaling pathways.</a:t>
-            </a:r>
-            <a:endParaRPr lang="en-US" sz="1800" dirty="0"/>
-          </a:p>
-          <a:p>
-            <a:pPr marL="342900" indent="-342900">
-              <a:spcAft>
-                <a:spcPts val="800"/>
-              </a:spcAft>
-              <a:buSzPct val="100000"/>
-              <a:buChar char="•"/>
-            </a:pPr>
-            <a:r>
-              <a:rPr lang="en-US" sz="1800" dirty="0">
-                <a:solidFill>
-                  <a:srgbClr val="333333"/>
-                </a:solidFill>
-                <a:latin typeface="Arial" pitchFamily="34" charset="0"/>
-                <a:ea typeface="Arial" pitchFamily="34" charset="-122"/>
-                <a:cs typeface="Arial" pitchFamily="34" charset="-120"/>
-              </a:rPr>
-              <a:t>Low risk of bias in studies.</a:t>
+              <a:t>Signature predicts immunotherapy response.</a:t>
             </a:r>
             <a:endParaRPr lang="en-US" sz="1800" dirty="0"/>
           </a:p>
@@ -6270,7 +6375,7 @@
                   <a:srgbClr val="888888"/>
                 </a:solidFill>
               </a:rPr>
-              <a:t>Fatima Aroob, Sultan Muhammad Tauseef, Awlqadr Farhang Hameed et al.. Food science &amp; nutrition. 2026-07-25 DOI: 10.1002/fsn3.72133</a:t>
+              <a:t>Zhang Rui-Feng, Zhang Wan-Ze, Li He et al.. Translational oncology. 2026-07-27 DOI: 10.1016/j.tranon.2026.102930</a:t>
             </a:r>
             <a:endParaRPr lang="en-US" sz="800" dirty="0"/>
           </a:p>
@@ -6470,7 +6575,7 @@
                   </a:extLst>
                 </a:hlinkClick>
               </a:rPr>
-              <a:t>Oxidative Stress and Inflammation in Colorectal Cancer–Redox–Immune Crosstalk, Biomarkers, and Translational Implications: A Qualitative Systematic Review</a:t>
+              <a:t>Mitochondria-Targeting Iridium(III) Complexes Induce PANoptosis and Ferroptosis for Boosting Chemoimmunotherapy Against Immune-Desert Colorectal Cancer.</a:t>
             </a:r>
             <a:endParaRPr lang="en-US" sz="2400" dirty="0"/>
           </a:p>
@@ -6506,7 +6611,7 @@
                   <a:srgbClr val="888888"/>
                 </a:solidFill>
               </a:rPr>
-              <a:t>Life  ·  Systematic Review</a:t>
+              <a:t>Angewandte Chemie (International ed. in English)  ·  Basic Research  ·  🌏 Asia</a:t>
             </a:r>
             <a:endParaRPr lang="en-US" sz="1000" dirty="0"/>
           </a:p>
@@ -6549,7 +6654,7 @@
                 <a:ea typeface="Arial" pitchFamily="34" charset="-122"/>
                 <a:cs typeface="Arial" pitchFamily="34" charset="-120"/>
               </a:rPr>
-              <a:t>Oxidative stress links to inflammation</a:t>
+              <a:t>MSS-CRC poses chemotherapy challenges.</a:t>
             </a:r>
             <a:endParaRPr lang="en-US" sz="1800" dirty="0"/>
           </a:p>
@@ -6570,7 +6675,7 @@
                 <a:ea typeface="Arial" pitchFamily="34" charset="-122"/>
                 <a:cs typeface="Arial" pitchFamily="34" charset="-120"/>
               </a:rPr>
-              <a:t>Redox-inflammation interplay in CRC</a:t>
+              <a:t>Iridium(III) complexes induce PANoptosis.</a:t>
             </a:r>
             <a:endParaRPr lang="en-US" sz="1800" dirty="0"/>
           </a:p>
@@ -6591,7 +6696,49 @@
                 <a:ea typeface="Arial" pitchFamily="34" charset="-122"/>
                 <a:cs typeface="Arial" pitchFamily="34" charset="-120"/>
               </a:rPr>
-              <a:t>Potential biomarkers for CRC detection</a:t>
+              <a:t>Concurrent ferroptosis boosts immunotherapy.</a:t>
+            </a:r>
+            <a:endParaRPr lang="en-US" sz="1800" dirty="0"/>
+          </a:p>
+          <a:p>
+            <a:pPr marL="342900" indent="-342900">
+              <a:spcAft>
+                <a:spcPts val="800"/>
+              </a:spcAft>
+              <a:buSzPct val="100000"/>
+              <a:buChar char="•"/>
+            </a:pPr>
+            <a:r>
+              <a:rPr lang="en-US" sz="1800" dirty="0">
+                <a:solidFill>
+                  <a:srgbClr val="333333"/>
+                </a:solidFill>
+                <a:latin typeface="Arial" pitchFamily="34" charset="0"/>
+                <a:ea typeface="Arial" pitchFamily="34" charset="-122"/>
+                <a:cs typeface="Arial" pitchFamily="34" charset="-120"/>
+              </a:rPr>
+              <a:t>Mechanism-guided design enhances efficacy.</a:t>
+            </a:r>
+            <a:endParaRPr lang="en-US" sz="1800" dirty="0"/>
+          </a:p>
+          <a:p>
+            <a:pPr marL="342900" indent="-342900">
+              <a:spcAft>
+                <a:spcPts val="800"/>
+              </a:spcAft>
+              <a:buSzPct val="100000"/>
+              <a:buChar char="•"/>
+            </a:pPr>
+            <a:r>
+              <a:rPr lang="en-US" sz="1800" dirty="0">
+                <a:solidFill>
+                  <a:srgbClr val="333333"/>
+                </a:solidFill>
+                <a:latin typeface="Arial" pitchFamily="34" charset="0"/>
+                <a:ea typeface="Arial" pitchFamily="34" charset="-122"/>
+                <a:cs typeface="Arial" pitchFamily="34" charset="-120"/>
+              </a:rPr>
+              <a:t>Proteomic analysis confirms pathway activation.</a:t>
             </a:r>
             <a:endParaRPr lang="en-US" sz="1800" dirty="0"/>
           </a:p>
@@ -6627,7 +6774,7 @@
                   <a:srgbClr val="888888"/>
                 </a:solidFill>
               </a:rPr>
-              <a:t>R Marinescu, D Marinescu, D Preda. Life. 2026</a:t>
+              <a:t>Liu Xing, Feng Tao, Yang Xiaoting et al.. Angewandte Chemie (International ed. in English). 2026-07-29 DOI: 10.1002/anie.3918717</a:t>
             </a:r>
             <a:endParaRPr lang="en-US" sz="800" dirty="0"/>
           </a:p>
@@ -6827,7 +6974,7 @@
                   </a:extLst>
                 </a:hlinkClick>
               </a:rPr>
-              <a:t>Awareness of inflammatory bowel disease-associated colorectal cancer risk and its management in patients with inflammatory bowel disease: a systematic review</a:t>
+              <a:t>NKR+CD8+ T cells and iNKT cells protect mice from AOM/DSS-induced colorectal cancer under conditions of IFN&amp;#x3b3;-mediated hyperinflammation.</a:t>
             </a:r>
             <a:endParaRPr lang="en-US" sz="2400" dirty="0"/>
           </a:p>
@@ -6863,7 +7010,7 @@
                   <a:srgbClr val="888888"/>
                 </a:solidFill>
               </a:rPr>
-              <a:t>Crohns &amp; Colitis 360  ·  Systematic Review</a:t>
+              <a:t>Inflammation research : official journal of the European Histamine Research Society ... [et al.]  ·  🌏 Asia</a:t>
             </a:r>
             <a:endParaRPr lang="en-US" sz="1000" dirty="0"/>
           </a:p>
@@ -6906,7 +7053,7 @@
                 <a:ea typeface="Arial" pitchFamily="34" charset="-122"/>
                 <a:cs typeface="Arial" pitchFamily="34" charset="-120"/>
               </a:rPr>
-              <a:t>Limited awareness of colorectal cancer risk</a:t>
+              <a:t>NKR+CD8+ T cells enhance anti-tumor immunity.</a:t>
             </a:r>
             <a:endParaRPr lang="en-US" sz="1800" dirty="0"/>
           </a:p>
@@ -6927,7 +7074,7 @@
                 <a:ea typeface="Arial" pitchFamily="34" charset="-122"/>
                 <a:cs typeface="Arial" pitchFamily="34" charset="-120"/>
               </a:rPr>
-              <a:t>Need for better patient education strategies</a:t>
+              <a:t>iNKT cells crucial for CRC control.</a:t>
             </a:r>
             <a:endParaRPr lang="en-US" sz="1800" dirty="0"/>
           </a:p>
@@ -6948,7 +7095,7 @@
                 <a:ea typeface="Arial" pitchFamily="34" charset="-122"/>
                 <a:cs typeface="Arial" pitchFamily="34" charset="-120"/>
               </a:rPr>
-              <a:t>Research gaps in management practices</a:t>
+              <a:t>IFN-gamma mediates hyperinflammation effects.</a:t>
             </a:r>
             <a:endParaRPr lang="en-US" sz="1800" dirty="0"/>
           </a:p>
@@ -6984,7 +7131,7 @@
                   <a:srgbClr val="888888"/>
                 </a:solidFill>
               </a:rPr>
-              <a:t>F Khan, C Norton, W Czuber-Dochan. Crohns &amp; Colitis 360. 2026</a:t>
+              <a:t>Park Hyun Jung, Lee Sung Won, Park Yun Hoo et al.. Inflammation research : official journal of the European Histamine Research Society ... [et al.]. 2026-07-31 DOI: 10.1007/s00011-026-02325-3</a:t>
             </a:r>
             <a:endParaRPr lang="en-US" sz="800" dirty="0"/>
           </a:p>
@@ -7184,7 +7331,7 @@
                   </a:extLst>
                 </a:hlinkClick>
               </a:rPr>
-              <a:t>Mechanistic Insights Into Dose-Dependent Alleviation of Colorectal Cancer Through Artemisinin-Loaded Mesoporous Silica Nanoparticles in 1,2-Dimethylhydrazine-Induced Albino Wistar Rats.</a:t>
+              <a:t>Predictive utility of the C-reactive protein-albumin-lymphocyte (CALLY) index in Colorectal cancer: A meta-analysis</a:t>
             </a:r>
             <a:endParaRPr lang="en-US" sz="2400" dirty="0"/>
           </a:p>
@@ -7220,7 +7367,7 @@
                   <a:srgbClr val="888888"/>
                 </a:solidFill>
               </a:rPr>
-              <a:t>Dose-response : a publication of International Hormesis Society  ·  Basic Research</a:t>
+              <a:t>Clinics and Research in Hepatology and …  ·  Meta-Analysis</a:t>
             </a:r>
             <a:endParaRPr lang="en-US" sz="1000" dirty="0"/>
           </a:p>
@@ -7263,7 +7410,7 @@
                 <a:ea typeface="Arial" pitchFamily="34" charset="-122"/>
                 <a:cs typeface="Arial" pitchFamily="34" charset="-120"/>
               </a:rPr>
-              <a:t>Artemisinin-loaded MSNPs synthesized via sol-gel method.</a:t>
+              <a:t>CALLY index predicts colorectal cancer outcomes.</a:t>
             </a:r>
             <a:endParaRPr lang="en-US" sz="1800" dirty="0"/>
           </a:p>
@@ -7284,7 +7431,7 @@
                 <a:ea typeface="Arial" pitchFamily="34" charset="-122"/>
                 <a:cs typeface="Arial" pitchFamily="34" charset="-120"/>
               </a:rPr>
-              <a:t>In vivo study on DMH-induced colorectal tumors.</a:t>
+              <a:t>Inflammation and immune function are crucial.</a:t>
             </a:r>
             <a:endParaRPr lang="en-US" sz="1800" dirty="0"/>
           </a:p>
@@ -7305,49 +7452,7 @@
                 <a:ea typeface="Arial" pitchFamily="34" charset="-122"/>
                 <a:cs typeface="Arial" pitchFamily="34" charset="-120"/>
               </a:rPr>
-              <a:t>Significant tumor suppression at 100 mg/kg dose.</a:t>
-            </a:r>
-            <a:endParaRPr lang="en-US" sz="1800" dirty="0"/>
-          </a:p>
-          <a:p>
-            <a:pPr marL="342900" indent="-342900">
-              <a:spcAft>
-                <a:spcPts val="800"/>
-              </a:spcAft>
-              <a:buSzPct val="100000"/>
-              <a:buChar char="•"/>
-            </a:pPr>
-            <a:r>
-              <a:rPr lang="en-US" sz="1800" dirty="0">
-                <a:solidFill>
-                  <a:srgbClr val="333333"/>
-                </a:solidFill>
-                <a:latin typeface="Arial" pitchFamily="34" charset="0"/>
-                <a:ea typeface="Arial" pitchFamily="34" charset="-122"/>
-                <a:cs typeface="Arial" pitchFamily="34" charset="-120"/>
-              </a:rPr>
-              <a:t>Controlled drug release observed in vitro.</a:t>
-            </a:r>
-            <a:endParaRPr lang="en-US" sz="1800" dirty="0"/>
-          </a:p>
-          <a:p>
-            <a:pPr marL="342900" indent="-342900">
-              <a:spcAft>
-                <a:spcPts val="800"/>
-              </a:spcAft>
-              <a:buSzPct val="100000"/>
-              <a:buChar char="•"/>
-            </a:pPr>
-            <a:r>
-              <a:rPr lang="en-US" sz="1800" dirty="0">
-                <a:solidFill>
-                  <a:srgbClr val="333333"/>
-                </a:solidFill>
-                <a:latin typeface="Arial" pitchFamily="34" charset="0"/>
-                <a:ea typeface="Arial" pitchFamily="34" charset="-122"/>
-                <a:cs typeface="Arial" pitchFamily="34" charset="-120"/>
-              </a:rPr>
-              <a:t>Potential for targeted colorectal cancer therapy.</a:t>
+              <a:t>Meta-analysis supports CALLY's clinical utility.</a:t>
             </a:r>
             <a:endParaRPr lang="en-US" sz="1800" dirty="0"/>
           </a:p>
@@ -7383,7 +7488,7 @@
                   <a:srgbClr val="888888"/>
                 </a:solidFill>
               </a:rPr>
-              <a:t>Zahid Fatima, Ilyas Umair, Zahid Sara et al.. Dose-response : a publication of International Hormesis Society. 2026-07-25 DOI: 10.1177/15593258261472123</a:t>
+              <a:t>X Li, T Chu, W Chen. Clinics and Research in Hepatology and …. 2026</a:t>
             </a:r>
             <a:endParaRPr lang="en-US" sz="800" dirty="0"/>
           </a:p>

</xml_diff>

<commit_message>
chore: update weekly digest 2026-08-10
</commit_message>
<xml_diff>
--- a/docs/digest-en.pptx
+++ b/docs/digest-en.pptx
@@ -2249,7 +2249,7 @@
                   <a:srgbClr val="888888"/>
                 </a:solidFill>
               </a:rPr>
-              <a:t>2026-07-27 — 2026-08-03</a:t>
+              <a:t>2026-08-03 — 2026-08-10</a:t>
             </a:r>
             <a:endParaRPr lang="en-US" sz="1400" dirty="0"/>
           </a:p>
@@ -2440,7 +2440,7 @@
                   </a:extLst>
                 </a:hlinkClick>
               </a:rPr>
-              <a:t>Combining genotoxic gut bacterial strains increases tumor burden and accelerates onset in a germ-free mouse model of colon carcinogenesis.</a:t>
+              <a:t>The barrier–microbiota–inflammation axis in colorectal cancer: Mechanisms and emerging diagnostic &amp; therapeutic strategies</a:t>
             </a:r>
             <a:endParaRPr lang="en-US" sz="2400" dirty="0"/>
           </a:p>
@@ -2476,7 +2476,7 @@
                   <a:srgbClr val="888888"/>
                 </a:solidFill>
               </a:rPr>
-              <a:t>Cell reports  ·  IF 8.8  ·  Basic Research</a:t>
+              <a:t>Cancers  ·  Basic Research</a:t>
             </a:r>
             <a:endParaRPr lang="en-US" sz="1000" dirty="0"/>
           </a:p>
@@ -2519,7 +2519,7 @@
                 <a:ea typeface="Arial" pitchFamily="34" charset="-122"/>
                 <a:cs typeface="Arial" pitchFamily="34" charset="-120"/>
               </a:rPr>
-              <a:t>Germ-free mice colonized with 19 microbiotas</a:t>
+              <a:t>LPS triggers pro-inflammatory cytokines secretion</a:t>
             </a:r>
             <a:endParaRPr lang="en-US" sz="1800" dirty="0"/>
           </a:p>
@@ -2540,7 +2540,7 @@
                 <a:ea typeface="Arial" pitchFamily="34" charset="-122"/>
                 <a:cs typeface="Arial" pitchFamily="34" charset="-120"/>
               </a:rPr>
-              <a:t>Tumor counts vary by donor microbiota</a:t>
+              <a:t>Downregulates tight junction proteins in cells</a:t>
             </a:r>
             <a:endParaRPr lang="en-US" sz="1800" dirty="0"/>
           </a:p>
@@ -2561,7 +2561,7 @@
                 <a:ea typeface="Arial" pitchFamily="34" charset="-122"/>
                 <a:cs typeface="Arial" pitchFamily="34" charset="-120"/>
               </a:rPr>
-              <a:t>Genotoxicity predicts tumorigenic microbes</a:t>
+              <a:t>Promotes epithelial cell migration and invasion</a:t>
             </a:r>
             <a:endParaRPr lang="en-US" sz="1800" dirty="0"/>
           </a:p>
@@ -2582,7 +2582,7 @@
                 <a:ea typeface="Arial" pitchFamily="34" charset="-122"/>
                 <a:cs typeface="Arial" pitchFamily="34" charset="-120"/>
               </a:rPr>
-              <a:t>Combining genotoxic strains increases tumors</a:t>
+              <a:t>Microbiota influences colorectal cancer progression</a:t>
             </a:r>
             <a:endParaRPr lang="en-US" sz="1800" dirty="0"/>
           </a:p>
@@ -2603,7 +2603,7 @@
                 <a:ea typeface="Arial" pitchFamily="34" charset="-122"/>
                 <a:cs typeface="Arial" pitchFamily="34" charset="-120"/>
               </a:rPr>
-              <a:t>Balance of strains affects tumor onset</a:t>
+              <a:t>Emerging strategies for diagnosis and therapy</a:t>
             </a:r>
             <a:endParaRPr lang="en-US" sz="1800" dirty="0"/>
           </a:p>
@@ -2639,7 +2639,7 @@
                   <a:srgbClr val="888888"/>
                 </a:solidFill>
               </a:rPr>
-              <a:t>Plitt Tamar, Piessevaux Alix, Rajpal Urvija et al.. Cell reports. 2026-07-30 DOI: 10.1016/j.celrep.2026.117645</a:t>
+              <a:t>X Dong, J Yang, L He. Cancers. 2026</a:t>
             </a:r>
             <a:endParaRPr lang="en-US" sz="800" dirty="0"/>
           </a:p>
@@ -2839,7 +2839,7 @@
                   </a:extLst>
                 </a:hlinkClick>
               </a:rPr>
-              <a:t>Immediate Second Look After Cytoreduction for Colorectal or Ovarian Carcinomatosis: An Invisible Gorilla Effect?</a:t>
+              <a:t>Protocol for surgical stress-promoted colorectal cancer liver metastasis in mice.</a:t>
             </a:r>
             <a:endParaRPr lang="en-US" sz="2400" dirty="0"/>
           </a:p>
@@ -2875,7 +2875,7 @@
                   <a:srgbClr val="888888"/>
                 </a:solidFill>
               </a:rPr>
-              <a:t>Annals of surgical oncology  ·  IF 3.8  ·  Prospective Study</a:t>
+              <a:t>STAR protocols</a:t>
             </a:r>
             <a:endParaRPr lang="en-US" sz="1000" dirty="0"/>
           </a:p>
@@ -2918,7 +2918,7 @@
                 <a:ea typeface="Arial" pitchFamily="34" charset="-122"/>
                 <a:cs typeface="Arial" pitchFamily="34" charset="-120"/>
               </a:rPr>
-              <a:t>Study on immediate second look after CRS</a:t>
+              <a:t>Protocol for colorectal cancer liver metastasis study</a:t>
             </a:r>
             <a:endParaRPr lang="en-US" sz="1800" dirty="0"/>
           </a:p>
@@ -2939,7 +2939,7 @@
                 <a:ea typeface="Arial" pitchFamily="34" charset="-122"/>
                 <a:cs typeface="Arial" pitchFamily="34" charset="-120"/>
               </a:rPr>
-              <a:t>172 patients underwent CC0 CRS evaluated</a:t>
+              <a:t>Combines hepatic I/R with tumor cell injection</a:t>
             </a:r>
             <a:endParaRPr lang="en-US" sz="1800" dirty="0"/>
           </a:p>
@@ -2960,49 +2960,7 @@
                 <a:ea typeface="Arial" pitchFamily="34" charset="-122"/>
                 <a:cs typeface="Arial" pitchFamily="34" charset="-120"/>
               </a:rPr>
-              <a:t>88.1% had additional nodules resected</a:t>
-            </a:r>
-            <a:endParaRPr lang="en-US" sz="1800" dirty="0"/>
-          </a:p>
-          <a:p>
-            <a:pPr marL="342900" indent="-342900">
-              <a:spcAft>
-                <a:spcPts val="800"/>
-              </a:spcAft>
-              <a:buSzPct val="100000"/>
-              <a:buChar char="•"/>
-            </a:pPr>
-            <a:r>
-              <a:rPr lang="en-US" sz="1800" dirty="0">
-                <a:solidFill>
-                  <a:srgbClr val="333333"/>
-                </a:solidFill>
-                <a:latin typeface="Arial" pitchFamily="34" charset="0"/>
-                <a:ea typeface="Arial" pitchFamily="34" charset="-122"/>
-                <a:cs typeface="Arial" pitchFamily="34" charset="-120"/>
-              </a:rPr>
-              <a:t>47.4% confirmed malignancy in resected nodules</a:t>
-            </a:r>
-            <a:endParaRPr lang="en-US" sz="1800" dirty="0"/>
-          </a:p>
-          <a:p>
-            <a:pPr marL="342900" indent="-342900">
-              <a:spcAft>
-                <a:spcPts val="800"/>
-              </a:spcAft>
-              <a:buSzPct val="100000"/>
-              <a:buChar char="•"/>
-            </a:pPr>
-            <a:r>
-              <a:rPr lang="en-US" sz="1800" dirty="0">
-                <a:solidFill>
-                  <a:srgbClr val="333333"/>
-                </a:solidFill>
-                <a:latin typeface="Arial" pitchFamily="34" charset="0"/>
-                <a:ea typeface="Arial" pitchFamily="34" charset="-122"/>
-                <a:cs typeface="Arial" pitchFamily="34" charset="-120"/>
-              </a:rPr>
-              <a:t>High cognitive attention but errors observed</a:t>
+              <a:t>Monitors liver metastasis in mice model</a:t>
             </a:r>
             <a:endParaRPr lang="en-US" sz="1800" dirty="0"/>
           </a:p>
@@ -3038,7 +2996,7 @@
                   <a:srgbClr val="888888"/>
                 </a:solidFill>
               </a:rPr>
-              <a:t>Dumont Fr&amp;#xe9;d&amp;#xe9;ric, Cosse Lola, Thibaudeau Emilie et al.. Annals of surgical oncology. 2026-07-07 DOI: 10.1245/s10434-026-19493-5</a:t>
+              <a:t>Han Jian, Tsung Peter, Blatz Natalie et al.. STAR protocols. 2026-08-08 DOI: 10.1016/j.xpro.2026.104770</a:t>
             </a:r>
             <a:endParaRPr lang="en-US" sz="800" dirty="0"/>
           </a:p>
@@ -3238,7 +3196,7 @@
                   </a:extLst>
                 </a:hlinkClick>
               </a:rPr>
-              <a:t>Incidence and outcomes of metachronous peritoneal metastasis in the setting of obstructing colon cancer: a systematic review.</a:t>
+              <a:t>Discovery of APO-50815, a potent WEE1 kinase inhibitor with exceptional efficacy against patient-derived colorectal cancer organoids.</a:t>
             </a:r>
             <a:endParaRPr lang="en-US" sz="2400" dirty="0"/>
           </a:p>
@@ -3274,7 +3232,7 @@
                   <a:srgbClr val="888888"/>
                 </a:solidFill>
               </a:rPr>
-              <a:t>European journal of surgical oncology : the journal of the European Society of Surgical Oncology and the British Association of Surgical Oncology  ·  Systematic Review</a:t>
+              <a:t>European journal of medicinal chemistry</a:t>
             </a:r>
             <a:endParaRPr lang="en-US" sz="1000" dirty="0"/>
           </a:p>
@@ -3317,7 +3275,7 @@
                 <a:ea typeface="Arial" pitchFamily="34" charset="-122"/>
                 <a:cs typeface="Arial" pitchFamily="34" charset="-120"/>
               </a:rPr>
-              <a:t>Colorectal peritoneal metastases are challenging to diagnose.</a:t>
+              <a:t>APO-50815 is a potent WEE1 inhibitor.</a:t>
             </a:r>
             <a:endParaRPr lang="en-US" sz="1800" dirty="0"/>
           </a:p>
@@ -3338,7 +3296,7 @@
                 <a:ea typeface="Arial" pitchFamily="34" charset="-122"/>
                 <a:cs typeface="Arial" pitchFamily="34" charset="-120"/>
               </a:rPr>
-              <a:t>Obstruction in colon cancer worsens survival outcomes.</a:t>
+              <a:t>Demonstrated efficacy against TP53-mutated CRC organoids.</a:t>
             </a:r>
             <a:endParaRPr lang="en-US" sz="1800" dirty="0"/>
           </a:p>
@@ -3359,7 +3317,7 @@
                 <a:ea typeface="Arial" pitchFamily="34" charset="-122"/>
                 <a:cs typeface="Arial" pitchFamily="34" charset="-120"/>
               </a:rPr>
-              <a:t>Metachronous peritoneal metastases rates: 7-21%.</a:t>
+              <a:t>Superior to AZD1775 and ZN-c3 in tests.</a:t>
             </a:r>
             <a:endParaRPr lang="en-US" sz="1800" dirty="0"/>
           </a:p>
@@ -3380,7 +3338,7 @@
                 <a:ea typeface="Arial" pitchFamily="34" charset="-122"/>
                 <a:cs typeface="Arial" pitchFamily="34" charset="-120"/>
               </a:rPr>
-              <a:t>3-year survival: 48-56% with peritoneal disease.</a:t>
+              <a:t>High therapeutic index (TI) values observed.</a:t>
             </a:r>
             <a:endParaRPr lang="en-US" sz="1800" dirty="0"/>
           </a:p>
@@ -3401,7 +3359,7 @@
                 <a:ea typeface="Arial" pitchFamily="34" charset="-122"/>
                 <a:cs typeface="Arial" pitchFamily="34" charset="-120"/>
               </a:rPr>
-              <a:t>Need for prospective trials to reduce recurrence risk.</a:t>
+              <a:t>Induces DNA damage and apoptosis in CRC cells.</a:t>
             </a:r>
             <a:endParaRPr lang="en-US" sz="1800" dirty="0"/>
           </a:p>
@@ -3437,7 +3395,7 @@
                   <a:srgbClr val="888888"/>
                 </a:solidFill>
               </a:rPr>
-              <a:t>O'Connell L V, McCafferty J, Udayasiri D et al.. European journal of surgical oncology : the journal of the European Society of Surgical Oncology and the British Association of Surgical Oncology. 2026-07-17 DOI: 10.1016/j.ejso.2026.111950</a:t>
+              <a:t>Syphers Joel L, Wright Josephine A, de Nys Rebekah et al.. European journal of medicinal chemistry. 2026-07-15 DOI: 10.1016/j.ejmech.2026.118838</a:t>
             </a:r>
             <a:endParaRPr lang="en-US" sz="800" dirty="0"/>
           </a:p>
@@ -3654,7 +3612,7 @@
                   <a:srgbClr val="FFFFFF"/>
                 </a:solidFill>
               </a:rPr>
-              <a:t>1. **免疫檢查點抑制劑的潛力**  </a:t>
+              <a:t>1. **微生物群與結腸直腸癌的關聯性**  </a:t>
             </a:r>
             <a:endParaRPr lang="en-US" sz="1200" dirty="0"/>
           </a:p>
@@ -3671,7 +3629,7 @@
                   <a:srgbClr val="FFFFFF"/>
                 </a:solidFill>
               </a:rPr>
-              <a:t>   The combination of neoadjuvant toripalimab and celecoxib demonstrates significant efficacy in dMMR/MSI-H locally advanced colorectal cancer, highlighting the potential of immune checkpoint inhibitors in enhancing treatment outcomes.  </a:t>
+              <a:t>   The dysbiotic microbiota play a crucial role in the development of colitis-associated colorectal cancer, highlighting the need for microbiome-targeted therapies.  </a:t>
             </a:r>
             <a:endParaRPr lang="en-US" sz="1200" dirty="0"/>
           </a:p>
@@ -3688,7 +3646,7 @@
                   <a:srgbClr val="FFFFFF"/>
                 </a:solidFill>
               </a:rPr>
-              <a:t>   併用新輔助治療的toripalimab和celecoxib在dMMR/MSI-H的局部晚期結腸直腸癌中顯示出顯著的療效，突顯了免疫檢查點抑制劑在改善治療結果中的潛力。</a:t>
+              <a:t>   微生物群失調在結腸炎相關結腸直腸癌的發展中扮演重要角色，強調了針對微生物組的治療需求。</a:t>
             </a:r>
             <a:endParaRPr lang="en-US" sz="1200" dirty="0"/>
           </a:p>
@@ -3714,7 +3672,7 @@
                   <a:srgbClr val="FFFFFF"/>
                 </a:solidFill>
               </a:rPr>
-              <a:t>2. **腸道微生物對癌症的影響**  </a:t>
+              <a:t>2. **炎症指標作為預後生物標記**  </a:t>
             </a:r>
             <a:endParaRPr lang="en-US" sz="1200" dirty="0"/>
           </a:p>
@@ -3731,7 +3689,7 @@
                   <a:srgbClr val="FFFFFF"/>
                 </a:solidFill>
               </a:rPr>
-              <a:t>   Dysbiosis in the gut microbiota is linked to inflammatory bowel disease and colorectal cancer, suggesting that modulation of gut microbiota could be a viable therapeutic strategy.  </a:t>
+              <a:t>   The systemic immune-inflammation index (SII) and C-reactive protein-albumin-lymphocyte (CALLY) index demonstrate potential as prognostic biomarkers in colorectal cancer, although further validation is needed due to inconsistent findings.  </a:t>
             </a:r>
             <a:endParaRPr lang="en-US" sz="1200" dirty="0"/>
           </a:p>
@@ -3748,7 +3706,7 @@
                   <a:srgbClr val="FFFFFF"/>
                 </a:solidFill>
               </a:rPr>
-              <a:t>   腸道微生物失調與炎症性腸病和結腸直腸癌有關，這表明調節腸道微生物可能是一種可行的治療策略。</a:t>
+              <a:t>   系統免疫炎症指數（SII）和C反應蛋白-白蛋白-淋巴細胞（CALLY）指數在結腸直腸癌中顯示出作為預後生物標記的潛力，儘管由於結果不一致，需要進一步驗證。</a:t>
             </a:r>
             <a:endParaRPr lang="en-US" sz="1200" dirty="0"/>
           </a:p>
@@ -3774,7 +3732,7 @@
                   <a:srgbClr val="FFFFFF"/>
                 </a:solidFill>
               </a:rPr>
-              <a:t>3. **炎症與癌症的關聯**  </a:t>
+              <a:t>3. **新型治療策略的探索**  </a:t>
             </a:r>
             <a:endParaRPr lang="en-US" sz="1200" dirty="0"/>
           </a:p>
@@ -3791,7 +3749,7 @@
                   <a:srgbClr val="FFFFFF"/>
                 </a:solidFill>
               </a:rPr>
-              <a:t>   The role of inflammation in colorectal cancer is multifaceted, with both promoting and suppressing effects depending on the context, emphasizing the need for targeted therapies that consider the tumor microenvironment.  </a:t>
+              <a:t>   The identification of natural compounds like metochalcone and novel inhibitors such as APO-50815 offers promising avenues for enhancing the efficacy of colorectal cancer treatments.  </a:t>
             </a:r>
             <a:endParaRPr lang="en-US" sz="1200" dirty="0"/>
           </a:p>
@@ -3808,7 +3766,7 @@
                   <a:srgbClr val="FFFFFF"/>
                 </a:solidFill>
               </a:rPr>
-              <a:t>   炎症在結腸直腸癌中的作用是多方面的，根據情境的不同可能有促進或抑制的效果，強調需要考慮腫瘤微環境的靶向治療。</a:t>
+              <a:t>   像美托卡酮這樣的天然化合物和新型抑制劑如APO-50815的發現，為提高結腸直腸癌治療的有效性提供了有希望的途徑。</a:t>
             </a:r>
             <a:endParaRPr lang="en-US" sz="1200" dirty="0"/>
           </a:p>
@@ -3834,7 +3792,7 @@
                   <a:srgbClr val="FFFFFF"/>
                 </a:solidFill>
               </a:rPr>
-              <a:t>4. **預測指標的應用**  </a:t>
+              <a:t>4. **腸道屏障與微生物的相互作用**  </a:t>
             </a:r>
             <a:endParaRPr lang="en-US" sz="1200" dirty="0"/>
           </a:p>
@@ -3851,7 +3809,7 @@
                   <a:srgbClr val="FFFFFF"/>
                 </a:solidFill>
               </a:rPr>
-              <a:t>   The C-reactive protein-albumin-lymphocyte (CALLY) index shows promise as a predictive marker for colorectal cancer outcomes, indicating the importance of inflammatory markers in prognostication.  </a:t>
+              <a:t>   The barrier-microbiota-inflammation axis is critical in colorectal cancer pathogenesis, suggesting that maintaining gut barrier integrity could be a therapeutic target.  </a:t>
             </a:r>
             <a:endParaRPr lang="en-US" sz="1200" dirty="0"/>
           </a:p>
@@ -3868,7 +3826,7 @@
                   <a:srgbClr val="FFFFFF"/>
                 </a:solidFill>
               </a:rPr>
-              <a:t>   C-反應蛋白-白蛋白-淋巴細胞（CALLY）指數顯示出作為結腸直腸癌預後標記的潛力，表明炎症標記在預後中的重要性。</a:t>
+              <a:t>   腸道屏障-微生物-炎症軸在結腸直腸癌的發病機制中至關重要，這表明維持腸道屏障完整性可能成為治療目標。</a:t>
             </a:r>
             <a:endParaRPr lang="en-US" sz="1200" dirty="0"/>
           </a:p>
@@ -3894,7 +3852,7 @@
                   <a:srgbClr val="FFFFFF"/>
                 </a:solidFill>
               </a:rPr>
-              <a:t>5. **新型治療策略的探索**  </a:t>
+              <a:t>5. **手術後轉移的機制**  </a:t>
             </a:r>
             <a:endParaRPr lang="en-US" sz="1200" dirty="0"/>
           </a:p>
@@ -3911,7 +3869,7 @@
                   <a:srgbClr val="FFFFFF"/>
                 </a:solidFill>
               </a:rPr>
-              <a:t>   Emerging therapies targeting mitochondrial pathways and programmed cell death mechanisms represent innovative approaches to overcoming resistance in microsatellite stable colorectal cancer.</a:t>
+              <a:t>   Understanding the mechanisms of surgical stress-promoted liver metastasis in colorectal cancer can lead to improved postoperative management strategies.</a:t>
             </a:r>
             <a:endParaRPr lang="en-US" sz="1200" dirty="0"/>
           </a:p>
@@ -4057,7 +4015,7 @@
                   <a:srgbClr val="FFFFFF"/>
                 </a:solidFill>
               </a:rPr>
-              <a:t>新興的針對線粒體途徑和程序性細胞死亡機制的治療策略代表了克服微衛星穩定型結腸直腸癌耐藥性的新方法。</a:t>
+              <a:t>了解手術壓力促進結腸直腸癌肝轉移的機制，可以促進術後管理策略的改善。</a:t>
             </a:r>
             <a:endParaRPr lang="en-US" sz="1200" dirty="0"/>
           </a:p>
@@ -4109,7 +4067,7 @@
                   <a:srgbClr val="FFFFFF"/>
                 </a:solidFill>
               </a:rPr>
-              <a:t>1. **免疫療法組合策略**  </a:t>
+              <a:t>1. **微生物組介入療法的探索**  </a:t>
             </a:r>
             <a:endParaRPr lang="en-US" sz="1200" dirty="0"/>
           </a:p>
@@ -4126,7 +4084,7 @@
                   <a:srgbClr val="FFFFFF"/>
                 </a:solidFill>
               </a:rPr>
-              <a:t>   Investigating the synergistic effects of combining immune checkpoint inhibitors with anti-inflammatory agents like celecoxib in various colorectal cancer subtypes could enhance therapeutic efficacy.  </a:t>
+              <a:t>   Future studies should investigate microbiome-modulating interventions as potential therapeutic strategies for preventing colitis-associated colorectal cancer.  </a:t>
             </a:r>
             <a:endParaRPr lang="en-US" sz="1200" dirty="0"/>
           </a:p>
@@ -4143,7 +4101,7 @@
                   <a:srgbClr val="FFFFFF"/>
                 </a:solidFill>
               </a:rPr>
-              <a:t>   探索將免疫檢查點抑制劑與抗炎劑如celecoxib結合的協同效應在不同結腸直腸癌亞型中的應用，可能提高療效。</a:t>
+              <a:t>   未來的研究應探索微生物組調節干預作為預防結腸炎相關結腸直腸癌的潛在治療策略。</a:t>
             </a:r>
             <a:endParaRPr lang="en-US" sz="1200" dirty="0"/>
           </a:p>
@@ -4169,7 +4127,7 @@
                   <a:srgbClr val="FFFFFF"/>
                 </a:solidFill>
               </a:rPr>
-              <a:t>2. **微生物組的調節**  </a:t>
+              <a:t>2. **炎症指標的標準化**  </a:t>
             </a:r>
             <a:endParaRPr lang="en-US" sz="1200" dirty="0"/>
           </a:p>
@@ -4186,7 +4144,7 @@
                   <a:srgbClr val="FFFFFF"/>
                 </a:solidFill>
               </a:rPr>
-              <a:t>   Future studies should focus on the manipulation of gut microbiota to assess its impact on treatment responses in colorectal cancer, particularly in patients with inflammatory bowel disease.  </a:t>
+              <a:t>   Standardization and validation of inflammatory biomarkers like SII and CALLY in diverse patient populations will enhance their clinical utility in colorectal cancer prognosis.  </a:t>
             </a:r>
             <a:endParaRPr lang="en-US" sz="1200" dirty="0"/>
           </a:p>
@@ -4203,7 +4161,7 @@
                   <a:srgbClr val="FFFFFF"/>
                 </a:solidFill>
               </a:rPr>
-              <a:t>   未來的研究應集中於調節腸道微生物，以評估其對結腸直腸癌治療反應的影響，特別是在炎症性腸病患者中。</a:t>
+              <a:t>   在不同患者群體中標準化和驗證炎症生物標記如SII和CALLY，將增強其在結腸直腸癌預後中的臨床應用。</a:t>
             </a:r>
             <a:endParaRPr lang="en-US" sz="1200" dirty="0"/>
           </a:p>
@@ -4229,7 +4187,7 @@
                   <a:srgbClr val="FFFFFF"/>
                 </a:solidFill>
               </a:rPr>
-              <a:t>3. **炎症標記的臨床應用**  </a:t>
+              <a:t>3. **新型藥物的臨床試驗**  </a:t>
             </a:r>
             <a:endParaRPr lang="en-US" sz="1200" dirty="0"/>
           </a:p>
@@ -4246,7 +4204,7 @@
                   <a:srgbClr val="FFFFFF"/>
                 </a:solidFill>
               </a:rPr>
-              <a:t>   Further validation of the CALLY index and other inflammatory biomarkers in diverse populations could refine prognostic models and guide personalized treatment approaches.  </a:t>
+              <a:t>   Clinical trials evaluating the efficacy of novel compounds such as metochalcone and WEE1 inhibitors against colorectal cancer should be prioritized.  </a:t>
             </a:r>
             <a:endParaRPr lang="en-US" sz="1200" dirty="0"/>
           </a:p>
@@ -4263,7 +4221,7 @@
                   <a:srgbClr val="FFFFFF"/>
                 </a:solidFill>
               </a:rPr>
-              <a:t>   在不同人群中進一步驗證CALLY指數和其他炎症生物標記，可能有助於完善預後模型並指導個性化治療方案。</a:t>
+              <a:t>   應優先進行臨床試驗，以評估新型化合物如美托卡酮和WEE1抑制劑對結腸直腸癌的療效。</a:t>
             </a:r>
             <a:endParaRPr lang="en-US" sz="1200" dirty="0"/>
           </a:p>
@@ -4289,7 +4247,7 @@
                   <a:srgbClr val="FFFFFF"/>
                 </a:solidFill>
               </a:rPr>
-              <a:t>4. **腫瘤微環境的研究**  </a:t>
+              <a:t>4. **腸道屏障功能的保護**  </a:t>
             </a:r>
             <a:endParaRPr lang="en-US" sz="1200" dirty="0"/>
           </a:p>
@@ -4306,7 +4264,7 @@
                   <a:srgbClr val="FFFFFF"/>
                 </a:solidFill>
               </a:rPr>
-              <a:t>   Comprehensive studies on the tumor microenvironment's heterogeneity and its influence on immune responses will be crucial for developing tailored immunotherapies.  </a:t>
+              <a:t>   Research should focus on strategies to protect and restore gut barrier function in colorectal cancer patients to mitigate inflammation and tumor progression.  </a:t>
             </a:r>
             <a:endParaRPr lang="en-US" sz="1200" dirty="0"/>
           </a:p>
@@ -4323,7 +4281,7 @@
                   <a:srgbClr val="FFFFFF"/>
                 </a:solidFill>
               </a:rPr>
-              <a:t>   對腫瘤微環境的異質性及其對免疫反應影響的綜合研究將對開發量身定制的免疫療法至關重要。</a:t>
+              <a:t>   研究應集中於保護和恢復結腸直腸癌患者的腸道屏障功能，以減輕炎症和腫瘤進展。</a:t>
             </a:r>
             <a:endParaRPr lang="en-US" sz="1200" dirty="0"/>
           </a:p>
@@ -4349,7 +4307,7 @@
                   <a:srgbClr val="FFFFFF"/>
                 </a:solidFill>
               </a:rPr>
-              <a:t>5. **新型治療機制的探索**  </a:t>
+              <a:t>5. **手術對轉移的影響**  </a:t>
             </a:r>
             <a:endParaRPr lang="en-US" sz="1200" dirty="0"/>
           </a:p>
@@ -4366,7 +4324,7 @@
                   <a:srgbClr val="FFFFFF"/>
                 </a:solidFill>
               </a:rPr>
-              <a:t>   Continued exploration of mitochondrial-targeting therapies and their role in enhancing immune responses in colorectal cancer could lead to novel treatment paradigms.  </a:t>
+              <a:t>   Investigating the impact of surgical techniques on the inflammatory microenvironment and subsequent metastasis in colorectal cancer could lead to improved surgical protocols.  </a:t>
             </a:r>
             <a:endParaRPr lang="en-US" sz="1200" dirty="0"/>
           </a:p>
@@ -4383,7 +4341,7 @@
                   <a:srgbClr val="FFFFFF"/>
                 </a:solidFill>
               </a:rPr>
-              <a:t>   繼續探索針對線粒體的治療及其在增強結腸直腸癌免疫反應中的作用，可能會導致新型治療範式的出現。</a:t>
+              <a:t>   研究手術技術對結腸直腸癌的炎症微環境及隨後轉移的影響，可能會促進手術方案的改善。</a:t>
             </a:r>
             <a:endParaRPr lang="en-US" sz="1200" dirty="0"/>
           </a:p>
@@ -4617,7 +4575,7 @@
                 <a:ea typeface="Arial" pitchFamily="34" charset="-122"/>
                 <a:cs typeface="Arial" pitchFamily="34" charset="-120"/>
               </a:rPr>
-              <a:t>Neoadjuvant toripalimab plus celecoxib versus toripalimab monotherapy for mismat…</a:t>
+              <a:t>Dysbiotic microbiota trigger colitis-associated colorectal cancer and imprint a …</a:t>
             </a:r>
             <a:endParaRPr lang="en-US" sz="1400" dirty="0"/>
           </a:p>
@@ -4654,7 +4612,7 @@
                 <a:ea typeface="Arial" pitchFamily="34" charset="-122"/>
                 <a:cs typeface="Arial" pitchFamily="34" charset="-120"/>
               </a:rPr>
-              <a:t>Diarylheptanoid Phytoestrogen from Curcuma comosa Attenuates Colitis and Colitis…</a:t>
+              <a:t>Dabupi decoction mitigates fluorouracil-induced intestinal mucositis via farneso…</a:t>
             </a:r>
             <a:endParaRPr lang="en-US" sz="1400" dirty="0"/>
           </a:p>
@@ -4691,7 +4649,7 @@
                 <a:ea typeface="Arial" pitchFamily="34" charset="-122"/>
                 <a:cs typeface="Arial" pitchFamily="34" charset="-120"/>
               </a:rPr>
-              <a:t>Probiotics may not adhere to gut and provide benefits in inflammatory bowel dise…</a:t>
+              <a:t>Prognostic value of systemic immune-inflammation index for colorectal cancer: a …</a:t>
             </a:r>
             <a:endParaRPr lang="en-US" sz="1400" dirty="0"/>
           </a:p>
@@ -4728,7 +4686,7 @@
                 <a:ea typeface="Arial" pitchFamily="34" charset="-122"/>
                 <a:cs typeface="Arial" pitchFamily="34" charset="-120"/>
               </a:rPr>
-              <a:t>IGHG1&amp;#x207a; plasma cells define an NF-&amp;#x3ba;B-driven inflammatory program tha…</a:t>
+              <a:t>Predictive utility of the C-reactive protein-albumin-lymphocyte (CALLY) index in…</a:t>
             </a:r>
             <a:endParaRPr lang="en-US" sz="1400" dirty="0"/>
           </a:p>
@@ -4765,7 +4723,7 @@
                 <a:ea typeface="Arial" pitchFamily="34" charset="-122"/>
                 <a:cs typeface="Arial" pitchFamily="34" charset="-120"/>
               </a:rPr>
-              <a:t>Mitochondria-Targeting Iridium(III) Complexes Induce PANoptosis and Ferroptosis …</a:t>
+              <a:t>Association of four non-insulin-based insulin resistance surrogate markers with …</a:t>
             </a:r>
             <a:endParaRPr lang="en-US" sz="1400" dirty="0"/>
           </a:p>
@@ -4802,7 +4760,7 @@
                 <a:ea typeface="Arial" pitchFamily="34" charset="-122"/>
                 <a:cs typeface="Arial" pitchFamily="34" charset="-120"/>
               </a:rPr>
-              <a:t>NKR+CD8+ T cells and iNKT cells protect mice from AOM/DSS-induced colorectal can…</a:t>
+              <a:t>A conserved Notch-Meis1-Pbx cascade specifies secretory progenitors into spatial…</a:t>
             </a:r>
             <a:endParaRPr lang="en-US" sz="1400" dirty="0"/>
           </a:p>
@@ -4839,7 +4797,7 @@
                 <a:ea typeface="Arial" pitchFamily="34" charset="-122"/>
                 <a:cs typeface="Arial" pitchFamily="34" charset="-120"/>
               </a:rPr>
-              <a:t>Predictive utility of the C-reactive protein-albumin-lymphocyte (CALLY) index in…</a:t>
+              <a:t>HO-1 Up-regulation and PINK1/Parkin-Mediated Mitophagy Contribute to the Anti-tu…</a:t>
             </a:r>
             <a:endParaRPr lang="en-US" sz="1400" dirty="0"/>
           </a:p>
@@ -4876,7 +4834,7 @@
                 <a:ea typeface="Arial" pitchFamily="34" charset="-122"/>
                 <a:cs typeface="Arial" pitchFamily="34" charset="-120"/>
               </a:rPr>
-              <a:t>Combining genotoxic gut bacterial strains increases tumor burden and accelerates…</a:t>
+              <a:t>The barrier–microbiota–inflammation axis in colorectal cancer: Mechanisms and em…</a:t>
             </a:r>
             <a:endParaRPr lang="en-US" sz="1400" dirty="0"/>
           </a:p>
@@ -4913,7 +4871,7 @@
                 <a:ea typeface="Arial" pitchFamily="34" charset="-122"/>
                 <a:cs typeface="Arial" pitchFamily="34" charset="-120"/>
               </a:rPr>
-              <a:t>Immediate Second Look After Cytoreduction for Colorectal or Ovarian Carcinomatos…</a:t>
+              <a:t>Protocol for surgical stress-promoted colorectal cancer liver metastasis in mice…</a:t>
             </a:r>
             <a:endParaRPr lang="en-US" sz="1400" dirty="0"/>
           </a:p>
@@ -4950,7 +4908,7 @@
                 <a:ea typeface="Arial" pitchFamily="34" charset="-122"/>
                 <a:cs typeface="Arial" pitchFamily="34" charset="-120"/>
               </a:rPr>
-              <a:t>Incidence and outcomes of metachronous peritoneal metastasis in the setting of o…</a:t>
+              <a:t>Discovery of APO-50815, a potent WEE1 kinase inhibitor with exceptional efficacy…</a:t>
             </a:r>
             <a:endParaRPr lang="en-US" sz="1400" dirty="0"/>
           </a:p>
@@ -5105,7 +5063,7 @@
                   </a:extLst>
                 </a:hlinkClick>
               </a:rPr>
-              <a:t>Neoadjuvant toripalimab plus celecoxib versus toripalimab monotherapy for mismatch repair-deficient or microsatellite instability-high, locally advanced colorectal cancer (PICC-2): an open-label, multicentre, randomised, phase 2 trial.</a:t>
+              <a:t>Dysbiotic microbiota trigger colitis-associated colorectal cancer and imprint a distinctive bile acid profile in a PSC-IBD model.</a:t>
             </a:r>
             <a:endParaRPr lang="en-US" sz="2400" dirty="0"/>
           </a:p>
@@ -5141,7 +5099,7 @@
                   <a:srgbClr val="888888"/>
                 </a:solidFill>
               </a:rPr>
-              <a:t>The Lancet. Oncology  ·  IF 41.6  ·  RCT Phase 3</a:t>
+              <a:t>Gut  ·  IF 24.5</a:t>
             </a:r>
             <a:endParaRPr lang="en-US" sz="1000" dirty="0"/>
           </a:p>
@@ -5184,7 +5142,7 @@
                 <a:ea typeface="Arial" pitchFamily="34" charset="-122"/>
                 <a:cs typeface="Arial" pitchFamily="34" charset="-120"/>
               </a:rPr>
-              <a:t>Neoadjuvant toripalimab plus celecoxib tested</a:t>
+              <a:t>PSC-UC shows higher dysplasia rates</a:t>
             </a:r>
             <a:endParaRPr lang="en-US" sz="1800" dirty="0"/>
           </a:p>
@@ -5205,7 +5163,7 @@
                 <a:ea typeface="Arial" pitchFamily="34" charset="-122"/>
                 <a:cs typeface="Arial" pitchFamily="34" charset="-120"/>
               </a:rPr>
-              <a:t>Significant increase in pathological complete response</a:t>
+              <a:t>Microbiota influences colitis and cancer</a:t>
             </a:r>
             <a:endParaRPr lang="en-US" sz="1800" dirty="0"/>
           </a:p>
@@ -5226,7 +5184,49 @@
                 <a:ea typeface="Arial" pitchFamily="34" charset="-122"/>
                 <a:cs typeface="Arial" pitchFamily="34" charset="-120"/>
               </a:rPr>
-              <a:t>Similar safety profile observed in both groups</a:t>
+              <a:t>Specific BA profiles linked to PSC-UC</a:t>
+            </a:r>
+            <a:endParaRPr lang="en-US" sz="1800" dirty="0"/>
+          </a:p>
+          <a:p>
+            <a:pPr marL="342900" indent="-342900">
+              <a:spcAft>
+                <a:spcPts val="800"/>
+              </a:spcAft>
+              <a:buSzPct val="100000"/>
+              <a:buChar char="•"/>
+            </a:pPr>
+            <a:r>
+              <a:rPr lang="en-US" sz="1800" dirty="0">
+                <a:solidFill>
+                  <a:srgbClr val="333333"/>
+                </a:solidFill>
+                <a:latin typeface="Arial" pitchFamily="34" charset="0"/>
+                <a:ea typeface="Arial" pitchFamily="34" charset="-122"/>
+                <a:cs typeface="Arial" pitchFamily="34" charset="-120"/>
+              </a:rPr>
+              <a:t>Germ-free mice resistant to colitis</a:t>
+            </a:r>
+            <a:endParaRPr lang="en-US" sz="1800" dirty="0"/>
+          </a:p>
+          <a:p>
+            <a:pPr marL="342900" indent="-342900">
+              <a:spcAft>
+                <a:spcPts val="800"/>
+              </a:spcAft>
+              <a:buSzPct val="100000"/>
+              <a:buChar char="•"/>
+            </a:pPr>
+            <a:r>
+              <a:rPr lang="en-US" sz="1800" dirty="0">
+                <a:solidFill>
+                  <a:srgbClr val="333333"/>
+                </a:solidFill>
+                <a:latin typeface="Arial" pitchFamily="34" charset="0"/>
+                <a:ea typeface="Arial" pitchFamily="34" charset="-122"/>
+                <a:cs typeface="Arial" pitchFamily="34" charset="-120"/>
+              </a:rPr>
+              <a:t>Restoring BA-transforming functions is key</a:t>
             </a:r>
             <a:endParaRPr lang="en-US" sz="1800" dirty="0"/>
           </a:p>
@@ -5262,7 +5262,7 @@
                   <a:srgbClr val="888888"/>
                 </a:solidFill>
               </a:rPr>
-              <a:t>Hu Huabin, Shen Xutao, Li Yunfeng et al.. The Lancet. Oncology. 2026-07-27 DOI: 10.1016/S1470-2045(26)00220-2</a:t>
+              <a:t>Awoniyi Muyiwa, El Hag Mohamed, Hernandez Josue et al.. Gut. 2026-08-06 DOI: 10.1136/gutjnl-2025-336675</a:t>
             </a:r>
             <a:endParaRPr lang="en-US" sz="800" dirty="0"/>
           </a:p>
@@ -5462,7 +5462,7 @@
                   </a:extLst>
                 </a:hlinkClick>
               </a:rPr>
-              <a:t>Diarylheptanoid Phytoestrogen from Curcuma comosa Attenuates Colitis and Colitis-Associated Colorectal Cancer by Inhibiting Inflammation and Oxidative Stress and Modulating Gut Microbiota.</a:t>
+              <a:t>Dabupi decoction mitigates fluorouracil-induced intestinal mucositis via farnesoid X receptor activation and dihydropyrimidine dehydrogenase upregulation.</a:t>
             </a:r>
             <a:endParaRPr lang="en-US" sz="2400" dirty="0"/>
           </a:p>
@@ -5498,7 +5498,7 @@
                   <a:srgbClr val="888888"/>
                 </a:solidFill>
               </a:rPr>
-              <a:t>Journal of agricultural and food chemistry  ·  RCT Phase 2  ·  🌏 Asia</a:t>
+              <a:t>Journal of ethnopharmacology  ·  Basic Research  ·  🌏 Asia</a:t>
             </a:r>
             <a:endParaRPr lang="en-US" sz="1000" dirty="0"/>
           </a:p>
@@ -5541,7 +5541,7 @@
                 <a:ea typeface="Arial" pitchFamily="34" charset="-122"/>
                 <a:cs typeface="Arial" pitchFamily="34" charset="-120"/>
               </a:rPr>
-              <a:t>Diarylheptanoids reduce colitis symptoms.</a:t>
+              <a:t>5-FU causes intestinal mucositis.</a:t>
             </a:r>
             <a:endParaRPr lang="en-US" sz="1800" dirty="0"/>
           </a:p>
@@ -5562,7 +5562,7 @@
                 <a:ea typeface="Arial" pitchFamily="34" charset="-122"/>
                 <a:cs typeface="Arial" pitchFamily="34" charset="-120"/>
               </a:rPr>
-              <a:t>DPH inhibits inflammation and oxidative stress.</a:t>
+              <a:t>DBPD activates FXR and upregulates DPYD.</a:t>
             </a:r>
             <a:endParaRPr lang="en-US" sz="1800" dirty="0"/>
           </a:p>
@@ -5583,7 +5583,7 @@
                 <a:ea typeface="Arial" pitchFamily="34" charset="-122"/>
                 <a:cs typeface="Arial" pitchFamily="34" charset="-120"/>
               </a:rPr>
-              <a:t>Modulates gut microbiota for health benefits.</a:t>
+              <a:t>DBPD reduces inflammation and barrier damage.</a:t>
             </a:r>
             <a:endParaRPr lang="en-US" sz="1800" dirty="0"/>
           </a:p>
@@ -5619,7 +5619,7 @@
                   <a:srgbClr val="888888"/>
                 </a:solidFill>
               </a:rPr>
-              <a:t>Truong Van-Long, Rarison Razanamanana H G, Song Eun-Ji et al.. Journal of agricultural and food chemistry. 2026-07-29 DOI: 10.1021/acs.jafc.5c17732</a:t>
+              <a:t>Wang ShunZhi, Li Yaling, Ma Jing et al.. Journal of ethnopharmacology. 2026-07-16 DOI: 10.1016/j.jep.2026.121742</a:t>
             </a:r>
             <a:endParaRPr lang="en-US" sz="800" dirty="0"/>
           </a:p>
@@ -5819,7 +5819,7 @@
                   </a:extLst>
                 </a:hlinkClick>
               </a:rPr>
-              <a:t>Probiotics may not adhere to gut and provide benefits in inflammatory bowel disease patients based on an AOM/DSS murine model.</a:t>
+              <a:t>Prognostic value of systemic immune-inflammation index for colorectal cancer: a systematic review and meta-analysis</a:t>
             </a:r>
             <a:endParaRPr lang="en-US" sz="2400" dirty="0"/>
           </a:p>
@@ -5855,7 +5855,7 @@
                   <a:srgbClr val="888888"/>
                 </a:solidFill>
               </a:rPr>
-              <a:t>Journal of the Formosan Medical Association = Taiwan yi zhi  ·  Basic Research  ·  🌏 Asia</a:t>
+              <a:t>Frontiers in Oncology  ·  Meta-Analysis</a:t>
             </a:r>
             <a:endParaRPr lang="en-US" sz="1000" dirty="0"/>
           </a:p>
@@ -5898,7 +5898,7 @@
                 <a:ea typeface="Arial" pitchFamily="34" charset="-122"/>
                 <a:cs typeface="Arial" pitchFamily="34" charset="-120"/>
               </a:rPr>
-              <a:t>Dysbiosis common in IBD patients.</a:t>
+              <a:t>SII as a prognostic biomarker in CRC</a:t>
             </a:r>
             <a:endParaRPr lang="en-US" sz="1800" dirty="0"/>
           </a:p>
@@ -5919,7 +5919,7 @@
                 <a:ea typeface="Arial" pitchFamily="34" charset="-122"/>
                 <a:cs typeface="Arial" pitchFamily="34" charset="-120"/>
               </a:rPr>
-              <a:t>Akkermansia muciniphila shows promise.</a:t>
+              <a:t>Inconsistent findings across studies</a:t>
             </a:r>
             <a:endParaRPr lang="en-US" sz="1800" dirty="0"/>
           </a:p>
@@ -5940,7 +5940,7 @@
                 <a:ea typeface="Arial" pitchFamily="34" charset="-122"/>
                 <a:cs typeface="Arial" pitchFamily="34" charset="-120"/>
               </a:rPr>
-              <a:t>AKK treatment showed no significant benefits.</a:t>
+              <a:t>Meta-analysis confirms SII's value</a:t>
             </a:r>
             <a:endParaRPr lang="en-US" sz="1800" dirty="0"/>
           </a:p>
@@ -5961,7 +5961,7 @@
                 <a:ea typeface="Arial" pitchFamily="34" charset="-122"/>
                 <a:cs typeface="Arial" pitchFamily="34" charset="-120"/>
               </a:rPr>
-              <a:t>Poor adherence in probiotic therapy observed.</a:t>
+              <a:t>Potential for personalized treatment strategies</a:t>
             </a:r>
             <a:endParaRPr lang="en-US" sz="1800" dirty="0"/>
           </a:p>
@@ -5982,7 +5982,7 @@
                 <a:ea typeface="Arial" pitchFamily="34" charset="-122"/>
                 <a:cs typeface="Arial" pitchFamily="34" charset="-120"/>
               </a:rPr>
-              <a:t>Further research needed on probiotics.</a:t>
+              <a:t>Need for standardized measurement protocols</a:t>
             </a:r>
             <a:endParaRPr lang="en-US" sz="1800" dirty="0"/>
           </a:p>
@@ -6018,7 +6018,7 @@
                   <a:srgbClr val="888888"/>
                 </a:solidFill>
               </a:rPr>
-              <a:t>Hu Ming-Luen, Wang Feng-Sheng, Lian Wei-Shiung et al.. Journal of the Formosan Medical Association = Taiwan yi zhi. 2026-07-27 DOI: 10.1016/j.jfma.2025.05.010</a:t>
+              <a:t>P Wang, H Jiang. Frontiers in Oncology. 2026</a:t>
             </a:r>
             <a:endParaRPr lang="en-US" sz="800" dirty="0"/>
           </a:p>
@@ -6218,7 +6218,7 @@
                   </a:extLst>
                 </a:hlinkClick>
               </a:rPr>
-              <a:t>IGHG1&amp;#x207a; plasma cells define an NF-&amp;#x3ba;B-driven inflammatory program that shapes T-cell immunity and immunotherapy response in colorectal cancer.</a:t>
+              <a:t>Predictive utility of the C-reactive protein-albumin-lymphocyte (CALLY) index in Colorectal cancer: A meta-analysis</a:t>
             </a:r>
             <a:endParaRPr lang="en-US" sz="2400" dirty="0"/>
           </a:p>
@@ -6254,7 +6254,7 @@
                   <a:srgbClr val="888888"/>
                 </a:solidFill>
               </a:rPr>
-              <a:t>Translational oncology  ·  Basic Research  ·  🌏 Asia</a:t>
+              <a:t>Clinics and Research in Hepatology and …  ·  Meta-Analysis</a:t>
             </a:r>
             <a:endParaRPr lang="en-US" sz="1000" dirty="0"/>
           </a:p>
@@ -6297,7 +6297,7 @@
                 <a:ea typeface="Arial" pitchFamily="34" charset="-122"/>
                 <a:cs typeface="Arial" pitchFamily="34" charset="-120"/>
               </a:rPr>
-              <a:t>IGHG1+ plasma cells enhance T-cell immunity.</a:t>
+              <a:t>CALLY index predicts colorectal cancer outcomes.</a:t>
             </a:r>
             <a:endParaRPr lang="en-US" sz="1800" dirty="0"/>
           </a:p>
@@ -6318,7 +6318,7 @@
                 <a:ea typeface="Arial" pitchFamily="34" charset="-122"/>
                 <a:cs typeface="Arial" pitchFamily="34" charset="-120"/>
               </a:rPr>
-              <a:t>NF-κB pathway drives inflammatory program.</a:t>
+              <a:t>Inflammation and immune function are key factors.</a:t>
             </a:r>
             <a:endParaRPr lang="en-US" sz="1800" dirty="0"/>
           </a:p>
@@ -6339,7 +6339,7 @@
                 <a:ea typeface="Arial" pitchFamily="34" charset="-122"/>
                 <a:cs typeface="Arial" pitchFamily="34" charset="-120"/>
               </a:rPr>
-              <a:t>Signature predicts immunotherapy response.</a:t>
+              <a:t>Meta-analysis supports CALLY's predictive utility.</a:t>
             </a:r>
             <a:endParaRPr lang="en-US" sz="1800" dirty="0"/>
           </a:p>
@@ -6375,7 +6375,7 @@
                   <a:srgbClr val="888888"/>
                 </a:solidFill>
               </a:rPr>
-              <a:t>Zhang Rui-Feng, Zhang Wan-Ze, Li He et al.. Translational oncology. 2026-07-27 DOI: 10.1016/j.tranon.2026.102930</a:t>
+              <a:t>X Li, T Chu, W Chen. Clinics and Research in Hepatology and …. 2026</a:t>
             </a:r>
             <a:endParaRPr lang="en-US" sz="800" dirty="0"/>
           </a:p>
@@ -6575,7 +6575,7 @@
                   </a:extLst>
                 </a:hlinkClick>
               </a:rPr>
-              <a:t>Mitochondria-Targeting Iridium(III) Complexes Induce PANoptosis and Ferroptosis for Boosting Chemoimmunotherapy Against Immune-Desert Colorectal Cancer.</a:t>
+              <a:t>Association of four non-insulin-based insulin resistance surrogate markers with colorectal cancer risk: a large-scale prospective cohort study using the UK …</a:t>
             </a:r>
             <a:endParaRPr lang="en-US" sz="2400" dirty="0"/>
           </a:p>
@@ -6611,7 +6611,7 @@
                   <a:srgbClr val="888888"/>
                 </a:solidFill>
               </a:rPr>
-              <a:t>Angewandte Chemie (International ed. in English)  ·  Basic Research  ·  🌏 Asia</a:t>
+              <a:t>Frontiers in …  ·  Prospective Study</a:t>
             </a:r>
             <a:endParaRPr lang="en-US" sz="1000" dirty="0"/>
           </a:p>
@@ -6654,7 +6654,7 @@
                 <a:ea typeface="Arial" pitchFamily="34" charset="-122"/>
                 <a:cs typeface="Arial" pitchFamily="34" charset="-120"/>
               </a:rPr>
-              <a:t>MSS-CRC poses chemotherapy challenges.</a:t>
+              <a:t>Study on insulin resistance markers</a:t>
             </a:r>
             <a:endParaRPr lang="en-US" sz="1800" dirty="0"/>
           </a:p>
@@ -6675,7 +6675,7 @@
                 <a:ea typeface="Arial" pitchFamily="34" charset="-122"/>
                 <a:cs typeface="Arial" pitchFamily="34" charset="-120"/>
               </a:rPr>
-              <a:t>Iridium(III) complexes induce PANoptosis.</a:t>
+              <a:t>Focus on colorectal cancer risk</a:t>
             </a:r>
             <a:endParaRPr lang="en-US" sz="1800" dirty="0"/>
           </a:p>
@@ -6696,7 +6696,7 @@
                 <a:ea typeface="Arial" pitchFamily="34" charset="-122"/>
                 <a:cs typeface="Arial" pitchFamily="34" charset="-120"/>
               </a:rPr>
-              <a:t>Concurrent ferroptosis boosts immunotherapy.</a:t>
+              <a:t>Large-scale prospective cohort analysis</a:t>
             </a:r>
             <a:endParaRPr lang="en-US" sz="1800" dirty="0"/>
           </a:p>
@@ -6717,7 +6717,7 @@
                 <a:ea typeface="Arial" pitchFamily="34" charset="-122"/>
                 <a:cs typeface="Arial" pitchFamily="34" charset="-120"/>
               </a:rPr>
-              <a:t>Mechanism-guided design enhances efficacy.</a:t>
+              <a:t>Association with chronic inflammation</a:t>
             </a:r>
             <a:endParaRPr lang="en-US" sz="1800" dirty="0"/>
           </a:p>
@@ -6738,7 +6738,7 @@
                 <a:ea typeface="Arial" pitchFamily="34" charset="-122"/>
                 <a:cs typeface="Arial" pitchFamily="34" charset="-120"/>
               </a:rPr>
-              <a:t>Proteomic analysis confirms pathway activation.</a:t>
+              <a:t>Potential role of estrogen</a:t>
             </a:r>
             <a:endParaRPr lang="en-US" sz="1800" dirty="0"/>
           </a:p>
@@ -6774,7 +6774,7 @@
                   <a:srgbClr val="888888"/>
                 </a:solidFill>
               </a:rPr>
-              <a:t>Liu Xing, Feng Tao, Yang Xiaoting et al.. Angewandte Chemie (International ed. in English). 2026-07-29 DOI: 10.1002/anie.3918717</a:t>
+              <a:t>Y Ding, J Wang, N Wang. Frontiers in …. 2026</a:t>
             </a:r>
             <a:endParaRPr lang="en-US" sz="800" dirty="0"/>
           </a:p>
@@ -6974,7 +6974,7 @@
                   </a:extLst>
                 </a:hlinkClick>
               </a:rPr>
-              <a:t>NKR+CD8+ T cells and iNKT cells protect mice from AOM/DSS-induced colorectal cancer under conditions of IFN&amp;#x3b3;-mediated hyperinflammation.</a:t>
+              <a:t>A conserved Notch-Meis1-Pbx cascade specifies secretory progenitors into spatially diverse intestinal best4 + cells.</a:t>
             </a:r>
             <a:endParaRPr lang="en-US" sz="2400" dirty="0"/>
           </a:p>
@@ -7010,7 +7010,7 @@
                   <a:srgbClr val="888888"/>
                 </a:solidFill>
               </a:rPr>
-              <a:t>Inflammation research : official journal of the European Histamine Research Society ... [et al.]  ·  🌏 Asia</a:t>
+              <a:t>Genes &amp; development  ·  Basic Research</a:t>
             </a:r>
             <a:endParaRPr lang="en-US" sz="1000" dirty="0"/>
           </a:p>
@@ -7053,7 +7053,7 @@
                 <a:ea typeface="Arial" pitchFamily="34" charset="-122"/>
                 <a:cs typeface="Arial" pitchFamily="34" charset="-120"/>
               </a:rPr>
-              <a:t>NKR+CD8+ T cells enhance anti-tumor immunity.</a:t>
+              <a:t>best4 + cells are important intestinal epithelial types</a:t>
             </a:r>
             <a:endParaRPr lang="en-US" sz="1800" dirty="0"/>
           </a:p>
@@ -7074,7 +7074,7 @@
                 <a:ea typeface="Arial" pitchFamily="34" charset="-122"/>
                 <a:cs typeface="Arial" pitchFamily="34" charset="-120"/>
               </a:rPr>
-              <a:t>iNKT cells crucial for CRC control.</a:t>
+              <a:t>Zebrafish model used for in vivo studies</a:t>
             </a:r>
             <a:endParaRPr lang="en-US" sz="1800" dirty="0"/>
           </a:p>
@@ -7095,7 +7095,49 @@
                 <a:ea typeface="Arial" pitchFamily="34" charset="-122"/>
                 <a:cs typeface="Arial" pitchFamily="34" charset="-120"/>
               </a:rPr>
-              <a:t>IFN-gamma mediates hyperinflammation effects.</a:t>
+              <a:t>Notch/Dll4 signaling regulates cell fate</a:t>
+            </a:r>
+            <a:endParaRPr lang="en-US" sz="1800" dirty="0"/>
+          </a:p>
+          <a:p>
+            <a:pPr marL="342900" indent="-342900">
+              <a:spcAft>
+                <a:spcPts val="800"/>
+              </a:spcAft>
+              <a:buSzPct val="100000"/>
+              <a:buChar char="•"/>
+            </a:pPr>
+            <a:r>
+              <a:rPr lang="en-US" sz="1800" dirty="0">
+                <a:solidFill>
+                  <a:srgbClr val="333333"/>
+                </a:solidFill>
+                <a:latin typeface="Arial" pitchFamily="34" charset="0"/>
+                <a:ea typeface="Arial" pitchFamily="34" charset="-122"/>
+                <a:cs typeface="Arial" pitchFamily="34" charset="-120"/>
+              </a:rPr>
+              <a:t>meis1b and pbx3a specify best4 + cells</a:t>
+            </a:r>
+            <a:endParaRPr lang="en-US" sz="1800" dirty="0"/>
+          </a:p>
+          <a:p>
+            <a:pPr marL="342900" indent="-342900">
+              <a:spcAft>
+                <a:spcPts val="800"/>
+              </a:spcAft>
+              <a:buSzPct val="100000"/>
+              <a:buChar char="•"/>
+            </a:pPr>
+            <a:r>
+              <a:rPr lang="en-US" sz="1800" dirty="0">
+                <a:solidFill>
+                  <a:srgbClr val="333333"/>
+                </a:solidFill>
+                <a:latin typeface="Arial" pitchFamily="34" charset="0"/>
+                <a:ea typeface="Arial" pitchFamily="34" charset="-122"/>
+                <a:cs typeface="Arial" pitchFamily="34" charset="-120"/>
+              </a:rPr>
+              <a:t>best4 + cells respond to luminal pH changes</a:t>
             </a:r>
             <a:endParaRPr lang="en-US" sz="1800" dirty="0"/>
           </a:p>
@@ -7131,7 +7173,7 @@
                   <a:srgbClr val="888888"/>
                 </a:solidFill>
               </a:rPr>
-              <a:t>Park Hyun Jung, Lee Sung Won, Park Yun Hoo et al.. Inflammation research : official journal of the European Histamine Research Society ... [et al.]. 2026-07-31 DOI: 10.1007/s00011-026-02325-3</a:t>
+              <a:t>Sur Abhinav, Segal Ella X, Nunneley Michael P et al.. Genes &amp; development. 2026-08-07 DOI: 10.1101/gad.353662.126</a:t>
             </a:r>
             <a:endParaRPr lang="en-US" sz="800" dirty="0"/>
           </a:p>
@@ -7331,7 +7373,7 @@
                   </a:extLst>
                 </a:hlinkClick>
               </a:rPr>
-              <a:t>Predictive utility of the C-reactive protein-albumin-lymphocyte (CALLY) index in Colorectal cancer: A meta-analysis</a:t>
+              <a:t>HO-1 Up-regulation and PINK1/Parkin-Mediated Mitophagy Contribute to the Anti-tumor Effects of Metochalcone in Colorectal Cancer.</a:t>
             </a:r>
             <a:endParaRPr lang="en-US" sz="2400" dirty="0"/>
           </a:p>
@@ -7367,7 +7409,7 @@
                   <a:srgbClr val="888888"/>
                 </a:solidFill>
               </a:rPr>
-              <a:t>Clinics and Research in Hepatology and …  ·  Meta-Analysis</a:t>
+              <a:t>Research (Washington, D.C.)  ·  Basic Research</a:t>
             </a:r>
             <a:endParaRPr lang="en-US" sz="1000" dirty="0"/>
           </a:p>
@@ -7410,7 +7452,7 @@
                 <a:ea typeface="Arial" pitchFamily="34" charset="-122"/>
                 <a:cs typeface="Arial" pitchFamily="34" charset="-120"/>
               </a:rPr>
-              <a:t>CALLY index predicts colorectal cancer outcomes.</a:t>
+              <a:t>Metochalcone reduces CRC cell viability significantly.</a:t>
             </a:r>
             <a:endParaRPr lang="en-US" sz="1800" dirty="0"/>
           </a:p>
@@ -7431,7 +7473,7 @@
                 <a:ea typeface="Arial" pitchFamily="34" charset="-122"/>
                 <a:cs typeface="Arial" pitchFamily="34" charset="-120"/>
               </a:rPr>
-              <a:t>Inflammation and immune function are crucial.</a:t>
+              <a:t>HO-1 identified as a key target in CRC.</a:t>
             </a:r>
             <a:endParaRPr lang="en-US" sz="1800" dirty="0"/>
           </a:p>
@@ -7452,7 +7494,49 @@
                 <a:ea typeface="Arial" pitchFamily="34" charset="-122"/>
                 <a:cs typeface="Arial" pitchFamily="34" charset="-120"/>
               </a:rPr>
-              <a:t>Meta-analysis supports CALLY's clinical utility.</a:t>
+              <a:t>MET activates PINK1/Parkin-mediated mitophagy.</a:t>
+            </a:r>
+            <a:endParaRPr lang="en-US" sz="1800" dirty="0"/>
+          </a:p>
+          <a:p>
+            <a:pPr marL="342900" indent="-342900">
+              <a:spcAft>
+                <a:spcPts val="800"/>
+              </a:spcAft>
+              <a:buSzPct val="100000"/>
+              <a:buChar char="•"/>
+            </a:pPr>
+            <a:r>
+              <a:rPr lang="en-US" sz="1800" dirty="0">
+                <a:solidFill>
+                  <a:srgbClr val="333333"/>
+                </a:solidFill>
+                <a:latin typeface="Arial" pitchFamily="34" charset="0"/>
+                <a:ea typeface="Arial" pitchFamily="34" charset="-122"/>
+                <a:cs typeface="Arial" pitchFamily="34" charset="-120"/>
+              </a:rPr>
+              <a:t>Tumor growth suppression observed in mouse models.</a:t>
+            </a:r>
+            <a:endParaRPr lang="en-US" sz="1800" dirty="0"/>
+          </a:p>
+          <a:p>
+            <a:pPr marL="342900" indent="-342900">
+              <a:spcAft>
+                <a:spcPts val="800"/>
+              </a:spcAft>
+              <a:buSzPct val="100000"/>
+              <a:buChar char="•"/>
+            </a:pPr>
+            <a:r>
+              <a:rPr lang="en-US" sz="1800" dirty="0">
+                <a:solidFill>
+                  <a:srgbClr val="333333"/>
+                </a:solidFill>
+                <a:latin typeface="Arial" pitchFamily="34" charset="0"/>
+                <a:ea typeface="Arial" pitchFamily="34" charset="-122"/>
+                <a:cs typeface="Arial" pitchFamily="34" charset="-120"/>
+              </a:rPr>
+              <a:t>MET alters gut microbiota composition positively.</a:t>
             </a:r>
             <a:endParaRPr lang="en-US" sz="1800" dirty="0"/>
           </a:p>
@@ -7488,7 +7572,7 @@
                   <a:srgbClr val="888888"/>
                 </a:solidFill>
               </a:rPr>
-              <a:t>X Li, T Chu, W Chen. Clinics and Research in Hepatology and …. 2026</a:t>
+              <a:t>Chen Pingting, An Junsha, Han Mingyu et al.. Research (Washington, D.C.). 2026-08-05 DOI: 10.34133/research.1387</a:t>
             </a:r>
             <a:endParaRPr lang="en-US" sz="800" dirty="0"/>
           </a:p>

</xml_diff>

<commit_message>
chore: update weekly digest 2026-08-17
</commit_message>
<xml_diff>
--- a/docs/digest-en.pptx
+++ b/docs/digest-en.pptx
@@ -2249,7 +2249,7 @@
                   <a:srgbClr val="888888"/>
                 </a:solidFill>
               </a:rPr>
-              <a:t>2026-08-03 — 2026-08-10</a:t>
+              <a:t>2026-08-10 — 2026-08-17</a:t>
             </a:r>
             <a:endParaRPr lang="en-US" sz="1400" dirty="0"/>
           </a:p>
@@ -2440,7 +2440,7 @@
                   </a:extLst>
                 </a:hlinkClick>
               </a:rPr>
-              <a:t>The barrier–microbiota–inflammation axis in colorectal cancer: Mechanisms and emerging diagnostic &amp; therapeutic strategies</a:t>
+              <a:t>Circulating granulocyte colony-stimulating factor as a sex-unbiased global marker of lung and colorectal cancer cachexia pre-clinical models.</a:t>
             </a:r>
             <a:endParaRPr lang="en-US" sz="2400" dirty="0"/>
           </a:p>
@@ -2476,7 +2476,7 @@
                   <a:srgbClr val="888888"/>
                 </a:solidFill>
               </a:rPr>
-              <a:t>Cancers  ·  Basic Research</a:t>
+              <a:t>Experimental physiology</a:t>
             </a:r>
             <a:endParaRPr lang="en-US" sz="1000" dirty="0"/>
           </a:p>
@@ -2519,7 +2519,7 @@
                 <a:ea typeface="Arial" pitchFamily="34" charset="-122"/>
                 <a:cs typeface="Arial" pitchFamily="34" charset="-120"/>
               </a:rPr>
-              <a:t>LPS triggers pro-inflammatory cytokines secretion</a:t>
+              <a:t>Cancer cachexia affects up to 80% of patients.</a:t>
             </a:r>
             <a:endParaRPr lang="en-US" sz="1800" dirty="0"/>
           </a:p>
@@ -2540,7 +2540,7 @@
                 <a:ea typeface="Arial" pitchFamily="34" charset="-122"/>
                 <a:cs typeface="Arial" pitchFamily="34" charset="-120"/>
               </a:rPr>
-              <a:t>Downregulates tight junction proteins in cells</a:t>
+              <a:t>G-CSF levels correlate with muscle mass loss.</a:t>
             </a:r>
             <a:endParaRPr lang="en-US" sz="1800" dirty="0"/>
           </a:p>
@@ -2561,7 +2561,7 @@
                 <a:ea typeface="Arial" pitchFamily="34" charset="-122"/>
                 <a:cs typeface="Arial" pitchFamily="34" charset="-120"/>
               </a:rPr>
-              <a:t>Promotes epithelial cell migration and invasion</a:t>
+              <a:t>Cytokine profiles analyzed in multiple models.</a:t>
             </a:r>
             <a:endParaRPr lang="en-US" sz="1800" dirty="0"/>
           </a:p>
@@ -2582,7 +2582,7 @@
                 <a:ea typeface="Arial" pitchFamily="34" charset="-122"/>
                 <a:cs typeface="Arial" pitchFamily="34" charset="-120"/>
               </a:rPr>
-              <a:t>Microbiota influences colorectal cancer progression</a:t>
+              <a:t>Interactive app developed for cytokine visualization.</a:t>
             </a:r>
             <a:endParaRPr lang="en-US" sz="1800" dirty="0"/>
           </a:p>
@@ -2603,7 +2603,7 @@
                 <a:ea typeface="Arial" pitchFamily="34" charset="-122"/>
                 <a:cs typeface="Arial" pitchFamily="34" charset="-120"/>
               </a:rPr>
-              <a:t>Emerging strategies for diagnosis and therapy</a:t>
+              <a:t>G-CSF:IL-13 ratio as a potential biomarker.</a:t>
             </a:r>
             <a:endParaRPr lang="en-US" sz="1800" dirty="0"/>
           </a:p>
@@ -2639,7 +2639,7 @@
                   <a:srgbClr val="888888"/>
                 </a:solidFill>
               </a:rPr>
-              <a:t>X Dong, J Yang, L He. Cancers. 2026</a:t>
+              <a:t>Morena Francielly, Schrems Eleanor R, Cabrera Ana Regina et al.. Experimental physiology. 2026-08-15 DOI: 10.1113/EP093809</a:t>
             </a:r>
             <a:endParaRPr lang="en-US" sz="800" dirty="0"/>
           </a:p>
@@ -2839,7 +2839,7 @@
                   </a:extLst>
                 </a:hlinkClick>
               </a:rPr>
-              <a:t>Protocol for surgical stress-promoted colorectal cancer liver metastasis in mice.</a:t>
+              <a:t>Consensus Guideline for the Management of Colorectal Cancer with Peritoneal Metastases: PSM Writing Group et al.</a:t>
             </a:r>
             <a:endParaRPr lang="en-US" sz="2400" dirty="0"/>
           </a:p>
@@ -2875,7 +2875,7 @@
                   <a:srgbClr val="888888"/>
                 </a:solidFill>
               </a:rPr>
-              <a:t>STAR protocols</a:t>
+              <a:t>Annals of surgical …</a:t>
             </a:r>
             <a:endParaRPr lang="en-US" sz="1000" dirty="0"/>
           </a:p>
@@ -2918,7 +2918,7 @@
                 <a:ea typeface="Arial" pitchFamily="34" charset="-122"/>
                 <a:cs typeface="Arial" pitchFamily="34" charset="-120"/>
               </a:rPr>
-              <a:t>Protocol for colorectal cancer liver metastasis study</a:t>
+              <a:t>Peritoneum frequently affected by CRC metastases.</a:t>
             </a:r>
             <a:endParaRPr lang="en-US" sz="1800" dirty="0"/>
           </a:p>
@@ -2939,7 +2939,7 @@
                 <a:ea typeface="Arial" pitchFamily="34" charset="-122"/>
                 <a:cs typeface="Arial" pitchFamily="34" charset="-120"/>
               </a:rPr>
-              <a:t>Combines hepatic I/R with tumor cell injection</a:t>
+              <a:t>Management guidelines aim to standardize treatment.</a:t>
             </a:r>
             <a:endParaRPr lang="en-US" sz="1800" dirty="0"/>
           </a:p>
@@ -2960,7 +2960,7 @@
                 <a:ea typeface="Arial" pitchFamily="34" charset="-122"/>
                 <a:cs typeface="Arial" pitchFamily="34" charset="-120"/>
               </a:rPr>
-              <a:t>Monitors liver metastasis in mice model</a:t>
+              <a:t>Consensus reached among expert panel members.</a:t>
             </a:r>
             <a:endParaRPr lang="en-US" sz="1800" dirty="0"/>
           </a:p>
@@ -2996,7 +2996,7 @@
                   <a:srgbClr val="888888"/>
                 </a:solidFill>
               </a:rPr>
-              <a:t>Han Jian, Tsung Peter, Blatz Natalie et al.. STAR protocols. 2026-08-08 DOI: 10.1016/j.xpro.2026.104770</a:t>
+              <a:t>KS Schultz, VV Bansal, MM Wach. Annals of surgical …. 2026</a:t>
             </a:r>
             <a:endParaRPr lang="en-US" sz="800" dirty="0"/>
           </a:p>
@@ -3196,7 +3196,7 @@
                   </a:extLst>
                 </a:hlinkClick>
               </a:rPr>
-              <a:t>Discovery of APO-50815, a potent WEE1 kinase inhibitor with exceptional efficacy against patient-derived colorectal cancer organoids.</a:t>
+              <a:t>Evolving therapeutics in colorectal cancer peritoneal metastases</a:t>
             </a:r>
             <a:endParaRPr lang="en-US" sz="2400" dirty="0"/>
           </a:p>
@@ -3232,7 +3232,7 @@
                   <a:srgbClr val="888888"/>
                 </a:solidFill>
               </a:rPr>
-              <a:t>European journal of medicinal chemistry</a:t>
+              <a:t>Cancer and Metastasis …</a:t>
             </a:r>
             <a:endParaRPr lang="en-US" sz="1000" dirty="0"/>
           </a:p>
@@ -3275,7 +3275,7 @@
                 <a:ea typeface="Arial" pitchFamily="34" charset="-122"/>
                 <a:cs typeface="Arial" pitchFamily="34" charset="-120"/>
               </a:rPr>
-              <a:t>APO-50815 is a potent WEE1 inhibitor.</a:t>
+              <a:t>Colorectal cancer peritoneal metastases are aggressive.</a:t>
             </a:r>
             <a:endParaRPr lang="en-US" sz="1800" dirty="0"/>
           </a:p>
@@ -3296,7 +3296,7 @@
                 <a:ea typeface="Arial" pitchFamily="34" charset="-122"/>
                 <a:cs typeface="Arial" pitchFamily="34" charset="-120"/>
               </a:rPr>
-              <a:t>Demonstrated efficacy against TP53-mutated CRC organoids.</a:t>
+              <a:t>Cytoreductive surgery improves survival rates.</a:t>
             </a:r>
             <a:endParaRPr lang="en-US" sz="1800" dirty="0"/>
           </a:p>
@@ -3317,49 +3317,7 @@
                 <a:ea typeface="Arial" pitchFamily="34" charset="-122"/>
                 <a:cs typeface="Arial" pitchFamily="34" charset="-120"/>
               </a:rPr>
-              <a:t>Superior to AZD1775 and ZN-c3 in tests.</a:t>
-            </a:r>
-            <a:endParaRPr lang="en-US" sz="1800" dirty="0"/>
-          </a:p>
-          <a:p>
-            <a:pPr marL="342900" indent="-342900">
-              <a:spcAft>
-                <a:spcPts val="800"/>
-              </a:spcAft>
-              <a:buSzPct val="100000"/>
-              <a:buChar char="•"/>
-            </a:pPr>
-            <a:r>
-              <a:rPr lang="en-US" sz="1800" dirty="0">
-                <a:solidFill>
-                  <a:srgbClr val="333333"/>
-                </a:solidFill>
-                <a:latin typeface="Arial" pitchFamily="34" charset="0"/>
-                <a:ea typeface="Arial" pitchFamily="34" charset="-122"/>
-                <a:cs typeface="Arial" pitchFamily="34" charset="-120"/>
-              </a:rPr>
-              <a:t>High therapeutic index (TI) values observed.</a:t>
-            </a:r>
-            <a:endParaRPr lang="en-US" sz="1800" dirty="0"/>
-          </a:p>
-          <a:p>
-            <a:pPr marL="342900" indent="-342900">
-              <a:spcAft>
-                <a:spcPts val="800"/>
-              </a:spcAft>
-              <a:buSzPct val="100000"/>
-              <a:buChar char="•"/>
-            </a:pPr>
-            <a:r>
-              <a:rPr lang="en-US" sz="1800" dirty="0">
-                <a:solidFill>
-                  <a:srgbClr val="333333"/>
-                </a:solidFill>
-                <a:latin typeface="Arial" pitchFamily="34" charset="0"/>
-                <a:ea typeface="Arial" pitchFamily="34" charset="-122"/>
-                <a:cs typeface="Arial" pitchFamily="34" charset="-120"/>
-              </a:rPr>
-              <a:t>Induces DNA damage and apoptosis in CRC cells.</a:t>
+              <a:t>Hyperthermic intraperitoneal chemotherapy is effective.</a:t>
             </a:r>
             <a:endParaRPr lang="en-US" sz="1800" dirty="0"/>
           </a:p>
@@ -3395,7 +3353,7 @@
                   <a:srgbClr val="888888"/>
                 </a:solidFill>
               </a:rPr>
-              <a:t>Syphers Joel L, Wright Josephine A, de Nys Rebekah et al.. European journal of medicinal chemistry. 2026-07-15 DOI: 10.1016/j.ejmech.2026.118838</a:t>
+              <a:t>JM Bader, N Aguirre, KS Schultz. Cancer and Metastasis …. 2026</a:t>
             </a:r>
             <a:endParaRPr lang="en-US" sz="800" dirty="0"/>
           </a:p>
@@ -3612,7 +3570,7 @@
                   <a:srgbClr val="FFFFFF"/>
                 </a:solidFill>
               </a:rPr>
-              <a:t>1. **微生物群與結腸直腸癌的關聯性**  </a:t>
+              <a:t>1. **雙重激活納米載體的潛力**  </a:t>
             </a:r>
             <a:endParaRPr lang="en-US" sz="1200" dirty="0"/>
           </a:p>
@@ -3629,7 +3587,7 @@
                   <a:srgbClr val="FFFFFF"/>
                 </a:solidFill>
               </a:rPr>
-              <a:t>   The dysbiotic microbiota play a crucial role in the development of colitis-associated colorectal cancer, highlighting the need for microbiome-targeted therapies.  </a:t>
+              <a:t>   The development of enzyme/reactive oxygen species-dually activated hyaluronic acid nanocarriers showcases a promising approach for targeted therapy in inflammatory bowel diseases and colorectal cancer, addressing both inflammation and tumor progression.  </a:t>
             </a:r>
             <a:endParaRPr lang="en-US" sz="1200" dirty="0"/>
           </a:p>
@@ -3646,7 +3604,7 @@
                   <a:srgbClr val="FFFFFF"/>
                 </a:solidFill>
               </a:rPr>
-              <a:t>   微生物群失調在結腸炎相關結腸直腸癌的發展中扮演重要角色，強調了針對微生物組的治療需求。</a:t>
+              <a:t>   雙重激活的透明質酸納米載體的開發展示了在炎症性腸病和結直腸癌的靶向治療中具有潛力的方法，針對炎症和腫瘤進展。</a:t>
             </a:r>
             <a:endParaRPr lang="en-US" sz="1200" dirty="0"/>
           </a:p>
@@ -3672,7 +3630,7 @@
                   <a:srgbClr val="FFFFFF"/>
                 </a:solidFill>
               </a:rPr>
-              <a:t>2. **炎症指標作為預後生物標記**  </a:t>
+              <a:t>2. **系統免疫炎症指數的預後價值**  </a:t>
             </a:r>
             <a:endParaRPr lang="en-US" sz="1200" dirty="0"/>
           </a:p>
@@ -3689,7 +3647,7 @@
                   <a:srgbClr val="FFFFFF"/>
                 </a:solidFill>
               </a:rPr>
-              <a:t>   The systemic immune-inflammation index (SII) and C-reactive protein-albumin-lymphocyte (CALLY) index demonstrate potential as prognostic biomarkers in colorectal cancer, although further validation is needed due to inconsistent findings.  </a:t>
+              <a:t>   The systemic immune-inflammation index (SII) emerges as a significant prognostic biomarker for colorectal cancer, although its effectiveness is hindered by inconsistent findings across studies, indicating a need for standardized assessment methods.  </a:t>
             </a:r>
             <a:endParaRPr lang="en-US" sz="1200" dirty="0"/>
           </a:p>
@@ -3706,7 +3664,7 @@
                   <a:srgbClr val="FFFFFF"/>
                 </a:solidFill>
               </a:rPr>
-              <a:t>   系統免疫炎症指數（SII）和C反應蛋白-白蛋白-淋巴細胞（CALLY）指數在結腸直腸癌中顯示出作為預後生物標記的潛力，儘管由於結果不一致，需要進一步驗證。</a:t>
+              <a:t>   系統免疫炎症指數（SII）作為結直腸癌的重要預後生物標記，儘管其有效性受到研究結果不一致的限制，顯示出需要標準化評估方法的必要性。</a:t>
             </a:r>
             <a:endParaRPr lang="en-US" sz="1200" dirty="0"/>
           </a:p>
@@ -3732,7 +3690,7 @@
                   <a:srgbClr val="FFFFFF"/>
                 </a:solidFill>
               </a:rPr>
-              <a:t>3. **新型治療策略的探索**  </a:t>
+              <a:t>3. **腸道微生物與炎症的交互作用**  </a:t>
             </a:r>
             <a:endParaRPr lang="en-US" sz="1200" dirty="0"/>
           </a:p>
@@ -3749,7 +3707,7 @@
                   <a:srgbClr val="FFFFFF"/>
                 </a:solidFill>
               </a:rPr>
-              <a:t>   The identification of natural compounds like metochalcone and novel inhibitors such as APO-50815 offers promising avenues for enhancing the efficacy of colorectal cancer treatments.  </a:t>
+              <a:t>   The barrier-microbiota-inflammation axis plays a crucial role in colorectal cancer progression, highlighting the importance of microbiome modulation as a therapeutic strategy.  </a:t>
             </a:r>
             <a:endParaRPr lang="en-US" sz="1200" dirty="0"/>
           </a:p>
@@ -3766,7 +3724,7 @@
                   <a:srgbClr val="FFFFFF"/>
                 </a:solidFill>
               </a:rPr>
-              <a:t>   像美托卡酮這樣的天然化合物和新型抑制劑如APO-50815的發現，為提高結腸直腸癌治療的有效性提供了有希望的途徑。</a:t>
+              <a:t>   障壁-微生物-炎症軸在結直腸癌進展中扮演重要角色，突顯了微生物群調節作為治療策略的重要性。</a:t>
             </a:r>
             <a:endParaRPr lang="en-US" sz="1200" dirty="0"/>
           </a:p>
@@ -3792,7 +3750,7 @@
                   <a:srgbClr val="FFFFFF"/>
                 </a:solidFill>
               </a:rPr>
-              <a:t>4. **腸道屏障與微生物的相互作用**  </a:t>
+              <a:t>4. **癌症惡病質的全身標記**  </a:t>
             </a:r>
             <a:endParaRPr lang="en-US" sz="1200" dirty="0"/>
           </a:p>
@@ -3809,7 +3767,7 @@
                   <a:srgbClr val="FFFFFF"/>
                 </a:solidFill>
               </a:rPr>
-              <a:t>   The barrier-microbiota-inflammation axis is critical in colorectal cancer pathogenesis, suggesting that maintaining gut barrier integrity could be a therapeutic target.  </a:t>
+              <a:t>   Circulating granulocyte colony-stimulating factor is identified as a global marker for cancer cachexia, emphasizing the need for further exploration of its role in metabolic and inflammatory dysregulation in colorectal cancer.  </a:t>
             </a:r>
             <a:endParaRPr lang="en-US" sz="1200" dirty="0"/>
           </a:p>
@@ -3826,7 +3784,7 @@
                   <a:srgbClr val="FFFFFF"/>
                 </a:solidFill>
               </a:rPr>
-              <a:t>   腸道屏障-微生物-炎症軸在結腸直腸癌的發病機制中至關重要，這表明維持腸道屏障完整性可能成為治療目標。</a:t>
+              <a:t>   循環顆粒單核細胞刺激因子被確定為癌症惡病質的全身標記，強調需要進一步探索其在結直腸癌中代謝和炎症失調的作用。</a:t>
             </a:r>
             <a:endParaRPr lang="en-US" sz="1200" dirty="0"/>
           </a:p>
@@ -3852,7 +3810,7 @@
                   <a:srgbClr val="FFFFFF"/>
                 </a:solidFill>
               </a:rPr>
-              <a:t>5. **手術後轉移的機制**  </a:t>
+              <a:t>5. **腫瘤微環境的挑戰**  </a:t>
             </a:r>
             <a:endParaRPr lang="en-US" sz="1200" dirty="0"/>
           </a:p>
@@ -3869,7 +3827,7 @@
                   <a:srgbClr val="FFFFFF"/>
                 </a:solidFill>
               </a:rPr>
-              <a:t>   Understanding the mechanisms of surgical stress-promoted liver metastasis in colorectal cancer can lead to improved postoperative management strategies.</a:t>
+              <a:t>   The immunosuppressive tumor microenvironment presents significant barriers to effective cancer immunotherapy, necessitating innovative strategies to enhance immune response and therapeutic efficacy.</a:t>
             </a:r>
             <a:endParaRPr lang="en-US" sz="1200" dirty="0"/>
           </a:p>
@@ -4015,7 +3973,7 @@
                   <a:srgbClr val="FFFFFF"/>
                 </a:solidFill>
               </a:rPr>
-              <a:t>了解手術壓力促進結腸直腸癌肝轉移的機制，可以促進術後管理策略的改善。</a:t>
+              <a:t>免疫抑制的腫瘤微環境對有效的癌症免疫治療構成重大障礙，需要創新的策略來增強免疫反應和治療效果。</a:t>
             </a:r>
             <a:endParaRPr lang="en-US" sz="1200" dirty="0"/>
           </a:p>
@@ -4067,7 +4025,7 @@
                   <a:srgbClr val="FFFFFF"/>
                 </a:solidFill>
               </a:rPr>
-              <a:t>1. **微生物組介入療法的探索**  </a:t>
+              <a:t>1. **納米載體的臨床應用**  </a:t>
             </a:r>
             <a:endParaRPr lang="en-US" sz="1200" dirty="0"/>
           </a:p>
@@ -4084,7 +4042,7 @@
                   <a:srgbClr val="FFFFFF"/>
                 </a:solidFill>
               </a:rPr>
-              <a:t>   Future studies should investigate microbiome-modulating interventions as potential therapeutic strategies for preventing colitis-associated colorectal cancer.  </a:t>
+              <a:t>   Future studies should focus on the clinical translation of dual-activated nanocarriers for targeted delivery of therapeutics in colorectal cancer and inflammatory bowel diseases.  </a:t>
             </a:r>
             <a:endParaRPr lang="en-US" sz="1200" dirty="0"/>
           </a:p>
@@ -4101,7 +4059,7 @@
                   <a:srgbClr val="FFFFFF"/>
                 </a:solidFill>
               </a:rPr>
-              <a:t>   未來的研究應探索微生物組調節干預作為預防結腸炎相關結腸直腸癌的潛在治療策略。</a:t>
+              <a:t>   未來的研究應專注於雙重激活納米載體在結直腸癌和炎症性腸病中靶向治療藥物的臨床應用。</a:t>
             </a:r>
             <a:endParaRPr lang="en-US" sz="1200" dirty="0"/>
           </a:p>
@@ -4127,7 +4085,7 @@
                   <a:srgbClr val="FFFFFF"/>
                 </a:solidFill>
               </a:rPr>
-              <a:t>2. **炎症指標的標準化**  </a:t>
+              <a:t>2. **標準化的SII評估**  </a:t>
             </a:r>
             <a:endParaRPr lang="en-US" sz="1200" dirty="0"/>
           </a:p>
@@ -4144,7 +4102,7 @@
                   <a:srgbClr val="FFFFFF"/>
                 </a:solidFill>
               </a:rPr>
-              <a:t>   Standardization and validation of inflammatory biomarkers like SII and CALLY in diverse patient populations will enhance their clinical utility in colorectal cancer prognosis.  </a:t>
+              <a:t>   Research should aim to standardize the measurement and application of the systemic immune-inflammation index across diverse patient populations to improve its prognostic utility.  </a:t>
             </a:r>
             <a:endParaRPr lang="en-US" sz="1200" dirty="0"/>
           </a:p>
@@ -4161,7 +4119,7 @@
                   <a:srgbClr val="FFFFFF"/>
                 </a:solidFill>
               </a:rPr>
-              <a:t>   在不同患者群體中標準化和驗證炎症生物標記如SII和CALLY，將增強其在結腸直腸癌預後中的臨床應用。</a:t>
+              <a:t>   研究應致力於標準化系統免疫炎症指數在不同患者群體中的測量和應用，以提高其預後效用。</a:t>
             </a:r>
             <a:endParaRPr lang="en-US" sz="1200" dirty="0"/>
           </a:p>
@@ -4187,7 +4145,7 @@
                   <a:srgbClr val="FFFFFF"/>
                 </a:solidFill>
               </a:rPr>
-              <a:t>3. **新型藥物的臨床試驗**  </a:t>
+              <a:t>3. **微生物群調節的療效探索**  </a:t>
             </a:r>
             <a:endParaRPr lang="en-US" sz="1200" dirty="0"/>
           </a:p>
@@ -4204,7 +4162,7 @@
                   <a:srgbClr val="FFFFFF"/>
                 </a:solidFill>
               </a:rPr>
-              <a:t>   Clinical trials evaluating the efficacy of novel compounds such as metochalcone and WEE1 inhibitors against colorectal cancer should be prioritized.  </a:t>
+              <a:t>   Investigating the therapeutic potential of microbiome modulation in colorectal cancer could lead to novel treatment strategies that enhance patient outcomes.  </a:t>
             </a:r>
             <a:endParaRPr lang="en-US" sz="1200" dirty="0"/>
           </a:p>
@@ -4221,7 +4179,7 @@
                   <a:srgbClr val="FFFFFF"/>
                 </a:solidFill>
               </a:rPr>
-              <a:t>   應優先進行臨床試驗，以評估新型化合物如美托卡酮和WEE1抑制劑對結腸直腸癌的療效。</a:t>
+              <a:t>   探索微生物群調節在結直腸癌中的治療潛力可能會導致增強患者預後的新治療策略。</a:t>
             </a:r>
             <a:endParaRPr lang="en-US" sz="1200" dirty="0"/>
           </a:p>
@@ -4247,7 +4205,7 @@
                   <a:srgbClr val="FFFFFF"/>
                 </a:solidFill>
               </a:rPr>
-              <a:t>4. **腸道屏障功能的保護**  </a:t>
+              <a:t>4. **癌症惡病質的機制研究**  </a:t>
             </a:r>
             <a:endParaRPr lang="en-US" sz="1200" dirty="0"/>
           </a:p>
@@ -4264,7 +4222,7 @@
                   <a:srgbClr val="FFFFFF"/>
                 </a:solidFill>
               </a:rPr>
-              <a:t>   Research should focus on strategies to protect and restore gut barrier function in colorectal cancer patients to mitigate inflammation and tumor progression.  </a:t>
+              <a:t>   Further investigation into the mechanisms underlying cancer cachexia, particularly the role of circulating factors, is essential for developing targeted interventions.  </a:t>
             </a:r>
             <a:endParaRPr lang="en-US" sz="1200" dirty="0"/>
           </a:p>
@@ -4281,7 +4239,7 @@
                   <a:srgbClr val="FFFFFF"/>
                 </a:solidFill>
               </a:rPr>
-              <a:t>   研究應集中於保護和恢復結腸直腸癌患者的腸道屏障功能，以減輕炎症和腫瘤進展。</a:t>
+              <a:t>   進一步研究癌症惡病質的機制，特別是循環因子的作用，對於開發靶向干預措施至關重要。</a:t>
             </a:r>
             <a:endParaRPr lang="en-US" sz="1200" dirty="0"/>
           </a:p>
@@ -4307,7 +4265,7 @@
                   <a:srgbClr val="FFFFFF"/>
                 </a:solidFill>
               </a:rPr>
-              <a:t>5. **手術對轉移的影響**  </a:t>
+              <a:t>5. **克服腫瘤微環境的策略**  </a:t>
             </a:r>
             <a:endParaRPr lang="en-US" sz="1200" dirty="0"/>
           </a:p>
@@ -4324,7 +4282,7 @@
                   <a:srgbClr val="FFFFFF"/>
                 </a:solidFill>
               </a:rPr>
-              <a:t>   Investigating the impact of surgical techniques on the inflammatory microenvironment and subsequent metastasis in colorectal cancer could lead to improved surgical protocols.  </a:t>
+              <a:t>   Innovative approaches to overcome the immunosuppressive tumor microenvironment, such as combination therapies and novel immunomodulators, should be prioritized in future research.  </a:t>
             </a:r>
             <a:endParaRPr lang="en-US" sz="1200" dirty="0"/>
           </a:p>
@@ -4341,7 +4299,7 @@
                   <a:srgbClr val="FFFFFF"/>
                 </a:solidFill>
               </a:rPr>
-              <a:t>   研究手術技術對結腸直腸癌的炎症微環境及隨後轉移的影響，可能會促進手術方案的改善。</a:t>
+              <a:t>   未來研究應優先考慮克服免疫抑制腫瘤微環境的創新方法，如聯合療法和新型免疫調節劑。</a:t>
             </a:r>
             <a:endParaRPr lang="en-US" sz="1200" dirty="0"/>
           </a:p>
@@ -4575,7 +4533,7 @@
                 <a:ea typeface="Arial" pitchFamily="34" charset="-122"/>
                 <a:cs typeface="Arial" pitchFamily="34" charset="-120"/>
               </a:rPr>
-              <a:t>Dysbiotic microbiota trigger colitis-associated colorectal cancer and imprint a …</a:t>
+              <a:t>Enzyme/Reactive Oxygen Species-Dually Activated Hyaluronic Acid Nanocarriers Ena…</a:t>
             </a:r>
             <a:endParaRPr lang="en-US" sz="1400" dirty="0"/>
           </a:p>
@@ -4686,7 +4644,7 @@
                 <a:ea typeface="Arial" pitchFamily="34" charset="-122"/>
                 <a:cs typeface="Arial" pitchFamily="34" charset="-120"/>
               </a:rPr>
-              <a:t>Predictive utility of the C-reactive protein-albumin-lymphocyte (CALLY) index in…</a:t>
+              <a:t>Iron, inflammation, and intestinal tumors: the crucial triad in colorectal cance…</a:t>
             </a:r>
             <a:endParaRPr lang="en-US" sz="1400" dirty="0"/>
           </a:p>
@@ -4723,7 +4681,7 @@
                 <a:ea typeface="Arial" pitchFamily="34" charset="-122"/>
                 <a:cs typeface="Arial" pitchFamily="34" charset="-120"/>
               </a:rPr>
-              <a:t>Association of four non-insulin-based insulin resistance surrogate markers with …</a:t>
+              <a:t>Neutrophil extracellular traps in colorectal cancer: context-dependent roles fro…</a:t>
             </a:r>
             <a:endParaRPr lang="en-US" sz="1400" dirty="0"/>
           </a:p>
@@ -4760,7 +4718,7 @@
                 <a:ea typeface="Arial" pitchFamily="34" charset="-122"/>
                 <a:cs typeface="Arial" pitchFamily="34" charset="-120"/>
               </a:rPr>
-              <a:t>A conserved Notch-Meis1-Pbx cascade specifies secretory progenitors into spatial…</a:t>
+              <a:t>Hierarchical core-shell nanoplatform with sequential Mn2+/Co2+ release enables d…</a:t>
             </a:r>
             <a:endParaRPr lang="en-US" sz="1400" dirty="0"/>
           </a:p>
@@ -4797,7 +4755,7 @@
                 <a:ea typeface="Arial" pitchFamily="34" charset="-122"/>
                 <a:cs typeface="Arial" pitchFamily="34" charset="-120"/>
               </a:rPr>
-              <a:t>HO-1 Up-regulation and PINK1/Parkin-Mediated Mitophagy Contribute to the Anti-tu…</a:t>
+              <a:t>The barrier–microbiota–inflammation axis in colorectal cancer: Mechanisms and em…</a:t>
             </a:r>
             <a:endParaRPr lang="en-US" sz="1400" dirty="0"/>
           </a:p>
@@ -4834,7 +4792,7 @@
                 <a:ea typeface="Arial" pitchFamily="34" charset="-122"/>
                 <a:cs typeface="Arial" pitchFamily="34" charset="-120"/>
               </a:rPr>
-              <a:t>The barrier–microbiota–inflammation axis in colorectal cancer: Mechanisms and em…</a:t>
+              <a:t>Circulating granulocyte colony-stimulating factor as a sex-unbiased global marke…</a:t>
             </a:r>
             <a:endParaRPr lang="en-US" sz="1400" dirty="0"/>
           </a:p>
@@ -4871,7 +4829,7 @@
                 <a:ea typeface="Arial" pitchFamily="34" charset="-122"/>
                 <a:cs typeface="Arial" pitchFamily="34" charset="-120"/>
               </a:rPr>
-              <a:t>Protocol for surgical stress-promoted colorectal cancer liver metastasis in mice…</a:t>
+              <a:t>Consensus Guideline for the Management of Colorectal Cancer with Peritoneal Meta…</a:t>
             </a:r>
             <a:endParaRPr lang="en-US" sz="1400" dirty="0"/>
           </a:p>
@@ -4908,7 +4866,7 @@
                 <a:ea typeface="Arial" pitchFamily="34" charset="-122"/>
                 <a:cs typeface="Arial" pitchFamily="34" charset="-120"/>
               </a:rPr>
-              <a:t>Discovery of APO-50815, a potent WEE1 kinase inhibitor with exceptional efficacy…</a:t>
+              <a:t>Evolving therapeutics in colorectal cancer peritoneal metastases</a:t>
             </a:r>
             <a:endParaRPr lang="en-US" sz="1400" dirty="0"/>
           </a:p>
@@ -5063,7 +5021,7 @@
                   </a:extLst>
                 </a:hlinkClick>
               </a:rPr>
-              <a:t>Dysbiotic microbiota trigger colitis-associated colorectal cancer and imprint a distinctive bile acid profile in a PSC-IBD model.</a:t>
+              <a:t>Enzyme/Reactive Oxygen Species-Dually Activated Hyaluronic Acid Nanocarriers Enable Celastrol Delivery for Site-Specific Therapy of Inflammatory Bowel Diseases and Colorectal Cancer.</a:t>
             </a:r>
             <a:endParaRPr lang="en-US" sz="2400" dirty="0"/>
           </a:p>
@@ -5099,7 +5057,7 @@
                   <a:srgbClr val="888888"/>
                 </a:solidFill>
               </a:rPr>
-              <a:t>Gut  ·  IF 24.5</a:t>
+              <a:t>International journal of nanomedicine  ·  Basic Research  ·  🌏 Asia</a:t>
             </a:r>
             <a:endParaRPr lang="en-US" sz="1000" dirty="0"/>
           </a:p>
@@ -5142,7 +5100,7 @@
                 <a:ea typeface="Arial" pitchFamily="34" charset="-122"/>
                 <a:cs typeface="Arial" pitchFamily="34" charset="-120"/>
               </a:rPr>
-              <a:t>PSC-UC shows higher dysplasia rates</a:t>
+              <a:t>Dual-responsive HA nanocarriers developed for therapy</a:t>
             </a:r>
             <a:endParaRPr lang="en-US" sz="1800" dirty="0"/>
           </a:p>
@@ -5163,7 +5121,7 @@
                 <a:ea typeface="Arial" pitchFamily="34" charset="-122"/>
                 <a:cs typeface="Arial" pitchFamily="34" charset="-120"/>
               </a:rPr>
-              <a:t>Microbiota influences colitis and cancer</a:t>
+              <a:t>Targeted delivery of Celastrol for UC and CAC</a:t>
             </a:r>
             <a:endParaRPr lang="en-US" sz="1800" dirty="0"/>
           </a:p>
@@ -5184,7 +5142,7 @@
                 <a:ea typeface="Arial" pitchFamily="34" charset="-122"/>
                 <a:cs typeface="Arial" pitchFamily="34" charset="-120"/>
               </a:rPr>
-              <a:t>Specific BA profiles linked to PSC-UC</a:t>
+              <a:t>Enhanced cellular uptake and macrophage polarization</a:t>
             </a:r>
             <a:endParaRPr lang="en-US" sz="1800" dirty="0"/>
           </a:p>
@@ -5205,7 +5163,7 @@
                 <a:ea typeface="Arial" pitchFamily="34" charset="-122"/>
                 <a:cs typeface="Arial" pitchFamily="34" charset="-120"/>
               </a:rPr>
-              <a:t>Germ-free mice resistant to colitis</a:t>
+              <a:t>Significant tumor burden reduction in colon cancer</a:t>
             </a:r>
             <a:endParaRPr lang="en-US" sz="1800" dirty="0"/>
           </a:p>
@@ -5226,7 +5184,7 @@
                 <a:ea typeface="Arial" pitchFamily="34" charset="-122"/>
                 <a:cs typeface="Arial" pitchFamily="34" charset="-120"/>
               </a:rPr>
-              <a:t>Restoring BA-transforming functions is key</a:t>
+              <a:t>Combination therapy boosts T cell infiltration</a:t>
             </a:r>
             <a:endParaRPr lang="en-US" sz="1800" dirty="0"/>
           </a:p>
@@ -5262,7 +5220,7 @@
                   <a:srgbClr val="888888"/>
                 </a:solidFill>
               </a:rPr>
-              <a:t>Awoniyi Muyiwa, El Hag Mohamed, Hernandez Josue et al.. Gut. 2026-08-06 DOI: 10.1136/gutjnl-2025-336675</a:t>
+              <a:t>Shi Jinfeng, Zhang Xueqian, Yang Linxing et al.. International journal of nanomedicine. 2026-08-15 DOI: 10.2147/IJN.S619486</a:t>
             </a:r>
             <a:endParaRPr lang="en-US" sz="800" dirty="0"/>
           </a:p>
@@ -5541,7 +5499,7 @@
                 <a:ea typeface="Arial" pitchFamily="34" charset="-122"/>
                 <a:cs typeface="Arial" pitchFamily="34" charset="-120"/>
               </a:rPr>
-              <a:t>5-FU causes intestinal mucositis.</a:t>
+              <a:t>5-FU causes intestinal mucositis during chemotherapy.</a:t>
             </a:r>
             <a:endParaRPr lang="en-US" sz="1800" dirty="0"/>
           </a:p>
@@ -5583,7 +5541,49 @@
                 <a:ea typeface="Arial" pitchFamily="34" charset="-122"/>
                 <a:cs typeface="Arial" pitchFamily="34" charset="-120"/>
               </a:rPr>
-              <a:t>DBPD reduces inflammation and barrier damage.</a:t>
+              <a:t>DBPD reduces inflammation and barrier dysfunction.</a:t>
+            </a:r>
+            <a:endParaRPr lang="en-US" sz="1800" dirty="0"/>
+          </a:p>
+          <a:p>
+            <a:pPr marL="342900" indent="-342900">
+              <a:spcAft>
+                <a:spcPts val="800"/>
+              </a:spcAft>
+              <a:buSzPct val="100000"/>
+              <a:buChar char="•"/>
+            </a:pPr>
+            <a:r>
+              <a:rPr lang="en-US" sz="1800" dirty="0">
+                <a:solidFill>
+                  <a:srgbClr val="333333"/>
+                </a:solidFill>
+                <a:latin typeface="Arial" pitchFamily="34" charset="0"/>
+                <a:ea typeface="Arial" pitchFamily="34" charset="-122"/>
+                <a:cs typeface="Arial" pitchFamily="34" charset="-120"/>
+              </a:rPr>
+              <a:t>Transcriptome analysis reveals key metabolic pathways.</a:t>
+            </a:r>
+            <a:endParaRPr lang="en-US" sz="1800" dirty="0"/>
+          </a:p>
+          <a:p>
+            <a:pPr marL="342900" indent="-342900">
+              <a:spcAft>
+                <a:spcPts val="800"/>
+              </a:spcAft>
+              <a:buSzPct val="100000"/>
+              <a:buChar char="•"/>
+            </a:pPr>
+            <a:r>
+              <a:rPr lang="en-US" sz="1800" dirty="0">
+                <a:solidFill>
+                  <a:srgbClr val="333333"/>
+                </a:solidFill>
+                <a:latin typeface="Arial" pitchFamily="34" charset="0"/>
+                <a:ea typeface="Arial" pitchFamily="34" charset="-122"/>
+                <a:cs typeface="Arial" pitchFamily="34" charset="-120"/>
+              </a:rPr>
+              <a:t>In vitro studies confirm DBPD's protective effects.</a:t>
             </a:r>
             <a:endParaRPr lang="en-US" sz="1800" dirty="0"/>
           </a:p>
@@ -5898,7 +5898,7 @@
                 <a:ea typeface="Arial" pitchFamily="34" charset="-122"/>
                 <a:cs typeface="Arial" pitchFamily="34" charset="-120"/>
               </a:rPr>
-              <a:t>SII as a prognostic biomarker in CRC</a:t>
+              <a:t>Systemic immune-inflammation index (SII) evaluated</a:t>
             </a:r>
             <a:endParaRPr lang="en-US" sz="1800" dirty="0"/>
           </a:p>
@@ -5919,7 +5919,7 @@
                 <a:ea typeface="Arial" pitchFamily="34" charset="-122"/>
                 <a:cs typeface="Arial" pitchFamily="34" charset="-120"/>
               </a:rPr>
-              <a:t>Inconsistent findings across studies</a:t>
+              <a:t>SII as a prognostic biomarker in CRC</a:t>
             </a:r>
             <a:endParaRPr lang="en-US" sz="1800" dirty="0"/>
           </a:p>
@@ -5940,7 +5940,7 @@
                 <a:ea typeface="Arial" pitchFamily="34" charset="-122"/>
                 <a:cs typeface="Arial" pitchFamily="34" charset="-120"/>
               </a:rPr>
-              <a:t>Meta-analysis confirms SII's value</a:t>
+              <a:t>Inconsistent findings across studies</a:t>
             </a:r>
             <a:endParaRPr lang="en-US" sz="1800" dirty="0"/>
           </a:p>
@@ -5961,7 +5961,7 @@
                 <a:ea typeface="Arial" pitchFamily="34" charset="-122"/>
                 <a:cs typeface="Arial" pitchFamily="34" charset="-120"/>
               </a:rPr>
-              <a:t>Potential for personalized treatment strategies</a:t>
+              <a:t>Meta-analysis conducted for clarity</a:t>
             </a:r>
             <a:endParaRPr lang="en-US" sz="1800" dirty="0"/>
           </a:p>
@@ -5982,7 +5982,7 @@
                 <a:ea typeface="Arial" pitchFamily="34" charset="-122"/>
                 <a:cs typeface="Arial" pitchFamily="34" charset="-120"/>
               </a:rPr>
-              <a:t>Need for standardized measurement protocols</a:t>
+              <a:t>Potential clinical application of SII</a:t>
             </a:r>
             <a:endParaRPr lang="en-US" sz="1800" dirty="0"/>
           </a:p>
@@ -6218,7 +6218,7 @@
                   </a:extLst>
                 </a:hlinkClick>
               </a:rPr>
-              <a:t>Predictive utility of the C-reactive protein-albumin-lymphocyte (CALLY) index in Colorectal cancer: A meta-analysis</a:t>
+              <a:t>Iron, inflammation, and intestinal tumors: the crucial triad in colorectal cancer progression and therapy</a:t>
             </a:r>
             <a:endParaRPr lang="en-US" sz="2400" dirty="0"/>
           </a:p>
@@ -6254,7 +6254,7 @@
                   <a:srgbClr val="888888"/>
                 </a:solidFill>
               </a:rPr>
-              <a:t>Clinics and Research in Hepatology and …  ·  Meta-Analysis</a:t>
+              <a:t>Clinical and …  ·  Prospective Study</a:t>
             </a:r>
             <a:endParaRPr lang="en-US" sz="1000" dirty="0"/>
           </a:p>
@@ -6297,7 +6297,7 @@
                 <a:ea typeface="Arial" pitchFamily="34" charset="-122"/>
                 <a:cs typeface="Arial" pitchFamily="34" charset="-120"/>
               </a:rPr>
-              <a:t>CALLY index predicts colorectal cancer outcomes.</a:t>
+              <a:t>Iron intake linked to CRC risk increase</a:t>
             </a:r>
             <a:endParaRPr lang="en-US" sz="1800" dirty="0"/>
           </a:p>
@@ -6318,7 +6318,7 @@
                 <a:ea typeface="Arial" pitchFamily="34" charset="-122"/>
                 <a:cs typeface="Arial" pitchFamily="34" charset="-120"/>
               </a:rPr>
-              <a:t>Inflammation and immune function are key factors.</a:t>
+              <a:t>Inflammation plays a significant role</a:t>
             </a:r>
             <a:endParaRPr lang="en-US" sz="1800" dirty="0"/>
           </a:p>
@@ -6339,7 +6339,7 @@
                 <a:ea typeface="Arial" pitchFamily="34" charset="-122"/>
                 <a:cs typeface="Arial" pitchFamily="34" charset="-120"/>
               </a:rPr>
-              <a:t>Meta-analysis supports CALLY's predictive utility.</a:t>
+              <a:t>Heme iron consumption raises concerns</a:t>
             </a:r>
             <a:endParaRPr lang="en-US" sz="1800" dirty="0"/>
           </a:p>
@@ -6375,7 +6375,7 @@
                   <a:srgbClr val="888888"/>
                 </a:solidFill>
               </a:rPr>
-              <a:t>X Li, T Chu, W Chen. Clinics and Research in Hepatology and …. 2026</a:t>
+              <a:t>M Abediasl, M Siavash, SS Esfahani. Clinical and …. 2026</a:t>
             </a:r>
             <a:endParaRPr lang="en-US" sz="800" dirty="0"/>
           </a:p>
@@ -6575,7 +6575,7 @@
                   </a:extLst>
                 </a:hlinkClick>
               </a:rPr>
-              <a:t>Association of four non-insulin-based insulin resistance surrogate markers with colorectal cancer risk: a large-scale prospective cohort study using the UK …</a:t>
+              <a:t>Neutrophil extracellular traps in colorectal cancer: context-dependent roles from inflammatory carcinogenesis to liver metastasis and therapeutic targeting</a:t>
             </a:r>
             <a:endParaRPr lang="en-US" sz="2400" dirty="0"/>
           </a:p>
@@ -6611,7 +6611,7 @@
                   <a:srgbClr val="888888"/>
                 </a:solidFill>
               </a:rPr>
-              <a:t>Frontiers in …  ·  Prospective Study</a:t>
+              <a:t>Journal of Translational Medicine  ·  IF 6.1</a:t>
             </a:r>
             <a:endParaRPr lang="en-US" sz="1000" dirty="0"/>
           </a:p>
@@ -6654,7 +6654,7 @@
                 <a:ea typeface="Arial" pitchFamily="34" charset="-122"/>
                 <a:cs typeface="Arial" pitchFamily="34" charset="-120"/>
               </a:rPr>
-              <a:t>Study on insulin resistance markers</a:t>
+              <a:t>Neutrophil extracellular traps (NETs) in CRC</a:t>
             </a:r>
             <a:endParaRPr lang="en-US" sz="1800" dirty="0"/>
           </a:p>
@@ -6675,7 +6675,7 @@
                 <a:ea typeface="Arial" pitchFamily="34" charset="-122"/>
                 <a:cs typeface="Arial" pitchFamily="34" charset="-120"/>
               </a:rPr>
-              <a:t>Focus on colorectal cancer risk</a:t>
+              <a:t>Role of inflammation in carcinogenesis</a:t>
             </a:r>
             <a:endParaRPr lang="en-US" sz="1800" dirty="0"/>
           </a:p>
@@ -6696,7 +6696,7 @@
                 <a:ea typeface="Arial" pitchFamily="34" charset="-122"/>
                 <a:cs typeface="Arial" pitchFamily="34" charset="-120"/>
               </a:rPr>
-              <a:t>Large-scale prospective cohort analysis</a:t>
+              <a:t>NETs contribute to liver metastasis</a:t>
             </a:r>
             <a:endParaRPr lang="en-US" sz="1800" dirty="0"/>
           </a:p>
@@ -6717,7 +6717,7 @@
                 <a:ea typeface="Arial" pitchFamily="34" charset="-122"/>
                 <a:cs typeface="Arial" pitchFamily="34" charset="-120"/>
               </a:rPr>
-              <a:t>Association with chronic inflammation</a:t>
+              <a:t>Therapeutic targeting of NETs explored</a:t>
             </a:r>
             <a:endParaRPr lang="en-US" sz="1800" dirty="0"/>
           </a:p>
@@ -6738,7 +6738,7 @@
                 <a:ea typeface="Arial" pitchFamily="34" charset="-122"/>
                 <a:cs typeface="Arial" pitchFamily="34" charset="-120"/>
               </a:rPr>
-              <a:t>Potential role of estrogen</a:t>
+              <a:t>Context-dependent functions of NETs</a:t>
             </a:r>
             <a:endParaRPr lang="en-US" sz="1800" dirty="0"/>
           </a:p>
@@ -6774,7 +6774,7 @@
                   <a:srgbClr val="888888"/>
                 </a:solidFill>
               </a:rPr>
-              <a:t>Y Ding, J Wang, N Wang. Frontiers in …. 2026</a:t>
+              <a:t>D Xu, R Wang, J Tan. Journal of Translational Medicine. 2026</a:t>
             </a:r>
             <a:endParaRPr lang="en-US" sz="800" dirty="0"/>
           </a:p>
@@ -6974,7 +6974,7 @@
                   </a:extLst>
                 </a:hlinkClick>
               </a:rPr>
-              <a:t>A conserved Notch-Meis1-Pbx cascade specifies secretory progenitors into spatially diverse intestinal best4 + cells.</a:t>
+              <a:t>Hierarchical core-shell nanoplatform with sequential Mn2+/Co2+ release enables dual-track STING amplification and radiosensitization for potent radio-metalloimmunotherapy.</a:t>
             </a:r>
             <a:endParaRPr lang="en-US" sz="2400" dirty="0"/>
           </a:p>
@@ -7010,7 +7010,7 @@
                   <a:srgbClr val="888888"/>
                 </a:solidFill>
               </a:rPr>
-              <a:t>Genes &amp; development  ·  Basic Research</a:t>
+              <a:t>Acta biomaterialia  ·  Basic Research</a:t>
             </a:r>
             <a:endParaRPr lang="en-US" sz="1000" dirty="0"/>
           </a:p>
@@ -7053,7 +7053,7 @@
                 <a:ea typeface="Arial" pitchFamily="34" charset="-122"/>
                 <a:cs typeface="Arial" pitchFamily="34" charset="-120"/>
               </a:rPr>
-              <a:t>best4 + cells are important intestinal epithelial types</a:t>
+              <a:t>Developed hierarchical core-shell nanoplatform</a:t>
             </a:r>
             <a:endParaRPr lang="en-US" sz="1800" dirty="0"/>
           </a:p>
@@ -7074,7 +7074,7 @@
                 <a:ea typeface="Arial" pitchFamily="34" charset="-122"/>
                 <a:cs typeface="Arial" pitchFamily="34" charset="-120"/>
               </a:rPr>
-              <a:t>Zebrafish model used for in vivo studies</a:t>
+              <a:t>Integrates radiosensitization with STING amplification</a:t>
             </a:r>
             <a:endParaRPr lang="en-US" sz="1800" dirty="0"/>
           </a:p>
@@ -7095,7 +7095,7 @@
                 <a:ea typeface="Arial" pitchFamily="34" charset="-122"/>
                 <a:cs typeface="Arial" pitchFamily="34" charset="-120"/>
               </a:rPr>
-              <a:t>Notch/Dll4 signaling regulates cell fate</a:t>
+              <a:t>Sequential release of Mn2+ and Co2+ ions</a:t>
             </a:r>
             <a:endParaRPr lang="en-US" sz="1800" dirty="0"/>
           </a:p>
@@ -7116,7 +7116,7 @@
                 <a:ea typeface="Arial" pitchFamily="34" charset="-122"/>
                 <a:cs typeface="Arial" pitchFamily="34" charset="-120"/>
               </a:rPr>
-              <a:t>meis1b and pbx3a specify best4 + cells</a:t>
+              <a:t>Transforms 'cold' tumors into 'hot' lesions</a:t>
             </a:r>
             <a:endParaRPr lang="en-US" sz="1800" dirty="0"/>
           </a:p>
@@ -7137,7 +7137,7 @@
                 <a:ea typeface="Arial" pitchFamily="34" charset="-122"/>
                 <a:cs typeface="Arial" pitchFamily="34" charset="-120"/>
               </a:rPr>
-              <a:t>best4 + cells respond to luminal pH changes</a:t>
+              <a:t>Establishes new radio-metalloimmunotherapy paradigm</a:t>
             </a:r>
             <a:endParaRPr lang="en-US" sz="1800" dirty="0"/>
           </a:p>
@@ -7173,7 +7173,7 @@
                   <a:srgbClr val="888888"/>
                 </a:solidFill>
               </a:rPr>
-              <a:t>Sur Abhinav, Segal Ella X, Nunneley Michael P et al.. Genes &amp; development. 2026-08-07 DOI: 10.1101/gad.353662.126</a:t>
+              <a:t>Luo Baiyi, Xiang Qingming, Xie Yingling et al.. Acta biomaterialia. 2026-08-13 DOI: 10.1016/j.actbio.2026.08.012</a:t>
             </a:r>
             <a:endParaRPr lang="en-US" sz="800" dirty="0"/>
           </a:p>
@@ -7373,7 +7373,7 @@
                   </a:extLst>
                 </a:hlinkClick>
               </a:rPr>
-              <a:t>HO-1 Up-regulation and PINK1/Parkin-Mediated Mitophagy Contribute to the Anti-tumor Effects of Metochalcone in Colorectal Cancer.</a:t>
+              <a:t>The barrier–microbiota–inflammation axis in colorectal cancer: Mechanisms and emerging diagnostic &amp; therapeutic strategies</a:t>
             </a:r>
             <a:endParaRPr lang="en-US" sz="2400" dirty="0"/>
           </a:p>
@@ -7409,7 +7409,7 @@
                   <a:srgbClr val="888888"/>
                 </a:solidFill>
               </a:rPr>
-              <a:t>Research (Washington, D.C.)  ·  Basic Research</a:t>
+              <a:t>Cancers  ·  Basic Research</a:t>
             </a:r>
             <a:endParaRPr lang="en-US" sz="1000" dirty="0"/>
           </a:p>
@@ -7452,7 +7452,7 @@
                 <a:ea typeface="Arial" pitchFamily="34" charset="-122"/>
                 <a:cs typeface="Arial" pitchFamily="34" charset="-120"/>
               </a:rPr>
-              <a:t>Metochalcone reduces CRC cell viability significantly.</a:t>
+              <a:t>LPS triggers pro-inflammatory cytokines secretion</a:t>
             </a:r>
             <a:endParaRPr lang="en-US" sz="1800" dirty="0"/>
           </a:p>
@@ -7473,7 +7473,7 @@
                 <a:ea typeface="Arial" pitchFamily="34" charset="-122"/>
                 <a:cs typeface="Arial" pitchFamily="34" charset="-120"/>
               </a:rPr>
-              <a:t>HO-1 identified as a key target in CRC.</a:t>
+              <a:t>Downregulates tight junction proteins in epithelium</a:t>
             </a:r>
             <a:endParaRPr lang="en-US" sz="1800" dirty="0"/>
           </a:p>
@@ -7494,7 +7494,7 @@
                 <a:ea typeface="Arial" pitchFamily="34" charset="-122"/>
                 <a:cs typeface="Arial" pitchFamily="34" charset="-120"/>
               </a:rPr>
-              <a:t>MET activates PINK1/Parkin-mediated mitophagy.</a:t>
+              <a:t>Promotes epithelial cell migration and invasion</a:t>
             </a:r>
             <a:endParaRPr lang="en-US" sz="1800" dirty="0"/>
           </a:p>
@@ -7515,7 +7515,7 @@
                 <a:ea typeface="Arial" pitchFamily="34" charset="-122"/>
                 <a:cs typeface="Arial" pitchFamily="34" charset="-120"/>
               </a:rPr>
-              <a:t>Tumor growth suppression observed in mouse models.</a:t>
+              <a:t>Microbiota influences inflammation in CRC</a:t>
             </a:r>
             <a:endParaRPr lang="en-US" sz="1800" dirty="0"/>
           </a:p>
@@ -7536,7 +7536,7 @@
                 <a:ea typeface="Arial" pitchFamily="34" charset="-122"/>
                 <a:cs typeface="Arial" pitchFamily="34" charset="-120"/>
               </a:rPr>
-              <a:t>MET alters gut microbiota composition positively.</a:t>
+              <a:t>Emerging strategies for diagnosis and therapy</a:t>
             </a:r>
             <a:endParaRPr lang="en-US" sz="1800" dirty="0"/>
           </a:p>
@@ -7572,7 +7572,7 @@
                   <a:srgbClr val="888888"/>
                 </a:solidFill>
               </a:rPr>
-              <a:t>Chen Pingting, An Junsha, Han Mingyu et al.. Research (Washington, D.C.). 2026-08-05 DOI: 10.34133/research.1387</a:t>
+              <a:t>X Dong, J Yang, L He. Cancers. 2026</a:t>
             </a:r>
             <a:endParaRPr lang="en-US" sz="800" dirty="0"/>
           </a:p>

</xml_diff>

<commit_message>
chore: update weekly digest 2026-08-24
</commit_message>
<xml_diff>
--- a/docs/digest-en.pptx
+++ b/docs/digest-en.pptx
@@ -2249,7 +2249,7 @@
                   <a:srgbClr val="888888"/>
                 </a:solidFill>
               </a:rPr>
-              <a:t>2026-08-10 — 2026-08-17</a:t>
+              <a:t>2026-08-17 — 2026-08-24</a:t>
             </a:r>
             <a:endParaRPr lang="en-US" sz="1400" dirty="0"/>
           </a:p>
@@ -2440,7 +2440,7 @@
                   </a:extLst>
                 </a:hlinkClick>
               </a:rPr>
-              <a:t>Circulating granulocyte colony-stimulating factor as a sex-unbiased global marker of lung and colorectal cancer cachexia pre-clinical models.</a:t>
+              <a:t>The barrier–microbiota–inflammation axis in colorectal cancer: Mechanisms and emerging diagnostic &amp; therapeutic strategies</a:t>
             </a:r>
             <a:endParaRPr lang="en-US" sz="2400" dirty="0"/>
           </a:p>
@@ -2476,7 +2476,7 @@
                   <a:srgbClr val="888888"/>
                 </a:solidFill>
               </a:rPr>
-              <a:t>Experimental physiology</a:t>
+              <a:t>Cancers  ·  Basic Research</a:t>
             </a:r>
             <a:endParaRPr lang="en-US" sz="1000" dirty="0"/>
           </a:p>
@@ -2519,7 +2519,7 @@
                 <a:ea typeface="Arial" pitchFamily="34" charset="-122"/>
                 <a:cs typeface="Arial" pitchFamily="34" charset="-120"/>
               </a:rPr>
-              <a:t>Cancer cachexia affects up to 80% of patients.</a:t>
+              <a:t>LPS triggers pro-inflammatory cytokines secretion</a:t>
             </a:r>
             <a:endParaRPr lang="en-US" sz="1800" dirty="0"/>
           </a:p>
@@ -2540,7 +2540,7 @@
                 <a:ea typeface="Arial" pitchFamily="34" charset="-122"/>
                 <a:cs typeface="Arial" pitchFamily="34" charset="-120"/>
               </a:rPr>
-              <a:t>G-CSF levels correlate with muscle mass loss.</a:t>
+              <a:t>Downregulates tight junction proteins in epithelium</a:t>
             </a:r>
             <a:endParaRPr lang="en-US" sz="1800" dirty="0"/>
           </a:p>
@@ -2561,7 +2561,7 @@
                 <a:ea typeface="Arial" pitchFamily="34" charset="-122"/>
                 <a:cs typeface="Arial" pitchFamily="34" charset="-120"/>
               </a:rPr>
-              <a:t>Cytokine profiles analyzed in multiple models.</a:t>
+              <a:t>Promotes epithelial cell migration and invasion</a:t>
             </a:r>
             <a:endParaRPr lang="en-US" sz="1800" dirty="0"/>
           </a:p>
@@ -2582,7 +2582,7 @@
                 <a:ea typeface="Arial" pitchFamily="34" charset="-122"/>
                 <a:cs typeface="Arial" pitchFamily="34" charset="-120"/>
               </a:rPr>
-              <a:t>Interactive app developed for cytokine visualization.</a:t>
+              <a:t>Identifies microbiota's role in colorectal cancer</a:t>
             </a:r>
             <a:endParaRPr lang="en-US" sz="1800" dirty="0"/>
           </a:p>
@@ -2603,7 +2603,7 @@
                 <a:ea typeface="Arial" pitchFamily="34" charset="-122"/>
                 <a:cs typeface="Arial" pitchFamily="34" charset="-120"/>
               </a:rPr>
-              <a:t>G-CSF:IL-13 ratio as a potential biomarker.</a:t>
+              <a:t>Emerging diagnostic and therapeutic strategies</a:t>
             </a:r>
             <a:endParaRPr lang="en-US" sz="1800" dirty="0"/>
           </a:p>
@@ -2639,7 +2639,7 @@
                   <a:srgbClr val="888888"/>
                 </a:solidFill>
               </a:rPr>
-              <a:t>Morena Francielly, Schrems Eleanor R, Cabrera Ana Regina et al.. Experimental physiology. 2026-08-15 DOI: 10.1113/EP093809</a:t>
+              <a:t>X Dong, J Yang, L He. Cancers. 2026</a:t>
             </a:r>
             <a:endParaRPr lang="en-US" sz="800" dirty="0"/>
           </a:p>
@@ -2839,7 +2839,7 @@
                   </a:extLst>
                 </a:hlinkClick>
               </a:rPr>
-              <a:t>Consensus Guideline for the Management of Colorectal Cancer with Peritoneal Metastases: PSM Writing Group et al.</a:t>
+              <a:t>LRMDA promotes intestinal mucosal barrier integrity and limits colitis and colon cancer.</a:t>
             </a:r>
             <a:endParaRPr lang="en-US" sz="2400" dirty="0"/>
           </a:p>
@@ -2875,7 +2875,7 @@
                   <a:srgbClr val="888888"/>
                 </a:solidFill>
               </a:rPr>
-              <a:t>Annals of surgical …</a:t>
+              <a:t>iScience</a:t>
             </a:r>
             <a:endParaRPr lang="en-US" sz="1000" dirty="0"/>
           </a:p>
@@ -2918,7 +2918,7 @@
                 <a:ea typeface="Arial" pitchFamily="34" charset="-122"/>
                 <a:cs typeface="Arial" pitchFamily="34" charset="-120"/>
               </a:rPr>
-              <a:t>Peritoneum frequently affected by CRC metastases.</a:t>
+              <a:t>LRMDA downregulated in IBD tissues.</a:t>
             </a:r>
             <a:endParaRPr lang="en-US" sz="1800" dirty="0"/>
           </a:p>
@@ -2939,7 +2939,7 @@
                 <a:ea typeface="Arial" pitchFamily="34" charset="-122"/>
                 <a:cs typeface="Arial" pitchFamily="34" charset="-120"/>
               </a:rPr>
-              <a:t>Management guidelines aim to standardize treatment.</a:t>
+              <a:t>Genetic ablation worsens colitis symptoms.</a:t>
             </a:r>
             <a:endParaRPr lang="en-US" sz="1800" dirty="0"/>
           </a:p>
@@ -2960,7 +2960,49 @@
                 <a:ea typeface="Arial" pitchFamily="34" charset="-122"/>
                 <a:cs typeface="Arial" pitchFamily="34" charset="-120"/>
               </a:rPr>
-              <a:t>Consensus reached among expert panel members.</a:t>
+              <a:t>LRMDA deficiency linked to tumorigenesis.</a:t>
+            </a:r>
+            <a:endParaRPr lang="en-US" sz="1800" dirty="0"/>
+          </a:p>
+          <a:p>
+            <a:pPr marL="342900" indent="-342900">
+              <a:spcAft>
+                <a:spcPts val="800"/>
+              </a:spcAft>
+              <a:buSzPct val="100000"/>
+              <a:buChar char="•"/>
+            </a:pPr>
+            <a:r>
+              <a:rPr lang="en-US" sz="1800" dirty="0">
+                <a:solidFill>
+                  <a:srgbClr val="333333"/>
+                </a:solidFill>
+                <a:latin typeface="Arial" pitchFamily="34" charset="0"/>
+                <a:ea typeface="Arial" pitchFamily="34" charset="-122"/>
+                <a:cs typeface="Arial" pitchFamily="34" charset="-120"/>
+              </a:rPr>
+              <a:t>Impaired mucin expression and barrier integrity.</a:t>
+            </a:r>
+            <a:endParaRPr lang="en-US" sz="1800" dirty="0"/>
+          </a:p>
+          <a:p>
+            <a:pPr marL="342900" indent="-342900">
+              <a:spcAft>
+                <a:spcPts val="800"/>
+              </a:spcAft>
+              <a:buSzPct val="100000"/>
+              <a:buChar char="•"/>
+            </a:pPr>
+            <a:r>
+              <a:rPr lang="en-US" sz="1800" dirty="0">
+                <a:solidFill>
+                  <a:srgbClr val="333333"/>
+                </a:solidFill>
+                <a:latin typeface="Arial" pitchFamily="34" charset="0"/>
+                <a:ea typeface="Arial" pitchFamily="34" charset="-122"/>
+                <a:cs typeface="Arial" pitchFamily="34" charset="-120"/>
+              </a:rPr>
+              <a:t>Supports goblet cell mucin transport.</a:t>
             </a:r>
             <a:endParaRPr lang="en-US" sz="1800" dirty="0"/>
           </a:p>
@@ -2996,7 +3038,7 @@
                   <a:srgbClr val="888888"/>
                 </a:solidFill>
               </a:rPr>
-              <a:t>KS Schultz, VV Bansal, MM Wach. Annals of surgical …. 2026</a:t>
+              <a:t>Yang Liping, Guo Yuyao, Xiao Bikun et al.. iScience. 2026-07-26 DOI: 10.1016/j.isci.2026.116785</a:t>
             </a:r>
             <a:endParaRPr lang="en-US" sz="800" dirty="0"/>
           </a:p>
@@ -3196,7 +3238,7 @@
                   </a:extLst>
                 </a:hlinkClick>
               </a:rPr>
-              <a:t>Evolving therapeutics in colorectal cancer peritoneal metastases</a:t>
+              <a:t>Tumor-driven arginine depletion induces T-cell metabolism reprogramming to suppress atherosclerosis in colorectal cancer.</a:t>
             </a:r>
             <a:endParaRPr lang="en-US" sz="2400" dirty="0"/>
           </a:p>
@@ -3232,7 +3274,7 @@
                   <a:srgbClr val="888888"/>
                 </a:solidFill>
               </a:rPr>
-              <a:t>Cancer and Metastasis …</a:t>
+              <a:t>Acta pharmacologica Sinica</a:t>
             </a:r>
             <a:endParaRPr lang="en-US" sz="1000" dirty="0"/>
           </a:p>
@@ -3275,7 +3317,7 @@
                 <a:ea typeface="Arial" pitchFamily="34" charset="-122"/>
                 <a:cs typeface="Arial" pitchFamily="34" charset="-120"/>
               </a:rPr>
-              <a:t>Colorectal cancer peritoneal metastases are aggressive.</a:t>
+              <a:t>Colorectal cancer affects atherosclerosis development.</a:t>
             </a:r>
             <a:endParaRPr lang="en-US" sz="1800" dirty="0"/>
           </a:p>
@@ -3296,7 +3338,7 @@
                 <a:ea typeface="Arial" pitchFamily="34" charset="-122"/>
                 <a:cs typeface="Arial" pitchFamily="34" charset="-120"/>
               </a:rPr>
-              <a:t>Cytoreductive surgery improves survival rates.</a:t>
+              <a:t>Tumors deplete arginine, altering T-cell metabolism.</a:t>
             </a:r>
             <a:endParaRPr lang="en-US" sz="1800" dirty="0"/>
           </a:p>
@@ -3317,7 +3359,7 @@
                 <a:ea typeface="Arial" pitchFamily="34" charset="-122"/>
                 <a:cs typeface="Arial" pitchFamily="34" charset="-120"/>
               </a:rPr>
-              <a:t>Hyperthermic intraperitoneal chemotherapy is effective.</a:t>
+              <a:t>Dietary arginine restores T-cell activation.</a:t>
             </a:r>
             <a:endParaRPr lang="en-US" sz="1800" dirty="0"/>
           </a:p>
@@ -3353,7 +3395,7 @@
                   <a:srgbClr val="888888"/>
                 </a:solidFill>
               </a:rPr>
-              <a:t>JM Bader, N Aguirre, KS Schultz. Cancer and Metastasis …. 2026</a:t>
+              <a:t>Ni Wen-Jun, Sun He-Yang, Chen Meng-Lei et al.. Acta pharmacologica Sinica. 2026-08-18 DOI: 10.1038/s41401-026-01899-2</a:t>
             </a:r>
             <a:endParaRPr lang="en-US" sz="800" dirty="0"/>
           </a:p>
@@ -3570,7 +3612,7 @@
                   <a:srgbClr val="FFFFFF"/>
                 </a:solidFill>
               </a:rPr>
-              <a:t>1. **雙重激活納米載體的潛力**  </a:t>
+              <a:t>1. **系統免疫炎症指數的預後價值**  </a:t>
             </a:r>
             <a:endParaRPr lang="en-US" sz="1200" dirty="0"/>
           </a:p>
@@ -3587,7 +3629,7 @@
                   <a:srgbClr val="FFFFFF"/>
                 </a:solidFill>
               </a:rPr>
-              <a:t>   The development of enzyme/reactive oxygen species-dually activated hyaluronic acid nanocarriers showcases a promising approach for targeted therapy in inflammatory bowel diseases and colorectal cancer, addressing both inflammation and tumor progression.  </a:t>
+              <a:t>   The systemic immune-inflammation index (SII) has emerged as a potential prognostic biomarker for colorectal cancer (CRC), although its predictive reliability remains inconsistent across studies.  </a:t>
             </a:r>
             <a:endParaRPr lang="en-US" sz="1200" dirty="0"/>
           </a:p>
@@ -3604,7 +3646,7 @@
                   <a:srgbClr val="FFFFFF"/>
                 </a:solidFill>
               </a:rPr>
-              <a:t>   雙重激活的透明質酸納米載體的開發展示了在炎症性腸病和結直腸癌的靶向治療中具有潛力的方法，針對炎症和腫瘤進展。</a:t>
+              <a:t>   系統免疫炎症指數（SII）已成為大腸癌（CRC）潛在的預後生物標記，儘管其預測可靠性在不同研究中仍不一致。</a:t>
             </a:r>
             <a:endParaRPr lang="en-US" sz="1200" dirty="0"/>
           </a:p>
@@ -3630,7 +3672,7 @@
                   <a:srgbClr val="FFFFFF"/>
                 </a:solidFill>
               </a:rPr>
-              <a:t>2. **系統免疫炎症指數的預後價值**  </a:t>
+              <a:t>2. **炎症與腫瘤進展的關聯**  </a:t>
             </a:r>
             <a:endParaRPr lang="en-US" sz="1200" dirty="0"/>
           </a:p>
@@ -3647,7 +3689,7 @@
                   <a:srgbClr val="FFFFFF"/>
                 </a:solidFill>
               </a:rPr>
-              <a:t>   The systemic immune-inflammation index (SII) emerges as a significant prognostic biomarker for colorectal cancer, although its effectiveness is hindered by inconsistent findings across studies, indicating a need for standardized assessment methods.  </a:t>
+              <a:t>   Chronic inflammation plays a significant role in colorectal cancer progression, highlighting the need for further exploration of inflammatory markers and their therapeutic implications.  </a:t>
             </a:r>
             <a:endParaRPr lang="en-US" sz="1200" dirty="0"/>
           </a:p>
@@ -3664,7 +3706,7 @@
                   <a:srgbClr val="FFFFFF"/>
                 </a:solidFill>
               </a:rPr>
-              <a:t>   系統免疫炎症指數（SII）作為結直腸癌的重要預後生物標記，儘管其有效性受到研究結果不一致的限制，顯示出需要標準化評估方法的必要性。</a:t>
+              <a:t>   慢性炎症在大腸癌進展中扮演重要角色，強調需要進一步探索炎症標記及其治療意涵。</a:t>
             </a:r>
             <a:endParaRPr lang="en-US" sz="1200" dirty="0"/>
           </a:p>
@@ -3690,7 +3732,7 @@
                   <a:srgbClr val="FFFFFF"/>
                 </a:solidFill>
               </a:rPr>
-              <a:t>3. **腸道微生物與炎症的交互作用**  </a:t>
+              <a:t>3. **微生物群與腫瘤微環境的相互作用**  </a:t>
             </a:r>
             <a:endParaRPr lang="en-US" sz="1200" dirty="0"/>
           </a:p>
@@ -3707,7 +3749,7 @@
                   <a:srgbClr val="FFFFFF"/>
                 </a:solidFill>
               </a:rPr>
-              <a:t>   The barrier-microbiota-inflammation axis plays a crucial role in colorectal cancer progression, highlighting the importance of microbiome modulation as a therapeutic strategy.  </a:t>
+              <a:t>   The interaction between gut microbiota and the tumor microenvironment is crucial in CRC, suggesting that microbiome-targeted therapies could be a promising avenue for treatment.  </a:t>
             </a:r>
             <a:endParaRPr lang="en-US" sz="1200" dirty="0"/>
           </a:p>
@@ -3724,7 +3766,7 @@
                   <a:srgbClr val="FFFFFF"/>
                 </a:solidFill>
               </a:rPr>
-              <a:t>   障壁-微生物-炎症軸在結直腸癌進展中扮演重要角色，突顯了微生物群調節作為治療策略的重要性。</a:t>
+              <a:t>   腸道微生物群與腫瘤微環境之間的相互作用在大腸癌中至關重要，這表明以微生物群為目標的治療可能是有前景的途徑。</a:t>
             </a:r>
             <a:endParaRPr lang="en-US" sz="1200" dirty="0"/>
           </a:p>
@@ -3750,7 +3792,7 @@
                   <a:srgbClr val="FFFFFF"/>
                 </a:solidFill>
               </a:rPr>
-              <a:t>4. **癌症惡病質的全身標記**  </a:t>
+              <a:t>4. **新型納米藥物的潛力**  </a:t>
             </a:r>
             <a:endParaRPr lang="en-US" sz="1200" dirty="0"/>
           </a:p>
@@ -3767,7 +3809,7 @@
                   <a:srgbClr val="FFFFFF"/>
                 </a:solidFill>
               </a:rPr>
-              <a:t>   Circulating granulocyte colony-stimulating factor is identified as a global marker for cancer cachexia, emphasizing the need for further exploration of its role in metabolic and inflammatory dysregulation in colorectal cancer.  </a:t>
+              <a:t>   Hybrid nanoparticles that target both tumor suppression and iron homeostasis show promise in treating CRC and associated anemia, indicating a shift towards multifunctional therapeutic strategies.  </a:t>
             </a:r>
             <a:endParaRPr lang="en-US" sz="1200" dirty="0"/>
           </a:p>
@@ -3784,7 +3826,7 @@
                   <a:srgbClr val="FFFFFF"/>
                 </a:solidFill>
               </a:rPr>
-              <a:t>   循環顆粒單核細胞刺激因子被確定為癌症惡病質的全身標記，強調需要進一步探索其在結直腸癌中代謝和炎症失調的作用。</a:t>
+              <a:t>   針對腫瘤抑制和鐵穩態的混合納米藥物在治療大腸癌及相關貧血方面顯示出潛力，表明治療策略正向多功能化轉變。</a:t>
             </a:r>
             <a:endParaRPr lang="en-US" sz="1200" dirty="0"/>
           </a:p>
@@ -3810,7 +3852,7 @@
                   <a:srgbClr val="FFFFFF"/>
                 </a:solidFill>
               </a:rPr>
-              <a:t>5. **腫瘤微環境的挑戰**  </a:t>
+              <a:t>5. **免疫逃逸機制的研究**  </a:t>
             </a:r>
             <a:endParaRPr lang="en-US" sz="1200" dirty="0"/>
           </a:p>
@@ -3827,7 +3869,7 @@
                   <a:srgbClr val="FFFFFF"/>
                 </a:solidFill>
               </a:rPr>
-              <a:t>   The immunosuppressive tumor microenvironment presents significant barriers to effective cancer immunotherapy, necessitating innovative strategies to enhance immune response and therapeutic efficacy.</a:t>
+              <a:t>   Understanding the mechanisms of immune evasion in CRC, particularly through pathways involving macrophages and tumor microenvironments, is critical for developing effective immunotherapies.</a:t>
             </a:r>
             <a:endParaRPr lang="en-US" sz="1200" dirty="0"/>
           </a:p>
@@ -3973,7 +4015,7 @@
                   <a:srgbClr val="FFFFFF"/>
                 </a:solidFill>
               </a:rPr>
-              <a:t>免疫抑制的腫瘤微環境對有效的癌症免疫治療構成重大障礙，需要創新的策略來增強免疫反應和治療效果。</a:t>
+              <a:t>理解大腸癌中免疫逃逸的機制，特別是涉及巨噬細胞和腫瘤微環境的途徑，對於開發有效的免疫療法至關重要。</a:t>
             </a:r>
             <a:endParaRPr lang="en-US" sz="1200" dirty="0"/>
           </a:p>
@@ -4025,7 +4067,7 @@
                   <a:srgbClr val="FFFFFF"/>
                 </a:solidFill>
               </a:rPr>
-              <a:t>1. **納米載體的臨床應用**  </a:t>
+              <a:t>1. **標準化SII的應用**  </a:t>
             </a:r>
             <a:endParaRPr lang="en-US" sz="1200" dirty="0"/>
           </a:p>
@@ -4042,7 +4084,7 @@
                   <a:srgbClr val="FFFFFF"/>
                 </a:solidFill>
               </a:rPr>
-              <a:t>   Future studies should focus on the clinical translation of dual-activated nanocarriers for targeted delivery of therapeutics in colorectal cancer and inflammatory bowel diseases.  </a:t>
+              <a:t>   Future studies should focus on standardizing the application of the systemic immune-inflammation index (SII) in clinical settings to improve its prognostic accuracy in CRC.  </a:t>
             </a:r>
             <a:endParaRPr lang="en-US" sz="1200" dirty="0"/>
           </a:p>
@@ -4059,7 +4101,7 @@
                   <a:srgbClr val="FFFFFF"/>
                 </a:solidFill>
               </a:rPr>
-              <a:t>   未來的研究應專注於雙重激活納米載體在結直腸癌和炎症性腸病中靶向治療藥物的臨床應用。</a:t>
+              <a:t>   未來研究應專注於標準化系統免疫炎症指數（SII）在臨床環境中的應用，以提高其在大腸癌中的預後準確性。</a:t>
             </a:r>
             <a:endParaRPr lang="en-US" sz="1200" dirty="0"/>
           </a:p>
@@ -4085,7 +4127,7 @@
                   <a:srgbClr val="FFFFFF"/>
                 </a:solidFill>
               </a:rPr>
-              <a:t>2. **標準化的SII評估**  </a:t>
+              <a:t>2. **炎症標記的臨床應用**  </a:t>
             </a:r>
             <a:endParaRPr lang="en-US" sz="1200" dirty="0"/>
           </a:p>
@@ -4102,7 +4144,7 @@
                   <a:srgbClr val="FFFFFF"/>
                 </a:solidFill>
               </a:rPr>
-              <a:t>   Research should aim to standardize the measurement and application of the systemic immune-inflammation index across diverse patient populations to improve its prognostic utility.  </a:t>
+              <a:t>   Investigating the clinical utility of various inflammatory markers could provide insights into personalized treatment strategies for CRC patients.  </a:t>
             </a:r>
             <a:endParaRPr lang="en-US" sz="1200" dirty="0"/>
           </a:p>
@@ -4119,7 +4161,7 @@
                   <a:srgbClr val="FFFFFF"/>
                 </a:solidFill>
               </a:rPr>
-              <a:t>   研究應致力於標準化系統免疫炎症指數在不同患者群體中的測量和應用，以提高其預後效用。</a:t>
+              <a:t>   探索各種炎症標記的臨床應用可能為大腸癌患者提供個性化治療策略的見解。</a:t>
             </a:r>
             <a:endParaRPr lang="en-US" sz="1200" dirty="0"/>
           </a:p>
@@ -4145,7 +4187,7 @@
                   <a:srgbClr val="FFFFFF"/>
                 </a:solidFill>
               </a:rPr>
-              <a:t>3. **微生物群調節的療效探索**  </a:t>
+              <a:t>3. **微生物群介入研究**  </a:t>
             </a:r>
             <a:endParaRPr lang="en-US" sz="1200" dirty="0"/>
           </a:p>
@@ -4162,7 +4204,7 @@
                   <a:srgbClr val="FFFFFF"/>
                 </a:solidFill>
               </a:rPr>
-              <a:t>   Investigating the therapeutic potential of microbiome modulation in colorectal cancer could lead to novel treatment strategies that enhance patient outcomes.  </a:t>
+              <a:t>   Research should aim to elucidate the therapeutic potential of modulating gut microbiota as a complementary approach to existing CRC therapies.  </a:t>
             </a:r>
             <a:endParaRPr lang="en-US" sz="1200" dirty="0"/>
           </a:p>
@@ -4179,7 +4221,7 @@
                   <a:srgbClr val="FFFFFF"/>
                 </a:solidFill>
               </a:rPr>
-              <a:t>   探索微生物群調節在結直腸癌中的治療潛力可能會導致增強患者預後的新治療策略。</a:t>
+              <a:t>   研究應旨在闡明調節腸道微生物群的治療潛力，作為現有大腸癌療法的補充方法。</a:t>
             </a:r>
             <a:endParaRPr lang="en-US" sz="1200" dirty="0"/>
           </a:p>
@@ -4205,7 +4247,7 @@
                   <a:srgbClr val="FFFFFF"/>
                 </a:solidFill>
               </a:rPr>
-              <a:t>4. **癌症惡病質的機制研究**  </a:t>
+              <a:t>4. **納米技術在治療中的應用**  </a:t>
             </a:r>
             <a:endParaRPr lang="en-US" sz="1200" dirty="0"/>
           </a:p>
@@ -4222,7 +4264,7 @@
                   <a:srgbClr val="FFFFFF"/>
                 </a:solidFill>
               </a:rPr>
-              <a:t>   Further investigation into the mechanisms underlying cancer cachexia, particularly the role of circulating factors, is essential for developing targeted interventions.  </a:t>
+              <a:t>   Further exploration of hybrid nanoparticles for targeted drug delivery in CRC treatment could enhance therapeutic efficacy and minimize side effects.  </a:t>
             </a:r>
             <a:endParaRPr lang="en-US" sz="1200" dirty="0"/>
           </a:p>
@@ -4239,7 +4281,7 @@
                   <a:srgbClr val="FFFFFF"/>
                 </a:solidFill>
               </a:rPr>
-              <a:t>   進一步研究癌症惡病質的機制，特別是循環因子的作用，對於開發靶向干預措施至關重要。</a:t>
+              <a:t>   進一步探索混合納米藥物在大腸癌治療中的靶向藥物傳遞應用，可能提高治療效果並最小化副作用。</a:t>
             </a:r>
             <a:endParaRPr lang="en-US" sz="1200" dirty="0"/>
           </a:p>
@@ -4265,7 +4307,7 @@
                   <a:srgbClr val="FFFFFF"/>
                 </a:solidFill>
               </a:rPr>
-              <a:t>5. **克服腫瘤微環境的策略**  </a:t>
+              <a:t>5. **免疫療法的機制研究**  </a:t>
             </a:r>
             <a:endParaRPr lang="en-US" sz="1200" dirty="0"/>
           </a:p>
@@ -4282,7 +4324,7 @@
                   <a:srgbClr val="FFFFFF"/>
                 </a:solidFill>
               </a:rPr>
-              <a:t>   Innovative approaches to overcome the immunosuppressive tumor microenvironment, such as combination therapies and novel immunomodulators, should be prioritized in future research.  </a:t>
+              <a:t>   Continued investigation into the mechanisms of immune resistance in CRC, particularly in relation to macrophage dynamics, will be essential for advancing immunotherapy approaches.  </a:t>
             </a:r>
             <a:endParaRPr lang="en-US" sz="1200" dirty="0"/>
           </a:p>
@@ -4299,7 +4341,7 @@
                   <a:srgbClr val="FFFFFF"/>
                 </a:solidFill>
               </a:rPr>
-              <a:t>   未來研究應優先考慮克服免疫抑制腫瘤微環境的創新方法，如聯合療法和新型免疫調節劑。</a:t>
+              <a:t>   持續研究大腸癌中免疫抵抗的機制，特別是與巨噬細胞動態相關的機制，對於推進免疫療法方法至關重要。</a:t>
             </a:r>
             <a:endParaRPr lang="en-US" sz="1200" dirty="0"/>
           </a:p>
@@ -4533,7 +4575,7 @@
                 <a:ea typeface="Arial" pitchFamily="34" charset="-122"/>
                 <a:cs typeface="Arial" pitchFamily="34" charset="-120"/>
               </a:rPr>
-              <a:t>Enzyme/Reactive Oxygen Species-Dually Activated Hyaluronic Acid Nanocarriers Ena…</a:t>
+              <a:t>Prognostic value of systemic immune-inflammation index for colorectal cancer: a …</a:t>
             </a:r>
             <a:endParaRPr lang="en-US" sz="1400" dirty="0"/>
           </a:p>
@@ -4570,7 +4612,7 @@
                 <a:ea typeface="Arial" pitchFamily="34" charset="-122"/>
                 <a:cs typeface="Arial" pitchFamily="34" charset="-120"/>
               </a:rPr>
-              <a:t>Dabupi decoction mitigates fluorouracil-induced intestinal mucositis via farneso…</a:t>
+              <a:t>Predictive utility of the C-reactive protein-albumin-lymphocyte (CALLY) index in…</a:t>
             </a:r>
             <a:endParaRPr lang="en-US" sz="1400" dirty="0"/>
           </a:p>
@@ -4607,7 +4649,7 @@
                 <a:ea typeface="Arial" pitchFamily="34" charset="-122"/>
                 <a:cs typeface="Arial" pitchFamily="34" charset="-120"/>
               </a:rPr>
-              <a:t>Prognostic value of systemic immune-inflammation index for colorectal cancer: a …</a:t>
+              <a:t>Iron, inflammation, and intestinal tumors: the crucial triad in colorectal cance…</a:t>
             </a:r>
             <a:endParaRPr lang="en-US" sz="1400" dirty="0"/>
           </a:p>
@@ -4644,7 +4686,7 @@
                 <a:ea typeface="Arial" pitchFamily="34" charset="-122"/>
                 <a:cs typeface="Arial" pitchFamily="34" charset="-120"/>
               </a:rPr>
-              <a:t>Iron, inflammation, and intestinal tumors: the crucial triad in colorectal cance…</a:t>
+              <a:t>Platelet membrane cloaked pectin and iron oxide based hybrid nanoparticles for t…</a:t>
             </a:r>
             <a:endParaRPr lang="en-US" sz="1400" dirty="0"/>
           </a:p>
@@ -4681,7 +4723,7 @@
                 <a:ea typeface="Arial" pitchFamily="34" charset="-122"/>
                 <a:cs typeface="Arial" pitchFamily="34" charset="-120"/>
               </a:rPr>
-              <a:t>Neutrophil extracellular traps in colorectal cancer: context-dependent roles fro…</a:t>
+              <a:t>In vitro biological potential of green-synthesized nanoparticles from the Egypti…</a:t>
             </a:r>
             <a:endParaRPr lang="en-US" sz="1400" dirty="0"/>
           </a:p>
@@ -4718,7 +4760,7 @@
                 <a:ea typeface="Arial" pitchFamily="34" charset="-122"/>
                 <a:cs typeface="Arial" pitchFamily="34" charset="-120"/>
               </a:rPr>
-              <a:t>Hierarchical core-shell nanoplatform with sequential Mn2+/Co2+ release enables d…</a:t>
+              <a:t>Host-Microbe Mechanisms of Fusobacterium nucleatum in Colorectal Cancer.</a:t>
             </a:r>
             <a:endParaRPr lang="en-US" sz="1400" dirty="0"/>
           </a:p>
@@ -4755,7 +4797,7 @@
                 <a:ea typeface="Arial" pitchFamily="34" charset="-122"/>
                 <a:cs typeface="Arial" pitchFamily="34" charset="-120"/>
               </a:rPr>
-              <a:t>The barrier–microbiota–inflammation axis in colorectal cancer: Mechanisms and em…</a:t>
+              <a:t>Evolution of SPP1+ cavity macrophage-mediated immunotherapy resistance in perito…</a:t>
             </a:r>
             <a:endParaRPr lang="en-US" sz="1400" dirty="0"/>
           </a:p>
@@ -4792,7 +4834,7 @@
                 <a:ea typeface="Arial" pitchFamily="34" charset="-122"/>
                 <a:cs typeface="Arial" pitchFamily="34" charset="-120"/>
               </a:rPr>
-              <a:t>Circulating granulocyte colony-stimulating factor as a sex-unbiased global marke…</a:t>
+              <a:t>The barrier–microbiota–inflammation axis in colorectal cancer: Mechanisms and em…</a:t>
             </a:r>
             <a:endParaRPr lang="en-US" sz="1400" dirty="0"/>
           </a:p>
@@ -4829,7 +4871,7 @@
                 <a:ea typeface="Arial" pitchFamily="34" charset="-122"/>
                 <a:cs typeface="Arial" pitchFamily="34" charset="-120"/>
               </a:rPr>
-              <a:t>Consensus Guideline for the Management of Colorectal Cancer with Peritoneal Meta…</a:t>
+              <a:t>LRMDA promotes intestinal mucosal barrier integrity and limits colitis and colon…</a:t>
             </a:r>
             <a:endParaRPr lang="en-US" sz="1400" dirty="0"/>
           </a:p>
@@ -4866,7 +4908,7 @@
                 <a:ea typeface="Arial" pitchFamily="34" charset="-122"/>
                 <a:cs typeface="Arial" pitchFamily="34" charset="-120"/>
               </a:rPr>
-              <a:t>Evolving therapeutics in colorectal cancer peritoneal metastases</a:t>
+              <a:t>Tumor-driven arginine depletion induces T-cell metabolism reprogramming to suppr…</a:t>
             </a:r>
             <a:endParaRPr lang="en-US" sz="1400" dirty="0"/>
           </a:p>
@@ -5021,7 +5063,7 @@
                   </a:extLst>
                 </a:hlinkClick>
               </a:rPr>
-              <a:t>Enzyme/Reactive Oxygen Species-Dually Activated Hyaluronic Acid Nanocarriers Enable Celastrol Delivery for Site-Specific Therapy of Inflammatory Bowel Diseases and Colorectal Cancer.</a:t>
+              <a:t>Prognostic value of systemic immune-inflammation index for colorectal cancer: a systematic review and meta-analysis</a:t>
             </a:r>
             <a:endParaRPr lang="en-US" sz="2400" dirty="0"/>
           </a:p>
@@ -5057,7 +5099,7 @@
                   <a:srgbClr val="888888"/>
                 </a:solidFill>
               </a:rPr>
-              <a:t>International journal of nanomedicine  ·  Basic Research  ·  🌏 Asia</a:t>
+              <a:t>Frontiers in Oncology  ·  Meta-Analysis</a:t>
             </a:r>
             <a:endParaRPr lang="en-US" sz="1000" dirty="0"/>
           </a:p>
@@ -5100,7 +5142,7 @@
                 <a:ea typeface="Arial" pitchFamily="34" charset="-122"/>
                 <a:cs typeface="Arial" pitchFamily="34" charset="-120"/>
               </a:rPr>
-              <a:t>Dual-responsive HA nanocarriers developed for therapy</a:t>
+              <a:t>Systemic immune-inflammation index (SII) evaluated</a:t>
             </a:r>
             <a:endParaRPr lang="en-US" sz="1800" dirty="0"/>
           </a:p>
@@ -5121,7 +5163,7 @@
                 <a:ea typeface="Arial" pitchFamily="34" charset="-122"/>
                 <a:cs typeface="Arial" pitchFamily="34" charset="-120"/>
               </a:rPr>
-              <a:t>Targeted delivery of Celastrol for UC and CAC</a:t>
+              <a:t>SII shows prognostic potential in CRC</a:t>
             </a:r>
             <a:endParaRPr lang="en-US" sz="1800" dirty="0"/>
           </a:p>
@@ -5142,7 +5184,7 @@
                 <a:ea typeface="Arial" pitchFamily="34" charset="-122"/>
                 <a:cs typeface="Arial" pitchFamily="34" charset="-120"/>
               </a:rPr>
-              <a:t>Enhanced cellular uptake and macrophage polarization</a:t>
+              <a:t>Inconsistent findings across studies</a:t>
             </a:r>
             <a:endParaRPr lang="en-US" sz="1800" dirty="0"/>
           </a:p>
@@ -5163,7 +5205,7 @@
                 <a:ea typeface="Arial" pitchFamily="34" charset="-122"/>
                 <a:cs typeface="Arial" pitchFamily="34" charset="-120"/>
               </a:rPr>
-              <a:t>Significant tumor burden reduction in colon cancer</a:t>
+              <a:t>Meta-analysis conducted for clarity</a:t>
             </a:r>
             <a:endParaRPr lang="en-US" sz="1800" dirty="0"/>
           </a:p>
@@ -5184,7 +5226,7 @@
                 <a:ea typeface="Arial" pitchFamily="34" charset="-122"/>
                 <a:cs typeface="Arial" pitchFamily="34" charset="-120"/>
               </a:rPr>
-              <a:t>Combination therapy boosts T cell infiltration</a:t>
+              <a:t>SII may guide treatment decisions</a:t>
             </a:r>
             <a:endParaRPr lang="en-US" sz="1800" dirty="0"/>
           </a:p>
@@ -5220,7 +5262,7 @@
                   <a:srgbClr val="888888"/>
                 </a:solidFill>
               </a:rPr>
-              <a:t>Shi Jinfeng, Zhang Xueqian, Yang Linxing et al.. International journal of nanomedicine. 2026-08-15 DOI: 10.2147/IJN.S619486</a:t>
+              <a:t>P Wang, H Jiang. Frontiers in Oncology. 2026</a:t>
             </a:r>
             <a:endParaRPr lang="en-US" sz="800" dirty="0"/>
           </a:p>
@@ -5420,7 +5462,7 @@
                   </a:extLst>
                 </a:hlinkClick>
               </a:rPr>
-              <a:t>Dabupi decoction mitigates fluorouracil-induced intestinal mucositis via farnesoid X receptor activation and dihydropyrimidine dehydrogenase upregulation.</a:t>
+              <a:t>Predictive utility of the C-reactive protein-albumin-lymphocyte (CALLY) index in Colorectal cancer: A meta-analysis</a:t>
             </a:r>
             <a:endParaRPr lang="en-US" sz="2400" dirty="0"/>
           </a:p>
@@ -5456,7 +5498,7 @@
                   <a:srgbClr val="888888"/>
                 </a:solidFill>
               </a:rPr>
-              <a:t>Journal of ethnopharmacology  ·  Basic Research  ·  🌏 Asia</a:t>
+              <a:t>Clinics and Research in Hepatology and …  ·  Meta-Analysis</a:t>
             </a:r>
             <a:endParaRPr lang="en-US" sz="1000" dirty="0"/>
           </a:p>
@@ -5499,7 +5541,7 @@
                 <a:ea typeface="Arial" pitchFamily="34" charset="-122"/>
                 <a:cs typeface="Arial" pitchFamily="34" charset="-120"/>
               </a:rPr>
-              <a:t>5-FU causes intestinal mucositis during chemotherapy.</a:t>
+              <a:t>CALLY index predicts colorectal cancer outcomes.</a:t>
             </a:r>
             <a:endParaRPr lang="en-US" sz="1800" dirty="0"/>
           </a:p>
@@ -5520,7 +5562,7 @@
                 <a:ea typeface="Arial" pitchFamily="34" charset="-122"/>
                 <a:cs typeface="Arial" pitchFamily="34" charset="-120"/>
               </a:rPr>
-              <a:t>DBPD activates FXR and upregulates DPYD.</a:t>
+              <a:t>Inflammation and immune function are crucial.</a:t>
             </a:r>
             <a:endParaRPr lang="en-US" sz="1800" dirty="0"/>
           </a:p>
@@ -5541,49 +5583,7 @@
                 <a:ea typeface="Arial" pitchFamily="34" charset="-122"/>
                 <a:cs typeface="Arial" pitchFamily="34" charset="-120"/>
               </a:rPr>
-              <a:t>DBPD reduces inflammation and barrier dysfunction.</a:t>
-            </a:r>
-            <a:endParaRPr lang="en-US" sz="1800" dirty="0"/>
-          </a:p>
-          <a:p>
-            <a:pPr marL="342900" indent="-342900">
-              <a:spcAft>
-                <a:spcPts val="800"/>
-              </a:spcAft>
-              <a:buSzPct val="100000"/>
-              <a:buChar char="•"/>
-            </a:pPr>
-            <a:r>
-              <a:rPr lang="en-US" sz="1800" dirty="0">
-                <a:solidFill>
-                  <a:srgbClr val="333333"/>
-                </a:solidFill>
-                <a:latin typeface="Arial" pitchFamily="34" charset="0"/>
-                <a:ea typeface="Arial" pitchFamily="34" charset="-122"/>
-                <a:cs typeface="Arial" pitchFamily="34" charset="-120"/>
-              </a:rPr>
-              <a:t>Transcriptome analysis reveals key metabolic pathways.</a:t>
-            </a:r>
-            <a:endParaRPr lang="en-US" sz="1800" dirty="0"/>
-          </a:p>
-          <a:p>
-            <a:pPr marL="342900" indent="-342900">
-              <a:spcAft>
-                <a:spcPts val="800"/>
-              </a:spcAft>
-              <a:buSzPct val="100000"/>
-              <a:buChar char="•"/>
-            </a:pPr>
-            <a:r>
-              <a:rPr lang="en-US" sz="1800" dirty="0">
-                <a:solidFill>
-                  <a:srgbClr val="333333"/>
-                </a:solidFill>
-                <a:latin typeface="Arial" pitchFamily="34" charset="0"/>
-                <a:ea typeface="Arial" pitchFamily="34" charset="-122"/>
-                <a:cs typeface="Arial" pitchFamily="34" charset="-120"/>
-              </a:rPr>
-              <a:t>In vitro studies confirm DBPD's protective effects.</a:t>
+              <a:t>Meta-analysis confirms CALLY's predictive value.</a:t>
             </a:r>
             <a:endParaRPr lang="en-US" sz="1800" dirty="0"/>
           </a:p>
@@ -5619,7 +5619,7 @@
                   <a:srgbClr val="888888"/>
                 </a:solidFill>
               </a:rPr>
-              <a:t>Wang ShunZhi, Li Yaling, Ma Jing et al.. Journal of ethnopharmacology. 2026-07-16 DOI: 10.1016/j.jep.2026.121742</a:t>
+              <a:t>X Li, T Chu, W Chen. Clinics and Research in Hepatology and …. 2026</a:t>
             </a:r>
             <a:endParaRPr lang="en-US" sz="800" dirty="0"/>
           </a:p>
@@ -5819,7 +5819,7 @@
                   </a:extLst>
                 </a:hlinkClick>
               </a:rPr>
-              <a:t>Prognostic value of systemic immune-inflammation index for colorectal cancer: a systematic review and meta-analysis</a:t>
+              <a:t>Iron, inflammation, and intestinal tumors: the crucial triad in colorectal cancer progression and therapy</a:t>
             </a:r>
             <a:endParaRPr lang="en-US" sz="2400" dirty="0"/>
           </a:p>
@@ -5855,7 +5855,7 @@
                   <a:srgbClr val="888888"/>
                 </a:solidFill>
               </a:rPr>
-              <a:t>Frontiers in Oncology  ·  Meta-Analysis</a:t>
+              <a:t>Clinical and …  ·  Prospective Study</a:t>
             </a:r>
             <a:endParaRPr lang="en-US" sz="1000" dirty="0"/>
           </a:p>
@@ -5898,7 +5898,7 @@
                 <a:ea typeface="Arial" pitchFamily="34" charset="-122"/>
                 <a:cs typeface="Arial" pitchFamily="34" charset="-120"/>
               </a:rPr>
-              <a:t>Systemic immune-inflammation index (SII) evaluated</a:t>
+              <a:t>Iron intake linked to CRC risk</a:t>
             </a:r>
             <a:endParaRPr lang="en-US" sz="1800" dirty="0"/>
           </a:p>
@@ -5919,7 +5919,7 @@
                 <a:ea typeface="Arial" pitchFamily="34" charset="-122"/>
                 <a:cs typeface="Arial" pitchFamily="34" charset="-120"/>
               </a:rPr>
-              <a:t>SII as a prognostic biomarker in CRC</a:t>
+              <a:t>Inflammation plays a significant role</a:t>
             </a:r>
             <a:endParaRPr lang="en-US" sz="1800" dirty="0"/>
           </a:p>
@@ -5940,49 +5940,7 @@
                 <a:ea typeface="Arial" pitchFamily="34" charset="-122"/>
                 <a:cs typeface="Arial" pitchFamily="34" charset="-120"/>
               </a:rPr>
-              <a:t>Inconsistent findings across studies</a:t>
-            </a:r>
-            <a:endParaRPr lang="en-US" sz="1800" dirty="0"/>
-          </a:p>
-          <a:p>
-            <a:pPr marL="342900" indent="-342900">
-              <a:spcAft>
-                <a:spcPts val="800"/>
-              </a:spcAft>
-              <a:buSzPct val="100000"/>
-              <a:buChar char="•"/>
-            </a:pPr>
-            <a:r>
-              <a:rPr lang="en-US" sz="1800" dirty="0">
-                <a:solidFill>
-                  <a:srgbClr val="333333"/>
-                </a:solidFill>
-                <a:latin typeface="Arial" pitchFamily="34" charset="0"/>
-                <a:ea typeface="Arial" pitchFamily="34" charset="-122"/>
-                <a:cs typeface="Arial" pitchFamily="34" charset="-120"/>
-              </a:rPr>
-              <a:t>Meta-analysis conducted for clarity</a:t>
-            </a:r>
-            <a:endParaRPr lang="en-US" sz="1800" dirty="0"/>
-          </a:p>
-          <a:p>
-            <a:pPr marL="342900" indent="-342900">
-              <a:spcAft>
-                <a:spcPts val="800"/>
-              </a:spcAft>
-              <a:buSzPct val="100000"/>
-              <a:buChar char="•"/>
-            </a:pPr>
-            <a:r>
-              <a:rPr lang="en-US" sz="1800" dirty="0">
-                <a:solidFill>
-                  <a:srgbClr val="333333"/>
-                </a:solidFill>
-                <a:latin typeface="Arial" pitchFamily="34" charset="0"/>
-                <a:ea typeface="Arial" pitchFamily="34" charset="-122"/>
-                <a:cs typeface="Arial" pitchFamily="34" charset="-120"/>
-              </a:rPr>
-              <a:t>Potential clinical application of SII</a:t>
+              <a:t>Heme iron increases tumor progression</a:t>
             </a:r>
             <a:endParaRPr lang="en-US" sz="1800" dirty="0"/>
           </a:p>
@@ -6018,7 +5976,7 @@
                   <a:srgbClr val="888888"/>
                 </a:solidFill>
               </a:rPr>
-              <a:t>P Wang, H Jiang. Frontiers in Oncology. 2026</a:t>
+              <a:t>M Abediasl, M Siavash, SS Esfahani. Clinical and …. 2026</a:t>
             </a:r>
             <a:endParaRPr lang="en-US" sz="800" dirty="0"/>
           </a:p>
@@ -6218,7 +6176,7 @@
                   </a:extLst>
                 </a:hlinkClick>
               </a:rPr>
-              <a:t>Iron, inflammation, and intestinal tumors: the crucial triad in colorectal cancer progression and therapy</a:t>
+              <a:t>Platelet membrane cloaked pectin and iron oxide based hybrid nanoparticles for the treatment of colorectal cancer and associated anemia.</a:t>
             </a:r>
             <a:endParaRPr lang="en-US" sz="2400" dirty="0"/>
           </a:p>
@@ -6254,7 +6212,7 @@
                   <a:srgbClr val="888888"/>
                 </a:solidFill>
               </a:rPr>
-              <a:t>Clinical and …  ·  Prospective Study</a:t>
+              <a:t>International journal of biological macromolecules  ·  Basic Research</a:t>
             </a:r>
             <a:endParaRPr lang="en-US" sz="1000" dirty="0"/>
           </a:p>
@@ -6297,7 +6255,7 @@
                 <a:ea typeface="Arial" pitchFamily="34" charset="-122"/>
                 <a:cs typeface="Arial" pitchFamily="34" charset="-120"/>
               </a:rPr>
-              <a:t>Iron intake linked to CRC risk increase</a:t>
+              <a:t>Developed hybrid nanoparticles for CRC treatment</a:t>
             </a:r>
             <a:endParaRPr lang="en-US" sz="1800" dirty="0"/>
           </a:p>
@@ -6318,7 +6276,7 @@
                 <a:ea typeface="Arial" pitchFamily="34" charset="-122"/>
                 <a:cs typeface="Arial" pitchFamily="34" charset="-120"/>
               </a:rPr>
-              <a:t>Inflammation plays a significant role</a:t>
+              <a:t>Gemcitabine encapsulated in pectin nanoparticles</a:t>
             </a:r>
             <a:endParaRPr lang="en-US" sz="1800" dirty="0"/>
           </a:p>
@@ -6339,7 +6297,49 @@
                 <a:ea typeface="Arial" pitchFamily="34" charset="-122"/>
                 <a:cs typeface="Arial" pitchFamily="34" charset="-120"/>
               </a:rPr>
-              <a:t>Heme iron consumption raises concerns</a:t>
+              <a:t>Platelet membranes enhance tumor targeting</a:t>
+            </a:r>
+            <a:endParaRPr lang="en-US" sz="1800" dirty="0"/>
+          </a:p>
+          <a:p>
+            <a:pPr marL="342900" indent="-342900">
+              <a:spcAft>
+                <a:spcPts val="800"/>
+              </a:spcAft>
+              <a:buSzPct val="100000"/>
+              <a:buChar char="•"/>
+            </a:pPr>
+            <a:r>
+              <a:rPr lang="en-US" sz="1800" dirty="0">
+                <a:solidFill>
+                  <a:srgbClr val="333333"/>
+                </a:solidFill>
+                <a:latin typeface="Arial" pitchFamily="34" charset="0"/>
+                <a:ea typeface="Arial" pitchFamily="34" charset="-122"/>
+                <a:cs typeface="Arial" pitchFamily="34" charset="-120"/>
+              </a:rPr>
+              <a:t>Simultaneous chemotherapy and iron supplementation</a:t>
+            </a:r>
+            <a:endParaRPr lang="en-US" sz="1800" dirty="0"/>
+          </a:p>
+          <a:p>
+            <a:pPr marL="342900" indent="-342900">
+              <a:spcAft>
+                <a:spcPts val="800"/>
+              </a:spcAft>
+              <a:buSzPct val="100000"/>
+              <a:buChar char="•"/>
+            </a:pPr>
+            <a:r>
+              <a:rPr lang="en-US" sz="1800" dirty="0">
+                <a:solidFill>
+                  <a:srgbClr val="333333"/>
+                </a:solidFill>
+                <a:latin typeface="Arial" pitchFamily="34" charset="0"/>
+                <a:ea typeface="Arial" pitchFamily="34" charset="-122"/>
+                <a:cs typeface="Arial" pitchFamily="34" charset="-120"/>
+              </a:rPr>
+              <a:t>Demonstrated significant tumor inhibition and survival</a:t>
             </a:r>
             <a:endParaRPr lang="en-US" sz="1800" dirty="0"/>
           </a:p>
@@ -6375,7 +6375,7 @@
                   <a:srgbClr val="888888"/>
                 </a:solidFill>
               </a:rPr>
-              <a:t>M Abediasl, M Siavash, SS Esfahani. Clinical and …. 2026</a:t>
+              <a:t>Mirza Rashna, Rehman Asim Ur, Javed Aqeedat et al.. International journal of biological macromolecules. 2026-08-22 DOI: 10.1016/j.ijbiomac.2026.154170</a:t>
             </a:r>
             <a:endParaRPr lang="en-US" sz="800" dirty="0"/>
           </a:p>
@@ -6575,7 +6575,7 @@
                   </a:extLst>
                 </a:hlinkClick>
               </a:rPr>
-              <a:t>Neutrophil extracellular traps in colorectal cancer: context-dependent roles from inflammatory carcinogenesis to liver metastasis and therapeutic targeting</a:t>
+              <a:t>In vitro biological potential of green-synthesized nanoparticles from the Egyptian edible bivalve Paratapes undulatus (Born, 1778).</a:t>
             </a:r>
             <a:endParaRPr lang="en-US" sz="2400" dirty="0"/>
           </a:p>
@@ -6611,7 +6611,7 @@
                   <a:srgbClr val="888888"/>
                 </a:solidFill>
               </a:rPr>
-              <a:t>Journal of Translational Medicine  ·  IF 6.1</a:t>
+              <a:t>Scientific reports  ·  Basic Research</a:t>
             </a:r>
             <a:endParaRPr lang="en-US" sz="1000" dirty="0"/>
           </a:p>
@@ -6654,7 +6654,7 @@
                 <a:ea typeface="Arial" pitchFamily="34" charset="-122"/>
                 <a:cs typeface="Arial" pitchFamily="34" charset="-120"/>
               </a:rPr>
-              <a:t>Neutrophil extracellular traps (NETs) in CRC</a:t>
+              <a:t>Study on Paratapes undulatus extract</a:t>
             </a:r>
             <a:endParaRPr lang="en-US" sz="1800" dirty="0"/>
           </a:p>
@@ -6675,7 +6675,7 @@
                 <a:ea typeface="Arial" pitchFamily="34" charset="-122"/>
                 <a:cs typeface="Arial" pitchFamily="34" charset="-120"/>
               </a:rPr>
-              <a:t>Role of inflammation in carcinogenesis</a:t>
+              <a:t>Characterization of green-synthesized nanoparticles</a:t>
             </a:r>
             <a:endParaRPr lang="en-US" sz="1800" dirty="0"/>
           </a:p>
@@ -6696,7 +6696,7 @@
                 <a:ea typeface="Arial" pitchFamily="34" charset="-122"/>
                 <a:cs typeface="Arial" pitchFamily="34" charset="-120"/>
               </a:rPr>
-              <a:t>NETs contribute to liver metastasis</a:t>
+              <a:t>Enhanced anticancer activity of Pu-SeNPs</a:t>
             </a:r>
             <a:endParaRPr lang="en-US" sz="1800" dirty="0"/>
           </a:p>
@@ -6717,7 +6717,7 @@
                 <a:ea typeface="Arial" pitchFamily="34" charset="-122"/>
                 <a:cs typeface="Arial" pitchFamily="34" charset="-120"/>
               </a:rPr>
-              <a:t>Therapeutic targeting of NETs explored</a:t>
+              <a:t>Potential for bio-based nanomedicines</a:t>
             </a:r>
             <a:endParaRPr lang="en-US" sz="1800" dirty="0"/>
           </a:p>
@@ -6738,7 +6738,7 @@
                 <a:ea typeface="Arial" pitchFamily="34" charset="-122"/>
                 <a:cs typeface="Arial" pitchFamily="34" charset="-120"/>
               </a:rPr>
-              <a:t>Context-dependent functions of NETs</a:t>
+              <a:t>Inconsistent efficacy against HepG-2 cells</a:t>
             </a:r>
             <a:endParaRPr lang="en-US" sz="1800" dirty="0"/>
           </a:p>
@@ -6774,7 +6774,7 @@
                   <a:srgbClr val="888888"/>
                 </a:solidFill>
               </a:rPr>
-              <a:t>D Xu, R Wang, J Tan. Journal of Translational Medicine. 2026</a:t>
+              <a:t>El Makawy Aida I, Zayed Khaled M, Mabrouk Dalia M et al.. Scientific reports. 2026-08-20 DOI: 10.1038/s41598-026-61397-7</a:t>
             </a:r>
             <a:endParaRPr lang="en-US" sz="800" dirty="0"/>
           </a:p>
@@ -6974,7 +6974,7 @@
                   </a:extLst>
                 </a:hlinkClick>
               </a:rPr>
-              <a:t>Hierarchical core-shell nanoplatform with sequential Mn2+/Co2+ release enables dual-track STING amplification and radiosensitization for potent radio-metalloimmunotherapy.</a:t>
+              <a:t>Host-Microbe Mechanisms of Fusobacterium nucleatum in Colorectal Cancer.</a:t>
             </a:r>
             <a:endParaRPr lang="en-US" sz="2400" dirty="0"/>
           </a:p>
@@ -7010,7 +7010,7 @@
                   <a:srgbClr val="888888"/>
                 </a:solidFill>
               </a:rPr>
-              <a:t>Acta biomaterialia  ·  Basic Research</a:t>
+              <a:t>Molecular oral microbiology  ·  Basic Research</a:t>
             </a:r>
             <a:endParaRPr lang="en-US" sz="1000" dirty="0"/>
           </a:p>
@@ -7053,7 +7053,7 @@
                 <a:ea typeface="Arial" pitchFamily="34" charset="-122"/>
                 <a:cs typeface="Arial" pitchFamily="34" charset="-120"/>
               </a:rPr>
-              <a:t>Developed hierarchical core-shell nanoplatform</a:t>
+              <a:t>Fusobacterium nucleatum linked to CRC progression.</a:t>
             </a:r>
             <a:endParaRPr lang="en-US" sz="1800" dirty="0"/>
           </a:p>
@@ -7074,7 +7074,7 @@
                 <a:ea typeface="Arial" pitchFamily="34" charset="-122"/>
                 <a:cs typeface="Arial" pitchFamily="34" charset="-120"/>
               </a:rPr>
-              <a:t>Integrates radiosensitization with STING amplification</a:t>
+              <a:t>Modulates immune and inflammatory pathways.</a:t>
             </a:r>
             <a:endParaRPr lang="en-US" sz="1800" dirty="0"/>
           </a:p>
@@ -7095,49 +7095,7 @@
                 <a:ea typeface="Arial" pitchFamily="34" charset="-122"/>
                 <a:cs typeface="Arial" pitchFamily="34" charset="-120"/>
               </a:rPr>
-              <a:t>Sequential release of Mn2+ and Co2+ ions</a:t>
-            </a:r>
-            <a:endParaRPr lang="en-US" sz="1800" dirty="0"/>
-          </a:p>
-          <a:p>
-            <a:pPr marL="342900" indent="-342900">
-              <a:spcAft>
-                <a:spcPts val="800"/>
-              </a:spcAft>
-              <a:buSzPct val="100000"/>
-              <a:buChar char="•"/>
-            </a:pPr>
-            <a:r>
-              <a:rPr lang="en-US" sz="1800" dirty="0">
-                <a:solidFill>
-                  <a:srgbClr val="333333"/>
-                </a:solidFill>
-                <a:latin typeface="Arial" pitchFamily="34" charset="0"/>
-                <a:ea typeface="Arial" pitchFamily="34" charset="-122"/>
-                <a:cs typeface="Arial" pitchFamily="34" charset="-120"/>
-              </a:rPr>
-              <a:t>Transforms 'cold' tumors into 'hot' lesions</a:t>
-            </a:r>
-            <a:endParaRPr lang="en-US" sz="1800" dirty="0"/>
-          </a:p>
-          <a:p>
-            <a:pPr marL="342900" indent="-342900">
-              <a:spcAft>
-                <a:spcPts val="800"/>
-              </a:spcAft>
-              <a:buSzPct val="100000"/>
-              <a:buChar char="•"/>
-            </a:pPr>
-            <a:r>
-              <a:rPr lang="en-US" sz="1800" dirty="0">
-                <a:solidFill>
-                  <a:srgbClr val="333333"/>
-                </a:solidFill>
-                <a:latin typeface="Arial" pitchFamily="34" charset="0"/>
-                <a:ea typeface="Arial" pitchFamily="34" charset="-122"/>
-                <a:cs typeface="Arial" pitchFamily="34" charset="-120"/>
-              </a:rPr>
-              <a:t>Establishes new radio-metalloimmunotherapy paradigm</a:t>
+              <a:t>Reshapes tumor microenvironment significantly.</a:t>
             </a:r>
             <a:endParaRPr lang="en-US" sz="1800" dirty="0"/>
           </a:p>
@@ -7173,7 +7131,7 @@
                   <a:srgbClr val="888888"/>
                 </a:solidFill>
               </a:rPr>
-              <a:t>Luo Baiyi, Xiang Qingming, Xie Yingling et al.. Acta biomaterialia. 2026-08-13 DOI: 10.1016/j.actbio.2026.08.012</a:t>
+              <a:t>Leite Hadda Lyzandra Austr&amp;#xed;aco, Lopes Fernanda Ferreira. Molecular oral microbiology. 2026-08-19 DOI: 10.1111/omi.70038</a:t>
             </a:r>
             <a:endParaRPr lang="en-US" sz="800" dirty="0"/>
           </a:p>
@@ -7373,7 +7331,7 @@
                   </a:extLst>
                 </a:hlinkClick>
               </a:rPr>
-              <a:t>The barrier–microbiota–inflammation axis in colorectal cancer: Mechanisms and emerging diagnostic &amp; therapeutic strategies</a:t>
+              <a:t>Evolution of SPP1+ cavity macrophage-mediated immunotherapy resistance in peritoneal metastasis of colorectal cancer.</a:t>
             </a:r>
             <a:endParaRPr lang="en-US" sz="2400" dirty="0"/>
           </a:p>
@@ -7409,7 +7367,7 @@
                   <a:srgbClr val="888888"/>
                 </a:solidFill>
               </a:rPr>
-              <a:t>Cancers  ·  Basic Research</a:t>
+              <a:t>Cell reports. Medicine  ·  Basic Research</a:t>
             </a:r>
             <a:endParaRPr lang="en-US" sz="1000" dirty="0"/>
           </a:p>
@@ -7452,7 +7410,7 @@
                 <a:ea typeface="Arial" pitchFamily="34" charset="-122"/>
                 <a:cs typeface="Arial" pitchFamily="34" charset="-120"/>
               </a:rPr>
-              <a:t>LPS triggers pro-inflammatory cytokines secretion</a:t>
+              <a:t>SPP1+ macrophages drive CD8+ T cell dysfunction.</a:t>
             </a:r>
             <a:endParaRPr lang="en-US" sz="1800" dirty="0"/>
           </a:p>
@@ -7473,7 +7431,7 @@
                 <a:ea typeface="Arial" pitchFamily="34" charset="-122"/>
                 <a:cs typeface="Arial" pitchFamily="34" charset="-120"/>
               </a:rPr>
-              <a:t>Downregulates tight junction proteins in epithelium</a:t>
+              <a:t>SPP1 enrichment linked to therapy resistance.</a:t>
             </a:r>
             <a:endParaRPr lang="en-US" sz="1800" dirty="0"/>
           </a:p>
@@ -7494,49 +7452,7 @@
                 <a:ea typeface="Arial" pitchFamily="34" charset="-122"/>
                 <a:cs typeface="Arial" pitchFamily="34" charset="-120"/>
               </a:rPr>
-              <a:t>Promotes epithelial cell migration and invasion</a:t>
-            </a:r>
-            <a:endParaRPr lang="en-US" sz="1800" dirty="0"/>
-          </a:p>
-          <a:p>
-            <a:pPr marL="342900" indent="-342900">
-              <a:spcAft>
-                <a:spcPts val="800"/>
-              </a:spcAft>
-              <a:buSzPct val="100000"/>
-              <a:buChar char="•"/>
-            </a:pPr>
-            <a:r>
-              <a:rPr lang="en-US" sz="1800" dirty="0">
-                <a:solidFill>
-                  <a:srgbClr val="333333"/>
-                </a:solidFill>
-                <a:latin typeface="Arial" pitchFamily="34" charset="0"/>
-                <a:ea typeface="Arial" pitchFamily="34" charset="-122"/>
-                <a:cs typeface="Arial" pitchFamily="34" charset="-120"/>
-              </a:rPr>
-              <a:t>Microbiota influences inflammation in CRC</a:t>
-            </a:r>
-            <a:endParaRPr lang="en-US" sz="1800" dirty="0"/>
-          </a:p>
-          <a:p>
-            <a:pPr marL="342900" indent="-342900">
-              <a:spcAft>
-                <a:spcPts val="800"/>
-              </a:spcAft>
-              <a:buSzPct val="100000"/>
-              <a:buChar char="•"/>
-            </a:pPr>
-            <a:r>
-              <a:rPr lang="en-US" sz="1800" dirty="0">
-                <a:solidFill>
-                  <a:srgbClr val="333333"/>
-                </a:solidFill>
-                <a:latin typeface="Arial" pitchFamily="34" charset="0"/>
-                <a:ea typeface="Arial" pitchFamily="34" charset="-122"/>
-                <a:cs typeface="Arial" pitchFamily="34" charset="-120"/>
-              </a:rPr>
-              <a:t>Emerging strategies for diagnosis and therapy</a:t>
+              <a:t>Knockout enhances T cell infiltration and efficacy.</a:t>
             </a:r>
             <a:endParaRPr lang="en-US" sz="1800" dirty="0"/>
           </a:p>
@@ -7572,7 +7488,7 @@
                   <a:srgbClr val="888888"/>
                 </a:solidFill>
               </a:rPr>
-              <a:t>X Dong, J Yang, L He. Cancers. 2026</a:t>
+              <a:t>Dai Xiaomeng, Lai Chunyu, Hong Libing et al.. Cell reports. Medicine. 2026-08-18 DOI: 10.1016/j.xcrm.2026.102930</a:t>
             </a:r>
             <a:endParaRPr lang="en-US" sz="800" dirty="0"/>
           </a:p>

</xml_diff>

<commit_message>
chore: update weekly digest 2026-08-31
</commit_message>
<xml_diff>
--- a/docs/digest-en.pptx
+++ b/docs/digest-en.pptx
@@ -2249,7 +2249,7 @@
                   <a:srgbClr val="888888"/>
                 </a:solidFill>
               </a:rPr>
-              <a:t>2026-08-17 — 2026-08-24</a:t>
+              <a:t>2026-08-24 — 2026-08-31</a:t>
             </a:r>
             <a:endParaRPr lang="en-US" sz="1400" dirty="0"/>
           </a:p>
@@ -2440,7 +2440,7 @@
                   </a:extLst>
                 </a:hlinkClick>
               </a:rPr>
-              <a:t>The barrier–microbiota–inflammation axis in colorectal cancer: Mechanisms and emerging diagnostic &amp; therapeutic strategies</a:t>
+              <a:t>Methylparaben promotes colorectal tumor growth through nuclear receptor-mediated transcriptional reprogramming and inflammatory signaling: Evidence from integrated transcriptomics and network toxicology.</a:t>
             </a:r>
             <a:endParaRPr lang="en-US" sz="2400" dirty="0"/>
           </a:p>
@@ -2476,7 +2476,7 @@
                   <a:srgbClr val="888888"/>
                 </a:solidFill>
               </a:rPr>
-              <a:t>Cancers  ·  Basic Research</a:t>
+              <a:t>Food and chemical toxicology : an international journal published for the British Industrial Biological Research Association  ·  Basic Research</a:t>
             </a:r>
             <a:endParaRPr lang="en-US" sz="1000" dirty="0"/>
           </a:p>
@@ -2519,91 +2519,7 @@
                 <a:ea typeface="Arial" pitchFamily="34" charset="-122"/>
                 <a:cs typeface="Arial" pitchFamily="34" charset="-120"/>
               </a:rPr>
-              <a:t>LPS triggers pro-inflammatory cytokines secretion</a:t>
-            </a:r>
-            <a:endParaRPr lang="en-US" sz="1800" dirty="0"/>
-          </a:p>
-          <a:p>
-            <a:pPr marL="342900" indent="-342900">
-              <a:spcAft>
-                <a:spcPts val="800"/>
-              </a:spcAft>
-              <a:buSzPct val="100000"/>
-              <a:buChar char="•"/>
-            </a:pPr>
-            <a:r>
-              <a:rPr lang="en-US" sz="1800" dirty="0">
-                <a:solidFill>
-                  <a:srgbClr val="333333"/>
-                </a:solidFill>
-                <a:latin typeface="Arial" pitchFamily="34" charset="0"/>
-                <a:ea typeface="Arial" pitchFamily="34" charset="-122"/>
-                <a:cs typeface="Arial" pitchFamily="34" charset="-120"/>
-              </a:rPr>
-              <a:t>Downregulates tight junction proteins in epithelium</a:t>
-            </a:r>
-            <a:endParaRPr lang="en-US" sz="1800" dirty="0"/>
-          </a:p>
-          <a:p>
-            <a:pPr marL="342900" indent="-342900">
-              <a:spcAft>
-                <a:spcPts val="800"/>
-              </a:spcAft>
-              <a:buSzPct val="100000"/>
-              <a:buChar char="•"/>
-            </a:pPr>
-            <a:r>
-              <a:rPr lang="en-US" sz="1800" dirty="0">
-                <a:solidFill>
-                  <a:srgbClr val="333333"/>
-                </a:solidFill>
-                <a:latin typeface="Arial" pitchFamily="34" charset="0"/>
-                <a:ea typeface="Arial" pitchFamily="34" charset="-122"/>
-                <a:cs typeface="Arial" pitchFamily="34" charset="-120"/>
-              </a:rPr>
-              <a:t>Promotes epithelial cell migration and invasion</a:t>
-            </a:r>
-            <a:endParaRPr lang="en-US" sz="1800" dirty="0"/>
-          </a:p>
-          <a:p>
-            <a:pPr marL="342900" indent="-342900">
-              <a:spcAft>
-                <a:spcPts val="800"/>
-              </a:spcAft>
-              <a:buSzPct val="100000"/>
-              <a:buChar char="•"/>
-            </a:pPr>
-            <a:r>
-              <a:rPr lang="en-US" sz="1800" dirty="0">
-                <a:solidFill>
-                  <a:srgbClr val="333333"/>
-                </a:solidFill>
-                <a:latin typeface="Arial" pitchFamily="34" charset="0"/>
-                <a:ea typeface="Arial" pitchFamily="34" charset="-122"/>
-                <a:cs typeface="Arial" pitchFamily="34" charset="-120"/>
-              </a:rPr>
-              <a:t>Identifies microbiota's role in colorectal cancer</a:t>
-            </a:r>
-            <a:endParaRPr lang="en-US" sz="1800" dirty="0"/>
-          </a:p>
-          <a:p>
-            <a:pPr marL="342900" indent="-342900">
-              <a:spcAft>
-                <a:spcPts val="800"/>
-              </a:spcAft>
-              <a:buSzPct val="100000"/>
-              <a:buChar char="•"/>
-            </a:pPr>
-            <a:r>
-              <a:rPr lang="en-US" sz="1800" dirty="0">
-                <a:solidFill>
-                  <a:srgbClr val="333333"/>
-                </a:solidFill>
-                <a:latin typeface="Arial" pitchFamily="34" charset="0"/>
-                <a:ea typeface="Arial" pitchFamily="34" charset="-122"/>
-                <a:cs typeface="Arial" pitchFamily="34" charset="-120"/>
-              </a:rPr>
-              <a:t>Emerging diagnostic and therapeutic strategies</a:t>
+              <a:t>(Generation failed)</a:t>
             </a:r>
             <a:endParaRPr lang="en-US" sz="1800" dirty="0"/>
           </a:p>
@@ -2639,7 +2555,7 @@
                   <a:srgbClr val="888888"/>
                 </a:solidFill>
               </a:rPr>
-              <a:t>X Dong, J Yang, L He. Cancers. 2026</a:t>
+              <a:t>Ma Zhisheng, Zhang Zheng, Zhou Yao et al.. Food and chemical toxicology : an international journal published for the British Industrial Biological Research Association. 2026-08-28 DOI: 10.1016/j.fct.2026.116349</a:t>
             </a:r>
             <a:endParaRPr lang="en-US" sz="800" dirty="0"/>
           </a:p>
@@ -2839,7 +2755,7 @@
                   </a:extLst>
                 </a:hlinkClick>
               </a:rPr>
-              <a:t>LRMDA promotes intestinal mucosal barrier integrity and limits colitis and colon cancer.</a:t>
+              <a:t>A conserved Notch-Meis1-Pbx cascade specifies secretory progenitors into spatially diverse intestinal best4 + cells.</a:t>
             </a:r>
             <a:endParaRPr lang="en-US" sz="2400" dirty="0"/>
           </a:p>
@@ -2875,7 +2791,7 @@
                   <a:srgbClr val="888888"/>
                 </a:solidFill>
               </a:rPr>
-              <a:t>iScience</a:t>
+              <a:t>Genes &amp; development  ·  Basic Research</a:t>
             </a:r>
             <a:endParaRPr lang="en-US" sz="1000" dirty="0"/>
           </a:p>
@@ -2918,91 +2834,7 @@
                 <a:ea typeface="Arial" pitchFamily="34" charset="-122"/>
                 <a:cs typeface="Arial" pitchFamily="34" charset="-120"/>
               </a:rPr>
-              <a:t>LRMDA downregulated in IBD tissues.</a:t>
-            </a:r>
-            <a:endParaRPr lang="en-US" sz="1800" dirty="0"/>
-          </a:p>
-          <a:p>
-            <a:pPr marL="342900" indent="-342900">
-              <a:spcAft>
-                <a:spcPts val="800"/>
-              </a:spcAft>
-              <a:buSzPct val="100000"/>
-              <a:buChar char="•"/>
-            </a:pPr>
-            <a:r>
-              <a:rPr lang="en-US" sz="1800" dirty="0">
-                <a:solidFill>
-                  <a:srgbClr val="333333"/>
-                </a:solidFill>
-                <a:latin typeface="Arial" pitchFamily="34" charset="0"/>
-                <a:ea typeface="Arial" pitchFamily="34" charset="-122"/>
-                <a:cs typeface="Arial" pitchFamily="34" charset="-120"/>
-              </a:rPr>
-              <a:t>Genetic ablation worsens colitis symptoms.</a:t>
-            </a:r>
-            <a:endParaRPr lang="en-US" sz="1800" dirty="0"/>
-          </a:p>
-          <a:p>
-            <a:pPr marL="342900" indent="-342900">
-              <a:spcAft>
-                <a:spcPts val="800"/>
-              </a:spcAft>
-              <a:buSzPct val="100000"/>
-              <a:buChar char="•"/>
-            </a:pPr>
-            <a:r>
-              <a:rPr lang="en-US" sz="1800" dirty="0">
-                <a:solidFill>
-                  <a:srgbClr val="333333"/>
-                </a:solidFill>
-                <a:latin typeface="Arial" pitchFamily="34" charset="0"/>
-                <a:ea typeface="Arial" pitchFamily="34" charset="-122"/>
-                <a:cs typeface="Arial" pitchFamily="34" charset="-120"/>
-              </a:rPr>
-              <a:t>LRMDA deficiency linked to tumorigenesis.</a:t>
-            </a:r>
-            <a:endParaRPr lang="en-US" sz="1800" dirty="0"/>
-          </a:p>
-          <a:p>
-            <a:pPr marL="342900" indent="-342900">
-              <a:spcAft>
-                <a:spcPts val="800"/>
-              </a:spcAft>
-              <a:buSzPct val="100000"/>
-              <a:buChar char="•"/>
-            </a:pPr>
-            <a:r>
-              <a:rPr lang="en-US" sz="1800" dirty="0">
-                <a:solidFill>
-                  <a:srgbClr val="333333"/>
-                </a:solidFill>
-                <a:latin typeface="Arial" pitchFamily="34" charset="0"/>
-                <a:ea typeface="Arial" pitchFamily="34" charset="-122"/>
-                <a:cs typeface="Arial" pitchFamily="34" charset="-120"/>
-              </a:rPr>
-              <a:t>Impaired mucin expression and barrier integrity.</a:t>
-            </a:r>
-            <a:endParaRPr lang="en-US" sz="1800" dirty="0"/>
-          </a:p>
-          <a:p>
-            <a:pPr marL="342900" indent="-342900">
-              <a:spcAft>
-                <a:spcPts val="800"/>
-              </a:spcAft>
-              <a:buSzPct val="100000"/>
-              <a:buChar char="•"/>
-            </a:pPr>
-            <a:r>
-              <a:rPr lang="en-US" sz="1800" dirty="0">
-                <a:solidFill>
-                  <a:srgbClr val="333333"/>
-                </a:solidFill>
-                <a:latin typeface="Arial" pitchFamily="34" charset="0"/>
-                <a:ea typeface="Arial" pitchFamily="34" charset="-122"/>
-                <a:cs typeface="Arial" pitchFamily="34" charset="-120"/>
-              </a:rPr>
-              <a:t>Supports goblet cell mucin transport.</a:t>
+              <a:t>(Generation failed)</a:t>
             </a:r>
             <a:endParaRPr lang="en-US" sz="1800" dirty="0"/>
           </a:p>
@@ -3038,7 +2870,7 @@
                   <a:srgbClr val="888888"/>
                 </a:solidFill>
               </a:rPr>
-              <a:t>Yang Liping, Guo Yuyao, Xiao Bikun et al.. iScience. 2026-07-26 DOI: 10.1016/j.isci.2026.116785</a:t>
+              <a:t>Sur Abhinav, Segal Ella X, Nunneley Michael P et al.. Genes &amp; development. 2026-08-26 DOI: 10.1101/gad.353662.126</a:t>
             </a:r>
             <a:endParaRPr lang="en-US" sz="800" dirty="0"/>
           </a:p>
@@ -3238,7 +3070,7 @@
                   </a:extLst>
                 </a:hlinkClick>
               </a:rPr>
-              <a:t>Tumor-driven arginine depletion induces T-cell metabolism reprogramming to suppress atherosclerosis in colorectal cancer.</a:t>
+              <a:t>cGAS-STING Modulates the NF-&amp;#x3ba;B Pathway to Influence the Occurrence of Ulcerative Colitis-Associated Colorectal Cancer.</a:t>
             </a:r>
             <a:endParaRPr lang="en-US" sz="2400" dirty="0"/>
           </a:p>
@@ -3274,7 +3106,7 @@
                   <a:srgbClr val="888888"/>
                 </a:solidFill>
               </a:rPr>
-              <a:t>Acta pharmacologica Sinica</a:t>
+              <a:t>Digestive diseases and sciences  ·  Basic Research</a:t>
             </a:r>
             <a:endParaRPr lang="en-US" sz="1000" dirty="0"/>
           </a:p>
@@ -3317,49 +3149,7 @@
                 <a:ea typeface="Arial" pitchFamily="34" charset="-122"/>
                 <a:cs typeface="Arial" pitchFamily="34" charset="-120"/>
               </a:rPr>
-              <a:t>Colorectal cancer affects atherosclerosis development.</a:t>
-            </a:r>
-            <a:endParaRPr lang="en-US" sz="1800" dirty="0"/>
-          </a:p>
-          <a:p>
-            <a:pPr marL="342900" indent="-342900">
-              <a:spcAft>
-                <a:spcPts val="800"/>
-              </a:spcAft>
-              <a:buSzPct val="100000"/>
-              <a:buChar char="•"/>
-            </a:pPr>
-            <a:r>
-              <a:rPr lang="en-US" sz="1800" dirty="0">
-                <a:solidFill>
-                  <a:srgbClr val="333333"/>
-                </a:solidFill>
-                <a:latin typeface="Arial" pitchFamily="34" charset="0"/>
-                <a:ea typeface="Arial" pitchFamily="34" charset="-122"/>
-                <a:cs typeface="Arial" pitchFamily="34" charset="-120"/>
-              </a:rPr>
-              <a:t>Tumors deplete arginine, altering T-cell metabolism.</a:t>
-            </a:r>
-            <a:endParaRPr lang="en-US" sz="1800" dirty="0"/>
-          </a:p>
-          <a:p>
-            <a:pPr marL="342900" indent="-342900">
-              <a:spcAft>
-                <a:spcPts val="800"/>
-              </a:spcAft>
-              <a:buSzPct val="100000"/>
-              <a:buChar char="•"/>
-            </a:pPr>
-            <a:r>
-              <a:rPr lang="en-US" sz="1800" dirty="0">
-                <a:solidFill>
-                  <a:srgbClr val="333333"/>
-                </a:solidFill>
-                <a:latin typeface="Arial" pitchFamily="34" charset="0"/>
-                <a:ea typeface="Arial" pitchFamily="34" charset="-122"/>
-                <a:cs typeface="Arial" pitchFamily="34" charset="-120"/>
-              </a:rPr>
-              <a:t>Dietary arginine restores T-cell activation.</a:t>
+              <a:t>(Generation failed)</a:t>
             </a:r>
             <a:endParaRPr lang="en-US" sz="1800" dirty="0"/>
           </a:p>
@@ -3395,7 +3185,7 @@
                   <a:srgbClr val="888888"/>
                 </a:solidFill>
               </a:rPr>
-              <a:t>Ni Wen-Jun, Sun He-Yang, Chen Meng-Lei et al.. Acta pharmacologica Sinica. 2026-08-18 DOI: 10.1038/s41401-026-01899-2</a:t>
+              <a:t>Wang Jian, Luo Anqing, Yao Yizhou et al.. Digestive diseases and sciences. 2026-08-24 DOI: 10.1007/s10620-026-10183-6</a:t>
             </a:r>
             <a:endParaRPr lang="en-US" sz="800" dirty="0"/>
           </a:p>
@@ -3586,290 +3376,7 @@
                   <a:srgbClr val="FFFFFF"/>
                 </a:solidFill>
               </a:rPr>
-              <a:t>### 綜合啟示 (Overall Insights)</a:t>
-            </a:r>
-            <a:endParaRPr lang="en-US" sz="1200" dirty="0"/>
-          </a:p>
-          <a:p>
-            <a:pPr indent="0" marL="0">
-              <a:lnSpc>
-                <a:spcPct val="150000"/>
-              </a:lnSpc>
-              <a:buNone/>
-            </a:pPr>
-            <a:endParaRPr lang="en-US" sz="1200" dirty="0"/>
-          </a:p>
-          <a:p>
-            <a:pPr indent="0" marL="0">
-              <a:lnSpc>
-                <a:spcPct val="150000"/>
-              </a:lnSpc>
-              <a:buNone/>
-            </a:pPr>
-            <a:r>
-              <a:rPr lang="en-US" sz="1200" dirty="0">
-                <a:solidFill>
-                  <a:srgbClr val="FFFFFF"/>
-                </a:solidFill>
-              </a:rPr>
-              <a:t>1. **系統免疫炎症指數的預後價值**  </a:t>
-            </a:r>
-            <a:endParaRPr lang="en-US" sz="1200" dirty="0"/>
-          </a:p>
-          <a:p>
-            <a:pPr indent="0" marL="0">
-              <a:lnSpc>
-                <a:spcPct val="150000"/>
-              </a:lnSpc>
-              <a:buNone/>
-            </a:pPr>
-            <a:r>
-              <a:rPr lang="en-US" sz="1200" dirty="0">
-                <a:solidFill>
-                  <a:srgbClr val="FFFFFF"/>
-                </a:solidFill>
-              </a:rPr>
-              <a:t>   The systemic immune-inflammation index (SII) has emerged as a potential prognostic biomarker for colorectal cancer (CRC), although its predictive reliability remains inconsistent across studies.  </a:t>
-            </a:r>
-            <a:endParaRPr lang="en-US" sz="1200" dirty="0"/>
-          </a:p>
-          <a:p>
-            <a:pPr indent="0" marL="0">
-              <a:lnSpc>
-                <a:spcPct val="150000"/>
-              </a:lnSpc>
-              <a:buNone/>
-            </a:pPr>
-            <a:r>
-              <a:rPr lang="en-US" sz="1200" dirty="0">
-                <a:solidFill>
-                  <a:srgbClr val="FFFFFF"/>
-                </a:solidFill>
-              </a:rPr>
-              <a:t>   系統免疫炎症指數（SII）已成為大腸癌（CRC）潛在的預後生物標記，儘管其預測可靠性在不同研究中仍不一致。</a:t>
-            </a:r>
-            <a:endParaRPr lang="en-US" sz="1200" dirty="0"/>
-          </a:p>
-          <a:p>
-            <a:pPr indent="0" marL="0">
-              <a:lnSpc>
-                <a:spcPct val="150000"/>
-              </a:lnSpc>
-              <a:buNone/>
-            </a:pPr>
-            <a:endParaRPr lang="en-US" sz="1200" dirty="0"/>
-          </a:p>
-          <a:p>
-            <a:pPr indent="0" marL="0">
-              <a:lnSpc>
-                <a:spcPct val="150000"/>
-              </a:lnSpc>
-              <a:buNone/>
-            </a:pPr>
-            <a:r>
-              <a:rPr lang="en-US" sz="1200" dirty="0">
-                <a:solidFill>
-                  <a:srgbClr val="FFFFFF"/>
-                </a:solidFill>
-              </a:rPr>
-              <a:t>2. **炎症與腫瘤進展的關聯**  </a:t>
-            </a:r>
-            <a:endParaRPr lang="en-US" sz="1200" dirty="0"/>
-          </a:p>
-          <a:p>
-            <a:pPr indent="0" marL="0">
-              <a:lnSpc>
-                <a:spcPct val="150000"/>
-              </a:lnSpc>
-              <a:buNone/>
-            </a:pPr>
-            <a:r>
-              <a:rPr lang="en-US" sz="1200" dirty="0">
-                <a:solidFill>
-                  <a:srgbClr val="FFFFFF"/>
-                </a:solidFill>
-              </a:rPr>
-              <a:t>   Chronic inflammation plays a significant role in colorectal cancer progression, highlighting the need for further exploration of inflammatory markers and their therapeutic implications.  </a:t>
-            </a:r>
-            <a:endParaRPr lang="en-US" sz="1200" dirty="0"/>
-          </a:p>
-          <a:p>
-            <a:pPr indent="0" marL="0">
-              <a:lnSpc>
-                <a:spcPct val="150000"/>
-              </a:lnSpc>
-              <a:buNone/>
-            </a:pPr>
-            <a:r>
-              <a:rPr lang="en-US" sz="1200" dirty="0">
-                <a:solidFill>
-                  <a:srgbClr val="FFFFFF"/>
-                </a:solidFill>
-              </a:rPr>
-              <a:t>   慢性炎症在大腸癌進展中扮演重要角色，強調需要進一步探索炎症標記及其治療意涵。</a:t>
-            </a:r>
-            <a:endParaRPr lang="en-US" sz="1200" dirty="0"/>
-          </a:p>
-          <a:p>
-            <a:pPr indent="0" marL="0">
-              <a:lnSpc>
-                <a:spcPct val="150000"/>
-              </a:lnSpc>
-              <a:buNone/>
-            </a:pPr>
-            <a:endParaRPr lang="en-US" sz="1200" dirty="0"/>
-          </a:p>
-          <a:p>
-            <a:pPr indent="0" marL="0">
-              <a:lnSpc>
-                <a:spcPct val="150000"/>
-              </a:lnSpc>
-              <a:buNone/>
-            </a:pPr>
-            <a:r>
-              <a:rPr lang="en-US" sz="1200" dirty="0">
-                <a:solidFill>
-                  <a:srgbClr val="FFFFFF"/>
-                </a:solidFill>
-              </a:rPr>
-              <a:t>3. **微生物群與腫瘤微環境的相互作用**  </a:t>
-            </a:r>
-            <a:endParaRPr lang="en-US" sz="1200" dirty="0"/>
-          </a:p>
-          <a:p>
-            <a:pPr indent="0" marL="0">
-              <a:lnSpc>
-                <a:spcPct val="150000"/>
-              </a:lnSpc>
-              <a:buNone/>
-            </a:pPr>
-            <a:r>
-              <a:rPr lang="en-US" sz="1200" dirty="0">
-                <a:solidFill>
-                  <a:srgbClr val="FFFFFF"/>
-                </a:solidFill>
-              </a:rPr>
-              <a:t>   The interaction between gut microbiota and the tumor microenvironment is crucial in CRC, suggesting that microbiome-targeted therapies could be a promising avenue for treatment.  </a:t>
-            </a:r>
-            <a:endParaRPr lang="en-US" sz="1200" dirty="0"/>
-          </a:p>
-          <a:p>
-            <a:pPr indent="0" marL="0">
-              <a:lnSpc>
-                <a:spcPct val="150000"/>
-              </a:lnSpc>
-              <a:buNone/>
-            </a:pPr>
-            <a:r>
-              <a:rPr lang="en-US" sz="1200" dirty="0">
-                <a:solidFill>
-                  <a:srgbClr val="FFFFFF"/>
-                </a:solidFill>
-              </a:rPr>
-              <a:t>   腸道微生物群與腫瘤微環境之間的相互作用在大腸癌中至關重要，這表明以微生物群為目標的治療可能是有前景的途徑。</a:t>
-            </a:r>
-            <a:endParaRPr lang="en-US" sz="1200" dirty="0"/>
-          </a:p>
-          <a:p>
-            <a:pPr indent="0" marL="0">
-              <a:lnSpc>
-                <a:spcPct val="150000"/>
-              </a:lnSpc>
-              <a:buNone/>
-            </a:pPr>
-            <a:endParaRPr lang="en-US" sz="1200" dirty="0"/>
-          </a:p>
-          <a:p>
-            <a:pPr indent="0" marL="0">
-              <a:lnSpc>
-                <a:spcPct val="150000"/>
-              </a:lnSpc>
-              <a:buNone/>
-            </a:pPr>
-            <a:r>
-              <a:rPr lang="en-US" sz="1200" dirty="0">
-                <a:solidFill>
-                  <a:srgbClr val="FFFFFF"/>
-                </a:solidFill>
-              </a:rPr>
-              <a:t>4. **新型納米藥物的潛力**  </a:t>
-            </a:r>
-            <a:endParaRPr lang="en-US" sz="1200" dirty="0"/>
-          </a:p>
-          <a:p>
-            <a:pPr indent="0" marL="0">
-              <a:lnSpc>
-                <a:spcPct val="150000"/>
-              </a:lnSpc>
-              <a:buNone/>
-            </a:pPr>
-            <a:r>
-              <a:rPr lang="en-US" sz="1200" dirty="0">
-                <a:solidFill>
-                  <a:srgbClr val="FFFFFF"/>
-                </a:solidFill>
-              </a:rPr>
-              <a:t>   Hybrid nanoparticles that target both tumor suppression and iron homeostasis show promise in treating CRC and associated anemia, indicating a shift towards multifunctional therapeutic strategies.  </a:t>
-            </a:r>
-            <a:endParaRPr lang="en-US" sz="1200" dirty="0"/>
-          </a:p>
-          <a:p>
-            <a:pPr indent="0" marL="0">
-              <a:lnSpc>
-                <a:spcPct val="150000"/>
-              </a:lnSpc>
-              <a:buNone/>
-            </a:pPr>
-            <a:r>
-              <a:rPr lang="en-US" sz="1200" dirty="0">
-                <a:solidFill>
-                  <a:srgbClr val="FFFFFF"/>
-                </a:solidFill>
-              </a:rPr>
-              <a:t>   針對腫瘤抑制和鐵穩態的混合納米藥物在治療大腸癌及相關貧血方面顯示出潛力，表明治療策略正向多功能化轉變。</a:t>
-            </a:r>
-            <a:endParaRPr lang="en-US" sz="1200" dirty="0"/>
-          </a:p>
-          <a:p>
-            <a:pPr indent="0" marL="0">
-              <a:lnSpc>
-                <a:spcPct val="150000"/>
-              </a:lnSpc>
-              <a:buNone/>
-            </a:pPr>
-            <a:endParaRPr lang="en-US" sz="1200" dirty="0"/>
-          </a:p>
-          <a:p>
-            <a:pPr indent="0" marL="0">
-              <a:lnSpc>
-                <a:spcPct val="150000"/>
-              </a:lnSpc>
-              <a:buNone/>
-            </a:pPr>
-            <a:r>
-              <a:rPr lang="en-US" sz="1200" dirty="0">
-                <a:solidFill>
-                  <a:srgbClr val="FFFFFF"/>
-                </a:solidFill>
-              </a:rPr>
-              <a:t>5. **免疫逃逸機制的研究**  </a:t>
-            </a:r>
-            <a:endParaRPr lang="en-US" sz="1200" dirty="0"/>
-          </a:p>
-          <a:p>
-            <a:pPr indent="0" marL="0">
-              <a:lnSpc>
-                <a:spcPct val="150000"/>
-              </a:lnSpc>
-              <a:buNone/>
-            </a:pPr>
-            <a:r>
-              <a:rPr lang="en-US" sz="1200" dirty="0">
-                <a:solidFill>
-                  <a:srgbClr val="FFFFFF"/>
-                </a:solidFill>
-              </a:rPr>
-              <a:t>   Understanding the mechanisms of immune evasion in CRC, particularly through pathways involving macrophages and tumor microenvironments, is critical for developing effective immunotherapies.</a:t>
+              <a:t>(Generati</a:t>
             </a:r>
             <a:endParaRPr lang="en-US" sz="1200" dirty="0"/>
           </a:p>
@@ -4015,333 +3522,7 @@
                   <a:srgbClr val="FFFFFF"/>
                 </a:solidFill>
               </a:rPr>
-              <a:t>理解大腸癌中免疫逃逸的機制，特別是涉及巨噬細胞和腫瘤微環境的途徑，對於開發有效的免疫療法至關重要。</a:t>
-            </a:r>
-            <a:endParaRPr lang="en-US" sz="1200" dirty="0"/>
-          </a:p>
-          <a:p>
-            <a:pPr indent="0" marL="0">
-              <a:lnSpc>
-                <a:spcPct val="150000"/>
-              </a:lnSpc>
-              <a:buNone/>
-            </a:pPr>
-            <a:endParaRPr lang="en-US" sz="1200" dirty="0"/>
-          </a:p>
-          <a:p>
-            <a:pPr indent="0" marL="0">
-              <a:lnSpc>
-                <a:spcPct val="150000"/>
-              </a:lnSpc>
-              <a:buNone/>
-            </a:pPr>
-            <a:r>
-              <a:rPr lang="en-US" sz="1200" dirty="0">
-                <a:solidFill>
-                  <a:srgbClr val="FFFFFF"/>
-                </a:solidFill>
-              </a:rPr>
-              <a:t>### 未來研究方向 (Future Research Directions)</a:t>
-            </a:r>
-            <a:endParaRPr lang="en-US" sz="1200" dirty="0"/>
-          </a:p>
-          <a:p>
-            <a:pPr indent="0" marL="0">
-              <a:lnSpc>
-                <a:spcPct val="150000"/>
-              </a:lnSpc>
-              <a:buNone/>
-            </a:pPr>
-            <a:endParaRPr lang="en-US" sz="1200" dirty="0"/>
-          </a:p>
-          <a:p>
-            <a:pPr indent="0" marL="0">
-              <a:lnSpc>
-                <a:spcPct val="150000"/>
-              </a:lnSpc>
-              <a:buNone/>
-            </a:pPr>
-            <a:r>
-              <a:rPr lang="en-US" sz="1200" dirty="0">
-                <a:solidFill>
-                  <a:srgbClr val="FFFFFF"/>
-                </a:solidFill>
-              </a:rPr>
-              <a:t>1. **標準化SII的應用**  </a:t>
-            </a:r>
-            <a:endParaRPr lang="en-US" sz="1200" dirty="0"/>
-          </a:p>
-          <a:p>
-            <a:pPr indent="0" marL="0">
-              <a:lnSpc>
-                <a:spcPct val="150000"/>
-              </a:lnSpc>
-              <a:buNone/>
-            </a:pPr>
-            <a:r>
-              <a:rPr lang="en-US" sz="1200" dirty="0">
-                <a:solidFill>
-                  <a:srgbClr val="FFFFFF"/>
-                </a:solidFill>
-              </a:rPr>
-              <a:t>   Future studies should focus on standardizing the application of the systemic immune-inflammation index (SII) in clinical settings to improve its prognostic accuracy in CRC.  </a:t>
-            </a:r>
-            <a:endParaRPr lang="en-US" sz="1200" dirty="0"/>
-          </a:p>
-          <a:p>
-            <a:pPr indent="0" marL="0">
-              <a:lnSpc>
-                <a:spcPct val="150000"/>
-              </a:lnSpc>
-              <a:buNone/>
-            </a:pPr>
-            <a:r>
-              <a:rPr lang="en-US" sz="1200" dirty="0">
-                <a:solidFill>
-                  <a:srgbClr val="FFFFFF"/>
-                </a:solidFill>
-              </a:rPr>
-              <a:t>   未來研究應專注於標準化系統免疫炎症指數（SII）在臨床環境中的應用，以提高其在大腸癌中的預後準確性。</a:t>
-            </a:r>
-            <a:endParaRPr lang="en-US" sz="1200" dirty="0"/>
-          </a:p>
-          <a:p>
-            <a:pPr indent="0" marL="0">
-              <a:lnSpc>
-                <a:spcPct val="150000"/>
-              </a:lnSpc>
-              <a:buNone/>
-            </a:pPr>
-            <a:endParaRPr lang="en-US" sz="1200" dirty="0"/>
-          </a:p>
-          <a:p>
-            <a:pPr indent="0" marL="0">
-              <a:lnSpc>
-                <a:spcPct val="150000"/>
-              </a:lnSpc>
-              <a:buNone/>
-            </a:pPr>
-            <a:r>
-              <a:rPr lang="en-US" sz="1200" dirty="0">
-                <a:solidFill>
-                  <a:srgbClr val="FFFFFF"/>
-                </a:solidFill>
-              </a:rPr>
-              <a:t>2. **炎症標記的臨床應用**  </a:t>
-            </a:r>
-            <a:endParaRPr lang="en-US" sz="1200" dirty="0"/>
-          </a:p>
-          <a:p>
-            <a:pPr indent="0" marL="0">
-              <a:lnSpc>
-                <a:spcPct val="150000"/>
-              </a:lnSpc>
-              <a:buNone/>
-            </a:pPr>
-            <a:r>
-              <a:rPr lang="en-US" sz="1200" dirty="0">
-                <a:solidFill>
-                  <a:srgbClr val="FFFFFF"/>
-                </a:solidFill>
-              </a:rPr>
-              <a:t>   Investigating the clinical utility of various inflammatory markers could provide insights into personalized treatment strategies for CRC patients.  </a:t>
-            </a:r>
-            <a:endParaRPr lang="en-US" sz="1200" dirty="0"/>
-          </a:p>
-          <a:p>
-            <a:pPr indent="0" marL="0">
-              <a:lnSpc>
-                <a:spcPct val="150000"/>
-              </a:lnSpc>
-              <a:buNone/>
-            </a:pPr>
-            <a:r>
-              <a:rPr lang="en-US" sz="1200" dirty="0">
-                <a:solidFill>
-                  <a:srgbClr val="FFFFFF"/>
-                </a:solidFill>
-              </a:rPr>
-              <a:t>   探索各種炎症標記的臨床應用可能為大腸癌患者提供個性化治療策略的見解。</a:t>
-            </a:r>
-            <a:endParaRPr lang="en-US" sz="1200" dirty="0"/>
-          </a:p>
-          <a:p>
-            <a:pPr indent="0" marL="0">
-              <a:lnSpc>
-                <a:spcPct val="150000"/>
-              </a:lnSpc>
-              <a:buNone/>
-            </a:pPr>
-            <a:endParaRPr lang="en-US" sz="1200" dirty="0"/>
-          </a:p>
-          <a:p>
-            <a:pPr indent="0" marL="0">
-              <a:lnSpc>
-                <a:spcPct val="150000"/>
-              </a:lnSpc>
-              <a:buNone/>
-            </a:pPr>
-            <a:r>
-              <a:rPr lang="en-US" sz="1200" dirty="0">
-                <a:solidFill>
-                  <a:srgbClr val="FFFFFF"/>
-                </a:solidFill>
-              </a:rPr>
-              <a:t>3. **微生物群介入研究**  </a:t>
-            </a:r>
-            <a:endParaRPr lang="en-US" sz="1200" dirty="0"/>
-          </a:p>
-          <a:p>
-            <a:pPr indent="0" marL="0">
-              <a:lnSpc>
-                <a:spcPct val="150000"/>
-              </a:lnSpc>
-              <a:buNone/>
-            </a:pPr>
-            <a:r>
-              <a:rPr lang="en-US" sz="1200" dirty="0">
-                <a:solidFill>
-                  <a:srgbClr val="FFFFFF"/>
-                </a:solidFill>
-              </a:rPr>
-              <a:t>   Research should aim to elucidate the therapeutic potential of modulating gut microbiota as a complementary approach to existing CRC therapies.  </a:t>
-            </a:r>
-            <a:endParaRPr lang="en-US" sz="1200" dirty="0"/>
-          </a:p>
-          <a:p>
-            <a:pPr indent="0" marL="0">
-              <a:lnSpc>
-                <a:spcPct val="150000"/>
-              </a:lnSpc>
-              <a:buNone/>
-            </a:pPr>
-            <a:r>
-              <a:rPr lang="en-US" sz="1200" dirty="0">
-                <a:solidFill>
-                  <a:srgbClr val="FFFFFF"/>
-                </a:solidFill>
-              </a:rPr>
-              <a:t>   研究應旨在闡明調節腸道微生物群的治療潛力，作為現有大腸癌療法的補充方法。</a:t>
-            </a:r>
-            <a:endParaRPr lang="en-US" sz="1200" dirty="0"/>
-          </a:p>
-          <a:p>
-            <a:pPr indent="0" marL="0">
-              <a:lnSpc>
-                <a:spcPct val="150000"/>
-              </a:lnSpc>
-              <a:buNone/>
-            </a:pPr>
-            <a:endParaRPr lang="en-US" sz="1200" dirty="0"/>
-          </a:p>
-          <a:p>
-            <a:pPr indent="0" marL="0">
-              <a:lnSpc>
-                <a:spcPct val="150000"/>
-              </a:lnSpc>
-              <a:buNone/>
-            </a:pPr>
-            <a:r>
-              <a:rPr lang="en-US" sz="1200" dirty="0">
-                <a:solidFill>
-                  <a:srgbClr val="FFFFFF"/>
-                </a:solidFill>
-              </a:rPr>
-              <a:t>4. **納米技術在治療中的應用**  </a:t>
-            </a:r>
-            <a:endParaRPr lang="en-US" sz="1200" dirty="0"/>
-          </a:p>
-          <a:p>
-            <a:pPr indent="0" marL="0">
-              <a:lnSpc>
-                <a:spcPct val="150000"/>
-              </a:lnSpc>
-              <a:buNone/>
-            </a:pPr>
-            <a:r>
-              <a:rPr lang="en-US" sz="1200" dirty="0">
-                <a:solidFill>
-                  <a:srgbClr val="FFFFFF"/>
-                </a:solidFill>
-              </a:rPr>
-              <a:t>   Further exploration of hybrid nanoparticles for targeted drug delivery in CRC treatment could enhance therapeutic efficacy and minimize side effects.  </a:t>
-            </a:r>
-            <a:endParaRPr lang="en-US" sz="1200" dirty="0"/>
-          </a:p>
-          <a:p>
-            <a:pPr indent="0" marL="0">
-              <a:lnSpc>
-                <a:spcPct val="150000"/>
-              </a:lnSpc>
-              <a:buNone/>
-            </a:pPr>
-            <a:r>
-              <a:rPr lang="en-US" sz="1200" dirty="0">
-                <a:solidFill>
-                  <a:srgbClr val="FFFFFF"/>
-                </a:solidFill>
-              </a:rPr>
-              <a:t>   進一步探索混合納米藥物在大腸癌治療中的靶向藥物傳遞應用，可能提高治療效果並最小化副作用。</a:t>
-            </a:r>
-            <a:endParaRPr lang="en-US" sz="1200" dirty="0"/>
-          </a:p>
-          <a:p>
-            <a:pPr indent="0" marL="0">
-              <a:lnSpc>
-                <a:spcPct val="150000"/>
-              </a:lnSpc>
-              <a:buNone/>
-            </a:pPr>
-            <a:endParaRPr lang="en-US" sz="1200" dirty="0"/>
-          </a:p>
-          <a:p>
-            <a:pPr indent="0" marL="0">
-              <a:lnSpc>
-                <a:spcPct val="150000"/>
-              </a:lnSpc>
-              <a:buNone/>
-            </a:pPr>
-            <a:r>
-              <a:rPr lang="en-US" sz="1200" dirty="0">
-                <a:solidFill>
-                  <a:srgbClr val="FFFFFF"/>
-                </a:solidFill>
-              </a:rPr>
-              <a:t>5. **免疫療法的機制研究**  </a:t>
-            </a:r>
-            <a:endParaRPr lang="en-US" sz="1200" dirty="0"/>
-          </a:p>
-          <a:p>
-            <a:pPr indent="0" marL="0">
-              <a:lnSpc>
-                <a:spcPct val="150000"/>
-              </a:lnSpc>
-              <a:buNone/>
-            </a:pPr>
-            <a:r>
-              <a:rPr lang="en-US" sz="1200" dirty="0">
-                <a:solidFill>
-                  <a:srgbClr val="FFFFFF"/>
-                </a:solidFill>
-              </a:rPr>
-              <a:t>   Continued investigation into the mechanisms of immune resistance in CRC, particularly in relation to macrophage dynamics, will be essential for advancing immunotherapy approaches.  </a:t>
-            </a:r>
-            <a:endParaRPr lang="en-US" sz="1200" dirty="0"/>
-          </a:p>
-          <a:p>
-            <a:pPr indent="0" marL="0">
-              <a:lnSpc>
-                <a:spcPct val="150000"/>
-              </a:lnSpc>
-              <a:buNone/>
-            </a:pPr>
-            <a:r>
-              <a:rPr lang="en-US" sz="1200" dirty="0">
-                <a:solidFill>
-                  <a:srgbClr val="FFFFFF"/>
-                </a:solidFill>
-              </a:rPr>
-              <a:t>   持續研究大腸癌中免疫抵抗的機制，特別是與巨噬細胞動態相關的機制，對於推進免疫療法方法至關重要。</a:t>
+              <a:t>on failed)</a:t>
             </a:r>
             <a:endParaRPr lang="en-US" sz="1200" dirty="0"/>
           </a:p>
@@ -4575,7 +3756,7 @@
                 <a:ea typeface="Arial" pitchFamily="34" charset="-122"/>
                 <a:cs typeface="Arial" pitchFamily="34" charset="-120"/>
               </a:rPr>
-              <a:t>Prognostic value of systemic immune-inflammation index for colorectal cancer: a …</a:t>
+              <a:t>Emerging exposure-driven accelerated colorectal carcinogenesis: a model with imp…</a:t>
             </a:r>
             <a:endParaRPr lang="en-US" sz="1400" dirty="0"/>
           </a:p>
@@ -4612,7 +3793,7 @@
                 <a:ea typeface="Arial" pitchFamily="34" charset="-122"/>
                 <a:cs typeface="Arial" pitchFamily="34" charset="-120"/>
               </a:rPr>
-              <a:t>Predictive utility of the C-reactive protein-albumin-lymphocyte (CALLY) index in…</a:t>
+              <a:t>Neoadjuvant chemotherapy and bevacizumab for colorectal peritoneal metastases: c…</a:t>
             </a:r>
             <a:endParaRPr lang="en-US" sz="1400" dirty="0"/>
           </a:p>
@@ -4649,7 +3830,7 @@
                 <a:ea typeface="Arial" pitchFamily="34" charset="-122"/>
                 <a:cs typeface="Arial" pitchFamily="34" charset="-120"/>
               </a:rPr>
-              <a:t>Iron, inflammation, and intestinal tumors: the crucial triad in colorectal cance…</a:t>
+              <a:t>Prophylactic Hyperthermic Intraperitoneal Chemotherapy in Locally Advanced Color…</a:t>
             </a:r>
             <a:endParaRPr lang="en-US" sz="1400" dirty="0"/>
           </a:p>
@@ -4686,7 +3867,7 @@
                 <a:ea typeface="Arial" pitchFamily="34" charset="-122"/>
                 <a:cs typeface="Arial" pitchFamily="34" charset="-120"/>
               </a:rPr>
-              <a:t>Platelet membrane cloaked pectin and iron oxide based hybrid nanoparticles for t…</a:t>
+              <a:t>Glucosamine Use and Its Association with Colorectal Cancer and Mortality: A Syst…</a:t>
             </a:r>
             <a:endParaRPr lang="en-US" sz="1400" dirty="0"/>
           </a:p>
@@ -4723,7 +3904,7 @@
                 <a:ea typeface="Arial" pitchFamily="34" charset="-122"/>
                 <a:cs typeface="Arial" pitchFamily="34" charset="-120"/>
               </a:rPr>
-              <a:t>In vitro biological potential of green-synthesized nanoparticles from the Egypti…</a:t>
+              <a:t>Prognostic value of pretreatment C-reactive–protein–albumin–lymphocyte index in …</a:t>
             </a:r>
             <a:endParaRPr lang="en-US" sz="1400" dirty="0"/>
           </a:p>
@@ -4760,7 +3941,7 @@
                 <a:ea typeface="Arial" pitchFamily="34" charset="-122"/>
                 <a:cs typeface="Arial" pitchFamily="34" charset="-120"/>
               </a:rPr>
-              <a:t>Host-Microbe Mechanisms of Fusobacterium nucleatum in Colorectal Cancer.</a:t>
+              <a:t>Risk Factors in Sporadic Early-Onset Colorectal Cancer, Current Evidence and Eme…</a:t>
             </a:r>
             <a:endParaRPr lang="en-US" sz="1400" dirty="0"/>
           </a:p>
@@ -4797,7 +3978,7 @@
                 <a:ea typeface="Arial" pitchFamily="34" charset="-122"/>
                 <a:cs typeface="Arial" pitchFamily="34" charset="-120"/>
               </a:rPr>
-              <a:t>Evolution of SPP1+ cavity macrophage-mediated immunotherapy resistance in perito…</a:t>
+              <a:t>Neutrophil extracellular traps in colorectal cancer: context-dependent roles fro…</a:t>
             </a:r>
             <a:endParaRPr lang="en-US" sz="1400" dirty="0"/>
           </a:p>
@@ -4834,7 +4015,7 @@
                 <a:ea typeface="Arial" pitchFamily="34" charset="-122"/>
                 <a:cs typeface="Arial" pitchFamily="34" charset="-120"/>
               </a:rPr>
-              <a:t>The barrier–microbiota–inflammation axis in colorectal cancer: Mechanisms and em…</a:t>
+              <a:t>Methylparaben promotes colorectal tumor growth through nuclear receptor-mediated…</a:t>
             </a:r>
             <a:endParaRPr lang="en-US" sz="1400" dirty="0"/>
           </a:p>
@@ -4871,7 +4052,7 @@
                 <a:ea typeface="Arial" pitchFamily="34" charset="-122"/>
                 <a:cs typeface="Arial" pitchFamily="34" charset="-120"/>
               </a:rPr>
-              <a:t>LRMDA promotes intestinal mucosal barrier integrity and limits colitis and colon…</a:t>
+              <a:t>A conserved Notch-Meis1-Pbx cascade specifies secretory progenitors into spatial…</a:t>
             </a:r>
             <a:endParaRPr lang="en-US" sz="1400" dirty="0"/>
           </a:p>
@@ -4908,7 +4089,7 @@
                 <a:ea typeface="Arial" pitchFamily="34" charset="-122"/>
                 <a:cs typeface="Arial" pitchFamily="34" charset="-120"/>
               </a:rPr>
-              <a:t>Tumor-driven arginine depletion induces T-cell metabolism reprogramming to suppr…</a:t>
+              <a:t>cGAS-STING Modulates the NF-&amp;#x3ba;B Pathway to Influence the Occurrence of Ulce…</a:t>
             </a:r>
             <a:endParaRPr lang="en-US" sz="1400" dirty="0"/>
           </a:p>
@@ -5063,7 +4244,7 @@
                   </a:extLst>
                 </a:hlinkClick>
               </a:rPr>
-              <a:t>Prognostic value of systemic immune-inflammation index for colorectal cancer: a systematic review and meta-analysis</a:t>
+              <a:t>Emerging exposure-driven accelerated colorectal carcinogenesis: a model with implications for screening colonoscopy effectiveness</a:t>
             </a:r>
             <a:endParaRPr lang="en-US" sz="2400" dirty="0"/>
           </a:p>
@@ -5099,7 +4280,7 @@
                   <a:srgbClr val="888888"/>
                 </a:solidFill>
               </a:rPr>
-              <a:t>Frontiers in Oncology  ·  Meta-Analysis</a:t>
+              <a:t>Gut  ·  IF 24.5  ·  Prospective Study</a:t>
             </a:r>
             <a:endParaRPr lang="en-US" sz="1000" dirty="0"/>
           </a:p>
@@ -5142,91 +4323,7 @@
                 <a:ea typeface="Arial" pitchFamily="34" charset="-122"/>
                 <a:cs typeface="Arial" pitchFamily="34" charset="-120"/>
               </a:rPr>
-              <a:t>Systemic immune-inflammation index (SII) evaluated</a:t>
-            </a:r>
-            <a:endParaRPr lang="en-US" sz="1800" dirty="0"/>
-          </a:p>
-          <a:p>
-            <a:pPr marL="342900" indent="-342900">
-              <a:spcAft>
-                <a:spcPts val="800"/>
-              </a:spcAft>
-              <a:buSzPct val="100000"/>
-              <a:buChar char="•"/>
-            </a:pPr>
-            <a:r>
-              <a:rPr lang="en-US" sz="1800" dirty="0">
-                <a:solidFill>
-                  <a:srgbClr val="333333"/>
-                </a:solidFill>
-                <a:latin typeface="Arial" pitchFamily="34" charset="0"/>
-                <a:ea typeface="Arial" pitchFamily="34" charset="-122"/>
-                <a:cs typeface="Arial" pitchFamily="34" charset="-120"/>
-              </a:rPr>
-              <a:t>SII shows prognostic potential in CRC</a:t>
-            </a:r>
-            <a:endParaRPr lang="en-US" sz="1800" dirty="0"/>
-          </a:p>
-          <a:p>
-            <a:pPr marL="342900" indent="-342900">
-              <a:spcAft>
-                <a:spcPts val="800"/>
-              </a:spcAft>
-              <a:buSzPct val="100000"/>
-              <a:buChar char="•"/>
-            </a:pPr>
-            <a:r>
-              <a:rPr lang="en-US" sz="1800" dirty="0">
-                <a:solidFill>
-                  <a:srgbClr val="333333"/>
-                </a:solidFill>
-                <a:latin typeface="Arial" pitchFamily="34" charset="0"/>
-                <a:ea typeface="Arial" pitchFamily="34" charset="-122"/>
-                <a:cs typeface="Arial" pitchFamily="34" charset="-120"/>
-              </a:rPr>
-              <a:t>Inconsistent findings across studies</a:t>
-            </a:r>
-            <a:endParaRPr lang="en-US" sz="1800" dirty="0"/>
-          </a:p>
-          <a:p>
-            <a:pPr marL="342900" indent="-342900">
-              <a:spcAft>
-                <a:spcPts val="800"/>
-              </a:spcAft>
-              <a:buSzPct val="100000"/>
-              <a:buChar char="•"/>
-            </a:pPr>
-            <a:r>
-              <a:rPr lang="en-US" sz="1800" dirty="0">
-                <a:solidFill>
-                  <a:srgbClr val="333333"/>
-                </a:solidFill>
-                <a:latin typeface="Arial" pitchFamily="34" charset="0"/>
-                <a:ea typeface="Arial" pitchFamily="34" charset="-122"/>
-                <a:cs typeface="Arial" pitchFamily="34" charset="-120"/>
-              </a:rPr>
-              <a:t>Meta-analysis conducted for clarity</a:t>
-            </a:r>
-            <a:endParaRPr lang="en-US" sz="1800" dirty="0"/>
-          </a:p>
-          <a:p>
-            <a:pPr marL="342900" indent="-342900">
-              <a:spcAft>
-                <a:spcPts val="800"/>
-              </a:spcAft>
-              <a:buSzPct val="100000"/>
-              <a:buChar char="•"/>
-            </a:pPr>
-            <a:r>
-              <a:rPr lang="en-US" sz="1800" dirty="0">
-                <a:solidFill>
-                  <a:srgbClr val="333333"/>
-                </a:solidFill>
-                <a:latin typeface="Arial" pitchFamily="34" charset="0"/>
-                <a:ea typeface="Arial" pitchFamily="34" charset="-122"/>
-                <a:cs typeface="Arial" pitchFamily="34" charset="-120"/>
-              </a:rPr>
-              <a:t>SII may guide treatment decisions</a:t>
+              <a:t>(Generation failed)</a:t>
             </a:r>
             <a:endParaRPr lang="en-US" sz="1800" dirty="0"/>
           </a:p>
@@ -5262,7 +4359,7 @@
                   <a:srgbClr val="888888"/>
                 </a:solidFill>
               </a:rPr>
-              <a:t>P Wang, H Jiang. Frontiers in Oncology. 2026</a:t>
+              <a:t>K Truninger, H Easwaran, F Macrae. Gut. 2026</a:t>
             </a:r>
             <a:endParaRPr lang="en-US" sz="800" dirty="0"/>
           </a:p>
@@ -5462,7 +4559,7 @@
                   </a:extLst>
                 </a:hlinkClick>
               </a:rPr>
-              <a:t>Predictive utility of the C-reactive protein-albumin-lymphocyte (CALLY) index in Colorectal cancer: A meta-analysis</a:t>
+              <a:t>Neoadjuvant chemotherapy and bevacizumab for colorectal peritoneal metastases: clinical and translational outcomes of the phase II BEV-IP trial</a:t>
             </a:r>
             <a:endParaRPr lang="en-US" sz="2400" dirty="0"/>
           </a:p>
@@ -5498,7 +4595,7 @@
                   <a:srgbClr val="888888"/>
                 </a:solidFill>
               </a:rPr>
-              <a:t>Clinics and Research in Hepatology and …  ·  Meta-Analysis</a:t>
+              <a:t>Translational …  ·  RCT Phase 2</a:t>
             </a:r>
             <a:endParaRPr lang="en-US" sz="1000" dirty="0"/>
           </a:p>
@@ -5541,49 +4638,7 @@
                 <a:ea typeface="Arial" pitchFamily="34" charset="-122"/>
                 <a:cs typeface="Arial" pitchFamily="34" charset="-120"/>
               </a:rPr>
-              <a:t>CALLY index predicts colorectal cancer outcomes.</a:t>
-            </a:r>
-            <a:endParaRPr lang="en-US" sz="1800" dirty="0"/>
-          </a:p>
-          <a:p>
-            <a:pPr marL="342900" indent="-342900">
-              <a:spcAft>
-                <a:spcPts val="800"/>
-              </a:spcAft>
-              <a:buSzPct val="100000"/>
-              <a:buChar char="•"/>
-            </a:pPr>
-            <a:r>
-              <a:rPr lang="en-US" sz="1800" dirty="0">
-                <a:solidFill>
-                  <a:srgbClr val="333333"/>
-                </a:solidFill>
-                <a:latin typeface="Arial" pitchFamily="34" charset="0"/>
-                <a:ea typeface="Arial" pitchFamily="34" charset="-122"/>
-                <a:cs typeface="Arial" pitchFamily="34" charset="-120"/>
-              </a:rPr>
-              <a:t>Inflammation and immune function are crucial.</a:t>
-            </a:r>
-            <a:endParaRPr lang="en-US" sz="1800" dirty="0"/>
-          </a:p>
-          <a:p>
-            <a:pPr marL="342900" indent="-342900">
-              <a:spcAft>
-                <a:spcPts val="800"/>
-              </a:spcAft>
-              <a:buSzPct val="100000"/>
-              <a:buChar char="•"/>
-            </a:pPr>
-            <a:r>
-              <a:rPr lang="en-US" sz="1800" dirty="0">
-                <a:solidFill>
-                  <a:srgbClr val="333333"/>
-                </a:solidFill>
-                <a:latin typeface="Arial" pitchFamily="34" charset="0"/>
-                <a:ea typeface="Arial" pitchFamily="34" charset="-122"/>
-                <a:cs typeface="Arial" pitchFamily="34" charset="-120"/>
-              </a:rPr>
-              <a:t>Meta-analysis confirms CALLY's predictive value.</a:t>
+              <a:t>(Generation failed)</a:t>
             </a:r>
             <a:endParaRPr lang="en-US" sz="1800" dirty="0"/>
           </a:p>
@@ -5619,7 +4674,7 @@
                   <a:srgbClr val="888888"/>
                 </a:solidFill>
               </a:rPr>
-              <a:t>X Li, T Chu, W Chen. Clinics and Research in Hepatology and …. 2026</a:t>
+              <a:t>DKA Chia, J Demuytere, A Hoorens…. Translational …. 2026</a:t>
             </a:r>
             <a:endParaRPr lang="en-US" sz="800" dirty="0"/>
           </a:p>
@@ -5819,7 +4874,7 @@
                   </a:extLst>
                 </a:hlinkClick>
               </a:rPr>
-              <a:t>Iron, inflammation, and intestinal tumors: the crucial triad in colorectal cancer progression and therapy</a:t>
+              <a:t>Prophylactic Hyperthermic Intraperitoneal Chemotherapy in Locally Advanced Colorectal Cancer: Systematic Review and Meta-Analysis</a:t>
             </a:r>
             <a:endParaRPr lang="en-US" sz="2400" dirty="0"/>
           </a:p>
@@ -5855,7 +4910,7 @@
                   <a:srgbClr val="888888"/>
                 </a:solidFill>
               </a:rPr>
-              <a:t>Clinical and …  ·  Prospective Study</a:t>
+              <a:t>Annals of Surgical …  ·  Meta-Analysis</a:t>
             </a:r>
             <a:endParaRPr lang="en-US" sz="1000" dirty="0"/>
           </a:p>
@@ -5898,49 +4953,7 @@
                 <a:ea typeface="Arial" pitchFamily="34" charset="-122"/>
                 <a:cs typeface="Arial" pitchFamily="34" charset="-120"/>
               </a:rPr>
-              <a:t>Iron intake linked to CRC risk</a:t>
-            </a:r>
-            <a:endParaRPr lang="en-US" sz="1800" dirty="0"/>
-          </a:p>
-          <a:p>
-            <a:pPr marL="342900" indent="-342900">
-              <a:spcAft>
-                <a:spcPts val="800"/>
-              </a:spcAft>
-              <a:buSzPct val="100000"/>
-              <a:buChar char="•"/>
-            </a:pPr>
-            <a:r>
-              <a:rPr lang="en-US" sz="1800" dirty="0">
-                <a:solidFill>
-                  <a:srgbClr val="333333"/>
-                </a:solidFill>
-                <a:latin typeface="Arial" pitchFamily="34" charset="0"/>
-                <a:ea typeface="Arial" pitchFamily="34" charset="-122"/>
-                <a:cs typeface="Arial" pitchFamily="34" charset="-120"/>
-              </a:rPr>
-              <a:t>Inflammation plays a significant role</a:t>
-            </a:r>
-            <a:endParaRPr lang="en-US" sz="1800" dirty="0"/>
-          </a:p>
-          <a:p>
-            <a:pPr marL="342900" indent="-342900">
-              <a:spcAft>
-                <a:spcPts val="800"/>
-              </a:spcAft>
-              <a:buSzPct val="100000"/>
-              <a:buChar char="•"/>
-            </a:pPr>
-            <a:r>
-              <a:rPr lang="en-US" sz="1800" dirty="0">
-                <a:solidFill>
-                  <a:srgbClr val="333333"/>
-                </a:solidFill>
-                <a:latin typeface="Arial" pitchFamily="34" charset="0"/>
-                <a:ea typeface="Arial" pitchFamily="34" charset="-122"/>
-                <a:cs typeface="Arial" pitchFamily="34" charset="-120"/>
-              </a:rPr>
-              <a:t>Heme iron increases tumor progression</a:t>
+              <a:t>(Generation failed)</a:t>
             </a:r>
             <a:endParaRPr lang="en-US" sz="1800" dirty="0"/>
           </a:p>
@@ -5976,7 +4989,7 @@
                   <a:srgbClr val="888888"/>
                 </a:solidFill>
               </a:rPr>
-              <a:t>M Abediasl, M Siavash, SS Esfahani. Clinical and …. 2026</a:t>
+              <a:t>YC Chen, SC Chang, YY Tsai. Annals of Surgical …. 2026</a:t>
             </a:r>
             <a:endParaRPr lang="en-US" sz="800" dirty="0"/>
           </a:p>
@@ -6176,7 +5189,7 @@
                   </a:extLst>
                 </a:hlinkClick>
               </a:rPr>
-              <a:t>Platelet membrane cloaked pectin and iron oxide based hybrid nanoparticles for the treatment of colorectal cancer and associated anemia.</a:t>
+              <a:t>Glucosamine Use and Its Association with Colorectal Cancer and Mortality: A Systematic Review and Meta-Analysis</a:t>
             </a:r>
             <a:endParaRPr lang="en-US" sz="2400" dirty="0"/>
           </a:p>
@@ -6212,7 +5225,7 @@
                   <a:srgbClr val="888888"/>
                 </a:solidFill>
               </a:rPr>
-              <a:t>International journal of biological macromolecules  ·  Basic Research</a:t>
+              <a:t>Journal of Cancer  ·  Meta-Analysis</a:t>
             </a:r>
             <a:endParaRPr lang="en-US" sz="1000" dirty="0"/>
           </a:p>
@@ -6255,91 +5268,7 @@
                 <a:ea typeface="Arial" pitchFamily="34" charset="-122"/>
                 <a:cs typeface="Arial" pitchFamily="34" charset="-120"/>
               </a:rPr>
-              <a:t>Developed hybrid nanoparticles for CRC treatment</a:t>
-            </a:r>
-            <a:endParaRPr lang="en-US" sz="1800" dirty="0"/>
-          </a:p>
-          <a:p>
-            <a:pPr marL="342900" indent="-342900">
-              <a:spcAft>
-                <a:spcPts val="800"/>
-              </a:spcAft>
-              <a:buSzPct val="100000"/>
-              <a:buChar char="•"/>
-            </a:pPr>
-            <a:r>
-              <a:rPr lang="en-US" sz="1800" dirty="0">
-                <a:solidFill>
-                  <a:srgbClr val="333333"/>
-                </a:solidFill>
-                <a:latin typeface="Arial" pitchFamily="34" charset="0"/>
-                <a:ea typeface="Arial" pitchFamily="34" charset="-122"/>
-                <a:cs typeface="Arial" pitchFamily="34" charset="-120"/>
-              </a:rPr>
-              <a:t>Gemcitabine encapsulated in pectin nanoparticles</a:t>
-            </a:r>
-            <a:endParaRPr lang="en-US" sz="1800" dirty="0"/>
-          </a:p>
-          <a:p>
-            <a:pPr marL="342900" indent="-342900">
-              <a:spcAft>
-                <a:spcPts val="800"/>
-              </a:spcAft>
-              <a:buSzPct val="100000"/>
-              <a:buChar char="•"/>
-            </a:pPr>
-            <a:r>
-              <a:rPr lang="en-US" sz="1800" dirty="0">
-                <a:solidFill>
-                  <a:srgbClr val="333333"/>
-                </a:solidFill>
-                <a:latin typeface="Arial" pitchFamily="34" charset="0"/>
-                <a:ea typeface="Arial" pitchFamily="34" charset="-122"/>
-                <a:cs typeface="Arial" pitchFamily="34" charset="-120"/>
-              </a:rPr>
-              <a:t>Platelet membranes enhance tumor targeting</a:t>
-            </a:r>
-            <a:endParaRPr lang="en-US" sz="1800" dirty="0"/>
-          </a:p>
-          <a:p>
-            <a:pPr marL="342900" indent="-342900">
-              <a:spcAft>
-                <a:spcPts val="800"/>
-              </a:spcAft>
-              <a:buSzPct val="100000"/>
-              <a:buChar char="•"/>
-            </a:pPr>
-            <a:r>
-              <a:rPr lang="en-US" sz="1800" dirty="0">
-                <a:solidFill>
-                  <a:srgbClr val="333333"/>
-                </a:solidFill>
-                <a:latin typeface="Arial" pitchFamily="34" charset="0"/>
-                <a:ea typeface="Arial" pitchFamily="34" charset="-122"/>
-                <a:cs typeface="Arial" pitchFamily="34" charset="-120"/>
-              </a:rPr>
-              <a:t>Simultaneous chemotherapy and iron supplementation</a:t>
-            </a:r>
-            <a:endParaRPr lang="en-US" sz="1800" dirty="0"/>
-          </a:p>
-          <a:p>
-            <a:pPr marL="342900" indent="-342900">
-              <a:spcAft>
-                <a:spcPts val="800"/>
-              </a:spcAft>
-              <a:buSzPct val="100000"/>
-              <a:buChar char="•"/>
-            </a:pPr>
-            <a:r>
-              <a:rPr lang="en-US" sz="1800" dirty="0">
-                <a:solidFill>
-                  <a:srgbClr val="333333"/>
-                </a:solidFill>
-                <a:latin typeface="Arial" pitchFamily="34" charset="0"/>
-                <a:ea typeface="Arial" pitchFamily="34" charset="-122"/>
-                <a:cs typeface="Arial" pitchFamily="34" charset="-120"/>
-              </a:rPr>
-              <a:t>Demonstrated significant tumor inhibition and survival</a:t>
+              <a:t>(Generation failed)</a:t>
             </a:r>
             <a:endParaRPr lang="en-US" sz="1800" dirty="0"/>
           </a:p>
@@ -6375,7 +5304,7 @@
                   <a:srgbClr val="888888"/>
                 </a:solidFill>
               </a:rPr>
-              <a:t>Mirza Rashna, Rehman Asim Ur, Javed Aqeedat et al.. International journal of biological macromolecules. 2026-08-22 DOI: 10.1016/j.ijbiomac.2026.154170</a:t>
+              <a:t>Y Yan, M Xu, R Wang. Journal of Cancer. 2026</a:t>
             </a:r>
             <a:endParaRPr lang="en-US" sz="800" dirty="0"/>
           </a:p>
@@ -6575,7 +5504,7 @@
                   </a:extLst>
                 </a:hlinkClick>
               </a:rPr>
-              <a:t>In vitro biological potential of green-synthesized nanoparticles from the Egyptian edible bivalve Paratapes undulatus (Born, 1778).</a:t>
+              <a:t>Prognostic value of pretreatment C-reactive–protein–albumin–lymphocyte index in colorectal cancer: systematic review and meta-analysis</a:t>
             </a:r>
             <a:endParaRPr lang="en-US" sz="2400" dirty="0"/>
           </a:p>
@@ -6611,7 +5540,7 @@
                   <a:srgbClr val="888888"/>
                 </a:solidFill>
               </a:rPr>
-              <a:t>Scientific reports  ·  Basic Research</a:t>
+              <a:t>Journal of …  ·  Meta-Analysis</a:t>
             </a:r>
             <a:endParaRPr lang="en-US" sz="1000" dirty="0"/>
           </a:p>
@@ -6654,91 +5583,7 @@
                 <a:ea typeface="Arial" pitchFamily="34" charset="-122"/>
                 <a:cs typeface="Arial" pitchFamily="34" charset="-120"/>
               </a:rPr>
-              <a:t>Study on Paratapes undulatus extract</a:t>
-            </a:r>
-            <a:endParaRPr lang="en-US" sz="1800" dirty="0"/>
-          </a:p>
-          <a:p>
-            <a:pPr marL="342900" indent="-342900">
-              <a:spcAft>
-                <a:spcPts val="800"/>
-              </a:spcAft>
-              <a:buSzPct val="100000"/>
-              <a:buChar char="•"/>
-            </a:pPr>
-            <a:r>
-              <a:rPr lang="en-US" sz="1800" dirty="0">
-                <a:solidFill>
-                  <a:srgbClr val="333333"/>
-                </a:solidFill>
-                <a:latin typeface="Arial" pitchFamily="34" charset="0"/>
-                <a:ea typeface="Arial" pitchFamily="34" charset="-122"/>
-                <a:cs typeface="Arial" pitchFamily="34" charset="-120"/>
-              </a:rPr>
-              <a:t>Characterization of green-synthesized nanoparticles</a:t>
-            </a:r>
-            <a:endParaRPr lang="en-US" sz="1800" dirty="0"/>
-          </a:p>
-          <a:p>
-            <a:pPr marL="342900" indent="-342900">
-              <a:spcAft>
-                <a:spcPts val="800"/>
-              </a:spcAft>
-              <a:buSzPct val="100000"/>
-              <a:buChar char="•"/>
-            </a:pPr>
-            <a:r>
-              <a:rPr lang="en-US" sz="1800" dirty="0">
-                <a:solidFill>
-                  <a:srgbClr val="333333"/>
-                </a:solidFill>
-                <a:latin typeface="Arial" pitchFamily="34" charset="0"/>
-                <a:ea typeface="Arial" pitchFamily="34" charset="-122"/>
-                <a:cs typeface="Arial" pitchFamily="34" charset="-120"/>
-              </a:rPr>
-              <a:t>Enhanced anticancer activity of Pu-SeNPs</a:t>
-            </a:r>
-            <a:endParaRPr lang="en-US" sz="1800" dirty="0"/>
-          </a:p>
-          <a:p>
-            <a:pPr marL="342900" indent="-342900">
-              <a:spcAft>
-                <a:spcPts val="800"/>
-              </a:spcAft>
-              <a:buSzPct val="100000"/>
-              <a:buChar char="•"/>
-            </a:pPr>
-            <a:r>
-              <a:rPr lang="en-US" sz="1800" dirty="0">
-                <a:solidFill>
-                  <a:srgbClr val="333333"/>
-                </a:solidFill>
-                <a:latin typeface="Arial" pitchFamily="34" charset="0"/>
-                <a:ea typeface="Arial" pitchFamily="34" charset="-122"/>
-                <a:cs typeface="Arial" pitchFamily="34" charset="-120"/>
-              </a:rPr>
-              <a:t>Potential for bio-based nanomedicines</a:t>
-            </a:r>
-            <a:endParaRPr lang="en-US" sz="1800" dirty="0"/>
-          </a:p>
-          <a:p>
-            <a:pPr marL="342900" indent="-342900">
-              <a:spcAft>
-                <a:spcPts val="800"/>
-              </a:spcAft>
-              <a:buSzPct val="100000"/>
-              <a:buChar char="•"/>
-            </a:pPr>
-            <a:r>
-              <a:rPr lang="en-US" sz="1800" dirty="0">
-                <a:solidFill>
-                  <a:srgbClr val="333333"/>
-                </a:solidFill>
-                <a:latin typeface="Arial" pitchFamily="34" charset="0"/>
-                <a:ea typeface="Arial" pitchFamily="34" charset="-122"/>
-                <a:cs typeface="Arial" pitchFamily="34" charset="-120"/>
-              </a:rPr>
-              <a:t>Inconsistent efficacy against HepG-2 cells</a:t>
+              <a:t>(Generation failed)</a:t>
             </a:r>
             <a:endParaRPr lang="en-US" sz="1800" dirty="0"/>
           </a:p>
@@ -6774,7 +5619,7 @@
                   <a:srgbClr val="888888"/>
                 </a:solidFill>
               </a:rPr>
-              <a:t>El Makawy Aida I, Zayed Khaled M, Mabrouk Dalia M et al.. Scientific reports. 2026-08-20 DOI: 10.1038/s41598-026-61397-7</a:t>
+              <a:t>M Shamohammadi, D Yarahmadi…. Journal of …. 2026</a:t>
             </a:r>
             <a:endParaRPr lang="en-US" sz="800" dirty="0"/>
           </a:p>
@@ -6974,7 +5819,7 @@
                   </a:extLst>
                 </a:hlinkClick>
               </a:rPr>
-              <a:t>Host-Microbe Mechanisms of Fusobacterium nucleatum in Colorectal Cancer.</a:t>
+              <a:t>Risk Factors in Sporadic Early-Onset Colorectal Cancer, Current Evidence and Emerging Insights: A Systematic Review</a:t>
             </a:r>
             <a:endParaRPr lang="en-US" sz="2400" dirty="0"/>
           </a:p>
@@ -7010,7 +5855,7 @@
                   <a:srgbClr val="888888"/>
                 </a:solidFill>
               </a:rPr>
-              <a:t>Molecular oral microbiology  ·  Basic Research</a:t>
+              <a:t>Cancers  ·  Systematic Review</a:t>
             </a:r>
             <a:endParaRPr lang="en-US" sz="1000" dirty="0"/>
           </a:p>
@@ -7053,49 +5898,7 @@
                 <a:ea typeface="Arial" pitchFamily="34" charset="-122"/>
                 <a:cs typeface="Arial" pitchFamily="34" charset="-120"/>
               </a:rPr>
-              <a:t>Fusobacterium nucleatum linked to CRC progression.</a:t>
-            </a:r>
-            <a:endParaRPr lang="en-US" sz="1800" dirty="0"/>
-          </a:p>
-          <a:p>
-            <a:pPr marL="342900" indent="-342900">
-              <a:spcAft>
-                <a:spcPts val="800"/>
-              </a:spcAft>
-              <a:buSzPct val="100000"/>
-              <a:buChar char="•"/>
-            </a:pPr>
-            <a:r>
-              <a:rPr lang="en-US" sz="1800" dirty="0">
-                <a:solidFill>
-                  <a:srgbClr val="333333"/>
-                </a:solidFill>
-                <a:latin typeface="Arial" pitchFamily="34" charset="0"/>
-                <a:ea typeface="Arial" pitchFamily="34" charset="-122"/>
-                <a:cs typeface="Arial" pitchFamily="34" charset="-120"/>
-              </a:rPr>
-              <a:t>Modulates immune and inflammatory pathways.</a:t>
-            </a:r>
-            <a:endParaRPr lang="en-US" sz="1800" dirty="0"/>
-          </a:p>
-          <a:p>
-            <a:pPr marL="342900" indent="-342900">
-              <a:spcAft>
-                <a:spcPts val="800"/>
-              </a:spcAft>
-              <a:buSzPct val="100000"/>
-              <a:buChar char="•"/>
-            </a:pPr>
-            <a:r>
-              <a:rPr lang="en-US" sz="1800" dirty="0">
-                <a:solidFill>
-                  <a:srgbClr val="333333"/>
-                </a:solidFill>
-                <a:latin typeface="Arial" pitchFamily="34" charset="0"/>
-                <a:ea typeface="Arial" pitchFamily="34" charset="-122"/>
-                <a:cs typeface="Arial" pitchFamily="34" charset="-120"/>
-              </a:rPr>
-              <a:t>Reshapes tumor microenvironment significantly.</a:t>
+              <a:t>(Generation failed)</a:t>
             </a:r>
             <a:endParaRPr lang="en-US" sz="1800" dirty="0"/>
           </a:p>
@@ -7131,7 +5934,7 @@
                   <a:srgbClr val="888888"/>
                 </a:solidFill>
               </a:rPr>
-              <a:t>Leite Hadda Lyzandra Austr&amp;#xed;aco, Lopes Fernanda Ferreira. Molecular oral microbiology. 2026-08-19 DOI: 10.1111/omi.70038</a:t>
+              <a:t>M Maddula, JE Cohen, D Kumarasinghe. Cancers. 2026</a:t>
             </a:r>
             <a:endParaRPr lang="en-US" sz="800" dirty="0"/>
           </a:p>
@@ -7331,7 +6134,7 @@
                   </a:extLst>
                 </a:hlinkClick>
               </a:rPr>
-              <a:t>Evolution of SPP1+ cavity macrophage-mediated immunotherapy resistance in peritoneal metastasis of colorectal cancer.</a:t>
+              <a:t>Neutrophil extracellular traps in colorectal cancer: context-dependent roles from inflammatory carcinogenesis to liver metastasis and therapeutic targeting</a:t>
             </a:r>
             <a:endParaRPr lang="en-US" sz="2400" dirty="0"/>
           </a:p>
@@ -7367,7 +6170,7 @@
                   <a:srgbClr val="888888"/>
                 </a:solidFill>
               </a:rPr>
-              <a:t>Cell reports. Medicine  ·  Basic Research</a:t>
+              <a:t>Journal of Translational Medicine  ·  IF 6.1</a:t>
             </a:r>
             <a:endParaRPr lang="en-US" sz="1000" dirty="0"/>
           </a:p>
@@ -7410,49 +6213,7 @@
                 <a:ea typeface="Arial" pitchFamily="34" charset="-122"/>
                 <a:cs typeface="Arial" pitchFamily="34" charset="-120"/>
               </a:rPr>
-              <a:t>SPP1+ macrophages drive CD8+ T cell dysfunction.</a:t>
-            </a:r>
-            <a:endParaRPr lang="en-US" sz="1800" dirty="0"/>
-          </a:p>
-          <a:p>
-            <a:pPr marL="342900" indent="-342900">
-              <a:spcAft>
-                <a:spcPts val="800"/>
-              </a:spcAft>
-              <a:buSzPct val="100000"/>
-              <a:buChar char="•"/>
-            </a:pPr>
-            <a:r>
-              <a:rPr lang="en-US" sz="1800" dirty="0">
-                <a:solidFill>
-                  <a:srgbClr val="333333"/>
-                </a:solidFill>
-                <a:latin typeface="Arial" pitchFamily="34" charset="0"/>
-                <a:ea typeface="Arial" pitchFamily="34" charset="-122"/>
-                <a:cs typeface="Arial" pitchFamily="34" charset="-120"/>
-              </a:rPr>
-              <a:t>SPP1 enrichment linked to therapy resistance.</a:t>
-            </a:r>
-            <a:endParaRPr lang="en-US" sz="1800" dirty="0"/>
-          </a:p>
-          <a:p>
-            <a:pPr marL="342900" indent="-342900">
-              <a:spcAft>
-                <a:spcPts val="800"/>
-              </a:spcAft>
-              <a:buSzPct val="100000"/>
-              <a:buChar char="•"/>
-            </a:pPr>
-            <a:r>
-              <a:rPr lang="en-US" sz="1800" dirty="0">
-                <a:solidFill>
-                  <a:srgbClr val="333333"/>
-                </a:solidFill>
-                <a:latin typeface="Arial" pitchFamily="34" charset="0"/>
-                <a:ea typeface="Arial" pitchFamily="34" charset="-122"/>
-                <a:cs typeface="Arial" pitchFamily="34" charset="-120"/>
-              </a:rPr>
-              <a:t>Knockout enhances T cell infiltration and efficacy.</a:t>
+              <a:t>(Generation failed)</a:t>
             </a:r>
             <a:endParaRPr lang="en-US" sz="1800" dirty="0"/>
           </a:p>
@@ -7488,7 +6249,7 @@
                   <a:srgbClr val="888888"/>
                 </a:solidFill>
               </a:rPr>
-              <a:t>Dai Xiaomeng, Lai Chunyu, Hong Libing et al.. Cell reports. Medicine. 2026-08-18 DOI: 10.1016/j.xcrm.2026.102930</a:t>
+              <a:t>D Xu, R Wang, J Tan. Journal of Translational Medicine. 2026</a:t>
             </a:r>
             <a:endParaRPr lang="en-US" sz="800" dirty="0"/>
           </a:p>

</xml_diff>